<commit_message>
auto commit 2026-07-02 02:52:01
</commit_message>
<xml_diff>
--- a/revision.pptx
+++ b/revision.pptx
@@ -10,6 +10,7 @@
     <p:sldId id="258" r:id="rId4"/>
     <p:sldId id="259" r:id="rId5"/>
     <p:sldId id="260" r:id="rId6"/>
+    <p:sldId id="261" r:id="rId7"/>
   </p:sldIdLst>
   <p:sldSz cx="12192000" cy="6858000"/>
   <p:notesSz cx="6858000" cy="9144000"/>
@@ -108,6 +109,11 @@
       </a:defRPr>
     </a:lvl9pPr>
   </p:defaultTextStyle>
+  <p:extLst>
+    <p:ext uri="{EFAFB233-063F-42B5-8137-9DF3F51BA10A}">
+      <p15:sldGuideLst xmlns:p15="http://schemas.microsoft.com/office/powerpoint/2012/main"/>
+    </p:ext>
+  </p:extLst>
 </p:presentation>
 </file>
 
@@ -258,7 +264,7 @@
           <a:p>
             <a:fld id="{6F584DAC-AA37-8C49-B5B6-53E9519E19BB}" type="datetimeFigureOut">
               <a:rPr lang="en-US" smtClean="0"/>
-              <a:t>4/19/26</a:t>
+              <a:t>6/28/26</a:t>
             </a:fld>
             <a:endParaRPr lang="en-US"/>
           </a:p>
@@ -456,7 +462,7 @@
           <a:p>
             <a:fld id="{6F584DAC-AA37-8C49-B5B6-53E9519E19BB}" type="datetimeFigureOut">
               <a:rPr lang="en-US" smtClean="0"/>
-              <a:t>4/19/26</a:t>
+              <a:t>6/28/26</a:t>
             </a:fld>
             <a:endParaRPr lang="en-US"/>
           </a:p>
@@ -664,7 +670,7 @@
           <a:p>
             <a:fld id="{6F584DAC-AA37-8C49-B5B6-53E9519E19BB}" type="datetimeFigureOut">
               <a:rPr lang="en-US" smtClean="0"/>
-              <a:t>4/19/26</a:t>
+              <a:t>6/28/26</a:t>
             </a:fld>
             <a:endParaRPr lang="en-US"/>
           </a:p>
@@ -862,7 +868,7 @@
           <a:p>
             <a:fld id="{6F584DAC-AA37-8C49-B5B6-53E9519E19BB}" type="datetimeFigureOut">
               <a:rPr lang="en-US" smtClean="0"/>
-              <a:t>4/19/26</a:t>
+              <a:t>6/28/26</a:t>
             </a:fld>
             <a:endParaRPr lang="en-US"/>
           </a:p>
@@ -1137,7 +1143,7 @@
           <a:p>
             <a:fld id="{6F584DAC-AA37-8C49-B5B6-53E9519E19BB}" type="datetimeFigureOut">
               <a:rPr lang="en-US" smtClean="0"/>
-              <a:t>4/19/26</a:t>
+              <a:t>6/28/26</a:t>
             </a:fld>
             <a:endParaRPr lang="en-US"/>
           </a:p>
@@ -1402,7 +1408,7 @@
           <a:p>
             <a:fld id="{6F584DAC-AA37-8C49-B5B6-53E9519E19BB}" type="datetimeFigureOut">
               <a:rPr lang="en-US" smtClean="0"/>
-              <a:t>4/19/26</a:t>
+              <a:t>6/28/26</a:t>
             </a:fld>
             <a:endParaRPr lang="en-US"/>
           </a:p>
@@ -1814,7 +1820,7 @@
           <a:p>
             <a:fld id="{6F584DAC-AA37-8C49-B5B6-53E9519E19BB}" type="datetimeFigureOut">
               <a:rPr lang="en-US" smtClean="0"/>
-              <a:t>4/19/26</a:t>
+              <a:t>6/28/26</a:t>
             </a:fld>
             <a:endParaRPr lang="en-US"/>
           </a:p>
@@ -1955,7 +1961,7 @@
           <a:p>
             <a:fld id="{6F584DAC-AA37-8C49-B5B6-53E9519E19BB}" type="datetimeFigureOut">
               <a:rPr lang="en-US" smtClean="0"/>
-              <a:t>4/19/26</a:t>
+              <a:t>6/28/26</a:t>
             </a:fld>
             <a:endParaRPr lang="en-US"/>
           </a:p>
@@ -2068,7 +2074,7 @@
           <a:p>
             <a:fld id="{6F584DAC-AA37-8C49-B5B6-53E9519E19BB}" type="datetimeFigureOut">
               <a:rPr lang="en-US" smtClean="0"/>
-              <a:t>4/19/26</a:t>
+              <a:t>6/28/26</a:t>
             </a:fld>
             <a:endParaRPr lang="en-US"/>
           </a:p>
@@ -2379,7 +2385,7 @@
           <a:p>
             <a:fld id="{6F584DAC-AA37-8C49-B5B6-53E9519E19BB}" type="datetimeFigureOut">
               <a:rPr lang="en-US" smtClean="0"/>
-              <a:t>4/19/26</a:t>
+              <a:t>6/28/26</a:t>
             </a:fld>
             <a:endParaRPr lang="en-US"/>
           </a:p>
@@ -2667,7 +2673,7 @@
           <a:p>
             <a:fld id="{6F584DAC-AA37-8C49-B5B6-53E9519E19BB}" type="datetimeFigureOut">
               <a:rPr lang="en-US" smtClean="0"/>
-              <a:t>4/19/26</a:t>
+              <a:t>6/28/26</a:t>
             </a:fld>
             <a:endParaRPr lang="en-US"/>
           </a:p>
@@ -2908,7 +2914,7 @@
           <a:p>
             <a:fld id="{6F584DAC-AA37-8C49-B5B6-53E9519E19BB}" type="datetimeFigureOut">
               <a:rPr lang="en-US" smtClean="0"/>
-              <a:t>4/19/26</a:t>
+              <a:t>6/28/26</a:t>
             </a:fld>
             <a:endParaRPr lang="en-US"/>
           </a:p>
@@ -9349,6 +9355,66 @@
     <p:extLst>
       <p:ext uri="{BB962C8B-B14F-4D97-AF65-F5344CB8AC3E}">
         <p14:creationId xmlns:p14="http://schemas.microsoft.com/office/powerpoint/2010/main" val="2657338834"/>
+      </p:ext>
+    </p:extLst>
+  </p:cSld>
+  <p:clrMapOvr>
+    <a:masterClrMapping/>
+  </p:clrMapOvr>
+</p:sld>
+</file>
+
+<file path=ppt/slides/slide6.xml><?xml version="1.0" encoding="utf-8"?>
+<p:sld xmlns:a="http://schemas.openxmlformats.org/drawingml/2006/main" xmlns:r="http://schemas.openxmlformats.org/officeDocument/2006/relationships" xmlns:p="http://schemas.openxmlformats.org/presentationml/2006/main">
+  <p:cSld>
+    <p:spTree>
+      <p:nvGrpSpPr>
+        <p:cNvPr id="1" name=""/>
+        <p:cNvGrpSpPr/>
+        <p:nvPr/>
+      </p:nvGrpSpPr>
+      <p:grpSpPr>
+        <a:xfrm>
+          <a:off x="0" y="0"/>
+          <a:ext cx="0" cy="0"/>
+          <a:chOff x="0" y="0"/>
+          <a:chExt cx="0" cy="0"/>
+        </a:xfrm>
+      </p:grpSpPr>
+      <p:pic>
+        <p:nvPicPr>
+          <p:cNvPr id="7" name="Picture 6">
+            <a:extLst>
+              <a:ext uri="{FF2B5EF4-FFF2-40B4-BE49-F238E27FC236}">
+                <a16:creationId xmlns:a16="http://schemas.microsoft.com/office/drawing/2014/main" id="{B464EB4C-020F-A258-EA1A-0DD5ADFF7BCC}"/>
+              </a:ext>
+            </a:extLst>
+          </p:cNvPr>
+          <p:cNvPicPr>
+            <a:picLocks noChangeAspect="1"/>
+          </p:cNvPicPr>
+          <p:nvPr/>
+        </p:nvPicPr>
+        <p:blipFill>
+          <a:blip r:embed="rId2"/>
+          <a:stretch>
+            <a:fillRect/>
+          </a:stretch>
+        </p:blipFill>
+        <p:spPr>
+          <a:xfrm>
+            <a:off x="2209800" y="505828"/>
+            <a:ext cx="7772400" cy="5846344"/>
+          </a:xfrm>
+          <a:prstGeom prst="rect">
+            <a:avLst/>
+          </a:prstGeom>
+        </p:spPr>
+      </p:pic>
+    </p:spTree>
+    <p:extLst>
+      <p:ext uri="{BB962C8B-B14F-4D97-AF65-F5344CB8AC3E}">
+        <p14:creationId xmlns:p14="http://schemas.microsoft.com/office/powerpoint/2010/main" val="1093682882"/>
       </p:ext>
     </p:extLst>
   </p:cSld>

</xml_diff>

<commit_message>
cpu_worker_backup is fully functional with old logic, now I am testing shared intersection code
</commit_message>
<xml_diff>
--- a/revision.pptx
+++ b/revision.pptx
@@ -264,7 +264,7 @@
           <a:p>
             <a:fld id="{6F584DAC-AA37-8C49-B5B6-53E9519E19BB}" type="datetimeFigureOut">
               <a:rPr lang="en-US" smtClean="0"/>
-              <a:t>6/28/26</a:t>
+              <a:t>7/1/26</a:t>
             </a:fld>
             <a:endParaRPr lang="en-US"/>
           </a:p>
@@ -462,7 +462,7 @@
           <a:p>
             <a:fld id="{6F584DAC-AA37-8C49-B5B6-53E9519E19BB}" type="datetimeFigureOut">
               <a:rPr lang="en-US" smtClean="0"/>
-              <a:t>6/28/26</a:t>
+              <a:t>7/1/26</a:t>
             </a:fld>
             <a:endParaRPr lang="en-US"/>
           </a:p>
@@ -670,7 +670,7 @@
           <a:p>
             <a:fld id="{6F584DAC-AA37-8C49-B5B6-53E9519E19BB}" type="datetimeFigureOut">
               <a:rPr lang="en-US" smtClean="0"/>
-              <a:t>6/28/26</a:t>
+              <a:t>7/1/26</a:t>
             </a:fld>
             <a:endParaRPr lang="en-US"/>
           </a:p>
@@ -868,7 +868,7 @@
           <a:p>
             <a:fld id="{6F584DAC-AA37-8C49-B5B6-53E9519E19BB}" type="datetimeFigureOut">
               <a:rPr lang="en-US" smtClean="0"/>
-              <a:t>6/28/26</a:t>
+              <a:t>7/1/26</a:t>
             </a:fld>
             <a:endParaRPr lang="en-US"/>
           </a:p>
@@ -1143,7 +1143,7 @@
           <a:p>
             <a:fld id="{6F584DAC-AA37-8C49-B5B6-53E9519E19BB}" type="datetimeFigureOut">
               <a:rPr lang="en-US" smtClean="0"/>
-              <a:t>6/28/26</a:t>
+              <a:t>7/1/26</a:t>
             </a:fld>
             <a:endParaRPr lang="en-US"/>
           </a:p>
@@ -1408,7 +1408,7 @@
           <a:p>
             <a:fld id="{6F584DAC-AA37-8C49-B5B6-53E9519E19BB}" type="datetimeFigureOut">
               <a:rPr lang="en-US" smtClean="0"/>
-              <a:t>6/28/26</a:t>
+              <a:t>7/1/26</a:t>
             </a:fld>
             <a:endParaRPr lang="en-US"/>
           </a:p>
@@ -1820,7 +1820,7 @@
           <a:p>
             <a:fld id="{6F584DAC-AA37-8C49-B5B6-53E9519E19BB}" type="datetimeFigureOut">
               <a:rPr lang="en-US" smtClean="0"/>
-              <a:t>6/28/26</a:t>
+              <a:t>7/1/26</a:t>
             </a:fld>
             <a:endParaRPr lang="en-US"/>
           </a:p>
@@ -1961,7 +1961,7 @@
           <a:p>
             <a:fld id="{6F584DAC-AA37-8C49-B5B6-53E9519E19BB}" type="datetimeFigureOut">
               <a:rPr lang="en-US" smtClean="0"/>
-              <a:t>6/28/26</a:t>
+              <a:t>7/1/26</a:t>
             </a:fld>
             <a:endParaRPr lang="en-US"/>
           </a:p>
@@ -2074,7 +2074,7 @@
           <a:p>
             <a:fld id="{6F584DAC-AA37-8C49-B5B6-53E9519E19BB}" type="datetimeFigureOut">
               <a:rPr lang="en-US" smtClean="0"/>
-              <a:t>6/28/26</a:t>
+              <a:t>7/1/26</a:t>
             </a:fld>
             <a:endParaRPr lang="en-US"/>
           </a:p>
@@ -2385,7 +2385,7 @@
           <a:p>
             <a:fld id="{6F584DAC-AA37-8C49-B5B6-53E9519E19BB}" type="datetimeFigureOut">
               <a:rPr lang="en-US" smtClean="0"/>
-              <a:t>6/28/26</a:t>
+              <a:t>7/1/26</a:t>
             </a:fld>
             <a:endParaRPr lang="en-US"/>
           </a:p>
@@ -2673,7 +2673,7 @@
           <a:p>
             <a:fld id="{6F584DAC-AA37-8C49-B5B6-53E9519E19BB}" type="datetimeFigureOut">
               <a:rPr lang="en-US" smtClean="0"/>
-              <a:t>6/28/26</a:t>
+              <a:t>7/1/26</a:t>
             </a:fld>
             <a:endParaRPr lang="en-US"/>
           </a:p>
@@ -2914,7 +2914,7 @@
           <a:p>
             <a:fld id="{6F584DAC-AA37-8C49-B5B6-53E9519E19BB}" type="datetimeFigureOut">
               <a:rPr lang="en-US" smtClean="0"/>
-              <a:t>6/28/26</a:t>
+              <a:t>7/1/26</a:t>
             </a:fld>
             <a:endParaRPr lang="en-US"/>
           </a:p>
@@ -9381,36 +9381,54 @@
           <a:chExt cx="0" cy="0"/>
         </a:xfrm>
       </p:grpSpPr>
-      <p:pic>
-        <p:nvPicPr>
-          <p:cNvPr id="7" name="Picture 6">
-            <a:extLst>
-              <a:ext uri="{FF2B5EF4-FFF2-40B4-BE49-F238E27FC236}">
-                <a16:creationId xmlns:a16="http://schemas.microsoft.com/office/drawing/2014/main" id="{B464EB4C-020F-A258-EA1A-0DD5ADFF7BCC}"/>
-              </a:ext>
-            </a:extLst>
-          </p:cNvPr>
-          <p:cNvPicPr>
-            <a:picLocks noChangeAspect="1"/>
-          </p:cNvPicPr>
+      <p:sp>
+        <p:nvSpPr>
+          <p:cNvPr id="2" name="TextBox 1">
+            <a:extLst>
+              <a:ext uri="{FF2B5EF4-FFF2-40B4-BE49-F238E27FC236}">
+                <a16:creationId xmlns:a16="http://schemas.microsoft.com/office/drawing/2014/main" id="{2352217D-D58A-58DB-010E-B8E0AF2338B1}"/>
+              </a:ext>
+            </a:extLst>
+          </p:cNvPr>
+          <p:cNvSpPr txBox="1"/>
           <p:nvPr/>
-        </p:nvPicPr>
-        <p:blipFill>
-          <a:blip r:embed="rId2"/>
-          <a:stretch>
-            <a:fillRect/>
-          </a:stretch>
-        </p:blipFill>
+        </p:nvSpPr>
         <p:spPr>
           <a:xfrm>
-            <a:off x="2209800" y="505828"/>
-            <a:ext cx="7772400" cy="5846344"/>
+            <a:off x="2493818" y="3096491"/>
+            <a:ext cx="8507457" cy="923330"/>
           </a:xfrm>
           <a:prstGeom prst="rect">
             <a:avLst/>
           </a:prstGeom>
+          <a:noFill/>
         </p:spPr>
-      </p:pic>
+        <p:txBody>
+          <a:bodyPr wrap="none" rtlCol="0">
+            <a:spAutoFit/>
+          </a:bodyPr>
+          <a:lstStyle/>
+          <a:p>
+            <a:r>
+              <a:rPr lang="en-US" dirty="0"/>
+              <a:t>switching to layered buffer should drop the computation instead of moving data host</a:t>
+            </a:r>
+          </a:p>
+          <a:p>
+            <a:endParaRPr lang="en-US" dirty="0"/>
+          </a:p>
+          <a:p>
+            <a:r>
+              <a:rPr lang="en-US" dirty="0"/>
+              <a:t>delete page 3, 4 in worst case if </a:t>
+            </a:r>
+            <a:r>
+              <a:rPr lang="en-US"/>
+              <a:t>can’t complete in 5 min</a:t>
+            </a:r>
+          </a:p>
+        </p:txBody>
+      </p:sp>
     </p:spTree>
     <p:extLst>
       <p:ext uri="{BB962C8B-B14F-4D97-AF65-F5344CB8AC3E}">

</xml_diff>

<commit_message>
auto commit 2026-07-16 17:20:47
</commit_message>
<xml_diff>
--- a/revision.pptx
+++ b/revision.pptx
@@ -10,7 +10,14 @@
     <p:sldId id="258" r:id="rId4"/>
     <p:sldId id="259" r:id="rId5"/>
     <p:sldId id="260" r:id="rId6"/>
-    <p:sldId id="261" r:id="rId7"/>
+    <p:sldId id="266" r:id="rId7"/>
+    <p:sldId id="267" r:id="rId8"/>
+    <p:sldId id="268" r:id="rId9"/>
+    <p:sldId id="269" r:id="rId10"/>
+    <p:sldId id="262" r:id="rId11"/>
+    <p:sldId id="263" r:id="rId12"/>
+    <p:sldId id="264" r:id="rId13"/>
+    <p:sldId id="265" r:id="rId14"/>
   </p:sldIdLst>
   <p:sldSz cx="12192000" cy="6858000"/>
   <p:notesSz cx="6858000" cy="9144000"/>
@@ -264,7 +271,7 @@
           <a:p>
             <a:fld id="{6F584DAC-AA37-8C49-B5B6-53E9519E19BB}" type="datetimeFigureOut">
               <a:rPr lang="en-US" smtClean="0"/>
-              <a:t>7/1/26</a:t>
+              <a:t>7/13/26</a:t>
             </a:fld>
             <a:endParaRPr lang="en-US"/>
           </a:p>
@@ -462,7 +469,7 @@
           <a:p>
             <a:fld id="{6F584DAC-AA37-8C49-B5B6-53E9519E19BB}" type="datetimeFigureOut">
               <a:rPr lang="en-US" smtClean="0"/>
-              <a:t>7/1/26</a:t>
+              <a:t>7/13/26</a:t>
             </a:fld>
             <a:endParaRPr lang="en-US"/>
           </a:p>
@@ -670,7 +677,7 @@
           <a:p>
             <a:fld id="{6F584DAC-AA37-8C49-B5B6-53E9519E19BB}" type="datetimeFigureOut">
               <a:rPr lang="en-US" smtClean="0"/>
-              <a:t>7/1/26</a:t>
+              <a:t>7/13/26</a:t>
             </a:fld>
             <a:endParaRPr lang="en-US"/>
           </a:p>
@@ -868,7 +875,7 @@
           <a:p>
             <a:fld id="{6F584DAC-AA37-8C49-B5B6-53E9519E19BB}" type="datetimeFigureOut">
               <a:rPr lang="en-US" smtClean="0"/>
-              <a:t>7/1/26</a:t>
+              <a:t>7/13/26</a:t>
             </a:fld>
             <a:endParaRPr lang="en-US"/>
           </a:p>
@@ -1143,7 +1150,7 @@
           <a:p>
             <a:fld id="{6F584DAC-AA37-8C49-B5B6-53E9519E19BB}" type="datetimeFigureOut">
               <a:rPr lang="en-US" smtClean="0"/>
-              <a:t>7/1/26</a:t>
+              <a:t>7/13/26</a:t>
             </a:fld>
             <a:endParaRPr lang="en-US"/>
           </a:p>
@@ -1408,7 +1415,7 @@
           <a:p>
             <a:fld id="{6F584DAC-AA37-8C49-B5B6-53E9519E19BB}" type="datetimeFigureOut">
               <a:rPr lang="en-US" smtClean="0"/>
-              <a:t>7/1/26</a:t>
+              <a:t>7/13/26</a:t>
             </a:fld>
             <a:endParaRPr lang="en-US"/>
           </a:p>
@@ -1820,7 +1827,7 @@
           <a:p>
             <a:fld id="{6F584DAC-AA37-8C49-B5B6-53E9519E19BB}" type="datetimeFigureOut">
               <a:rPr lang="en-US" smtClean="0"/>
-              <a:t>7/1/26</a:t>
+              <a:t>7/13/26</a:t>
             </a:fld>
             <a:endParaRPr lang="en-US"/>
           </a:p>
@@ -1961,7 +1968,7 @@
           <a:p>
             <a:fld id="{6F584DAC-AA37-8C49-B5B6-53E9519E19BB}" type="datetimeFigureOut">
               <a:rPr lang="en-US" smtClean="0"/>
-              <a:t>7/1/26</a:t>
+              <a:t>7/13/26</a:t>
             </a:fld>
             <a:endParaRPr lang="en-US"/>
           </a:p>
@@ -2074,7 +2081,7 @@
           <a:p>
             <a:fld id="{6F584DAC-AA37-8C49-B5B6-53E9519E19BB}" type="datetimeFigureOut">
               <a:rPr lang="en-US" smtClean="0"/>
-              <a:t>7/1/26</a:t>
+              <a:t>7/13/26</a:t>
             </a:fld>
             <a:endParaRPr lang="en-US"/>
           </a:p>
@@ -2385,7 +2392,7 @@
           <a:p>
             <a:fld id="{6F584DAC-AA37-8C49-B5B6-53E9519E19BB}" type="datetimeFigureOut">
               <a:rPr lang="en-US" smtClean="0"/>
-              <a:t>7/1/26</a:t>
+              <a:t>7/13/26</a:t>
             </a:fld>
             <a:endParaRPr lang="en-US"/>
           </a:p>
@@ -2673,7 +2680,7 @@
           <a:p>
             <a:fld id="{6F584DAC-AA37-8C49-B5B6-53E9519E19BB}" type="datetimeFigureOut">
               <a:rPr lang="en-US" smtClean="0"/>
-              <a:t>7/1/26</a:t>
+              <a:t>7/13/26</a:t>
             </a:fld>
             <a:endParaRPr lang="en-US"/>
           </a:p>
@@ -2914,7 +2921,7 @@
           <a:p>
             <a:fld id="{6F584DAC-AA37-8C49-B5B6-53E9519E19BB}" type="datetimeFigureOut">
               <a:rPr lang="en-US" smtClean="0"/>
-              <a:t>7/1/26</a:t>
+              <a:t>7/13/26</a:t>
             </a:fld>
             <a:endParaRPr lang="en-US"/>
           </a:p>
@@ -3467,6 +3474,2042 @@
 </p:sld>
 </file>
 
+<file path=ppt/slides/slide10.xml><?xml version="1.0" encoding="utf-8"?>
+<p:sld xmlns:a="http://schemas.openxmlformats.org/drawingml/2006/main" xmlns:r="http://schemas.openxmlformats.org/officeDocument/2006/relationships" xmlns:p="http://schemas.openxmlformats.org/presentationml/2006/main">
+  <p:cSld>
+    <p:spTree>
+      <p:nvGrpSpPr>
+        <p:cNvPr id="1" name=""/>
+        <p:cNvGrpSpPr/>
+        <p:nvPr/>
+      </p:nvGrpSpPr>
+      <p:grpSpPr>
+        <a:xfrm>
+          <a:off x="0" y="0"/>
+          <a:ext cx="0" cy="0"/>
+          <a:chOff x="0" y="0"/>
+          <a:chExt cx="0" cy="0"/>
+        </a:xfrm>
+      </p:grpSpPr>
+      <p:sp>
+        <p:nvSpPr>
+          <p:cNvPr id="2" name="Title 1">
+            <a:extLst>
+              <a:ext uri="{FF2B5EF4-FFF2-40B4-BE49-F238E27FC236}">
+                <a16:creationId xmlns:a16="http://schemas.microsoft.com/office/drawing/2014/main" id="{7628D451-66A4-3181-8DDD-496D006AA74A}"/>
+              </a:ext>
+            </a:extLst>
+          </p:cNvPr>
+          <p:cNvSpPr>
+            <a:spLocks noGrp="1"/>
+          </p:cNvSpPr>
+          <p:nvPr>
+            <p:ph type="title"/>
+          </p:nvPr>
+        </p:nvSpPr>
+        <p:spPr/>
+        <p:txBody>
+          <a:bodyPr/>
+          <a:lstStyle/>
+          <a:p>
+            <a:r>
+              <a:rPr lang="en-US" dirty="0"/>
+              <a:t>Why CPU is much faster than GPU? </a:t>
+            </a:r>
+          </a:p>
+        </p:txBody>
+      </p:sp>
+      <p:sp>
+        <p:nvSpPr>
+          <p:cNvPr id="3" name="Content Placeholder 2">
+            <a:extLst>
+              <a:ext uri="{FF2B5EF4-FFF2-40B4-BE49-F238E27FC236}">
+                <a16:creationId xmlns:a16="http://schemas.microsoft.com/office/drawing/2014/main" id="{4C8397CA-74DB-C096-A33A-4A6EA1EBA1FE}"/>
+              </a:ext>
+            </a:extLst>
+          </p:cNvPr>
+          <p:cNvSpPr>
+            <a:spLocks noGrp="1"/>
+          </p:cNvSpPr>
+          <p:nvPr>
+            <p:ph idx="1"/>
+          </p:nvPr>
+        </p:nvSpPr>
+        <p:spPr/>
+        <p:txBody>
+          <a:bodyPr/>
+          <a:lstStyle/>
+          <a:p>
+            <a:r>
+              <a:rPr lang="en-US" dirty="0"/>
+              <a:t>A few vertices are very high degree in the graphs</a:t>
+            </a:r>
+          </a:p>
+          <a:p>
+            <a:r>
+              <a:rPr lang="en-US" dirty="0"/>
+              <a:t>Since a warp processes a vertex, a high degree vertex causes a warp to take a long time</a:t>
+            </a:r>
+          </a:p>
+        </p:txBody>
+      </p:sp>
+      <p:pic>
+        <p:nvPicPr>
+          <p:cNvPr id="4" name="Picture 3">
+            <a:extLst>
+              <a:ext uri="{FF2B5EF4-FFF2-40B4-BE49-F238E27FC236}">
+                <a16:creationId xmlns:a16="http://schemas.microsoft.com/office/drawing/2014/main" id="{254BE56B-7E87-DFA0-0FE1-28C1ECB32A12}"/>
+              </a:ext>
+            </a:extLst>
+          </p:cNvPr>
+          <p:cNvPicPr>
+            <a:picLocks noChangeAspect="1"/>
+          </p:cNvPicPr>
+          <p:nvPr/>
+        </p:nvPicPr>
+        <p:blipFill>
+          <a:blip r:embed="rId2"/>
+          <a:stretch>
+            <a:fillRect/>
+          </a:stretch>
+        </p:blipFill>
+        <p:spPr>
+          <a:xfrm>
+            <a:off x="2182090" y="3429000"/>
+            <a:ext cx="3913909" cy="2860164"/>
+          </a:xfrm>
+          <a:prstGeom prst="rect">
+            <a:avLst/>
+          </a:prstGeom>
+        </p:spPr>
+      </p:pic>
+      <p:pic>
+        <p:nvPicPr>
+          <p:cNvPr id="5" name="Picture 4">
+            <a:extLst>
+              <a:ext uri="{FF2B5EF4-FFF2-40B4-BE49-F238E27FC236}">
+                <a16:creationId xmlns:a16="http://schemas.microsoft.com/office/drawing/2014/main" id="{DD33D4D8-8E2F-2C12-BC14-03C68E73F507}"/>
+              </a:ext>
+            </a:extLst>
+          </p:cNvPr>
+          <p:cNvPicPr>
+            <a:picLocks noChangeAspect="1"/>
+          </p:cNvPicPr>
+          <p:nvPr/>
+        </p:nvPicPr>
+        <p:blipFill>
+          <a:blip r:embed="rId3"/>
+          <a:stretch>
+            <a:fillRect/>
+          </a:stretch>
+        </p:blipFill>
+        <p:spPr>
+          <a:xfrm>
+            <a:off x="6719636" y="3429000"/>
+            <a:ext cx="3640100" cy="2660073"/>
+          </a:xfrm>
+          <a:prstGeom prst="rect">
+            <a:avLst/>
+          </a:prstGeom>
+        </p:spPr>
+      </p:pic>
+    </p:spTree>
+    <p:extLst>
+      <p:ext uri="{BB962C8B-B14F-4D97-AF65-F5344CB8AC3E}">
+        <p14:creationId xmlns:p14="http://schemas.microsoft.com/office/powerpoint/2010/main" val="831210412"/>
+      </p:ext>
+    </p:extLst>
+  </p:cSld>
+  <p:clrMapOvr>
+    <a:masterClrMapping/>
+  </p:clrMapOvr>
+</p:sld>
+</file>
+
+<file path=ppt/slides/slide11.xml><?xml version="1.0" encoding="utf-8"?>
+<p:sld xmlns:a="http://schemas.openxmlformats.org/drawingml/2006/main" xmlns:r="http://schemas.openxmlformats.org/officeDocument/2006/relationships" xmlns:p="http://schemas.openxmlformats.org/presentationml/2006/main">
+  <p:cSld>
+    <p:spTree>
+      <p:nvGrpSpPr>
+        <p:cNvPr id="1" name=""/>
+        <p:cNvGrpSpPr/>
+        <p:nvPr/>
+      </p:nvGrpSpPr>
+      <p:grpSpPr>
+        <a:xfrm>
+          <a:off x="0" y="0"/>
+          <a:ext cx="0" cy="0"/>
+          <a:chOff x="0" y="0"/>
+          <a:chExt cx="0" cy="0"/>
+        </a:xfrm>
+      </p:grpSpPr>
+      <p:sp>
+        <p:nvSpPr>
+          <p:cNvPr id="2" name="Title 1">
+            <a:extLst>
+              <a:ext uri="{FF2B5EF4-FFF2-40B4-BE49-F238E27FC236}">
+                <a16:creationId xmlns:a16="http://schemas.microsoft.com/office/drawing/2014/main" id="{31FF3868-9696-2B98-D1A3-613A21D0ADB3}"/>
+              </a:ext>
+            </a:extLst>
+          </p:cNvPr>
+          <p:cNvSpPr>
+            <a:spLocks noGrp="1"/>
+          </p:cNvSpPr>
+          <p:nvPr>
+            <p:ph type="title"/>
+          </p:nvPr>
+        </p:nvSpPr>
+        <p:spPr/>
+        <p:txBody>
+          <a:bodyPr/>
+          <a:lstStyle/>
+          <a:p>
+            <a:r>
+              <a:rPr lang="en-US" dirty="0"/>
+              <a:t>Why hybrid-copy is faster than layered?</a:t>
+            </a:r>
+          </a:p>
+        </p:txBody>
+      </p:sp>
+      <p:sp>
+        <p:nvSpPr>
+          <p:cNvPr id="3" name="Content Placeholder 2">
+            <a:extLst>
+              <a:ext uri="{FF2B5EF4-FFF2-40B4-BE49-F238E27FC236}">
+                <a16:creationId xmlns:a16="http://schemas.microsoft.com/office/drawing/2014/main" id="{6E11D006-07A2-FB25-AA6D-21914978DBDD}"/>
+              </a:ext>
+            </a:extLst>
+          </p:cNvPr>
+          <p:cNvSpPr>
+            <a:spLocks noGrp="1"/>
+          </p:cNvSpPr>
+          <p:nvPr>
+            <p:ph idx="1"/>
+          </p:nvPr>
+        </p:nvSpPr>
+        <p:spPr>
+          <a:xfrm>
+            <a:off x="838200" y="1825625"/>
+            <a:ext cx="10515600" cy="1935884"/>
+          </a:xfrm>
+        </p:spPr>
+        <p:txBody>
+          <a:bodyPr/>
+          <a:lstStyle/>
+          <a:p>
+            <a:r>
+              <a:rPr lang="en-US" dirty="0"/>
+              <a:t>In the layered case, a fixed </a:t>
+            </a:r>
+            <a:r>
+              <a:rPr lang="en-US" dirty="0" err="1"/>
+              <a:t>η</a:t>
+            </a:r>
+            <a:r>
+              <a:rPr lang="en-US" dirty="0"/>
+              <a:t> may underutilize GPU cores, increasing runtime. (currently </a:t>
+            </a:r>
+            <a:r>
+              <a:rPr lang="en-US" dirty="0" err="1"/>
+              <a:t>η</a:t>
+            </a:r>
+            <a:r>
+              <a:rPr lang="en-US" dirty="0"/>
+              <a:t>=2000)</a:t>
+            </a:r>
+          </a:p>
+          <a:p>
+            <a:r>
+              <a:rPr lang="en-US" dirty="0"/>
+              <a:t>Ping-pong execution processes the entire buffer, resulting in faster runtime.</a:t>
+            </a:r>
+          </a:p>
+        </p:txBody>
+      </p:sp>
+      <p:graphicFrame>
+        <p:nvGraphicFramePr>
+          <p:cNvPr id="6" name="Table 5">
+            <a:extLst>
+              <a:ext uri="{FF2B5EF4-FFF2-40B4-BE49-F238E27FC236}">
+                <a16:creationId xmlns:a16="http://schemas.microsoft.com/office/drawing/2014/main" id="{BE308B00-5A5B-3BAC-2EB1-D29D1B3561BF}"/>
+              </a:ext>
+            </a:extLst>
+          </p:cNvPr>
+          <p:cNvGraphicFramePr>
+            <a:graphicFrameLocks noGrp="1"/>
+          </p:cNvGraphicFramePr>
+          <p:nvPr>
+            <p:extLst>
+              <p:ext uri="{D42A27DB-BD31-4B8C-83A1-F6EECF244321}">
+                <p14:modId xmlns:p14="http://schemas.microsoft.com/office/powerpoint/2010/main" val="4085985711"/>
+              </p:ext>
+            </p:extLst>
+          </p:nvPr>
+        </p:nvGraphicFramePr>
+        <p:xfrm>
+          <a:off x="1402772" y="6188075"/>
+          <a:ext cx="8077200" cy="304800"/>
+        </p:xfrm>
+        <a:graphic>
+          <a:graphicData uri="http://schemas.openxmlformats.org/drawingml/2006/table">
+            <a:tbl>
+              <a:tblPr>
+                <a:tableStyleId>{3B4B98B0-60AC-42C2-AFA5-B58CD77FA1E5}</a:tableStyleId>
+              </a:tblPr>
+              <a:tblGrid>
+                <a:gridCol w="3810000">
+                  <a:extLst>
+                    <a:ext uri="{9D8B030D-6E8A-4147-A177-3AD203B41FA5}">
+                      <a16:colId xmlns:a16="http://schemas.microsoft.com/office/drawing/2014/main" val="440064474"/>
+                    </a:ext>
+                  </a:extLst>
+                </a:gridCol>
+                <a:gridCol w="1422400">
+                  <a:extLst>
+                    <a:ext uri="{9D8B030D-6E8A-4147-A177-3AD203B41FA5}">
+                      <a16:colId xmlns:a16="http://schemas.microsoft.com/office/drawing/2014/main" val="1993903042"/>
+                    </a:ext>
+                  </a:extLst>
+                </a:gridCol>
+                <a:gridCol w="1422400">
+                  <a:extLst>
+                    <a:ext uri="{9D8B030D-6E8A-4147-A177-3AD203B41FA5}">
+                      <a16:colId xmlns:a16="http://schemas.microsoft.com/office/drawing/2014/main" val="2045103679"/>
+                    </a:ext>
+                  </a:extLst>
+                </a:gridCol>
+                <a:gridCol w="1422400">
+                  <a:extLst>
+                    <a:ext uri="{9D8B030D-6E8A-4147-A177-3AD203B41FA5}">
+                      <a16:colId xmlns:a16="http://schemas.microsoft.com/office/drawing/2014/main" val="9635011"/>
+                    </a:ext>
+                  </a:extLst>
+                </a:gridCol>
+              </a:tblGrid>
+              <a:tr h="304800">
+                <a:tc>
+                  <a:txBody>
+                    <a:bodyPr/>
+                    <a:lstStyle/>
+                    <a:p>
+                      <a:pPr algn="l" fontAlgn="b">
+                        <a:buNone/>
+                      </a:pPr>
+                      <a:r>
+                        <a:rPr lang="en-US" sz="1700" u="none" strike="noStrike" dirty="0">
+                          <a:effectLst/>
+                        </a:rPr>
+                        <a:t>edit-</a:t>
+                      </a:r>
+                      <a:r>
+                        <a:rPr lang="en-US" sz="1700" u="none" strike="noStrike" dirty="0" err="1">
+                          <a:effectLst/>
+                        </a:rPr>
+                        <a:t>nlwiki</a:t>
+                      </a:r>
+                      <a:endParaRPr lang="en-US" sz="1700" b="0" i="0" u="none" strike="noStrike" dirty="0">
+                        <a:solidFill>
+                          <a:srgbClr val="000000"/>
+                        </a:solidFill>
+                        <a:effectLst/>
+                        <a:latin typeface="Monaco" pitchFamily="2" charset="77"/>
+                      </a:endParaRPr>
+                    </a:p>
+                  </a:txBody>
+                  <a:tcPr marL="0" marR="0" marT="0" marB="0" anchor="b"/>
+                </a:tc>
+                <a:tc>
+                  <a:txBody>
+                    <a:bodyPr/>
+                    <a:lstStyle/>
+                    <a:p>
+                      <a:pPr algn="r" fontAlgn="b">
+                        <a:buNone/>
+                      </a:pPr>
+                      <a:r>
+                        <a:rPr lang="en-US" sz="1700" u="none" strike="noStrike">
+                          <a:effectLst/>
+                        </a:rPr>
+                        <a:t>20.5</a:t>
+                      </a:r>
+                      <a:endParaRPr lang="en-US" sz="1700" b="0" i="0" u="none" strike="noStrike">
+                        <a:solidFill>
+                          <a:srgbClr val="000000"/>
+                        </a:solidFill>
+                        <a:effectLst/>
+                        <a:latin typeface="Monaco" pitchFamily="2" charset="77"/>
+                      </a:endParaRPr>
+                    </a:p>
+                  </a:txBody>
+                  <a:tcPr marL="0" marR="0" marT="0" marB="0" anchor="b"/>
+                </a:tc>
+                <a:tc>
+                  <a:txBody>
+                    <a:bodyPr/>
+                    <a:lstStyle/>
+                    <a:p>
+                      <a:pPr algn="r" fontAlgn="b">
+                        <a:buNone/>
+                      </a:pPr>
+                      <a:r>
+                        <a:rPr lang="en-US" sz="1700" u="none" strike="noStrike" dirty="0">
+                          <a:effectLst/>
+                        </a:rPr>
+                        <a:t>18.4</a:t>
+                      </a:r>
+                      <a:endParaRPr lang="en-US" sz="1700" b="0" i="0" u="none" strike="noStrike" dirty="0">
+                        <a:solidFill>
+                          <a:srgbClr val="000000"/>
+                        </a:solidFill>
+                        <a:effectLst/>
+                        <a:latin typeface="Monaco" pitchFamily="2" charset="77"/>
+                      </a:endParaRPr>
+                    </a:p>
+                  </a:txBody>
+                  <a:tcPr marL="0" marR="0" marT="0" marB="0" anchor="b"/>
+                </a:tc>
+                <a:tc>
+                  <a:txBody>
+                    <a:bodyPr/>
+                    <a:lstStyle/>
+                    <a:p>
+                      <a:pPr algn="r" fontAlgn="b">
+                        <a:buNone/>
+                      </a:pPr>
+                      <a:r>
+                        <a:rPr lang="en-US" sz="1700" u="none" strike="noStrike" dirty="0">
+                          <a:effectLst/>
+                        </a:rPr>
+                        <a:t>16.8</a:t>
+                      </a:r>
+                      <a:endParaRPr lang="en-US" sz="1700" b="0" i="0" u="none" strike="noStrike" dirty="0">
+                        <a:solidFill>
+                          <a:srgbClr val="000000"/>
+                        </a:solidFill>
+                        <a:effectLst/>
+                        <a:latin typeface="Monaco" pitchFamily="2" charset="77"/>
+                      </a:endParaRPr>
+                    </a:p>
+                  </a:txBody>
+                  <a:tcPr marL="0" marR="0" marT="0" marB="0" anchor="b"/>
+                </a:tc>
+                <a:extLst>
+                  <a:ext uri="{0D108BD9-81ED-4DB2-BD59-A6C34878D82A}">
+                    <a16:rowId xmlns:a16="http://schemas.microsoft.com/office/drawing/2014/main" val="737372659"/>
+                  </a:ext>
+                </a:extLst>
+              </a:tr>
+            </a:tbl>
+          </a:graphicData>
+        </a:graphic>
+      </p:graphicFrame>
+      <p:graphicFrame>
+        <p:nvGraphicFramePr>
+          <p:cNvPr id="7" name="Table 6">
+            <a:extLst>
+              <a:ext uri="{FF2B5EF4-FFF2-40B4-BE49-F238E27FC236}">
+                <a16:creationId xmlns:a16="http://schemas.microsoft.com/office/drawing/2014/main" id="{EE30A8DC-34D0-5DF0-03C7-008572D49F28}"/>
+              </a:ext>
+            </a:extLst>
+          </p:cNvPr>
+          <p:cNvGraphicFramePr>
+            <a:graphicFrameLocks noGrp="1"/>
+          </p:cNvGraphicFramePr>
+          <p:nvPr>
+            <p:extLst>
+              <p:ext uri="{D42A27DB-BD31-4B8C-83A1-F6EECF244321}">
+                <p14:modId xmlns:p14="http://schemas.microsoft.com/office/powerpoint/2010/main" val="2436802704"/>
+              </p:ext>
+            </p:extLst>
+          </p:nvPr>
+        </p:nvGraphicFramePr>
+        <p:xfrm>
+          <a:off x="1402772" y="5845175"/>
+          <a:ext cx="8077200" cy="342900"/>
+        </p:xfrm>
+        <a:graphic>
+          <a:graphicData uri="http://schemas.openxmlformats.org/drawingml/2006/table">
+            <a:tbl>
+              <a:tblPr>
+                <a:tableStyleId>{D113A9D2-9D6B-4929-AA2D-F23B5EE8CBE7}</a:tableStyleId>
+              </a:tblPr>
+              <a:tblGrid>
+                <a:gridCol w="3810000">
+                  <a:extLst>
+                    <a:ext uri="{9D8B030D-6E8A-4147-A177-3AD203B41FA5}">
+                      <a16:colId xmlns:a16="http://schemas.microsoft.com/office/drawing/2014/main" val="960849052"/>
+                    </a:ext>
+                  </a:extLst>
+                </a:gridCol>
+                <a:gridCol w="1422400">
+                  <a:extLst>
+                    <a:ext uri="{9D8B030D-6E8A-4147-A177-3AD203B41FA5}">
+                      <a16:colId xmlns:a16="http://schemas.microsoft.com/office/drawing/2014/main" val="2114501400"/>
+                    </a:ext>
+                  </a:extLst>
+                </a:gridCol>
+                <a:gridCol w="1422400">
+                  <a:extLst>
+                    <a:ext uri="{9D8B030D-6E8A-4147-A177-3AD203B41FA5}">
+                      <a16:colId xmlns:a16="http://schemas.microsoft.com/office/drawing/2014/main" val="2581511765"/>
+                    </a:ext>
+                  </a:extLst>
+                </a:gridCol>
+                <a:gridCol w="1422400">
+                  <a:extLst>
+                    <a:ext uri="{9D8B030D-6E8A-4147-A177-3AD203B41FA5}">
+                      <a16:colId xmlns:a16="http://schemas.microsoft.com/office/drawing/2014/main" val="2808599619"/>
+                    </a:ext>
+                  </a:extLst>
+                </a:gridCol>
+              </a:tblGrid>
+              <a:tr h="342900">
+                <a:tc>
+                  <a:txBody>
+                    <a:bodyPr/>
+                    <a:lstStyle/>
+                    <a:p>
+                      <a:pPr algn="l" fontAlgn="b">
+                        <a:buNone/>
+                      </a:pPr>
+                      <a:r>
+                        <a:rPr lang="en-US" sz="1600" b="1" u="none" strike="noStrike" dirty="0">
+                          <a:solidFill>
+                            <a:srgbClr val="000000"/>
+                          </a:solidFill>
+                          <a:effectLst/>
+                        </a:rPr>
+                        <a:t>eta values</a:t>
+                      </a:r>
+                      <a:endParaRPr lang="en-US" sz="1600" b="1" i="0" u="none" strike="noStrike" dirty="0">
+                        <a:solidFill>
+                          <a:srgbClr val="000000"/>
+                        </a:solidFill>
+                        <a:effectLst/>
+                        <a:latin typeface="Aptos Narrow" panose="020B0004020202020204" pitchFamily="34" charset="0"/>
+                      </a:endParaRPr>
+                    </a:p>
+                  </a:txBody>
+                  <a:tcPr marL="0" marR="0" marT="0" marB="0" anchor="b"/>
+                </a:tc>
+                <a:tc>
+                  <a:txBody>
+                    <a:bodyPr/>
+                    <a:lstStyle/>
+                    <a:p>
+                      <a:pPr algn="l" fontAlgn="b">
+                        <a:buNone/>
+                      </a:pPr>
+                      <a:r>
+                        <a:rPr lang="en-US" sz="1600" b="1" u="none" strike="noStrike">
+                          <a:effectLst/>
+                        </a:rPr>
+                        <a:t>              1,000 </a:t>
+                      </a:r>
+                      <a:endParaRPr lang="en-US" sz="1600" b="1" i="0" u="none" strike="noStrike">
+                        <a:solidFill>
+                          <a:srgbClr val="000000"/>
+                        </a:solidFill>
+                        <a:effectLst/>
+                        <a:latin typeface="Aptos Narrow" panose="020B0004020202020204" pitchFamily="34" charset="0"/>
+                      </a:endParaRPr>
+                    </a:p>
+                  </a:txBody>
+                  <a:tcPr marL="0" marR="0" marT="0" marB="0" anchor="b"/>
+                </a:tc>
+                <a:tc>
+                  <a:txBody>
+                    <a:bodyPr/>
+                    <a:lstStyle/>
+                    <a:p>
+                      <a:pPr algn="l" fontAlgn="b">
+                        <a:buNone/>
+                      </a:pPr>
+                      <a:r>
+                        <a:rPr lang="en-US" sz="1600" b="1" u="none" strike="noStrike">
+                          <a:effectLst/>
+                        </a:rPr>
+                        <a:t>              2,000 </a:t>
+                      </a:r>
+                      <a:endParaRPr lang="en-US" sz="1600" b="1" i="0" u="none" strike="noStrike">
+                        <a:solidFill>
+                          <a:srgbClr val="000000"/>
+                        </a:solidFill>
+                        <a:effectLst/>
+                        <a:latin typeface="Aptos Narrow" panose="020B0004020202020204" pitchFamily="34" charset="0"/>
+                      </a:endParaRPr>
+                    </a:p>
+                  </a:txBody>
+                  <a:tcPr marL="0" marR="0" marT="0" marB="0" anchor="b"/>
+                </a:tc>
+                <a:tc>
+                  <a:txBody>
+                    <a:bodyPr/>
+                    <a:lstStyle/>
+                    <a:p>
+                      <a:pPr algn="l" fontAlgn="b">
+                        <a:buNone/>
+                      </a:pPr>
+                      <a:r>
+                        <a:rPr lang="en-US" sz="1600" b="1" u="none" strike="noStrike" dirty="0">
+                          <a:effectLst/>
+                        </a:rPr>
+                        <a:t>              5,000 </a:t>
+                      </a:r>
+                      <a:endParaRPr lang="en-US" sz="1600" b="1" i="0" u="none" strike="noStrike" dirty="0">
+                        <a:solidFill>
+                          <a:srgbClr val="000000"/>
+                        </a:solidFill>
+                        <a:effectLst/>
+                        <a:latin typeface="Aptos Narrow" panose="020B0004020202020204" pitchFamily="34" charset="0"/>
+                      </a:endParaRPr>
+                    </a:p>
+                  </a:txBody>
+                  <a:tcPr marL="0" marR="0" marT="0" marB="0" anchor="b"/>
+                </a:tc>
+                <a:extLst>
+                  <a:ext uri="{0D108BD9-81ED-4DB2-BD59-A6C34878D82A}">
+                    <a16:rowId xmlns:a16="http://schemas.microsoft.com/office/drawing/2014/main" val="712991610"/>
+                  </a:ext>
+                </a:extLst>
+              </a:tr>
+            </a:tbl>
+          </a:graphicData>
+        </a:graphic>
+      </p:graphicFrame>
+      <p:graphicFrame>
+        <p:nvGraphicFramePr>
+          <p:cNvPr id="8" name="Table 7">
+            <a:extLst>
+              <a:ext uri="{FF2B5EF4-FFF2-40B4-BE49-F238E27FC236}">
+                <a16:creationId xmlns:a16="http://schemas.microsoft.com/office/drawing/2014/main" id="{38C9E8D5-9850-50E3-F8B6-44CB0BEB3EA4}"/>
+              </a:ext>
+            </a:extLst>
+          </p:cNvPr>
+          <p:cNvGraphicFramePr>
+            <a:graphicFrameLocks noGrp="1"/>
+          </p:cNvGraphicFramePr>
+          <p:nvPr>
+            <p:extLst>
+              <p:ext uri="{D42A27DB-BD31-4B8C-83A1-F6EECF244321}">
+                <p14:modId xmlns:p14="http://schemas.microsoft.com/office/powerpoint/2010/main" val="3408055540"/>
+              </p:ext>
+            </p:extLst>
+          </p:nvPr>
+        </p:nvGraphicFramePr>
+        <p:xfrm>
+          <a:off x="1194954" y="3761509"/>
+          <a:ext cx="10235046" cy="966355"/>
+        </p:xfrm>
+        <a:graphic>
+          <a:graphicData uri="http://schemas.openxmlformats.org/drawingml/2006/table">
+            <a:tbl>
+              <a:tblPr>
+                <a:tableStyleId>{5C22544A-7EE6-4342-B048-85BDC9FD1C3A}</a:tableStyleId>
+              </a:tblPr>
+              <a:tblGrid>
+                <a:gridCol w="1669205">
+                  <a:extLst>
+                    <a:ext uri="{9D8B030D-6E8A-4147-A177-3AD203B41FA5}">
+                      <a16:colId xmlns:a16="http://schemas.microsoft.com/office/drawing/2014/main" val="2457110133"/>
+                    </a:ext>
+                  </a:extLst>
+                </a:gridCol>
+                <a:gridCol w="1312986">
+                  <a:extLst>
+                    <a:ext uri="{9D8B030D-6E8A-4147-A177-3AD203B41FA5}">
+                      <a16:colId xmlns:a16="http://schemas.microsoft.com/office/drawing/2014/main" val="3853503667"/>
+                    </a:ext>
+                  </a:extLst>
+                </a:gridCol>
+                <a:gridCol w="1662235">
+                  <a:extLst>
+                    <a:ext uri="{9D8B030D-6E8A-4147-A177-3AD203B41FA5}">
+                      <a16:colId xmlns:a16="http://schemas.microsoft.com/office/drawing/2014/main" val="1010362570"/>
+                    </a:ext>
+                  </a:extLst>
+                </a:gridCol>
+                <a:gridCol w="2795310">
+                  <a:extLst>
+                    <a:ext uri="{9D8B030D-6E8A-4147-A177-3AD203B41FA5}">
+                      <a16:colId xmlns:a16="http://schemas.microsoft.com/office/drawing/2014/main" val="3721380"/>
+                    </a:ext>
+                  </a:extLst>
+                </a:gridCol>
+                <a:gridCol w="2795310">
+                  <a:extLst>
+                    <a:ext uri="{9D8B030D-6E8A-4147-A177-3AD203B41FA5}">
+                      <a16:colId xmlns:a16="http://schemas.microsoft.com/office/drawing/2014/main" val="3894600151"/>
+                    </a:ext>
+                  </a:extLst>
+                </a:gridCol>
+              </a:tblGrid>
+              <a:tr h="639010">
+                <a:tc>
+                  <a:txBody>
+                    <a:bodyPr/>
+                    <a:lstStyle/>
+                    <a:p>
+                      <a:pPr algn="l" fontAlgn="b">
+                        <a:buNone/>
+                      </a:pPr>
+                      <a:r>
+                        <a:rPr lang="en-US" sz="1800" b="1" u="none" strike="noStrike" dirty="0">
+                          <a:effectLst/>
+                        </a:rPr>
+                        <a:t>dataset</a:t>
+                      </a:r>
+                      <a:endParaRPr lang="en-US" sz="1800" b="1" i="0" u="none" strike="noStrike" dirty="0">
+                        <a:solidFill>
+                          <a:srgbClr val="FFFFFF"/>
+                        </a:solidFill>
+                        <a:effectLst/>
+                        <a:latin typeface="Aptos Narrow" panose="020B0004020202020204" pitchFamily="34" charset="0"/>
+                      </a:endParaRPr>
+                    </a:p>
+                  </a:txBody>
+                  <a:tcPr marL="5454" marR="5454" marT="5454" marB="0" anchor="b"/>
+                </a:tc>
+                <a:tc>
+                  <a:txBody>
+                    <a:bodyPr/>
+                    <a:lstStyle/>
+                    <a:p>
+                      <a:pPr algn="l" fontAlgn="b">
+                        <a:buNone/>
+                      </a:pPr>
+                      <a:r>
+                        <a:rPr lang="en-US" sz="1800" b="1" u="none" strike="noStrike" dirty="0">
+                          <a:effectLst/>
+                        </a:rPr>
+                        <a:t>G2AIMD (</a:t>
+                      </a:r>
+                      <a:r>
+                        <a:rPr lang="en-US" sz="1800" b="1" u="none" strike="noStrike" dirty="0" err="1">
+                          <a:effectLst/>
+                        </a:rPr>
+                        <a:t>pingpong</a:t>
+                      </a:r>
+                      <a:r>
+                        <a:rPr lang="en-US" sz="1800" b="1" u="none" strike="noStrike" dirty="0">
+                          <a:effectLst/>
+                        </a:rPr>
+                        <a:t>)</a:t>
+                      </a:r>
+                      <a:endParaRPr lang="en-US" sz="1800" b="1" i="0" u="none" strike="noStrike" dirty="0">
+                        <a:solidFill>
+                          <a:srgbClr val="FFFFFF"/>
+                        </a:solidFill>
+                        <a:effectLst/>
+                        <a:latin typeface="Aptos Narrow" panose="020B0004020202020204" pitchFamily="34" charset="0"/>
+                      </a:endParaRPr>
+                    </a:p>
+                  </a:txBody>
+                  <a:tcPr marL="5454" marR="5454" marT="5454" marB="0" anchor="b"/>
+                </a:tc>
+                <a:tc>
+                  <a:txBody>
+                    <a:bodyPr/>
+                    <a:lstStyle/>
+                    <a:p>
+                      <a:pPr algn="l" fontAlgn="b">
+                        <a:buNone/>
+                      </a:pPr>
+                      <a:r>
+                        <a:rPr lang="en-US" sz="1800" b="1" u="none" strike="noStrike">
+                          <a:effectLst/>
+                        </a:rPr>
+                        <a:t>gpu-layered</a:t>
+                      </a:r>
+                      <a:endParaRPr lang="en-US" sz="1800" b="1" i="0" u="none" strike="noStrike">
+                        <a:solidFill>
+                          <a:srgbClr val="FFFFFF"/>
+                        </a:solidFill>
+                        <a:effectLst/>
+                        <a:latin typeface="Aptos Narrow" panose="020B0004020202020204" pitchFamily="34" charset="0"/>
+                      </a:endParaRPr>
+                    </a:p>
+                  </a:txBody>
+                  <a:tcPr marL="5454" marR="5454" marT="5454" marB="0" anchor="b"/>
+                </a:tc>
+                <a:tc>
+                  <a:txBody>
+                    <a:bodyPr/>
+                    <a:lstStyle/>
+                    <a:p>
+                      <a:pPr algn="ctr" fontAlgn="b">
+                        <a:buNone/>
+                      </a:pPr>
+                      <a:r>
+                        <a:rPr lang="en-US" sz="1800" b="1" u="none" strike="noStrike" dirty="0" err="1">
+                          <a:effectLst/>
+                        </a:rPr>
+                        <a:t>gpu</a:t>
+                      </a:r>
+                      <a:r>
+                        <a:rPr lang="en-US" sz="1800" b="1" u="none" strike="noStrike" dirty="0">
+                          <a:effectLst/>
+                        </a:rPr>
+                        <a:t>-hybrid-drop </a:t>
+                      </a:r>
+                      <a:endParaRPr lang="en-US" sz="1800" b="1" i="0" u="none" strike="noStrike" dirty="0">
+                        <a:solidFill>
+                          <a:srgbClr val="FFFFFF"/>
+                        </a:solidFill>
+                        <a:effectLst/>
+                        <a:latin typeface="Aptos Narrow" panose="020B0004020202020204" pitchFamily="34" charset="0"/>
+                      </a:endParaRPr>
+                    </a:p>
+                  </a:txBody>
+                  <a:tcPr marL="5454" marR="5454" marT="5454" marB="0" anchor="b"/>
+                </a:tc>
+                <a:tc>
+                  <a:txBody>
+                    <a:bodyPr/>
+                    <a:lstStyle/>
+                    <a:p>
+                      <a:pPr algn="ctr" fontAlgn="b">
+                        <a:buNone/>
+                      </a:pPr>
+                      <a:r>
+                        <a:rPr lang="en-US" sz="1600" b="1" u="none" strike="noStrike" dirty="0" err="1">
+                          <a:solidFill>
+                            <a:schemeClr val="accent1"/>
+                          </a:solidFill>
+                          <a:effectLst/>
+                        </a:rPr>
+                        <a:t>gpu</a:t>
+                      </a:r>
+                      <a:r>
+                        <a:rPr lang="en-US" sz="1600" b="1" u="none" strike="noStrike" dirty="0">
+                          <a:solidFill>
+                            <a:schemeClr val="accent1"/>
+                          </a:solidFill>
+                          <a:effectLst/>
+                        </a:rPr>
+                        <a:t>-hybrid-copy</a:t>
+                      </a:r>
+                      <a:endParaRPr lang="en-US" sz="1600" b="1" i="0" u="none" strike="noStrike" dirty="0">
+                        <a:solidFill>
+                          <a:schemeClr val="accent1"/>
+                        </a:solidFill>
+                        <a:effectLst/>
+                        <a:latin typeface="Aptos Narrow" panose="020B0004020202020204" pitchFamily="34" charset="0"/>
+                      </a:endParaRPr>
+                    </a:p>
+                  </a:txBody>
+                  <a:tcPr marL="9525" marR="9525" marT="9525" marB="0" anchor="b"/>
+                </a:tc>
+                <a:extLst>
+                  <a:ext uri="{0D108BD9-81ED-4DB2-BD59-A6C34878D82A}">
+                    <a16:rowId xmlns:a16="http://schemas.microsoft.com/office/drawing/2014/main" val="2035187684"/>
+                  </a:ext>
+                </a:extLst>
+              </a:tr>
+              <a:tr h="327345">
+                <a:tc>
+                  <a:txBody>
+                    <a:bodyPr/>
+                    <a:lstStyle/>
+                    <a:p>
+                      <a:pPr algn="l" fontAlgn="b">
+                        <a:buNone/>
+                      </a:pPr>
+                      <a:r>
+                        <a:rPr lang="en-US" sz="1800" u="none" strike="noStrike">
+                          <a:effectLst/>
+                        </a:rPr>
+                        <a:t>edit-nlwiki</a:t>
+                      </a:r>
+                      <a:endParaRPr lang="en-US" sz="1800" b="0" i="0" u="none" strike="noStrike">
+                        <a:solidFill>
+                          <a:srgbClr val="000000"/>
+                        </a:solidFill>
+                        <a:effectLst/>
+                        <a:latin typeface="Aptos Narrow" panose="020B0004020202020204" pitchFamily="34" charset="0"/>
+                      </a:endParaRPr>
+                    </a:p>
+                  </a:txBody>
+                  <a:tcPr marL="5454" marR="5454" marT="5454" marB="0" anchor="b"/>
+                </a:tc>
+                <a:tc>
+                  <a:txBody>
+                    <a:bodyPr/>
+                    <a:lstStyle/>
+                    <a:p>
+                      <a:pPr algn="ctr" fontAlgn="b">
+                        <a:buNone/>
+                      </a:pPr>
+                      <a:r>
+                        <a:rPr lang="en-US" sz="1800" u="none" strike="noStrike" dirty="0">
+                          <a:effectLst/>
+                        </a:rPr>
+                        <a:t>11.3</a:t>
+                      </a:r>
+                      <a:endParaRPr lang="en-US" sz="1800" b="0" i="0" u="none" strike="noStrike" dirty="0">
+                        <a:solidFill>
+                          <a:srgbClr val="000000"/>
+                        </a:solidFill>
+                        <a:effectLst/>
+                        <a:latin typeface="Aptos Narrow" panose="020B0004020202020204" pitchFamily="34" charset="0"/>
+                      </a:endParaRPr>
+                    </a:p>
+                  </a:txBody>
+                  <a:tcPr marL="5454" marR="5454" marT="5454" marB="0" anchor="b"/>
+                </a:tc>
+                <a:tc>
+                  <a:txBody>
+                    <a:bodyPr/>
+                    <a:lstStyle/>
+                    <a:p>
+                      <a:pPr algn="ctr" fontAlgn="b">
+                        <a:buNone/>
+                      </a:pPr>
+                      <a:r>
+                        <a:rPr lang="en-US" sz="1800" u="none" strike="noStrike" dirty="0">
+                          <a:effectLst/>
+                        </a:rPr>
+                        <a:t>20.0</a:t>
+                      </a:r>
+                      <a:endParaRPr lang="en-US" sz="1800" b="0" i="0" u="none" strike="noStrike" dirty="0">
+                        <a:solidFill>
+                          <a:srgbClr val="000000"/>
+                        </a:solidFill>
+                        <a:effectLst/>
+                        <a:latin typeface="Aptos Narrow" panose="020B0004020202020204" pitchFamily="34" charset="0"/>
+                      </a:endParaRPr>
+                    </a:p>
+                  </a:txBody>
+                  <a:tcPr marL="5454" marR="5454" marT="5454" marB="0" anchor="b"/>
+                </a:tc>
+                <a:tc>
+                  <a:txBody>
+                    <a:bodyPr/>
+                    <a:lstStyle/>
+                    <a:p>
+                      <a:pPr algn="r" fontAlgn="b">
+                        <a:buNone/>
+                      </a:pPr>
+                      <a:r>
+                        <a:rPr lang="en-US" sz="1800" u="none" strike="noStrike" dirty="0">
+                          <a:effectLst/>
+                        </a:rPr>
+                        <a:t>12.4</a:t>
+                      </a:r>
+                      <a:endParaRPr lang="en-US" sz="1800" b="0" i="0" u="none" strike="noStrike" dirty="0">
+                        <a:solidFill>
+                          <a:srgbClr val="000000"/>
+                        </a:solidFill>
+                        <a:effectLst/>
+                        <a:latin typeface="Monaco" pitchFamily="2" charset="77"/>
+                      </a:endParaRPr>
+                    </a:p>
+                  </a:txBody>
+                  <a:tcPr marL="5454" marR="5454" marT="5454" marB="0" anchor="b"/>
+                </a:tc>
+                <a:tc>
+                  <a:txBody>
+                    <a:bodyPr/>
+                    <a:lstStyle/>
+                    <a:p>
+                      <a:pPr algn="ctr" fontAlgn="b">
+                        <a:buNone/>
+                      </a:pPr>
+                      <a:r>
+                        <a:rPr lang="en-US" sz="1800" b="0" u="none" strike="noStrike" dirty="0">
+                          <a:solidFill>
+                            <a:schemeClr val="accent1"/>
+                          </a:solidFill>
+                          <a:effectLst/>
+                        </a:rPr>
+                        <a:t>11.0</a:t>
+                      </a:r>
+                      <a:endParaRPr lang="en-US" sz="1800" b="0" i="0" u="none" strike="noStrike" dirty="0">
+                        <a:solidFill>
+                          <a:schemeClr val="accent1"/>
+                        </a:solidFill>
+                        <a:effectLst/>
+                        <a:latin typeface="Aptos Narrow" panose="020B0004020202020204" pitchFamily="34" charset="0"/>
+                      </a:endParaRPr>
+                    </a:p>
+                  </a:txBody>
+                  <a:tcPr marL="9525" marR="9525" marT="9525" marB="0" anchor="b"/>
+                </a:tc>
+                <a:extLst>
+                  <a:ext uri="{0D108BD9-81ED-4DB2-BD59-A6C34878D82A}">
+                    <a16:rowId xmlns:a16="http://schemas.microsoft.com/office/drawing/2014/main" val="932854261"/>
+                  </a:ext>
+                </a:extLst>
+              </a:tr>
+            </a:tbl>
+          </a:graphicData>
+        </a:graphic>
+      </p:graphicFrame>
+      <p:sp>
+        <p:nvSpPr>
+          <p:cNvPr id="9" name="TextBox 8">
+            <a:extLst>
+              <a:ext uri="{FF2B5EF4-FFF2-40B4-BE49-F238E27FC236}">
+                <a16:creationId xmlns:a16="http://schemas.microsoft.com/office/drawing/2014/main" id="{23B95060-A99D-E2AE-DB18-3CC5868B03BB}"/>
+              </a:ext>
+            </a:extLst>
+          </p:cNvPr>
+          <p:cNvSpPr txBox="1"/>
+          <p:nvPr/>
+        </p:nvSpPr>
+        <p:spPr>
+          <a:xfrm>
+            <a:off x="675409" y="5268191"/>
+            <a:ext cx="3767763" cy="369332"/>
+          </a:xfrm>
+          <a:prstGeom prst="rect">
+            <a:avLst/>
+          </a:prstGeom>
+          <a:noFill/>
+        </p:spPr>
+        <p:txBody>
+          <a:bodyPr wrap="none" rtlCol="0">
+            <a:spAutoFit/>
+          </a:bodyPr>
+          <a:lstStyle/>
+          <a:p>
+            <a:r>
+              <a:rPr lang="en-US" dirty="0"/>
+              <a:t>experiments with other values of eta</a:t>
+            </a:r>
+          </a:p>
+        </p:txBody>
+      </p:sp>
+    </p:spTree>
+    <p:extLst>
+      <p:ext uri="{BB962C8B-B14F-4D97-AF65-F5344CB8AC3E}">
+        <p14:creationId xmlns:p14="http://schemas.microsoft.com/office/powerpoint/2010/main" val="2863794999"/>
+      </p:ext>
+    </p:extLst>
+  </p:cSld>
+  <p:clrMapOvr>
+    <a:masterClrMapping/>
+  </p:clrMapOvr>
+</p:sld>
+</file>
+
+<file path=ppt/slides/slide12.xml><?xml version="1.0" encoding="utf-8"?>
+<p:sld xmlns:a="http://schemas.openxmlformats.org/drawingml/2006/main" xmlns:r="http://schemas.openxmlformats.org/officeDocument/2006/relationships" xmlns:p="http://schemas.openxmlformats.org/presentationml/2006/main">
+  <p:cSld>
+    <p:spTree>
+      <p:nvGrpSpPr>
+        <p:cNvPr id="1" name=""/>
+        <p:cNvGrpSpPr/>
+        <p:nvPr/>
+      </p:nvGrpSpPr>
+      <p:grpSpPr>
+        <a:xfrm>
+          <a:off x="0" y="0"/>
+          <a:ext cx="0" cy="0"/>
+          <a:chOff x="0" y="0"/>
+          <a:chExt cx="0" cy="0"/>
+        </a:xfrm>
+      </p:grpSpPr>
+      <p:sp>
+        <p:nvSpPr>
+          <p:cNvPr id="2" name="Title 1">
+            <a:extLst>
+              <a:ext uri="{FF2B5EF4-FFF2-40B4-BE49-F238E27FC236}">
+                <a16:creationId xmlns:a16="http://schemas.microsoft.com/office/drawing/2014/main" id="{E2D6E464-F975-0C7D-197A-2970399E6190}"/>
+              </a:ext>
+            </a:extLst>
+          </p:cNvPr>
+          <p:cNvSpPr>
+            <a:spLocks noGrp="1"/>
+          </p:cNvSpPr>
+          <p:nvPr>
+            <p:ph type="title"/>
+          </p:nvPr>
+        </p:nvSpPr>
+        <p:spPr/>
+        <p:txBody>
+          <a:bodyPr/>
+          <a:lstStyle/>
+          <a:p>
+            <a:r>
+              <a:rPr lang="en-US" dirty="0"/>
+              <a:t>Why hybrid-drop is slower than layered?</a:t>
+            </a:r>
+          </a:p>
+        </p:txBody>
+      </p:sp>
+      <p:sp>
+        <p:nvSpPr>
+          <p:cNvPr id="3" name="Content Placeholder 2">
+            <a:extLst>
+              <a:ext uri="{FF2B5EF4-FFF2-40B4-BE49-F238E27FC236}">
+                <a16:creationId xmlns:a16="http://schemas.microsoft.com/office/drawing/2014/main" id="{E9A6BDEF-0548-33E3-938B-027E7E255047}"/>
+              </a:ext>
+            </a:extLst>
+          </p:cNvPr>
+          <p:cNvSpPr>
+            <a:spLocks noGrp="1"/>
+          </p:cNvSpPr>
+          <p:nvPr>
+            <p:ph idx="1"/>
+          </p:nvPr>
+        </p:nvSpPr>
+        <p:spPr/>
+        <p:txBody>
+          <a:bodyPr/>
+          <a:lstStyle/>
+          <a:p>
+            <a:r>
+              <a:rPr lang="en-US" dirty="0"/>
+              <a:t>It was caused by an incorrect </a:t>
+            </a:r>
+            <a:r>
+              <a:rPr lang="en-US" dirty="0" err="1"/>
+              <a:t>gpuchunk</a:t>
+            </a:r>
+            <a:r>
+              <a:rPr lang="en-US" dirty="0"/>
+              <a:t> setting: </a:t>
+            </a:r>
+          </a:p>
+          <a:p>
+            <a:pPr marL="457200" lvl="1" indent="0">
+              <a:buNone/>
+            </a:pPr>
+            <a:r>
+              <a:rPr lang="en-US" dirty="0"/>
+              <a:t>Hybrid-Drop used 100K, while the others used 1M.</a:t>
+            </a:r>
+          </a:p>
+        </p:txBody>
+      </p:sp>
+      <p:graphicFrame>
+        <p:nvGraphicFramePr>
+          <p:cNvPr id="6" name="Table 5">
+            <a:extLst>
+              <a:ext uri="{FF2B5EF4-FFF2-40B4-BE49-F238E27FC236}">
+                <a16:creationId xmlns:a16="http://schemas.microsoft.com/office/drawing/2014/main" id="{3C79D71B-105A-025B-1FD4-CB5747B99BA5}"/>
+              </a:ext>
+            </a:extLst>
+          </p:cNvPr>
+          <p:cNvGraphicFramePr>
+            <a:graphicFrameLocks noGrp="1"/>
+          </p:cNvGraphicFramePr>
+          <p:nvPr>
+            <p:extLst>
+              <p:ext uri="{D42A27DB-BD31-4B8C-83A1-F6EECF244321}">
+                <p14:modId xmlns:p14="http://schemas.microsoft.com/office/powerpoint/2010/main" val="2218124874"/>
+              </p:ext>
+            </p:extLst>
+          </p:nvPr>
+        </p:nvGraphicFramePr>
+        <p:xfrm>
+          <a:off x="509155" y="3761509"/>
+          <a:ext cx="10920846" cy="1136215"/>
+        </p:xfrm>
+        <a:graphic>
+          <a:graphicData uri="http://schemas.openxmlformats.org/drawingml/2006/table">
+            <a:tbl>
+              <a:tblPr>
+                <a:tableStyleId>{5C22544A-7EE6-4342-B048-85BDC9FD1C3A}</a:tableStyleId>
+              </a:tblPr>
+              <a:tblGrid>
+                <a:gridCol w="2202872">
+                  <a:extLst>
+                    <a:ext uri="{9D8B030D-6E8A-4147-A177-3AD203B41FA5}">
+                      <a16:colId xmlns:a16="http://schemas.microsoft.com/office/drawing/2014/main" val="2457110133"/>
+                    </a:ext>
+                  </a:extLst>
+                </a:gridCol>
+                <a:gridCol w="1953491">
+                  <a:extLst>
+                    <a:ext uri="{9D8B030D-6E8A-4147-A177-3AD203B41FA5}">
+                      <a16:colId xmlns:a16="http://schemas.microsoft.com/office/drawing/2014/main" val="3853503667"/>
+                    </a:ext>
+                  </a:extLst>
+                </a:gridCol>
+                <a:gridCol w="1527464">
+                  <a:extLst>
+                    <a:ext uri="{9D8B030D-6E8A-4147-A177-3AD203B41FA5}">
+                      <a16:colId xmlns:a16="http://schemas.microsoft.com/office/drawing/2014/main" val="1010362570"/>
+                    </a:ext>
+                  </a:extLst>
+                </a:gridCol>
+                <a:gridCol w="2254409">
+                  <a:extLst>
+                    <a:ext uri="{9D8B030D-6E8A-4147-A177-3AD203B41FA5}">
+                      <a16:colId xmlns:a16="http://schemas.microsoft.com/office/drawing/2014/main" val="3721380"/>
+                    </a:ext>
+                  </a:extLst>
+                </a:gridCol>
+                <a:gridCol w="2982610">
+                  <a:extLst>
+                    <a:ext uri="{9D8B030D-6E8A-4147-A177-3AD203B41FA5}">
+                      <a16:colId xmlns:a16="http://schemas.microsoft.com/office/drawing/2014/main" val="3894600151"/>
+                    </a:ext>
+                  </a:extLst>
+                </a:gridCol>
+              </a:tblGrid>
+              <a:tr h="639010">
+                <a:tc>
+                  <a:txBody>
+                    <a:bodyPr/>
+                    <a:lstStyle/>
+                    <a:p>
+                      <a:pPr algn="ctr" fontAlgn="b">
+                        <a:buNone/>
+                      </a:pPr>
+                      <a:r>
+                        <a:rPr lang="en-US" sz="1800" b="1" u="none" strike="noStrike" dirty="0">
+                          <a:effectLst/>
+                        </a:rPr>
+                        <a:t>dataset</a:t>
+                      </a:r>
+                      <a:endParaRPr lang="en-US" sz="1800" b="1" i="0" u="none" strike="noStrike" dirty="0">
+                        <a:solidFill>
+                          <a:srgbClr val="FFFFFF"/>
+                        </a:solidFill>
+                        <a:effectLst/>
+                        <a:latin typeface="Aptos Narrow" panose="020B0004020202020204" pitchFamily="34" charset="0"/>
+                      </a:endParaRPr>
+                    </a:p>
+                  </a:txBody>
+                  <a:tcPr marL="5454" marR="5454" marT="5454" marB="0" anchor="b"/>
+                </a:tc>
+                <a:tc>
+                  <a:txBody>
+                    <a:bodyPr/>
+                    <a:lstStyle/>
+                    <a:p>
+                      <a:pPr algn="ctr" fontAlgn="b">
+                        <a:buNone/>
+                      </a:pPr>
+                      <a:r>
+                        <a:rPr lang="en-US" sz="1800" b="1" u="none" strike="noStrike" dirty="0">
+                          <a:effectLst/>
+                        </a:rPr>
+                        <a:t>G2AIMD (</a:t>
+                      </a:r>
+                      <a:r>
+                        <a:rPr lang="en-US" sz="1800" b="1" u="none" strike="noStrike" dirty="0" err="1">
+                          <a:effectLst/>
+                        </a:rPr>
+                        <a:t>pingpong</a:t>
+                      </a:r>
+                      <a:r>
+                        <a:rPr lang="en-US" sz="1800" b="1" u="none" strike="noStrike" dirty="0">
+                          <a:effectLst/>
+                        </a:rPr>
+                        <a:t>)</a:t>
+                      </a:r>
+                      <a:endParaRPr lang="en-US" sz="1800" b="1" i="0" u="none" strike="noStrike" dirty="0">
+                        <a:solidFill>
+                          <a:srgbClr val="FFFFFF"/>
+                        </a:solidFill>
+                        <a:effectLst/>
+                        <a:latin typeface="Aptos Narrow" panose="020B0004020202020204" pitchFamily="34" charset="0"/>
+                      </a:endParaRPr>
+                    </a:p>
+                  </a:txBody>
+                  <a:tcPr marL="5454" marR="5454" marT="5454" marB="0" anchor="b"/>
+                </a:tc>
+                <a:tc>
+                  <a:txBody>
+                    <a:bodyPr/>
+                    <a:lstStyle/>
+                    <a:p>
+                      <a:pPr algn="ctr" fontAlgn="b">
+                        <a:buNone/>
+                      </a:pPr>
+                      <a:r>
+                        <a:rPr lang="en-US" sz="1800" b="1" u="none" strike="noStrike" dirty="0" err="1">
+                          <a:effectLst/>
+                        </a:rPr>
+                        <a:t>gpu</a:t>
+                      </a:r>
+                      <a:r>
+                        <a:rPr lang="en-US" sz="1800" b="1" u="none" strike="noStrike" dirty="0">
+                          <a:effectLst/>
+                        </a:rPr>
+                        <a:t>-layered</a:t>
+                      </a:r>
+                      <a:endParaRPr lang="en-US" sz="1800" b="1" i="0" u="none" strike="noStrike" dirty="0">
+                        <a:solidFill>
+                          <a:srgbClr val="FFFFFF"/>
+                        </a:solidFill>
+                        <a:effectLst/>
+                        <a:latin typeface="Aptos Narrow" panose="020B0004020202020204" pitchFamily="34" charset="0"/>
+                      </a:endParaRPr>
+                    </a:p>
+                  </a:txBody>
+                  <a:tcPr marL="5454" marR="5454" marT="5454" marB="0" anchor="b"/>
+                </a:tc>
+                <a:tc>
+                  <a:txBody>
+                    <a:bodyPr/>
+                    <a:lstStyle/>
+                    <a:p>
+                      <a:pPr algn="ctr" fontAlgn="b">
+                        <a:buNone/>
+                      </a:pPr>
+                      <a:r>
+                        <a:rPr lang="en-US" sz="1800" b="1" u="none" strike="noStrike" dirty="0" err="1">
+                          <a:solidFill>
+                            <a:srgbClr val="C00000"/>
+                          </a:solidFill>
+                          <a:effectLst/>
+                        </a:rPr>
+                        <a:t>gpu</a:t>
+                      </a:r>
+                      <a:r>
+                        <a:rPr lang="en-US" sz="1800" b="1" u="none" strike="noStrike" dirty="0">
+                          <a:solidFill>
+                            <a:srgbClr val="C00000"/>
+                          </a:solidFill>
+                          <a:effectLst/>
+                        </a:rPr>
+                        <a:t>-hybrid-drop </a:t>
+                      </a:r>
+                      <a:endParaRPr lang="en-US" sz="1800" b="1" i="0" u="none" strike="noStrike" dirty="0">
+                        <a:solidFill>
+                          <a:srgbClr val="C00000"/>
+                        </a:solidFill>
+                        <a:effectLst/>
+                        <a:latin typeface="Aptos Narrow" panose="020B0004020202020204" pitchFamily="34" charset="0"/>
+                      </a:endParaRPr>
+                    </a:p>
+                  </a:txBody>
+                  <a:tcPr marL="5454" marR="5454" marT="5454" marB="0" anchor="b"/>
+                </a:tc>
+                <a:tc>
+                  <a:txBody>
+                    <a:bodyPr/>
+                    <a:lstStyle/>
+                    <a:p>
+                      <a:pPr algn="ctr" fontAlgn="b">
+                        <a:buNone/>
+                      </a:pPr>
+                      <a:r>
+                        <a:rPr lang="en-US" sz="1600" b="1" u="none" strike="noStrike" dirty="0" err="1">
+                          <a:solidFill>
+                            <a:schemeClr val="tx1"/>
+                          </a:solidFill>
+                          <a:effectLst/>
+                        </a:rPr>
+                        <a:t>gpu</a:t>
+                      </a:r>
+                      <a:r>
+                        <a:rPr lang="en-US" sz="1600" b="1" u="none" strike="noStrike" dirty="0">
+                          <a:solidFill>
+                            <a:schemeClr val="tx1"/>
+                          </a:solidFill>
+                          <a:effectLst/>
+                        </a:rPr>
+                        <a:t>-hybrid-copy</a:t>
+                      </a:r>
+                      <a:endParaRPr lang="en-US" sz="1600" b="1" i="0" u="none" strike="noStrike" dirty="0">
+                        <a:solidFill>
+                          <a:schemeClr val="tx1"/>
+                        </a:solidFill>
+                        <a:effectLst/>
+                        <a:latin typeface="Aptos Narrow" panose="020B0004020202020204" pitchFamily="34" charset="0"/>
+                      </a:endParaRPr>
+                    </a:p>
+                  </a:txBody>
+                  <a:tcPr marL="9525" marR="9525" marT="9525" marB="0" anchor="b"/>
+                </a:tc>
+                <a:extLst>
+                  <a:ext uri="{0D108BD9-81ED-4DB2-BD59-A6C34878D82A}">
+                    <a16:rowId xmlns:a16="http://schemas.microsoft.com/office/drawing/2014/main" val="2035187684"/>
+                  </a:ext>
+                </a:extLst>
+              </a:tr>
+              <a:tr h="327345">
+                <a:tc>
+                  <a:txBody>
+                    <a:bodyPr/>
+                    <a:lstStyle/>
+                    <a:p>
+                      <a:pPr algn="l" fontAlgn="b">
+                        <a:buNone/>
+                      </a:pPr>
+                      <a:r>
+                        <a:rPr lang="en-US" sz="1600" b="0" u="none" strike="noStrike" dirty="0">
+                          <a:solidFill>
+                            <a:schemeClr val="tx1"/>
+                          </a:solidFill>
+                          <a:effectLst/>
+                        </a:rPr>
+                        <a:t>web-wikipedia_link_en13-all</a:t>
+                      </a:r>
+                      <a:endParaRPr lang="en-US" sz="1600" b="0" i="0" u="none" strike="noStrike" dirty="0">
+                        <a:solidFill>
+                          <a:schemeClr val="tx1"/>
+                        </a:solidFill>
+                        <a:effectLst/>
+                        <a:latin typeface="Aptos Narrow" panose="020B0004020202020204" pitchFamily="34" charset="0"/>
+                      </a:endParaRPr>
+                    </a:p>
+                  </a:txBody>
+                  <a:tcPr marL="9525" marR="9525" marT="9525" marB="0" anchor="b"/>
+                </a:tc>
+                <a:tc>
+                  <a:txBody>
+                    <a:bodyPr/>
+                    <a:lstStyle/>
+                    <a:p>
+                      <a:pPr algn="ctr" fontAlgn="b">
+                        <a:buNone/>
+                      </a:pPr>
+                      <a:r>
+                        <a:rPr lang="en-US" sz="1800" b="0" u="none" strike="noStrike" dirty="0">
+                          <a:solidFill>
+                            <a:schemeClr val="tx1"/>
+                          </a:solidFill>
+                          <a:effectLst/>
+                        </a:rPr>
+                        <a:t>150.7</a:t>
+                      </a:r>
+                      <a:endParaRPr lang="en-US" sz="1800" b="0" i="0" u="none" strike="noStrike" dirty="0">
+                        <a:solidFill>
+                          <a:schemeClr val="tx1"/>
+                        </a:solidFill>
+                        <a:effectLst/>
+                        <a:latin typeface="Aptos Narrow" panose="020B0004020202020204" pitchFamily="34" charset="0"/>
+                      </a:endParaRPr>
+                    </a:p>
+                  </a:txBody>
+                  <a:tcPr marL="9525" marR="9525" marT="9525" marB="0" anchor="b"/>
+                </a:tc>
+                <a:tc>
+                  <a:txBody>
+                    <a:bodyPr/>
+                    <a:lstStyle/>
+                    <a:p>
+                      <a:pPr algn="ctr" fontAlgn="b">
+                        <a:buNone/>
+                      </a:pPr>
+                      <a:r>
+                        <a:rPr lang="en-US" sz="1800" b="0" u="none" strike="noStrike" dirty="0">
+                          <a:solidFill>
+                            <a:schemeClr val="tx1"/>
+                          </a:solidFill>
+                          <a:effectLst/>
+                        </a:rPr>
+                        <a:t>225.3</a:t>
+                      </a:r>
+                      <a:endParaRPr lang="en-US" sz="1800" b="0" i="0" u="none" strike="noStrike" dirty="0">
+                        <a:solidFill>
+                          <a:schemeClr val="tx1"/>
+                        </a:solidFill>
+                        <a:effectLst/>
+                        <a:latin typeface="Aptos Narrow" panose="020B0004020202020204" pitchFamily="34" charset="0"/>
+                      </a:endParaRPr>
+                    </a:p>
+                  </a:txBody>
+                  <a:tcPr marL="9525" marR="9525" marT="9525" marB="0" anchor="b"/>
+                </a:tc>
+                <a:tc>
+                  <a:txBody>
+                    <a:bodyPr/>
+                    <a:lstStyle/>
+                    <a:p>
+                      <a:pPr algn="ctr" fontAlgn="b">
+                        <a:buNone/>
+                      </a:pPr>
+                      <a:r>
+                        <a:rPr lang="en-US" sz="1700" b="0" u="none" strike="noStrike" dirty="0">
+                          <a:solidFill>
+                            <a:srgbClr val="C00000"/>
+                          </a:solidFill>
+                          <a:effectLst/>
+                        </a:rPr>
+                        <a:t>317.9</a:t>
+                      </a:r>
+                      <a:endParaRPr lang="en-US" sz="1700" b="0" i="0" u="none" strike="noStrike" dirty="0">
+                        <a:solidFill>
+                          <a:srgbClr val="C00000"/>
+                        </a:solidFill>
+                        <a:effectLst/>
+                        <a:latin typeface="Monaco" pitchFamily="2" charset="77"/>
+                      </a:endParaRPr>
+                    </a:p>
+                  </a:txBody>
+                  <a:tcPr marL="9525" marR="9525" marT="9525" marB="0" anchor="b"/>
+                </a:tc>
+                <a:tc>
+                  <a:txBody>
+                    <a:bodyPr/>
+                    <a:lstStyle/>
+                    <a:p>
+                      <a:pPr algn="ctr" fontAlgn="b">
+                        <a:buNone/>
+                      </a:pPr>
+                      <a:r>
+                        <a:rPr lang="en-US" sz="1800" b="0" u="none" strike="noStrike" dirty="0">
+                          <a:solidFill>
+                            <a:schemeClr val="tx1"/>
+                          </a:solidFill>
+                          <a:effectLst/>
+                        </a:rPr>
+                        <a:t>147.3</a:t>
+                      </a:r>
+                      <a:endParaRPr lang="en-US" sz="1800" b="0" i="0" u="none" strike="noStrike" dirty="0">
+                        <a:solidFill>
+                          <a:schemeClr val="tx1"/>
+                        </a:solidFill>
+                        <a:effectLst/>
+                        <a:latin typeface="Aptos Narrow" panose="020B0004020202020204" pitchFamily="34" charset="0"/>
+                      </a:endParaRPr>
+                    </a:p>
+                  </a:txBody>
+                  <a:tcPr marL="9525" marR="9525" marT="9525" marB="0" anchor="b"/>
+                </a:tc>
+                <a:extLst>
+                  <a:ext uri="{0D108BD9-81ED-4DB2-BD59-A6C34878D82A}">
+                    <a16:rowId xmlns:a16="http://schemas.microsoft.com/office/drawing/2014/main" val="932854261"/>
+                  </a:ext>
+                </a:extLst>
+              </a:tr>
+            </a:tbl>
+          </a:graphicData>
+        </a:graphic>
+      </p:graphicFrame>
+    </p:spTree>
+    <p:extLst>
+      <p:ext uri="{BB962C8B-B14F-4D97-AF65-F5344CB8AC3E}">
+        <p14:creationId xmlns:p14="http://schemas.microsoft.com/office/powerpoint/2010/main" val="3038923083"/>
+      </p:ext>
+    </p:extLst>
+  </p:cSld>
+  <p:clrMapOvr>
+    <a:masterClrMapping/>
+  </p:clrMapOvr>
+</p:sld>
+</file>
+
+<file path=ppt/slides/slide13.xml><?xml version="1.0" encoding="utf-8"?>
+<p:sld xmlns:a="http://schemas.openxmlformats.org/drawingml/2006/main" xmlns:r="http://schemas.openxmlformats.org/officeDocument/2006/relationships" xmlns:p="http://schemas.openxmlformats.org/presentationml/2006/main">
+  <p:cSld>
+    <p:spTree>
+      <p:nvGrpSpPr>
+        <p:cNvPr id="1" name=""/>
+        <p:cNvGrpSpPr/>
+        <p:nvPr/>
+      </p:nvGrpSpPr>
+      <p:grpSpPr>
+        <a:xfrm>
+          <a:off x="0" y="0"/>
+          <a:ext cx="0" cy="0"/>
+          <a:chOff x="0" y="0"/>
+          <a:chExt cx="0" cy="0"/>
+        </a:xfrm>
+      </p:grpSpPr>
+      <p:sp>
+        <p:nvSpPr>
+          <p:cNvPr id="2" name="Title 1">
+            <a:extLst>
+              <a:ext uri="{FF2B5EF4-FFF2-40B4-BE49-F238E27FC236}">
+                <a16:creationId xmlns:a16="http://schemas.microsoft.com/office/drawing/2014/main" id="{30F612FE-A783-B001-47EB-C974AAAD00C7}"/>
+              </a:ext>
+            </a:extLst>
+          </p:cNvPr>
+          <p:cNvSpPr>
+            <a:spLocks noGrp="1"/>
+          </p:cNvSpPr>
+          <p:nvPr>
+            <p:ph type="title"/>
+          </p:nvPr>
+        </p:nvSpPr>
+        <p:spPr/>
+        <p:txBody>
+          <a:bodyPr/>
+          <a:lstStyle/>
+          <a:p>
+            <a:r>
+              <a:rPr lang="en-US" dirty="0"/>
+              <a:t>Why hybrid is slower than layered? (SM)</a:t>
+            </a:r>
+          </a:p>
+        </p:txBody>
+      </p:sp>
+      <p:graphicFrame>
+        <p:nvGraphicFramePr>
+          <p:cNvPr id="4" name="Content Placeholder 3">
+            <a:extLst>
+              <a:ext uri="{FF2B5EF4-FFF2-40B4-BE49-F238E27FC236}">
+                <a16:creationId xmlns:a16="http://schemas.microsoft.com/office/drawing/2014/main" id="{EC9936E5-358D-5258-9BD9-A37F7DC97992}"/>
+              </a:ext>
+            </a:extLst>
+          </p:cNvPr>
+          <p:cNvGraphicFramePr>
+            <a:graphicFrameLocks noGrp="1"/>
+          </p:cNvGraphicFramePr>
+          <p:nvPr>
+            <p:ph idx="1"/>
+            <p:extLst>
+              <p:ext uri="{D42A27DB-BD31-4B8C-83A1-F6EECF244321}">
+                <p14:modId xmlns:p14="http://schemas.microsoft.com/office/powerpoint/2010/main" val="2113408363"/>
+              </p:ext>
+            </p:extLst>
+          </p:nvPr>
+        </p:nvGraphicFramePr>
+        <p:xfrm>
+          <a:off x="838200" y="2700976"/>
+          <a:ext cx="10515600" cy="526440"/>
+        </p:xfrm>
+        <a:graphic>
+          <a:graphicData uri="http://schemas.openxmlformats.org/drawingml/2006/table">
+            <a:tbl>
+              <a:tblPr>
+                <a:tableStyleId>{073A0DAA-6AF3-43AB-8588-CEC1D06C72B9}</a:tableStyleId>
+              </a:tblPr>
+              <a:tblGrid>
+                <a:gridCol w="2916250">
+                  <a:extLst>
+                    <a:ext uri="{9D8B030D-6E8A-4147-A177-3AD203B41FA5}">
+                      <a16:colId xmlns:a16="http://schemas.microsoft.com/office/drawing/2014/main" val="1046455315"/>
+                    </a:ext>
+                  </a:extLst>
+                </a:gridCol>
+                <a:gridCol w="838332">
+                  <a:extLst>
+                    <a:ext uri="{9D8B030D-6E8A-4147-A177-3AD203B41FA5}">
+                      <a16:colId xmlns:a16="http://schemas.microsoft.com/office/drawing/2014/main" val="1687158871"/>
+                    </a:ext>
+                  </a:extLst>
+                </a:gridCol>
+                <a:gridCol w="2201408">
+                  <a:extLst>
+                    <a:ext uri="{9D8B030D-6E8A-4147-A177-3AD203B41FA5}">
+                      <a16:colId xmlns:a16="http://schemas.microsoft.com/office/drawing/2014/main" val="263035580"/>
+                    </a:ext>
+                  </a:extLst>
+                </a:gridCol>
+                <a:gridCol w="1227592">
+                  <a:extLst>
+                    <a:ext uri="{9D8B030D-6E8A-4147-A177-3AD203B41FA5}">
+                      <a16:colId xmlns:a16="http://schemas.microsoft.com/office/drawing/2014/main" val="4056306273"/>
+                    </a:ext>
+                  </a:extLst>
+                </a:gridCol>
+                <a:gridCol w="1812148">
+                  <a:extLst>
+                    <a:ext uri="{9D8B030D-6E8A-4147-A177-3AD203B41FA5}">
+                      <a16:colId xmlns:a16="http://schemas.microsoft.com/office/drawing/2014/main" val="329124393"/>
+                    </a:ext>
+                  </a:extLst>
+                </a:gridCol>
+                <a:gridCol w="1519870">
+                  <a:extLst>
+                    <a:ext uri="{9D8B030D-6E8A-4147-A177-3AD203B41FA5}">
+                      <a16:colId xmlns:a16="http://schemas.microsoft.com/office/drawing/2014/main" val="2603204388"/>
+                    </a:ext>
+                  </a:extLst>
+                </a:gridCol>
+              </a:tblGrid>
+              <a:tr h="275476">
+                <a:tc>
+                  <a:txBody>
+                    <a:bodyPr/>
+                    <a:lstStyle/>
+                    <a:p>
+                      <a:pPr algn="l" fontAlgn="b">
+                        <a:buNone/>
+                      </a:pPr>
+                      <a:r>
+                        <a:rPr lang="en-US" sz="1600" u="none" strike="noStrike">
+                          <a:effectLst/>
+                        </a:rPr>
+                        <a:t>dataset</a:t>
+                      </a:r>
+                      <a:endParaRPr lang="en-US" sz="1600" b="1" i="0" u="none" strike="noStrike">
+                        <a:solidFill>
+                          <a:srgbClr val="FFFFFF"/>
+                        </a:solidFill>
+                        <a:effectLst/>
+                        <a:latin typeface="Aptos Narrow" panose="020B0004020202020204" pitchFamily="34" charset="0"/>
+                      </a:endParaRPr>
+                    </a:p>
+                  </a:txBody>
+                  <a:tcPr marL="7124" marR="7124" marT="7124" marB="0" anchor="b"/>
+                </a:tc>
+                <a:tc>
+                  <a:txBody>
+                    <a:bodyPr/>
+                    <a:lstStyle/>
+                    <a:p>
+                      <a:pPr algn="l" fontAlgn="b">
+                        <a:buNone/>
+                      </a:pPr>
+                      <a:r>
+                        <a:rPr lang="en-US" sz="1600" u="none" strike="noStrike" dirty="0">
+                          <a:effectLst/>
+                        </a:rPr>
+                        <a:t>query</a:t>
+                      </a:r>
+                      <a:endParaRPr lang="en-US" sz="1600" b="1" i="0" u="none" strike="noStrike" dirty="0">
+                        <a:solidFill>
+                          <a:srgbClr val="FFFFFF"/>
+                        </a:solidFill>
+                        <a:effectLst/>
+                        <a:latin typeface="Aptos Narrow" panose="020B0004020202020204" pitchFamily="34" charset="0"/>
+                      </a:endParaRPr>
+                    </a:p>
+                  </a:txBody>
+                  <a:tcPr marL="7124" marR="7124" marT="7124" marB="0" anchor="b"/>
+                </a:tc>
+                <a:tc>
+                  <a:txBody>
+                    <a:bodyPr/>
+                    <a:lstStyle/>
+                    <a:p>
+                      <a:pPr algn="l" fontAlgn="b">
+                        <a:buNone/>
+                      </a:pPr>
+                      <a:r>
+                        <a:rPr lang="en-US" sz="1600" u="none" strike="noStrike">
+                          <a:effectLst/>
+                        </a:rPr>
+                        <a:t>G2AIMD (pingpong)</a:t>
+                      </a:r>
+                      <a:endParaRPr lang="en-US" sz="1600" b="1" i="0" u="none" strike="noStrike">
+                        <a:solidFill>
+                          <a:srgbClr val="FFFFFF"/>
+                        </a:solidFill>
+                        <a:effectLst/>
+                        <a:latin typeface="Aptos Narrow" panose="020B0004020202020204" pitchFamily="34" charset="0"/>
+                      </a:endParaRPr>
+                    </a:p>
+                  </a:txBody>
+                  <a:tcPr marL="7124" marR="7124" marT="7124" marB="0" anchor="b"/>
+                </a:tc>
+                <a:tc>
+                  <a:txBody>
+                    <a:bodyPr/>
+                    <a:lstStyle/>
+                    <a:p>
+                      <a:pPr algn="l" fontAlgn="b">
+                        <a:buNone/>
+                      </a:pPr>
+                      <a:r>
+                        <a:rPr lang="en-US" sz="1600" u="none" strike="noStrike" dirty="0" err="1">
+                          <a:effectLst/>
+                        </a:rPr>
+                        <a:t>gpu</a:t>
+                      </a:r>
+                      <a:r>
+                        <a:rPr lang="en-US" sz="1600" u="none" strike="noStrike" dirty="0">
+                          <a:effectLst/>
+                        </a:rPr>
+                        <a:t>-layered</a:t>
+                      </a:r>
+                      <a:endParaRPr lang="en-US" sz="1600" b="1" i="0" u="none" strike="noStrike" dirty="0">
+                        <a:solidFill>
+                          <a:srgbClr val="FFFFFF"/>
+                        </a:solidFill>
+                        <a:effectLst/>
+                        <a:latin typeface="Aptos Narrow" panose="020B0004020202020204" pitchFamily="34" charset="0"/>
+                      </a:endParaRPr>
+                    </a:p>
+                  </a:txBody>
+                  <a:tcPr marL="7124" marR="7124" marT="7124" marB="0" anchor="b"/>
+                </a:tc>
+                <a:tc>
+                  <a:txBody>
+                    <a:bodyPr/>
+                    <a:lstStyle/>
+                    <a:p>
+                      <a:pPr algn="l" fontAlgn="b">
+                        <a:buNone/>
+                      </a:pPr>
+                      <a:r>
+                        <a:rPr lang="en-US" sz="1600" u="none" strike="noStrike" dirty="0" err="1">
+                          <a:solidFill>
+                            <a:srgbClr val="C00000"/>
+                          </a:solidFill>
+                          <a:effectLst/>
+                        </a:rPr>
+                        <a:t>gpu</a:t>
+                      </a:r>
+                      <a:r>
+                        <a:rPr lang="en-US" sz="1600" u="none" strike="noStrike" dirty="0">
+                          <a:solidFill>
+                            <a:srgbClr val="C00000"/>
+                          </a:solidFill>
+                          <a:effectLst/>
+                        </a:rPr>
+                        <a:t>-hybrid-drop</a:t>
+                      </a:r>
+                      <a:endParaRPr lang="en-US" sz="1600" b="1" i="0" u="none" strike="noStrike" dirty="0">
+                        <a:solidFill>
+                          <a:srgbClr val="C00000"/>
+                        </a:solidFill>
+                        <a:effectLst/>
+                        <a:latin typeface="Aptos Narrow" panose="020B0004020202020204" pitchFamily="34" charset="0"/>
+                      </a:endParaRPr>
+                    </a:p>
+                  </a:txBody>
+                  <a:tcPr marL="7124" marR="7124" marT="7124" marB="0" anchor="b"/>
+                </a:tc>
+                <a:tc>
+                  <a:txBody>
+                    <a:bodyPr/>
+                    <a:lstStyle/>
+                    <a:p>
+                      <a:pPr algn="l" fontAlgn="b">
+                        <a:buNone/>
+                      </a:pPr>
+                      <a:r>
+                        <a:rPr lang="en-US" sz="1600" u="none" strike="noStrike" dirty="0" err="1">
+                          <a:solidFill>
+                            <a:srgbClr val="C00000"/>
+                          </a:solidFill>
+                          <a:effectLst/>
+                        </a:rPr>
+                        <a:t>gpu</a:t>
+                      </a:r>
+                      <a:r>
+                        <a:rPr lang="en-US" sz="1600" u="none" strike="noStrike" dirty="0">
+                          <a:solidFill>
+                            <a:srgbClr val="C00000"/>
+                          </a:solidFill>
+                          <a:effectLst/>
+                        </a:rPr>
+                        <a:t>-hybrid-copy</a:t>
+                      </a:r>
+                      <a:endParaRPr lang="en-US" sz="1600" b="1" i="0" u="none" strike="noStrike" dirty="0">
+                        <a:solidFill>
+                          <a:srgbClr val="C00000"/>
+                        </a:solidFill>
+                        <a:effectLst/>
+                        <a:latin typeface="Aptos Narrow" panose="020B0004020202020204" pitchFamily="34" charset="0"/>
+                      </a:endParaRPr>
+                    </a:p>
+                  </a:txBody>
+                  <a:tcPr marL="7124" marR="7124" marT="7124" marB="0" anchor="b"/>
+                </a:tc>
+                <a:extLst>
+                  <a:ext uri="{0D108BD9-81ED-4DB2-BD59-A6C34878D82A}">
+                    <a16:rowId xmlns:a16="http://schemas.microsoft.com/office/drawing/2014/main" val="1927394708"/>
+                  </a:ext>
+                </a:extLst>
+              </a:tr>
+              <a:tr h="246979">
+                <a:tc>
+                  <a:txBody>
+                    <a:bodyPr/>
+                    <a:lstStyle/>
+                    <a:p>
+                      <a:pPr algn="l" fontAlgn="b">
+                        <a:buNone/>
+                      </a:pPr>
+                      <a:r>
+                        <a:rPr lang="en-US" sz="1600" u="none" strike="noStrike" dirty="0" err="1">
+                          <a:effectLst/>
+                        </a:rPr>
+                        <a:t>zhishi-baidu-internallink</a:t>
+                      </a:r>
+                      <a:endParaRPr lang="en-US" sz="1600" b="0" i="0" u="none" strike="noStrike" dirty="0">
+                        <a:solidFill>
+                          <a:srgbClr val="000000"/>
+                        </a:solidFill>
+                        <a:effectLst/>
+                        <a:latin typeface="Monaco" pitchFamily="2" charset="77"/>
+                      </a:endParaRPr>
+                    </a:p>
+                  </a:txBody>
+                  <a:tcPr marL="7124" marR="7124" marT="7124" marB="0" anchor="b"/>
+                </a:tc>
+                <a:tc>
+                  <a:txBody>
+                    <a:bodyPr/>
+                    <a:lstStyle/>
+                    <a:p>
+                      <a:pPr algn="ctr" fontAlgn="b">
+                        <a:buNone/>
+                      </a:pPr>
+                      <a:r>
+                        <a:rPr lang="en-US" sz="1600" u="none" strike="noStrike" dirty="0">
+                          <a:effectLst/>
+                        </a:rPr>
+                        <a:t>6</a:t>
+                      </a:r>
+                      <a:endParaRPr lang="en-US" sz="1600" b="0" i="0" u="none" strike="noStrike" dirty="0">
+                        <a:solidFill>
+                          <a:srgbClr val="000000"/>
+                        </a:solidFill>
+                        <a:effectLst/>
+                        <a:latin typeface="Monaco" pitchFamily="2" charset="77"/>
+                      </a:endParaRPr>
+                    </a:p>
+                  </a:txBody>
+                  <a:tcPr marL="7124" marR="7124" marT="7124" marB="0" anchor="b"/>
+                </a:tc>
+                <a:tc>
+                  <a:txBody>
+                    <a:bodyPr/>
+                    <a:lstStyle/>
+                    <a:p>
+                      <a:pPr algn="ctr" fontAlgn="b">
+                        <a:buNone/>
+                      </a:pPr>
+                      <a:r>
+                        <a:rPr lang="en-US" sz="1600" u="none" strike="noStrike" dirty="0">
+                          <a:effectLst/>
+                        </a:rPr>
+                        <a:t>42.4</a:t>
+                      </a:r>
+                      <a:endParaRPr lang="en-US" sz="1600" b="0" i="0" u="none" strike="noStrike" dirty="0">
+                        <a:solidFill>
+                          <a:srgbClr val="000000"/>
+                        </a:solidFill>
+                        <a:effectLst/>
+                        <a:latin typeface="Monaco" pitchFamily="2" charset="77"/>
+                      </a:endParaRPr>
+                    </a:p>
+                  </a:txBody>
+                  <a:tcPr marL="7124" marR="7124" marT="7124" marB="0" anchor="b"/>
+                </a:tc>
+                <a:tc>
+                  <a:txBody>
+                    <a:bodyPr/>
+                    <a:lstStyle/>
+                    <a:p>
+                      <a:pPr algn="ctr" fontAlgn="b">
+                        <a:buNone/>
+                      </a:pPr>
+                      <a:r>
+                        <a:rPr lang="en-US" sz="1600" u="none" strike="noStrike" dirty="0">
+                          <a:effectLst/>
+                        </a:rPr>
+                        <a:t>42.5</a:t>
+                      </a:r>
+                      <a:endParaRPr lang="en-US" sz="1600" b="0" i="0" u="none" strike="noStrike" dirty="0">
+                        <a:solidFill>
+                          <a:srgbClr val="000000"/>
+                        </a:solidFill>
+                        <a:effectLst/>
+                        <a:latin typeface="Monaco" pitchFamily="2" charset="77"/>
+                      </a:endParaRPr>
+                    </a:p>
+                  </a:txBody>
+                  <a:tcPr marL="7124" marR="7124" marT="7124" marB="0" anchor="b"/>
+                </a:tc>
+                <a:tc>
+                  <a:txBody>
+                    <a:bodyPr/>
+                    <a:lstStyle/>
+                    <a:p>
+                      <a:pPr algn="ctr" fontAlgn="b">
+                        <a:buNone/>
+                      </a:pPr>
+                      <a:r>
+                        <a:rPr lang="en-US" sz="1600" u="none" strike="noStrike" dirty="0">
+                          <a:solidFill>
+                            <a:srgbClr val="C00000"/>
+                          </a:solidFill>
+                          <a:effectLst/>
+                        </a:rPr>
+                        <a:t>558.7</a:t>
+                      </a:r>
+                      <a:endParaRPr lang="en-US" sz="1600" b="0" i="0" u="none" strike="noStrike" dirty="0">
+                        <a:solidFill>
+                          <a:srgbClr val="C00000"/>
+                        </a:solidFill>
+                        <a:effectLst/>
+                        <a:latin typeface="Monaco" pitchFamily="2" charset="77"/>
+                      </a:endParaRPr>
+                    </a:p>
+                  </a:txBody>
+                  <a:tcPr marL="7124" marR="7124" marT="7124" marB="0" anchor="b"/>
+                </a:tc>
+                <a:tc>
+                  <a:txBody>
+                    <a:bodyPr/>
+                    <a:lstStyle/>
+                    <a:p>
+                      <a:pPr algn="ctr" fontAlgn="b">
+                        <a:buNone/>
+                      </a:pPr>
+                      <a:r>
+                        <a:rPr lang="en-US" sz="1600" u="none" strike="noStrike" dirty="0">
+                          <a:solidFill>
+                            <a:srgbClr val="C00000"/>
+                          </a:solidFill>
+                          <a:effectLst/>
+                        </a:rPr>
+                        <a:t>507.6</a:t>
+                      </a:r>
+                      <a:endParaRPr lang="en-US" sz="1600" b="0" i="0" u="none" strike="noStrike" dirty="0">
+                        <a:solidFill>
+                          <a:srgbClr val="C00000"/>
+                        </a:solidFill>
+                        <a:effectLst/>
+                        <a:latin typeface="Monaco" pitchFamily="2" charset="77"/>
+                      </a:endParaRPr>
+                    </a:p>
+                  </a:txBody>
+                  <a:tcPr marL="7124" marR="7124" marT="7124" marB="0" anchor="b"/>
+                </a:tc>
+                <a:extLst>
+                  <a:ext uri="{0D108BD9-81ED-4DB2-BD59-A6C34878D82A}">
+                    <a16:rowId xmlns:a16="http://schemas.microsoft.com/office/drawing/2014/main" val="2305100746"/>
+                  </a:ext>
+                </a:extLst>
+              </a:tr>
+            </a:tbl>
+          </a:graphicData>
+        </a:graphic>
+      </p:graphicFrame>
+      <p:sp>
+        <p:nvSpPr>
+          <p:cNvPr id="5" name="TextBox 4">
+            <a:extLst>
+              <a:ext uri="{FF2B5EF4-FFF2-40B4-BE49-F238E27FC236}">
+                <a16:creationId xmlns:a16="http://schemas.microsoft.com/office/drawing/2014/main" id="{8BB84B85-9C29-14C3-9295-F96DCFB2D293}"/>
+              </a:ext>
+            </a:extLst>
+          </p:cNvPr>
+          <p:cNvSpPr txBox="1"/>
+          <p:nvPr/>
+        </p:nvSpPr>
+        <p:spPr>
+          <a:xfrm>
+            <a:off x="1091046" y="3910553"/>
+            <a:ext cx="7720446" cy="646331"/>
+          </a:xfrm>
+          <a:prstGeom prst="rect">
+            <a:avLst/>
+          </a:prstGeom>
+          <a:noFill/>
+        </p:spPr>
+        <p:txBody>
+          <a:bodyPr wrap="square" rtlCol="0">
+            <a:spAutoFit/>
+          </a:bodyPr>
+          <a:lstStyle/>
+          <a:p>
+            <a:r>
+              <a:rPr lang="en-US" dirty="0"/>
+              <a:t>In both hybrid modes, overflow tasks spill to the host buffer when device memory is full, causing significant overhead. </a:t>
+            </a:r>
+          </a:p>
+        </p:txBody>
+      </p:sp>
+    </p:spTree>
+    <p:extLst>
+      <p:ext uri="{BB962C8B-B14F-4D97-AF65-F5344CB8AC3E}">
+        <p14:creationId xmlns:p14="http://schemas.microsoft.com/office/powerpoint/2010/main" val="698545430"/>
+      </p:ext>
+    </p:extLst>
+  </p:cSld>
+  <p:clrMapOvr>
+    <a:masterClrMapping/>
+  </p:clrMapOvr>
+</p:sld>
+</file>
+
 <file path=ppt/slides/slide2.xml><?xml version="1.0" encoding="utf-8"?>
 <p:sld xmlns:a="http://schemas.openxmlformats.org/drawingml/2006/main" xmlns:r="http://schemas.openxmlformats.org/officeDocument/2006/relationships" xmlns:p="http://schemas.openxmlformats.org/presentationml/2006/main">
   <p:cSld>
@@ -9381,12 +11424,200 @@
           <a:chExt cx="0" cy="0"/>
         </a:xfrm>
       </p:grpSpPr>
+      <p:pic>
+        <p:nvPicPr>
+          <p:cNvPr id="36" name="Picture 35">
+            <a:extLst>
+              <a:ext uri="{FF2B5EF4-FFF2-40B4-BE49-F238E27FC236}">
+                <a16:creationId xmlns:a16="http://schemas.microsoft.com/office/drawing/2014/main" id="{E5CE3626-FB0A-692A-F035-A1DF78C2178A}"/>
+              </a:ext>
+            </a:extLst>
+          </p:cNvPr>
+          <p:cNvPicPr>
+            <a:picLocks noChangeAspect="1"/>
+          </p:cNvPicPr>
+          <p:nvPr/>
+        </p:nvPicPr>
+        <p:blipFill>
+          <a:blip r:embed="rId2"/>
+          <a:stretch>
+            <a:fillRect/>
+          </a:stretch>
+        </p:blipFill>
+        <p:spPr>
+          <a:xfrm>
+            <a:off x="5098602" y="0"/>
+            <a:ext cx="6603274" cy="6858000"/>
+          </a:xfrm>
+          <a:prstGeom prst="rect">
+            <a:avLst/>
+          </a:prstGeom>
+        </p:spPr>
+      </p:pic>
       <p:sp>
         <p:nvSpPr>
-          <p:cNvPr id="2" name="TextBox 1">
-            <a:extLst>
-              <a:ext uri="{FF2B5EF4-FFF2-40B4-BE49-F238E27FC236}">
-                <a16:creationId xmlns:a16="http://schemas.microsoft.com/office/drawing/2014/main" id="{2352217D-D58A-58DB-010E-B8E0AF2338B1}"/>
+          <p:cNvPr id="2" name="Title 1">
+            <a:extLst>
+              <a:ext uri="{FF2B5EF4-FFF2-40B4-BE49-F238E27FC236}">
+                <a16:creationId xmlns:a16="http://schemas.microsoft.com/office/drawing/2014/main" id="{34150E0C-EF31-9E3B-653E-154243818C07}"/>
+              </a:ext>
+            </a:extLst>
+          </p:cNvPr>
+          <p:cNvSpPr>
+            <a:spLocks noGrp="1"/>
+          </p:cNvSpPr>
+          <p:nvPr>
+            <p:ph type="title"/>
+          </p:nvPr>
+        </p:nvSpPr>
+        <p:spPr/>
+        <p:txBody>
+          <a:bodyPr/>
+          <a:lstStyle/>
+          <a:p>
+            <a:r>
+              <a:rPr lang="en-US" dirty="0"/>
+              <a:t>Scratch Buffer</a:t>
+            </a:r>
+          </a:p>
+        </p:txBody>
+      </p:sp>
+      <p:graphicFrame>
+        <p:nvGraphicFramePr>
+          <p:cNvPr id="31" name="Content Placeholder 3">
+            <a:extLst>
+              <a:ext uri="{FF2B5EF4-FFF2-40B4-BE49-F238E27FC236}">
+                <a16:creationId xmlns:a16="http://schemas.microsoft.com/office/drawing/2014/main" id="{19DFFE26-B75F-43CD-55F5-9E3EA43815AA}"/>
+              </a:ext>
+            </a:extLst>
+          </p:cNvPr>
+          <p:cNvGraphicFramePr>
+            <a:graphicFrameLocks/>
+          </p:cNvGraphicFramePr>
+          <p:nvPr/>
+        </p:nvGraphicFramePr>
+        <p:xfrm>
+          <a:off x="5219609" y="860756"/>
+          <a:ext cx="3180630" cy="438359"/>
+        </p:xfrm>
+        <a:graphic>
+          <a:graphicData uri="http://schemas.openxmlformats.org/drawingml/2006/table">
+            <a:tbl>
+              <a:tblPr firstRow="1" bandRow="1">
+                <a:tableStyleId>{5940675A-B579-460E-94D1-54222C63F5DA}</a:tableStyleId>
+              </a:tblPr>
+              <a:tblGrid>
+                <a:gridCol w="636126">
+                  <a:extLst>
+                    <a:ext uri="{9D8B030D-6E8A-4147-A177-3AD203B41FA5}">
+                      <a16:colId xmlns:a16="http://schemas.microsoft.com/office/drawing/2014/main" val="194980701"/>
+                    </a:ext>
+                  </a:extLst>
+                </a:gridCol>
+                <a:gridCol w="636126">
+                  <a:extLst>
+                    <a:ext uri="{9D8B030D-6E8A-4147-A177-3AD203B41FA5}">
+                      <a16:colId xmlns:a16="http://schemas.microsoft.com/office/drawing/2014/main" val="2814616541"/>
+                    </a:ext>
+                  </a:extLst>
+                </a:gridCol>
+                <a:gridCol w="636126">
+                  <a:extLst>
+                    <a:ext uri="{9D8B030D-6E8A-4147-A177-3AD203B41FA5}">
+                      <a16:colId xmlns:a16="http://schemas.microsoft.com/office/drawing/2014/main" val="3925629564"/>
+                    </a:ext>
+                  </a:extLst>
+                </a:gridCol>
+                <a:gridCol w="636126">
+                  <a:extLst>
+                    <a:ext uri="{9D8B030D-6E8A-4147-A177-3AD203B41FA5}">
+                      <a16:colId xmlns:a16="http://schemas.microsoft.com/office/drawing/2014/main" val="505726368"/>
+                    </a:ext>
+                  </a:extLst>
+                </a:gridCol>
+                <a:gridCol w="636126">
+                  <a:extLst>
+                    <a:ext uri="{9D8B030D-6E8A-4147-A177-3AD203B41FA5}">
+                      <a16:colId xmlns:a16="http://schemas.microsoft.com/office/drawing/2014/main" val="3268241414"/>
+                    </a:ext>
+                  </a:extLst>
+                </a:gridCol>
+              </a:tblGrid>
+              <a:tr h="438359">
+                <a:tc>
+                  <a:txBody>
+                    <a:bodyPr/>
+                    <a:lstStyle/>
+                    <a:p>
+                      <a:pPr algn="ctr"/>
+                      <a:endParaRPr lang="en-US"/>
+                    </a:p>
+                  </a:txBody>
+                  <a:tcPr/>
+                </a:tc>
+                <a:tc>
+                  <a:txBody>
+                    <a:bodyPr/>
+                    <a:lstStyle/>
+                    <a:p>
+                      <a:pPr algn="ctr"/>
+                      <a:endParaRPr lang="en-US" dirty="0"/>
+                    </a:p>
+                  </a:txBody>
+                  <a:tcPr/>
+                </a:tc>
+                <a:tc>
+                  <a:txBody>
+                    <a:bodyPr/>
+                    <a:lstStyle/>
+                    <a:p>
+                      <a:pPr algn="ctr"/>
+                      <a:r>
+                        <a:rPr lang="en-US" dirty="0"/>
+                        <a:t>v</a:t>
+                      </a:r>
+                    </a:p>
+                  </a:txBody>
+                  <a:tcPr/>
+                </a:tc>
+                <a:tc>
+                  <a:txBody>
+                    <a:bodyPr/>
+                    <a:lstStyle/>
+                    <a:p>
+                      <a:pPr algn="ctr"/>
+                      <a:endParaRPr lang="en-US" dirty="0"/>
+                    </a:p>
+                  </a:txBody>
+                  <a:tcPr/>
+                </a:tc>
+                <a:tc>
+                  <a:txBody>
+                    <a:bodyPr/>
+                    <a:lstStyle/>
+                    <a:p>
+                      <a:pPr algn="ctr"/>
+                      <a:endParaRPr lang="en-US" dirty="0"/>
+                    </a:p>
+                  </a:txBody>
+                  <a:tcPr/>
+                </a:tc>
+                <a:extLst>
+                  <a:ext uri="{0D108BD9-81ED-4DB2-BD59-A6C34878D82A}">
+                    <a16:rowId xmlns:a16="http://schemas.microsoft.com/office/drawing/2014/main" val="2287342528"/>
+                  </a:ext>
+                </a:extLst>
+              </a:tr>
+            </a:tbl>
+          </a:graphicData>
+        </a:graphic>
+      </p:graphicFrame>
+      <p:sp>
+        <p:nvSpPr>
+          <p:cNvPr id="32" name="TextBox 31">
+            <a:extLst>
+              <a:ext uri="{FF2B5EF4-FFF2-40B4-BE49-F238E27FC236}">
+                <a16:creationId xmlns:a16="http://schemas.microsoft.com/office/drawing/2014/main" id="{CD8A8E56-B852-AB89-A094-0ABE1BBE77BC}"/>
               </a:ext>
             </a:extLst>
           </p:cNvPr>
@@ -9395,8 +11626,517 @@
         </p:nvSpPr>
         <p:spPr>
           <a:xfrm>
-            <a:off x="2493818" y="3096491"/>
-            <a:ext cx="8507457" cy="923330"/>
+            <a:off x="5993706" y="374835"/>
+            <a:ext cx="1756127" cy="369332"/>
+          </a:xfrm>
+          <a:prstGeom prst="rect">
+            <a:avLst/>
+          </a:prstGeom>
+          <a:noFill/>
+        </p:spPr>
+        <p:txBody>
+          <a:bodyPr wrap="square" rtlCol="0">
+            <a:spAutoFit/>
+          </a:bodyPr>
+          <a:lstStyle/>
+          <a:p>
+            <a:r>
+              <a:rPr lang="en-US" dirty="0"/>
+              <a:t>top level tasks</a:t>
+            </a:r>
+          </a:p>
+        </p:txBody>
+      </p:sp>
+      <p:sp>
+        <p:nvSpPr>
+          <p:cNvPr id="33" name="Rectangle 32">
+            <a:extLst>
+              <a:ext uri="{FF2B5EF4-FFF2-40B4-BE49-F238E27FC236}">
+                <a16:creationId xmlns:a16="http://schemas.microsoft.com/office/drawing/2014/main" id="{2B306A4D-FDE3-C800-7E1C-84906394F217}"/>
+              </a:ext>
+            </a:extLst>
+          </p:cNvPr>
+          <p:cNvSpPr/>
+          <p:nvPr/>
+        </p:nvSpPr>
+        <p:spPr>
+          <a:xfrm>
+            <a:off x="6358791" y="1515328"/>
+            <a:ext cx="908197" cy="558836"/>
+          </a:xfrm>
+          <a:prstGeom prst="rect">
+            <a:avLst/>
+          </a:prstGeom>
+          <a:ln>
+            <a:prstDash val="dash"/>
+          </a:ln>
+        </p:spPr>
+        <p:style>
+          <a:lnRef idx="2">
+            <a:schemeClr val="dk1"/>
+          </a:lnRef>
+          <a:fillRef idx="1">
+            <a:schemeClr val="lt1"/>
+          </a:fillRef>
+          <a:effectRef idx="0">
+            <a:schemeClr val="dk1"/>
+          </a:effectRef>
+          <a:fontRef idx="minor">
+            <a:schemeClr val="dk1"/>
+          </a:fontRef>
+        </p:style>
+        <p:txBody>
+          <a:bodyPr rtlCol="0" anchor="ctr"/>
+          <a:lstStyle/>
+          <a:p>
+            <a:pPr algn="ctr"/>
+            <a:r>
+              <a:rPr lang="en-US" dirty="0"/>
+              <a:t>2-hop neigh</a:t>
+            </a:r>
+          </a:p>
+        </p:txBody>
+      </p:sp>
+      <p:cxnSp>
+        <p:nvCxnSpPr>
+          <p:cNvPr id="34" name="Straight Connector 33">
+            <a:extLst>
+              <a:ext uri="{FF2B5EF4-FFF2-40B4-BE49-F238E27FC236}">
+                <a16:creationId xmlns:a16="http://schemas.microsoft.com/office/drawing/2014/main" id="{ADA448AB-F1BC-2284-B2BB-209FB2E9000F}"/>
+              </a:ext>
+            </a:extLst>
+          </p:cNvPr>
+          <p:cNvCxnSpPr>
+            <a:cxnSpLocks/>
+            <a:stCxn id="31" idx="2"/>
+            <a:endCxn id="33" idx="0"/>
+          </p:cNvCxnSpPr>
+          <p:nvPr/>
+        </p:nvCxnSpPr>
+        <p:spPr>
+          <a:xfrm>
+            <a:off x="6809924" y="1299115"/>
+            <a:ext cx="2966" cy="216213"/>
+          </a:xfrm>
+          <a:prstGeom prst="line">
+            <a:avLst/>
+          </a:prstGeom>
+        </p:spPr>
+        <p:style>
+          <a:lnRef idx="2">
+            <a:schemeClr val="accent1"/>
+          </a:lnRef>
+          <a:fillRef idx="0">
+            <a:schemeClr val="accent1"/>
+          </a:fillRef>
+          <a:effectRef idx="1">
+            <a:schemeClr val="accent1"/>
+          </a:effectRef>
+          <a:fontRef idx="minor">
+            <a:schemeClr val="tx1"/>
+          </a:fontRef>
+        </p:style>
+      </p:cxnSp>
+    </p:spTree>
+    <p:extLst>
+      <p:ext uri="{BB962C8B-B14F-4D97-AF65-F5344CB8AC3E}">
+        <p14:creationId xmlns:p14="http://schemas.microsoft.com/office/powerpoint/2010/main" val="79774286"/>
+      </p:ext>
+    </p:extLst>
+  </p:cSld>
+  <p:clrMapOvr>
+    <a:masterClrMapping/>
+  </p:clrMapOvr>
+</p:sld>
+</file>
+
+<file path=ppt/slides/slide7.xml><?xml version="1.0" encoding="utf-8"?>
+<p:sld xmlns:a="http://schemas.openxmlformats.org/drawingml/2006/main" xmlns:r="http://schemas.openxmlformats.org/officeDocument/2006/relationships" xmlns:p="http://schemas.openxmlformats.org/presentationml/2006/main">
+  <p:cSld>
+    <p:spTree>
+      <p:nvGrpSpPr>
+        <p:cNvPr id="1" name="">
+          <a:extLst>
+            <a:ext uri="{FF2B5EF4-FFF2-40B4-BE49-F238E27FC236}">
+              <a16:creationId xmlns:a16="http://schemas.microsoft.com/office/drawing/2014/main" id="{CEA5A725-C0FB-AFBB-BD77-C989D1102897}"/>
+            </a:ext>
+          </a:extLst>
+        </p:cNvPr>
+        <p:cNvGrpSpPr/>
+        <p:nvPr/>
+      </p:nvGrpSpPr>
+      <p:grpSpPr>
+        <a:xfrm>
+          <a:off x="0" y="0"/>
+          <a:ext cx="0" cy="0"/>
+          <a:chOff x="0" y="0"/>
+          <a:chExt cx="0" cy="0"/>
+        </a:xfrm>
+      </p:grpSpPr>
+      <p:pic>
+        <p:nvPicPr>
+          <p:cNvPr id="36" name="Picture 35">
+            <a:extLst>
+              <a:ext uri="{FF2B5EF4-FFF2-40B4-BE49-F238E27FC236}">
+                <a16:creationId xmlns:a16="http://schemas.microsoft.com/office/drawing/2014/main" id="{F65E09FD-86C3-B452-444F-53A4F6F7658F}"/>
+              </a:ext>
+            </a:extLst>
+          </p:cNvPr>
+          <p:cNvPicPr>
+            <a:picLocks noChangeAspect="1"/>
+          </p:cNvPicPr>
+          <p:nvPr/>
+        </p:nvPicPr>
+        <p:blipFill>
+          <a:blip r:embed="rId2"/>
+          <a:stretch>
+            <a:fillRect/>
+          </a:stretch>
+        </p:blipFill>
+        <p:spPr>
+          <a:xfrm>
+            <a:off x="5098602" y="0"/>
+            <a:ext cx="6603274" cy="6858000"/>
+          </a:xfrm>
+          <a:prstGeom prst="rect">
+            <a:avLst/>
+          </a:prstGeom>
+        </p:spPr>
+      </p:pic>
+      <p:sp>
+        <p:nvSpPr>
+          <p:cNvPr id="2" name="Title 1">
+            <a:extLst>
+              <a:ext uri="{FF2B5EF4-FFF2-40B4-BE49-F238E27FC236}">
+                <a16:creationId xmlns:a16="http://schemas.microsoft.com/office/drawing/2014/main" id="{252F1B3E-B919-6AAB-EBA8-2232CDA90401}"/>
+              </a:ext>
+            </a:extLst>
+          </p:cNvPr>
+          <p:cNvSpPr>
+            <a:spLocks noGrp="1"/>
+          </p:cNvSpPr>
+          <p:nvPr>
+            <p:ph type="title"/>
+          </p:nvPr>
+        </p:nvSpPr>
+        <p:spPr/>
+        <p:txBody>
+          <a:bodyPr/>
+          <a:lstStyle/>
+          <a:p>
+            <a:r>
+              <a:rPr lang="en-US" dirty="0"/>
+              <a:t>Scratch Buffer</a:t>
+            </a:r>
+          </a:p>
+        </p:txBody>
+      </p:sp>
+      <p:graphicFrame>
+        <p:nvGraphicFramePr>
+          <p:cNvPr id="31" name="Content Placeholder 3">
+            <a:extLst>
+              <a:ext uri="{FF2B5EF4-FFF2-40B4-BE49-F238E27FC236}">
+                <a16:creationId xmlns:a16="http://schemas.microsoft.com/office/drawing/2014/main" id="{F7BEEAA0-DB71-CB33-8F1C-7F30FD0FB0F1}"/>
+              </a:ext>
+            </a:extLst>
+          </p:cNvPr>
+          <p:cNvGraphicFramePr>
+            <a:graphicFrameLocks/>
+          </p:cNvGraphicFramePr>
+          <p:nvPr/>
+        </p:nvGraphicFramePr>
+        <p:xfrm>
+          <a:off x="5219609" y="860756"/>
+          <a:ext cx="3180630" cy="438359"/>
+        </p:xfrm>
+        <a:graphic>
+          <a:graphicData uri="http://schemas.openxmlformats.org/drawingml/2006/table">
+            <a:tbl>
+              <a:tblPr firstRow="1" bandRow="1">
+                <a:tableStyleId>{5940675A-B579-460E-94D1-54222C63F5DA}</a:tableStyleId>
+              </a:tblPr>
+              <a:tblGrid>
+                <a:gridCol w="636126">
+                  <a:extLst>
+                    <a:ext uri="{9D8B030D-6E8A-4147-A177-3AD203B41FA5}">
+                      <a16:colId xmlns:a16="http://schemas.microsoft.com/office/drawing/2014/main" val="194980701"/>
+                    </a:ext>
+                  </a:extLst>
+                </a:gridCol>
+                <a:gridCol w="636126">
+                  <a:extLst>
+                    <a:ext uri="{9D8B030D-6E8A-4147-A177-3AD203B41FA5}">
+                      <a16:colId xmlns:a16="http://schemas.microsoft.com/office/drawing/2014/main" val="2814616541"/>
+                    </a:ext>
+                  </a:extLst>
+                </a:gridCol>
+                <a:gridCol w="636126">
+                  <a:extLst>
+                    <a:ext uri="{9D8B030D-6E8A-4147-A177-3AD203B41FA5}">
+                      <a16:colId xmlns:a16="http://schemas.microsoft.com/office/drawing/2014/main" val="3925629564"/>
+                    </a:ext>
+                  </a:extLst>
+                </a:gridCol>
+                <a:gridCol w="636126">
+                  <a:extLst>
+                    <a:ext uri="{9D8B030D-6E8A-4147-A177-3AD203B41FA5}">
+                      <a16:colId xmlns:a16="http://schemas.microsoft.com/office/drawing/2014/main" val="505726368"/>
+                    </a:ext>
+                  </a:extLst>
+                </a:gridCol>
+                <a:gridCol w="636126">
+                  <a:extLst>
+                    <a:ext uri="{9D8B030D-6E8A-4147-A177-3AD203B41FA5}">
+                      <a16:colId xmlns:a16="http://schemas.microsoft.com/office/drawing/2014/main" val="3268241414"/>
+                    </a:ext>
+                  </a:extLst>
+                </a:gridCol>
+              </a:tblGrid>
+              <a:tr h="438359">
+                <a:tc>
+                  <a:txBody>
+                    <a:bodyPr/>
+                    <a:lstStyle/>
+                    <a:p>
+                      <a:pPr algn="ctr"/>
+                      <a:endParaRPr lang="en-US"/>
+                    </a:p>
+                  </a:txBody>
+                  <a:tcPr/>
+                </a:tc>
+                <a:tc>
+                  <a:txBody>
+                    <a:bodyPr/>
+                    <a:lstStyle/>
+                    <a:p>
+                      <a:pPr algn="ctr"/>
+                      <a:endParaRPr lang="en-US" dirty="0"/>
+                    </a:p>
+                  </a:txBody>
+                  <a:tcPr/>
+                </a:tc>
+                <a:tc>
+                  <a:txBody>
+                    <a:bodyPr/>
+                    <a:lstStyle/>
+                    <a:p>
+                      <a:pPr algn="ctr"/>
+                      <a:r>
+                        <a:rPr lang="en-US" dirty="0"/>
+                        <a:t>v</a:t>
+                      </a:r>
+                    </a:p>
+                  </a:txBody>
+                  <a:tcPr/>
+                </a:tc>
+                <a:tc>
+                  <a:txBody>
+                    <a:bodyPr/>
+                    <a:lstStyle/>
+                    <a:p>
+                      <a:pPr algn="ctr"/>
+                      <a:endParaRPr lang="en-US" dirty="0"/>
+                    </a:p>
+                  </a:txBody>
+                  <a:tcPr/>
+                </a:tc>
+                <a:tc>
+                  <a:txBody>
+                    <a:bodyPr/>
+                    <a:lstStyle/>
+                    <a:p>
+                      <a:pPr algn="ctr"/>
+                      <a:endParaRPr lang="en-US" dirty="0"/>
+                    </a:p>
+                  </a:txBody>
+                  <a:tcPr/>
+                </a:tc>
+                <a:extLst>
+                  <a:ext uri="{0D108BD9-81ED-4DB2-BD59-A6C34878D82A}">
+                    <a16:rowId xmlns:a16="http://schemas.microsoft.com/office/drawing/2014/main" val="2287342528"/>
+                  </a:ext>
+                </a:extLst>
+              </a:tr>
+            </a:tbl>
+          </a:graphicData>
+        </a:graphic>
+      </p:graphicFrame>
+      <p:sp>
+        <p:nvSpPr>
+          <p:cNvPr id="32" name="TextBox 31">
+            <a:extLst>
+              <a:ext uri="{FF2B5EF4-FFF2-40B4-BE49-F238E27FC236}">
+                <a16:creationId xmlns:a16="http://schemas.microsoft.com/office/drawing/2014/main" id="{DD450443-76AA-47EF-8518-82CDF232C420}"/>
+              </a:ext>
+            </a:extLst>
+          </p:cNvPr>
+          <p:cNvSpPr txBox="1"/>
+          <p:nvPr/>
+        </p:nvSpPr>
+        <p:spPr>
+          <a:xfrm>
+            <a:off x="5993706" y="374835"/>
+            <a:ext cx="1756127" cy="369332"/>
+          </a:xfrm>
+          <a:prstGeom prst="rect">
+            <a:avLst/>
+          </a:prstGeom>
+          <a:noFill/>
+        </p:spPr>
+        <p:txBody>
+          <a:bodyPr wrap="square" rtlCol="0">
+            <a:spAutoFit/>
+          </a:bodyPr>
+          <a:lstStyle/>
+          <a:p>
+            <a:r>
+              <a:rPr lang="en-US" dirty="0"/>
+              <a:t>top level tasks</a:t>
+            </a:r>
+          </a:p>
+        </p:txBody>
+      </p:sp>
+      <p:sp>
+        <p:nvSpPr>
+          <p:cNvPr id="33" name="Rectangle 32">
+            <a:extLst>
+              <a:ext uri="{FF2B5EF4-FFF2-40B4-BE49-F238E27FC236}">
+                <a16:creationId xmlns:a16="http://schemas.microsoft.com/office/drawing/2014/main" id="{F3DF527D-D515-F294-E1EC-14ED18FFC723}"/>
+              </a:ext>
+            </a:extLst>
+          </p:cNvPr>
+          <p:cNvSpPr/>
+          <p:nvPr/>
+        </p:nvSpPr>
+        <p:spPr>
+          <a:xfrm>
+            <a:off x="6358791" y="1515328"/>
+            <a:ext cx="908197" cy="558836"/>
+          </a:xfrm>
+          <a:prstGeom prst="rect">
+            <a:avLst/>
+          </a:prstGeom>
+          <a:ln>
+            <a:prstDash val="dash"/>
+          </a:ln>
+        </p:spPr>
+        <p:style>
+          <a:lnRef idx="2">
+            <a:schemeClr val="dk1"/>
+          </a:lnRef>
+          <a:fillRef idx="1">
+            <a:schemeClr val="lt1"/>
+          </a:fillRef>
+          <a:effectRef idx="0">
+            <a:schemeClr val="dk1"/>
+          </a:effectRef>
+          <a:fontRef idx="minor">
+            <a:schemeClr val="dk1"/>
+          </a:fontRef>
+        </p:style>
+        <p:txBody>
+          <a:bodyPr rtlCol="0" anchor="ctr"/>
+          <a:lstStyle/>
+          <a:p>
+            <a:pPr algn="ctr"/>
+            <a:r>
+              <a:rPr lang="en-US" dirty="0"/>
+              <a:t>2-hop neigh</a:t>
+            </a:r>
+          </a:p>
+        </p:txBody>
+      </p:sp>
+      <p:cxnSp>
+        <p:nvCxnSpPr>
+          <p:cNvPr id="34" name="Straight Connector 33">
+            <a:extLst>
+              <a:ext uri="{FF2B5EF4-FFF2-40B4-BE49-F238E27FC236}">
+                <a16:creationId xmlns:a16="http://schemas.microsoft.com/office/drawing/2014/main" id="{F4BC0C70-8964-A7F5-37A8-04C08D4E0EBC}"/>
+              </a:ext>
+            </a:extLst>
+          </p:cNvPr>
+          <p:cNvCxnSpPr>
+            <a:cxnSpLocks/>
+            <a:stCxn id="31" idx="2"/>
+            <a:endCxn id="33" idx="0"/>
+          </p:cNvCxnSpPr>
+          <p:nvPr/>
+        </p:nvCxnSpPr>
+        <p:spPr>
+          <a:xfrm>
+            <a:off x="6809924" y="1299115"/>
+            <a:ext cx="2966" cy="216213"/>
+          </a:xfrm>
+          <a:prstGeom prst="line">
+            <a:avLst/>
+          </a:prstGeom>
+        </p:spPr>
+        <p:style>
+          <a:lnRef idx="2">
+            <a:schemeClr val="accent1"/>
+          </a:lnRef>
+          <a:fillRef idx="0">
+            <a:schemeClr val="accent1"/>
+          </a:fillRef>
+          <a:effectRef idx="1">
+            <a:schemeClr val="accent1"/>
+          </a:effectRef>
+          <a:fontRef idx="minor">
+            <a:schemeClr val="tx1"/>
+          </a:fontRef>
+        </p:style>
+      </p:cxnSp>
+      <p:sp>
+        <p:nvSpPr>
+          <p:cNvPr id="4" name="TextBox 3">
+            <a:extLst>
+              <a:ext uri="{FF2B5EF4-FFF2-40B4-BE49-F238E27FC236}">
+                <a16:creationId xmlns:a16="http://schemas.microsoft.com/office/drawing/2014/main" id="{59088A7C-78EB-F510-6A5A-607DA4322B1B}"/>
+              </a:ext>
+            </a:extLst>
+          </p:cNvPr>
+          <p:cNvSpPr txBox="1"/>
+          <p:nvPr/>
+        </p:nvSpPr>
+        <p:spPr>
+          <a:xfrm>
+            <a:off x="1709998" y="3289727"/>
+            <a:ext cx="1850571" cy="369332"/>
+          </a:xfrm>
+          <a:prstGeom prst="rect">
+            <a:avLst/>
+          </a:prstGeom>
+          <a:noFill/>
+        </p:spPr>
+        <p:txBody>
+          <a:bodyPr wrap="square" rtlCol="0">
+            <a:spAutoFit/>
+          </a:bodyPr>
+          <a:lstStyle/>
+          <a:p>
+            <a:r>
+              <a:rPr lang="en-US" dirty="0"/>
+              <a:t>per warp scratch</a:t>
+            </a:r>
+          </a:p>
+        </p:txBody>
+      </p:sp>
+      <p:sp>
+        <p:nvSpPr>
+          <p:cNvPr id="5" name="TextBox 4">
+            <a:extLst>
+              <a:ext uri="{FF2B5EF4-FFF2-40B4-BE49-F238E27FC236}">
+                <a16:creationId xmlns:a16="http://schemas.microsoft.com/office/drawing/2014/main" id="{58D53A03-19D4-3309-7501-A43EB6713F89}"/>
+              </a:ext>
+            </a:extLst>
+          </p:cNvPr>
+          <p:cNvSpPr txBox="1"/>
+          <p:nvPr/>
+        </p:nvSpPr>
+        <p:spPr>
+          <a:xfrm>
+            <a:off x="1172184" y="3576806"/>
+            <a:ext cx="2953501" cy="369332"/>
           </a:xfrm>
           <a:prstGeom prst="rect">
             <a:avLst/>
@@ -9411,20 +12151,7 @@
           <a:p>
             <a:r>
               <a:rPr lang="en-US" dirty="0"/>
-              <a:t>switching to layered buffer should drop the computation instead of moving data host</a:t>
-            </a:r>
-          </a:p>
-          <a:p>
-            <a:endParaRPr lang="en-US" dirty="0"/>
-          </a:p>
-          <a:p>
-            <a:r>
-              <a:rPr lang="en-US" dirty="0"/>
-              <a:t>delete page 3, 4 in worst case if </a:t>
-            </a:r>
-            <a:r>
-              <a:rPr lang="en-US"/>
-              <a:t>can’t complete in 5 min</a:t>
+              <a:t>with 32000 it sums to 6.5GB</a:t>
             </a:r>
           </a:p>
         </p:txBody>
@@ -9432,7 +12159,1184 @@
     </p:spTree>
     <p:extLst>
       <p:ext uri="{BB962C8B-B14F-4D97-AF65-F5344CB8AC3E}">
-        <p14:creationId xmlns:p14="http://schemas.microsoft.com/office/powerpoint/2010/main" val="1093682882"/>
+        <p14:creationId xmlns:p14="http://schemas.microsoft.com/office/powerpoint/2010/main" val="167228868"/>
+      </p:ext>
+    </p:extLst>
+  </p:cSld>
+  <p:clrMapOvr>
+    <a:masterClrMapping/>
+  </p:clrMapOvr>
+</p:sld>
+</file>
+
+<file path=ppt/slides/slide8.xml><?xml version="1.0" encoding="utf-8"?>
+<p:sld xmlns:a="http://schemas.openxmlformats.org/drawingml/2006/main" xmlns:r="http://schemas.openxmlformats.org/officeDocument/2006/relationships" xmlns:p="http://schemas.openxmlformats.org/presentationml/2006/main">
+  <p:cSld>
+    <p:spTree>
+      <p:nvGrpSpPr>
+        <p:cNvPr id="1" name=""/>
+        <p:cNvGrpSpPr/>
+        <p:nvPr/>
+      </p:nvGrpSpPr>
+      <p:grpSpPr>
+        <a:xfrm>
+          <a:off x="0" y="0"/>
+          <a:ext cx="0" cy="0"/>
+          <a:chOff x="0" y="0"/>
+          <a:chExt cx="0" cy="0"/>
+        </a:xfrm>
+      </p:grpSpPr>
+      <p:sp>
+        <p:nvSpPr>
+          <p:cNvPr id="2" name="Title 1">
+            <a:extLst>
+              <a:ext uri="{FF2B5EF4-FFF2-40B4-BE49-F238E27FC236}">
+                <a16:creationId xmlns:a16="http://schemas.microsoft.com/office/drawing/2014/main" id="{767B744D-A139-FB1A-B60B-51B6E6286C0D}"/>
+              </a:ext>
+            </a:extLst>
+          </p:cNvPr>
+          <p:cNvSpPr>
+            <a:spLocks noGrp="1"/>
+          </p:cNvSpPr>
+          <p:nvPr>
+            <p:ph type="title"/>
+          </p:nvPr>
+        </p:nvSpPr>
+        <p:spPr/>
+        <p:txBody>
+          <a:bodyPr/>
+          <a:lstStyle/>
+          <a:p>
+            <a:r>
+              <a:rPr lang="en-US" dirty="0"/>
+              <a:t>Handlink Big Tasks</a:t>
+            </a:r>
+          </a:p>
+        </p:txBody>
+      </p:sp>
+      <p:graphicFrame>
+        <p:nvGraphicFramePr>
+          <p:cNvPr id="4" name="Content Placeholder 3">
+            <a:extLst>
+              <a:ext uri="{FF2B5EF4-FFF2-40B4-BE49-F238E27FC236}">
+                <a16:creationId xmlns:a16="http://schemas.microsoft.com/office/drawing/2014/main" id="{F923482F-EE93-313A-EB53-C79917AA892F}"/>
+              </a:ext>
+            </a:extLst>
+          </p:cNvPr>
+          <p:cNvGraphicFramePr>
+            <a:graphicFrameLocks/>
+          </p:cNvGraphicFramePr>
+          <p:nvPr/>
+        </p:nvGraphicFramePr>
+        <p:xfrm>
+          <a:off x="4092558" y="2098718"/>
+          <a:ext cx="3180630" cy="438359"/>
+        </p:xfrm>
+        <a:graphic>
+          <a:graphicData uri="http://schemas.openxmlformats.org/drawingml/2006/table">
+            <a:tbl>
+              <a:tblPr firstRow="1" bandRow="1">
+                <a:tableStyleId>{5940675A-B579-460E-94D1-54222C63F5DA}</a:tableStyleId>
+              </a:tblPr>
+              <a:tblGrid>
+                <a:gridCol w="636126">
+                  <a:extLst>
+                    <a:ext uri="{9D8B030D-6E8A-4147-A177-3AD203B41FA5}">
+                      <a16:colId xmlns:a16="http://schemas.microsoft.com/office/drawing/2014/main" val="194980701"/>
+                    </a:ext>
+                  </a:extLst>
+                </a:gridCol>
+                <a:gridCol w="636126">
+                  <a:extLst>
+                    <a:ext uri="{9D8B030D-6E8A-4147-A177-3AD203B41FA5}">
+                      <a16:colId xmlns:a16="http://schemas.microsoft.com/office/drawing/2014/main" val="2814616541"/>
+                    </a:ext>
+                  </a:extLst>
+                </a:gridCol>
+                <a:gridCol w="636126">
+                  <a:extLst>
+                    <a:ext uri="{9D8B030D-6E8A-4147-A177-3AD203B41FA5}">
+                      <a16:colId xmlns:a16="http://schemas.microsoft.com/office/drawing/2014/main" val="3925629564"/>
+                    </a:ext>
+                  </a:extLst>
+                </a:gridCol>
+                <a:gridCol w="636126">
+                  <a:extLst>
+                    <a:ext uri="{9D8B030D-6E8A-4147-A177-3AD203B41FA5}">
+                      <a16:colId xmlns:a16="http://schemas.microsoft.com/office/drawing/2014/main" val="505726368"/>
+                    </a:ext>
+                  </a:extLst>
+                </a:gridCol>
+                <a:gridCol w="636126">
+                  <a:extLst>
+                    <a:ext uri="{9D8B030D-6E8A-4147-A177-3AD203B41FA5}">
+                      <a16:colId xmlns:a16="http://schemas.microsoft.com/office/drawing/2014/main" val="3268241414"/>
+                    </a:ext>
+                  </a:extLst>
+                </a:gridCol>
+              </a:tblGrid>
+              <a:tr h="438359">
+                <a:tc>
+                  <a:txBody>
+                    <a:bodyPr/>
+                    <a:lstStyle/>
+                    <a:p>
+                      <a:pPr algn="ctr"/>
+                      <a:endParaRPr lang="en-US" dirty="0"/>
+                    </a:p>
+                  </a:txBody>
+                  <a:tcPr/>
+                </a:tc>
+                <a:tc>
+                  <a:txBody>
+                    <a:bodyPr/>
+                    <a:lstStyle/>
+                    <a:p>
+                      <a:pPr algn="ctr"/>
+                      <a:endParaRPr lang="en-US" dirty="0"/>
+                    </a:p>
+                  </a:txBody>
+                  <a:tcPr/>
+                </a:tc>
+                <a:tc>
+                  <a:txBody>
+                    <a:bodyPr/>
+                    <a:lstStyle/>
+                    <a:p>
+                      <a:pPr algn="ctr"/>
+                      <a:r>
+                        <a:rPr lang="en-US" dirty="0"/>
+                        <a:t>v</a:t>
+                      </a:r>
+                    </a:p>
+                  </a:txBody>
+                  <a:tcPr/>
+                </a:tc>
+                <a:tc>
+                  <a:txBody>
+                    <a:bodyPr/>
+                    <a:lstStyle/>
+                    <a:p>
+                      <a:pPr algn="ctr"/>
+                      <a:endParaRPr lang="en-US" dirty="0"/>
+                    </a:p>
+                  </a:txBody>
+                  <a:tcPr/>
+                </a:tc>
+                <a:tc>
+                  <a:txBody>
+                    <a:bodyPr/>
+                    <a:lstStyle/>
+                    <a:p>
+                      <a:pPr algn="ctr"/>
+                      <a:endParaRPr lang="en-US" dirty="0"/>
+                    </a:p>
+                  </a:txBody>
+                  <a:tcPr/>
+                </a:tc>
+                <a:extLst>
+                  <a:ext uri="{0D108BD9-81ED-4DB2-BD59-A6C34878D82A}">
+                    <a16:rowId xmlns:a16="http://schemas.microsoft.com/office/drawing/2014/main" val="2287342528"/>
+                  </a:ext>
+                </a:extLst>
+              </a:tr>
+            </a:tbl>
+          </a:graphicData>
+        </a:graphic>
+      </p:graphicFrame>
+      <p:sp>
+        <p:nvSpPr>
+          <p:cNvPr id="5" name="TextBox 4">
+            <a:extLst>
+              <a:ext uri="{FF2B5EF4-FFF2-40B4-BE49-F238E27FC236}">
+                <a16:creationId xmlns:a16="http://schemas.microsoft.com/office/drawing/2014/main" id="{DA5B80B6-EC4E-F048-0038-CFF6411D550E}"/>
+              </a:ext>
+            </a:extLst>
+          </p:cNvPr>
+          <p:cNvSpPr txBox="1"/>
+          <p:nvPr/>
+        </p:nvSpPr>
+        <p:spPr>
+          <a:xfrm>
+            <a:off x="4866655" y="1612797"/>
+            <a:ext cx="1756127" cy="369332"/>
+          </a:xfrm>
+          <a:prstGeom prst="rect">
+            <a:avLst/>
+          </a:prstGeom>
+          <a:noFill/>
+        </p:spPr>
+        <p:txBody>
+          <a:bodyPr wrap="square" rtlCol="0">
+            <a:spAutoFit/>
+          </a:bodyPr>
+          <a:lstStyle/>
+          <a:p>
+            <a:r>
+              <a:rPr lang="en-US" dirty="0"/>
+              <a:t>root vertices</a:t>
+            </a:r>
+          </a:p>
+        </p:txBody>
+      </p:sp>
+      <p:sp>
+        <p:nvSpPr>
+          <p:cNvPr id="6" name="Rectangle 5">
+            <a:extLst>
+              <a:ext uri="{FF2B5EF4-FFF2-40B4-BE49-F238E27FC236}">
+                <a16:creationId xmlns:a16="http://schemas.microsoft.com/office/drawing/2014/main" id="{E25991E7-EBD9-411B-061E-6EB77AADD304}"/>
+              </a:ext>
+            </a:extLst>
+          </p:cNvPr>
+          <p:cNvSpPr/>
+          <p:nvPr/>
+        </p:nvSpPr>
+        <p:spPr>
+          <a:xfrm>
+            <a:off x="5231740" y="2753290"/>
+            <a:ext cx="908197" cy="558836"/>
+          </a:xfrm>
+          <a:prstGeom prst="rect">
+            <a:avLst/>
+          </a:prstGeom>
+          <a:ln>
+            <a:prstDash val="dash"/>
+          </a:ln>
+        </p:spPr>
+        <p:style>
+          <a:lnRef idx="2">
+            <a:schemeClr val="dk1"/>
+          </a:lnRef>
+          <a:fillRef idx="1">
+            <a:schemeClr val="lt1"/>
+          </a:fillRef>
+          <a:effectRef idx="0">
+            <a:schemeClr val="dk1"/>
+          </a:effectRef>
+          <a:fontRef idx="minor">
+            <a:schemeClr val="dk1"/>
+          </a:fontRef>
+        </p:style>
+        <p:txBody>
+          <a:bodyPr rtlCol="0" anchor="ctr"/>
+          <a:lstStyle/>
+          <a:p>
+            <a:pPr algn="ctr"/>
+            <a:r>
+              <a:rPr lang="en-US" dirty="0"/>
+              <a:t>2-hop neigh</a:t>
+            </a:r>
+          </a:p>
+        </p:txBody>
+      </p:sp>
+      <p:cxnSp>
+        <p:nvCxnSpPr>
+          <p:cNvPr id="7" name="Straight Connector 6">
+            <a:extLst>
+              <a:ext uri="{FF2B5EF4-FFF2-40B4-BE49-F238E27FC236}">
+                <a16:creationId xmlns:a16="http://schemas.microsoft.com/office/drawing/2014/main" id="{4B12D79D-DB24-5704-F564-5A38DEC648E9}"/>
+              </a:ext>
+            </a:extLst>
+          </p:cNvPr>
+          <p:cNvCxnSpPr>
+            <a:cxnSpLocks/>
+            <a:stCxn id="4" idx="2"/>
+            <a:endCxn id="6" idx="0"/>
+          </p:cNvCxnSpPr>
+          <p:nvPr/>
+        </p:nvCxnSpPr>
+        <p:spPr>
+          <a:xfrm>
+            <a:off x="5682873" y="2537077"/>
+            <a:ext cx="2966" cy="216213"/>
+          </a:xfrm>
+          <a:prstGeom prst="line">
+            <a:avLst/>
+          </a:prstGeom>
+        </p:spPr>
+        <p:style>
+          <a:lnRef idx="2">
+            <a:schemeClr val="accent1"/>
+          </a:lnRef>
+          <a:fillRef idx="0">
+            <a:schemeClr val="accent1"/>
+          </a:fillRef>
+          <a:effectRef idx="1">
+            <a:schemeClr val="accent1"/>
+          </a:effectRef>
+          <a:fontRef idx="minor">
+            <a:schemeClr val="tx1"/>
+          </a:fontRef>
+        </p:style>
+      </p:cxnSp>
+      <p:sp>
+        <p:nvSpPr>
+          <p:cNvPr id="9" name="TextBox 8">
+            <a:extLst>
+              <a:ext uri="{FF2B5EF4-FFF2-40B4-BE49-F238E27FC236}">
+                <a16:creationId xmlns:a16="http://schemas.microsoft.com/office/drawing/2014/main" id="{0C93F2F9-94CF-FE9B-9197-06D4D1F1CD30}"/>
+              </a:ext>
+            </a:extLst>
+          </p:cNvPr>
+          <p:cNvSpPr txBox="1"/>
+          <p:nvPr/>
+        </p:nvSpPr>
+        <p:spPr>
+          <a:xfrm>
+            <a:off x="1214293" y="3528339"/>
+            <a:ext cx="9851287" cy="646331"/>
+          </a:xfrm>
+          <a:prstGeom prst="rect">
+            <a:avLst/>
+          </a:prstGeom>
+          <a:noFill/>
+        </p:spPr>
+        <p:txBody>
+          <a:bodyPr wrap="none" rtlCol="0">
+            <a:spAutoFit/>
+          </a:bodyPr>
+          <a:lstStyle/>
+          <a:p>
+            <a:r>
+              <a:rPr lang="en-US" dirty="0"/>
+              <a:t>root vertices with big tasks are separated at initialization step, using CPU threads (by OpenMP)</a:t>
+            </a:r>
+          </a:p>
+          <a:p>
+            <a:endParaRPr lang="en-US" dirty="0"/>
+          </a:p>
+        </p:txBody>
+      </p:sp>
+      <p:graphicFrame>
+        <p:nvGraphicFramePr>
+          <p:cNvPr id="10" name="Content Placeholder 3">
+            <a:extLst>
+              <a:ext uri="{FF2B5EF4-FFF2-40B4-BE49-F238E27FC236}">
+                <a16:creationId xmlns:a16="http://schemas.microsoft.com/office/drawing/2014/main" id="{BF605D24-416F-9502-BA14-C0F3CB133CFE}"/>
+              </a:ext>
+            </a:extLst>
+          </p:cNvPr>
+          <p:cNvGraphicFramePr>
+            <a:graphicFrameLocks/>
+          </p:cNvGraphicFramePr>
+          <p:nvPr/>
+        </p:nvGraphicFramePr>
+        <p:xfrm>
+          <a:off x="2686966" y="4796747"/>
+          <a:ext cx="1908378" cy="438359"/>
+        </p:xfrm>
+        <a:graphic>
+          <a:graphicData uri="http://schemas.openxmlformats.org/drawingml/2006/table">
+            <a:tbl>
+              <a:tblPr firstRow="1" bandRow="1">
+                <a:tableStyleId>{5940675A-B579-460E-94D1-54222C63F5DA}</a:tableStyleId>
+              </a:tblPr>
+              <a:tblGrid>
+                <a:gridCol w="636126">
+                  <a:extLst>
+                    <a:ext uri="{9D8B030D-6E8A-4147-A177-3AD203B41FA5}">
+                      <a16:colId xmlns:a16="http://schemas.microsoft.com/office/drawing/2014/main" val="194980701"/>
+                    </a:ext>
+                  </a:extLst>
+                </a:gridCol>
+                <a:gridCol w="636126">
+                  <a:extLst>
+                    <a:ext uri="{9D8B030D-6E8A-4147-A177-3AD203B41FA5}">
+                      <a16:colId xmlns:a16="http://schemas.microsoft.com/office/drawing/2014/main" val="2814616541"/>
+                    </a:ext>
+                  </a:extLst>
+                </a:gridCol>
+                <a:gridCol w="636126">
+                  <a:extLst>
+                    <a:ext uri="{9D8B030D-6E8A-4147-A177-3AD203B41FA5}">
+                      <a16:colId xmlns:a16="http://schemas.microsoft.com/office/drawing/2014/main" val="3925629564"/>
+                    </a:ext>
+                  </a:extLst>
+                </a:gridCol>
+              </a:tblGrid>
+              <a:tr h="438359">
+                <a:tc>
+                  <a:txBody>
+                    <a:bodyPr/>
+                    <a:lstStyle/>
+                    <a:p>
+                      <a:pPr algn="ctr"/>
+                      <a:endParaRPr lang="en-US" dirty="0"/>
+                    </a:p>
+                  </a:txBody>
+                  <a:tcPr/>
+                </a:tc>
+                <a:tc>
+                  <a:txBody>
+                    <a:bodyPr/>
+                    <a:lstStyle/>
+                    <a:p>
+                      <a:pPr algn="ctr"/>
+                      <a:endParaRPr lang="en-US" dirty="0"/>
+                    </a:p>
+                  </a:txBody>
+                  <a:tcPr/>
+                </a:tc>
+                <a:tc>
+                  <a:txBody>
+                    <a:bodyPr/>
+                    <a:lstStyle/>
+                    <a:p>
+                      <a:pPr algn="ctr"/>
+                      <a:endParaRPr lang="en-US" dirty="0"/>
+                    </a:p>
+                  </a:txBody>
+                  <a:tcPr/>
+                </a:tc>
+                <a:extLst>
+                  <a:ext uri="{0D108BD9-81ED-4DB2-BD59-A6C34878D82A}">
+                    <a16:rowId xmlns:a16="http://schemas.microsoft.com/office/drawing/2014/main" val="2287342528"/>
+                  </a:ext>
+                </a:extLst>
+              </a:tr>
+            </a:tbl>
+          </a:graphicData>
+        </a:graphic>
+      </p:graphicFrame>
+      <p:sp>
+        <p:nvSpPr>
+          <p:cNvPr id="11" name="TextBox 10">
+            <a:extLst>
+              <a:ext uri="{FF2B5EF4-FFF2-40B4-BE49-F238E27FC236}">
+                <a16:creationId xmlns:a16="http://schemas.microsoft.com/office/drawing/2014/main" id="{955C8D13-994B-590F-D315-8769F534E8DE}"/>
+              </a:ext>
+            </a:extLst>
+          </p:cNvPr>
+          <p:cNvSpPr txBox="1"/>
+          <p:nvPr/>
+        </p:nvSpPr>
+        <p:spPr>
+          <a:xfrm>
+            <a:off x="2626729" y="4428363"/>
+            <a:ext cx="2406533" cy="369332"/>
+          </a:xfrm>
+          <a:prstGeom prst="rect">
+            <a:avLst/>
+          </a:prstGeom>
+          <a:noFill/>
+        </p:spPr>
+        <p:txBody>
+          <a:bodyPr wrap="square" rtlCol="0">
+            <a:spAutoFit/>
+          </a:bodyPr>
+          <a:lstStyle/>
+          <a:p>
+            <a:r>
+              <a:rPr lang="en-US" dirty="0"/>
+              <a:t>regular root vertices</a:t>
+            </a:r>
+          </a:p>
+        </p:txBody>
+      </p:sp>
+      <p:graphicFrame>
+        <p:nvGraphicFramePr>
+          <p:cNvPr id="14" name="Content Placeholder 3">
+            <a:extLst>
+              <a:ext uri="{FF2B5EF4-FFF2-40B4-BE49-F238E27FC236}">
+                <a16:creationId xmlns:a16="http://schemas.microsoft.com/office/drawing/2014/main" id="{C6FCD81F-D4A1-BEE8-5E13-FBED0B789AD8}"/>
+              </a:ext>
+            </a:extLst>
+          </p:cNvPr>
+          <p:cNvGraphicFramePr>
+            <a:graphicFrameLocks/>
+          </p:cNvGraphicFramePr>
+          <p:nvPr/>
+        </p:nvGraphicFramePr>
+        <p:xfrm>
+          <a:off x="7885816" y="4809544"/>
+          <a:ext cx="1272252" cy="438359"/>
+        </p:xfrm>
+        <a:graphic>
+          <a:graphicData uri="http://schemas.openxmlformats.org/drawingml/2006/table">
+            <a:tbl>
+              <a:tblPr firstRow="1" bandRow="1">
+                <a:tableStyleId>{5940675A-B579-460E-94D1-54222C63F5DA}</a:tableStyleId>
+              </a:tblPr>
+              <a:tblGrid>
+                <a:gridCol w="636126">
+                  <a:extLst>
+                    <a:ext uri="{9D8B030D-6E8A-4147-A177-3AD203B41FA5}">
+                      <a16:colId xmlns:a16="http://schemas.microsoft.com/office/drawing/2014/main" val="194980701"/>
+                    </a:ext>
+                  </a:extLst>
+                </a:gridCol>
+                <a:gridCol w="636126">
+                  <a:extLst>
+                    <a:ext uri="{9D8B030D-6E8A-4147-A177-3AD203B41FA5}">
+                      <a16:colId xmlns:a16="http://schemas.microsoft.com/office/drawing/2014/main" val="2814616541"/>
+                    </a:ext>
+                  </a:extLst>
+                </a:gridCol>
+              </a:tblGrid>
+              <a:tr h="438359">
+                <a:tc>
+                  <a:txBody>
+                    <a:bodyPr/>
+                    <a:lstStyle/>
+                    <a:p>
+                      <a:pPr algn="ctr"/>
+                      <a:endParaRPr lang="en-US" dirty="0"/>
+                    </a:p>
+                  </a:txBody>
+                  <a:tcPr/>
+                </a:tc>
+                <a:tc>
+                  <a:txBody>
+                    <a:bodyPr/>
+                    <a:lstStyle/>
+                    <a:p>
+                      <a:pPr algn="ctr"/>
+                      <a:endParaRPr lang="en-US" dirty="0"/>
+                    </a:p>
+                  </a:txBody>
+                  <a:tcPr/>
+                </a:tc>
+                <a:extLst>
+                  <a:ext uri="{0D108BD9-81ED-4DB2-BD59-A6C34878D82A}">
+                    <a16:rowId xmlns:a16="http://schemas.microsoft.com/office/drawing/2014/main" val="2287342528"/>
+                  </a:ext>
+                </a:extLst>
+              </a:tr>
+            </a:tbl>
+          </a:graphicData>
+        </a:graphic>
+      </p:graphicFrame>
+      <p:sp>
+        <p:nvSpPr>
+          <p:cNvPr id="15" name="TextBox 14">
+            <a:extLst>
+              <a:ext uri="{FF2B5EF4-FFF2-40B4-BE49-F238E27FC236}">
+                <a16:creationId xmlns:a16="http://schemas.microsoft.com/office/drawing/2014/main" id="{44B4EE0A-6C55-BBED-95D8-E20AFE162E30}"/>
+              </a:ext>
+            </a:extLst>
+          </p:cNvPr>
+          <p:cNvSpPr txBox="1"/>
+          <p:nvPr/>
+        </p:nvSpPr>
+        <p:spPr>
+          <a:xfrm>
+            <a:off x="7596657" y="4427415"/>
+            <a:ext cx="2406533" cy="369332"/>
+          </a:xfrm>
+          <a:prstGeom prst="rect">
+            <a:avLst/>
+          </a:prstGeom>
+          <a:noFill/>
+        </p:spPr>
+        <p:txBody>
+          <a:bodyPr wrap="square" rtlCol="0">
+            <a:spAutoFit/>
+          </a:bodyPr>
+          <a:lstStyle/>
+          <a:p>
+            <a:r>
+              <a:rPr lang="en-US" dirty="0" err="1"/>
+              <a:t>big_root</a:t>
+            </a:r>
+            <a:r>
+              <a:rPr lang="en-US" dirty="0"/>
+              <a:t> vertices</a:t>
+            </a:r>
+          </a:p>
+        </p:txBody>
+      </p:sp>
+      <p:sp>
+        <p:nvSpPr>
+          <p:cNvPr id="19" name="TextBox 18">
+            <a:extLst>
+              <a:ext uri="{FF2B5EF4-FFF2-40B4-BE49-F238E27FC236}">
+                <a16:creationId xmlns:a16="http://schemas.microsoft.com/office/drawing/2014/main" id="{04B344CD-3D80-F184-01EF-D60C64B87CD9}"/>
+              </a:ext>
+            </a:extLst>
+          </p:cNvPr>
+          <p:cNvSpPr txBox="1"/>
+          <p:nvPr/>
+        </p:nvSpPr>
+        <p:spPr>
+          <a:xfrm>
+            <a:off x="7227116" y="5365990"/>
+            <a:ext cx="3034677" cy="646331"/>
+          </a:xfrm>
+          <a:prstGeom prst="rect">
+            <a:avLst/>
+          </a:prstGeom>
+          <a:noFill/>
+        </p:spPr>
+        <p:txBody>
+          <a:bodyPr wrap="none" rtlCol="0">
+            <a:spAutoFit/>
+          </a:bodyPr>
+          <a:lstStyle/>
+          <a:p>
+            <a:r>
+              <a:rPr lang="en-US" dirty="0"/>
+              <a:t>master schedules </a:t>
+            </a:r>
+            <a:r>
+              <a:rPr lang="en-US" dirty="0" err="1"/>
+              <a:t>big_root</a:t>
+            </a:r>
+            <a:r>
+              <a:rPr lang="en-US" dirty="0"/>
+              <a:t> </a:t>
+            </a:r>
+          </a:p>
+          <a:p>
+            <a:r>
+              <a:rPr lang="en-US" dirty="0"/>
+              <a:t>vertices to CPU threads only </a:t>
+            </a:r>
+          </a:p>
+        </p:txBody>
+      </p:sp>
+    </p:spTree>
+    <p:extLst>
+      <p:ext uri="{BB962C8B-B14F-4D97-AF65-F5344CB8AC3E}">
+        <p14:creationId xmlns:p14="http://schemas.microsoft.com/office/powerpoint/2010/main" val="760717346"/>
+      </p:ext>
+    </p:extLst>
+  </p:cSld>
+  <p:clrMapOvr>
+    <a:masterClrMapping/>
+  </p:clrMapOvr>
+</p:sld>
+</file>
+
+<file path=ppt/slides/slide9.xml><?xml version="1.0" encoding="utf-8"?>
+<p:sld xmlns:a="http://schemas.openxmlformats.org/drawingml/2006/main" xmlns:r="http://schemas.openxmlformats.org/officeDocument/2006/relationships" xmlns:p="http://schemas.openxmlformats.org/presentationml/2006/main">
+  <p:cSld>
+    <p:spTree>
+      <p:nvGrpSpPr>
+        <p:cNvPr id="1" name=""/>
+        <p:cNvGrpSpPr/>
+        <p:nvPr/>
+      </p:nvGrpSpPr>
+      <p:grpSpPr>
+        <a:xfrm>
+          <a:off x="0" y="0"/>
+          <a:ext cx="0" cy="0"/>
+          <a:chOff x="0" y="0"/>
+          <a:chExt cx="0" cy="0"/>
+        </a:xfrm>
+      </p:grpSpPr>
+      <p:sp>
+        <p:nvSpPr>
+          <p:cNvPr id="2" name="Title 1">
+            <a:extLst>
+              <a:ext uri="{FF2B5EF4-FFF2-40B4-BE49-F238E27FC236}">
+                <a16:creationId xmlns:a16="http://schemas.microsoft.com/office/drawing/2014/main" id="{7D291E18-9DFD-BE05-AAD5-88906D182AFF}"/>
+              </a:ext>
+            </a:extLst>
+          </p:cNvPr>
+          <p:cNvSpPr>
+            <a:spLocks noGrp="1"/>
+          </p:cNvSpPr>
+          <p:nvPr>
+            <p:ph type="title"/>
+          </p:nvPr>
+        </p:nvSpPr>
+        <p:spPr/>
+        <p:txBody>
+          <a:bodyPr/>
+          <a:lstStyle/>
+          <a:p>
+            <a:r>
+              <a:rPr lang="en-US" dirty="0"/>
+              <a:t>Update CPU Worker</a:t>
+            </a:r>
+          </a:p>
+        </p:txBody>
+      </p:sp>
+      <p:pic>
+        <p:nvPicPr>
+          <p:cNvPr id="4" name="Picture 3">
+            <a:extLst>
+              <a:ext uri="{FF2B5EF4-FFF2-40B4-BE49-F238E27FC236}">
+                <a16:creationId xmlns:a16="http://schemas.microsoft.com/office/drawing/2014/main" id="{B34F3316-7270-F1BB-A82C-E34019F8BAEE}"/>
+              </a:ext>
+            </a:extLst>
+          </p:cNvPr>
+          <p:cNvPicPr>
+            <a:picLocks noChangeAspect="1"/>
+          </p:cNvPicPr>
+          <p:nvPr/>
+        </p:nvPicPr>
+        <p:blipFill>
+          <a:blip r:embed="rId2"/>
+          <a:srcRect b="9091"/>
+          <a:stretch>
+            <a:fillRect/>
+          </a:stretch>
+        </p:blipFill>
+        <p:spPr>
+          <a:xfrm>
+            <a:off x="2349500" y="1955631"/>
+            <a:ext cx="7950200" cy="2603669"/>
+          </a:xfrm>
+          <a:prstGeom prst="rect">
+            <a:avLst/>
+          </a:prstGeom>
+        </p:spPr>
+      </p:pic>
+      <p:pic>
+        <p:nvPicPr>
+          <p:cNvPr id="7" name="Picture 6">
+            <a:extLst>
+              <a:ext uri="{FF2B5EF4-FFF2-40B4-BE49-F238E27FC236}">
+                <a16:creationId xmlns:a16="http://schemas.microsoft.com/office/drawing/2014/main" id="{0887BFF7-624C-257F-6649-8B778DD7D07F}"/>
+              </a:ext>
+            </a:extLst>
+          </p:cNvPr>
+          <p:cNvPicPr>
+            <a:picLocks noChangeAspect="1"/>
+          </p:cNvPicPr>
+          <p:nvPr/>
+        </p:nvPicPr>
+        <p:blipFill>
+          <a:blip r:embed="rId3"/>
+          <a:srcRect l="53140"/>
+          <a:stretch>
+            <a:fillRect/>
+          </a:stretch>
+        </p:blipFill>
+        <p:spPr>
+          <a:xfrm>
+            <a:off x="7412901" y="5259645"/>
+            <a:ext cx="390360" cy="730728"/>
+          </a:xfrm>
+          <a:prstGeom prst="rect">
+            <a:avLst/>
+          </a:prstGeom>
+        </p:spPr>
+      </p:pic>
+      <p:sp>
+        <p:nvSpPr>
+          <p:cNvPr id="8" name="TextBox 7">
+            <a:extLst>
+              <a:ext uri="{FF2B5EF4-FFF2-40B4-BE49-F238E27FC236}">
+                <a16:creationId xmlns:a16="http://schemas.microsoft.com/office/drawing/2014/main" id="{8D916048-DF75-1452-4265-9D9A582345D9}"/>
+              </a:ext>
+            </a:extLst>
+          </p:cNvPr>
+          <p:cNvSpPr txBox="1"/>
+          <p:nvPr/>
+        </p:nvSpPr>
+        <p:spPr>
+          <a:xfrm>
+            <a:off x="7412901" y="5259645"/>
+            <a:ext cx="626006" cy="276999"/>
+          </a:xfrm>
+          <a:prstGeom prst="rect">
+            <a:avLst/>
+          </a:prstGeom>
+          <a:noFill/>
+        </p:spPr>
+        <p:txBody>
+          <a:bodyPr wrap="square" rtlCol="0">
+            <a:spAutoFit/>
+          </a:bodyPr>
+          <a:lstStyle/>
+          <a:p>
+            <a:r>
+              <a:rPr lang="en-US" sz="1200" b="1" i="1" dirty="0"/>
+              <a:t>big</a:t>
+            </a:r>
+          </a:p>
+        </p:txBody>
+      </p:sp>
+      <p:pic>
+        <p:nvPicPr>
+          <p:cNvPr id="15" name="Picture 14">
+            <a:extLst>
+              <a:ext uri="{FF2B5EF4-FFF2-40B4-BE49-F238E27FC236}">
+                <a16:creationId xmlns:a16="http://schemas.microsoft.com/office/drawing/2014/main" id="{190DF368-E8DA-C66C-E90C-77DD0DB2C4F5}"/>
+              </a:ext>
+            </a:extLst>
+          </p:cNvPr>
+          <p:cNvPicPr>
+            <a:picLocks noChangeAspect="1"/>
+          </p:cNvPicPr>
+          <p:nvPr/>
+        </p:nvPicPr>
+        <p:blipFill>
+          <a:blip r:embed="rId4"/>
+          <a:stretch>
+            <a:fillRect/>
+          </a:stretch>
+        </p:blipFill>
+        <p:spPr>
+          <a:xfrm>
+            <a:off x="5721350" y="1663531"/>
+            <a:ext cx="2527300" cy="292100"/>
+          </a:xfrm>
+          <a:prstGeom prst="rect">
+            <a:avLst/>
+          </a:prstGeom>
+        </p:spPr>
+      </p:pic>
+      <p:sp>
+        <p:nvSpPr>
+          <p:cNvPr id="16" name="TextBox 15">
+            <a:extLst>
+              <a:ext uri="{FF2B5EF4-FFF2-40B4-BE49-F238E27FC236}">
+                <a16:creationId xmlns:a16="http://schemas.microsoft.com/office/drawing/2014/main" id="{132A7DEC-0ED2-99D7-C858-3C74D3068193}"/>
+              </a:ext>
+            </a:extLst>
+          </p:cNvPr>
+          <p:cNvSpPr txBox="1"/>
+          <p:nvPr/>
+        </p:nvSpPr>
+        <p:spPr>
+          <a:xfrm>
+            <a:off x="5721350" y="1321356"/>
+            <a:ext cx="954107" cy="369332"/>
+          </a:xfrm>
+          <a:prstGeom prst="rect">
+            <a:avLst/>
+          </a:prstGeom>
+          <a:noFill/>
+        </p:spPr>
+        <p:txBody>
+          <a:bodyPr wrap="none" rtlCol="0">
+            <a:spAutoFit/>
+          </a:bodyPr>
+          <a:lstStyle/>
+          <a:p>
+            <a:r>
+              <a:rPr lang="en-US" dirty="0"/>
+              <a:t>CPU </a:t>
+            </a:r>
+            <a:r>
+              <a:rPr lang="en-US" dirty="0">
+                <a:sym typeface="Wingdings" pitchFamily="2" charset="2"/>
+              </a:rPr>
+              <a:t> </a:t>
+            </a:r>
+            <a:endParaRPr lang="en-US" dirty="0"/>
+          </a:p>
+        </p:txBody>
+      </p:sp>
+      <p:sp>
+        <p:nvSpPr>
+          <p:cNvPr id="17" name="TextBox 16">
+            <a:extLst>
+              <a:ext uri="{FF2B5EF4-FFF2-40B4-BE49-F238E27FC236}">
+                <a16:creationId xmlns:a16="http://schemas.microsoft.com/office/drawing/2014/main" id="{12E7DE85-92A7-A7EA-AE7C-F1B776E35B2C}"/>
+              </a:ext>
+            </a:extLst>
+          </p:cNvPr>
+          <p:cNvSpPr txBox="1"/>
+          <p:nvPr/>
+        </p:nvSpPr>
+        <p:spPr>
+          <a:xfrm>
+            <a:off x="4622800" y="1586299"/>
+            <a:ext cx="989438" cy="369332"/>
+          </a:xfrm>
+          <a:prstGeom prst="rect">
+            <a:avLst/>
+          </a:prstGeom>
+          <a:noFill/>
+        </p:spPr>
+        <p:txBody>
+          <a:bodyPr wrap="none" rtlCol="0">
+            <a:spAutoFit/>
+          </a:bodyPr>
+          <a:lstStyle/>
+          <a:p>
+            <a:r>
+              <a:rPr lang="en-US" dirty="0" err="1"/>
+              <a:t>big_root</a:t>
+            </a:r>
+            <a:endParaRPr lang="en-US" dirty="0"/>
+          </a:p>
+        </p:txBody>
+      </p:sp>
+      <p:cxnSp>
+        <p:nvCxnSpPr>
+          <p:cNvPr id="19" name="Straight Arrow Connector 18">
+            <a:extLst>
+              <a:ext uri="{FF2B5EF4-FFF2-40B4-BE49-F238E27FC236}">
+                <a16:creationId xmlns:a16="http://schemas.microsoft.com/office/drawing/2014/main" id="{77C7BAF6-FF5F-E302-0365-0CAF2AAD1F7C}"/>
+              </a:ext>
+            </a:extLst>
+          </p:cNvPr>
+          <p:cNvCxnSpPr>
+            <a:stCxn id="15" idx="2"/>
+          </p:cNvCxnSpPr>
+          <p:nvPr/>
+        </p:nvCxnSpPr>
+        <p:spPr>
+          <a:xfrm>
+            <a:off x="6985000" y="1955631"/>
+            <a:ext cx="1263650" cy="1168569"/>
+          </a:xfrm>
+          <a:prstGeom prst="straightConnector1">
+            <a:avLst/>
+          </a:prstGeom>
+          <a:ln>
+            <a:tailEnd type="triangle"/>
+          </a:ln>
+        </p:spPr>
+        <p:style>
+          <a:lnRef idx="2">
+            <a:schemeClr val="accent1"/>
+          </a:lnRef>
+          <a:fillRef idx="0">
+            <a:schemeClr val="accent1"/>
+          </a:fillRef>
+          <a:effectRef idx="1">
+            <a:schemeClr val="accent1"/>
+          </a:effectRef>
+          <a:fontRef idx="minor">
+            <a:schemeClr val="tx1"/>
+          </a:fontRef>
+        </p:style>
+      </p:cxnSp>
+      <p:cxnSp>
+        <p:nvCxnSpPr>
+          <p:cNvPr id="20" name="Straight Arrow Connector 19">
+            <a:extLst>
+              <a:ext uri="{FF2B5EF4-FFF2-40B4-BE49-F238E27FC236}">
+                <a16:creationId xmlns:a16="http://schemas.microsoft.com/office/drawing/2014/main" id="{A188E86F-74E4-1777-90C5-96968350B754}"/>
+              </a:ext>
+            </a:extLst>
+          </p:cNvPr>
+          <p:cNvCxnSpPr>
+            <a:cxnSpLocks/>
+          </p:cNvCxnSpPr>
+          <p:nvPr/>
+        </p:nvCxnSpPr>
+        <p:spPr>
+          <a:xfrm>
+            <a:off x="7539468" y="3572171"/>
+            <a:ext cx="27025" cy="1687473"/>
+          </a:xfrm>
+          <a:prstGeom prst="straightConnector1">
+            <a:avLst/>
+          </a:prstGeom>
+          <a:ln>
+            <a:prstDash val="dash"/>
+            <a:tailEnd type="triangle"/>
+          </a:ln>
+        </p:spPr>
+        <p:style>
+          <a:lnRef idx="2">
+            <a:schemeClr val="accent1"/>
+          </a:lnRef>
+          <a:fillRef idx="0">
+            <a:schemeClr val="accent1"/>
+          </a:fillRef>
+          <a:effectRef idx="1">
+            <a:schemeClr val="accent1"/>
+          </a:effectRef>
+          <a:fontRef idx="minor">
+            <a:schemeClr val="tx1"/>
+          </a:fontRef>
+        </p:style>
+      </p:cxnSp>
+      <p:sp>
+        <p:nvSpPr>
+          <p:cNvPr id="22" name="TextBox 21">
+            <a:extLst>
+              <a:ext uri="{FF2B5EF4-FFF2-40B4-BE49-F238E27FC236}">
+                <a16:creationId xmlns:a16="http://schemas.microsoft.com/office/drawing/2014/main" id="{953AEAA8-B890-570B-D908-E2423BC4FBAA}"/>
+              </a:ext>
+            </a:extLst>
+          </p:cNvPr>
+          <p:cNvSpPr txBox="1"/>
+          <p:nvPr/>
+        </p:nvSpPr>
+        <p:spPr>
+          <a:xfrm>
+            <a:off x="6592907" y="4618895"/>
+            <a:ext cx="950004" cy="646331"/>
+          </a:xfrm>
+          <a:prstGeom prst="rect">
+            <a:avLst/>
+          </a:prstGeom>
+          <a:noFill/>
+        </p:spPr>
+        <p:txBody>
+          <a:bodyPr wrap="none" rtlCol="0">
+            <a:spAutoFit/>
+          </a:bodyPr>
+          <a:lstStyle/>
+          <a:p>
+            <a:r>
+              <a:rPr lang="en-US" dirty="0"/>
+              <a:t>still a </a:t>
+            </a:r>
+          </a:p>
+          <a:p>
+            <a:r>
+              <a:rPr lang="en-US" dirty="0"/>
+              <a:t>big task</a:t>
+            </a:r>
+          </a:p>
+        </p:txBody>
+      </p:sp>
+      <p:pic>
+        <p:nvPicPr>
+          <p:cNvPr id="25" name="Picture 24">
+            <a:extLst>
+              <a:ext uri="{FF2B5EF4-FFF2-40B4-BE49-F238E27FC236}">
+                <a16:creationId xmlns:a16="http://schemas.microsoft.com/office/drawing/2014/main" id="{93D4A19A-2EDE-CB25-E141-9CEF122CCFC2}"/>
+              </a:ext>
+            </a:extLst>
+          </p:cNvPr>
+          <p:cNvPicPr>
+            <a:picLocks noChangeAspect="1"/>
+          </p:cNvPicPr>
+          <p:nvPr/>
+        </p:nvPicPr>
+        <p:blipFill>
+          <a:blip r:embed="rId5"/>
+          <a:srcRect r="28414" b="18252"/>
+          <a:stretch>
+            <a:fillRect/>
+          </a:stretch>
+        </p:blipFill>
+        <p:spPr>
+          <a:xfrm>
+            <a:off x="8038907" y="5756778"/>
+            <a:ext cx="736405" cy="467190"/>
+          </a:xfrm>
+          <a:prstGeom prst="rect">
+            <a:avLst/>
+          </a:prstGeom>
+        </p:spPr>
+      </p:pic>
+      <p:cxnSp>
+        <p:nvCxnSpPr>
+          <p:cNvPr id="26" name="Straight Arrow Connector 25">
+            <a:extLst>
+              <a:ext uri="{FF2B5EF4-FFF2-40B4-BE49-F238E27FC236}">
+                <a16:creationId xmlns:a16="http://schemas.microsoft.com/office/drawing/2014/main" id="{F8B99B4F-A683-F981-B0B5-E57FAF0629D9}"/>
+              </a:ext>
+            </a:extLst>
+          </p:cNvPr>
+          <p:cNvCxnSpPr>
+            <a:cxnSpLocks/>
+            <a:endCxn id="25" idx="1"/>
+          </p:cNvCxnSpPr>
+          <p:nvPr/>
+        </p:nvCxnSpPr>
+        <p:spPr>
+          <a:xfrm>
+            <a:off x="7632312" y="5990373"/>
+            <a:ext cx="406595" cy="0"/>
+          </a:xfrm>
+          <a:prstGeom prst="straightConnector1">
+            <a:avLst/>
+          </a:prstGeom>
+          <a:ln>
+            <a:prstDash val="dash"/>
+            <a:tailEnd type="triangle"/>
+          </a:ln>
+        </p:spPr>
+        <p:style>
+          <a:lnRef idx="2">
+            <a:schemeClr val="accent1"/>
+          </a:lnRef>
+          <a:fillRef idx="0">
+            <a:schemeClr val="accent1"/>
+          </a:fillRef>
+          <a:effectRef idx="1">
+            <a:schemeClr val="accent1"/>
+          </a:effectRef>
+          <a:fontRef idx="minor">
+            <a:schemeClr val="tx1"/>
+          </a:fontRef>
+        </p:style>
+      </p:cxnSp>
+      <p:sp>
+        <p:nvSpPr>
+          <p:cNvPr id="31" name="TextBox 30">
+            <a:extLst>
+              <a:ext uri="{FF2B5EF4-FFF2-40B4-BE49-F238E27FC236}">
+                <a16:creationId xmlns:a16="http://schemas.microsoft.com/office/drawing/2014/main" id="{089AF7A7-23FB-40B7-63F6-C7FA798F1045}"/>
+              </a:ext>
+            </a:extLst>
+          </p:cNvPr>
+          <p:cNvSpPr txBox="1"/>
+          <p:nvPr/>
+        </p:nvSpPr>
+        <p:spPr>
+          <a:xfrm>
+            <a:off x="8700988" y="5805707"/>
+            <a:ext cx="716863" cy="369332"/>
+          </a:xfrm>
+          <a:prstGeom prst="rect">
+            <a:avLst/>
+          </a:prstGeom>
+          <a:noFill/>
+        </p:spPr>
+        <p:txBody>
+          <a:bodyPr wrap="none" rtlCol="0">
+            <a:spAutoFit/>
+          </a:bodyPr>
+          <a:lstStyle/>
+          <a:p>
+            <a:r>
+              <a:rPr lang="en-US" i="1" dirty="0" err="1"/>
+              <a:t>big_S</a:t>
+            </a:r>
+            <a:endParaRPr lang="en-US" i="1" dirty="0"/>
+          </a:p>
+        </p:txBody>
+      </p:sp>
+      <p:cxnSp>
+        <p:nvCxnSpPr>
+          <p:cNvPr id="33" name="Straight Arrow Connector 32">
+            <a:extLst>
+              <a:ext uri="{FF2B5EF4-FFF2-40B4-BE49-F238E27FC236}">
+                <a16:creationId xmlns:a16="http://schemas.microsoft.com/office/drawing/2014/main" id="{11A66878-DAE4-281F-4E7A-65095BA631A9}"/>
+              </a:ext>
+            </a:extLst>
+          </p:cNvPr>
+          <p:cNvCxnSpPr>
+            <a:cxnSpLocks/>
+            <a:stCxn id="25" idx="1"/>
+          </p:cNvCxnSpPr>
+          <p:nvPr/>
+        </p:nvCxnSpPr>
+        <p:spPr>
+          <a:xfrm flipV="1">
+            <a:off x="8038907" y="3552586"/>
+            <a:ext cx="474147" cy="2437787"/>
+          </a:xfrm>
+          <a:prstGeom prst="straightConnector1">
+            <a:avLst/>
+          </a:prstGeom>
+          <a:ln>
+            <a:tailEnd type="triangle"/>
+          </a:ln>
+        </p:spPr>
+        <p:style>
+          <a:lnRef idx="2">
+            <a:schemeClr val="accent1"/>
+          </a:lnRef>
+          <a:fillRef idx="0">
+            <a:schemeClr val="accent1"/>
+          </a:fillRef>
+          <a:effectRef idx="1">
+            <a:schemeClr val="accent1"/>
+          </a:effectRef>
+          <a:fontRef idx="minor">
+            <a:schemeClr val="tx1"/>
+          </a:fontRef>
+        </p:style>
+      </p:cxnSp>
+    </p:spTree>
+    <p:extLst>
+      <p:ext uri="{BB962C8B-B14F-4D97-AF65-F5344CB8AC3E}">
+        <p14:creationId xmlns:p14="http://schemas.microsoft.com/office/powerpoint/2010/main" val="567586229"/>
       </p:ext>
     </p:extLst>
   </p:cSld>

</xml_diff>

<commit_message>
auto commit 2026-07-30 17:54:52
</commit_message>
<xml_diff>
--- a/revision.pptx
+++ b/revision.pptx
@@ -17,7 +17,10 @@
     <p:sldId id="262" r:id="rId11"/>
     <p:sldId id="263" r:id="rId12"/>
     <p:sldId id="264" r:id="rId13"/>
-    <p:sldId id="265" r:id="rId14"/>
+    <p:sldId id="270" r:id="rId14"/>
+    <p:sldId id="265" r:id="rId15"/>
+    <p:sldId id="271" r:id="rId16"/>
+    <p:sldId id="272" r:id="rId17"/>
   </p:sldIdLst>
   <p:sldSz cx="12192000" cy="6858000"/>
   <p:notesSz cx="6858000" cy="9144000"/>
@@ -271,7 +274,7 @@
           <a:p>
             <a:fld id="{6F584DAC-AA37-8C49-B5B6-53E9519E19BB}" type="datetimeFigureOut">
               <a:rPr lang="en-US" smtClean="0"/>
-              <a:t>7/13/26</a:t>
+              <a:t>7/25/26</a:t>
             </a:fld>
             <a:endParaRPr lang="en-US"/>
           </a:p>
@@ -469,7 +472,7 @@
           <a:p>
             <a:fld id="{6F584DAC-AA37-8C49-B5B6-53E9519E19BB}" type="datetimeFigureOut">
               <a:rPr lang="en-US" smtClean="0"/>
-              <a:t>7/13/26</a:t>
+              <a:t>7/25/26</a:t>
             </a:fld>
             <a:endParaRPr lang="en-US"/>
           </a:p>
@@ -677,7 +680,7 @@
           <a:p>
             <a:fld id="{6F584DAC-AA37-8C49-B5B6-53E9519E19BB}" type="datetimeFigureOut">
               <a:rPr lang="en-US" smtClean="0"/>
-              <a:t>7/13/26</a:t>
+              <a:t>7/25/26</a:t>
             </a:fld>
             <a:endParaRPr lang="en-US"/>
           </a:p>
@@ -875,7 +878,7 @@
           <a:p>
             <a:fld id="{6F584DAC-AA37-8C49-B5B6-53E9519E19BB}" type="datetimeFigureOut">
               <a:rPr lang="en-US" smtClean="0"/>
-              <a:t>7/13/26</a:t>
+              <a:t>7/25/26</a:t>
             </a:fld>
             <a:endParaRPr lang="en-US"/>
           </a:p>
@@ -1150,7 +1153,7 @@
           <a:p>
             <a:fld id="{6F584DAC-AA37-8C49-B5B6-53E9519E19BB}" type="datetimeFigureOut">
               <a:rPr lang="en-US" smtClean="0"/>
-              <a:t>7/13/26</a:t>
+              <a:t>7/25/26</a:t>
             </a:fld>
             <a:endParaRPr lang="en-US"/>
           </a:p>
@@ -1415,7 +1418,7 @@
           <a:p>
             <a:fld id="{6F584DAC-AA37-8C49-B5B6-53E9519E19BB}" type="datetimeFigureOut">
               <a:rPr lang="en-US" smtClean="0"/>
-              <a:t>7/13/26</a:t>
+              <a:t>7/25/26</a:t>
             </a:fld>
             <a:endParaRPr lang="en-US"/>
           </a:p>
@@ -1827,7 +1830,7 @@
           <a:p>
             <a:fld id="{6F584DAC-AA37-8C49-B5B6-53E9519E19BB}" type="datetimeFigureOut">
               <a:rPr lang="en-US" smtClean="0"/>
-              <a:t>7/13/26</a:t>
+              <a:t>7/25/26</a:t>
             </a:fld>
             <a:endParaRPr lang="en-US"/>
           </a:p>
@@ -1968,7 +1971,7 @@
           <a:p>
             <a:fld id="{6F584DAC-AA37-8C49-B5B6-53E9519E19BB}" type="datetimeFigureOut">
               <a:rPr lang="en-US" smtClean="0"/>
-              <a:t>7/13/26</a:t>
+              <a:t>7/25/26</a:t>
             </a:fld>
             <a:endParaRPr lang="en-US"/>
           </a:p>
@@ -2081,7 +2084,7 @@
           <a:p>
             <a:fld id="{6F584DAC-AA37-8C49-B5B6-53E9519E19BB}" type="datetimeFigureOut">
               <a:rPr lang="en-US" smtClean="0"/>
-              <a:t>7/13/26</a:t>
+              <a:t>7/25/26</a:t>
             </a:fld>
             <a:endParaRPr lang="en-US"/>
           </a:p>
@@ -2392,7 +2395,7 @@
           <a:p>
             <a:fld id="{6F584DAC-AA37-8C49-B5B6-53E9519E19BB}" type="datetimeFigureOut">
               <a:rPr lang="en-US" smtClean="0"/>
-              <a:t>7/13/26</a:t>
+              <a:t>7/25/26</a:t>
             </a:fld>
             <a:endParaRPr lang="en-US"/>
           </a:p>
@@ -2680,7 +2683,7 @@
           <a:p>
             <a:fld id="{6F584DAC-AA37-8C49-B5B6-53E9519E19BB}" type="datetimeFigureOut">
               <a:rPr lang="en-US" smtClean="0"/>
-              <a:t>7/13/26</a:t>
+              <a:t>7/25/26</a:t>
             </a:fld>
             <a:endParaRPr lang="en-US"/>
           </a:p>
@@ -2921,7 +2924,7 @@
           <a:p>
             <a:fld id="{6F584DAC-AA37-8C49-B5B6-53E9519E19BB}" type="datetimeFigureOut">
               <a:rPr lang="en-US" smtClean="0"/>
-              <a:t>7/13/26</a:t>
+              <a:t>7/25/26</a:t>
             </a:fld>
             <a:endParaRPr lang="en-US"/>
           </a:p>
@@ -3360,9 +3363,10 @@
           <a:lstStyle/>
           <a:p>
             <a:r>
-              <a:rPr lang="en-US" dirty="0"/>
+              <a:rPr lang="en-US"/>
               <a:t>Managed Memory Spill Buffer</a:t>
             </a:r>
+            <a:endParaRPr lang="en-US" dirty="0"/>
           </a:p>
         </p:txBody>
       </p:sp>
@@ -3427,9 +3431,10 @@
           <a:lstStyle/>
           <a:p>
             <a:r>
-              <a:rPr lang="en-US" dirty="0"/>
+              <a:rPr lang="en-US"/>
               <a:t>Too slow to read/write to managed memory buffer. </a:t>
             </a:r>
+            <a:endParaRPr lang="en-US" dirty="0"/>
           </a:p>
           <a:p>
             <a:r>
@@ -3449,15 +3454,25 @@
           </a:p>
           <a:p>
             <a:r>
+              <a:rPr lang="en-US"/>
+              <a:t>total run time: 105.2 sec </a:t>
+            </a:r>
+            <a:endParaRPr lang="en-US" dirty="0"/>
+          </a:p>
+          <a:p>
+            <a:r>
+              <a:rPr lang="en-US"/>
+              <a:t>host buffer read</a:t>
+            </a:r>
+            <a:r>
               <a:rPr lang="en-US" dirty="0"/>
-              <a:t>total run time: 105.2 sec </a:t>
-            </a:r>
-          </a:p>
-          <a:p>
-            <a:r>
-              <a:rPr lang="en-US" dirty="0"/>
-              <a:t>host buffer read/write: 20.3 sec</a:t>
-            </a:r>
+              <a:t>/</a:t>
+            </a:r>
+            <a:r>
+              <a:rPr lang="en-US"/>
+              <a:t>write: 20.3 sec</a:t>
+            </a:r>
+            <a:endParaRPr lang="en-US" dirty="0"/>
           </a:p>
         </p:txBody>
       </p:sp>
@@ -3513,9 +3528,10 @@
           <a:lstStyle/>
           <a:p>
             <a:r>
-              <a:rPr lang="en-US" dirty="0"/>
+              <a:rPr lang="en-US"/>
               <a:t>Why CPU is much faster than GPU? </a:t>
             </a:r>
+            <a:endParaRPr lang="en-US" dirty="0"/>
           </a:p>
         </p:txBody>
       </p:sp>
@@ -3541,15 +3557,17 @@
           <a:lstStyle/>
           <a:p>
             <a:r>
-              <a:rPr lang="en-US" dirty="0"/>
+              <a:rPr lang="en-US"/>
               <a:t>A few vertices are very high degree in the graphs</a:t>
             </a:r>
-          </a:p>
-          <a:p>
-            <a:r>
-              <a:rPr lang="en-US" dirty="0"/>
+            <a:endParaRPr lang="en-US" dirty="0"/>
+          </a:p>
+          <a:p>
+            <a:r>
+              <a:rPr lang="en-US"/>
               <a:t>Since a warp processes a vertex, a high degree vertex causes a warp to take a long time</a:t>
             </a:r>
+            <a:endParaRPr lang="en-US" dirty="0"/>
           </a:p>
         </p:txBody>
       </p:sp>
@@ -3665,8 +3683,12 @@
           <a:lstStyle/>
           <a:p>
             <a:r>
+              <a:rPr lang="en-US"/>
+              <a:t>Why hybrid-copy is faster than layered</a:t>
+            </a:r>
+            <a:r>
               <a:rPr lang="en-US" dirty="0"/>
-              <a:t>Why hybrid-copy is faster than layered?</a:t>
+              <a:t>?</a:t>
             </a:r>
           </a:p>
         </p:txBody>
@@ -3698,20 +3720,8 @@
           <a:lstStyle/>
           <a:p>
             <a:r>
-              <a:rPr lang="en-US" dirty="0"/>
-              <a:t>In the layered case, a fixed </a:t>
-            </a:r>
-            <a:r>
-              <a:rPr lang="en-US" dirty="0" err="1"/>
-              <a:t>η</a:t>
-            </a:r>
-            <a:r>
-              <a:rPr lang="en-US" dirty="0"/>
-              <a:t> may underutilize GPU cores, increasing runtime. (currently </a:t>
-            </a:r>
-            <a:r>
-              <a:rPr lang="en-US" dirty="0" err="1"/>
-              <a:t>η</a:t>
+              <a:rPr lang="en-US"/>
+              <a:t>In the layered case, a fixed η may underutilize GPU cores, increasing runtime. (currently η</a:t>
             </a:r>
             <a:r>
               <a:rPr lang="en-US" dirty="0"/>
@@ -3720,8 +3730,12 @@
           </a:p>
           <a:p>
             <a:r>
+              <a:rPr lang="en-US"/>
+              <a:t>Ping-pong execution processes the entire buffer, resulting in faster runtime</a:t>
+            </a:r>
+            <a:r>
               <a:rPr lang="en-US" dirty="0"/>
-              <a:t>Ping-pong execution processes the entire buffer, resulting in faster runtime.</a:t>
+              <a:t>.</a:t>
             </a:r>
           </a:p>
         </p:txBody>
@@ -3973,7 +3987,7 @@
                         <a:buNone/>
                       </a:pPr>
                       <a:r>
-                        <a:rPr lang="en-US" sz="1600" b="1" u="none" strike="noStrike" dirty="0">
+                        <a:rPr lang="en-US" sz="1600" b="1" u="none" strike="noStrike">
                           <a:solidFill>
                             <a:srgbClr val="000000"/>
                           </a:solidFill>
@@ -4006,7 +4020,7 @@
                         </a:rPr>
                         <a:t>              1,000 </a:t>
                       </a:r>
-                      <a:endParaRPr lang="en-US" sz="1600" b="1" i="0" u="none" strike="noStrike">
+                      <a:endParaRPr lang="en-US" sz="1600" b="1" i="0" u="none" strike="noStrike" dirty="0">
                         <a:solidFill>
                           <a:srgbClr val="000000"/>
                         </a:solidFill>
@@ -4031,7 +4045,7 @@
                         </a:rPr>
                         <a:t>              2,000 </a:t>
                       </a:r>
-                      <a:endParaRPr lang="en-US" sz="1600" b="1" i="0" u="none" strike="noStrike">
+                      <a:endParaRPr lang="en-US" sz="1600" b="1" i="0" u="none" strike="noStrike" dirty="0">
                         <a:solidFill>
                           <a:srgbClr val="000000"/>
                         </a:solidFill>
@@ -4051,7 +4065,7 @@
                         <a:buNone/>
                       </a:pPr>
                       <a:r>
-                        <a:rPr lang="en-US" sz="1600" b="1" u="none" strike="noStrike" dirty="0">
+                        <a:rPr lang="en-US" sz="1600" b="1" u="none" strike="noStrike">
                           <a:effectLst/>
                         </a:rPr>
                         <a:t>              5,000 </a:t>
@@ -4179,7 +4193,7 @@
                         <a:buNone/>
                       </a:pPr>
                       <a:r>
-                        <a:rPr lang="en-US" sz="1800" b="1" u="none" strike="noStrike" dirty="0">
+                        <a:rPr lang="en-US" sz="1800" b="1" u="none" strike="noStrike">
                           <a:effectLst/>
                         </a:rPr>
                         <a:t>G2AIMD (</a:t>
@@ -4241,16 +4255,10 @@
                         <a:buNone/>
                       </a:pPr>
                       <a:r>
-                        <a:rPr lang="en-US" sz="1800" b="1" u="none" strike="noStrike" dirty="0" err="1">
+                        <a:rPr lang="en-US" sz="1800" b="1" u="none" strike="noStrike">
                           <a:effectLst/>
                         </a:rPr>
-                        <a:t>gpu</a:t>
-                      </a:r>
-                      <a:r>
-                        <a:rPr lang="en-US" sz="1800" b="1" u="none" strike="noStrike" dirty="0">
-                          <a:effectLst/>
-                        </a:rPr>
-                        <a:t>-hybrid-drop </a:t>
+                        <a:t>gpu-hybrid-drop </a:t>
                       </a:r>
                       <a:endParaRPr lang="en-US" sz="1800" b="1" i="0" u="none" strike="noStrike" dirty="0">
                         <a:solidFill>
@@ -4474,9 +4482,10 @@
           <a:lstStyle/>
           <a:p>
             <a:r>
-              <a:rPr lang="en-US" dirty="0"/>
+              <a:rPr lang="en-US"/>
               <a:t>experiments with other values of eta</a:t>
             </a:r>
+            <a:endParaRPr lang="en-US" dirty="0"/>
           </a:p>
         </p:txBody>
       </p:sp>
@@ -4532,8 +4541,12 @@
           <a:lstStyle/>
           <a:p>
             <a:r>
+              <a:rPr lang="en-US"/>
+              <a:t>Why hybrid-drop is slower than layered</a:t>
+            </a:r>
+            <a:r>
               <a:rPr lang="en-US" dirty="0"/>
-              <a:t>Why hybrid-drop is slower than layered?</a:t>
+              <a:t>?</a:t>
             </a:r>
           </a:p>
         </p:txBody>
@@ -4560,25 +4573,22 @@
           <a:lstStyle/>
           <a:p>
             <a:r>
-              <a:rPr lang="en-US" dirty="0"/>
-              <a:t>It was caused by an incorrect </a:t>
-            </a:r>
-            <a:r>
-              <a:rPr lang="en-US" dirty="0" err="1"/>
-              <a:t>gpuchunk</a:t>
-            </a:r>
-            <a:r>
-              <a:rPr lang="en-US" dirty="0"/>
-              <a:t> setting: </a:t>
-            </a:r>
+              <a:rPr lang="en-US"/>
+              <a:t>It was caused by an incorrect gpuchunk setting: </a:t>
+            </a:r>
+            <a:endParaRPr lang="en-US" dirty="0"/>
           </a:p>
           <a:p>
             <a:pPr marL="457200" lvl="1" indent="0">
               <a:buNone/>
             </a:pPr>
             <a:r>
+              <a:rPr lang="en-US"/>
+              <a:t>Hybrid-Drop used 100K, while the others used 1M</a:t>
+            </a:r>
+            <a:r>
               <a:rPr lang="en-US" dirty="0"/>
-              <a:t>Hybrid-Drop used 100K, while the others used 1M.</a:t>
+              <a:t>.</a:t>
             </a:r>
           </a:p>
         </p:txBody>
@@ -4685,7 +4695,7 @@
                         <a:buNone/>
                       </a:pPr>
                       <a:r>
-                        <a:rPr lang="en-US" sz="1800" b="1" u="none" strike="noStrike" dirty="0">
+                        <a:rPr lang="en-US" sz="1800" b="1" u="none" strike="noStrike">
                           <a:effectLst/>
                         </a:rPr>
                         <a:t>G2AIMD (</a:t>
@@ -4753,22 +4763,13 @@
                         <a:buNone/>
                       </a:pPr>
                       <a:r>
-                        <a:rPr lang="en-US" sz="1800" b="1" u="none" strike="noStrike" dirty="0" err="1">
+                        <a:rPr lang="en-US" sz="1800" b="1" u="none" strike="noStrike">
                           <a:solidFill>
                             <a:srgbClr val="C00000"/>
                           </a:solidFill>
                           <a:effectLst/>
                         </a:rPr>
-                        <a:t>gpu</a:t>
-                      </a:r>
-                      <a:r>
-                        <a:rPr lang="en-US" sz="1800" b="1" u="none" strike="noStrike" dirty="0">
-                          <a:solidFill>
-                            <a:srgbClr val="C00000"/>
-                          </a:solidFill>
-                          <a:effectLst/>
-                        </a:rPr>
-                        <a:t>-hybrid-drop </a:t>
+                        <a:t>gpu-hybrid-drop </a:t>
                       </a:r>
                       <a:endParaRPr lang="en-US" sz="1800" b="1" i="0" u="none" strike="noStrike" dirty="0">
                         <a:solidFill>
@@ -5010,7 +5011,7 @@
           <p:cNvPr id="2" name="Title 1">
             <a:extLst>
               <a:ext uri="{FF2B5EF4-FFF2-40B4-BE49-F238E27FC236}">
-                <a16:creationId xmlns:a16="http://schemas.microsoft.com/office/drawing/2014/main" id="{30F612FE-A783-B001-47EB-C974AAAD00C7}"/>
+                <a16:creationId xmlns:a16="http://schemas.microsoft.com/office/drawing/2014/main" id="{2002CC27-9BF7-ABE2-59B0-7428A1CC885D}"/>
               </a:ext>
             </a:extLst>
           </p:cNvPr>
@@ -5028,7 +5029,356 @@
           <a:p>
             <a:r>
               <a:rPr lang="en-US" dirty="0"/>
-              <a:t>Why hybrid is slower than layered? (SM)</a:t>
+              <a:t>hybrid-drop mode behavior at overflow</a:t>
+            </a:r>
+          </a:p>
+        </p:txBody>
+      </p:sp>
+      <p:sp>
+        <p:nvSpPr>
+          <p:cNvPr id="3" name="Content Placeholder 2">
+            <a:extLst>
+              <a:ext uri="{FF2B5EF4-FFF2-40B4-BE49-F238E27FC236}">
+                <a16:creationId xmlns:a16="http://schemas.microsoft.com/office/drawing/2014/main" id="{58BB11E9-601D-4836-E83A-0A1BA9B8B6A1}"/>
+              </a:ext>
+            </a:extLst>
+          </p:cNvPr>
+          <p:cNvSpPr>
+            <a:spLocks noGrp="1"/>
+          </p:cNvSpPr>
+          <p:nvPr>
+            <p:ph idx="1"/>
+          </p:nvPr>
+        </p:nvSpPr>
+        <p:spPr>
+          <a:xfrm>
+            <a:off x="838200" y="1825625"/>
+            <a:ext cx="10515600" cy="959139"/>
+          </a:xfrm>
+        </p:spPr>
+        <p:txBody>
+          <a:bodyPr/>
+          <a:lstStyle/>
+          <a:p>
+            <a:r>
+              <a:rPr lang="en-US"/>
+              <a:t>append(.) returns a struct: </a:t>
+            </a:r>
+            <a:endParaRPr lang="en-US" dirty="0"/>
+          </a:p>
+          <a:p>
+            <a:endParaRPr lang="en-US" dirty="0"/>
+          </a:p>
+        </p:txBody>
+      </p:sp>
+      <p:pic>
+        <p:nvPicPr>
+          <p:cNvPr id="5" name="Picture 4">
+            <a:extLst>
+              <a:ext uri="{FF2B5EF4-FFF2-40B4-BE49-F238E27FC236}">
+                <a16:creationId xmlns:a16="http://schemas.microsoft.com/office/drawing/2014/main" id="{94EA4180-C95A-FDFE-168E-69E46CD36B34}"/>
+              </a:ext>
+            </a:extLst>
+          </p:cNvPr>
+          <p:cNvPicPr>
+            <a:picLocks noChangeAspect="1"/>
+          </p:cNvPicPr>
+          <p:nvPr/>
+        </p:nvPicPr>
+        <p:blipFill>
+          <a:blip r:embed="rId2"/>
+          <a:stretch>
+            <a:fillRect/>
+          </a:stretch>
+        </p:blipFill>
+        <p:spPr>
+          <a:xfrm>
+            <a:off x="1423555" y="3429000"/>
+            <a:ext cx="3276600" cy="1765300"/>
+          </a:xfrm>
+          <a:prstGeom prst="rect">
+            <a:avLst/>
+          </a:prstGeom>
+        </p:spPr>
+      </p:pic>
+      <p:pic>
+        <p:nvPicPr>
+          <p:cNvPr id="7" name="Picture 6">
+            <a:extLst>
+              <a:ext uri="{FF2B5EF4-FFF2-40B4-BE49-F238E27FC236}">
+                <a16:creationId xmlns:a16="http://schemas.microsoft.com/office/drawing/2014/main" id="{2215397C-BA58-64C7-163D-038E7F87267B}"/>
+              </a:ext>
+            </a:extLst>
+          </p:cNvPr>
+          <p:cNvPicPr>
+            <a:picLocks noChangeAspect="1"/>
+          </p:cNvPicPr>
+          <p:nvPr/>
+        </p:nvPicPr>
+        <p:blipFill>
+          <a:blip r:embed="rId3"/>
+          <a:stretch>
+            <a:fillRect/>
+          </a:stretch>
+        </p:blipFill>
+        <p:spPr>
+          <a:xfrm>
+            <a:off x="5739247" y="3346450"/>
+            <a:ext cx="3733800" cy="1930400"/>
+          </a:xfrm>
+          <a:prstGeom prst="rect">
+            <a:avLst/>
+          </a:prstGeom>
+        </p:spPr>
+      </p:pic>
+      <p:sp>
+        <p:nvSpPr>
+          <p:cNvPr id="8" name="TextBox 7">
+            <a:extLst>
+              <a:ext uri="{FF2B5EF4-FFF2-40B4-BE49-F238E27FC236}">
+                <a16:creationId xmlns:a16="http://schemas.microsoft.com/office/drawing/2014/main" id="{E8AD4573-45A7-FD18-2AF6-E1657605FBE0}"/>
+              </a:ext>
+            </a:extLst>
+          </p:cNvPr>
+          <p:cNvSpPr txBox="1"/>
+          <p:nvPr/>
+        </p:nvSpPr>
+        <p:spPr>
+          <a:xfrm>
+            <a:off x="8427028" y="2596535"/>
+            <a:ext cx="2514600" cy="646331"/>
+          </a:xfrm>
+          <a:prstGeom prst="rect">
+            <a:avLst/>
+          </a:prstGeom>
+          <a:noFill/>
+        </p:spPr>
+        <p:txBody>
+          <a:bodyPr wrap="square" rtlCol="0">
+            <a:spAutoFit/>
+          </a:bodyPr>
+          <a:lstStyle/>
+          <a:p>
+            <a:r>
+              <a:rPr lang="en-US"/>
+              <a:t>when overflow occurs, it returns </a:t>
+            </a:r>
+            <a:r>
+              <a:rPr lang="en-US" b="1">
+                <a:latin typeface="Consolas" panose="020B0609020204030204" pitchFamily="49" charset="0"/>
+                <a:cs typeface="Consolas" panose="020B0609020204030204" pitchFamily="49" charset="0"/>
+              </a:rPr>
+              <a:t>nullptr</a:t>
+            </a:r>
+            <a:endParaRPr lang="en-US" b="1" dirty="0">
+              <a:latin typeface="Consolas" panose="020B0609020204030204" pitchFamily="49" charset="0"/>
+              <a:cs typeface="Consolas" panose="020B0609020204030204" pitchFamily="49" charset="0"/>
+            </a:endParaRPr>
+          </a:p>
+        </p:txBody>
+      </p:sp>
+      <p:sp>
+        <p:nvSpPr>
+          <p:cNvPr id="9" name="TextBox 8">
+            <a:extLst>
+              <a:ext uri="{FF2B5EF4-FFF2-40B4-BE49-F238E27FC236}">
+                <a16:creationId xmlns:a16="http://schemas.microsoft.com/office/drawing/2014/main" id="{395FF1DE-4BE1-66C7-50E7-F0472D26ECDE}"/>
+              </a:ext>
+            </a:extLst>
+          </p:cNvPr>
+          <p:cNvSpPr txBox="1"/>
+          <p:nvPr/>
+        </p:nvSpPr>
+        <p:spPr>
+          <a:xfrm>
+            <a:off x="2556164" y="5507182"/>
+            <a:ext cx="2060436" cy="369332"/>
+          </a:xfrm>
+          <a:prstGeom prst="rect">
+            <a:avLst/>
+          </a:prstGeom>
+          <a:noFill/>
+        </p:spPr>
+        <p:txBody>
+          <a:bodyPr wrap="none" rtlCol="0">
+            <a:spAutoFit/>
+          </a:bodyPr>
+          <a:lstStyle/>
+          <a:p>
+            <a:r>
+              <a:rPr lang="en-US" dirty="0"/>
+              <a:t>Device/Host buffer</a:t>
+            </a:r>
+          </a:p>
+        </p:txBody>
+      </p:sp>
+      <p:cxnSp>
+        <p:nvCxnSpPr>
+          <p:cNvPr id="11" name="Straight Arrow Connector 10">
+            <a:extLst>
+              <a:ext uri="{FF2B5EF4-FFF2-40B4-BE49-F238E27FC236}">
+                <a16:creationId xmlns:a16="http://schemas.microsoft.com/office/drawing/2014/main" id="{EC3B161E-9205-D5CA-37C3-474132DE88B9}"/>
+              </a:ext>
+            </a:extLst>
+          </p:cNvPr>
+          <p:cNvCxnSpPr/>
+          <p:nvPr/>
+        </p:nvCxnSpPr>
+        <p:spPr>
+          <a:xfrm>
+            <a:off x="3314700" y="4873336"/>
+            <a:ext cx="218209" cy="529937"/>
+          </a:xfrm>
+          <a:prstGeom prst="straightConnector1">
+            <a:avLst/>
+          </a:prstGeom>
+          <a:ln>
+            <a:tailEnd type="triangle"/>
+          </a:ln>
+        </p:spPr>
+        <p:style>
+          <a:lnRef idx="2">
+            <a:schemeClr val="accent1"/>
+          </a:lnRef>
+          <a:fillRef idx="0">
+            <a:schemeClr val="accent1"/>
+          </a:fillRef>
+          <a:effectRef idx="1">
+            <a:schemeClr val="accent1"/>
+          </a:effectRef>
+          <a:fontRef idx="minor">
+            <a:schemeClr val="tx1"/>
+          </a:fontRef>
+        </p:style>
+      </p:cxnSp>
+      <p:sp>
+        <p:nvSpPr>
+          <p:cNvPr id="12" name="TextBox 11">
+            <a:extLst>
+              <a:ext uri="{FF2B5EF4-FFF2-40B4-BE49-F238E27FC236}">
+                <a16:creationId xmlns:a16="http://schemas.microsoft.com/office/drawing/2014/main" id="{35934F10-8757-3CE4-7CC8-7484E5DED4A2}"/>
+              </a:ext>
+            </a:extLst>
+          </p:cNvPr>
+          <p:cNvSpPr txBox="1"/>
+          <p:nvPr/>
+        </p:nvSpPr>
+        <p:spPr>
+          <a:xfrm>
+            <a:off x="1485900" y="2940627"/>
+            <a:ext cx="1386855" cy="369332"/>
+          </a:xfrm>
+          <a:prstGeom prst="rect">
+            <a:avLst/>
+          </a:prstGeom>
+          <a:noFill/>
+        </p:spPr>
+        <p:txBody>
+          <a:bodyPr wrap="none" rtlCol="0">
+            <a:spAutoFit/>
+          </a:bodyPr>
+          <a:lstStyle/>
+          <a:p>
+            <a:r>
+              <a:rPr lang="en-US" dirty="0"/>
+              <a:t>System side</a:t>
+            </a:r>
+          </a:p>
+        </p:txBody>
+      </p:sp>
+      <p:sp>
+        <p:nvSpPr>
+          <p:cNvPr id="13" name="TextBox 12">
+            <a:extLst>
+              <a:ext uri="{FF2B5EF4-FFF2-40B4-BE49-F238E27FC236}">
+                <a16:creationId xmlns:a16="http://schemas.microsoft.com/office/drawing/2014/main" id="{9828E7C9-8762-E292-E163-E9FB046A616C}"/>
+              </a:ext>
+            </a:extLst>
+          </p:cNvPr>
+          <p:cNvSpPr txBox="1"/>
+          <p:nvPr/>
+        </p:nvSpPr>
+        <p:spPr>
+          <a:xfrm>
+            <a:off x="5659582" y="2925326"/>
+            <a:ext cx="1045479" cy="369332"/>
+          </a:xfrm>
+          <a:prstGeom prst="rect">
+            <a:avLst/>
+          </a:prstGeom>
+          <a:noFill/>
+        </p:spPr>
+        <p:txBody>
+          <a:bodyPr wrap="none" rtlCol="0">
+            <a:spAutoFit/>
+          </a:bodyPr>
+          <a:lstStyle/>
+          <a:p>
+            <a:r>
+              <a:rPr lang="en-US" dirty="0"/>
+              <a:t>App side</a:t>
+            </a:r>
+          </a:p>
+        </p:txBody>
+      </p:sp>
+    </p:spTree>
+    <p:extLst>
+      <p:ext uri="{BB962C8B-B14F-4D97-AF65-F5344CB8AC3E}">
+        <p14:creationId xmlns:p14="http://schemas.microsoft.com/office/powerpoint/2010/main" val="3779921726"/>
+      </p:ext>
+    </p:extLst>
+  </p:cSld>
+  <p:clrMapOvr>
+    <a:masterClrMapping/>
+  </p:clrMapOvr>
+</p:sld>
+</file>
+
+<file path=ppt/slides/slide14.xml><?xml version="1.0" encoding="utf-8"?>
+<p:sld xmlns:a="http://schemas.openxmlformats.org/drawingml/2006/main" xmlns:r="http://schemas.openxmlformats.org/officeDocument/2006/relationships" xmlns:p="http://schemas.openxmlformats.org/presentationml/2006/main">
+  <p:cSld>
+    <p:spTree>
+      <p:nvGrpSpPr>
+        <p:cNvPr id="1" name=""/>
+        <p:cNvGrpSpPr/>
+        <p:nvPr/>
+      </p:nvGrpSpPr>
+      <p:grpSpPr>
+        <a:xfrm>
+          <a:off x="0" y="0"/>
+          <a:ext cx="0" cy="0"/>
+          <a:chOff x="0" y="0"/>
+          <a:chExt cx="0" cy="0"/>
+        </a:xfrm>
+      </p:grpSpPr>
+      <p:sp>
+        <p:nvSpPr>
+          <p:cNvPr id="2" name="Title 1">
+            <a:extLst>
+              <a:ext uri="{FF2B5EF4-FFF2-40B4-BE49-F238E27FC236}">
+                <a16:creationId xmlns:a16="http://schemas.microsoft.com/office/drawing/2014/main" id="{30F612FE-A783-B001-47EB-C974AAAD00C7}"/>
+              </a:ext>
+            </a:extLst>
+          </p:cNvPr>
+          <p:cNvSpPr>
+            <a:spLocks noGrp="1"/>
+          </p:cNvSpPr>
+          <p:nvPr>
+            <p:ph type="title"/>
+          </p:nvPr>
+        </p:nvSpPr>
+        <p:spPr/>
+        <p:txBody>
+          <a:bodyPr/>
+          <a:lstStyle/>
+          <a:p>
+            <a:r>
+              <a:rPr lang="en-US"/>
+              <a:t>Why hybrid is slower than layered? (</a:t>
+            </a:r>
+            <a:r>
+              <a:rPr lang="en-US" dirty="0"/>
+              <a:t>SM)</a:t>
             </a:r>
           </a:p>
         </p:txBody>
@@ -5049,13 +5399,13 @@
             <p:ph idx="1"/>
             <p:extLst>
               <p:ext uri="{D42A27DB-BD31-4B8C-83A1-F6EECF244321}">
-                <p14:modId xmlns:p14="http://schemas.microsoft.com/office/powerpoint/2010/main" val="2113408363"/>
+                <p14:modId xmlns:p14="http://schemas.microsoft.com/office/powerpoint/2010/main" val="2868310211"/>
               </p:ext>
             </p:extLst>
           </p:nvPr>
         </p:nvGraphicFramePr>
         <p:xfrm>
-          <a:off x="838200" y="2700976"/>
+          <a:off x="838200" y="1900876"/>
           <a:ext cx="10515600" cy="526440"/>
         </p:xfrm>
         <a:graphic>
@@ -5118,12 +5468,1254 @@
                         <a:buNone/>
                       </a:pPr>
                       <a:r>
-                        <a:rPr lang="en-US" sz="1600" u="none" strike="noStrike">
+                        <a:rPr lang="en-US" sz="1600" u="none" strike="noStrike" dirty="0">
                           <a:effectLst/>
                         </a:rPr>
                         <a:t>dataset</a:t>
                       </a:r>
-                      <a:endParaRPr lang="en-US" sz="1600" b="1" i="0" u="none" strike="noStrike">
+                      <a:endParaRPr lang="en-US" sz="1600" b="1" i="0" u="none" strike="noStrike" dirty="0">
+                        <a:solidFill>
+                          <a:srgbClr val="FFFFFF"/>
+                        </a:solidFill>
+                        <a:effectLst/>
+                        <a:latin typeface="Aptos Narrow" panose="020B0004020202020204" pitchFamily="34" charset="0"/>
+                      </a:endParaRPr>
+                    </a:p>
+                  </a:txBody>
+                  <a:tcPr marL="7124" marR="7124" marT="7124" marB="0" anchor="b"/>
+                </a:tc>
+                <a:tc>
+                  <a:txBody>
+                    <a:bodyPr/>
+                    <a:lstStyle/>
+                    <a:p>
+                      <a:pPr algn="l" fontAlgn="b">
+                        <a:buNone/>
+                      </a:pPr>
+                      <a:r>
+                        <a:rPr lang="en-US" sz="1600" u="none" strike="noStrike" dirty="0">
+                          <a:effectLst/>
+                        </a:rPr>
+                        <a:t>query</a:t>
+                      </a:r>
+                      <a:endParaRPr lang="en-US" sz="1600" b="1" i="0" u="none" strike="noStrike" dirty="0">
+                        <a:solidFill>
+                          <a:srgbClr val="FFFFFF"/>
+                        </a:solidFill>
+                        <a:effectLst/>
+                        <a:latin typeface="Aptos Narrow" panose="020B0004020202020204" pitchFamily="34" charset="0"/>
+                      </a:endParaRPr>
+                    </a:p>
+                  </a:txBody>
+                  <a:tcPr marL="7124" marR="7124" marT="7124" marB="0" anchor="b"/>
+                </a:tc>
+                <a:tc>
+                  <a:txBody>
+                    <a:bodyPr/>
+                    <a:lstStyle/>
+                    <a:p>
+                      <a:pPr algn="l" fontAlgn="b">
+                        <a:buNone/>
+                      </a:pPr>
+                      <a:r>
+                        <a:rPr lang="en-US" sz="1600" u="none" strike="noStrike" dirty="0">
+                          <a:effectLst/>
+                        </a:rPr>
+                        <a:t>G2AIMD (</a:t>
+                      </a:r>
+                      <a:r>
+                        <a:rPr lang="en-US" sz="1600" u="none" strike="noStrike" dirty="0" err="1">
+                          <a:effectLst/>
+                        </a:rPr>
+                        <a:t>pingpong</a:t>
+                      </a:r>
+                      <a:r>
+                        <a:rPr lang="en-US" sz="1600" u="none" strike="noStrike" dirty="0">
+                          <a:effectLst/>
+                        </a:rPr>
+                        <a:t>)</a:t>
+                      </a:r>
+                      <a:endParaRPr lang="en-US" sz="1600" b="1" i="0" u="none" strike="noStrike" dirty="0">
+                        <a:solidFill>
+                          <a:srgbClr val="FFFFFF"/>
+                        </a:solidFill>
+                        <a:effectLst/>
+                        <a:latin typeface="Aptos Narrow" panose="020B0004020202020204" pitchFamily="34" charset="0"/>
+                      </a:endParaRPr>
+                    </a:p>
+                  </a:txBody>
+                  <a:tcPr marL="7124" marR="7124" marT="7124" marB="0" anchor="b"/>
+                </a:tc>
+                <a:tc>
+                  <a:txBody>
+                    <a:bodyPr/>
+                    <a:lstStyle/>
+                    <a:p>
+                      <a:pPr algn="l" fontAlgn="b">
+                        <a:buNone/>
+                      </a:pPr>
+                      <a:r>
+                        <a:rPr lang="en-US" sz="1600" u="none" strike="noStrike" dirty="0" err="1">
+                          <a:effectLst/>
+                        </a:rPr>
+                        <a:t>gpu</a:t>
+                      </a:r>
+                      <a:r>
+                        <a:rPr lang="en-US" sz="1600" u="none" strike="noStrike" dirty="0">
+                          <a:effectLst/>
+                        </a:rPr>
+                        <a:t>-layered</a:t>
+                      </a:r>
+                      <a:endParaRPr lang="en-US" sz="1600" b="1" i="0" u="none" strike="noStrike" dirty="0">
+                        <a:solidFill>
+                          <a:srgbClr val="FFFFFF"/>
+                        </a:solidFill>
+                        <a:effectLst/>
+                        <a:latin typeface="Aptos Narrow" panose="020B0004020202020204" pitchFamily="34" charset="0"/>
+                      </a:endParaRPr>
+                    </a:p>
+                  </a:txBody>
+                  <a:tcPr marL="7124" marR="7124" marT="7124" marB="0" anchor="b"/>
+                </a:tc>
+                <a:tc>
+                  <a:txBody>
+                    <a:bodyPr/>
+                    <a:lstStyle/>
+                    <a:p>
+                      <a:pPr algn="l" fontAlgn="b">
+                        <a:buNone/>
+                      </a:pPr>
+                      <a:r>
+                        <a:rPr lang="en-US" sz="1600" u="none" strike="noStrike" dirty="0" err="1">
+                          <a:solidFill>
+                            <a:srgbClr val="C00000"/>
+                          </a:solidFill>
+                          <a:effectLst/>
+                        </a:rPr>
+                        <a:t>gpu</a:t>
+                      </a:r>
+                      <a:r>
+                        <a:rPr lang="en-US" sz="1600" u="none" strike="noStrike" dirty="0">
+                          <a:solidFill>
+                            <a:srgbClr val="C00000"/>
+                          </a:solidFill>
+                          <a:effectLst/>
+                        </a:rPr>
+                        <a:t>-hybrid-drop</a:t>
+                      </a:r>
+                      <a:endParaRPr lang="en-US" sz="1600" b="1" i="0" u="none" strike="noStrike" dirty="0">
+                        <a:solidFill>
+                          <a:srgbClr val="C00000"/>
+                        </a:solidFill>
+                        <a:effectLst/>
+                        <a:latin typeface="Aptos Narrow" panose="020B0004020202020204" pitchFamily="34" charset="0"/>
+                      </a:endParaRPr>
+                    </a:p>
+                  </a:txBody>
+                  <a:tcPr marL="7124" marR="7124" marT="7124" marB="0" anchor="b"/>
+                </a:tc>
+                <a:tc>
+                  <a:txBody>
+                    <a:bodyPr/>
+                    <a:lstStyle/>
+                    <a:p>
+                      <a:pPr algn="l" fontAlgn="b">
+                        <a:buNone/>
+                      </a:pPr>
+                      <a:r>
+                        <a:rPr lang="en-US" sz="1600" u="none" strike="noStrike" dirty="0" err="1">
+                          <a:solidFill>
+                            <a:srgbClr val="C00000"/>
+                          </a:solidFill>
+                          <a:effectLst/>
+                        </a:rPr>
+                        <a:t>gpu</a:t>
+                      </a:r>
+                      <a:r>
+                        <a:rPr lang="en-US" sz="1600" u="none" strike="noStrike" dirty="0">
+                          <a:solidFill>
+                            <a:srgbClr val="C00000"/>
+                          </a:solidFill>
+                          <a:effectLst/>
+                        </a:rPr>
+                        <a:t>-hybrid-copy</a:t>
+                      </a:r>
+                      <a:endParaRPr lang="en-US" sz="1600" b="1" i="0" u="none" strike="noStrike" dirty="0">
+                        <a:solidFill>
+                          <a:srgbClr val="C00000"/>
+                        </a:solidFill>
+                        <a:effectLst/>
+                        <a:latin typeface="Aptos Narrow" panose="020B0004020202020204" pitchFamily="34" charset="0"/>
+                      </a:endParaRPr>
+                    </a:p>
+                  </a:txBody>
+                  <a:tcPr marL="7124" marR="7124" marT="7124" marB="0" anchor="b"/>
+                </a:tc>
+                <a:extLst>
+                  <a:ext uri="{0D108BD9-81ED-4DB2-BD59-A6C34878D82A}">
+                    <a16:rowId xmlns:a16="http://schemas.microsoft.com/office/drawing/2014/main" val="1927394708"/>
+                  </a:ext>
+                </a:extLst>
+              </a:tr>
+              <a:tr h="246979">
+                <a:tc>
+                  <a:txBody>
+                    <a:bodyPr/>
+                    <a:lstStyle/>
+                    <a:p>
+                      <a:pPr algn="l" fontAlgn="b">
+                        <a:buNone/>
+                      </a:pPr>
+                      <a:r>
+                        <a:rPr lang="en-US" sz="1600" u="none" strike="noStrike" dirty="0" err="1">
+                          <a:effectLst/>
+                        </a:rPr>
+                        <a:t>zhishi-baidu-internallink</a:t>
+                      </a:r>
+                      <a:endParaRPr lang="en-US" sz="1600" b="0" i="0" u="none" strike="noStrike" dirty="0">
+                        <a:solidFill>
+                          <a:srgbClr val="000000"/>
+                        </a:solidFill>
+                        <a:effectLst/>
+                        <a:latin typeface="Monaco" pitchFamily="2" charset="77"/>
+                      </a:endParaRPr>
+                    </a:p>
+                  </a:txBody>
+                  <a:tcPr marL="7124" marR="7124" marT="7124" marB="0" anchor="b"/>
+                </a:tc>
+                <a:tc>
+                  <a:txBody>
+                    <a:bodyPr/>
+                    <a:lstStyle/>
+                    <a:p>
+                      <a:pPr algn="ctr" fontAlgn="b">
+                        <a:buNone/>
+                      </a:pPr>
+                      <a:r>
+                        <a:rPr lang="en-US" sz="1600" u="none" strike="noStrike" dirty="0">
+                          <a:effectLst/>
+                        </a:rPr>
+                        <a:t>6</a:t>
+                      </a:r>
+                      <a:endParaRPr lang="en-US" sz="1600" b="0" i="0" u="none" strike="noStrike" dirty="0">
+                        <a:solidFill>
+                          <a:srgbClr val="000000"/>
+                        </a:solidFill>
+                        <a:effectLst/>
+                        <a:latin typeface="Monaco" pitchFamily="2" charset="77"/>
+                      </a:endParaRPr>
+                    </a:p>
+                  </a:txBody>
+                  <a:tcPr marL="7124" marR="7124" marT="7124" marB="0" anchor="b"/>
+                </a:tc>
+                <a:tc>
+                  <a:txBody>
+                    <a:bodyPr/>
+                    <a:lstStyle/>
+                    <a:p>
+                      <a:pPr algn="ctr" fontAlgn="b">
+                        <a:buNone/>
+                      </a:pPr>
+                      <a:r>
+                        <a:rPr lang="en-US" sz="1600" u="none" strike="noStrike" dirty="0">
+                          <a:effectLst/>
+                        </a:rPr>
+                        <a:t>42.4</a:t>
+                      </a:r>
+                      <a:endParaRPr lang="en-US" sz="1600" b="0" i="0" u="none" strike="noStrike" dirty="0">
+                        <a:solidFill>
+                          <a:srgbClr val="000000"/>
+                        </a:solidFill>
+                        <a:effectLst/>
+                        <a:latin typeface="Monaco" pitchFamily="2" charset="77"/>
+                      </a:endParaRPr>
+                    </a:p>
+                  </a:txBody>
+                  <a:tcPr marL="7124" marR="7124" marT="7124" marB="0" anchor="b"/>
+                </a:tc>
+                <a:tc>
+                  <a:txBody>
+                    <a:bodyPr/>
+                    <a:lstStyle/>
+                    <a:p>
+                      <a:pPr algn="ctr" fontAlgn="b">
+                        <a:buNone/>
+                      </a:pPr>
+                      <a:r>
+                        <a:rPr lang="en-US" sz="1600" u="none" strike="noStrike" dirty="0">
+                          <a:effectLst/>
+                        </a:rPr>
+                        <a:t>42.5</a:t>
+                      </a:r>
+                      <a:endParaRPr lang="en-US" sz="1600" b="0" i="0" u="none" strike="noStrike" dirty="0">
+                        <a:solidFill>
+                          <a:srgbClr val="000000"/>
+                        </a:solidFill>
+                        <a:effectLst/>
+                        <a:latin typeface="Monaco" pitchFamily="2" charset="77"/>
+                      </a:endParaRPr>
+                    </a:p>
+                  </a:txBody>
+                  <a:tcPr marL="7124" marR="7124" marT="7124" marB="0" anchor="b"/>
+                </a:tc>
+                <a:tc>
+                  <a:txBody>
+                    <a:bodyPr/>
+                    <a:lstStyle/>
+                    <a:p>
+                      <a:pPr algn="ctr" fontAlgn="b">
+                        <a:buNone/>
+                      </a:pPr>
+                      <a:r>
+                        <a:rPr lang="en-US" sz="1600" u="none" strike="noStrike" dirty="0">
+                          <a:solidFill>
+                            <a:srgbClr val="C00000"/>
+                          </a:solidFill>
+                          <a:effectLst/>
+                        </a:rPr>
+                        <a:t>558.7</a:t>
+                      </a:r>
+                      <a:endParaRPr lang="en-US" sz="1600" b="0" i="0" u="none" strike="noStrike" dirty="0">
+                        <a:solidFill>
+                          <a:srgbClr val="C00000"/>
+                        </a:solidFill>
+                        <a:effectLst/>
+                        <a:latin typeface="Monaco" pitchFamily="2" charset="77"/>
+                      </a:endParaRPr>
+                    </a:p>
+                  </a:txBody>
+                  <a:tcPr marL="7124" marR="7124" marT="7124" marB="0" anchor="b"/>
+                </a:tc>
+                <a:tc>
+                  <a:txBody>
+                    <a:bodyPr/>
+                    <a:lstStyle/>
+                    <a:p>
+                      <a:pPr algn="ctr" fontAlgn="b">
+                        <a:buNone/>
+                      </a:pPr>
+                      <a:r>
+                        <a:rPr lang="en-US" sz="1600" u="none" strike="noStrike" dirty="0">
+                          <a:solidFill>
+                            <a:srgbClr val="C00000"/>
+                          </a:solidFill>
+                          <a:effectLst/>
+                        </a:rPr>
+                        <a:t>507.6</a:t>
+                      </a:r>
+                      <a:endParaRPr lang="en-US" sz="1600" b="0" i="0" u="none" strike="noStrike" dirty="0">
+                        <a:solidFill>
+                          <a:srgbClr val="C00000"/>
+                        </a:solidFill>
+                        <a:effectLst/>
+                        <a:latin typeface="Monaco" pitchFamily="2" charset="77"/>
+                      </a:endParaRPr>
+                    </a:p>
+                  </a:txBody>
+                  <a:tcPr marL="7124" marR="7124" marT="7124" marB="0" anchor="b"/>
+                </a:tc>
+                <a:extLst>
+                  <a:ext uri="{0D108BD9-81ED-4DB2-BD59-A6C34878D82A}">
+                    <a16:rowId xmlns:a16="http://schemas.microsoft.com/office/drawing/2014/main" val="2305100746"/>
+                  </a:ext>
+                </a:extLst>
+              </a:tr>
+            </a:tbl>
+          </a:graphicData>
+        </a:graphic>
+      </p:graphicFrame>
+      <p:graphicFrame>
+        <p:nvGraphicFramePr>
+          <p:cNvPr id="6" name="Table 5">
+            <a:extLst>
+              <a:ext uri="{FF2B5EF4-FFF2-40B4-BE49-F238E27FC236}">
+                <a16:creationId xmlns:a16="http://schemas.microsoft.com/office/drawing/2014/main" id="{57FCEF90-6001-61FD-248D-4F9005122A57}"/>
+              </a:ext>
+            </a:extLst>
+          </p:cNvPr>
+          <p:cNvGraphicFramePr>
+            <a:graphicFrameLocks noGrp="1"/>
+          </p:cNvGraphicFramePr>
+          <p:nvPr>
+            <p:extLst>
+              <p:ext uri="{D42A27DB-BD31-4B8C-83A1-F6EECF244321}">
+                <p14:modId xmlns:p14="http://schemas.microsoft.com/office/powerpoint/2010/main" val="844391383"/>
+              </p:ext>
+            </p:extLst>
+          </p:nvPr>
+        </p:nvGraphicFramePr>
+        <p:xfrm>
+          <a:off x="568038" y="3291201"/>
+          <a:ext cx="5527965" cy="1752600"/>
+        </p:xfrm>
+        <a:graphic>
+          <a:graphicData uri="http://schemas.openxmlformats.org/drawingml/2006/table">
+            <a:tbl>
+              <a:tblPr>
+                <a:tableStyleId>{5C22544A-7EE6-4342-B048-85BDC9FD1C3A}</a:tableStyleId>
+              </a:tblPr>
+              <a:tblGrid>
+                <a:gridCol w="1842655">
+                  <a:extLst>
+                    <a:ext uri="{9D8B030D-6E8A-4147-A177-3AD203B41FA5}">
+                      <a16:colId xmlns:a16="http://schemas.microsoft.com/office/drawing/2014/main" val="4023161429"/>
+                    </a:ext>
+                  </a:extLst>
+                </a:gridCol>
+                <a:gridCol w="1842655">
+                  <a:extLst>
+                    <a:ext uri="{9D8B030D-6E8A-4147-A177-3AD203B41FA5}">
+                      <a16:colId xmlns:a16="http://schemas.microsoft.com/office/drawing/2014/main" val="1027886083"/>
+                    </a:ext>
+                  </a:extLst>
+                </a:gridCol>
+                <a:gridCol w="1842655">
+                  <a:extLst>
+                    <a:ext uri="{9D8B030D-6E8A-4147-A177-3AD203B41FA5}">
+                      <a16:colId xmlns:a16="http://schemas.microsoft.com/office/drawing/2014/main" val="2854186224"/>
+                    </a:ext>
+                  </a:extLst>
+                </a:gridCol>
+              </a:tblGrid>
+              <a:tr h="292100">
+                <a:tc>
+                  <a:txBody>
+                    <a:bodyPr/>
+                    <a:lstStyle/>
+                    <a:p>
+                      <a:pPr algn="ctr" fontAlgn="b">
+                        <a:buNone/>
+                      </a:pPr>
+                      <a:r>
+                        <a:rPr lang="en-US" sz="1600" u="none" strike="noStrike" dirty="0" err="1">
+                          <a:effectLst/>
+                        </a:rPr>
+                        <a:t>gpu</a:t>
+                      </a:r>
+                      <a:r>
+                        <a:rPr lang="en-US" sz="1600" u="none" strike="noStrike" dirty="0">
+                          <a:effectLst/>
+                        </a:rPr>
+                        <a:t>-layered</a:t>
+                      </a:r>
+                      <a:endParaRPr lang="en-US" sz="1600" b="1" i="0" u="none" strike="noStrike" dirty="0">
+                        <a:solidFill>
+                          <a:srgbClr val="FFFFFF"/>
+                        </a:solidFill>
+                        <a:effectLst/>
+                        <a:latin typeface="Aptos Narrow" panose="020B0004020202020204" pitchFamily="34" charset="0"/>
+                      </a:endParaRPr>
+                    </a:p>
+                  </a:txBody>
+                  <a:tcPr marL="7124" marR="7124" marT="7124" marB="0" anchor="b"/>
+                </a:tc>
+                <a:tc>
+                  <a:txBody>
+                    <a:bodyPr/>
+                    <a:lstStyle/>
+                    <a:p>
+                      <a:pPr algn="ctr" fontAlgn="b">
+                        <a:buNone/>
+                      </a:pPr>
+                      <a:r>
+                        <a:rPr lang="en-US" sz="1600" u="none" strike="noStrike" dirty="0" err="1">
+                          <a:solidFill>
+                            <a:schemeClr val="tx1"/>
+                          </a:solidFill>
+                          <a:effectLst/>
+                        </a:rPr>
+                        <a:t>gpu</a:t>
+                      </a:r>
+                      <a:r>
+                        <a:rPr lang="en-US" sz="1600" u="none" strike="noStrike" dirty="0">
+                          <a:solidFill>
+                            <a:schemeClr val="tx1"/>
+                          </a:solidFill>
+                          <a:effectLst/>
+                        </a:rPr>
+                        <a:t>-hybrid-drop</a:t>
+                      </a:r>
+                      <a:endParaRPr lang="en-US" sz="1600" b="1" i="0" u="none" strike="noStrike" dirty="0">
+                        <a:solidFill>
+                          <a:schemeClr val="tx1"/>
+                        </a:solidFill>
+                        <a:effectLst/>
+                        <a:latin typeface="Aptos Narrow" panose="020B0004020202020204" pitchFamily="34" charset="0"/>
+                      </a:endParaRPr>
+                    </a:p>
+                  </a:txBody>
+                  <a:tcPr marL="7124" marR="7124" marT="7124" marB="0" anchor="b"/>
+                </a:tc>
+                <a:tc>
+                  <a:txBody>
+                    <a:bodyPr/>
+                    <a:lstStyle/>
+                    <a:p>
+                      <a:pPr algn="ctr" fontAlgn="b">
+                        <a:buNone/>
+                      </a:pPr>
+                      <a:r>
+                        <a:rPr lang="en-US" sz="1600" u="none" strike="noStrike" dirty="0" err="1">
+                          <a:solidFill>
+                            <a:schemeClr val="tx1"/>
+                          </a:solidFill>
+                          <a:effectLst/>
+                        </a:rPr>
+                        <a:t>gpu</a:t>
+                      </a:r>
+                      <a:r>
+                        <a:rPr lang="en-US" sz="1600" u="none" strike="noStrike" dirty="0">
+                          <a:solidFill>
+                            <a:schemeClr val="tx1"/>
+                          </a:solidFill>
+                          <a:effectLst/>
+                        </a:rPr>
+                        <a:t>-hybrid-copy</a:t>
+                      </a:r>
+                      <a:endParaRPr lang="en-US" sz="1600" b="1" i="0" u="none" strike="noStrike" dirty="0">
+                        <a:solidFill>
+                          <a:schemeClr val="tx1"/>
+                        </a:solidFill>
+                        <a:effectLst/>
+                        <a:latin typeface="Aptos Narrow" panose="020B0004020202020204" pitchFamily="34" charset="0"/>
+                      </a:endParaRPr>
+                    </a:p>
+                  </a:txBody>
+                  <a:tcPr marL="7124" marR="7124" marT="7124" marB="0" anchor="b"/>
+                </a:tc>
+                <a:extLst>
+                  <a:ext uri="{0D108BD9-81ED-4DB2-BD59-A6C34878D82A}">
+                    <a16:rowId xmlns:a16="http://schemas.microsoft.com/office/drawing/2014/main" val="964431789"/>
+                  </a:ext>
+                </a:extLst>
+              </a:tr>
+              <a:tr h="292100">
+                <a:tc>
+                  <a:txBody>
+                    <a:bodyPr/>
+                    <a:lstStyle/>
+                    <a:p>
+                      <a:pPr algn="ctr" fontAlgn="b">
+                        <a:buNone/>
+                      </a:pPr>
+                      <a:r>
+                        <a:rPr lang="en-US" sz="1600" u="none" strike="noStrike" dirty="0">
+                          <a:effectLst/>
+                        </a:rPr>
+                        <a:t>331.9</a:t>
+                      </a:r>
+                      <a:endParaRPr lang="en-US" sz="1600" b="0" i="0" u="none" strike="noStrike" dirty="0">
+                        <a:solidFill>
+                          <a:srgbClr val="000000"/>
+                        </a:solidFill>
+                        <a:effectLst/>
+                        <a:latin typeface="Monaco" pitchFamily="2" charset="77"/>
+                      </a:endParaRPr>
+                    </a:p>
+                  </a:txBody>
+                  <a:tcPr marL="0" marR="0" marT="0" marB="0" anchor="b"/>
+                </a:tc>
+                <a:tc>
+                  <a:txBody>
+                    <a:bodyPr/>
+                    <a:lstStyle/>
+                    <a:p>
+                      <a:pPr algn="ctr" fontAlgn="b">
+                        <a:buNone/>
+                      </a:pPr>
+                      <a:r>
+                        <a:rPr lang="en-US" sz="1600" u="none" strike="noStrike" dirty="0">
+                          <a:effectLst/>
+                        </a:rPr>
+                        <a:t>281.0</a:t>
+                      </a:r>
+                      <a:endParaRPr lang="en-US" sz="1600" b="0" i="0" u="none" strike="noStrike" dirty="0">
+                        <a:solidFill>
+                          <a:srgbClr val="000000"/>
+                        </a:solidFill>
+                        <a:effectLst/>
+                        <a:latin typeface="Monaco" pitchFamily="2" charset="77"/>
+                      </a:endParaRPr>
+                    </a:p>
+                  </a:txBody>
+                  <a:tcPr marL="0" marR="0" marT="0" marB="0" anchor="b"/>
+                </a:tc>
+                <a:tc>
+                  <a:txBody>
+                    <a:bodyPr/>
+                    <a:lstStyle/>
+                    <a:p>
+                      <a:pPr algn="ctr" fontAlgn="b">
+                        <a:buNone/>
+                      </a:pPr>
+                      <a:r>
+                        <a:rPr lang="en-US" sz="1600" u="none" strike="noStrike" dirty="0">
+                          <a:effectLst/>
+                        </a:rPr>
+                        <a:t>183.09</a:t>
+                      </a:r>
+                      <a:endParaRPr lang="en-US" sz="1600" b="0" i="0" u="none" strike="noStrike" dirty="0">
+                        <a:solidFill>
+                          <a:srgbClr val="000000"/>
+                        </a:solidFill>
+                        <a:effectLst/>
+                        <a:latin typeface="Monaco" pitchFamily="2" charset="77"/>
+                      </a:endParaRPr>
+                    </a:p>
+                  </a:txBody>
+                  <a:tcPr marL="0" marR="0" marT="0" marB="0" anchor="b"/>
+                </a:tc>
+                <a:extLst>
+                  <a:ext uri="{0D108BD9-81ED-4DB2-BD59-A6C34878D82A}">
+                    <a16:rowId xmlns:a16="http://schemas.microsoft.com/office/drawing/2014/main" val="1579266394"/>
+                  </a:ext>
+                </a:extLst>
+              </a:tr>
+              <a:tr h="292100">
+                <a:tc>
+                  <a:txBody>
+                    <a:bodyPr/>
+                    <a:lstStyle/>
+                    <a:p>
+                      <a:pPr algn="ctr" fontAlgn="b">
+                        <a:buNone/>
+                      </a:pPr>
+                      <a:r>
+                        <a:rPr lang="en-US" sz="1600" u="none" strike="noStrike" dirty="0">
+                          <a:effectLst/>
+                        </a:rPr>
+                        <a:t>234.4</a:t>
+                      </a:r>
+                      <a:endParaRPr lang="en-US" sz="1600" b="0" i="0" u="none" strike="noStrike" dirty="0">
+                        <a:solidFill>
+                          <a:srgbClr val="000000"/>
+                        </a:solidFill>
+                        <a:effectLst/>
+                        <a:latin typeface="Monaco" pitchFamily="2" charset="77"/>
+                      </a:endParaRPr>
+                    </a:p>
+                  </a:txBody>
+                  <a:tcPr marL="0" marR="0" marT="0" marB="0" anchor="b"/>
+                </a:tc>
+                <a:tc>
+                  <a:txBody>
+                    <a:bodyPr/>
+                    <a:lstStyle/>
+                    <a:p>
+                      <a:pPr algn="ctr" fontAlgn="b">
+                        <a:buNone/>
+                      </a:pPr>
+                      <a:r>
+                        <a:rPr lang="en-US" sz="1600" u="none" strike="noStrike" dirty="0">
+                          <a:effectLst/>
+                        </a:rPr>
+                        <a:t>175.6</a:t>
+                      </a:r>
+                      <a:endParaRPr lang="en-US" sz="1600" b="0" i="0" u="none" strike="noStrike" dirty="0">
+                        <a:solidFill>
+                          <a:srgbClr val="000000"/>
+                        </a:solidFill>
+                        <a:effectLst/>
+                        <a:latin typeface="Monaco" pitchFamily="2" charset="77"/>
+                      </a:endParaRPr>
+                    </a:p>
+                  </a:txBody>
+                  <a:tcPr marL="0" marR="0" marT="0" marB="0" anchor="b"/>
+                </a:tc>
+                <a:tc>
+                  <a:txBody>
+                    <a:bodyPr/>
+                    <a:lstStyle/>
+                    <a:p>
+                      <a:pPr algn="ctr" fontAlgn="b">
+                        <a:buNone/>
+                      </a:pPr>
+                      <a:r>
+                        <a:rPr lang="en-US" sz="1600" u="none" strike="noStrike" dirty="0">
+                          <a:effectLst/>
+                        </a:rPr>
+                        <a:t>479.54</a:t>
+                      </a:r>
+                      <a:endParaRPr lang="en-US" sz="1600" b="0" i="0" u="none" strike="noStrike" dirty="0">
+                        <a:solidFill>
+                          <a:srgbClr val="000000"/>
+                        </a:solidFill>
+                        <a:effectLst/>
+                        <a:latin typeface="Monaco" pitchFamily="2" charset="77"/>
+                      </a:endParaRPr>
+                    </a:p>
+                  </a:txBody>
+                  <a:tcPr marL="0" marR="0" marT="0" marB="0" anchor="b"/>
+                </a:tc>
+                <a:extLst>
+                  <a:ext uri="{0D108BD9-81ED-4DB2-BD59-A6C34878D82A}">
+                    <a16:rowId xmlns:a16="http://schemas.microsoft.com/office/drawing/2014/main" val="310646299"/>
+                  </a:ext>
+                </a:extLst>
+              </a:tr>
+              <a:tr h="292100">
+                <a:tc>
+                  <a:txBody>
+                    <a:bodyPr/>
+                    <a:lstStyle/>
+                    <a:p>
+                      <a:pPr algn="ctr" fontAlgn="b">
+                        <a:buNone/>
+                      </a:pPr>
+                      <a:r>
+                        <a:rPr lang="en-US" sz="1600" u="none" strike="noStrike" dirty="0">
+                          <a:effectLst/>
+                        </a:rPr>
+                        <a:t>149.7</a:t>
+                      </a:r>
+                      <a:endParaRPr lang="en-US" sz="1600" b="0" i="0" u="none" strike="noStrike" dirty="0">
+                        <a:solidFill>
+                          <a:srgbClr val="000000"/>
+                        </a:solidFill>
+                        <a:effectLst/>
+                        <a:latin typeface="Monaco" pitchFamily="2" charset="77"/>
+                      </a:endParaRPr>
+                    </a:p>
+                  </a:txBody>
+                  <a:tcPr marL="0" marR="0" marT="0" marB="0" anchor="b"/>
+                </a:tc>
+                <a:tc>
+                  <a:txBody>
+                    <a:bodyPr/>
+                    <a:lstStyle/>
+                    <a:p>
+                      <a:pPr algn="ctr" fontAlgn="b">
+                        <a:buNone/>
+                      </a:pPr>
+                      <a:r>
+                        <a:rPr lang="en-US" sz="1600" u="none" strike="noStrike" dirty="0">
+                          <a:effectLst/>
+                        </a:rPr>
+                        <a:t>429.7</a:t>
+                      </a:r>
+                      <a:endParaRPr lang="en-US" sz="1600" b="0" i="0" u="none" strike="noStrike" dirty="0">
+                        <a:solidFill>
+                          <a:srgbClr val="000000"/>
+                        </a:solidFill>
+                        <a:effectLst/>
+                        <a:latin typeface="Monaco" pitchFamily="2" charset="77"/>
+                      </a:endParaRPr>
+                    </a:p>
+                  </a:txBody>
+                  <a:tcPr marL="0" marR="0" marT="0" marB="0" anchor="b"/>
+                </a:tc>
+                <a:tc>
+                  <a:txBody>
+                    <a:bodyPr/>
+                    <a:lstStyle/>
+                    <a:p>
+                      <a:pPr algn="ctr" fontAlgn="b">
+                        <a:buNone/>
+                      </a:pPr>
+                      <a:r>
+                        <a:rPr lang="en-US" sz="1600" u="none" strike="noStrike" dirty="0">
+                          <a:effectLst/>
+                        </a:rPr>
+                        <a:t>180.02</a:t>
+                      </a:r>
+                      <a:endParaRPr lang="en-US" sz="1600" b="0" i="0" u="none" strike="noStrike" dirty="0">
+                        <a:solidFill>
+                          <a:srgbClr val="000000"/>
+                        </a:solidFill>
+                        <a:effectLst/>
+                        <a:latin typeface="Monaco" pitchFamily="2" charset="77"/>
+                      </a:endParaRPr>
+                    </a:p>
+                  </a:txBody>
+                  <a:tcPr marL="0" marR="0" marT="0" marB="0" anchor="b"/>
+                </a:tc>
+                <a:extLst>
+                  <a:ext uri="{0D108BD9-81ED-4DB2-BD59-A6C34878D82A}">
+                    <a16:rowId xmlns:a16="http://schemas.microsoft.com/office/drawing/2014/main" val="183417123"/>
+                  </a:ext>
+                </a:extLst>
+              </a:tr>
+              <a:tr h="292100">
+                <a:tc>
+                  <a:txBody>
+                    <a:bodyPr/>
+                    <a:lstStyle/>
+                    <a:p>
+                      <a:pPr algn="ctr" fontAlgn="b">
+                        <a:buNone/>
+                      </a:pPr>
+                      <a:r>
+                        <a:rPr lang="en-US" sz="1600" b="1" u="none" strike="noStrike" dirty="0">
+                          <a:effectLst/>
+                        </a:rPr>
+                        <a:t>42.4*</a:t>
+                      </a:r>
+                      <a:endParaRPr lang="en-US" sz="1600" b="1" i="0" u="none" strike="noStrike" dirty="0">
+                        <a:solidFill>
+                          <a:srgbClr val="000000"/>
+                        </a:solidFill>
+                        <a:effectLst/>
+                        <a:latin typeface="Monaco" pitchFamily="2" charset="77"/>
+                      </a:endParaRPr>
+                    </a:p>
+                  </a:txBody>
+                  <a:tcPr marL="0" marR="0" marT="0" marB="0" anchor="b"/>
+                </a:tc>
+                <a:tc>
+                  <a:txBody>
+                    <a:bodyPr/>
+                    <a:lstStyle/>
+                    <a:p>
+                      <a:pPr algn="ctr" fontAlgn="b">
+                        <a:buNone/>
+                      </a:pPr>
+                      <a:r>
+                        <a:rPr lang="en-US" sz="1600" u="none" strike="noStrike" dirty="0">
+                          <a:effectLst/>
+                        </a:rPr>
+                        <a:t>177.5</a:t>
+                      </a:r>
+                      <a:endParaRPr lang="en-US" sz="1600" b="0" i="0" u="none" strike="noStrike" dirty="0">
+                        <a:solidFill>
+                          <a:srgbClr val="000000"/>
+                        </a:solidFill>
+                        <a:effectLst/>
+                        <a:latin typeface="Monaco" pitchFamily="2" charset="77"/>
+                      </a:endParaRPr>
+                    </a:p>
+                  </a:txBody>
+                  <a:tcPr marL="0" marR="0" marT="0" marB="0" anchor="b"/>
+                </a:tc>
+                <a:tc>
+                  <a:txBody>
+                    <a:bodyPr/>
+                    <a:lstStyle/>
+                    <a:p>
+                      <a:pPr algn="ctr" fontAlgn="b">
+                        <a:buNone/>
+                      </a:pPr>
+                      <a:r>
+                        <a:rPr lang="en-US" sz="1600" u="none" strike="noStrike" dirty="0">
+                          <a:effectLst/>
+                        </a:rPr>
+                        <a:t>182.85</a:t>
+                      </a:r>
+                      <a:endParaRPr lang="en-US" sz="1600" b="0" i="0" u="none" strike="noStrike" dirty="0">
+                        <a:solidFill>
+                          <a:srgbClr val="000000"/>
+                        </a:solidFill>
+                        <a:effectLst/>
+                        <a:latin typeface="Monaco" pitchFamily="2" charset="77"/>
+                      </a:endParaRPr>
+                    </a:p>
+                  </a:txBody>
+                  <a:tcPr marL="0" marR="0" marT="0" marB="0" anchor="b"/>
+                </a:tc>
+                <a:extLst>
+                  <a:ext uri="{0D108BD9-81ED-4DB2-BD59-A6C34878D82A}">
+                    <a16:rowId xmlns:a16="http://schemas.microsoft.com/office/drawing/2014/main" val="814087310"/>
+                  </a:ext>
+                </a:extLst>
+              </a:tr>
+              <a:tr h="292100">
+                <a:tc>
+                  <a:txBody>
+                    <a:bodyPr/>
+                    <a:lstStyle/>
+                    <a:p>
+                      <a:pPr algn="ctr" fontAlgn="b">
+                        <a:buNone/>
+                      </a:pPr>
+                      <a:r>
+                        <a:rPr lang="en-US" sz="1600" u="none" strike="noStrike" dirty="0">
+                          <a:effectLst/>
+                        </a:rPr>
+                        <a:t>191.6</a:t>
+                      </a:r>
+                      <a:endParaRPr lang="en-US" sz="1600" b="0" i="0" u="none" strike="noStrike" dirty="0">
+                        <a:solidFill>
+                          <a:srgbClr val="000000"/>
+                        </a:solidFill>
+                        <a:effectLst/>
+                        <a:latin typeface="Monaco" pitchFamily="2" charset="77"/>
+                      </a:endParaRPr>
+                    </a:p>
+                  </a:txBody>
+                  <a:tcPr marL="0" marR="0" marT="0" marB="0" anchor="b"/>
+                </a:tc>
+                <a:tc>
+                  <a:txBody>
+                    <a:bodyPr/>
+                    <a:lstStyle/>
+                    <a:p>
+                      <a:pPr algn="ctr" fontAlgn="b">
+                        <a:buNone/>
+                      </a:pPr>
+                      <a:r>
+                        <a:rPr lang="en-US" sz="1600" b="1" u="none" strike="noStrike" dirty="0">
+                          <a:effectLst/>
+                        </a:rPr>
+                        <a:t>41.6*</a:t>
+                      </a:r>
+                      <a:endParaRPr lang="en-US" sz="1600" b="1" i="0" u="none" strike="noStrike" dirty="0">
+                        <a:solidFill>
+                          <a:srgbClr val="000000"/>
+                        </a:solidFill>
+                        <a:effectLst/>
+                        <a:latin typeface="Monaco" pitchFamily="2" charset="77"/>
+                      </a:endParaRPr>
+                    </a:p>
+                  </a:txBody>
+                  <a:tcPr marL="0" marR="0" marT="0" marB="0" anchor="b"/>
+                </a:tc>
+                <a:tc>
+                  <a:txBody>
+                    <a:bodyPr/>
+                    <a:lstStyle/>
+                    <a:p>
+                      <a:pPr algn="ctr" fontAlgn="b">
+                        <a:buNone/>
+                      </a:pPr>
+                      <a:r>
+                        <a:rPr lang="en-US" sz="1600" u="none" strike="noStrike" dirty="0">
+                          <a:effectLst/>
+                        </a:rPr>
+                        <a:t>476.47</a:t>
+                      </a:r>
+                      <a:endParaRPr lang="en-US" sz="1600" b="0" i="0" u="none" strike="noStrike" dirty="0">
+                        <a:solidFill>
+                          <a:srgbClr val="000000"/>
+                        </a:solidFill>
+                        <a:effectLst/>
+                        <a:latin typeface="Monaco" pitchFamily="2" charset="77"/>
+                      </a:endParaRPr>
+                    </a:p>
+                  </a:txBody>
+                  <a:tcPr marL="0" marR="0" marT="0" marB="0" anchor="b"/>
+                </a:tc>
+                <a:extLst>
+                  <a:ext uri="{0D108BD9-81ED-4DB2-BD59-A6C34878D82A}">
+                    <a16:rowId xmlns:a16="http://schemas.microsoft.com/office/drawing/2014/main" val="1467335156"/>
+                  </a:ext>
+                </a:extLst>
+              </a:tr>
+            </a:tbl>
+          </a:graphicData>
+        </a:graphic>
+      </p:graphicFrame>
+      <p:sp>
+        <p:nvSpPr>
+          <p:cNvPr id="7" name="TextBox 6">
+            <a:extLst>
+              <a:ext uri="{FF2B5EF4-FFF2-40B4-BE49-F238E27FC236}">
+                <a16:creationId xmlns:a16="http://schemas.microsoft.com/office/drawing/2014/main" id="{5C3F4191-D22A-D3C5-EF9F-30E752B27629}"/>
+              </a:ext>
+            </a:extLst>
+          </p:cNvPr>
+          <p:cNvSpPr txBox="1"/>
+          <p:nvPr/>
+        </p:nvSpPr>
+        <p:spPr>
+          <a:xfrm>
+            <a:off x="2469574" y="2921869"/>
+            <a:ext cx="1507400" cy="369332"/>
+          </a:xfrm>
+          <a:prstGeom prst="rect">
+            <a:avLst/>
+          </a:prstGeom>
+          <a:noFill/>
+        </p:spPr>
+        <p:txBody>
+          <a:bodyPr wrap="none" rtlCol="0">
+            <a:spAutoFit/>
+          </a:bodyPr>
+          <a:lstStyle/>
+          <a:p>
+            <a:r>
+              <a:rPr lang="en-US" b="1" dirty="0"/>
+              <a:t>5 executions</a:t>
+            </a:r>
+          </a:p>
+        </p:txBody>
+      </p:sp>
+      <p:sp>
+        <p:nvSpPr>
+          <p:cNvPr id="9" name="TextBox 8">
+            <a:extLst>
+              <a:ext uri="{FF2B5EF4-FFF2-40B4-BE49-F238E27FC236}">
+                <a16:creationId xmlns:a16="http://schemas.microsoft.com/office/drawing/2014/main" id="{F953B5A9-DF3D-53CF-A3B9-B621C35D24CF}"/>
+              </a:ext>
+            </a:extLst>
+          </p:cNvPr>
+          <p:cNvSpPr txBox="1"/>
+          <p:nvPr/>
+        </p:nvSpPr>
+        <p:spPr>
+          <a:xfrm>
+            <a:off x="1714500" y="5538355"/>
+            <a:ext cx="2818977" cy="369332"/>
+          </a:xfrm>
+          <a:prstGeom prst="rect">
+            <a:avLst/>
+          </a:prstGeom>
+          <a:noFill/>
+        </p:spPr>
+        <p:txBody>
+          <a:bodyPr wrap="none" rtlCol="0">
+            <a:spAutoFit/>
+          </a:bodyPr>
+          <a:lstStyle/>
+          <a:p>
+            <a:r>
+              <a:rPr lang="en-US" b="1" dirty="0"/>
+              <a:t>* Did not overflow to host</a:t>
+            </a:r>
+          </a:p>
+        </p:txBody>
+      </p:sp>
+      <p:sp>
+        <p:nvSpPr>
+          <p:cNvPr id="11" name="TextBox 10">
+            <a:extLst>
+              <a:ext uri="{FF2B5EF4-FFF2-40B4-BE49-F238E27FC236}">
+                <a16:creationId xmlns:a16="http://schemas.microsoft.com/office/drawing/2014/main" id="{410B255E-E163-B8EB-5D6D-DD441EED9F78}"/>
+              </a:ext>
+            </a:extLst>
+          </p:cNvPr>
+          <p:cNvSpPr txBox="1"/>
+          <p:nvPr/>
+        </p:nvSpPr>
+        <p:spPr>
+          <a:xfrm>
+            <a:off x="7031182" y="3705836"/>
+            <a:ext cx="4502727" cy="1754326"/>
+          </a:xfrm>
+          <a:prstGeom prst="rect">
+            <a:avLst/>
+          </a:prstGeom>
+          <a:noFill/>
+        </p:spPr>
+        <p:txBody>
+          <a:bodyPr wrap="square">
+            <a:spAutoFit/>
+          </a:bodyPr>
+          <a:lstStyle/>
+          <a:p>
+            <a:r>
+              <a:rPr lang="en-US" b="1" dirty="0" err="1"/>
+              <a:t>gpu</a:t>
+            </a:r>
+            <a:r>
+              <a:rPr lang="en-US" b="1" dirty="0"/>
+              <a:t>-hybrid-copy summary:</a:t>
+            </a:r>
+            <a:endParaRPr lang="en-US" b="1" dirty="0">
+              <a:latin typeface="Aptos Narrow" panose="020B0004020202020204" pitchFamily="34" charset="0"/>
+            </a:endParaRPr>
+          </a:p>
+          <a:p>
+            <a:endParaRPr lang="en-US" dirty="0"/>
+          </a:p>
+          <a:p>
+            <a:r>
+              <a:rPr lang="en-US" dirty="0"/>
+              <a:t>Total time (s): 181.56</a:t>
+            </a:r>
+          </a:p>
+          <a:p>
+            <a:r>
+              <a:rPr lang="en-US" dirty="0"/>
+              <a:t>at switch </a:t>
+            </a:r>
+            <a:r>
+              <a:rPr lang="en-US" dirty="0" err="1"/>
+              <a:t>dump_to_host</a:t>
+            </a:r>
+            <a:r>
+              <a:rPr lang="en-US" dirty="0"/>
+              <a:t> time (s): 3.44</a:t>
+            </a:r>
+          </a:p>
+          <a:p>
+            <a:r>
+              <a:rPr lang="en-US" dirty="0"/>
+              <a:t>other </a:t>
+            </a:r>
+            <a:r>
+              <a:rPr lang="en-US" dirty="0" err="1"/>
+              <a:t>dump_to_host</a:t>
+            </a:r>
+            <a:r>
+              <a:rPr lang="en-US" dirty="0"/>
+              <a:t> time (s): 24.86</a:t>
+            </a:r>
+          </a:p>
+          <a:p>
+            <a:r>
+              <a:rPr lang="en-US" dirty="0" err="1"/>
+              <a:t>load_from_host</a:t>
+            </a:r>
+            <a:r>
+              <a:rPr lang="en-US" dirty="0"/>
+              <a:t> time (s): 31.78</a:t>
+            </a:r>
+          </a:p>
+        </p:txBody>
+      </p:sp>
+    </p:spTree>
+    <p:extLst>
+      <p:ext uri="{BB962C8B-B14F-4D97-AF65-F5344CB8AC3E}">
+        <p14:creationId xmlns:p14="http://schemas.microsoft.com/office/powerpoint/2010/main" val="698545430"/>
+      </p:ext>
+    </p:extLst>
+  </p:cSld>
+  <p:clrMapOvr>
+    <a:masterClrMapping/>
+  </p:clrMapOvr>
+</p:sld>
+</file>
+
+<file path=ppt/slides/slide15.xml><?xml version="1.0" encoding="utf-8"?>
+<p:sld xmlns:a="http://schemas.openxmlformats.org/drawingml/2006/main" xmlns:r="http://schemas.openxmlformats.org/officeDocument/2006/relationships" xmlns:p="http://schemas.openxmlformats.org/presentationml/2006/main">
+  <p:cSld>
+    <p:spTree>
+      <p:nvGrpSpPr>
+        <p:cNvPr id="1" name="">
+          <a:extLst>
+            <a:ext uri="{FF2B5EF4-FFF2-40B4-BE49-F238E27FC236}">
+              <a16:creationId xmlns:a16="http://schemas.microsoft.com/office/drawing/2014/main" id="{3895BEF8-7CFE-8D4A-07BD-F542601BA21D}"/>
+            </a:ext>
+          </a:extLst>
+        </p:cNvPr>
+        <p:cNvGrpSpPr/>
+        <p:nvPr/>
+      </p:nvGrpSpPr>
+      <p:grpSpPr>
+        <a:xfrm>
+          <a:off x="0" y="0"/>
+          <a:ext cx="0" cy="0"/>
+          <a:chOff x="0" y="0"/>
+          <a:chExt cx="0" cy="0"/>
+        </a:xfrm>
+      </p:grpSpPr>
+      <p:sp>
+        <p:nvSpPr>
+          <p:cNvPr id="2" name="Title 1">
+            <a:extLst>
+              <a:ext uri="{FF2B5EF4-FFF2-40B4-BE49-F238E27FC236}">
+                <a16:creationId xmlns:a16="http://schemas.microsoft.com/office/drawing/2014/main" id="{E7DE7B21-17B3-0962-472F-BE6388D2E106}"/>
+              </a:ext>
+            </a:extLst>
+          </p:cNvPr>
+          <p:cNvSpPr>
+            <a:spLocks noGrp="1"/>
+          </p:cNvSpPr>
+          <p:nvPr>
+            <p:ph type="title"/>
+          </p:nvPr>
+        </p:nvSpPr>
+        <p:spPr/>
+        <p:txBody>
+          <a:bodyPr/>
+          <a:lstStyle/>
+          <a:p>
+            <a:r>
+              <a:rPr lang="en-US"/>
+              <a:t>Why hybrid is slower than layered? (</a:t>
+            </a:r>
+            <a:r>
+              <a:rPr lang="en-US" dirty="0"/>
+              <a:t>SM)</a:t>
+            </a:r>
+          </a:p>
+        </p:txBody>
+      </p:sp>
+      <p:graphicFrame>
+        <p:nvGraphicFramePr>
+          <p:cNvPr id="4" name="Content Placeholder 3">
+            <a:extLst>
+              <a:ext uri="{FF2B5EF4-FFF2-40B4-BE49-F238E27FC236}">
+                <a16:creationId xmlns:a16="http://schemas.microsoft.com/office/drawing/2014/main" id="{FF9DD2AD-416D-F32C-3937-4B189D3C7952}"/>
+              </a:ext>
+            </a:extLst>
+          </p:cNvPr>
+          <p:cNvGraphicFramePr>
+            <a:graphicFrameLocks noGrp="1"/>
+          </p:cNvGraphicFramePr>
+          <p:nvPr>
+            <p:ph idx="1"/>
+          </p:nvPr>
+        </p:nvGraphicFramePr>
+        <p:xfrm>
+          <a:off x="838200" y="1900876"/>
+          <a:ext cx="10515600" cy="526440"/>
+        </p:xfrm>
+        <a:graphic>
+          <a:graphicData uri="http://schemas.openxmlformats.org/drawingml/2006/table">
+            <a:tbl>
+              <a:tblPr>
+                <a:tableStyleId>{073A0DAA-6AF3-43AB-8588-CEC1D06C72B9}</a:tableStyleId>
+              </a:tblPr>
+              <a:tblGrid>
+                <a:gridCol w="2916250">
+                  <a:extLst>
+                    <a:ext uri="{9D8B030D-6E8A-4147-A177-3AD203B41FA5}">
+                      <a16:colId xmlns:a16="http://schemas.microsoft.com/office/drawing/2014/main" val="1046455315"/>
+                    </a:ext>
+                  </a:extLst>
+                </a:gridCol>
+                <a:gridCol w="838332">
+                  <a:extLst>
+                    <a:ext uri="{9D8B030D-6E8A-4147-A177-3AD203B41FA5}">
+                      <a16:colId xmlns:a16="http://schemas.microsoft.com/office/drawing/2014/main" val="1687158871"/>
+                    </a:ext>
+                  </a:extLst>
+                </a:gridCol>
+                <a:gridCol w="2201408">
+                  <a:extLst>
+                    <a:ext uri="{9D8B030D-6E8A-4147-A177-3AD203B41FA5}">
+                      <a16:colId xmlns:a16="http://schemas.microsoft.com/office/drawing/2014/main" val="263035580"/>
+                    </a:ext>
+                  </a:extLst>
+                </a:gridCol>
+                <a:gridCol w="1227592">
+                  <a:extLst>
+                    <a:ext uri="{9D8B030D-6E8A-4147-A177-3AD203B41FA5}">
+                      <a16:colId xmlns:a16="http://schemas.microsoft.com/office/drawing/2014/main" val="4056306273"/>
+                    </a:ext>
+                  </a:extLst>
+                </a:gridCol>
+                <a:gridCol w="1812148">
+                  <a:extLst>
+                    <a:ext uri="{9D8B030D-6E8A-4147-A177-3AD203B41FA5}">
+                      <a16:colId xmlns:a16="http://schemas.microsoft.com/office/drawing/2014/main" val="329124393"/>
+                    </a:ext>
+                  </a:extLst>
+                </a:gridCol>
+                <a:gridCol w="1519870">
+                  <a:extLst>
+                    <a:ext uri="{9D8B030D-6E8A-4147-A177-3AD203B41FA5}">
+                      <a16:colId xmlns:a16="http://schemas.microsoft.com/office/drawing/2014/main" val="2603204388"/>
+                    </a:ext>
+                  </a:extLst>
+                </a:gridCol>
+              </a:tblGrid>
+              <a:tr h="275476">
+                <a:tc>
+                  <a:txBody>
+                    <a:bodyPr/>
+                    <a:lstStyle/>
+                    <a:p>
+                      <a:pPr algn="l" fontAlgn="b">
+                        <a:buNone/>
+                      </a:pPr>
+                      <a:r>
+                        <a:rPr lang="en-US" sz="1600" u="none" strike="noStrike" dirty="0">
+                          <a:effectLst/>
+                        </a:rPr>
+                        <a:t>dataset</a:t>
+                      </a:r>
+                      <a:endParaRPr lang="en-US" sz="1600" b="1" i="0" u="none" strike="noStrike" dirty="0">
                         <a:solidFill>
                           <a:srgbClr val="FFFFFF"/>
                         </a:solidFill>
@@ -5171,9 +6763,21 @@
                         <a:rPr lang="en-US" sz="1600" u="none" strike="noStrike">
                           <a:effectLst/>
                         </a:rPr>
-                        <a:t>G2AIMD (pingpong)</a:t>
+                        <a:t>G2AIMD (</a:t>
                       </a:r>
-                      <a:endParaRPr lang="en-US" sz="1600" b="1" i="0" u="none" strike="noStrike">
+                      <a:r>
+                        <a:rPr lang="en-US" sz="1600" u="none" strike="noStrike" dirty="0" err="1">
+                          <a:effectLst/>
+                        </a:rPr>
+                        <a:t>pingpong</a:t>
+                      </a:r>
+                      <a:r>
+                        <a:rPr lang="en-US" sz="1600" u="none" strike="noStrike" dirty="0">
+                          <a:effectLst/>
+                        </a:rPr>
+                        <a:t>)</a:t>
+                      </a:r>
+                      <a:endParaRPr lang="en-US" sz="1600" b="1" i="0" u="none" strike="noStrike" dirty="0">
                         <a:solidFill>
                           <a:srgbClr val="FFFFFF"/>
                         </a:solidFill>
@@ -5464,10 +7068,148 @@
       </p:graphicFrame>
       <p:sp>
         <p:nvSpPr>
-          <p:cNvPr id="5" name="TextBox 4">
-            <a:extLst>
-              <a:ext uri="{FF2B5EF4-FFF2-40B4-BE49-F238E27FC236}">
-                <a16:creationId xmlns:a16="http://schemas.microsoft.com/office/drawing/2014/main" id="{8BB84B85-9C29-14C3-9295-F96DCFB2D293}"/>
+          <p:cNvPr id="3" name="Rectangle 2">
+            <a:extLst>
+              <a:ext uri="{FF2B5EF4-FFF2-40B4-BE49-F238E27FC236}">
+                <a16:creationId xmlns:a16="http://schemas.microsoft.com/office/drawing/2014/main" id="{B963D685-554F-5083-27AA-BCFDFC43A3D4}"/>
+              </a:ext>
+            </a:extLst>
+          </p:cNvPr>
+          <p:cNvSpPr/>
+          <p:nvPr/>
+        </p:nvSpPr>
+        <p:spPr>
+          <a:xfrm>
+            <a:off x="1239537" y="3546333"/>
+            <a:ext cx="3688772" cy="369331"/>
+          </a:xfrm>
+          <a:prstGeom prst="rect">
+            <a:avLst/>
+          </a:prstGeom>
+        </p:spPr>
+        <p:style>
+          <a:lnRef idx="2">
+            <a:schemeClr val="dk1"/>
+          </a:lnRef>
+          <a:fillRef idx="1">
+            <a:schemeClr val="lt1"/>
+          </a:fillRef>
+          <a:effectRef idx="0">
+            <a:schemeClr val="dk1"/>
+          </a:effectRef>
+          <a:fontRef idx="minor">
+            <a:schemeClr val="dk1"/>
+          </a:fontRef>
+        </p:style>
+        <p:txBody>
+          <a:bodyPr rtlCol="0" anchor="ctr"/>
+          <a:lstStyle/>
+          <a:p>
+            <a:pPr algn="ctr"/>
+            <a:endParaRPr lang="en-US"/>
+          </a:p>
+        </p:txBody>
+      </p:sp>
+      <p:sp>
+        <p:nvSpPr>
+          <p:cNvPr id="5" name="Rectangle 4">
+            <a:extLst>
+              <a:ext uri="{FF2B5EF4-FFF2-40B4-BE49-F238E27FC236}">
+                <a16:creationId xmlns:a16="http://schemas.microsoft.com/office/drawing/2014/main" id="{AB724227-A814-D618-0507-C5D96FD2B3E3}"/>
+              </a:ext>
+            </a:extLst>
+          </p:cNvPr>
+          <p:cNvSpPr/>
+          <p:nvPr/>
+        </p:nvSpPr>
+        <p:spPr>
+          <a:xfrm>
+            <a:off x="1769474" y="3637480"/>
+            <a:ext cx="507660" cy="192684"/>
+          </a:xfrm>
+          <a:prstGeom prst="rect">
+            <a:avLst/>
+          </a:prstGeom>
+          <a:solidFill>
+            <a:schemeClr val="accent1"/>
+          </a:solidFill>
+        </p:spPr>
+        <p:style>
+          <a:lnRef idx="2">
+            <a:schemeClr val="dk1"/>
+          </a:lnRef>
+          <a:fillRef idx="1">
+            <a:schemeClr val="lt1"/>
+          </a:fillRef>
+          <a:effectRef idx="0">
+            <a:schemeClr val="dk1"/>
+          </a:effectRef>
+          <a:fontRef idx="minor">
+            <a:schemeClr val="dk1"/>
+          </a:fontRef>
+        </p:style>
+        <p:txBody>
+          <a:bodyPr rtlCol="0" anchor="ctr"/>
+          <a:lstStyle/>
+          <a:p>
+            <a:pPr algn="ctr"/>
+            <a:endParaRPr lang="en-US"/>
+          </a:p>
+        </p:txBody>
+      </p:sp>
+      <p:sp>
+        <p:nvSpPr>
+          <p:cNvPr id="8" name="Rectangle 7">
+            <a:extLst>
+              <a:ext uri="{FF2B5EF4-FFF2-40B4-BE49-F238E27FC236}">
+                <a16:creationId xmlns:a16="http://schemas.microsoft.com/office/drawing/2014/main" id="{3B58A93F-2524-B9DA-454F-89C0186D36C4}"/>
+              </a:ext>
+            </a:extLst>
+          </p:cNvPr>
+          <p:cNvSpPr/>
+          <p:nvPr/>
+        </p:nvSpPr>
+        <p:spPr>
+          <a:xfrm>
+            <a:off x="3733357" y="3643128"/>
+            <a:ext cx="474992" cy="187036"/>
+          </a:xfrm>
+          <a:prstGeom prst="rect">
+            <a:avLst/>
+          </a:prstGeom>
+          <a:solidFill>
+            <a:schemeClr val="accent1"/>
+          </a:solidFill>
+        </p:spPr>
+        <p:style>
+          <a:lnRef idx="2">
+            <a:schemeClr val="dk1"/>
+          </a:lnRef>
+          <a:fillRef idx="1">
+            <a:schemeClr val="lt1"/>
+          </a:fillRef>
+          <a:effectRef idx="0">
+            <a:schemeClr val="dk1"/>
+          </a:effectRef>
+          <a:fontRef idx="minor">
+            <a:schemeClr val="dk1"/>
+          </a:fontRef>
+        </p:style>
+        <p:txBody>
+          <a:bodyPr rtlCol="0" anchor="ctr"/>
+          <a:lstStyle/>
+          <a:p>
+            <a:pPr algn="ctr"/>
+            <a:endParaRPr lang="en-US"/>
+          </a:p>
+        </p:txBody>
+      </p:sp>
+      <p:sp>
+        <p:nvSpPr>
+          <p:cNvPr id="9" name="TextBox 8">
+            <a:extLst>
+              <a:ext uri="{FF2B5EF4-FFF2-40B4-BE49-F238E27FC236}">
+                <a16:creationId xmlns:a16="http://schemas.microsoft.com/office/drawing/2014/main" id="{4EFA0C88-9263-A67B-F9E0-5D8BE0D21B02}"/>
               </a:ext>
             </a:extLst>
           </p:cNvPr>
@@ -5476,8 +7218,8 @@
         </p:nvSpPr>
         <p:spPr>
           <a:xfrm>
-            <a:off x="1091046" y="3910553"/>
-            <a:ext cx="7720446" cy="646331"/>
+            <a:off x="250467" y="3166356"/>
+            <a:ext cx="749629" cy="369332"/>
           </a:xfrm>
           <a:prstGeom prst="rect">
             <a:avLst/>
@@ -5485,6 +7227,821 @@
           <a:noFill/>
         </p:spPr>
         <p:txBody>
+          <a:bodyPr wrap="none" rtlCol="0">
+            <a:spAutoFit/>
+          </a:bodyPr>
+          <a:lstStyle/>
+          <a:p>
+            <a:r>
+              <a:rPr lang="en-US" dirty="0"/>
+              <a:t>level </a:t>
+            </a:r>
+            <a:r>
+              <a:rPr lang="en-US" dirty="0" err="1"/>
+              <a:t>i</a:t>
+            </a:r>
+            <a:endParaRPr lang="en-US" dirty="0"/>
+          </a:p>
+        </p:txBody>
+      </p:sp>
+      <p:sp>
+        <p:nvSpPr>
+          <p:cNvPr id="10" name="Rectangle 9">
+            <a:extLst>
+              <a:ext uri="{FF2B5EF4-FFF2-40B4-BE49-F238E27FC236}">
+                <a16:creationId xmlns:a16="http://schemas.microsoft.com/office/drawing/2014/main" id="{0BB8EB49-67E0-4193-A247-07DBFD2B6542}"/>
+              </a:ext>
+            </a:extLst>
+          </p:cNvPr>
+          <p:cNvSpPr/>
+          <p:nvPr/>
+        </p:nvSpPr>
+        <p:spPr>
+          <a:xfrm>
+            <a:off x="1239537" y="4568799"/>
+            <a:ext cx="3688772" cy="369331"/>
+          </a:xfrm>
+          <a:prstGeom prst="rect">
+            <a:avLst/>
+          </a:prstGeom>
+        </p:spPr>
+        <p:style>
+          <a:lnRef idx="2">
+            <a:schemeClr val="dk1"/>
+          </a:lnRef>
+          <a:fillRef idx="1">
+            <a:schemeClr val="lt1"/>
+          </a:fillRef>
+          <a:effectRef idx="0">
+            <a:schemeClr val="dk1"/>
+          </a:effectRef>
+          <a:fontRef idx="minor">
+            <a:schemeClr val="dk1"/>
+          </a:fontRef>
+        </p:style>
+        <p:txBody>
+          <a:bodyPr rtlCol="0" anchor="ctr"/>
+          <a:lstStyle/>
+          <a:p>
+            <a:pPr algn="ctr"/>
+            <a:endParaRPr lang="en-US"/>
+          </a:p>
+        </p:txBody>
+      </p:sp>
+      <p:sp>
+        <p:nvSpPr>
+          <p:cNvPr id="13" name="TextBox 12">
+            <a:extLst>
+              <a:ext uri="{FF2B5EF4-FFF2-40B4-BE49-F238E27FC236}">
+                <a16:creationId xmlns:a16="http://schemas.microsoft.com/office/drawing/2014/main" id="{DBEEAC42-33B4-0AD8-26C2-89339F812096}"/>
+              </a:ext>
+            </a:extLst>
+          </p:cNvPr>
+          <p:cNvSpPr txBox="1"/>
+          <p:nvPr/>
+        </p:nvSpPr>
+        <p:spPr>
+          <a:xfrm>
+            <a:off x="184658" y="4360808"/>
+            <a:ext cx="996491" cy="369332"/>
+          </a:xfrm>
+          <a:prstGeom prst="rect">
+            <a:avLst/>
+          </a:prstGeom>
+          <a:noFill/>
+        </p:spPr>
+        <p:txBody>
+          <a:bodyPr wrap="none" rtlCol="0">
+            <a:spAutoFit/>
+          </a:bodyPr>
+          <a:lstStyle/>
+          <a:p>
+            <a:r>
+              <a:rPr lang="en-US" dirty="0"/>
+              <a:t>level i+1</a:t>
+            </a:r>
+          </a:p>
+        </p:txBody>
+      </p:sp>
+      <p:cxnSp>
+        <p:nvCxnSpPr>
+          <p:cNvPr id="15" name="Straight Connector 14">
+            <a:extLst>
+              <a:ext uri="{FF2B5EF4-FFF2-40B4-BE49-F238E27FC236}">
+                <a16:creationId xmlns:a16="http://schemas.microsoft.com/office/drawing/2014/main" id="{4472F976-D9C5-900C-295F-A8A09B99C333}"/>
+              </a:ext>
+            </a:extLst>
+          </p:cNvPr>
+          <p:cNvCxnSpPr>
+            <a:cxnSpLocks/>
+          </p:cNvCxnSpPr>
+          <p:nvPr/>
+        </p:nvCxnSpPr>
+        <p:spPr>
+          <a:xfrm>
+            <a:off x="3087633" y="3416901"/>
+            <a:ext cx="0" cy="681029"/>
+          </a:xfrm>
+          <a:prstGeom prst="line">
+            <a:avLst/>
+          </a:prstGeom>
+          <a:ln>
+            <a:prstDash val="dash"/>
+          </a:ln>
+        </p:spPr>
+        <p:style>
+          <a:lnRef idx="2">
+            <a:schemeClr val="accent1"/>
+          </a:lnRef>
+          <a:fillRef idx="0">
+            <a:schemeClr val="accent1"/>
+          </a:fillRef>
+          <a:effectRef idx="1">
+            <a:schemeClr val="accent1"/>
+          </a:effectRef>
+          <a:fontRef idx="minor">
+            <a:schemeClr val="tx1"/>
+          </a:fontRef>
+        </p:style>
+      </p:cxnSp>
+      <p:sp>
+        <p:nvSpPr>
+          <p:cNvPr id="17" name="TextBox 16">
+            <a:extLst>
+              <a:ext uri="{FF2B5EF4-FFF2-40B4-BE49-F238E27FC236}">
+                <a16:creationId xmlns:a16="http://schemas.microsoft.com/office/drawing/2014/main" id="{8BC24FDA-23F5-3179-C619-D559EFD84644}"/>
+              </a:ext>
+            </a:extLst>
+          </p:cNvPr>
+          <p:cNvSpPr txBox="1"/>
+          <p:nvPr/>
+        </p:nvSpPr>
+        <p:spPr>
+          <a:xfrm>
+            <a:off x="2831738" y="3099816"/>
+            <a:ext cx="504369" cy="369332"/>
+          </a:xfrm>
+          <a:prstGeom prst="rect">
+            <a:avLst/>
+          </a:prstGeom>
+          <a:noFill/>
+        </p:spPr>
+        <p:txBody>
+          <a:bodyPr wrap="none" rtlCol="0">
+            <a:spAutoFit/>
+          </a:bodyPr>
+          <a:lstStyle/>
+          <a:p>
+            <a:r>
+              <a:rPr lang="en-US" dirty="0"/>
+              <a:t>eta</a:t>
+            </a:r>
+          </a:p>
+        </p:txBody>
+      </p:sp>
+      <p:sp>
+        <p:nvSpPr>
+          <p:cNvPr id="29" name="Rectangle 28">
+            <a:extLst>
+              <a:ext uri="{FF2B5EF4-FFF2-40B4-BE49-F238E27FC236}">
+                <a16:creationId xmlns:a16="http://schemas.microsoft.com/office/drawing/2014/main" id="{54AF1626-445B-6904-AD56-56F4982218C4}"/>
+              </a:ext>
+            </a:extLst>
+          </p:cNvPr>
+          <p:cNvSpPr/>
+          <p:nvPr/>
+        </p:nvSpPr>
+        <p:spPr>
+          <a:xfrm>
+            <a:off x="7665028" y="3462544"/>
+            <a:ext cx="3688772" cy="369331"/>
+          </a:xfrm>
+          <a:prstGeom prst="rect">
+            <a:avLst/>
+          </a:prstGeom>
+        </p:spPr>
+        <p:style>
+          <a:lnRef idx="2">
+            <a:schemeClr val="dk1"/>
+          </a:lnRef>
+          <a:fillRef idx="1">
+            <a:schemeClr val="lt1"/>
+          </a:fillRef>
+          <a:effectRef idx="0">
+            <a:schemeClr val="dk1"/>
+          </a:effectRef>
+          <a:fontRef idx="minor">
+            <a:schemeClr val="dk1"/>
+          </a:fontRef>
+        </p:style>
+        <p:txBody>
+          <a:bodyPr rtlCol="0" anchor="ctr"/>
+          <a:lstStyle/>
+          <a:p>
+            <a:pPr algn="ctr"/>
+            <a:endParaRPr lang="en-US"/>
+          </a:p>
+        </p:txBody>
+      </p:sp>
+      <p:sp>
+        <p:nvSpPr>
+          <p:cNvPr id="30" name="Rectangle 29">
+            <a:extLst>
+              <a:ext uri="{FF2B5EF4-FFF2-40B4-BE49-F238E27FC236}">
+                <a16:creationId xmlns:a16="http://schemas.microsoft.com/office/drawing/2014/main" id="{037DC134-4846-C19E-3F45-17B96B58AC46}"/>
+              </a:ext>
+            </a:extLst>
+          </p:cNvPr>
+          <p:cNvSpPr/>
+          <p:nvPr/>
+        </p:nvSpPr>
+        <p:spPr>
+          <a:xfrm>
+            <a:off x="8194965" y="3553691"/>
+            <a:ext cx="507660" cy="192684"/>
+          </a:xfrm>
+          <a:prstGeom prst="rect">
+            <a:avLst/>
+          </a:prstGeom>
+          <a:solidFill>
+            <a:schemeClr val="accent1"/>
+          </a:solidFill>
+        </p:spPr>
+        <p:style>
+          <a:lnRef idx="2">
+            <a:schemeClr val="dk1"/>
+          </a:lnRef>
+          <a:fillRef idx="1">
+            <a:schemeClr val="lt1"/>
+          </a:fillRef>
+          <a:effectRef idx="0">
+            <a:schemeClr val="dk1"/>
+          </a:effectRef>
+          <a:fontRef idx="minor">
+            <a:schemeClr val="dk1"/>
+          </a:fontRef>
+        </p:style>
+        <p:txBody>
+          <a:bodyPr rtlCol="0" anchor="ctr"/>
+          <a:lstStyle/>
+          <a:p>
+            <a:pPr algn="ctr"/>
+            <a:endParaRPr lang="en-US"/>
+          </a:p>
+        </p:txBody>
+      </p:sp>
+      <p:sp>
+        <p:nvSpPr>
+          <p:cNvPr id="31" name="Rectangle 30">
+            <a:extLst>
+              <a:ext uri="{FF2B5EF4-FFF2-40B4-BE49-F238E27FC236}">
+                <a16:creationId xmlns:a16="http://schemas.microsoft.com/office/drawing/2014/main" id="{D0F8857A-CFB8-CC19-B6CC-19043ED96654}"/>
+              </a:ext>
+            </a:extLst>
+          </p:cNvPr>
+          <p:cNvSpPr/>
+          <p:nvPr/>
+        </p:nvSpPr>
+        <p:spPr>
+          <a:xfrm>
+            <a:off x="8805823" y="3554744"/>
+            <a:ext cx="474992" cy="187036"/>
+          </a:xfrm>
+          <a:prstGeom prst="rect">
+            <a:avLst/>
+          </a:prstGeom>
+          <a:solidFill>
+            <a:schemeClr val="accent1"/>
+          </a:solidFill>
+        </p:spPr>
+        <p:style>
+          <a:lnRef idx="2">
+            <a:schemeClr val="dk1"/>
+          </a:lnRef>
+          <a:fillRef idx="1">
+            <a:schemeClr val="lt1"/>
+          </a:fillRef>
+          <a:effectRef idx="0">
+            <a:schemeClr val="dk1"/>
+          </a:effectRef>
+          <a:fontRef idx="minor">
+            <a:schemeClr val="dk1"/>
+          </a:fontRef>
+        </p:style>
+        <p:txBody>
+          <a:bodyPr rtlCol="0" anchor="ctr"/>
+          <a:lstStyle/>
+          <a:p>
+            <a:pPr algn="ctr"/>
+            <a:endParaRPr lang="en-US"/>
+          </a:p>
+        </p:txBody>
+      </p:sp>
+      <p:sp>
+        <p:nvSpPr>
+          <p:cNvPr id="32" name="TextBox 31">
+            <a:extLst>
+              <a:ext uri="{FF2B5EF4-FFF2-40B4-BE49-F238E27FC236}">
+                <a16:creationId xmlns:a16="http://schemas.microsoft.com/office/drawing/2014/main" id="{7EED57B5-E32C-36EA-6A99-301B401718C3}"/>
+              </a:ext>
+            </a:extLst>
+          </p:cNvPr>
+          <p:cNvSpPr txBox="1"/>
+          <p:nvPr/>
+        </p:nvSpPr>
+        <p:spPr>
+          <a:xfrm>
+            <a:off x="6675958" y="3082567"/>
+            <a:ext cx="749629" cy="369332"/>
+          </a:xfrm>
+          <a:prstGeom prst="rect">
+            <a:avLst/>
+          </a:prstGeom>
+          <a:noFill/>
+        </p:spPr>
+        <p:txBody>
+          <a:bodyPr wrap="none" rtlCol="0">
+            <a:spAutoFit/>
+          </a:bodyPr>
+          <a:lstStyle/>
+          <a:p>
+            <a:r>
+              <a:rPr lang="en-US" dirty="0"/>
+              <a:t>level </a:t>
+            </a:r>
+            <a:r>
+              <a:rPr lang="en-US" dirty="0" err="1"/>
+              <a:t>i</a:t>
+            </a:r>
+            <a:endParaRPr lang="en-US" dirty="0"/>
+          </a:p>
+        </p:txBody>
+      </p:sp>
+      <p:sp>
+        <p:nvSpPr>
+          <p:cNvPr id="33" name="Rectangle 32">
+            <a:extLst>
+              <a:ext uri="{FF2B5EF4-FFF2-40B4-BE49-F238E27FC236}">
+                <a16:creationId xmlns:a16="http://schemas.microsoft.com/office/drawing/2014/main" id="{D13A147D-63D4-4B9F-812B-4ED61C736254}"/>
+              </a:ext>
+            </a:extLst>
+          </p:cNvPr>
+          <p:cNvSpPr/>
+          <p:nvPr/>
+        </p:nvSpPr>
+        <p:spPr>
+          <a:xfrm>
+            <a:off x="7665028" y="4485010"/>
+            <a:ext cx="3688772" cy="369331"/>
+          </a:xfrm>
+          <a:prstGeom prst="rect">
+            <a:avLst/>
+          </a:prstGeom>
+        </p:spPr>
+        <p:style>
+          <a:lnRef idx="2">
+            <a:schemeClr val="dk1"/>
+          </a:lnRef>
+          <a:fillRef idx="1">
+            <a:schemeClr val="lt1"/>
+          </a:fillRef>
+          <a:effectRef idx="0">
+            <a:schemeClr val="dk1"/>
+          </a:effectRef>
+          <a:fontRef idx="minor">
+            <a:schemeClr val="dk1"/>
+          </a:fontRef>
+        </p:style>
+        <p:txBody>
+          <a:bodyPr rtlCol="0" anchor="ctr"/>
+          <a:lstStyle/>
+          <a:p>
+            <a:pPr algn="ctr"/>
+            <a:endParaRPr lang="en-US" dirty="0"/>
+          </a:p>
+        </p:txBody>
+      </p:sp>
+      <p:sp>
+        <p:nvSpPr>
+          <p:cNvPr id="34" name="TextBox 33">
+            <a:extLst>
+              <a:ext uri="{FF2B5EF4-FFF2-40B4-BE49-F238E27FC236}">
+                <a16:creationId xmlns:a16="http://schemas.microsoft.com/office/drawing/2014/main" id="{800C058B-0396-82B4-4508-45A4039593FA}"/>
+              </a:ext>
+            </a:extLst>
+          </p:cNvPr>
+          <p:cNvSpPr txBox="1"/>
+          <p:nvPr/>
+        </p:nvSpPr>
+        <p:spPr>
+          <a:xfrm>
+            <a:off x="6610149" y="4277019"/>
+            <a:ext cx="996491" cy="369332"/>
+          </a:xfrm>
+          <a:prstGeom prst="rect">
+            <a:avLst/>
+          </a:prstGeom>
+          <a:noFill/>
+        </p:spPr>
+        <p:txBody>
+          <a:bodyPr wrap="none" rtlCol="0">
+            <a:spAutoFit/>
+          </a:bodyPr>
+          <a:lstStyle/>
+          <a:p>
+            <a:r>
+              <a:rPr lang="en-US" dirty="0"/>
+              <a:t>level i+1</a:t>
+            </a:r>
+          </a:p>
+        </p:txBody>
+      </p:sp>
+      <p:cxnSp>
+        <p:nvCxnSpPr>
+          <p:cNvPr id="35" name="Straight Connector 34">
+            <a:extLst>
+              <a:ext uri="{FF2B5EF4-FFF2-40B4-BE49-F238E27FC236}">
+                <a16:creationId xmlns:a16="http://schemas.microsoft.com/office/drawing/2014/main" id="{6066618D-9A64-FF92-3E61-78A9CF30E0F3}"/>
+              </a:ext>
+            </a:extLst>
+          </p:cNvPr>
+          <p:cNvCxnSpPr>
+            <a:cxnSpLocks/>
+          </p:cNvCxnSpPr>
+          <p:nvPr/>
+        </p:nvCxnSpPr>
+        <p:spPr>
+          <a:xfrm>
+            <a:off x="9513124" y="3333112"/>
+            <a:ext cx="0" cy="681029"/>
+          </a:xfrm>
+          <a:prstGeom prst="line">
+            <a:avLst/>
+          </a:prstGeom>
+          <a:ln>
+            <a:prstDash val="dash"/>
+          </a:ln>
+        </p:spPr>
+        <p:style>
+          <a:lnRef idx="2">
+            <a:schemeClr val="accent1"/>
+          </a:lnRef>
+          <a:fillRef idx="0">
+            <a:schemeClr val="accent1"/>
+          </a:fillRef>
+          <a:effectRef idx="1">
+            <a:schemeClr val="accent1"/>
+          </a:effectRef>
+          <a:fontRef idx="minor">
+            <a:schemeClr val="tx1"/>
+          </a:fontRef>
+        </p:style>
+      </p:cxnSp>
+      <p:sp>
+        <p:nvSpPr>
+          <p:cNvPr id="36" name="TextBox 35">
+            <a:extLst>
+              <a:ext uri="{FF2B5EF4-FFF2-40B4-BE49-F238E27FC236}">
+                <a16:creationId xmlns:a16="http://schemas.microsoft.com/office/drawing/2014/main" id="{3E3FAC43-2749-D1F9-82CD-BD337CEB35F6}"/>
+              </a:ext>
+            </a:extLst>
+          </p:cNvPr>
+          <p:cNvSpPr txBox="1"/>
+          <p:nvPr/>
+        </p:nvSpPr>
+        <p:spPr>
+          <a:xfrm>
+            <a:off x="9257229" y="3016027"/>
+            <a:ext cx="504369" cy="369332"/>
+          </a:xfrm>
+          <a:prstGeom prst="rect">
+            <a:avLst/>
+          </a:prstGeom>
+          <a:noFill/>
+        </p:spPr>
+        <p:txBody>
+          <a:bodyPr wrap="none" rtlCol="0">
+            <a:spAutoFit/>
+          </a:bodyPr>
+          <a:lstStyle/>
+          <a:p>
+            <a:r>
+              <a:rPr lang="en-US" dirty="0"/>
+              <a:t>eta</a:t>
+            </a:r>
+          </a:p>
+        </p:txBody>
+      </p:sp>
+      <p:sp>
+        <p:nvSpPr>
+          <p:cNvPr id="39" name="TextBox 38">
+            <a:extLst>
+              <a:ext uri="{FF2B5EF4-FFF2-40B4-BE49-F238E27FC236}">
+                <a16:creationId xmlns:a16="http://schemas.microsoft.com/office/drawing/2014/main" id="{6539E560-8E6D-891F-8F31-D4488203EAEF}"/>
+              </a:ext>
+            </a:extLst>
+          </p:cNvPr>
+          <p:cNvSpPr txBox="1"/>
+          <p:nvPr/>
+        </p:nvSpPr>
+        <p:spPr>
+          <a:xfrm>
+            <a:off x="1569244" y="2778175"/>
+            <a:ext cx="3029355" cy="369332"/>
+          </a:xfrm>
+          <a:prstGeom prst="rect">
+            <a:avLst/>
+          </a:prstGeom>
+          <a:noFill/>
+        </p:spPr>
+        <p:txBody>
+          <a:bodyPr wrap="none" rtlCol="0">
+            <a:spAutoFit/>
+          </a:bodyPr>
+          <a:lstStyle/>
+          <a:p>
+            <a:r>
+              <a:rPr lang="en-US" b="1" dirty="0"/>
+              <a:t>Execution with No overflow</a:t>
+            </a:r>
+          </a:p>
+        </p:txBody>
+      </p:sp>
+      <p:sp>
+        <p:nvSpPr>
+          <p:cNvPr id="40" name="TextBox 39">
+            <a:extLst>
+              <a:ext uri="{FF2B5EF4-FFF2-40B4-BE49-F238E27FC236}">
+                <a16:creationId xmlns:a16="http://schemas.microsoft.com/office/drawing/2014/main" id="{349A843C-FF3D-7129-9537-A3EA729D7B6F}"/>
+              </a:ext>
+            </a:extLst>
+          </p:cNvPr>
+          <p:cNvSpPr txBox="1"/>
+          <p:nvPr/>
+        </p:nvSpPr>
+        <p:spPr>
+          <a:xfrm>
+            <a:off x="8082331" y="2711119"/>
+            <a:ext cx="2683107" cy="369332"/>
+          </a:xfrm>
+          <a:prstGeom prst="rect">
+            <a:avLst/>
+          </a:prstGeom>
+          <a:noFill/>
+        </p:spPr>
+        <p:txBody>
+          <a:bodyPr wrap="none" rtlCol="0">
+            <a:spAutoFit/>
+          </a:bodyPr>
+          <a:lstStyle/>
+          <a:p>
+            <a:r>
+              <a:rPr lang="en-US" b="1" dirty="0"/>
+              <a:t>Execution with overflow</a:t>
+            </a:r>
+          </a:p>
+        </p:txBody>
+      </p:sp>
+      <p:sp>
+        <p:nvSpPr>
+          <p:cNvPr id="42" name="Rectangle 41">
+            <a:extLst>
+              <a:ext uri="{FF2B5EF4-FFF2-40B4-BE49-F238E27FC236}">
+                <a16:creationId xmlns:a16="http://schemas.microsoft.com/office/drawing/2014/main" id="{383F1A2F-950C-27AB-6732-D2761185EDD8}"/>
+              </a:ext>
+            </a:extLst>
+          </p:cNvPr>
+          <p:cNvSpPr/>
+          <p:nvPr/>
+        </p:nvSpPr>
+        <p:spPr>
+          <a:xfrm>
+            <a:off x="7665028" y="5049369"/>
+            <a:ext cx="3688772" cy="369331"/>
+          </a:xfrm>
+          <a:prstGeom prst="rect">
+            <a:avLst/>
+          </a:prstGeom>
+        </p:spPr>
+        <p:style>
+          <a:lnRef idx="2">
+            <a:schemeClr val="dk1"/>
+          </a:lnRef>
+          <a:fillRef idx="1">
+            <a:schemeClr val="lt1"/>
+          </a:fillRef>
+          <a:effectRef idx="0">
+            <a:schemeClr val="dk1"/>
+          </a:effectRef>
+          <a:fontRef idx="minor">
+            <a:schemeClr val="dk1"/>
+          </a:fontRef>
+        </p:style>
+        <p:txBody>
+          <a:bodyPr rtlCol="0" anchor="ctr"/>
+          <a:lstStyle/>
+          <a:p>
+            <a:pPr algn="ctr"/>
+            <a:endParaRPr lang="en-US"/>
+          </a:p>
+        </p:txBody>
+      </p:sp>
+      <p:sp>
+        <p:nvSpPr>
+          <p:cNvPr id="45" name="Rectangle 44">
+            <a:extLst>
+              <a:ext uri="{FF2B5EF4-FFF2-40B4-BE49-F238E27FC236}">
+                <a16:creationId xmlns:a16="http://schemas.microsoft.com/office/drawing/2014/main" id="{C858C73A-4B0B-288F-6624-A646A7838B10}"/>
+              </a:ext>
+            </a:extLst>
+          </p:cNvPr>
+          <p:cNvSpPr/>
+          <p:nvPr/>
+        </p:nvSpPr>
+        <p:spPr>
+          <a:xfrm>
+            <a:off x="1496387" y="4661657"/>
+            <a:ext cx="2909358" cy="192684"/>
+          </a:xfrm>
+          <a:prstGeom prst="rect">
+            <a:avLst/>
+          </a:prstGeom>
+        </p:spPr>
+        <p:style>
+          <a:lnRef idx="2">
+            <a:schemeClr val="accent5">
+              <a:shade val="15000"/>
+            </a:schemeClr>
+          </a:lnRef>
+          <a:fillRef idx="1">
+            <a:schemeClr val="accent5"/>
+          </a:fillRef>
+          <a:effectRef idx="0">
+            <a:schemeClr val="accent5"/>
+          </a:effectRef>
+          <a:fontRef idx="minor">
+            <a:schemeClr val="lt1"/>
+          </a:fontRef>
+        </p:style>
+        <p:txBody>
+          <a:bodyPr rtlCol="0" anchor="ctr"/>
+          <a:lstStyle/>
+          <a:p>
+            <a:pPr algn="ctr"/>
+            <a:endParaRPr lang="en-US"/>
+          </a:p>
+        </p:txBody>
+      </p:sp>
+      <p:sp>
+        <p:nvSpPr>
+          <p:cNvPr id="46" name="Rectangle 45">
+            <a:extLst>
+              <a:ext uri="{FF2B5EF4-FFF2-40B4-BE49-F238E27FC236}">
+                <a16:creationId xmlns:a16="http://schemas.microsoft.com/office/drawing/2014/main" id="{6AA04472-4CC8-E841-AD7D-816B1B93BD90}"/>
+              </a:ext>
+            </a:extLst>
+          </p:cNvPr>
+          <p:cNvSpPr/>
+          <p:nvPr/>
+        </p:nvSpPr>
+        <p:spPr>
+          <a:xfrm>
+            <a:off x="7752159" y="4565315"/>
+            <a:ext cx="3501196" cy="164825"/>
+          </a:xfrm>
+          <a:prstGeom prst="rect">
+            <a:avLst/>
+          </a:prstGeom>
+        </p:spPr>
+        <p:style>
+          <a:lnRef idx="2">
+            <a:schemeClr val="accent5">
+              <a:shade val="15000"/>
+            </a:schemeClr>
+          </a:lnRef>
+          <a:fillRef idx="1">
+            <a:schemeClr val="accent5"/>
+          </a:fillRef>
+          <a:effectRef idx="0">
+            <a:schemeClr val="accent5"/>
+          </a:effectRef>
+          <a:fontRef idx="minor">
+            <a:schemeClr val="lt1"/>
+          </a:fontRef>
+        </p:style>
+        <p:txBody>
+          <a:bodyPr rtlCol="0" anchor="ctr"/>
+          <a:lstStyle/>
+          <a:p>
+            <a:pPr algn="ctr"/>
+            <a:endParaRPr lang="en-US"/>
+          </a:p>
+        </p:txBody>
+      </p:sp>
+      <p:sp>
+        <p:nvSpPr>
+          <p:cNvPr id="47" name="Rectangle 46">
+            <a:extLst>
+              <a:ext uri="{FF2B5EF4-FFF2-40B4-BE49-F238E27FC236}">
+                <a16:creationId xmlns:a16="http://schemas.microsoft.com/office/drawing/2014/main" id="{3B9A3039-3A9C-96C9-AFEC-D9ECB1A2BDCB}"/>
+              </a:ext>
+            </a:extLst>
+          </p:cNvPr>
+          <p:cNvSpPr/>
+          <p:nvPr/>
+        </p:nvSpPr>
+        <p:spPr>
+          <a:xfrm>
+            <a:off x="7758815" y="5151621"/>
+            <a:ext cx="1754309" cy="173589"/>
+          </a:xfrm>
+          <a:prstGeom prst="rect">
+            <a:avLst/>
+          </a:prstGeom>
+        </p:spPr>
+        <p:style>
+          <a:lnRef idx="2">
+            <a:schemeClr val="accent5">
+              <a:shade val="15000"/>
+            </a:schemeClr>
+          </a:lnRef>
+          <a:fillRef idx="1">
+            <a:schemeClr val="accent5"/>
+          </a:fillRef>
+          <a:effectRef idx="0">
+            <a:schemeClr val="accent5"/>
+          </a:effectRef>
+          <a:fontRef idx="minor">
+            <a:schemeClr val="lt1"/>
+          </a:fontRef>
+        </p:style>
+        <p:txBody>
+          <a:bodyPr rtlCol="0" anchor="ctr"/>
+          <a:lstStyle/>
+          <a:p>
+            <a:pPr algn="ctr"/>
+            <a:endParaRPr lang="en-US"/>
+          </a:p>
+        </p:txBody>
+      </p:sp>
+      <p:sp>
+        <p:nvSpPr>
+          <p:cNvPr id="48" name="TextBox 47">
+            <a:extLst>
+              <a:ext uri="{FF2B5EF4-FFF2-40B4-BE49-F238E27FC236}">
+                <a16:creationId xmlns:a16="http://schemas.microsoft.com/office/drawing/2014/main" id="{DDC9A123-D36C-0B80-DD88-A14FD1931A61}"/>
+              </a:ext>
+            </a:extLst>
+          </p:cNvPr>
+          <p:cNvSpPr txBox="1"/>
+          <p:nvPr/>
+        </p:nvSpPr>
+        <p:spPr>
+          <a:xfrm>
+            <a:off x="6381620" y="4867103"/>
+            <a:ext cx="1330301" cy="369332"/>
+          </a:xfrm>
+          <a:prstGeom prst="rect">
+            <a:avLst/>
+          </a:prstGeom>
+          <a:noFill/>
+        </p:spPr>
+        <p:txBody>
+          <a:bodyPr wrap="none" rtlCol="0">
+            <a:spAutoFit/>
+          </a:bodyPr>
+          <a:lstStyle/>
+          <a:p>
+            <a:r>
+              <a:rPr lang="en-US" b="1" dirty="0"/>
+              <a:t>host buffer</a:t>
+            </a:r>
+          </a:p>
+        </p:txBody>
+      </p:sp>
+      <p:sp>
+        <p:nvSpPr>
+          <p:cNvPr id="49" name="TextBox 48">
+            <a:extLst>
+              <a:ext uri="{FF2B5EF4-FFF2-40B4-BE49-F238E27FC236}">
+                <a16:creationId xmlns:a16="http://schemas.microsoft.com/office/drawing/2014/main" id="{673FAE0D-C7DD-8686-AF24-52938EEE735D}"/>
+              </a:ext>
+            </a:extLst>
+          </p:cNvPr>
+          <p:cNvSpPr txBox="1"/>
+          <p:nvPr/>
+        </p:nvSpPr>
+        <p:spPr>
+          <a:xfrm>
+            <a:off x="6381620" y="5379110"/>
+            <a:ext cx="5964382" cy="1508105"/>
+          </a:xfrm>
+          <a:prstGeom prst="rect">
+            <a:avLst/>
+          </a:prstGeom>
+          <a:noFill/>
+        </p:spPr>
+        <p:txBody>
           <a:bodyPr wrap="square" rtlCol="0">
             <a:spAutoFit/>
           </a:bodyPr>
@@ -5492,7 +8049,51 @@
           <a:p>
             <a:r>
               <a:rPr lang="en-US" dirty="0"/>
-              <a:t>In both hybrid modes, overflow tasks spill to the host buffer when device memory is full, causing significant overhead. </a:t>
+              <a:t>it spilled 482,573,443 tasks to host during expansion, spending 90.28 s in the expand kernel.</a:t>
+            </a:r>
+          </a:p>
+          <a:p>
+            <a:r>
+              <a:rPr lang="en-US" sz="1400" dirty="0"/>
+              <a:t>Total time (s): 181.56</a:t>
+            </a:r>
+          </a:p>
+          <a:p>
+            <a:r>
+              <a:rPr lang="en-US" sz="1400" dirty="0"/>
+              <a:t>at switch </a:t>
+            </a:r>
+            <a:r>
+              <a:rPr lang="en-US" sz="1400" dirty="0" err="1"/>
+              <a:t>dump_to_host</a:t>
+            </a:r>
+            <a:r>
+              <a:rPr lang="en-US" sz="1400" dirty="0"/>
+              <a:t> time (s): 3.44</a:t>
+            </a:r>
+          </a:p>
+          <a:p>
+            <a:r>
+              <a:rPr lang="en-US" sz="1400" dirty="0"/>
+              <a:t>other </a:t>
+            </a:r>
+            <a:r>
+              <a:rPr lang="en-US" sz="1400" dirty="0" err="1"/>
+              <a:t>dump_to_host</a:t>
+            </a:r>
+            <a:r>
+              <a:rPr lang="en-US" sz="1400" dirty="0"/>
+              <a:t> time (s): 24.86</a:t>
+            </a:r>
+          </a:p>
+          <a:p>
+            <a:r>
+              <a:rPr lang="en-US" sz="1400" dirty="0" err="1"/>
+              <a:t>load_from_host</a:t>
+            </a:r>
+            <a:r>
+              <a:rPr lang="en-US" sz="1400" dirty="0"/>
+              <a:t> time (s): 31.78</a:t>
             </a:r>
           </a:p>
         </p:txBody>
@@ -5500,7 +8101,87 @@
     </p:spTree>
     <p:extLst>
       <p:ext uri="{BB962C8B-B14F-4D97-AF65-F5344CB8AC3E}">
-        <p14:creationId xmlns:p14="http://schemas.microsoft.com/office/powerpoint/2010/main" val="698545430"/>
+        <p14:creationId xmlns:p14="http://schemas.microsoft.com/office/powerpoint/2010/main" val="3476703163"/>
+      </p:ext>
+    </p:extLst>
+  </p:cSld>
+  <p:clrMapOvr>
+    <a:masterClrMapping/>
+  </p:clrMapOvr>
+</p:sld>
+</file>
+
+<file path=ppt/slides/slide16.xml><?xml version="1.0" encoding="utf-8"?>
+<p:sld xmlns:a="http://schemas.openxmlformats.org/drawingml/2006/main" xmlns:r="http://schemas.openxmlformats.org/officeDocument/2006/relationships" xmlns:p="http://schemas.openxmlformats.org/presentationml/2006/main">
+  <p:cSld>
+    <p:spTree>
+      <p:nvGrpSpPr>
+        <p:cNvPr id="1" name=""/>
+        <p:cNvGrpSpPr/>
+        <p:nvPr/>
+      </p:nvGrpSpPr>
+      <p:grpSpPr>
+        <a:xfrm>
+          <a:off x="0" y="0"/>
+          <a:ext cx="0" cy="0"/>
+          <a:chOff x="0" y="0"/>
+          <a:chExt cx="0" cy="0"/>
+        </a:xfrm>
+      </p:grpSpPr>
+      <p:sp>
+        <p:nvSpPr>
+          <p:cNvPr id="2" name="Title 1">
+            <a:extLst>
+              <a:ext uri="{FF2B5EF4-FFF2-40B4-BE49-F238E27FC236}">
+                <a16:creationId xmlns:a16="http://schemas.microsoft.com/office/drawing/2014/main" id="{FA0C761D-9E6B-F920-E605-52E6A438EEE8}"/>
+              </a:ext>
+            </a:extLst>
+          </p:cNvPr>
+          <p:cNvSpPr>
+            <a:spLocks noGrp="1"/>
+          </p:cNvSpPr>
+          <p:nvPr>
+            <p:ph type="title"/>
+          </p:nvPr>
+        </p:nvSpPr>
+        <p:spPr/>
+        <p:txBody>
+          <a:bodyPr/>
+          <a:lstStyle/>
+          <a:p>
+            <a:endParaRPr lang="en-US"/>
+          </a:p>
+        </p:txBody>
+      </p:sp>
+      <p:sp>
+        <p:nvSpPr>
+          <p:cNvPr id="3" name="Content Placeholder 2">
+            <a:extLst>
+              <a:ext uri="{FF2B5EF4-FFF2-40B4-BE49-F238E27FC236}">
+                <a16:creationId xmlns:a16="http://schemas.microsoft.com/office/drawing/2014/main" id="{3A8EB93B-7AA2-1523-AA7F-EC52B02E04F3}"/>
+              </a:ext>
+            </a:extLst>
+          </p:cNvPr>
+          <p:cNvSpPr>
+            <a:spLocks noGrp="1"/>
+          </p:cNvSpPr>
+          <p:nvPr>
+            <p:ph idx="1"/>
+          </p:nvPr>
+        </p:nvSpPr>
+        <p:spPr/>
+        <p:txBody>
+          <a:bodyPr/>
+          <a:lstStyle/>
+          <a:p>
+            <a:endParaRPr lang="en-US"/>
+          </a:p>
+        </p:txBody>
+      </p:sp>
+    </p:spTree>
+    <p:extLst>
+      <p:ext uri="{BB962C8B-B14F-4D97-AF65-F5344CB8AC3E}">
+        <p14:creationId xmlns:p14="http://schemas.microsoft.com/office/powerpoint/2010/main" val="1294580401"/>
       </p:ext>
     </p:extLst>
   </p:cSld>
@@ -5549,9 +8230,10 @@
           <a:lstStyle/>
           <a:p>
             <a:r>
-              <a:rPr lang="en-US" dirty="0"/>
+              <a:rPr lang="en-US"/>
               <a:t>Host Resident Buffer</a:t>
             </a:r>
+            <a:endParaRPr lang="en-US" dirty="0"/>
           </a:p>
         </p:txBody>
       </p:sp>
@@ -5582,29 +8264,32 @@
           <a:lstStyle/>
           <a:p>
             <a:r>
-              <a:rPr lang="en-US" dirty="0"/>
+              <a:rPr lang="en-US"/>
               <a:t>Create with </a:t>
             </a:r>
             <a:r>
-              <a:rPr lang="en-US" b="1" dirty="0"/>
+              <a:rPr lang="en-US" b="1"/>
               <a:t>new</a:t>
             </a:r>
             <a:r>
-              <a:rPr lang="en-US" dirty="0"/>
+              <a:rPr lang="en-US"/>
               <a:t> </a:t>
             </a:r>
-          </a:p>
-          <a:p>
-            <a:r>
-              <a:rPr lang="en-US" dirty="0"/>
+            <a:endParaRPr lang="en-US" dirty="0"/>
+          </a:p>
+          <a:p>
+            <a:r>
+              <a:rPr lang="en-US"/>
               <a:t>After returning from kernel, copy data to/from host buffer</a:t>
             </a:r>
-          </a:p>
-          <a:p>
-            <a:r>
-              <a:rPr lang="en-US" dirty="0"/>
+            <a:endParaRPr lang="en-US" dirty="0"/>
+          </a:p>
+          <a:p>
+            <a:r>
+              <a:rPr lang="en-US"/>
               <a:t>Bulk copy data instead of copying each subgraph</a:t>
             </a:r>
+            <a:endParaRPr lang="en-US" dirty="0"/>
           </a:p>
           <a:p>
             <a:pPr marL="0" indent="0">
@@ -5650,15 +8335,25 @@
           </a:p>
           <a:p>
             <a:r>
+              <a:rPr lang="en-US"/>
+              <a:t>total run time: 76.6 sec </a:t>
+            </a:r>
+            <a:endParaRPr lang="en-US" dirty="0"/>
+          </a:p>
+          <a:p>
+            <a:r>
+              <a:rPr lang="en-US"/>
+              <a:t>host buffer read</a:t>
+            </a:r>
+            <a:r>
               <a:rPr lang="en-US" dirty="0"/>
-              <a:t>total run time: 76.6 sec </a:t>
-            </a:r>
-          </a:p>
-          <a:p>
-            <a:r>
-              <a:rPr lang="en-US" dirty="0"/>
-              <a:t>host buffer read/write: 1.3 sec</a:t>
-            </a:r>
+              <a:t>/</a:t>
+            </a:r>
+            <a:r>
+              <a:rPr lang="en-US"/>
+              <a:t>write: 1.3 sec</a:t>
+            </a:r>
+            <a:endParaRPr lang="en-US" dirty="0"/>
           </a:p>
         </p:txBody>
       </p:sp>
@@ -6559,9 +9254,10 @@
           <a:lstStyle/>
           <a:p>
             <a:r>
-              <a:rPr lang="en-US" dirty="0"/>
+              <a:rPr lang="en-US"/>
               <a:t>Host Resident Buffer – Downside </a:t>
             </a:r>
+            <a:endParaRPr lang="en-US" dirty="0"/>
           </a:p>
         </p:txBody>
       </p:sp>
@@ -6728,19 +9424,20 @@
           <a:lstStyle/>
           <a:p>
             <a:r>
-              <a:rPr lang="en-US" dirty="0"/>
+              <a:rPr lang="en-US"/>
               <a:t>90% filled </a:t>
             </a:r>
             <a:r>
-              <a:rPr lang="en-US" dirty="0">
+              <a:rPr lang="en-US">
                 <a:sym typeface="Wingdings" pitchFamily="2" charset="2"/>
               </a:rPr>
               <a:t></a:t>
             </a:r>
             <a:r>
-              <a:rPr lang="en-US" dirty="0"/>
+              <a:rPr lang="en-US"/>
               <a:t> press brake pedal </a:t>
             </a:r>
+            <a:endParaRPr lang="en-US" dirty="0"/>
           </a:p>
         </p:txBody>
       </p:sp>
@@ -6816,9 +9513,10 @@
           <a:lstStyle/>
           <a:p>
             <a:r>
-              <a:rPr lang="en-US" dirty="0"/>
+              <a:rPr lang="en-US"/>
               <a:t>spill to H</a:t>
             </a:r>
+            <a:endParaRPr lang="en-US" dirty="0"/>
           </a:p>
         </p:txBody>
       </p:sp>
@@ -6851,9 +9549,10 @@
           <a:lstStyle/>
           <a:p>
             <a:r>
-              <a:rPr lang="en-US" b="1" dirty="0"/>
+              <a:rPr lang="en-US" b="1"/>
               <a:t>Managed Memory case: </a:t>
             </a:r>
+            <a:endParaRPr lang="en-US" b="1" dirty="0"/>
           </a:p>
         </p:txBody>
       </p:sp>
@@ -7020,19 +9719,20 @@
           <a:lstStyle/>
           <a:p>
             <a:r>
-              <a:rPr lang="en-US" dirty="0"/>
+              <a:rPr lang="en-US"/>
               <a:t>90% filled </a:t>
             </a:r>
             <a:r>
-              <a:rPr lang="en-US" dirty="0">
+              <a:rPr lang="en-US">
                 <a:sym typeface="Wingdings" pitchFamily="2" charset="2"/>
               </a:rPr>
               <a:t></a:t>
             </a:r>
             <a:r>
-              <a:rPr lang="en-US" dirty="0"/>
+              <a:rPr lang="en-US"/>
               <a:t> press brake pedal </a:t>
             </a:r>
+            <a:endParaRPr lang="en-US" dirty="0"/>
           </a:p>
         </p:txBody>
       </p:sp>
@@ -7065,13 +9765,18 @@
           <a:lstStyle/>
           <a:p>
             <a:r>
-              <a:rPr lang="en-US" dirty="0">
+              <a:rPr lang="en-US">
                 <a:solidFill>
                   <a:srgbClr val="FF0000"/>
                 </a:solidFill>
               </a:rPr>
               <a:t>spill not possible</a:t>
             </a:r>
+            <a:endParaRPr lang="en-US" dirty="0">
+              <a:solidFill>
+                <a:srgbClr val="FF0000"/>
+              </a:solidFill>
+            </a:endParaRPr>
           </a:p>
         </p:txBody>
       </p:sp>
@@ -7104,9 +9809,10 @@
           <a:lstStyle/>
           <a:p>
             <a:r>
-              <a:rPr lang="en-US" b="1" dirty="0"/>
+              <a:rPr lang="en-US" b="1"/>
               <a:t>Host Resident: </a:t>
             </a:r>
+            <a:endParaRPr lang="en-US" b="1" dirty="0"/>
           </a:p>
         </p:txBody>
       </p:sp>
@@ -7144,7 +9850,23 @@
                   <a:schemeClr val="accent1"/>
                 </a:solidFill>
               </a:rPr>
-              <a:t>wikipedia_link_fr</a:t>
+              <a:t>wikipedia_link</a:t>
+            </a:r>
+            <a:r>
+              <a:rPr lang="en-US" err="1">
+                <a:solidFill>
+                  <a:schemeClr val="accent1"/>
+                </a:solidFill>
+              </a:rPr>
+              <a:t>_</a:t>
+            </a:r>
+            <a:r>
+              <a:rPr lang="en-US">
+                <a:solidFill>
+                  <a:schemeClr val="accent1"/>
+                </a:solidFill>
+              </a:rPr>
+              <a:t>fr is facing this situation. How to address it</a:t>
             </a:r>
             <a:r>
               <a:rPr lang="en-US" dirty="0">
@@ -7152,7 +9874,7 @@
                   <a:schemeClr val="accent1"/>
                 </a:solidFill>
               </a:rPr>
-              <a:t> is facing this situation. How to address it??</a:t>
+              <a:t>??</a:t>
             </a:r>
           </a:p>
         </p:txBody>
@@ -7209,9 +9931,10 @@
           <a:lstStyle/>
           <a:p>
             <a:r>
-              <a:rPr lang="en-US" dirty="0"/>
+              <a:rPr lang="en-US"/>
               <a:t>Quasi Clique Application</a:t>
             </a:r>
+            <a:endParaRPr lang="en-US" dirty="0"/>
           </a:p>
         </p:txBody>
       </p:sp>
@@ -7656,9 +10379,10 @@
           <a:lstStyle/>
           <a:p>
             <a:r>
-              <a:rPr lang="en-US" sz="4800" dirty="0"/>
+              <a:rPr lang="en-US" sz="4800"/>
               <a:t>Results - MQC</a:t>
             </a:r>
+            <a:endParaRPr lang="en-US" sz="4800" dirty="0"/>
           </a:p>
         </p:txBody>
       </p:sp>
@@ -7832,7 +10556,7 @@
                         <a:buNone/>
                       </a:pPr>
                       <a:r>
-                        <a:rPr lang="en-US" sz="2000" b="1" i="0" u="none" strike="noStrike">
+                        <a:rPr lang="en-US" sz="2000" b="1" i="0" u="none" strike="noStrike" dirty="0">
                           <a:solidFill>
                             <a:srgbClr val="FFFFFF"/>
                           </a:solidFill>
@@ -7841,7 +10565,7 @@
                         </a:rPr>
                         <a:t>dataset</a:t>
                       </a:r>
-                      <a:endParaRPr lang="en-US" sz="2300" b="0" i="0" u="none" strike="noStrike">
+                      <a:endParaRPr lang="en-US" sz="2300" b="0" i="0" u="none" strike="noStrike" dirty="0">
                         <a:effectLst/>
                         <a:latin typeface="Arial" panose="020B0604020202020204" pitchFamily="34" charset="0"/>
                       </a:endParaRPr>
@@ -8378,6 +11102,16 @@
                         <a:buNone/>
                       </a:pPr>
                       <a:r>
+                        <a:rPr lang="en-US" sz="2000" b="1" i="0" u="none" strike="noStrike" dirty="0">
+                          <a:solidFill>
+                            <a:srgbClr val="FFFFFF"/>
+                          </a:solidFill>
+                          <a:effectLst/>
+                          <a:latin typeface="Aptos Narrow" panose="020B0004020202020204" pitchFamily="34" charset="0"/>
+                        </a:rPr>
+                        <a:t>#{</a:t>
+                      </a:r>
+                      <a:r>
                         <a:rPr lang="en-US" sz="2000" b="1" i="0" u="none" strike="noStrike">
                           <a:solidFill>
                             <a:srgbClr val="FFFFFF"/>
@@ -8385,9 +11119,9 @@
                           <a:effectLst/>
                           <a:latin typeface="Aptos Narrow" panose="020B0004020202020204" pitchFamily="34" charset="0"/>
                         </a:rPr>
-                        <a:t>#{cu-QC} </a:t>
+                        <a:t>cu-QC} </a:t>
                       </a:r>
-                      <a:endParaRPr lang="en-US" sz="2300" b="0" i="0" u="none" strike="noStrike">
+                      <a:endParaRPr lang="en-US" sz="2300" b="0" i="0" u="none" strike="noStrike" dirty="0">
                         <a:effectLst/>
                         <a:latin typeface="Arial" panose="020B0604020202020204" pitchFamily="34" charset="0"/>
                       </a:endParaRPr>
@@ -8512,7 +11246,7 @@
                         </a:rPr>
                         <a:t>                   26,198 </a:t>
                       </a:r>
-                      <a:endParaRPr lang="en-US" sz="2300" b="0" i="0" u="none" strike="noStrike">
+                      <a:endParaRPr lang="en-US" sz="2300" b="0" i="0" u="none" strike="noStrike" dirty="0">
                         <a:effectLst/>
                         <a:latin typeface="Arial" panose="020B0604020202020204" pitchFamily="34" charset="0"/>
                       </a:endParaRPr>
@@ -9103,7 +11837,7 @@
                         </a:rPr>
                         <a:t>                   39,577 </a:t>
                       </a:r>
-                      <a:endParaRPr lang="en-US" sz="2300" b="0" i="0" u="none" strike="noStrike">
+                      <a:endParaRPr lang="en-US" sz="2300" b="0" i="0" u="none" strike="noStrike" dirty="0">
                         <a:effectLst/>
                         <a:latin typeface="Arial" panose="020B0604020202020204" pitchFamily="34" charset="0"/>
                       </a:endParaRPr>
@@ -9694,7 +12428,7 @@
                         </a:rPr>
                         <a:t>                108,301 </a:t>
                       </a:r>
-                      <a:endParaRPr lang="en-US" sz="2300" b="0" i="0" u="none" strike="noStrike">
+                      <a:endParaRPr lang="en-US" sz="2300" b="0" i="0" u="none" strike="noStrike" dirty="0">
                         <a:effectLst/>
                         <a:latin typeface="Arial" panose="020B0604020202020204" pitchFamily="34" charset="0"/>
                       </a:endParaRPr>
@@ -10160,9 +12894,19 @@
                           <a:effectLst/>
                           <a:latin typeface="Aptos Narrow" panose="020B0004020202020204" pitchFamily="34" charset="0"/>
                         </a:rPr>
-                        <a:t>0, paper reported(4396)</a:t>
+                        <a:t>0, paper reported</a:t>
                       </a:r>
-                      <a:endParaRPr lang="en-US" sz="2300" b="0" i="0" u="none" strike="noStrike">
+                      <a:r>
+                        <a:rPr lang="en-US" sz="1500" b="0" i="0" u="none" strike="noStrike" dirty="0">
+                          <a:solidFill>
+                            <a:srgbClr val="C00000"/>
+                          </a:solidFill>
+                          <a:effectLst/>
+                          <a:latin typeface="Aptos Narrow" panose="020B0004020202020204" pitchFamily="34" charset="0"/>
+                        </a:rPr>
+                        <a:t>(4396)</a:t>
+                      </a:r>
+                      <a:endParaRPr lang="en-US" sz="2300" b="0" i="0" u="none" strike="noStrike" dirty="0">
                         <a:effectLst/>
                         <a:latin typeface="Arial" panose="020B0604020202020204" pitchFamily="34" charset="0"/>
                       </a:endParaRPr>
@@ -10285,7 +13029,7 @@
                         </a:rPr>
                         <a:t>                   36,692 </a:t>
                       </a:r>
-                      <a:endParaRPr lang="en-US" sz="2300" b="0" i="0" u="none" strike="noStrike">
+                      <a:endParaRPr lang="en-US" sz="2300" b="0" i="0" u="none" strike="noStrike" dirty="0">
                         <a:effectLst/>
                         <a:latin typeface="Arial" panose="020B0604020202020204" pitchFamily="34" charset="0"/>
                       </a:endParaRPr>
@@ -10751,9 +13495,19 @@
                           <a:effectLst/>
                           <a:latin typeface="Aptos Narrow" panose="020B0004020202020204" pitchFamily="34" charset="0"/>
                         </a:rPr>
-                        <a:t>0, paper reported(200)</a:t>
+                        <a:t>0, paper reported</a:t>
                       </a:r>
-                      <a:endParaRPr lang="en-US" sz="2300" b="0" i="0" u="none" strike="noStrike">
+                      <a:r>
+                        <a:rPr lang="en-US" sz="1500" b="0" i="0" u="none" strike="noStrike" dirty="0">
+                          <a:solidFill>
+                            <a:srgbClr val="C00000"/>
+                          </a:solidFill>
+                          <a:effectLst/>
+                          <a:latin typeface="Aptos Narrow" panose="020B0004020202020204" pitchFamily="34" charset="0"/>
+                        </a:rPr>
+                        <a:t>(200)</a:t>
+                      </a:r>
+                      <a:endParaRPr lang="en-US" sz="2300" b="0" i="0" u="none" strike="noStrike" dirty="0">
                         <a:effectLst/>
                         <a:latin typeface="Arial" panose="020B0604020202020204" pitchFamily="34" charset="0"/>
                       </a:endParaRPr>
@@ -10876,7 +13630,7 @@
                         </a:rPr>
                         <a:t>                      4,039 </a:t>
                       </a:r>
-                      <a:endParaRPr lang="en-US" sz="2300" b="0" i="0" u="none" strike="noStrike">
+                      <a:endParaRPr lang="en-US" sz="2300" b="0" i="0" u="none" strike="noStrike" dirty="0">
                         <a:effectLst/>
                         <a:latin typeface="Arial" panose="020B0604020202020204" pitchFamily="34" charset="0"/>
                       </a:endParaRPr>
@@ -11335,6 +14089,16 @@
                         <a:buNone/>
                       </a:pPr>
                       <a:r>
+                        <a:rPr lang="en-US" sz="1500" b="0" i="0" u="none" strike="noStrike">
+                          <a:solidFill>
+                            <a:srgbClr val="C00000"/>
+                          </a:solidFill>
+                          <a:effectLst/>
+                          <a:latin typeface="Aptos Narrow" panose="020B0004020202020204" pitchFamily="34" charset="0"/>
+                        </a:rPr>
+                        <a:t>0, paper reported (</a:t>
+                      </a:r>
+                      <a:r>
                         <a:rPr lang="en-US" sz="1500" b="0" i="0" u="none" strike="noStrike" dirty="0">
                           <a:solidFill>
                             <a:srgbClr val="C00000"/>
@@ -11342,7 +14106,7 @@
                           <a:effectLst/>
                           <a:latin typeface="Aptos Narrow" panose="020B0004020202020204" pitchFamily="34" charset="0"/>
                         </a:rPr>
-                        <a:t>0, paper reported (2)</a:t>
+                        <a:t>2)</a:t>
                       </a:r>
                       <a:endParaRPr lang="en-US" sz="2300" b="0" i="0" u="none" strike="noStrike" dirty="0">
                         <a:effectLst/>
@@ -11476,9 +14240,10 @@
           <a:lstStyle/>
           <a:p>
             <a:r>
-              <a:rPr lang="en-US" dirty="0"/>
+              <a:rPr lang="en-US"/>
               <a:t>Scratch Buffer</a:t>
             </a:r>
+            <a:endParaRPr lang="en-US" dirty="0"/>
           </a:p>
         </p:txBody>
       </p:sp>
@@ -11641,9 +14406,10 @@
           <a:lstStyle/>
           <a:p>
             <a:r>
-              <a:rPr lang="en-US" dirty="0"/>
+              <a:rPr lang="en-US"/>
               <a:t>top level tasks</a:t>
             </a:r>
+            <a:endParaRPr lang="en-US" dirty="0"/>
           </a:p>
         </p:txBody>
       </p:sp>
@@ -11691,9 +14457,10 @@
           <a:p>
             <a:pPr algn="ctr"/>
             <a:r>
-              <a:rPr lang="en-US" dirty="0"/>
+              <a:rPr lang="en-US"/>
               <a:t>2-hop neigh</a:t>
             </a:r>
+            <a:endParaRPr lang="en-US" dirty="0"/>
           </a:p>
         </p:txBody>
       </p:sp>
@@ -11825,9 +14592,10 @@
           <a:lstStyle/>
           <a:p>
             <a:r>
-              <a:rPr lang="en-US" dirty="0"/>
+              <a:rPr lang="en-US"/>
               <a:t>Scratch Buffer</a:t>
             </a:r>
+            <a:endParaRPr lang="en-US" dirty="0"/>
           </a:p>
         </p:txBody>
       </p:sp>
@@ -11990,9 +14758,10 @@
           <a:lstStyle/>
           <a:p>
             <a:r>
-              <a:rPr lang="en-US" dirty="0"/>
+              <a:rPr lang="en-US"/>
               <a:t>top level tasks</a:t>
             </a:r>
+            <a:endParaRPr lang="en-US" dirty="0"/>
           </a:p>
         </p:txBody>
       </p:sp>
@@ -12040,9 +14809,10 @@
           <a:p>
             <a:pPr algn="ctr"/>
             <a:r>
-              <a:rPr lang="en-US" dirty="0"/>
+              <a:rPr lang="en-US"/>
               <a:t>2-hop neigh</a:t>
             </a:r>
+            <a:endParaRPr lang="en-US" dirty="0"/>
           </a:p>
         </p:txBody>
       </p:sp>
@@ -12115,9 +14885,10 @@
           <a:lstStyle/>
           <a:p>
             <a:r>
-              <a:rPr lang="en-US" dirty="0"/>
+              <a:rPr lang="en-US"/>
               <a:t>per warp scratch</a:t>
             </a:r>
+            <a:endParaRPr lang="en-US" dirty="0"/>
           </a:p>
         </p:txBody>
       </p:sp>
@@ -12150,9 +14921,10 @@
           <a:lstStyle/>
           <a:p>
             <a:r>
-              <a:rPr lang="en-US" dirty="0"/>
+              <a:rPr lang="en-US"/>
               <a:t>with 32000 it sums to 6.5GB</a:t>
             </a:r>
+            <a:endParaRPr lang="en-US" dirty="0"/>
           </a:p>
         </p:txBody>
       </p:sp>
@@ -12208,9 +14980,10 @@
           <a:lstStyle/>
           <a:p>
             <a:r>
-              <a:rPr lang="en-US" dirty="0"/>
+              <a:rPr lang="en-US"/>
               <a:t>Handlink Big Tasks</a:t>
             </a:r>
+            <a:endParaRPr lang="en-US" dirty="0"/>
           </a:p>
         </p:txBody>
       </p:sp>
@@ -12373,9 +15146,10 @@
           <a:lstStyle/>
           <a:p>
             <a:r>
-              <a:rPr lang="en-US" dirty="0"/>
+              <a:rPr lang="en-US"/>
               <a:t>root vertices</a:t>
             </a:r>
+            <a:endParaRPr lang="en-US" dirty="0"/>
           </a:p>
         </p:txBody>
       </p:sp>
@@ -12423,9 +15197,10 @@
           <a:p>
             <a:pPr algn="ctr"/>
             <a:r>
-              <a:rPr lang="en-US" dirty="0"/>
+              <a:rPr lang="en-US"/>
               <a:t>2-hop neigh</a:t>
             </a:r>
+            <a:endParaRPr lang="en-US" dirty="0"/>
           </a:p>
         </p:txBody>
       </p:sp>
@@ -12498,8 +15273,12 @@
           <a:lstStyle/>
           <a:p>
             <a:r>
+              <a:rPr lang="en-US"/>
+              <a:t>root vertices with big tasks are separated at initialization step, using CPU threads (by OpenMP</a:t>
+            </a:r>
+            <a:r>
               <a:rPr lang="en-US" dirty="0"/>
-              <a:t>root vertices with big tasks are separated at initialization step, using CPU threads (by OpenMP)</a:t>
+              <a:t>)</a:t>
             </a:r>
           </a:p>
           <a:p>
@@ -12627,9 +15406,10 @@
           <a:lstStyle/>
           <a:p>
             <a:r>
-              <a:rPr lang="en-US" dirty="0"/>
+              <a:rPr lang="en-US"/>
               <a:t>regular root vertices</a:t>
             </a:r>
+            <a:endParaRPr lang="en-US" dirty="0"/>
           </a:p>
         </p:txBody>
       </p:sp>
@@ -12736,12 +15516,17 @@
           <a:p>
             <a:r>
               <a:rPr lang="en-US" dirty="0" err="1"/>
-              <a:t>big_root</a:t>
-            </a:r>
-            <a:r>
-              <a:rPr lang="en-US" dirty="0"/>
-              <a:t> vertices</a:t>
-            </a:r>
+              <a:t>big</a:t>
+            </a:r>
+            <a:r>
+              <a:rPr lang="en-US" err="1"/>
+              <a:t>_</a:t>
+            </a:r>
+            <a:r>
+              <a:rPr lang="en-US"/>
+              <a:t>root vertices</a:t>
+            </a:r>
+            <a:endParaRPr lang="en-US" dirty="0"/>
           </a:p>
         </p:txBody>
       </p:sp>
@@ -12774,23 +15559,25 @@
           <a:lstStyle/>
           <a:p>
             <a:r>
-              <a:rPr lang="en-US" dirty="0"/>
-              <a:t>master schedules </a:t>
-            </a:r>
-            <a:r>
-              <a:rPr lang="en-US" dirty="0" err="1"/>
-              <a:t>big_root</a:t>
-            </a:r>
-            <a:r>
-              <a:rPr lang="en-US" dirty="0"/>
-              <a:t> </a:t>
-            </a:r>
-          </a:p>
-          <a:p>
-            <a:r>
-              <a:rPr lang="en-US" dirty="0"/>
+              <a:rPr lang="en-US"/>
+              <a:t>master schedules big</a:t>
+            </a:r>
+            <a:r>
+              <a:rPr lang="en-US" err="1"/>
+              <a:t>_</a:t>
+            </a:r>
+            <a:r>
+              <a:rPr lang="en-US"/>
+              <a:t>root </a:t>
+            </a:r>
+            <a:endParaRPr lang="en-US" dirty="0"/>
+          </a:p>
+          <a:p>
+            <a:r>
+              <a:rPr lang="en-US"/>
               <a:t>vertices to CPU threads only </a:t>
             </a:r>
+            <a:endParaRPr lang="en-US" dirty="0"/>
           </a:p>
         </p:txBody>
       </p:sp>
@@ -12846,9 +15633,10 @@
           <a:lstStyle/>
           <a:p>
             <a:r>
-              <a:rPr lang="en-US" dirty="0"/>
+              <a:rPr lang="en-US"/>
               <a:t>Update CPU Worker</a:t>
             </a:r>
+            <a:endParaRPr lang="en-US" dirty="0"/>
           </a:p>
         </p:txBody>
       </p:sp>
@@ -13008,11 +15796,11 @@
           <a:lstStyle/>
           <a:p>
             <a:r>
-              <a:rPr lang="en-US" dirty="0"/>
+              <a:rPr lang="en-US"/>
               <a:t>CPU </a:t>
             </a:r>
             <a:r>
-              <a:rPr lang="en-US" dirty="0">
+              <a:rPr lang="en-US">
                 <a:sym typeface="Wingdings" pitchFamily="2" charset="2"/>
               </a:rPr>
               <a:t> </a:t>
@@ -13169,15 +15957,17 @@
           <a:lstStyle/>
           <a:p>
             <a:r>
-              <a:rPr lang="en-US" dirty="0"/>
+              <a:rPr lang="en-US"/>
               <a:t>still a </a:t>
             </a:r>
-          </a:p>
-          <a:p>
-            <a:r>
-              <a:rPr lang="en-US" dirty="0"/>
+            <a:endParaRPr lang="en-US" dirty="0"/>
+          </a:p>
+          <a:p>
+            <a:r>
+              <a:rPr lang="en-US"/>
               <a:t>big task</a:t>
             </a:r>
+            <a:endParaRPr lang="en-US" dirty="0"/>
           </a:p>
         </p:txBody>
       </p:sp>

</xml_diff>

<commit_message>
auto commit 2026-08-06 12:00:20
</commit_message>
<xml_diff>
--- a/revision.pptx
+++ b/revision.pptx
@@ -19,14 +19,24 @@
     <p:sldId id="271" r:id="rId13"/>
     <p:sldId id="272" r:id="rId14"/>
     <p:sldId id="273" r:id="rId15"/>
-    <p:sldId id="274" r:id="rId16"/>
-    <p:sldId id="275" r:id="rId17"/>
-    <p:sldId id="258" r:id="rId18"/>
-    <p:sldId id="276" r:id="rId19"/>
-    <p:sldId id="277" r:id="rId20"/>
-    <p:sldId id="278" r:id="rId21"/>
-    <p:sldId id="279" r:id="rId22"/>
-    <p:sldId id="269" r:id="rId23"/>
+    <p:sldId id="284" r:id="rId16"/>
+    <p:sldId id="274" r:id="rId17"/>
+    <p:sldId id="280" r:id="rId18"/>
+    <p:sldId id="285" r:id="rId19"/>
+    <p:sldId id="287" r:id="rId20"/>
+    <p:sldId id="288" r:id="rId21"/>
+    <p:sldId id="289" r:id="rId22"/>
+    <p:sldId id="290" r:id="rId23"/>
+    <p:sldId id="275" r:id="rId24"/>
+    <p:sldId id="281" r:id="rId25"/>
+    <p:sldId id="283" r:id="rId26"/>
+    <p:sldId id="258" r:id="rId27"/>
+    <p:sldId id="276" r:id="rId28"/>
+    <p:sldId id="277" r:id="rId29"/>
+    <p:sldId id="282" r:id="rId30"/>
+    <p:sldId id="278" r:id="rId31"/>
+    <p:sldId id="279" r:id="rId32"/>
+    <p:sldId id="269" r:id="rId33"/>
   </p:sldIdLst>
   <p:sldSz cx="12192000" cy="6858000"/>
   <p:notesSz cx="6858000" cy="9144000"/>
@@ -6953,6 +6963,678 @@
   <p:cSld>
     <p:spTree>
       <p:nvGrpSpPr>
+        <p:cNvPr id="1" name=""/>
+        <p:cNvGrpSpPr/>
+        <p:nvPr/>
+      </p:nvGrpSpPr>
+      <p:grpSpPr>
+        <a:xfrm>
+          <a:off x="0" y="0"/>
+          <a:ext cx="0" cy="0"/>
+          <a:chOff x="0" y="0"/>
+          <a:chExt cx="0" cy="0"/>
+        </a:xfrm>
+      </p:grpSpPr>
+      <p:sp>
+        <p:nvSpPr>
+          <p:cNvPr id="2" name="Title 1">
+            <a:extLst>
+              <a:ext uri="{FF2B5EF4-FFF2-40B4-BE49-F238E27FC236}">
+                <a16:creationId xmlns:a16="http://schemas.microsoft.com/office/drawing/2014/main" id="{E0502D63-F9C5-9012-124B-263F602BC8A3}"/>
+              </a:ext>
+            </a:extLst>
+          </p:cNvPr>
+          <p:cNvSpPr>
+            <a:spLocks noGrp="1"/>
+          </p:cNvSpPr>
+          <p:nvPr>
+            <p:ph type="title"/>
+          </p:nvPr>
+        </p:nvSpPr>
+        <p:spPr/>
+        <p:txBody>
+          <a:bodyPr/>
+          <a:lstStyle/>
+          <a:p>
+            <a:r>
+              <a:rPr lang="en-US" dirty="0"/>
+              <a:t>Experiments with large values of \eta</a:t>
+            </a:r>
+          </a:p>
+        </p:txBody>
+      </p:sp>
+      <p:graphicFrame>
+        <p:nvGraphicFramePr>
+          <p:cNvPr id="4" name="Content Placeholder 3">
+            <a:extLst>
+              <a:ext uri="{FF2B5EF4-FFF2-40B4-BE49-F238E27FC236}">
+                <a16:creationId xmlns:a16="http://schemas.microsoft.com/office/drawing/2014/main" id="{D4AC5A53-E074-1665-73A7-6741D4CA10F9}"/>
+              </a:ext>
+            </a:extLst>
+          </p:cNvPr>
+          <p:cNvGraphicFramePr>
+            <a:graphicFrameLocks noGrp="1"/>
+          </p:cNvGraphicFramePr>
+          <p:nvPr>
+            <p:ph idx="1"/>
+            <p:extLst>
+              <p:ext uri="{D42A27DB-BD31-4B8C-83A1-F6EECF244321}">
+                <p14:modId xmlns:p14="http://schemas.microsoft.com/office/powerpoint/2010/main" val="373944674"/>
+              </p:ext>
+            </p:extLst>
+          </p:nvPr>
+        </p:nvGraphicFramePr>
+        <p:xfrm>
+          <a:off x="1387366" y="2671735"/>
+          <a:ext cx="8747236" cy="914400"/>
+        </p:xfrm>
+        <a:graphic>
+          <a:graphicData uri="http://schemas.openxmlformats.org/drawingml/2006/table">
+            <a:tbl>
+              <a:tblPr>
+                <a:tableStyleId>{5C22544A-7EE6-4342-B048-85BDC9FD1C3A}</a:tableStyleId>
+              </a:tblPr>
+              <a:tblGrid>
+                <a:gridCol w="2699764">
+                  <a:extLst>
+                    <a:ext uri="{9D8B030D-6E8A-4147-A177-3AD203B41FA5}">
+                      <a16:colId xmlns:a16="http://schemas.microsoft.com/office/drawing/2014/main" val="3982992337"/>
+                    </a:ext>
+                  </a:extLst>
+                </a:gridCol>
+                <a:gridCol w="1007912">
+                  <a:extLst>
+                    <a:ext uri="{9D8B030D-6E8A-4147-A177-3AD203B41FA5}">
+                      <a16:colId xmlns:a16="http://schemas.microsoft.com/office/drawing/2014/main" val="1361271205"/>
+                    </a:ext>
+                  </a:extLst>
+                </a:gridCol>
+                <a:gridCol w="1007912">
+                  <a:extLst>
+                    <a:ext uri="{9D8B030D-6E8A-4147-A177-3AD203B41FA5}">
+                      <a16:colId xmlns:a16="http://schemas.microsoft.com/office/drawing/2014/main" val="1242792071"/>
+                    </a:ext>
+                  </a:extLst>
+                </a:gridCol>
+                <a:gridCol w="1007912">
+                  <a:extLst>
+                    <a:ext uri="{9D8B030D-6E8A-4147-A177-3AD203B41FA5}">
+                      <a16:colId xmlns:a16="http://schemas.microsoft.com/office/drawing/2014/main" val="2393205825"/>
+                    </a:ext>
+                  </a:extLst>
+                </a:gridCol>
+                <a:gridCol w="1007912">
+                  <a:extLst>
+                    <a:ext uri="{9D8B030D-6E8A-4147-A177-3AD203B41FA5}">
+                      <a16:colId xmlns:a16="http://schemas.microsoft.com/office/drawing/2014/main" val="3749845620"/>
+                    </a:ext>
+                  </a:extLst>
+                </a:gridCol>
+                <a:gridCol w="1007912">
+                  <a:extLst>
+                    <a:ext uri="{9D8B030D-6E8A-4147-A177-3AD203B41FA5}">
+                      <a16:colId xmlns:a16="http://schemas.microsoft.com/office/drawing/2014/main" val="218826624"/>
+                    </a:ext>
+                  </a:extLst>
+                </a:gridCol>
+                <a:gridCol w="1007912">
+                  <a:extLst>
+                    <a:ext uri="{9D8B030D-6E8A-4147-A177-3AD203B41FA5}">
+                      <a16:colId xmlns:a16="http://schemas.microsoft.com/office/drawing/2014/main" val="1630939330"/>
+                    </a:ext>
+                  </a:extLst>
+                </a:gridCol>
+              </a:tblGrid>
+              <a:tr h="304800">
+                <a:tc>
+                  <a:txBody>
+                    <a:bodyPr/>
+                    <a:lstStyle/>
+                    <a:p>
+                      <a:pPr algn="l" fontAlgn="b">
+                        <a:buNone/>
+                      </a:pPr>
+                      <a:r>
+                        <a:rPr lang="en-US" sz="1700" b="0" i="0" u="none" strike="noStrike" dirty="0">
+                          <a:solidFill>
+                            <a:srgbClr val="000000"/>
+                          </a:solidFill>
+                          <a:effectLst/>
+                          <a:latin typeface="Monaco" pitchFamily="2" charset="77"/>
+                        </a:rPr>
+                        <a:t>Dataset</a:t>
+                      </a:r>
+                    </a:p>
+                  </a:txBody>
+                  <a:tcPr marL="9525" marR="9525" marT="9525" marB="0" anchor="b"/>
+                </a:tc>
+                <a:tc>
+                  <a:txBody>
+                    <a:bodyPr/>
+                    <a:lstStyle/>
+                    <a:p>
+                      <a:pPr marL="0" algn="ctr" defTabSz="914400" rtl="0" eaLnBrk="1" fontAlgn="b" latinLnBrk="0" hangingPunct="1">
+                        <a:buNone/>
+                      </a:pPr>
+                      <a:r>
+                        <a:rPr lang="en-US" sz="1700" b="0" i="0" u="none" strike="noStrike" dirty="0">
+                          <a:solidFill>
+                            <a:srgbClr val="000000"/>
+                          </a:solidFill>
+                          <a:effectLst/>
+                          <a:latin typeface="Monaco" pitchFamily="2" charset="77"/>
+                        </a:rPr>
+                        <a:t>G2-AIMD</a:t>
+                      </a:r>
+                    </a:p>
+                  </a:txBody>
+                  <a:tcPr marL="9525" marR="9525" marT="9525" marB="0" anchor="b"/>
+                </a:tc>
+                <a:tc>
+                  <a:txBody>
+                    <a:bodyPr/>
+                    <a:lstStyle/>
+                    <a:p>
+                      <a:pPr marL="0" algn="ctr" defTabSz="914400" rtl="0" eaLnBrk="1" fontAlgn="b" latinLnBrk="0" hangingPunct="1">
+                        <a:buNone/>
+                      </a:pPr>
+                      <a:r>
+                        <a:rPr lang="en-US" sz="1700" b="0" i="0" u="none" strike="noStrike" dirty="0">
+                          <a:solidFill>
+                            <a:srgbClr val="000000"/>
+                          </a:solidFill>
+                          <a:effectLst/>
+                          <a:latin typeface="Monaco" pitchFamily="2" charset="77"/>
+                        </a:rPr>
+                        <a:t>1000</a:t>
+                      </a:r>
+                    </a:p>
+                  </a:txBody>
+                  <a:tcPr marL="9525" marR="9525" marT="9525" marB="0" anchor="b"/>
+                </a:tc>
+                <a:tc>
+                  <a:txBody>
+                    <a:bodyPr/>
+                    <a:lstStyle/>
+                    <a:p>
+                      <a:pPr marL="0" algn="ctr" defTabSz="914400" rtl="0" eaLnBrk="1" fontAlgn="b" latinLnBrk="0" hangingPunct="1">
+                        <a:buNone/>
+                      </a:pPr>
+                      <a:r>
+                        <a:rPr lang="en-US" sz="1700" b="0" i="0" u="none" strike="noStrike" dirty="0">
+                          <a:solidFill>
+                            <a:srgbClr val="000000"/>
+                          </a:solidFill>
+                          <a:effectLst/>
+                          <a:latin typeface="Monaco" pitchFamily="2" charset="77"/>
+                        </a:rPr>
+                        <a:t>2000</a:t>
+                      </a:r>
+                    </a:p>
+                  </a:txBody>
+                  <a:tcPr marL="9525" marR="9525" marT="9525" marB="0" anchor="b"/>
+                </a:tc>
+                <a:tc>
+                  <a:txBody>
+                    <a:bodyPr/>
+                    <a:lstStyle/>
+                    <a:p>
+                      <a:pPr marL="0" algn="ctr" defTabSz="914400" rtl="0" eaLnBrk="1" fontAlgn="b" latinLnBrk="0" hangingPunct="1">
+                        <a:buNone/>
+                      </a:pPr>
+                      <a:r>
+                        <a:rPr lang="en-US" sz="1700" b="0" i="0" u="none" strike="noStrike" dirty="0">
+                          <a:solidFill>
+                            <a:srgbClr val="000000"/>
+                          </a:solidFill>
+                          <a:effectLst/>
+                          <a:latin typeface="Monaco" pitchFamily="2" charset="77"/>
+                        </a:rPr>
+                        <a:t>5000</a:t>
+                      </a:r>
+                    </a:p>
+                  </a:txBody>
+                  <a:tcPr marL="9525" marR="9525" marT="9525" marB="0" anchor="b"/>
+                </a:tc>
+                <a:tc>
+                  <a:txBody>
+                    <a:bodyPr/>
+                    <a:lstStyle/>
+                    <a:p>
+                      <a:pPr marL="0" algn="ctr" defTabSz="914400" rtl="0" eaLnBrk="1" fontAlgn="b" latinLnBrk="0" hangingPunct="1">
+                        <a:buNone/>
+                      </a:pPr>
+                      <a:r>
+                        <a:rPr lang="en-US" sz="1700" b="0" i="0" u="none" strike="noStrike" dirty="0">
+                          <a:solidFill>
+                            <a:srgbClr val="000000"/>
+                          </a:solidFill>
+                          <a:effectLst/>
+                          <a:latin typeface="Monaco" pitchFamily="2" charset="77"/>
+                        </a:rPr>
+                        <a:t>10000</a:t>
+                      </a:r>
+                    </a:p>
+                  </a:txBody>
+                  <a:tcPr marL="9525" marR="9525" marT="9525" marB="0" anchor="b"/>
+                </a:tc>
+                <a:tc>
+                  <a:txBody>
+                    <a:bodyPr/>
+                    <a:lstStyle/>
+                    <a:p>
+                      <a:pPr marL="0" algn="ctr" defTabSz="914400" rtl="0" eaLnBrk="1" fontAlgn="b" latinLnBrk="0" hangingPunct="1">
+                        <a:buNone/>
+                      </a:pPr>
+                      <a:r>
+                        <a:rPr lang="en-US" sz="1700" b="0" i="0" u="none" strike="noStrike" dirty="0">
+                          <a:solidFill>
+                            <a:srgbClr val="000000"/>
+                          </a:solidFill>
+                          <a:effectLst/>
+                          <a:latin typeface="Monaco" pitchFamily="2" charset="77"/>
+                        </a:rPr>
+                        <a:t>20000</a:t>
+                      </a:r>
+                    </a:p>
+                  </a:txBody>
+                  <a:tcPr marL="9525" marR="9525" marT="9525" marB="0" anchor="b"/>
+                </a:tc>
+                <a:extLst>
+                  <a:ext uri="{0D108BD9-81ED-4DB2-BD59-A6C34878D82A}">
+                    <a16:rowId xmlns:a16="http://schemas.microsoft.com/office/drawing/2014/main" val="782536880"/>
+                  </a:ext>
+                </a:extLst>
+              </a:tr>
+              <a:tr h="304800">
+                <a:tc>
+                  <a:txBody>
+                    <a:bodyPr/>
+                    <a:lstStyle/>
+                    <a:p>
+                      <a:pPr algn="l" fontAlgn="b">
+                        <a:buNone/>
+                      </a:pPr>
+                      <a:r>
+                        <a:rPr lang="en-US" sz="1700" u="none" strike="noStrike" dirty="0" err="1">
+                          <a:effectLst/>
+                        </a:rPr>
+                        <a:t>orkut-groupmemberships</a:t>
+                      </a:r>
+                      <a:endParaRPr lang="en-US" sz="1700" b="0" i="0" u="none" strike="noStrike" dirty="0">
+                        <a:solidFill>
+                          <a:srgbClr val="000000"/>
+                        </a:solidFill>
+                        <a:effectLst/>
+                        <a:latin typeface="Monaco" pitchFamily="2" charset="77"/>
+                      </a:endParaRPr>
+                    </a:p>
+                  </a:txBody>
+                  <a:tcPr marL="9525" marR="9525" marT="9525" marB="0" anchor="b"/>
+                </a:tc>
+                <a:tc>
+                  <a:txBody>
+                    <a:bodyPr/>
+                    <a:lstStyle/>
+                    <a:p>
+                      <a:pPr algn="ctr" fontAlgn="b">
+                        <a:buNone/>
+                      </a:pPr>
+                      <a:r>
+                        <a:rPr lang="en-US" sz="1700" b="0" i="0" u="none" strike="noStrike" dirty="0">
+                          <a:solidFill>
+                            <a:srgbClr val="000000"/>
+                          </a:solidFill>
+                          <a:effectLst/>
+                          <a:latin typeface="Monaco" pitchFamily="2" charset="77"/>
+                        </a:rPr>
+                        <a:t>14.1</a:t>
+                      </a:r>
+                    </a:p>
+                  </a:txBody>
+                  <a:tcPr marL="9525" marR="9525" marT="9525" marB="0" anchor="b"/>
+                </a:tc>
+                <a:tc>
+                  <a:txBody>
+                    <a:bodyPr/>
+                    <a:lstStyle/>
+                    <a:p>
+                      <a:pPr algn="ctr" fontAlgn="b">
+                        <a:buNone/>
+                      </a:pPr>
+                      <a:r>
+                        <a:rPr lang="en-US" sz="1700" u="none" strike="noStrike" dirty="0">
+                          <a:effectLst/>
+                        </a:rPr>
+                        <a:t>32.7</a:t>
+                      </a:r>
+                      <a:endParaRPr lang="en-US" sz="1700" b="0" i="0" u="none" strike="noStrike" dirty="0">
+                        <a:solidFill>
+                          <a:srgbClr val="000000"/>
+                        </a:solidFill>
+                        <a:effectLst/>
+                        <a:latin typeface="Monaco" pitchFamily="2" charset="77"/>
+                      </a:endParaRPr>
+                    </a:p>
+                  </a:txBody>
+                  <a:tcPr marL="9525" marR="9525" marT="9525" marB="0" anchor="b"/>
+                </a:tc>
+                <a:tc>
+                  <a:txBody>
+                    <a:bodyPr/>
+                    <a:lstStyle/>
+                    <a:p>
+                      <a:pPr algn="ctr" fontAlgn="b">
+                        <a:buNone/>
+                      </a:pPr>
+                      <a:r>
+                        <a:rPr lang="en-US" sz="1700" u="none" strike="noStrike" dirty="0">
+                          <a:effectLst/>
+                        </a:rPr>
+                        <a:t>25.0</a:t>
+                      </a:r>
+                      <a:endParaRPr lang="en-US" sz="1700" b="0" i="0" u="none" strike="noStrike" dirty="0">
+                        <a:solidFill>
+                          <a:srgbClr val="000000"/>
+                        </a:solidFill>
+                        <a:effectLst/>
+                        <a:latin typeface="Monaco" pitchFamily="2" charset="77"/>
+                      </a:endParaRPr>
+                    </a:p>
+                  </a:txBody>
+                  <a:tcPr marL="9525" marR="9525" marT="9525" marB="0" anchor="b"/>
+                </a:tc>
+                <a:tc>
+                  <a:txBody>
+                    <a:bodyPr/>
+                    <a:lstStyle/>
+                    <a:p>
+                      <a:pPr algn="ctr" fontAlgn="b">
+                        <a:buNone/>
+                      </a:pPr>
+                      <a:r>
+                        <a:rPr lang="en-US" sz="1700" u="none" strike="noStrike" dirty="0">
+                          <a:effectLst/>
+                        </a:rPr>
+                        <a:t>20.0</a:t>
+                      </a:r>
+                      <a:endParaRPr lang="en-US" sz="1700" b="0" i="0" u="none" strike="noStrike" dirty="0">
+                        <a:solidFill>
+                          <a:srgbClr val="000000"/>
+                        </a:solidFill>
+                        <a:effectLst/>
+                        <a:latin typeface="Monaco" pitchFamily="2" charset="77"/>
+                      </a:endParaRPr>
+                    </a:p>
+                  </a:txBody>
+                  <a:tcPr marL="9525" marR="9525" marT="9525" marB="0" anchor="b"/>
+                </a:tc>
+                <a:tc>
+                  <a:txBody>
+                    <a:bodyPr/>
+                    <a:lstStyle/>
+                    <a:p>
+                      <a:pPr marL="0" algn="ctr" defTabSz="914400" rtl="0" eaLnBrk="1" fontAlgn="b" latinLnBrk="0" hangingPunct="1">
+                        <a:buNone/>
+                      </a:pPr>
+                      <a:r>
+                        <a:rPr lang="en-US" sz="1700" b="0" i="0" u="none" strike="noStrike" dirty="0">
+                          <a:solidFill>
+                            <a:srgbClr val="000000"/>
+                          </a:solidFill>
+                          <a:effectLst/>
+                          <a:latin typeface="Monaco" pitchFamily="2" charset="77"/>
+                        </a:rPr>
+                        <a:t>14.1</a:t>
+                      </a:r>
+                    </a:p>
+                  </a:txBody>
+                  <a:tcPr marL="9525" marR="9525" marT="9525" marB="0" anchor="b"/>
+                </a:tc>
+                <a:tc>
+                  <a:txBody>
+                    <a:bodyPr/>
+                    <a:lstStyle/>
+                    <a:p>
+                      <a:pPr marL="0" algn="ctr" defTabSz="914400" rtl="0" eaLnBrk="1" fontAlgn="b" latinLnBrk="0" hangingPunct="1">
+                        <a:buNone/>
+                      </a:pPr>
+                      <a:r>
+                        <a:rPr lang="en-US" sz="1700" b="0" i="0" u="none" strike="noStrike" dirty="0">
+                          <a:solidFill>
+                            <a:srgbClr val="000000"/>
+                          </a:solidFill>
+                          <a:effectLst/>
+                          <a:latin typeface="Monaco" pitchFamily="2" charset="77"/>
+                        </a:rPr>
+                        <a:t>14.0</a:t>
+                      </a:r>
+                    </a:p>
+                  </a:txBody>
+                  <a:tcPr marL="9525" marR="9525" marT="9525" marB="0" anchor="b"/>
+                </a:tc>
+                <a:extLst>
+                  <a:ext uri="{0D108BD9-81ED-4DB2-BD59-A6C34878D82A}">
+                    <a16:rowId xmlns:a16="http://schemas.microsoft.com/office/drawing/2014/main" val="455996298"/>
+                  </a:ext>
+                </a:extLst>
+              </a:tr>
+              <a:tr h="304800">
+                <a:tc>
+                  <a:txBody>
+                    <a:bodyPr/>
+                    <a:lstStyle/>
+                    <a:p>
+                      <a:pPr algn="l" fontAlgn="b">
+                        <a:buNone/>
+                      </a:pPr>
+                      <a:r>
+                        <a:rPr lang="en-US" sz="1700" b="0" i="0" u="none" strike="noStrike" dirty="0">
+                          <a:solidFill>
+                            <a:srgbClr val="000000"/>
+                          </a:solidFill>
+                          <a:effectLst/>
+                          <a:latin typeface="Monaco" pitchFamily="2" charset="77"/>
+                        </a:rPr>
+                        <a:t>edit-</a:t>
+                      </a:r>
+                      <a:r>
+                        <a:rPr lang="en-US" sz="1700" b="0" i="0" u="none" strike="noStrike" dirty="0" err="1">
+                          <a:solidFill>
+                            <a:srgbClr val="000000"/>
+                          </a:solidFill>
+                          <a:effectLst/>
+                          <a:latin typeface="Monaco" pitchFamily="2" charset="77"/>
+                        </a:rPr>
+                        <a:t>nlwiki</a:t>
+                      </a:r>
+                      <a:endParaRPr lang="en-US" sz="1700" b="0" i="0" u="none" strike="noStrike" dirty="0">
+                        <a:solidFill>
+                          <a:srgbClr val="000000"/>
+                        </a:solidFill>
+                        <a:effectLst/>
+                        <a:latin typeface="Monaco" pitchFamily="2" charset="77"/>
+                      </a:endParaRPr>
+                    </a:p>
+                  </a:txBody>
+                  <a:tcPr marL="9525" marR="9525" marT="9525" marB="0" anchor="b"/>
+                </a:tc>
+                <a:tc>
+                  <a:txBody>
+                    <a:bodyPr/>
+                    <a:lstStyle/>
+                    <a:p>
+                      <a:pPr algn="ctr" fontAlgn="b">
+                        <a:buNone/>
+                      </a:pPr>
+                      <a:r>
+                        <a:rPr lang="en-US" sz="1700" b="0" i="0" u="none" strike="noStrike" dirty="0">
+                          <a:solidFill>
+                            <a:srgbClr val="000000"/>
+                          </a:solidFill>
+                          <a:effectLst/>
+                          <a:latin typeface="Monaco" pitchFamily="2" charset="77"/>
+                        </a:rPr>
+                        <a:t>11.3</a:t>
+                      </a:r>
+                    </a:p>
+                  </a:txBody>
+                  <a:tcPr marL="9525" marR="9525" marT="9525" marB="0" anchor="b"/>
+                </a:tc>
+                <a:tc>
+                  <a:txBody>
+                    <a:bodyPr/>
+                    <a:lstStyle/>
+                    <a:p>
+                      <a:pPr algn="ctr" fontAlgn="b">
+                        <a:buNone/>
+                      </a:pPr>
+                      <a:r>
+                        <a:rPr lang="en-US" sz="1700" b="0" i="0" u="none" strike="noStrike">
+                          <a:solidFill>
+                            <a:srgbClr val="000000"/>
+                          </a:solidFill>
+                          <a:effectLst/>
+                          <a:latin typeface="Monaco" pitchFamily="2" charset="77"/>
+                        </a:rPr>
+                        <a:t>20.5</a:t>
+                      </a:r>
+                    </a:p>
+                  </a:txBody>
+                  <a:tcPr marL="9525" marR="9525" marT="9525" marB="0" anchor="b"/>
+                </a:tc>
+                <a:tc>
+                  <a:txBody>
+                    <a:bodyPr/>
+                    <a:lstStyle/>
+                    <a:p>
+                      <a:pPr algn="ctr" fontAlgn="b">
+                        <a:buNone/>
+                      </a:pPr>
+                      <a:r>
+                        <a:rPr lang="en-US" sz="1700" b="0" i="0" u="none" strike="noStrike">
+                          <a:solidFill>
+                            <a:srgbClr val="000000"/>
+                          </a:solidFill>
+                          <a:effectLst/>
+                          <a:latin typeface="Monaco" pitchFamily="2" charset="77"/>
+                        </a:rPr>
+                        <a:t>18.4</a:t>
+                      </a:r>
+                    </a:p>
+                  </a:txBody>
+                  <a:tcPr marL="9525" marR="9525" marT="9525" marB="0" anchor="b"/>
+                </a:tc>
+                <a:tc>
+                  <a:txBody>
+                    <a:bodyPr/>
+                    <a:lstStyle/>
+                    <a:p>
+                      <a:pPr algn="ctr" fontAlgn="b">
+                        <a:buNone/>
+                      </a:pPr>
+                      <a:r>
+                        <a:rPr lang="en-US" sz="1700" b="0" i="0" u="none" strike="noStrike" dirty="0">
+                          <a:solidFill>
+                            <a:srgbClr val="000000"/>
+                          </a:solidFill>
+                          <a:effectLst/>
+                          <a:latin typeface="Monaco" pitchFamily="2" charset="77"/>
+                        </a:rPr>
+                        <a:t>16.8</a:t>
+                      </a:r>
+                    </a:p>
+                  </a:txBody>
+                  <a:tcPr marL="9525" marR="9525" marT="9525" marB="0" anchor="b"/>
+                </a:tc>
+                <a:tc>
+                  <a:txBody>
+                    <a:bodyPr/>
+                    <a:lstStyle/>
+                    <a:p>
+                      <a:pPr marL="0" marR="0" lvl="0" indent="0" algn="ctr" defTabSz="914400" rtl="0" eaLnBrk="1" fontAlgn="b" latinLnBrk="0" hangingPunct="1">
+                        <a:lnSpc>
+                          <a:spcPct val="100000"/>
+                        </a:lnSpc>
+                        <a:spcBef>
+                          <a:spcPts val="0"/>
+                        </a:spcBef>
+                        <a:spcAft>
+                          <a:spcPts val="0"/>
+                        </a:spcAft>
+                        <a:buClrTx/>
+                        <a:buSzTx/>
+                        <a:buFontTx/>
+                        <a:buNone/>
+                        <a:tabLst/>
+                        <a:defRPr/>
+                      </a:pPr>
+                      <a:r>
+                        <a:rPr lang="en-US" sz="1800" kern="1200" dirty="0">
+                          <a:solidFill>
+                            <a:schemeClr val="dk1"/>
+                          </a:solidFill>
+                          <a:effectLst/>
+                          <a:latin typeface="+mn-lt"/>
+                          <a:ea typeface="+mn-ea"/>
+                          <a:cs typeface="+mn-cs"/>
+                        </a:rPr>
+                        <a:t>10.9</a:t>
+                      </a:r>
+                    </a:p>
+                  </a:txBody>
+                  <a:tcPr marL="9525" marR="9525" marT="9525" marB="0" anchor="b"/>
+                </a:tc>
+                <a:tc>
+                  <a:txBody>
+                    <a:bodyPr/>
+                    <a:lstStyle/>
+                    <a:p>
+                      <a:pPr marL="0" algn="ctr" defTabSz="914400" rtl="0" eaLnBrk="1" fontAlgn="b" latinLnBrk="0" hangingPunct="1">
+                        <a:buNone/>
+                      </a:pPr>
+                      <a:r>
+                        <a:rPr lang="en-US" sz="1700" b="0" i="0" u="none" strike="noStrike" dirty="0">
+                          <a:solidFill>
+                            <a:srgbClr val="000000"/>
+                          </a:solidFill>
+                          <a:effectLst/>
+                          <a:latin typeface="Monaco" pitchFamily="2" charset="77"/>
+                        </a:rPr>
+                        <a:t>10.9</a:t>
+                      </a:r>
+                    </a:p>
+                  </a:txBody>
+                  <a:tcPr marL="9525" marR="9525" marT="9525" marB="0" anchor="b"/>
+                </a:tc>
+                <a:extLst>
+                  <a:ext uri="{0D108BD9-81ED-4DB2-BD59-A6C34878D82A}">
+                    <a16:rowId xmlns:a16="http://schemas.microsoft.com/office/drawing/2014/main" val="3198839292"/>
+                  </a:ext>
+                </a:extLst>
+              </a:tr>
+            </a:tbl>
+          </a:graphicData>
+        </a:graphic>
+      </p:graphicFrame>
+    </p:spTree>
+    <p:extLst>
+      <p:ext uri="{BB962C8B-B14F-4D97-AF65-F5344CB8AC3E}">
+        <p14:creationId xmlns:p14="http://schemas.microsoft.com/office/powerpoint/2010/main" val="1453935113"/>
+      </p:ext>
+    </p:extLst>
+  </p:cSld>
+  <p:clrMapOvr>
+    <a:masterClrMapping/>
+  </p:clrMapOvr>
+</p:sld>
+</file>
+
+<file path=ppt/slides/slide16.xml><?xml version="1.0" encoding="utf-8"?>
+<p:sld xmlns:a="http://schemas.openxmlformats.org/drawingml/2006/main" xmlns:r="http://schemas.openxmlformats.org/officeDocument/2006/relationships" xmlns:p="http://schemas.openxmlformats.org/presentationml/2006/main">
+  <p:cSld>
+    <p:spTree>
+      <p:nvGrpSpPr>
         <p:cNvPr id="1" name="">
           <a:extLst>
             <a:ext uri="{FF2B5EF4-FFF2-40B4-BE49-F238E27FC236}">
@@ -7054,7 +7736,7 @@
 </p:sld>
 </file>
 
-<file path=ppt/slides/slide16.xml><?xml version="1.0" encoding="utf-8"?>
+<file path=ppt/slides/slide17.xml><?xml version="1.0" encoding="utf-8"?>
 <p:sld xmlns:a="http://schemas.openxmlformats.org/drawingml/2006/main" xmlns:r="http://schemas.openxmlformats.org/officeDocument/2006/relationships" xmlns:p="http://schemas.openxmlformats.org/presentationml/2006/main">
   <p:cSld>
     <p:spTree>
@@ -7076,7 +7758,7 @@
           <p:cNvPr id="2" name="Title 1">
             <a:extLst>
               <a:ext uri="{FF2B5EF4-FFF2-40B4-BE49-F238E27FC236}">
-                <a16:creationId xmlns:a16="http://schemas.microsoft.com/office/drawing/2014/main" id="{F79AD936-1399-EE37-291B-F67F6F53B8C5}"/>
+                <a16:creationId xmlns:a16="http://schemas.microsoft.com/office/drawing/2014/main" id="{D00AB84B-5FC3-CF1A-03F1-04C6367834E8}"/>
               </a:ext>
             </a:extLst>
           </p:cNvPr>
@@ -7094,7 +7776,7 @@
           <a:p>
             <a:r>
               <a:rPr lang="en-US" dirty="0"/>
-              <a:t>SM Application</a:t>
+              <a:t>MC Application</a:t>
             </a:r>
           </a:p>
         </p:txBody>
@@ -7104,7 +7786,238 @@
           <p:cNvPr id="3" name="Content Placeholder 2">
             <a:extLst>
               <a:ext uri="{FF2B5EF4-FFF2-40B4-BE49-F238E27FC236}">
-                <a16:creationId xmlns:a16="http://schemas.microsoft.com/office/drawing/2014/main" id="{8FA57192-4680-17A3-7ACB-2A18544BDEC2}"/>
+                <a16:creationId xmlns:a16="http://schemas.microsoft.com/office/drawing/2014/main" id="{BAC3E0DA-47DF-D5E9-E482-73BFE2694185}"/>
+              </a:ext>
+            </a:extLst>
+          </p:cNvPr>
+          <p:cNvSpPr>
+            <a:spLocks noGrp="1"/>
+          </p:cNvSpPr>
+          <p:nvPr>
+            <p:ph idx="1"/>
+          </p:nvPr>
+        </p:nvSpPr>
+        <p:spPr/>
+        <p:txBody>
+          <a:bodyPr>
+            <a:normAutofit lnSpcReduction="10000"/>
+          </a:bodyPr>
+          <a:lstStyle/>
+          <a:p>
+            <a:pPr lvl="0"/>
+            <a:r>
+              <a:rPr lang="en-US" dirty="0"/>
+              <a:t>CPU+GPU outperforms GPU-Hybrid in 28 of 50 cases, achieving speedups of up to 14.21×.</a:t>
+            </a:r>
+          </a:p>
+          <a:p>
+            <a:pPr lvl="0"/>
+            <a:r>
+              <a:rPr lang="en-US" dirty="0"/>
+              <a:t>In the remaining cases where CPU+GPU is slower, the performance degradation is negligible, occurring only for short-running executions (i.e., less than 10 seconds).</a:t>
+            </a:r>
+          </a:p>
+          <a:p>
+            <a:pPr lvl="0"/>
+            <a:r>
+              <a:rPr lang="en-US" dirty="0"/>
+              <a:t>CPU+GPU consistently outperforms the CPU-only implementation, delivering speedups of up to 12.78×.</a:t>
+            </a:r>
+          </a:p>
+          <a:p>
+            <a:pPr lvl="0"/>
+            <a:endParaRPr lang="en-US" dirty="0">
+              <a:solidFill>
+                <a:srgbClr val="C00000"/>
+              </a:solidFill>
+            </a:endParaRPr>
+          </a:p>
+          <a:p>
+            <a:pPr lvl="0"/>
+            <a:r>
+              <a:rPr lang="en-US" dirty="0">
+                <a:solidFill>
+                  <a:srgbClr val="C00000"/>
+                </a:solidFill>
+              </a:rPr>
+              <a:t>select some dataset to show, which performs well not just ratio but also execution time</a:t>
+            </a:r>
+          </a:p>
+        </p:txBody>
+      </p:sp>
+    </p:spTree>
+    <p:extLst>
+      <p:ext uri="{BB962C8B-B14F-4D97-AF65-F5344CB8AC3E}">
+        <p14:creationId xmlns:p14="http://schemas.microsoft.com/office/powerpoint/2010/main" val="3907863780"/>
+      </p:ext>
+    </p:extLst>
+  </p:cSld>
+  <p:clrMapOvr>
+    <a:masterClrMapping/>
+  </p:clrMapOvr>
+</p:sld>
+</file>
+
+<file path=ppt/slides/slide18.xml><?xml version="1.0" encoding="utf-8"?>
+<p:sld xmlns:a="http://schemas.openxmlformats.org/drawingml/2006/main" xmlns:r="http://schemas.openxmlformats.org/officeDocument/2006/relationships" xmlns:p="http://schemas.openxmlformats.org/presentationml/2006/main">
+  <p:cSld>
+    <p:spTree>
+      <p:nvGrpSpPr>
+        <p:cNvPr id="1" name=""/>
+        <p:cNvGrpSpPr/>
+        <p:nvPr/>
+      </p:nvGrpSpPr>
+      <p:grpSpPr>
+        <a:xfrm>
+          <a:off x="0" y="0"/>
+          <a:ext cx="0" cy="0"/>
+          <a:chOff x="0" y="0"/>
+          <a:chExt cx="0" cy="0"/>
+        </a:xfrm>
+      </p:grpSpPr>
+      <p:sp>
+        <p:nvSpPr>
+          <p:cNvPr id="2" name="Title 1">
+            <a:extLst>
+              <a:ext uri="{FF2B5EF4-FFF2-40B4-BE49-F238E27FC236}">
+                <a16:creationId xmlns:a16="http://schemas.microsoft.com/office/drawing/2014/main" id="{2087E04A-BBFD-0C94-7E96-DE0D38F9AC78}"/>
+              </a:ext>
+            </a:extLst>
+          </p:cNvPr>
+          <p:cNvSpPr>
+            <a:spLocks noGrp="1"/>
+          </p:cNvSpPr>
+          <p:nvPr>
+            <p:ph type="title"/>
+          </p:nvPr>
+        </p:nvSpPr>
+        <p:spPr/>
+        <p:txBody>
+          <a:bodyPr/>
+          <a:lstStyle/>
+          <a:p>
+            <a:r>
+              <a:rPr lang="en-US" dirty="0"/>
+              <a:t>Dataset Selection Reminder </a:t>
+            </a:r>
+          </a:p>
+        </p:txBody>
+      </p:sp>
+      <p:sp>
+        <p:nvSpPr>
+          <p:cNvPr id="3" name="Content Placeholder 2">
+            <a:extLst>
+              <a:ext uri="{FF2B5EF4-FFF2-40B4-BE49-F238E27FC236}">
+                <a16:creationId xmlns:a16="http://schemas.microsoft.com/office/drawing/2014/main" id="{EA52B759-8633-48D2-B6C1-6C2C8146D9EA}"/>
+              </a:ext>
+            </a:extLst>
+          </p:cNvPr>
+          <p:cNvSpPr>
+            <a:spLocks noGrp="1"/>
+          </p:cNvSpPr>
+          <p:nvPr>
+            <p:ph idx="1"/>
+          </p:nvPr>
+        </p:nvSpPr>
+        <p:spPr/>
+        <p:txBody>
+          <a:bodyPr>
+            <a:normAutofit fontScale="92500"/>
+          </a:bodyPr>
+          <a:lstStyle/>
+          <a:p>
+            <a:r>
+              <a:rPr lang="en-US" dirty="0"/>
+              <a:t>Redo eta selection for MC, it may not be 2000 anymore. If possible, find why old time results are longer than what they should be </a:t>
+            </a:r>
+          </a:p>
+          <a:p>
+            <a:r>
+              <a:rPr lang="en-US" dirty="0"/>
+              <a:t>In experiments, we cannot have each application with a separate set of datasets. Reviewers will argue that we are selecting favorable datasets for each application, and will ask you to try some dataset in application 1 that you did not use in application 2 on application 2 in revision, which can perform poor causing rejection after revision.</a:t>
+            </a:r>
+          </a:p>
+          <a:p>
+            <a:r>
+              <a:rPr lang="en-US" dirty="0"/>
+              <a:t>Normal people will do what reviewers expect: use a common set of datasets, like in Table 1. Then each application reports performance on datasets in Table 1.</a:t>
+            </a:r>
+          </a:p>
+          <a:p>
+            <a:endParaRPr lang="en-US" dirty="0"/>
+          </a:p>
+        </p:txBody>
+      </p:sp>
+    </p:spTree>
+    <p:extLst>
+      <p:ext uri="{BB962C8B-B14F-4D97-AF65-F5344CB8AC3E}">
+        <p14:creationId xmlns:p14="http://schemas.microsoft.com/office/powerpoint/2010/main" val="3641683647"/>
+      </p:ext>
+    </p:extLst>
+  </p:cSld>
+  <p:clrMapOvr>
+    <a:masterClrMapping/>
+  </p:clrMapOvr>
+</p:sld>
+</file>
+
+<file path=ppt/slides/slide19.xml><?xml version="1.0" encoding="utf-8"?>
+<p:sld xmlns:a="http://schemas.openxmlformats.org/drawingml/2006/main" xmlns:r="http://schemas.openxmlformats.org/officeDocument/2006/relationships" xmlns:p="http://schemas.openxmlformats.org/presentationml/2006/main">
+  <p:cSld>
+    <p:spTree>
+      <p:nvGrpSpPr>
+        <p:cNvPr id="1" name="">
+          <a:extLst>
+            <a:ext uri="{FF2B5EF4-FFF2-40B4-BE49-F238E27FC236}">
+              <a16:creationId xmlns:a16="http://schemas.microsoft.com/office/drawing/2014/main" id="{40E7D9F4-5A22-B2FF-C0ED-7C904583DBA0}"/>
+            </a:ext>
+          </a:extLst>
+        </p:cNvPr>
+        <p:cNvGrpSpPr/>
+        <p:nvPr/>
+      </p:nvGrpSpPr>
+      <p:grpSpPr>
+        <a:xfrm>
+          <a:off x="0" y="0"/>
+          <a:ext cx="0" cy="0"/>
+          <a:chOff x="0" y="0"/>
+          <a:chExt cx="0" cy="0"/>
+        </a:xfrm>
+      </p:grpSpPr>
+      <p:sp>
+        <p:nvSpPr>
+          <p:cNvPr id="2" name="Title 1">
+            <a:extLst>
+              <a:ext uri="{FF2B5EF4-FFF2-40B4-BE49-F238E27FC236}">
+                <a16:creationId xmlns:a16="http://schemas.microsoft.com/office/drawing/2014/main" id="{57F10B4E-9268-486A-EBA8-E276AE68ABE0}"/>
+              </a:ext>
+            </a:extLst>
+          </p:cNvPr>
+          <p:cNvSpPr>
+            <a:spLocks noGrp="1"/>
+          </p:cNvSpPr>
+          <p:nvPr>
+            <p:ph type="title"/>
+          </p:nvPr>
+        </p:nvSpPr>
+        <p:spPr/>
+        <p:txBody>
+          <a:bodyPr/>
+          <a:lstStyle/>
+          <a:p>
+            <a:r>
+              <a:rPr lang="en-US" dirty="0"/>
+              <a:t>Dataset Selection Reminder </a:t>
+            </a:r>
+          </a:p>
+        </p:txBody>
+      </p:sp>
+      <p:sp>
+        <p:nvSpPr>
+          <p:cNvPr id="3" name="Content Placeholder 2">
+            <a:extLst>
+              <a:ext uri="{FF2B5EF4-FFF2-40B4-BE49-F238E27FC236}">
+                <a16:creationId xmlns:a16="http://schemas.microsoft.com/office/drawing/2014/main" id="{8A3BFD78-8A4E-5E54-4238-7AA35DD401B6}"/>
               </a:ext>
             </a:extLst>
           </p:cNvPr>
@@ -7122,11 +8035,1487 @@
           <a:p>
             <a:r>
               <a:rPr lang="en-US" dirty="0"/>
-              <a:t>G2-AIMD can fail (OOM in 2 cases), and always slower than GPU-Layered, up to 1.98x</a:t>
-            </a:r>
-          </a:p>
-          <a:p>
+              <a:t>You have to select favorable datasets for all 3 applications. The only exception is that you can claim QC cannot run on datasets in Table 1 due to </a:t>
+            </a:r>
+            <a:r>
+              <a:rPr lang="en-US" dirty="0" err="1"/>
+              <a:t>Guimu’s</a:t>
+            </a:r>
+            <a:r>
+              <a:rPr lang="en-US" dirty="0"/>
+              <a:t> 2-hop device memory CSR, so you pick smaller graphs that QC can run</a:t>
+            </a:r>
+          </a:p>
+          <a:p>
+            <a:r>
+              <a:rPr lang="en-US" dirty="0"/>
+              <a:t>You can say that QC can be improved by k-means binning + GPU streams + CPU subgraph construction pipelining, but will be future work. So let’s assume this will be considered/accepted/passed by reviewers. Let’s at least pick Table 1 to be used by MC and SM, first 2 applications.</a:t>
+            </a:r>
+          </a:p>
+        </p:txBody>
+      </p:sp>
+    </p:spTree>
+    <p:extLst>
+      <p:ext uri="{BB962C8B-B14F-4D97-AF65-F5344CB8AC3E}">
+        <p14:creationId xmlns:p14="http://schemas.microsoft.com/office/powerpoint/2010/main" val="1587627556"/>
+      </p:ext>
+    </p:extLst>
+  </p:cSld>
+  <p:clrMapOvr>
+    <a:masterClrMapping/>
+  </p:clrMapOvr>
+</p:sld>
+</file>
+
+<file path=ppt/slides/slide2.xml><?xml version="1.0" encoding="utf-8"?>
+<p:sld xmlns:a="http://schemas.openxmlformats.org/drawingml/2006/main" xmlns:r="http://schemas.openxmlformats.org/officeDocument/2006/relationships" xmlns:p="http://schemas.openxmlformats.org/presentationml/2006/main">
+  <p:cSld>
+    <p:spTree>
+      <p:nvGrpSpPr>
+        <p:cNvPr id="1" name=""/>
+        <p:cNvGrpSpPr/>
+        <p:nvPr/>
+      </p:nvGrpSpPr>
+      <p:grpSpPr>
+        <a:xfrm>
+          <a:off x="0" y="0"/>
+          <a:ext cx="0" cy="0"/>
+          <a:chOff x="0" y="0"/>
+          <a:chExt cx="0" cy="0"/>
+        </a:xfrm>
+      </p:grpSpPr>
+      <p:sp>
+        <p:nvSpPr>
+          <p:cNvPr id="2" name="Title 1">
+            <a:extLst>
+              <a:ext uri="{FF2B5EF4-FFF2-40B4-BE49-F238E27FC236}">
+                <a16:creationId xmlns:a16="http://schemas.microsoft.com/office/drawing/2014/main" id="{404C8055-AC4B-5124-0509-8DA608A7DA3E}"/>
+              </a:ext>
+            </a:extLst>
+          </p:cNvPr>
+          <p:cNvSpPr>
+            <a:spLocks noGrp="1"/>
+          </p:cNvSpPr>
+          <p:nvPr>
+            <p:ph type="title"/>
+          </p:nvPr>
+        </p:nvSpPr>
+        <p:spPr/>
+        <p:txBody>
+          <a:bodyPr/>
+          <a:lstStyle/>
+          <a:p>
+            <a:r>
+              <a:rPr lang="en-US"/>
+              <a:t>Host Resident Buffer</a:t>
+            </a:r>
             <a:endParaRPr lang="en-US" dirty="0"/>
+          </a:p>
+        </p:txBody>
+      </p:sp>
+      <p:sp>
+        <p:nvSpPr>
+          <p:cNvPr id="3" name="Content Placeholder 2">
+            <a:extLst>
+              <a:ext uri="{FF2B5EF4-FFF2-40B4-BE49-F238E27FC236}">
+                <a16:creationId xmlns:a16="http://schemas.microsoft.com/office/drawing/2014/main" id="{D1F3F9EF-384A-6025-F4AC-E25DAFB4FCA0}"/>
+              </a:ext>
+            </a:extLst>
+          </p:cNvPr>
+          <p:cNvSpPr>
+            <a:spLocks noGrp="1"/>
+          </p:cNvSpPr>
+          <p:nvPr>
+            <p:ph idx="1"/>
+          </p:nvPr>
+        </p:nvSpPr>
+        <p:spPr>
+          <a:xfrm>
+            <a:off x="838200" y="1825625"/>
+            <a:ext cx="10515600" cy="1853734"/>
+          </a:xfrm>
+        </p:spPr>
+        <p:txBody>
+          <a:bodyPr/>
+          <a:lstStyle/>
+          <a:p>
+            <a:r>
+              <a:rPr lang="en-US"/>
+              <a:t>Create with </a:t>
+            </a:r>
+            <a:r>
+              <a:rPr lang="en-US" b="1"/>
+              <a:t>new</a:t>
+            </a:r>
+            <a:r>
+              <a:rPr lang="en-US"/>
+              <a:t> </a:t>
+            </a:r>
+            <a:endParaRPr lang="en-US" dirty="0"/>
+          </a:p>
+          <a:p>
+            <a:r>
+              <a:rPr lang="en-US"/>
+              <a:t>After returning from kernel, copy data to/from host buffer</a:t>
+            </a:r>
+            <a:endParaRPr lang="en-US" dirty="0"/>
+          </a:p>
+          <a:p>
+            <a:r>
+              <a:rPr lang="en-US"/>
+              <a:t>Bulk copy data instead of copying each subgraph</a:t>
+            </a:r>
+            <a:endParaRPr lang="en-US" dirty="0"/>
+          </a:p>
+          <a:p>
+            <a:pPr marL="0" indent="0">
+              <a:buNone/>
+            </a:pPr>
+            <a:endParaRPr lang="en-US" dirty="0"/>
+          </a:p>
+        </p:txBody>
+      </p:sp>
+      <p:sp>
+        <p:nvSpPr>
+          <p:cNvPr id="5" name="TextBox 4">
+            <a:extLst>
+              <a:ext uri="{FF2B5EF4-FFF2-40B4-BE49-F238E27FC236}">
+                <a16:creationId xmlns:a16="http://schemas.microsoft.com/office/drawing/2014/main" id="{91B173A4-D879-8F03-F25D-E7815C89E0E5}"/>
+              </a:ext>
+            </a:extLst>
+          </p:cNvPr>
+          <p:cNvSpPr txBox="1"/>
+          <p:nvPr/>
+        </p:nvSpPr>
+        <p:spPr>
+          <a:xfrm>
+            <a:off x="1135117" y="4942490"/>
+            <a:ext cx="6096000" cy="923330"/>
+          </a:xfrm>
+          <a:prstGeom prst="rect">
+            <a:avLst/>
+          </a:prstGeom>
+          <a:noFill/>
+        </p:spPr>
+        <p:txBody>
+          <a:bodyPr wrap="square">
+            <a:spAutoFit/>
+          </a:bodyPr>
+          <a:lstStyle/>
+          <a:p>
+            <a:r>
+              <a:rPr lang="en-US" b="1" dirty="0" err="1"/>
+              <a:t>wikipedia_link_ru</a:t>
+            </a:r>
+            <a:endParaRPr lang="en-US" b="1" dirty="0"/>
+          </a:p>
+          <a:p>
+            <a:r>
+              <a:rPr lang="en-US"/>
+              <a:t>total run time: 76.6 sec </a:t>
+            </a:r>
+            <a:endParaRPr lang="en-US" dirty="0"/>
+          </a:p>
+          <a:p>
+            <a:r>
+              <a:rPr lang="en-US"/>
+              <a:t>host buffer read</a:t>
+            </a:r>
+            <a:r>
+              <a:rPr lang="en-US" dirty="0"/>
+              <a:t>/</a:t>
+            </a:r>
+            <a:r>
+              <a:rPr lang="en-US"/>
+              <a:t>write: 1.3 sec</a:t>
+            </a:r>
+            <a:endParaRPr lang="en-US" dirty="0"/>
+          </a:p>
+        </p:txBody>
+      </p:sp>
+      <p:sp>
+        <p:nvSpPr>
+          <p:cNvPr id="7" name="Rectangle 6">
+            <a:extLst>
+              <a:ext uri="{FF2B5EF4-FFF2-40B4-BE49-F238E27FC236}">
+                <a16:creationId xmlns:a16="http://schemas.microsoft.com/office/drawing/2014/main" id="{ADEFBDFB-41DF-7F29-62B9-ECD1A2DD775A}"/>
+              </a:ext>
+            </a:extLst>
+          </p:cNvPr>
+          <p:cNvSpPr/>
+          <p:nvPr/>
+        </p:nvSpPr>
+        <p:spPr>
+          <a:xfrm>
+            <a:off x="6369270" y="4001294"/>
+            <a:ext cx="3909848" cy="367862"/>
+          </a:xfrm>
+          <a:prstGeom prst="rect">
+            <a:avLst/>
+          </a:prstGeom>
+        </p:spPr>
+        <p:style>
+          <a:lnRef idx="2">
+            <a:schemeClr val="dk1"/>
+          </a:lnRef>
+          <a:fillRef idx="1">
+            <a:schemeClr val="lt1"/>
+          </a:fillRef>
+          <a:effectRef idx="0">
+            <a:schemeClr val="dk1"/>
+          </a:effectRef>
+          <a:fontRef idx="minor">
+            <a:schemeClr val="dk1"/>
+          </a:fontRef>
+        </p:style>
+        <p:txBody>
+          <a:bodyPr rtlCol="0" anchor="ctr"/>
+          <a:lstStyle/>
+          <a:p>
+            <a:pPr algn="ctr"/>
+            <a:endParaRPr lang="en-US" dirty="0"/>
+          </a:p>
+        </p:txBody>
+      </p:sp>
+      <p:sp>
+        <p:nvSpPr>
+          <p:cNvPr id="8" name="Rectangle 7">
+            <a:extLst>
+              <a:ext uri="{FF2B5EF4-FFF2-40B4-BE49-F238E27FC236}">
+                <a16:creationId xmlns:a16="http://schemas.microsoft.com/office/drawing/2014/main" id="{4CCA4AD0-905A-73B5-2396-1B60E26A33B2}"/>
+              </a:ext>
+            </a:extLst>
+          </p:cNvPr>
+          <p:cNvSpPr/>
+          <p:nvPr/>
+        </p:nvSpPr>
+        <p:spPr>
+          <a:xfrm>
+            <a:off x="6369269" y="4691091"/>
+            <a:ext cx="5281447" cy="367862"/>
+          </a:xfrm>
+          <a:prstGeom prst="rect">
+            <a:avLst/>
+          </a:prstGeom>
+        </p:spPr>
+        <p:style>
+          <a:lnRef idx="2">
+            <a:schemeClr val="dk1"/>
+          </a:lnRef>
+          <a:fillRef idx="1">
+            <a:schemeClr val="lt1"/>
+          </a:fillRef>
+          <a:effectRef idx="0">
+            <a:schemeClr val="dk1"/>
+          </a:effectRef>
+          <a:fontRef idx="minor">
+            <a:schemeClr val="dk1"/>
+          </a:fontRef>
+        </p:style>
+        <p:txBody>
+          <a:bodyPr rtlCol="0" anchor="ctr"/>
+          <a:lstStyle/>
+          <a:p>
+            <a:pPr algn="ctr"/>
+            <a:endParaRPr lang="en-US" dirty="0"/>
+          </a:p>
+        </p:txBody>
+      </p:sp>
+      <p:sp>
+        <p:nvSpPr>
+          <p:cNvPr id="9" name="Rectangle 8">
+            <a:extLst>
+              <a:ext uri="{FF2B5EF4-FFF2-40B4-BE49-F238E27FC236}">
+                <a16:creationId xmlns:a16="http://schemas.microsoft.com/office/drawing/2014/main" id="{B997D780-A2CF-ADE2-2254-21FE67E594F0}"/>
+              </a:ext>
+            </a:extLst>
+          </p:cNvPr>
+          <p:cNvSpPr/>
+          <p:nvPr/>
+        </p:nvSpPr>
+        <p:spPr>
+          <a:xfrm>
+            <a:off x="6453353" y="4051803"/>
+            <a:ext cx="178676" cy="266844"/>
+          </a:xfrm>
+          <a:prstGeom prst="rect">
+            <a:avLst/>
+          </a:prstGeom>
+        </p:spPr>
+        <p:style>
+          <a:lnRef idx="2">
+            <a:schemeClr val="accent1">
+              <a:shade val="15000"/>
+            </a:schemeClr>
+          </a:lnRef>
+          <a:fillRef idx="1">
+            <a:schemeClr val="accent1"/>
+          </a:fillRef>
+          <a:effectRef idx="0">
+            <a:schemeClr val="accent1"/>
+          </a:effectRef>
+          <a:fontRef idx="minor">
+            <a:schemeClr val="lt1"/>
+          </a:fontRef>
+        </p:style>
+        <p:txBody>
+          <a:bodyPr rtlCol="0" anchor="ctr"/>
+          <a:lstStyle/>
+          <a:p>
+            <a:pPr algn="ctr"/>
+            <a:endParaRPr lang="en-US"/>
+          </a:p>
+        </p:txBody>
+      </p:sp>
+      <p:sp>
+        <p:nvSpPr>
+          <p:cNvPr id="10" name="Rectangle 9">
+            <a:extLst>
+              <a:ext uri="{FF2B5EF4-FFF2-40B4-BE49-F238E27FC236}">
+                <a16:creationId xmlns:a16="http://schemas.microsoft.com/office/drawing/2014/main" id="{4DF4DC7D-F514-61BA-B92D-3CAC78907D58}"/>
+              </a:ext>
+            </a:extLst>
+          </p:cNvPr>
+          <p:cNvSpPr/>
+          <p:nvPr/>
+        </p:nvSpPr>
+        <p:spPr>
+          <a:xfrm>
+            <a:off x="6716112" y="4051803"/>
+            <a:ext cx="178676" cy="266844"/>
+          </a:xfrm>
+          <a:prstGeom prst="rect">
+            <a:avLst/>
+          </a:prstGeom>
+        </p:spPr>
+        <p:style>
+          <a:lnRef idx="2">
+            <a:schemeClr val="accent1">
+              <a:shade val="15000"/>
+            </a:schemeClr>
+          </a:lnRef>
+          <a:fillRef idx="1">
+            <a:schemeClr val="accent1"/>
+          </a:fillRef>
+          <a:effectRef idx="0">
+            <a:schemeClr val="accent1"/>
+          </a:effectRef>
+          <a:fontRef idx="minor">
+            <a:schemeClr val="lt1"/>
+          </a:fontRef>
+        </p:style>
+        <p:txBody>
+          <a:bodyPr rtlCol="0" anchor="ctr"/>
+          <a:lstStyle/>
+          <a:p>
+            <a:pPr algn="ctr"/>
+            <a:endParaRPr lang="en-US"/>
+          </a:p>
+        </p:txBody>
+      </p:sp>
+      <p:sp>
+        <p:nvSpPr>
+          <p:cNvPr id="11" name="Rectangle 10">
+            <a:extLst>
+              <a:ext uri="{FF2B5EF4-FFF2-40B4-BE49-F238E27FC236}">
+                <a16:creationId xmlns:a16="http://schemas.microsoft.com/office/drawing/2014/main" id="{8366C9C8-6328-FFE2-28BC-DDA56EF2F51E}"/>
+              </a:ext>
+            </a:extLst>
+          </p:cNvPr>
+          <p:cNvSpPr/>
+          <p:nvPr/>
+        </p:nvSpPr>
+        <p:spPr>
+          <a:xfrm>
+            <a:off x="6978871" y="4051803"/>
+            <a:ext cx="178676" cy="266844"/>
+          </a:xfrm>
+          <a:prstGeom prst="rect">
+            <a:avLst/>
+          </a:prstGeom>
+        </p:spPr>
+        <p:style>
+          <a:lnRef idx="2">
+            <a:schemeClr val="accent1">
+              <a:shade val="15000"/>
+            </a:schemeClr>
+          </a:lnRef>
+          <a:fillRef idx="1">
+            <a:schemeClr val="accent1"/>
+          </a:fillRef>
+          <a:effectRef idx="0">
+            <a:schemeClr val="accent1"/>
+          </a:effectRef>
+          <a:fontRef idx="minor">
+            <a:schemeClr val="lt1"/>
+          </a:fontRef>
+        </p:style>
+        <p:txBody>
+          <a:bodyPr rtlCol="0" anchor="ctr"/>
+          <a:lstStyle/>
+          <a:p>
+            <a:pPr algn="ctr"/>
+            <a:endParaRPr lang="en-US"/>
+          </a:p>
+        </p:txBody>
+      </p:sp>
+      <p:sp>
+        <p:nvSpPr>
+          <p:cNvPr id="12" name="Rectangle 11">
+            <a:extLst>
+              <a:ext uri="{FF2B5EF4-FFF2-40B4-BE49-F238E27FC236}">
+                <a16:creationId xmlns:a16="http://schemas.microsoft.com/office/drawing/2014/main" id="{A97CB73C-AF4D-75B5-9FF0-C8A040C2A12F}"/>
+              </a:ext>
+            </a:extLst>
+          </p:cNvPr>
+          <p:cNvSpPr/>
+          <p:nvPr/>
+        </p:nvSpPr>
+        <p:spPr>
+          <a:xfrm>
+            <a:off x="7241630" y="4051803"/>
+            <a:ext cx="178676" cy="266844"/>
+          </a:xfrm>
+          <a:prstGeom prst="rect">
+            <a:avLst/>
+          </a:prstGeom>
+        </p:spPr>
+        <p:style>
+          <a:lnRef idx="2">
+            <a:schemeClr val="accent1">
+              <a:shade val="15000"/>
+            </a:schemeClr>
+          </a:lnRef>
+          <a:fillRef idx="1">
+            <a:schemeClr val="accent1"/>
+          </a:fillRef>
+          <a:effectRef idx="0">
+            <a:schemeClr val="accent1"/>
+          </a:effectRef>
+          <a:fontRef idx="minor">
+            <a:schemeClr val="lt1"/>
+          </a:fontRef>
+        </p:style>
+        <p:txBody>
+          <a:bodyPr rtlCol="0" anchor="ctr"/>
+          <a:lstStyle/>
+          <a:p>
+            <a:pPr algn="ctr"/>
+            <a:endParaRPr lang="en-US"/>
+          </a:p>
+        </p:txBody>
+      </p:sp>
+      <p:sp>
+        <p:nvSpPr>
+          <p:cNvPr id="13" name="Rectangle 12">
+            <a:extLst>
+              <a:ext uri="{FF2B5EF4-FFF2-40B4-BE49-F238E27FC236}">
+                <a16:creationId xmlns:a16="http://schemas.microsoft.com/office/drawing/2014/main" id="{6DDC9702-9889-7364-6CE6-71121028C96E}"/>
+              </a:ext>
+            </a:extLst>
+          </p:cNvPr>
+          <p:cNvSpPr/>
+          <p:nvPr/>
+        </p:nvSpPr>
+        <p:spPr>
+          <a:xfrm>
+            <a:off x="7504389" y="4051803"/>
+            <a:ext cx="178676" cy="266844"/>
+          </a:xfrm>
+          <a:prstGeom prst="rect">
+            <a:avLst/>
+          </a:prstGeom>
+        </p:spPr>
+        <p:style>
+          <a:lnRef idx="2">
+            <a:schemeClr val="accent1">
+              <a:shade val="15000"/>
+            </a:schemeClr>
+          </a:lnRef>
+          <a:fillRef idx="1">
+            <a:schemeClr val="accent1"/>
+          </a:fillRef>
+          <a:effectRef idx="0">
+            <a:schemeClr val="accent1"/>
+          </a:effectRef>
+          <a:fontRef idx="minor">
+            <a:schemeClr val="lt1"/>
+          </a:fontRef>
+        </p:style>
+        <p:txBody>
+          <a:bodyPr rtlCol="0" anchor="ctr"/>
+          <a:lstStyle/>
+          <a:p>
+            <a:pPr algn="ctr"/>
+            <a:endParaRPr lang="en-US"/>
+          </a:p>
+        </p:txBody>
+      </p:sp>
+      <p:sp>
+        <p:nvSpPr>
+          <p:cNvPr id="14" name="Rectangle 13">
+            <a:extLst>
+              <a:ext uri="{FF2B5EF4-FFF2-40B4-BE49-F238E27FC236}">
+                <a16:creationId xmlns:a16="http://schemas.microsoft.com/office/drawing/2014/main" id="{9045F749-FD06-0D3D-7909-D2347A5FE9F5}"/>
+              </a:ext>
+            </a:extLst>
+          </p:cNvPr>
+          <p:cNvSpPr/>
+          <p:nvPr/>
+        </p:nvSpPr>
+        <p:spPr>
+          <a:xfrm>
+            <a:off x="7767148" y="4051803"/>
+            <a:ext cx="178676" cy="266844"/>
+          </a:xfrm>
+          <a:prstGeom prst="rect">
+            <a:avLst/>
+          </a:prstGeom>
+        </p:spPr>
+        <p:style>
+          <a:lnRef idx="2">
+            <a:schemeClr val="accent1">
+              <a:shade val="15000"/>
+            </a:schemeClr>
+          </a:lnRef>
+          <a:fillRef idx="1">
+            <a:schemeClr val="accent1"/>
+          </a:fillRef>
+          <a:effectRef idx="0">
+            <a:schemeClr val="accent1"/>
+          </a:effectRef>
+          <a:fontRef idx="minor">
+            <a:schemeClr val="lt1"/>
+          </a:fontRef>
+        </p:style>
+        <p:txBody>
+          <a:bodyPr rtlCol="0" anchor="ctr"/>
+          <a:lstStyle/>
+          <a:p>
+            <a:pPr algn="ctr"/>
+            <a:endParaRPr lang="en-US"/>
+          </a:p>
+        </p:txBody>
+      </p:sp>
+      <p:sp>
+        <p:nvSpPr>
+          <p:cNvPr id="15" name="Rectangle 14">
+            <a:extLst>
+              <a:ext uri="{FF2B5EF4-FFF2-40B4-BE49-F238E27FC236}">
+                <a16:creationId xmlns:a16="http://schemas.microsoft.com/office/drawing/2014/main" id="{2ABB24A6-520A-8390-DD38-29421AA7B233}"/>
+              </a:ext>
+            </a:extLst>
+          </p:cNvPr>
+          <p:cNvSpPr/>
+          <p:nvPr/>
+        </p:nvSpPr>
+        <p:spPr>
+          <a:xfrm>
+            <a:off x="7252141" y="4748964"/>
+            <a:ext cx="178676" cy="266844"/>
+          </a:xfrm>
+          <a:prstGeom prst="rect">
+            <a:avLst/>
+          </a:prstGeom>
+        </p:spPr>
+        <p:style>
+          <a:lnRef idx="2">
+            <a:schemeClr val="accent1">
+              <a:shade val="15000"/>
+            </a:schemeClr>
+          </a:lnRef>
+          <a:fillRef idx="1">
+            <a:schemeClr val="accent1"/>
+          </a:fillRef>
+          <a:effectRef idx="0">
+            <a:schemeClr val="accent1"/>
+          </a:effectRef>
+          <a:fontRef idx="minor">
+            <a:schemeClr val="lt1"/>
+          </a:fontRef>
+        </p:style>
+        <p:txBody>
+          <a:bodyPr rtlCol="0" anchor="ctr"/>
+          <a:lstStyle/>
+          <a:p>
+            <a:pPr algn="ctr"/>
+            <a:endParaRPr lang="en-US"/>
+          </a:p>
+        </p:txBody>
+      </p:sp>
+      <p:sp>
+        <p:nvSpPr>
+          <p:cNvPr id="16" name="Rectangle 15">
+            <a:extLst>
+              <a:ext uri="{FF2B5EF4-FFF2-40B4-BE49-F238E27FC236}">
+                <a16:creationId xmlns:a16="http://schemas.microsoft.com/office/drawing/2014/main" id="{F4A72DB4-0476-BAE8-979B-CA1FA6C5B484}"/>
+              </a:ext>
+            </a:extLst>
+          </p:cNvPr>
+          <p:cNvSpPr/>
+          <p:nvPr/>
+        </p:nvSpPr>
+        <p:spPr>
+          <a:xfrm>
+            <a:off x="7514900" y="4748964"/>
+            <a:ext cx="178676" cy="266844"/>
+          </a:xfrm>
+          <a:prstGeom prst="rect">
+            <a:avLst/>
+          </a:prstGeom>
+        </p:spPr>
+        <p:style>
+          <a:lnRef idx="2">
+            <a:schemeClr val="accent1">
+              <a:shade val="15000"/>
+            </a:schemeClr>
+          </a:lnRef>
+          <a:fillRef idx="1">
+            <a:schemeClr val="accent1"/>
+          </a:fillRef>
+          <a:effectRef idx="0">
+            <a:schemeClr val="accent1"/>
+          </a:effectRef>
+          <a:fontRef idx="minor">
+            <a:schemeClr val="lt1"/>
+          </a:fontRef>
+        </p:style>
+        <p:txBody>
+          <a:bodyPr rtlCol="0" anchor="ctr"/>
+          <a:lstStyle/>
+          <a:p>
+            <a:pPr algn="ctr"/>
+            <a:endParaRPr lang="en-US"/>
+          </a:p>
+        </p:txBody>
+      </p:sp>
+      <p:sp>
+        <p:nvSpPr>
+          <p:cNvPr id="17" name="Rectangle 16">
+            <a:extLst>
+              <a:ext uri="{FF2B5EF4-FFF2-40B4-BE49-F238E27FC236}">
+                <a16:creationId xmlns:a16="http://schemas.microsoft.com/office/drawing/2014/main" id="{5E183DA3-803D-4514-6E30-05674FA14CED}"/>
+              </a:ext>
+            </a:extLst>
+          </p:cNvPr>
+          <p:cNvSpPr/>
+          <p:nvPr/>
+        </p:nvSpPr>
+        <p:spPr>
+          <a:xfrm>
+            <a:off x="7777659" y="4748964"/>
+            <a:ext cx="178676" cy="266844"/>
+          </a:xfrm>
+          <a:prstGeom prst="rect">
+            <a:avLst/>
+          </a:prstGeom>
+        </p:spPr>
+        <p:style>
+          <a:lnRef idx="2">
+            <a:schemeClr val="accent1">
+              <a:shade val="15000"/>
+            </a:schemeClr>
+          </a:lnRef>
+          <a:fillRef idx="1">
+            <a:schemeClr val="accent1"/>
+          </a:fillRef>
+          <a:effectRef idx="0">
+            <a:schemeClr val="accent1"/>
+          </a:effectRef>
+          <a:fontRef idx="minor">
+            <a:schemeClr val="lt1"/>
+          </a:fontRef>
+        </p:style>
+        <p:txBody>
+          <a:bodyPr rtlCol="0" anchor="ctr"/>
+          <a:lstStyle/>
+          <a:p>
+            <a:pPr algn="ctr"/>
+            <a:endParaRPr lang="en-US"/>
+          </a:p>
+        </p:txBody>
+      </p:sp>
+      <p:sp>
+        <p:nvSpPr>
+          <p:cNvPr id="18" name="Rectangle 17">
+            <a:extLst>
+              <a:ext uri="{FF2B5EF4-FFF2-40B4-BE49-F238E27FC236}">
+                <a16:creationId xmlns:a16="http://schemas.microsoft.com/office/drawing/2014/main" id="{7A77F7D2-A995-61AE-E9F2-6048D1D7A137}"/>
+              </a:ext>
+            </a:extLst>
+          </p:cNvPr>
+          <p:cNvSpPr/>
+          <p:nvPr/>
+        </p:nvSpPr>
+        <p:spPr>
+          <a:xfrm>
+            <a:off x="8040418" y="4748964"/>
+            <a:ext cx="178676" cy="266844"/>
+          </a:xfrm>
+          <a:prstGeom prst="rect">
+            <a:avLst/>
+          </a:prstGeom>
+        </p:spPr>
+        <p:style>
+          <a:lnRef idx="2">
+            <a:schemeClr val="accent1">
+              <a:shade val="15000"/>
+            </a:schemeClr>
+          </a:lnRef>
+          <a:fillRef idx="1">
+            <a:schemeClr val="accent1"/>
+          </a:fillRef>
+          <a:effectRef idx="0">
+            <a:schemeClr val="accent1"/>
+          </a:effectRef>
+          <a:fontRef idx="minor">
+            <a:schemeClr val="lt1"/>
+          </a:fontRef>
+        </p:style>
+        <p:txBody>
+          <a:bodyPr rtlCol="0" anchor="ctr"/>
+          <a:lstStyle/>
+          <a:p>
+            <a:pPr algn="ctr"/>
+            <a:endParaRPr lang="en-US"/>
+          </a:p>
+        </p:txBody>
+      </p:sp>
+      <p:sp>
+        <p:nvSpPr>
+          <p:cNvPr id="19" name="Rectangle 18">
+            <a:extLst>
+              <a:ext uri="{FF2B5EF4-FFF2-40B4-BE49-F238E27FC236}">
+                <a16:creationId xmlns:a16="http://schemas.microsoft.com/office/drawing/2014/main" id="{A890374B-097C-5122-CBAD-2915914995C4}"/>
+              </a:ext>
+            </a:extLst>
+          </p:cNvPr>
+          <p:cNvSpPr/>
+          <p:nvPr/>
+        </p:nvSpPr>
+        <p:spPr>
+          <a:xfrm>
+            <a:off x="8303177" y="4748964"/>
+            <a:ext cx="178676" cy="266844"/>
+          </a:xfrm>
+          <a:prstGeom prst="rect">
+            <a:avLst/>
+          </a:prstGeom>
+        </p:spPr>
+        <p:style>
+          <a:lnRef idx="2">
+            <a:schemeClr val="accent1">
+              <a:shade val="15000"/>
+            </a:schemeClr>
+          </a:lnRef>
+          <a:fillRef idx="1">
+            <a:schemeClr val="accent1"/>
+          </a:fillRef>
+          <a:effectRef idx="0">
+            <a:schemeClr val="accent1"/>
+          </a:effectRef>
+          <a:fontRef idx="minor">
+            <a:schemeClr val="lt1"/>
+          </a:fontRef>
+        </p:style>
+        <p:txBody>
+          <a:bodyPr rtlCol="0" anchor="ctr"/>
+          <a:lstStyle/>
+          <a:p>
+            <a:pPr algn="ctr"/>
+            <a:endParaRPr lang="en-US"/>
+          </a:p>
+        </p:txBody>
+      </p:sp>
+      <p:sp>
+        <p:nvSpPr>
+          <p:cNvPr id="20" name="Rectangle 19">
+            <a:extLst>
+              <a:ext uri="{FF2B5EF4-FFF2-40B4-BE49-F238E27FC236}">
+                <a16:creationId xmlns:a16="http://schemas.microsoft.com/office/drawing/2014/main" id="{F87CEC49-1F7E-1E80-E876-1E69912CAB70}"/>
+              </a:ext>
+            </a:extLst>
+          </p:cNvPr>
+          <p:cNvSpPr/>
+          <p:nvPr/>
+        </p:nvSpPr>
+        <p:spPr>
+          <a:xfrm>
+            <a:off x="8565936" y="4748964"/>
+            <a:ext cx="178676" cy="266844"/>
+          </a:xfrm>
+          <a:prstGeom prst="rect">
+            <a:avLst/>
+          </a:prstGeom>
+        </p:spPr>
+        <p:style>
+          <a:lnRef idx="2">
+            <a:schemeClr val="accent1">
+              <a:shade val="15000"/>
+            </a:schemeClr>
+          </a:lnRef>
+          <a:fillRef idx="1">
+            <a:schemeClr val="accent1"/>
+          </a:fillRef>
+          <a:effectRef idx="0">
+            <a:schemeClr val="accent1"/>
+          </a:effectRef>
+          <a:fontRef idx="minor">
+            <a:schemeClr val="lt1"/>
+          </a:fontRef>
+        </p:style>
+        <p:txBody>
+          <a:bodyPr rtlCol="0" anchor="ctr"/>
+          <a:lstStyle/>
+          <a:p>
+            <a:pPr algn="ctr"/>
+            <a:endParaRPr lang="en-US"/>
+          </a:p>
+        </p:txBody>
+      </p:sp>
+      <p:sp>
+        <p:nvSpPr>
+          <p:cNvPr id="22" name="TextBox 21">
+            <a:extLst>
+              <a:ext uri="{FF2B5EF4-FFF2-40B4-BE49-F238E27FC236}">
+                <a16:creationId xmlns:a16="http://schemas.microsoft.com/office/drawing/2014/main" id="{7D979762-27FC-9B1F-8300-846E2E53A02D}"/>
+              </a:ext>
+            </a:extLst>
+          </p:cNvPr>
+          <p:cNvSpPr txBox="1"/>
+          <p:nvPr/>
+        </p:nvSpPr>
+        <p:spPr>
+          <a:xfrm>
+            <a:off x="6096000" y="3666756"/>
+            <a:ext cx="798786" cy="369332"/>
+          </a:xfrm>
+          <a:prstGeom prst="rect">
+            <a:avLst/>
+          </a:prstGeom>
+          <a:noFill/>
+        </p:spPr>
+        <p:txBody>
+          <a:bodyPr wrap="square">
+            <a:spAutoFit/>
+          </a:bodyPr>
+          <a:lstStyle/>
+          <a:p>
+            <a:pPr algn="ctr"/>
+            <a:r>
+              <a:rPr lang="en-US" dirty="0" err="1"/>
+              <a:t>Brd</a:t>
+            </a:r>
+            <a:endParaRPr lang="en-US" dirty="0"/>
+          </a:p>
+        </p:txBody>
+      </p:sp>
+      <p:sp>
+        <p:nvSpPr>
+          <p:cNvPr id="23" name="TextBox 22">
+            <a:extLst>
+              <a:ext uri="{FF2B5EF4-FFF2-40B4-BE49-F238E27FC236}">
+                <a16:creationId xmlns:a16="http://schemas.microsoft.com/office/drawing/2014/main" id="{05758331-BB25-1684-0F06-17283CFB3658}"/>
+              </a:ext>
+            </a:extLst>
+          </p:cNvPr>
+          <p:cNvSpPr txBox="1"/>
+          <p:nvPr/>
+        </p:nvSpPr>
+        <p:spPr>
+          <a:xfrm>
+            <a:off x="6001409" y="4379632"/>
+            <a:ext cx="798786" cy="369332"/>
+          </a:xfrm>
+          <a:prstGeom prst="rect">
+            <a:avLst/>
+          </a:prstGeom>
+          <a:noFill/>
+        </p:spPr>
+        <p:txBody>
+          <a:bodyPr wrap="square">
+            <a:spAutoFit/>
+          </a:bodyPr>
+          <a:lstStyle/>
+          <a:p>
+            <a:pPr algn="ctr"/>
+            <a:r>
+              <a:rPr lang="en-US" dirty="0"/>
+              <a:t>H</a:t>
+            </a:r>
+          </a:p>
+        </p:txBody>
+      </p:sp>
+      <p:sp>
+        <p:nvSpPr>
+          <p:cNvPr id="24" name="Rectangle 23">
+            <a:extLst>
+              <a:ext uri="{FF2B5EF4-FFF2-40B4-BE49-F238E27FC236}">
+                <a16:creationId xmlns:a16="http://schemas.microsoft.com/office/drawing/2014/main" id="{FCFCB574-DD58-2725-E233-047340E09CB3}"/>
+              </a:ext>
+            </a:extLst>
+          </p:cNvPr>
+          <p:cNvSpPr/>
+          <p:nvPr/>
+        </p:nvSpPr>
+        <p:spPr>
+          <a:xfrm>
+            <a:off x="6458611" y="4756913"/>
+            <a:ext cx="178676" cy="266844"/>
+          </a:xfrm>
+          <a:prstGeom prst="rect">
+            <a:avLst/>
+          </a:prstGeom>
+        </p:spPr>
+        <p:style>
+          <a:lnRef idx="1">
+            <a:schemeClr val="dk1"/>
+          </a:lnRef>
+          <a:fillRef idx="2">
+            <a:schemeClr val="dk1"/>
+          </a:fillRef>
+          <a:effectRef idx="1">
+            <a:schemeClr val="dk1"/>
+          </a:effectRef>
+          <a:fontRef idx="minor">
+            <a:schemeClr val="dk1"/>
+          </a:fontRef>
+        </p:style>
+        <p:txBody>
+          <a:bodyPr rtlCol="0" anchor="ctr"/>
+          <a:lstStyle/>
+          <a:p>
+            <a:pPr algn="ctr"/>
+            <a:endParaRPr lang="en-US"/>
+          </a:p>
+        </p:txBody>
+      </p:sp>
+      <p:sp>
+        <p:nvSpPr>
+          <p:cNvPr id="25" name="Rectangle 24">
+            <a:extLst>
+              <a:ext uri="{FF2B5EF4-FFF2-40B4-BE49-F238E27FC236}">
+                <a16:creationId xmlns:a16="http://schemas.microsoft.com/office/drawing/2014/main" id="{5FB0DF84-B1EE-F287-C1A8-3E3058C29298}"/>
+              </a:ext>
+            </a:extLst>
+          </p:cNvPr>
+          <p:cNvSpPr/>
+          <p:nvPr/>
+        </p:nvSpPr>
+        <p:spPr>
+          <a:xfrm>
+            <a:off x="6721370" y="4756913"/>
+            <a:ext cx="178676" cy="266844"/>
+          </a:xfrm>
+          <a:prstGeom prst="rect">
+            <a:avLst/>
+          </a:prstGeom>
+        </p:spPr>
+        <p:style>
+          <a:lnRef idx="1">
+            <a:schemeClr val="dk1"/>
+          </a:lnRef>
+          <a:fillRef idx="2">
+            <a:schemeClr val="dk1"/>
+          </a:fillRef>
+          <a:effectRef idx="1">
+            <a:schemeClr val="dk1"/>
+          </a:effectRef>
+          <a:fontRef idx="minor">
+            <a:schemeClr val="dk1"/>
+          </a:fontRef>
+        </p:style>
+        <p:txBody>
+          <a:bodyPr rtlCol="0" anchor="ctr"/>
+          <a:lstStyle/>
+          <a:p>
+            <a:pPr algn="ctr"/>
+            <a:endParaRPr lang="en-US"/>
+          </a:p>
+        </p:txBody>
+      </p:sp>
+      <p:sp>
+        <p:nvSpPr>
+          <p:cNvPr id="26" name="Rectangle 25">
+            <a:extLst>
+              <a:ext uri="{FF2B5EF4-FFF2-40B4-BE49-F238E27FC236}">
+                <a16:creationId xmlns:a16="http://schemas.microsoft.com/office/drawing/2014/main" id="{0590E2C1-92CB-2B2B-4BB2-1ADC3CEC5873}"/>
+              </a:ext>
+            </a:extLst>
+          </p:cNvPr>
+          <p:cNvSpPr/>
+          <p:nvPr/>
+        </p:nvSpPr>
+        <p:spPr>
+          <a:xfrm>
+            <a:off x="6984129" y="4756913"/>
+            <a:ext cx="178676" cy="266844"/>
+          </a:xfrm>
+          <a:prstGeom prst="rect">
+            <a:avLst/>
+          </a:prstGeom>
+        </p:spPr>
+        <p:style>
+          <a:lnRef idx="1">
+            <a:schemeClr val="dk1"/>
+          </a:lnRef>
+          <a:fillRef idx="2">
+            <a:schemeClr val="dk1"/>
+          </a:fillRef>
+          <a:effectRef idx="1">
+            <a:schemeClr val="dk1"/>
+          </a:effectRef>
+          <a:fontRef idx="minor">
+            <a:schemeClr val="dk1"/>
+          </a:fontRef>
+        </p:style>
+        <p:txBody>
+          <a:bodyPr rtlCol="0" anchor="ctr"/>
+          <a:lstStyle/>
+          <a:p>
+            <a:pPr algn="ctr"/>
+            <a:endParaRPr lang="en-US"/>
+          </a:p>
+        </p:txBody>
+      </p:sp>
+    </p:spTree>
+    <p:extLst>
+      <p:ext uri="{BB962C8B-B14F-4D97-AF65-F5344CB8AC3E}">
+        <p14:creationId xmlns:p14="http://schemas.microsoft.com/office/powerpoint/2010/main" val="2434206618"/>
+      </p:ext>
+    </p:extLst>
+  </p:cSld>
+  <p:clrMapOvr>
+    <a:masterClrMapping/>
+  </p:clrMapOvr>
+</p:sld>
+</file>
+
+<file path=ppt/slides/slide20.xml><?xml version="1.0" encoding="utf-8"?>
+<p:sld xmlns:a="http://schemas.openxmlformats.org/drawingml/2006/main" xmlns:r="http://schemas.openxmlformats.org/officeDocument/2006/relationships" xmlns:p="http://schemas.openxmlformats.org/presentationml/2006/main">
+  <p:cSld>
+    <p:spTree>
+      <p:nvGrpSpPr>
+        <p:cNvPr id="1" name="">
+          <a:extLst>
+            <a:ext uri="{FF2B5EF4-FFF2-40B4-BE49-F238E27FC236}">
+              <a16:creationId xmlns:a16="http://schemas.microsoft.com/office/drawing/2014/main" id="{3F9066FE-DBC4-1801-FB3C-C2C8353CC752}"/>
+            </a:ext>
+          </a:extLst>
+        </p:cNvPr>
+        <p:cNvGrpSpPr/>
+        <p:nvPr/>
+      </p:nvGrpSpPr>
+      <p:grpSpPr>
+        <a:xfrm>
+          <a:off x="0" y="0"/>
+          <a:ext cx="0" cy="0"/>
+          <a:chOff x="0" y="0"/>
+          <a:chExt cx="0" cy="0"/>
+        </a:xfrm>
+      </p:grpSpPr>
+      <p:sp>
+        <p:nvSpPr>
+          <p:cNvPr id="2" name="Title 1">
+            <a:extLst>
+              <a:ext uri="{FF2B5EF4-FFF2-40B4-BE49-F238E27FC236}">
+                <a16:creationId xmlns:a16="http://schemas.microsoft.com/office/drawing/2014/main" id="{C6FB037D-B131-BF47-6C97-172C6BF1F68F}"/>
+              </a:ext>
+            </a:extLst>
+          </p:cNvPr>
+          <p:cNvSpPr>
+            <a:spLocks noGrp="1"/>
+          </p:cNvSpPr>
+          <p:nvPr>
+            <p:ph type="title"/>
+          </p:nvPr>
+        </p:nvSpPr>
+        <p:spPr/>
+        <p:txBody>
+          <a:bodyPr/>
+          <a:lstStyle/>
+          <a:p>
+            <a:r>
+              <a:rPr lang="en-US" dirty="0"/>
+              <a:t>Dataset Selection Reminder </a:t>
+            </a:r>
+          </a:p>
+        </p:txBody>
+      </p:sp>
+      <p:sp>
+        <p:nvSpPr>
+          <p:cNvPr id="3" name="Content Placeholder 2">
+            <a:extLst>
+              <a:ext uri="{FF2B5EF4-FFF2-40B4-BE49-F238E27FC236}">
+                <a16:creationId xmlns:a16="http://schemas.microsoft.com/office/drawing/2014/main" id="{511018E7-913C-204D-2FD8-54413DAA9AAC}"/>
+              </a:ext>
+            </a:extLst>
+          </p:cNvPr>
+          <p:cNvSpPr>
+            <a:spLocks noGrp="1"/>
+          </p:cNvSpPr>
+          <p:nvPr>
+            <p:ph idx="1"/>
+          </p:nvPr>
+        </p:nvSpPr>
+        <p:spPr/>
+        <p:txBody>
+          <a:bodyPr>
+            <a:normAutofit lnSpcReduction="10000"/>
+          </a:bodyPr>
+          <a:lstStyle/>
+          <a:p>
+            <a:r>
+              <a:rPr lang="en-US" dirty="0"/>
+              <a:t>I think in a paper, Table 1 with more than 20 datasets is an overkill as we do not have such space in main text. We can put more data to appendix, but we do not need to show all your data (esp. those unfavorable ones). However, Table 1 cannot have less than 10 - 12 datasets, too few is a concern. If you cannot find 20 working well for both MC and SM, at least find, e.g., 16.</a:t>
+            </a:r>
+          </a:p>
+          <a:p>
+            <a:r>
+              <a:rPr lang="en-US" dirty="0"/>
+              <a:t>Let’s first find k datasets that are really good for MC. It can be 20, but can also be 40-50. Throw away really unfavorable datasets for MC. You need larger k since some of them may need to be dropped further due to poor performance on SM, and after dropping, we hope to still see 20 datasets we can put in Table 1. </a:t>
+            </a:r>
+          </a:p>
+        </p:txBody>
+      </p:sp>
+    </p:spTree>
+    <p:extLst>
+      <p:ext uri="{BB962C8B-B14F-4D97-AF65-F5344CB8AC3E}">
+        <p14:creationId xmlns:p14="http://schemas.microsoft.com/office/powerpoint/2010/main" val="3815703154"/>
+      </p:ext>
+    </p:extLst>
+  </p:cSld>
+  <p:clrMapOvr>
+    <a:masterClrMapping/>
+  </p:clrMapOvr>
+</p:sld>
+</file>
+
+<file path=ppt/slides/slide21.xml><?xml version="1.0" encoding="utf-8"?>
+<p:sld xmlns:a="http://schemas.openxmlformats.org/drawingml/2006/main" xmlns:r="http://schemas.openxmlformats.org/officeDocument/2006/relationships" xmlns:p="http://schemas.openxmlformats.org/presentationml/2006/main">
+  <p:cSld>
+    <p:spTree>
+      <p:nvGrpSpPr>
+        <p:cNvPr id="1" name="">
+          <a:extLst>
+            <a:ext uri="{FF2B5EF4-FFF2-40B4-BE49-F238E27FC236}">
+              <a16:creationId xmlns:a16="http://schemas.microsoft.com/office/drawing/2014/main" id="{3AEB08FE-877C-04D2-96E1-E55A7CDB0DF3}"/>
+            </a:ext>
+          </a:extLst>
+        </p:cNvPr>
+        <p:cNvGrpSpPr/>
+        <p:nvPr/>
+      </p:nvGrpSpPr>
+      <p:grpSpPr>
+        <a:xfrm>
+          <a:off x="0" y="0"/>
+          <a:ext cx="0" cy="0"/>
+          <a:chOff x="0" y="0"/>
+          <a:chExt cx="0" cy="0"/>
+        </a:xfrm>
+      </p:grpSpPr>
+      <p:sp>
+        <p:nvSpPr>
+          <p:cNvPr id="2" name="Title 1">
+            <a:extLst>
+              <a:ext uri="{FF2B5EF4-FFF2-40B4-BE49-F238E27FC236}">
+                <a16:creationId xmlns:a16="http://schemas.microsoft.com/office/drawing/2014/main" id="{A5BE06AB-00CA-1C95-54F8-C4FB706E4918}"/>
+              </a:ext>
+            </a:extLst>
+          </p:cNvPr>
+          <p:cNvSpPr>
+            <a:spLocks noGrp="1"/>
+          </p:cNvSpPr>
+          <p:nvPr>
+            <p:ph type="title"/>
+          </p:nvPr>
+        </p:nvSpPr>
+        <p:spPr/>
+        <p:txBody>
+          <a:bodyPr/>
+          <a:lstStyle/>
+          <a:p>
+            <a:r>
+              <a:rPr lang="en-US" dirty="0"/>
+              <a:t>Dataset Selection Reminder </a:t>
+            </a:r>
+          </a:p>
+        </p:txBody>
+      </p:sp>
+      <p:sp>
+        <p:nvSpPr>
+          <p:cNvPr id="3" name="Content Placeholder 2">
+            <a:extLst>
+              <a:ext uri="{FF2B5EF4-FFF2-40B4-BE49-F238E27FC236}">
+                <a16:creationId xmlns:a16="http://schemas.microsoft.com/office/drawing/2014/main" id="{1715042B-C4CA-CD9D-1261-E582B9B90853}"/>
+              </a:ext>
+            </a:extLst>
+          </p:cNvPr>
+          <p:cNvSpPr>
+            <a:spLocks noGrp="1"/>
+          </p:cNvSpPr>
+          <p:nvPr>
+            <p:ph idx="1"/>
+          </p:nvPr>
+        </p:nvSpPr>
+        <p:spPr/>
+        <p:txBody>
+          <a:bodyPr>
+            <a:normAutofit fontScale="92500" lnSpcReduction="20000"/>
+          </a:bodyPr>
+          <a:lstStyle/>
+          <a:p>
+            <a:r>
+              <a:rPr lang="en-US" dirty="0"/>
+              <a:t>Then, move on to Application 2: SM. There is no point to try any dataset outside k selected for MC. We may shrink the k datasets to k’ further, but hopefully k’ is 20, or at least 16.</a:t>
+            </a:r>
+          </a:p>
+          <a:p>
+            <a:r>
+              <a:rPr lang="en-US" dirty="0"/>
+              <a:t>In SM, we try to find datasets with large max-deg and small avg-deg, but CPU+GPU is still not helpful (in fact, worse than GPU-only, like 99% of GPU-only). So our focus now is on hoping GPU-layered &gt;&gt; G2-AIMD. When we shrink MC’s good datasets, we need to make sure we pick those with good GPU-layered &gt;&gt; G2-AIMD, or at least have a significant portion like that.</a:t>
+            </a:r>
+          </a:p>
+          <a:p>
+            <a:r>
+              <a:rPr lang="en-US" dirty="0"/>
+              <a:t>Goal: For SM application, we can argue that we do not have deep recursion tree (depth decided by query graph size), but our GPU-layered design is favorable over G2-AIMD. If we cannot show GPU-layered &gt;&gt; G2-AIMD, reviewer will say that you can just use G2-AIMD, reject our paper due to SM application</a:t>
+            </a:r>
+          </a:p>
+        </p:txBody>
+      </p:sp>
+    </p:spTree>
+    <p:extLst>
+      <p:ext uri="{BB962C8B-B14F-4D97-AF65-F5344CB8AC3E}">
+        <p14:creationId xmlns:p14="http://schemas.microsoft.com/office/powerpoint/2010/main" val="1484636445"/>
+      </p:ext>
+    </p:extLst>
+  </p:cSld>
+  <p:clrMapOvr>
+    <a:masterClrMapping/>
+  </p:clrMapOvr>
+</p:sld>
+</file>
+
+<file path=ppt/slides/slide22.xml><?xml version="1.0" encoding="utf-8"?>
+<p:sld xmlns:a="http://schemas.openxmlformats.org/drawingml/2006/main" xmlns:r="http://schemas.openxmlformats.org/officeDocument/2006/relationships" xmlns:p="http://schemas.openxmlformats.org/presentationml/2006/main">
+  <p:cSld>
+    <p:spTree>
+      <p:nvGrpSpPr>
+        <p:cNvPr id="1" name=""/>
+        <p:cNvGrpSpPr/>
+        <p:nvPr/>
+      </p:nvGrpSpPr>
+      <p:grpSpPr>
+        <a:xfrm>
+          <a:off x="0" y="0"/>
+          <a:ext cx="0" cy="0"/>
+          <a:chOff x="0" y="0"/>
+          <a:chExt cx="0" cy="0"/>
+        </a:xfrm>
+      </p:grpSpPr>
+      <p:sp>
+        <p:nvSpPr>
+          <p:cNvPr id="2" name="Title 1">
+            <a:extLst>
+              <a:ext uri="{FF2B5EF4-FFF2-40B4-BE49-F238E27FC236}">
+                <a16:creationId xmlns:a16="http://schemas.microsoft.com/office/drawing/2014/main" id="{3A8ED60D-AE4D-1263-5A65-3AB751842A01}"/>
+              </a:ext>
+            </a:extLst>
+          </p:cNvPr>
+          <p:cNvSpPr>
+            <a:spLocks noGrp="1"/>
+          </p:cNvSpPr>
+          <p:nvPr>
+            <p:ph type="title"/>
+          </p:nvPr>
+        </p:nvSpPr>
+        <p:spPr/>
+        <p:txBody>
+          <a:bodyPr/>
+          <a:lstStyle/>
+          <a:p>
+            <a:r>
+              <a:rPr lang="en-US" dirty="0"/>
+              <a:t>Dataset Reminder</a:t>
+            </a:r>
+          </a:p>
+        </p:txBody>
+      </p:sp>
+      <p:sp>
+        <p:nvSpPr>
+          <p:cNvPr id="3" name="Content Placeholder 2">
+            <a:extLst>
+              <a:ext uri="{FF2B5EF4-FFF2-40B4-BE49-F238E27FC236}">
+                <a16:creationId xmlns:a16="http://schemas.microsoft.com/office/drawing/2014/main" id="{CBB21DC3-7BA9-6F6A-9706-55CFC283FC4A}"/>
+              </a:ext>
+            </a:extLst>
+          </p:cNvPr>
+          <p:cNvSpPr>
+            <a:spLocks noGrp="1"/>
+          </p:cNvSpPr>
+          <p:nvPr>
+            <p:ph idx="1"/>
+          </p:nvPr>
+        </p:nvSpPr>
+        <p:spPr/>
+        <p:txBody>
+          <a:bodyPr>
+            <a:normAutofit fontScale="92500" lnSpcReduction="20000"/>
+          </a:bodyPr>
+          <a:lstStyle/>
+          <a:p>
+            <a:r>
+              <a:rPr lang="en-US" dirty="0"/>
+              <a:t>For QC, GPU-layered ~= G2-AIMD, though for two datasets where GPU-only throws some large-</a:t>
+            </a:r>
+            <a:r>
+              <a:rPr lang="en-US" dirty="0" err="1"/>
+              <a:t>candidateSet</a:t>
+            </a:r>
+            <a:r>
+              <a:rPr lang="en-US" dirty="0"/>
+              <a:t> tasks, GPU-layered &gt;&gt; G2-AIMD. Note that GPU-layered and G2-AIMD throw the same task sets. </a:t>
+            </a:r>
+          </a:p>
+          <a:p>
+            <a:r>
+              <a:rPr lang="en-US" dirty="0"/>
+              <a:t>GPU-layered ~= G2-AIMD because G2-AIMD does not encounter device buffer overflow issue so no wasted chunk computation </a:t>
+            </a:r>
+            <a:r>
+              <a:rPr lang="en-US" dirty="0">
+                <a:solidFill>
+                  <a:srgbClr val="C00000"/>
+                </a:solidFill>
+              </a:rPr>
+              <a:t>[need verification]. </a:t>
+            </a:r>
+            <a:r>
+              <a:rPr lang="en-US" dirty="0"/>
+              <a:t>G2-AIMD has no eta limit, so if no overflow, is going to be good.</a:t>
+            </a:r>
+          </a:p>
+          <a:p>
+            <a:r>
+              <a:rPr lang="en-US" dirty="0"/>
+              <a:t>However, GPU-hybrid will not help since GPU-layered ~= G2-AIMD, no one is much faster than the other. So we should focus how CPU + GPU &gt;&gt;  GPU-layered</a:t>
+            </a:r>
+          </a:p>
+          <a:p>
+            <a:r>
+              <a:rPr lang="en-US" dirty="0">
+                <a:solidFill>
+                  <a:srgbClr val="C00000"/>
+                </a:solidFill>
+              </a:rPr>
+              <a:t>Make sure datasets in Table 1 run OOM. </a:t>
+            </a:r>
+            <a:r>
+              <a:rPr lang="en-US" dirty="0"/>
+              <a:t>If not, then QC (with some parameters set) gives good results and can be added to Application 3. Kick out those in Table 1 that do not run OOM, but gives bad QC results.</a:t>
+            </a:r>
+          </a:p>
+        </p:txBody>
+      </p:sp>
+    </p:spTree>
+    <p:extLst>
+      <p:ext uri="{BB962C8B-B14F-4D97-AF65-F5344CB8AC3E}">
+        <p14:creationId xmlns:p14="http://schemas.microsoft.com/office/powerpoint/2010/main" val="1852982210"/>
+      </p:ext>
+    </p:extLst>
+  </p:cSld>
+  <p:clrMapOvr>
+    <a:masterClrMapping/>
+  </p:clrMapOvr>
+</p:sld>
+</file>
+
+<file path=ppt/slides/slide23.xml><?xml version="1.0" encoding="utf-8"?>
+<p:sld xmlns:a="http://schemas.openxmlformats.org/drawingml/2006/main" xmlns:r="http://schemas.openxmlformats.org/officeDocument/2006/relationships" xmlns:p="http://schemas.openxmlformats.org/presentationml/2006/main">
+  <p:cSld>
+    <p:spTree>
+      <p:nvGrpSpPr>
+        <p:cNvPr id="1" name=""/>
+        <p:cNvGrpSpPr/>
+        <p:nvPr/>
+      </p:nvGrpSpPr>
+      <p:grpSpPr>
+        <a:xfrm>
+          <a:off x="0" y="0"/>
+          <a:ext cx="0" cy="0"/>
+          <a:chOff x="0" y="0"/>
+          <a:chExt cx="0" cy="0"/>
+        </a:xfrm>
+      </p:grpSpPr>
+      <p:sp>
+        <p:nvSpPr>
+          <p:cNvPr id="2" name="Title 1">
+            <a:extLst>
+              <a:ext uri="{FF2B5EF4-FFF2-40B4-BE49-F238E27FC236}">
+                <a16:creationId xmlns:a16="http://schemas.microsoft.com/office/drawing/2014/main" id="{F79AD936-1399-EE37-291B-F67F6F53B8C5}"/>
+              </a:ext>
+            </a:extLst>
+          </p:cNvPr>
+          <p:cNvSpPr>
+            <a:spLocks noGrp="1"/>
+          </p:cNvSpPr>
+          <p:nvPr>
+            <p:ph type="title"/>
+          </p:nvPr>
+        </p:nvSpPr>
+        <p:spPr/>
+        <p:txBody>
+          <a:bodyPr/>
+          <a:lstStyle/>
+          <a:p>
+            <a:r>
+              <a:rPr lang="en-US" dirty="0"/>
+              <a:t>SM Application</a:t>
+            </a:r>
+          </a:p>
+        </p:txBody>
+      </p:sp>
+      <p:sp>
+        <p:nvSpPr>
+          <p:cNvPr id="3" name="Content Placeholder 2">
+            <a:extLst>
+              <a:ext uri="{FF2B5EF4-FFF2-40B4-BE49-F238E27FC236}">
+                <a16:creationId xmlns:a16="http://schemas.microsoft.com/office/drawing/2014/main" id="{8FA57192-4680-17A3-7ACB-2A18544BDEC2}"/>
+              </a:ext>
+            </a:extLst>
+          </p:cNvPr>
+          <p:cNvSpPr>
+            <a:spLocks noGrp="1"/>
+          </p:cNvSpPr>
+          <p:nvPr>
+            <p:ph idx="1"/>
+          </p:nvPr>
+        </p:nvSpPr>
+        <p:spPr/>
+        <p:txBody>
+          <a:bodyPr/>
+          <a:lstStyle/>
+          <a:p>
+            <a:pPr lvl="0"/>
+            <a:r>
+              <a:rPr lang="en-US" dirty="0"/>
+              <a:t>G2-AIMD fails in two cases due to out-of-memory (OOM) errors and is consistently slower than GPU-Layered, with slowdowns of up to 1.98×.</a:t>
+            </a:r>
+          </a:p>
+          <a:p>
+            <a:pPr lvl="0"/>
+            <a:r>
+              <a:rPr lang="en-US" dirty="0"/>
+              <a:t>GPU-Layered outperforms GPU-Hybrid in nearly all cases.</a:t>
+            </a:r>
+          </a:p>
+          <a:p>
+            <a:pPr lvl="0"/>
+            <a:r>
+              <a:rPr lang="en-US" dirty="0"/>
+              <a:t>The CPU-only implementation is prohibitively slow for this application, which also limits the performance of the CPU+GPU approach in CPU-bound scenarios.</a:t>
+            </a:r>
           </a:p>
         </p:txBody>
       </p:sp>
@@ -7143,7 +9532,333 @@
 </p:sld>
 </file>
 
-<file path=ppt/slides/slide17.xml><?xml version="1.0" encoding="utf-8"?>
+<file path=ppt/slides/slide24.xml><?xml version="1.0" encoding="utf-8"?>
+<p:sld xmlns:a="http://schemas.openxmlformats.org/drawingml/2006/main" xmlns:r="http://schemas.openxmlformats.org/officeDocument/2006/relationships" xmlns:p="http://schemas.openxmlformats.org/presentationml/2006/main">
+  <p:cSld>
+    <p:spTree>
+      <p:nvGrpSpPr>
+        <p:cNvPr id="1" name=""/>
+        <p:cNvGrpSpPr/>
+        <p:nvPr/>
+      </p:nvGrpSpPr>
+      <p:grpSpPr>
+        <a:xfrm>
+          <a:off x="0" y="0"/>
+          <a:ext cx="0" cy="0"/>
+          <a:chOff x="0" y="0"/>
+          <a:chExt cx="0" cy="0"/>
+        </a:xfrm>
+      </p:grpSpPr>
+      <p:sp>
+        <p:nvSpPr>
+          <p:cNvPr id="2" name="Title 1">
+            <a:extLst>
+              <a:ext uri="{FF2B5EF4-FFF2-40B4-BE49-F238E27FC236}">
+                <a16:creationId xmlns:a16="http://schemas.microsoft.com/office/drawing/2014/main" id="{46A5DAA1-1F51-475B-350C-03993AAE1EFC}"/>
+              </a:ext>
+            </a:extLst>
+          </p:cNvPr>
+          <p:cNvSpPr>
+            <a:spLocks noGrp="1"/>
+          </p:cNvSpPr>
+          <p:nvPr>
+            <p:ph type="title"/>
+          </p:nvPr>
+        </p:nvSpPr>
+        <p:spPr/>
+        <p:txBody>
+          <a:bodyPr/>
+          <a:lstStyle/>
+          <a:p>
+            <a:r>
+              <a:rPr lang="en-US" dirty="0"/>
+              <a:t>MQC Application</a:t>
+            </a:r>
+          </a:p>
+        </p:txBody>
+      </p:sp>
+      <p:sp>
+        <p:nvSpPr>
+          <p:cNvPr id="3" name="Content Placeholder 2">
+            <a:extLst>
+              <a:ext uri="{FF2B5EF4-FFF2-40B4-BE49-F238E27FC236}">
+                <a16:creationId xmlns:a16="http://schemas.microsoft.com/office/drawing/2014/main" id="{8E0728CE-78F1-153D-476C-635EE54A2221}"/>
+              </a:ext>
+            </a:extLst>
+          </p:cNvPr>
+          <p:cNvSpPr>
+            <a:spLocks noGrp="1"/>
+          </p:cNvSpPr>
+          <p:nvPr>
+            <p:ph idx="1"/>
+          </p:nvPr>
+        </p:nvSpPr>
+        <p:spPr/>
+        <p:txBody>
+          <a:bodyPr/>
+          <a:lstStyle/>
+          <a:p>
+            <a:pPr lvl="0"/>
+            <a:r>
+              <a:rPr lang="en-US" dirty="0"/>
+              <a:t>G2-AIMD runs out of memory on two datasets and is up to 2.43× slower.</a:t>
+            </a:r>
+          </a:p>
+          <a:p>
+            <a:pPr lvl="0"/>
+            <a:r>
+              <a:rPr lang="en-US" dirty="0"/>
+              <a:t>GPU-Layered consistently outperforms GPU-hybrid.</a:t>
+            </a:r>
+          </a:p>
+          <a:p>
+            <a:pPr lvl="0"/>
+            <a:r>
+              <a:rPr lang="en-US" dirty="0"/>
+              <a:t>Fixed GPU chunk sizes caused poor utilization, motivating adaptive chunk sizing.</a:t>
+            </a:r>
+          </a:p>
+          <a:p>
+            <a:pPr lvl="0"/>
+            <a:r>
+              <a:rPr lang="en-US" dirty="0"/>
+              <a:t>The combined CPU+GPU approach consistently outperforms GPU-Layered by up to 21.1×.</a:t>
+            </a:r>
+          </a:p>
+        </p:txBody>
+      </p:sp>
+    </p:spTree>
+    <p:extLst>
+      <p:ext uri="{BB962C8B-B14F-4D97-AF65-F5344CB8AC3E}">
+        <p14:creationId xmlns:p14="http://schemas.microsoft.com/office/powerpoint/2010/main" val="3836206850"/>
+      </p:ext>
+    </p:extLst>
+  </p:cSld>
+  <p:clrMapOvr>
+    <a:masterClrMapping/>
+  </p:clrMapOvr>
+</p:sld>
+</file>
+
+<file path=ppt/slides/slide25.xml><?xml version="1.0" encoding="utf-8"?>
+<p:sld xmlns:a="http://schemas.openxmlformats.org/drawingml/2006/main" xmlns:r="http://schemas.openxmlformats.org/officeDocument/2006/relationships" xmlns:p="http://schemas.openxmlformats.org/presentationml/2006/main">
+  <p:cSld>
+    <p:spTree>
+      <p:nvGrpSpPr>
+        <p:cNvPr id="1" name=""/>
+        <p:cNvGrpSpPr/>
+        <p:nvPr/>
+      </p:nvGrpSpPr>
+      <p:grpSpPr>
+        <a:xfrm>
+          <a:off x="0" y="0"/>
+          <a:ext cx="0" cy="0"/>
+          <a:chOff x="0" y="0"/>
+          <a:chExt cx="0" cy="0"/>
+        </a:xfrm>
+      </p:grpSpPr>
+      <p:sp>
+        <p:nvSpPr>
+          <p:cNvPr id="2" name="Title 1">
+            <a:extLst>
+              <a:ext uri="{FF2B5EF4-FFF2-40B4-BE49-F238E27FC236}">
+                <a16:creationId xmlns:a16="http://schemas.microsoft.com/office/drawing/2014/main" id="{40527D02-03A8-BD45-4197-6BC5DC71D7C1}"/>
+              </a:ext>
+            </a:extLst>
+          </p:cNvPr>
+          <p:cNvSpPr>
+            <a:spLocks noGrp="1"/>
+          </p:cNvSpPr>
+          <p:nvPr>
+            <p:ph type="title"/>
+          </p:nvPr>
+        </p:nvSpPr>
+        <p:spPr/>
+        <p:txBody>
+          <a:bodyPr/>
+          <a:lstStyle/>
+          <a:p>
+            <a:r>
+              <a:rPr lang="en-US" dirty="0"/>
+              <a:t>MQC Adaptive GPU Chunk</a:t>
+            </a:r>
+          </a:p>
+        </p:txBody>
+      </p:sp>
+      <p:sp>
+        <p:nvSpPr>
+          <p:cNvPr id="3" name="Content Placeholder 2">
+            <a:extLst>
+              <a:ext uri="{FF2B5EF4-FFF2-40B4-BE49-F238E27FC236}">
+                <a16:creationId xmlns:a16="http://schemas.microsoft.com/office/drawing/2014/main" id="{B40F28F1-46A9-25E2-9F3A-20A11D91F975}"/>
+              </a:ext>
+            </a:extLst>
+          </p:cNvPr>
+          <p:cNvSpPr>
+            <a:spLocks noGrp="1"/>
+          </p:cNvSpPr>
+          <p:nvPr>
+            <p:ph idx="1"/>
+          </p:nvPr>
+        </p:nvSpPr>
+        <p:spPr/>
+        <p:txBody>
+          <a:bodyPr/>
+          <a:lstStyle/>
+          <a:p>
+            <a:pPr lvl="0"/>
+            <a:r>
+              <a:rPr lang="en-US" dirty="0"/>
+              <a:t>The number of root tasks in MQC varies significantly across datasets.</a:t>
+            </a:r>
+          </a:p>
+          <a:p>
+            <a:pPr lvl="0"/>
+            <a:r>
+              <a:rPr lang="en-US" dirty="0"/>
+              <a:t>A fixed GPU chunk size can cause load imbalance and GPU underutilization.</a:t>
+            </a:r>
+          </a:p>
+          <a:p>
+            <a:pPr lvl="0"/>
+            <a:r>
+              <a:rPr lang="en-US" dirty="0"/>
+              <a:t>We dynamically calculate the GPU chunk size as:</a:t>
+            </a:r>
+          </a:p>
+          <a:p>
+            <a:pPr marL="0" indent="0">
+              <a:buNone/>
+            </a:pPr>
+            <a:r>
+              <a:rPr lang="en-US" dirty="0"/>
+              <a:t>                   </a:t>
+            </a:r>
+            <a:r>
+              <a:rPr lang="en-US" dirty="0" err="1"/>
+              <a:t>GPU_chunk</a:t>
+            </a:r>
+            <a:r>
+              <a:rPr lang="en-US" dirty="0"/>
+              <a:t>=max(</a:t>
+            </a:r>
+            <a:r>
+              <a:rPr lang="en-US" dirty="0" err="1"/>
+              <a:t>root_tasks</a:t>
+            </a:r>
+            <a:r>
+              <a:rPr lang="en-US" dirty="0"/>
+              <a:t>/</a:t>
+            </a:r>
+            <a:r>
+              <a:rPr lang="en-US" dirty="0" err="1"/>
+              <a:t>c,min_chunk</a:t>
+            </a:r>
+            <a:r>
+              <a:rPr lang="en-US" dirty="0"/>
+              <a:t>)</a:t>
+            </a:r>
+          </a:p>
+          <a:p>
+            <a:pPr lvl="0"/>
+            <a:r>
+              <a:rPr lang="en-US" dirty="0"/>
+              <a:t>c controls the number of chunks.</a:t>
+            </a:r>
+          </a:p>
+          <a:p>
+            <a:pPr lvl="0"/>
+            <a:r>
+              <a:rPr lang="en-US" dirty="0" err="1"/>
+              <a:t>min_chunk</a:t>
+            </a:r>
+            <a:r>
+              <a:rPr lang="en-US" dirty="0"/>
+              <a:t> prevents GPU chunks from becoming too small.</a:t>
+            </a:r>
+          </a:p>
+          <a:p>
+            <a:pPr lvl="0"/>
+            <a:r>
+              <a:rPr lang="en-US" dirty="0">
+                <a:solidFill>
+                  <a:srgbClr val="C00000"/>
+                </a:solidFill>
+              </a:rPr>
+              <a:t>add experiments for tuning eta</a:t>
+            </a:r>
+          </a:p>
+        </p:txBody>
+      </p:sp>
+      <p:sp>
+        <p:nvSpPr>
+          <p:cNvPr id="4" name="TextBox 3">
+            <a:extLst>
+              <a:ext uri="{FF2B5EF4-FFF2-40B4-BE49-F238E27FC236}">
+                <a16:creationId xmlns:a16="http://schemas.microsoft.com/office/drawing/2014/main" id="{603C6030-394A-60A6-9AEA-297BFDD75394}"/>
+              </a:ext>
+            </a:extLst>
+          </p:cNvPr>
+          <p:cNvSpPr txBox="1"/>
+          <p:nvPr/>
+        </p:nvSpPr>
+        <p:spPr>
+          <a:xfrm>
+            <a:off x="6337738" y="6474372"/>
+            <a:ext cx="4243341" cy="369332"/>
+          </a:xfrm>
+          <a:prstGeom prst="rect">
+            <a:avLst/>
+          </a:prstGeom>
+          <a:noFill/>
+        </p:spPr>
+        <p:txBody>
+          <a:bodyPr wrap="none" rtlCol="0">
+            <a:spAutoFit/>
+          </a:bodyPr>
+          <a:lstStyle/>
+          <a:p>
+            <a:r>
+              <a:rPr lang="en-US" dirty="0">
+                <a:solidFill>
+                  <a:srgbClr val="C00000"/>
+                </a:solidFill>
+              </a:rPr>
+              <a:t>try </a:t>
+            </a:r>
+            <a:r>
+              <a:rPr lang="en-US" dirty="0" err="1">
+                <a:solidFill>
+                  <a:srgbClr val="C00000"/>
+                </a:solidFill>
+              </a:rPr>
+              <a:t>min_chunk</a:t>
+            </a:r>
+            <a:r>
+              <a:rPr lang="en-US" dirty="0">
+                <a:solidFill>
+                  <a:srgbClr val="C00000"/>
+                </a:solidFill>
+              </a:rPr>
+              <a:t> = 100 for 2 small datasets</a:t>
+            </a:r>
+          </a:p>
+        </p:txBody>
+      </p:sp>
+    </p:spTree>
+    <p:extLst>
+      <p:ext uri="{BB962C8B-B14F-4D97-AF65-F5344CB8AC3E}">
+        <p14:creationId xmlns:p14="http://schemas.microsoft.com/office/powerpoint/2010/main" val="1162687428"/>
+      </p:ext>
+    </p:extLst>
+  </p:cSld>
+  <p:clrMapOvr>
+    <a:masterClrMapping/>
+  </p:clrMapOvr>
+</p:sld>
+</file>
+
+<file path=ppt/slides/slide26.xml><?xml version="1.0" encoding="utf-8"?>
 <p:sld xmlns:a="http://schemas.openxmlformats.org/drawingml/2006/main" xmlns:r="http://schemas.openxmlformats.org/officeDocument/2006/relationships" xmlns:p="http://schemas.openxmlformats.org/presentationml/2006/main">
   <p:cSld>
     <p:spTree>
@@ -7473,7 +10188,7 @@
 </p:sld>
 </file>
 
-<file path=ppt/slides/slide18.xml><?xml version="1.0" encoding="utf-8"?>
+<file path=ppt/slides/slide27.xml><?xml version="1.0" encoding="utf-8"?>
 <p:sld xmlns:a="http://schemas.openxmlformats.org/drawingml/2006/main" xmlns:r="http://schemas.openxmlformats.org/officeDocument/2006/relationships" xmlns:p="http://schemas.openxmlformats.org/presentationml/2006/main">
   <p:cSld>
     <p:spTree>
@@ -7956,7 +10671,7 @@
 </p:sld>
 </file>
 
-<file path=ppt/slides/slide19.xml><?xml version="1.0" encoding="utf-8"?>
+<file path=ppt/slides/slide28.xml><?xml version="1.0" encoding="utf-8"?>
 <p:sld xmlns:a="http://schemas.openxmlformats.org/drawingml/2006/main" xmlns:r="http://schemas.openxmlformats.org/officeDocument/2006/relationships" xmlns:p="http://schemas.openxmlformats.org/presentationml/2006/main">
   <p:cSld>
     <p:spTree>
@@ -8207,7 +10922,7 @@
 </p:sld>
 </file>
 
-<file path=ppt/slides/slide2.xml><?xml version="1.0" encoding="utf-8"?>
+<file path=ppt/slides/slide29.xml><?xml version="1.0" encoding="utf-8"?>
 <p:sld xmlns:a="http://schemas.openxmlformats.org/drawingml/2006/main" xmlns:r="http://schemas.openxmlformats.org/officeDocument/2006/relationships" xmlns:p="http://schemas.openxmlformats.org/presentationml/2006/main">
   <p:cSld>
     <p:spTree>
@@ -8229,7 +10944,7 @@
           <p:cNvPr id="2" name="Title 1">
             <a:extLst>
               <a:ext uri="{FF2B5EF4-FFF2-40B4-BE49-F238E27FC236}">
-                <a16:creationId xmlns:a16="http://schemas.microsoft.com/office/drawing/2014/main" id="{404C8055-AC4B-5124-0509-8DA608A7DA3E}"/>
+                <a16:creationId xmlns:a16="http://schemas.microsoft.com/office/drawing/2014/main" id="{DF9C7201-1C1B-1754-0B8F-E07786E708BB}"/>
               </a:ext>
             </a:extLst>
           </p:cNvPr>
@@ -8246,10 +10961,9 @@
           <a:lstStyle/>
           <a:p>
             <a:r>
-              <a:rPr lang="en-US"/>
-              <a:t>Host Resident Buffer</a:t>
-            </a:r>
-            <a:endParaRPr lang="en-US" dirty="0"/>
+              <a:rPr lang="en-US" dirty="0"/>
+              <a:t>Why G2-AIMD is Faster </a:t>
+            </a:r>
           </a:p>
         </p:txBody>
       </p:sp>
@@ -8258,7 +10972,7 @@
           <p:cNvPr id="3" name="Content Placeholder 2">
             <a:extLst>
               <a:ext uri="{FF2B5EF4-FFF2-40B4-BE49-F238E27FC236}">
-                <a16:creationId xmlns:a16="http://schemas.microsoft.com/office/drawing/2014/main" id="{D1F3F9EF-384A-6025-F4AC-E25DAFB4FCA0}"/>
+                <a16:creationId xmlns:a16="http://schemas.microsoft.com/office/drawing/2014/main" id="{7BD2331F-55B5-2DF4-61ED-3D123CA1E3FD}"/>
               </a:ext>
             </a:extLst>
           </p:cNvPr>
@@ -8269,58 +10983,57 @@
             <p:ph idx="1"/>
           </p:nvPr>
         </p:nvSpPr>
-        <p:spPr>
-          <a:xfrm>
-            <a:off x="838200" y="1825625"/>
-            <a:ext cx="10515600" cy="1853734"/>
-          </a:xfrm>
-        </p:spPr>
+        <p:spPr/>
         <p:txBody>
-          <a:bodyPr/>
+          <a:bodyPr>
+            <a:normAutofit lnSpcReduction="10000"/>
+          </a:bodyPr>
           <a:lstStyle/>
-          <a:p>
-            <a:r>
-              <a:rPr lang="en-US"/>
-              <a:t>Create with </a:t>
-            </a:r>
-            <a:r>
-              <a:rPr lang="en-US" b="1"/>
-              <a:t>new</a:t>
-            </a:r>
-            <a:r>
-              <a:rPr lang="en-US"/>
-              <a:t> </a:t>
-            </a:r>
-            <a:endParaRPr lang="en-US" dirty="0"/>
-          </a:p>
-          <a:p>
-            <a:r>
-              <a:rPr lang="en-US"/>
-              <a:t>After returning from kernel, copy data to/from host buffer</a:t>
-            </a:r>
-            <a:endParaRPr lang="en-US" dirty="0"/>
-          </a:p>
-          <a:p>
-            <a:r>
-              <a:rPr lang="en-US"/>
-              <a:t>Bulk copy data instead of copying each subgraph</a:t>
-            </a:r>
-            <a:endParaRPr lang="en-US" dirty="0"/>
-          </a:p>
           <a:p>
             <a:pPr marL="0" indent="0">
               <a:buNone/>
             </a:pPr>
-            <a:endParaRPr lang="en-US" dirty="0"/>
+            <a:r>
+              <a:rPr lang="en-US" dirty="0"/>
+              <a:t>In some cases, G2-AIMD outperforms GPU-hybrid even when neither system overflows.</a:t>
+            </a:r>
+          </a:p>
+          <a:p>
+            <a:pPr lvl="0"/>
+            <a:r>
+              <a:rPr lang="en-US" dirty="0"/>
+              <a:t>G2-AIMD follows a simpler, application-specific GPU execution path.</a:t>
+            </a:r>
+          </a:p>
+          <a:p>
+            <a:pPr lvl="0"/>
+            <a:r>
+              <a:rPr lang="en-US" dirty="0"/>
+              <a:t>Our system uses adaptive device and host buffers to protect against overflow.</a:t>
+            </a:r>
+          </a:p>
+          <a:p>
+            <a:pPr lvl="0"/>
+            <a:r>
+              <a:rPr lang="en-US" dirty="0"/>
+              <a:t>This flexibility requires additional capacity checks, overflow tracking, and destination selection.</a:t>
+            </a:r>
+          </a:p>
+          <a:p>
+            <a:pPr lvl="0"/>
+            <a:r>
+              <a:rPr lang="en-US" dirty="0"/>
+              <a:t>The generic buffer interface keeps more state alive, which can change compiler optimizations and register allocations.</a:t>
+            </a:r>
           </a:p>
         </p:txBody>
       </p:sp>
       <p:sp>
         <p:nvSpPr>
-          <p:cNvPr id="5" name="TextBox 4">
-            <a:extLst>
-              <a:ext uri="{FF2B5EF4-FFF2-40B4-BE49-F238E27FC236}">
-                <a16:creationId xmlns:a16="http://schemas.microsoft.com/office/drawing/2014/main" id="{91B173A4-D879-8F03-F25D-E7815C89E0E5}"/>
+          <p:cNvPr id="4" name="TextBox 3">
+            <a:extLst>
+              <a:ext uri="{FF2B5EF4-FFF2-40B4-BE49-F238E27FC236}">
+                <a16:creationId xmlns:a16="http://schemas.microsoft.com/office/drawing/2014/main" id="{734C9161-0742-3499-7282-73EBA029134B}"/>
               </a:ext>
             </a:extLst>
           </p:cNvPr>
@@ -8329,8 +11042,8 @@
         </p:nvSpPr>
         <p:spPr>
           <a:xfrm>
-            <a:off x="1135117" y="4942490"/>
-            <a:ext cx="6096000" cy="923330"/>
+            <a:off x="4214811" y="6123543"/>
+            <a:ext cx="6807376" cy="369332"/>
           </a:xfrm>
           <a:prstGeom prst="rect">
             <a:avLst/>
@@ -8338,890 +11051,39 @@
           <a:noFill/>
         </p:spPr>
         <p:txBody>
-          <a:bodyPr wrap="square">
+          <a:bodyPr wrap="none" rtlCol="0">
             <a:spAutoFit/>
           </a:bodyPr>
           <a:lstStyle/>
           <a:p>
             <a:r>
-              <a:rPr lang="en-US" b="1" dirty="0" err="1"/>
-              <a:t>wikipedia_link_ru</a:t>
-            </a:r>
-            <a:endParaRPr lang="en-US" b="1" dirty="0"/>
-          </a:p>
-          <a:p>
-            <a:r>
-              <a:rPr lang="en-US"/>
-              <a:t>total run time: 76.6 sec </a:t>
-            </a:r>
-            <a:endParaRPr lang="en-US" dirty="0"/>
-          </a:p>
-          <a:p>
-            <a:r>
-              <a:rPr lang="en-US"/>
-              <a:t>host buffer read</a:t>
-            </a:r>
-            <a:r>
-              <a:rPr lang="en-US" dirty="0"/>
-              <a:t>/</a:t>
-            </a:r>
-            <a:r>
-              <a:rPr lang="en-US"/>
-              <a:t>write: 1.3 sec</a:t>
-            </a:r>
-            <a:endParaRPr lang="en-US" dirty="0"/>
-          </a:p>
-        </p:txBody>
-      </p:sp>
-      <p:sp>
-        <p:nvSpPr>
-          <p:cNvPr id="7" name="Rectangle 6">
-            <a:extLst>
-              <a:ext uri="{FF2B5EF4-FFF2-40B4-BE49-F238E27FC236}">
-                <a16:creationId xmlns:a16="http://schemas.microsoft.com/office/drawing/2014/main" id="{ADEFBDFB-41DF-7F29-62B9-ECD1A2DD775A}"/>
-              </a:ext>
-            </a:extLst>
-          </p:cNvPr>
-          <p:cNvSpPr/>
-          <p:nvPr/>
-        </p:nvSpPr>
-        <p:spPr>
-          <a:xfrm>
-            <a:off x="6369270" y="4001294"/>
-            <a:ext cx="3909848" cy="367862"/>
-          </a:xfrm>
-          <a:prstGeom prst="rect">
-            <a:avLst/>
-          </a:prstGeom>
-        </p:spPr>
-        <p:style>
-          <a:lnRef idx="2">
-            <a:schemeClr val="dk1"/>
-          </a:lnRef>
-          <a:fillRef idx="1">
-            <a:schemeClr val="lt1"/>
-          </a:fillRef>
-          <a:effectRef idx="0">
-            <a:schemeClr val="dk1"/>
-          </a:effectRef>
-          <a:fontRef idx="minor">
-            <a:schemeClr val="dk1"/>
-          </a:fontRef>
-        </p:style>
-        <p:txBody>
-          <a:bodyPr rtlCol="0" anchor="ctr"/>
-          <a:lstStyle/>
-          <a:p>
-            <a:pPr algn="ctr"/>
-            <a:endParaRPr lang="en-US" dirty="0"/>
-          </a:p>
-        </p:txBody>
-      </p:sp>
-      <p:sp>
-        <p:nvSpPr>
-          <p:cNvPr id="8" name="Rectangle 7">
-            <a:extLst>
-              <a:ext uri="{FF2B5EF4-FFF2-40B4-BE49-F238E27FC236}">
-                <a16:creationId xmlns:a16="http://schemas.microsoft.com/office/drawing/2014/main" id="{4CCA4AD0-905A-73B5-2396-1B60E26A33B2}"/>
-              </a:ext>
-            </a:extLst>
-          </p:cNvPr>
-          <p:cNvSpPr/>
-          <p:nvPr/>
-        </p:nvSpPr>
-        <p:spPr>
-          <a:xfrm>
-            <a:off x="6369269" y="4691091"/>
-            <a:ext cx="5281447" cy="367862"/>
-          </a:xfrm>
-          <a:prstGeom prst="rect">
-            <a:avLst/>
-          </a:prstGeom>
-        </p:spPr>
-        <p:style>
-          <a:lnRef idx="2">
-            <a:schemeClr val="dk1"/>
-          </a:lnRef>
-          <a:fillRef idx="1">
-            <a:schemeClr val="lt1"/>
-          </a:fillRef>
-          <a:effectRef idx="0">
-            <a:schemeClr val="dk1"/>
-          </a:effectRef>
-          <a:fontRef idx="minor">
-            <a:schemeClr val="dk1"/>
-          </a:fontRef>
-        </p:style>
-        <p:txBody>
-          <a:bodyPr rtlCol="0" anchor="ctr"/>
-          <a:lstStyle/>
-          <a:p>
-            <a:pPr algn="ctr"/>
-            <a:endParaRPr lang="en-US" dirty="0"/>
-          </a:p>
-        </p:txBody>
-      </p:sp>
-      <p:sp>
-        <p:nvSpPr>
-          <p:cNvPr id="9" name="Rectangle 8">
-            <a:extLst>
-              <a:ext uri="{FF2B5EF4-FFF2-40B4-BE49-F238E27FC236}">
-                <a16:creationId xmlns:a16="http://schemas.microsoft.com/office/drawing/2014/main" id="{B997D780-A2CF-ADE2-2254-21FE67E594F0}"/>
-              </a:ext>
-            </a:extLst>
-          </p:cNvPr>
-          <p:cNvSpPr/>
-          <p:nvPr/>
-        </p:nvSpPr>
-        <p:spPr>
-          <a:xfrm>
-            <a:off x="6453353" y="4051803"/>
-            <a:ext cx="178676" cy="266844"/>
-          </a:xfrm>
-          <a:prstGeom prst="rect">
-            <a:avLst/>
-          </a:prstGeom>
-        </p:spPr>
-        <p:style>
-          <a:lnRef idx="2">
-            <a:schemeClr val="accent1">
-              <a:shade val="15000"/>
-            </a:schemeClr>
-          </a:lnRef>
-          <a:fillRef idx="1">
-            <a:schemeClr val="accent1"/>
-          </a:fillRef>
-          <a:effectRef idx="0">
-            <a:schemeClr val="accent1"/>
-          </a:effectRef>
-          <a:fontRef idx="minor">
-            <a:schemeClr val="lt1"/>
-          </a:fontRef>
-        </p:style>
-        <p:txBody>
-          <a:bodyPr rtlCol="0" anchor="ctr"/>
-          <a:lstStyle/>
-          <a:p>
-            <a:pPr algn="ctr"/>
-            <a:endParaRPr lang="en-US"/>
-          </a:p>
-        </p:txBody>
-      </p:sp>
-      <p:sp>
-        <p:nvSpPr>
-          <p:cNvPr id="10" name="Rectangle 9">
-            <a:extLst>
-              <a:ext uri="{FF2B5EF4-FFF2-40B4-BE49-F238E27FC236}">
-                <a16:creationId xmlns:a16="http://schemas.microsoft.com/office/drawing/2014/main" id="{4DF4DC7D-F514-61BA-B92D-3CAC78907D58}"/>
-              </a:ext>
-            </a:extLst>
-          </p:cNvPr>
-          <p:cNvSpPr/>
-          <p:nvPr/>
-        </p:nvSpPr>
-        <p:spPr>
-          <a:xfrm>
-            <a:off x="6716112" y="4051803"/>
-            <a:ext cx="178676" cy="266844"/>
-          </a:xfrm>
-          <a:prstGeom prst="rect">
-            <a:avLst/>
-          </a:prstGeom>
-        </p:spPr>
-        <p:style>
-          <a:lnRef idx="2">
-            <a:schemeClr val="accent1">
-              <a:shade val="15000"/>
-            </a:schemeClr>
-          </a:lnRef>
-          <a:fillRef idx="1">
-            <a:schemeClr val="accent1"/>
-          </a:fillRef>
-          <a:effectRef idx="0">
-            <a:schemeClr val="accent1"/>
-          </a:effectRef>
-          <a:fontRef idx="minor">
-            <a:schemeClr val="lt1"/>
-          </a:fontRef>
-        </p:style>
-        <p:txBody>
-          <a:bodyPr rtlCol="0" anchor="ctr"/>
-          <a:lstStyle/>
-          <a:p>
-            <a:pPr algn="ctr"/>
-            <a:endParaRPr lang="en-US"/>
-          </a:p>
-        </p:txBody>
-      </p:sp>
-      <p:sp>
-        <p:nvSpPr>
-          <p:cNvPr id="11" name="Rectangle 10">
-            <a:extLst>
-              <a:ext uri="{FF2B5EF4-FFF2-40B4-BE49-F238E27FC236}">
-                <a16:creationId xmlns:a16="http://schemas.microsoft.com/office/drawing/2014/main" id="{8366C9C8-6328-FFE2-28BC-DDA56EF2F51E}"/>
-              </a:ext>
-            </a:extLst>
-          </p:cNvPr>
-          <p:cNvSpPr/>
-          <p:nvPr/>
-        </p:nvSpPr>
-        <p:spPr>
-          <a:xfrm>
-            <a:off x="6978871" y="4051803"/>
-            <a:ext cx="178676" cy="266844"/>
-          </a:xfrm>
-          <a:prstGeom prst="rect">
-            <a:avLst/>
-          </a:prstGeom>
-        </p:spPr>
-        <p:style>
-          <a:lnRef idx="2">
-            <a:schemeClr val="accent1">
-              <a:shade val="15000"/>
-            </a:schemeClr>
-          </a:lnRef>
-          <a:fillRef idx="1">
-            <a:schemeClr val="accent1"/>
-          </a:fillRef>
-          <a:effectRef idx="0">
-            <a:schemeClr val="accent1"/>
-          </a:effectRef>
-          <a:fontRef idx="minor">
-            <a:schemeClr val="lt1"/>
-          </a:fontRef>
-        </p:style>
-        <p:txBody>
-          <a:bodyPr rtlCol="0" anchor="ctr"/>
-          <a:lstStyle/>
-          <a:p>
-            <a:pPr algn="ctr"/>
-            <a:endParaRPr lang="en-US"/>
-          </a:p>
-        </p:txBody>
-      </p:sp>
-      <p:sp>
-        <p:nvSpPr>
-          <p:cNvPr id="12" name="Rectangle 11">
-            <a:extLst>
-              <a:ext uri="{FF2B5EF4-FFF2-40B4-BE49-F238E27FC236}">
-                <a16:creationId xmlns:a16="http://schemas.microsoft.com/office/drawing/2014/main" id="{A97CB73C-AF4D-75B5-9FF0-C8A040C2A12F}"/>
-              </a:ext>
-            </a:extLst>
-          </p:cNvPr>
-          <p:cNvSpPr/>
-          <p:nvPr/>
-        </p:nvSpPr>
-        <p:spPr>
-          <a:xfrm>
-            <a:off x="7241630" y="4051803"/>
-            <a:ext cx="178676" cy="266844"/>
-          </a:xfrm>
-          <a:prstGeom prst="rect">
-            <a:avLst/>
-          </a:prstGeom>
-        </p:spPr>
-        <p:style>
-          <a:lnRef idx="2">
-            <a:schemeClr val="accent1">
-              <a:shade val="15000"/>
-            </a:schemeClr>
-          </a:lnRef>
-          <a:fillRef idx="1">
-            <a:schemeClr val="accent1"/>
-          </a:fillRef>
-          <a:effectRef idx="0">
-            <a:schemeClr val="accent1"/>
-          </a:effectRef>
-          <a:fontRef idx="minor">
-            <a:schemeClr val="lt1"/>
-          </a:fontRef>
-        </p:style>
-        <p:txBody>
-          <a:bodyPr rtlCol="0" anchor="ctr"/>
-          <a:lstStyle/>
-          <a:p>
-            <a:pPr algn="ctr"/>
-            <a:endParaRPr lang="en-US"/>
-          </a:p>
-        </p:txBody>
-      </p:sp>
-      <p:sp>
-        <p:nvSpPr>
-          <p:cNvPr id="13" name="Rectangle 12">
-            <a:extLst>
-              <a:ext uri="{FF2B5EF4-FFF2-40B4-BE49-F238E27FC236}">
-                <a16:creationId xmlns:a16="http://schemas.microsoft.com/office/drawing/2014/main" id="{6DDC9702-9889-7364-6CE6-71121028C96E}"/>
-              </a:ext>
-            </a:extLst>
-          </p:cNvPr>
-          <p:cNvSpPr/>
-          <p:nvPr/>
-        </p:nvSpPr>
-        <p:spPr>
-          <a:xfrm>
-            <a:off x="7504389" y="4051803"/>
-            <a:ext cx="178676" cy="266844"/>
-          </a:xfrm>
-          <a:prstGeom prst="rect">
-            <a:avLst/>
-          </a:prstGeom>
-        </p:spPr>
-        <p:style>
-          <a:lnRef idx="2">
-            <a:schemeClr val="accent1">
-              <a:shade val="15000"/>
-            </a:schemeClr>
-          </a:lnRef>
-          <a:fillRef idx="1">
-            <a:schemeClr val="accent1"/>
-          </a:fillRef>
-          <a:effectRef idx="0">
-            <a:schemeClr val="accent1"/>
-          </a:effectRef>
-          <a:fontRef idx="minor">
-            <a:schemeClr val="lt1"/>
-          </a:fontRef>
-        </p:style>
-        <p:txBody>
-          <a:bodyPr rtlCol="0" anchor="ctr"/>
-          <a:lstStyle/>
-          <a:p>
-            <a:pPr algn="ctr"/>
-            <a:endParaRPr lang="en-US"/>
-          </a:p>
-        </p:txBody>
-      </p:sp>
-      <p:sp>
-        <p:nvSpPr>
-          <p:cNvPr id="14" name="Rectangle 13">
-            <a:extLst>
-              <a:ext uri="{FF2B5EF4-FFF2-40B4-BE49-F238E27FC236}">
-                <a16:creationId xmlns:a16="http://schemas.microsoft.com/office/drawing/2014/main" id="{9045F749-FD06-0D3D-7909-D2347A5FE9F5}"/>
-              </a:ext>
-            </a:extLst>
-          </p:cNvPr>
-          <p:cNvSpPr/>
-          <p:nvPr/>
-        </p:nvSpPr>
-        <p:spPr>
-          <a:xfrm>
-            <a:off x="7767148" y="4051803"/>
-            <a:ext cx="178676" cy="266844"/>
-          </a:xfrm>
-          <a:prstGeom prst="rect">
-            <a:avLst/>
-          </a:prstGeom>
-        </p:spPr>
-        <p:style>
-          <a:lnRef idx="2">
-            <a:schemeClr val="accent1">
-              <a:shade val="15000"/>
-            </a:schemeClr>
-          </a:lnRef>
-          <a:fillRef idx="1">
-            <a:schemeClr val="accent1"/>
-          </a:fillRef>
-          <a:effectRef idx="0">
-            <a:schemeClr val="accent1"/>
-          </a:effectRef>
-          <a:fontRef idx="minor">
-            <a:schemeClr val="lt1"/>
-          </a:fontRef>
-        </p:style>
-        <p:txBody>
-          <a:bodyPr rtlCol="0" anchor="ctr"/>
-          <a:lstStyle/>
-          <a:p>
-            <a:pPr algn="ctr"/>
-            <a:endParaRPr lang="en-US"/>
-          </a:p>
-        </p:txBody>
-      </p:sp>
-      <p:sp>
-        <p:nvSpPr>
-          <p:cNvPr id="15" name="Rectangle 14">
-            <a:extLst>
-              <a:ext uri="{FF2B5EF4-FFF2-40B4-BE49-F238E27FC236}">
-                <a16:creationId xmlns:a16="http://schemas.microsoft.com/office/drawing/2014/main" id="{2ABB24A6-520A-8390-DD38-29421AA7B233}"/>
-              </a:ext>
-            </a:extLst>
-          </p:cNvPr>
-          <p:cNvSpPr/>
-          <p:nvPr/>
-        </p:nvSpPr>
-        <p:spPr>
-          <a:xfrm>
-            <a:off x="7252141" y="4748964"/>
-            <a:ext cx="178676" cy="266844"/>
-          </a:xfrm>
-          <a:prstGeom prst="rect">
-            <a:avLst/>
-          </a:prstGeom>
-        </p:spPr>
-        <p:style>
-          <a:lnRef idx="2">
-            <a:schemeClr val="accent1">
-              <a:shade val="15000"/>
-            </a:schemeClr>
-          </a:lnRef>
-          <a:fillRef idx="1">
-            <a:schemeClr val="accent1"/>
-          </a:fillRef>
-          <a:effectRef idx="0">
-            <a:schemeClr val="accent1"/>
-          </a:effectRef>
-          <a:fontRef idx="minor">
-            <a:schemeClr val="lt1"/>
-          </a:fontRef>
-        </p:style>
-        <p:txBody>
-          <a:bodyPr rtlCol="0" anchor="ctr"/>
-          <a:lstStyle/>
-          <a:p>
-            <a:pPr algn="ctr"/>
-            <a:endParaRPr lang="en-US"/>
-          </a:p>
-        </p:txBody>
-      </p:sp>
-      <p:sp>
-        <p:nvSpPr>
-          <p:cNvPr id="16" name="Rectangle 15">
-            <a:extLst>
-              <a:ext uri="{FF2B5EF4-FFF2-40B4-BE49-F238E27FC236}">
-                <a16:creationId xmlns:a16="http://schemas.microsoft.com/office/drawing/2014/main" id="{F4A72DB4-0476-BAE8-979B-CA1FA6C5B484}"/>
-              </a:ext>
-            </a:extLst>
-          </p:cNvPr>
-          <p:cNvSpPr/>
-          <p:nvPr/>
-        </p:nvSpPr>
-        <p:spPr>
-          <a:xfrm>
-            <a:off x="7514900" y="4748964"/>
-            <a:ext cx="178676" cy="266844"/>
-          </a:xfrm>
-          <a:prstGeom prst="rect">
-            <a:avLst/>
-          </a:prstGeom>
-        </p:spPr>
-        <p:style>
-          <a:lnRef idx="2">
-            <a:schemeClr val="accent1">
-              <a:shade val="15000"/>
-            </a:schemeClr>
-          </a:lnRef>
-          <a:fillRef idx="1">
-            <a:schemeClr val="accent1"/>
-          </a:fillRef>
-          <a:effectRef idx="0">
-            <a:schemeClr val="accent1"/>
-          </a:effectRef>
-          <a:fontRef idx="minor">
-            <a:schemeClr val="lt1"/>
-          </a:fontRef>
-        </p:style>
-        <p:txBody>
-          <a:bodyPr rtlCol="0" anchor="ctr"/>
-          <a:lstStyle/>
-          <a:p>
-            <a:pPr algn="ctr"/>
-            <a:endParaRPr lang="en-US"/>
-          </a:p>
-        </p:txBody>
-      </p:sp>
-      <p:sp>
-        <p:nvSpPr>
-          <p:cNvPr id="17" name="Rectangle 16">
-            <a:extLst>
-              <a:ext uri="{FF2B5EF4-FFF2-40B4-BE49-F238E27FC236}">
-                <a16:creationId xmlns:a16="http://schemas.microsoft.com/office/drawing/2014/main" id="{5E183DA3-803D-4514-6E30-05674FA14CED}"/>
-              </a:ext>
-            </a:extLst>
-          </p:cNvPr>
-          <p:cNvSpPr/>
-          <p:nvPr/>
-        </p:nvSpPr>
-        <p:spPr>
-          <a:xfrm>
-            <a:off x="7777659" y="4748964"/>
-            <a:ext cx="178676" cy="266844"/>
-          </a:xfrm>
-          <a:prstGeom prst="rect">
-            <a:avLst/>
-          </a:prstGeom>
-        </p:spPr>
-        <p:style>
-          <a:lnRef idx="2">
-            <a:schemeClr val="accent1">
-              <a:shade val="15000"/>
-            </a:schemeClr>
-          </a:lnRef>
-          <a:fillRef idx="1">
-            <a:schemeClr val="accent1"/>
-          </a:fillRef>
-          <a:effectRef idx="0">
-            <a:schemeClr val="accent1"/>
-          </a:effectRef>
-          <a:fontRef idx="minor">
-            <a:schemeClr val="lt1"/>
-          </a:fontRef>
-        </p:style>
-        <p:txBody>
-          <a:bodyPr rtlCol="0" anchor="ctr"/>
-          <a:lstStyle/>
-          <a:p>
-            <a:pPr algn="ctr"/>
-            <a:endParaRPr lang="en-US"/>
-          </a:p>
-        </p:txBody>
-      </p:sp>
-      <p:sp>
-        <p:nvSpPr>
-          <p:cNvPr id="18" name="Rectangle 17">
-            <a:extLst>
-              <a:ext uri="{FF2B5EF4-FFF2-40B4-BE49-F238E27FC236}">
-                <a16:creationId xmlns:a16="http://schemas.microsoft.com/office/drawing/2014/main" id="{7A77F7D2-A995-61AE-E9F2-6048D1D7A137}"/>
-              </a:ext>
-            </a:extLst>
-          </p:cNvPr>
-          <p:cNvSpPr/>
-          <p:nvPr/>
-        </p:nvSpPr>
-        <p:spPr>
-          <a:xfrm>
-            <a:off x="8040418" y="4748964"/>
-            <a:ext cx="178676" cy="266844"/>
-          </a:xfrm>
-          <a:prstGeom prst="rect">
-            <a:avLst/>
-          </a:prstGeom>
-        </p:spPr>
-        <p:style>
-          <a:lnRef idx="2">
-            <a:schemeClr val="accent1">
-              <a:shade val="15000"/>
-            </a:schemeClr>
-          </a:lnRef>
-          <a:fillRef idx="1">
-            <a:schemeClr val="accent1"/>
-          </a:fillRef>
-          <a:effectRef idx="0">
-            <a:schemeClr val="accent1"/>
-          </a:effectRef>
-          <a:fontRef idx="minor">
-            <a:schemeClr val="lt1"/>
-          </a:fontRef>
-        </p:style>
-        <p:txBody>
-          <a:bodyPr rtlCol="0" anchor="ctr"/>
-          <a:lstStyle/>
-          <a:p>
-            <a:pPr algn="ctr"/>
-            <a:endParaRPr lang="en-US"/>
-          </a:p>
-        </p:txBody>
-      </p:sp>
-      <p:sp>
-        <p:nvSpPr>
-          <p:cNvPr id="19" name="Rectangle 18">
-            <a:extLst>
-              <a:ext uri="{FF2B5EF4-FFF2-40B4-BE49-F238E27FC236}">
-                <a16:creationId xmlns:a16="http://schemas.microsoft.com/office/drawing/2014/main" id="{A890374B-097C-5122-CBAD-2915914995C4}"/>
-              </a:ext>
-            </a:extLst>
-          </p:cNvPr>
-          <p:cNvSpPr/>
-          <p:nvPr/>
-        </p:nvSpPr>
-        <p:spPr>
-          <a:xfrm>
-            <a:off x="8303177" y="4748964"/>
-            <a:ext cx="178676" cy="266844"/>
-          </a:xfrm>
-          <a:prstGeom prst="rect">
-            <a:avLst/>
-          </a:prstGeom>
-        </p:spPr>
-        <p:style>
-          <a:lnRef idx="2">
-            <a:schemeClr val="accent1">
-              <a:shade val="15000"/>
-            </a:schemeClr>
-          </a:lnRef>
-          <a:fillRef idx="1">
-            <a:schemeClr val="accent1"/>
-          </a:fillRef>
-          <a:effectRef idx="0">
-            <a:schemeClr val="accent1"/>
-          </a:effectRef>
-          <a:fontRef idx="minor">
-            <a:schemeClr val="lt1"/>
-          </a:fontRef>
-        </p:style>
-        <p:txBody>
-          <a:bodyPr rtlCol="0" anchor="ctr"/>
-          <a:lstStyle/>
-          <a:p>
-            <a:pPr algn="ctr"/>
-            <a:endParaRPr lang="en-US"/>
-          </a:p>
-        </p:txBody>
-      </p:sp>
-      <p:sp>
-        <p:nvSpPr>
-          <p:cNvPr id="20" name="Rectangle 19">
-            <a:extLst>
-              <a:ext uri="{FF2B5EF4-FFF2-40B4-BE49-F238E27FC236}">
-                <a16:creationId xmlns:a16="http://schemas.microsoft.com/office/drawing/2014/main" id="{F87CEC49-1F7E-1E80-E876-1E69912CAB70}"/>
-              </a:ext>
-            </a:extLst>
-          </p:cNvPr>
-          <p:cNvSpPr/>
-          <p:nvPr/>
-        </p:nvSpPr>
-        <p:spPr>
-          <a:xfrm>
-            <a:off x="8565936" y="4748964"/>
-            <a:ext cx="178676" cy="266844"/>
-          </a:xfrm>
-          <a:prstGeom prst="rect">
-            <a:avLst/>
-          </a:prstGeom>
-        </p:spPr>
-        <p:style>
-          <a:lnRef idx="2">
-            <a:schemeClr val="accent1">
-              <a:shade val="15000"/>
-            </a:schemeClr>
-          </a:lnRef>
-          <a:fillRef idx="1">
-            <a:schemeClr val="accent1"/>
-          </a:fillRef>
-          <a:effectRef idx="0">
-            <a:schemeClr val="accent1"/>
-          </a:effectRef>
-          <a:fontRef idx="minor">
-            <a:schemeClr val="lt1"/>
-          </a:fontRef>
-        </p:style>
-        <p:txBody>
-          <a:bodyPr rtlCol="0" anchor="ctr"/>
-          <a:lstStyle/>
-          <a:p>
-            <a:pPr algn="ctr"/>
-            <a:endParaRPr lang="en-US"/>
-          </a:p>
-        </p:txBody>
-      </p:sp>
-      <p:sp>
-        <p:nvSpPr>
-          <p:cNvPr id="22" name="TextBox 21">
-            <a:extLst>
-              <a:ext uri="{FF2B5EF4-FFF2-40B4-BE49-F238E27FC236}">
-                <a16:creationId xmlns:a16="http://schemas.microsoft.com/office/drawing/2014/main" id="{7D979762-27FC-9B1F-8300-846E2E53A02D}"/>
-              </a:ext>
-            </a:extLst>
-          </p:cNvPr>
-          <p:cNvSpPr txBox="1"/>
-          <p:nvPr/>
-        </p:nvSpPr>
-        <p:spPr>
-          <a:xfrm>
-            <a:off x="6096000" y="3666756"/>
-            <a:ext cx="798786" cy="369332"/>
-          </a:xfrm>
-          <a:prstGeom prst="rect">
-            <a:avLst/>
-          </a:prstGeom>
-          <a:noFill/>
-        </p:spPr>
-        <p:txBody>
-          <a:bodyPr wrap="square">
-            <a:spAutoFit/>
-          </a:bodyPr>
-          <a:lstStyle/>
-          <a:p>
-            <a:pPr algn="ctr"/>
-            <a:r>
-              <a:rPr lang="en-US" dirty="0" err="1"/>
-              <a:t>Brd</a:t>
-            </a:r>
-            <a:endParaRPr lang="en-US" dirty="0"/>
-          </a:p>
-        </p:txBody>
-      </p:sp>
-      <p:sp>
-        <p:nvSpPr>
-          <p:cNvPr id="23" name="TextBox 22">
-            <a:extLst>
-              <a:ext uri="{FF2B5EF4-FFF2-40B4-BE49-F238E27FC236}">
-                <a16:creationId xmlns:a16="http://schemas.microsoft.com/office/drawing/2014/main" id="{05758331-BB25-1684-0F06-17283CFB3658}"/>
-              </a:ext>
-            </a:extLst>
-          </p:cNvPr>
-          <p:cNvSpPr txBox="1"/>
-          <p:nvPr/>
-        </p:nvSpPr>
-        <p:spPr>
-          <a:xfrm>
-            <a:off x="6001409" y="4379632"/>
-            <a:ext cx="798786" cy="369332"/>
-          </a:xfrm>
-          <a:prstGeom prst="rect">
-            <a:avLst/>
-          </a:prstGeom>
-          <a:noFill/>
-        </p:spPr>
-        <p:txBody>
-          <a:bodyPr wrap="square">
-            <a:spAutoFit/>
-          </a:bodyPr>
-          <a:lstStyle/>
-          <a:p>
-            <a:pPr algn="ctr"/>
-            <a:r>
-              <a:rPr lang="en-US" dirty="0"/>
-              <a:t>H</a:t>
-            </a:r>
-          </a:p>
-        </p:txBody>
-      </p:sp>
-      <p:sp>
-        <p:nvSpPr>
-          <p:cNvPr id="24" name="Rectangle 23">
-            <a:extLst>
-              <a:ext uri="{FF2B5EF4-FFF2-40B4-BE49-F238E27FC236}">
-                <a16:creationId xmlns:a16="http://schemas.microsoft.com/office/drawing/2014/main" id="{FCFCB574-DD58-2725-E233-047340E09CB3}"/>
-              </a:ext>
-            </a:extLst>
-          </p:cNvPr>
-          <p:cNvSpPr/>
-          <p:nvPr/>
-        </p:nvSpPr>
-        <p:spPr>
-          <a:xfrm>
-            <a:off x="6458611" y="4756913"/>
-            <a:ext cx="178676" cy="266844"/>
-          </a:xfrm>
-          <a:prstGeom prst="rect">
-            <a:avLst/>
-          </a:prstGeom>
-        </p:spPr>
-        <p:style>
-          <a:lnRef idx="1">
-            <a:schemeClr val="dk1"/>
-          </a:lnRef>
-          <a:fillRef idx="2">
-            <a:schemeClr val="dk1"/>
-          </a:fillRef>
-          <a:effectRef idx="1">
-            <a:schemeClr val="dk1"/>
-          </a:effectRef>
-          <a:fontRef idx="minor">
-            <a:schemeClr val="dk1"/>
-          </a:fontRef>
-        </p:style>
-        <p:txBody>
-          <a:bodyPr rtlCol="0" anchor="ctr"/>
-          <a:lstStyle/>
-          <a:p>
-            <a:pPr algn="ctr"/>
-            <a:endParaRPr lang="en-US"/>
-          </a:p>
-        </p:txBody>
-      </p:sp>
-      <p:sp>
-        <p:nvSpPr>
-          <p:cNvPr id="25" name="Rectangle 24">
-            <a:extLst>
-              <a:ext uri="{FF2B5EF4-FFF2-40B4-BE49-F238E27FC236}">
-                <a16:creationId xmlns:a16="http://schemas.microsoft.com/office/drawing/2014/main" id="{5FB0DF84-B1EE-F287-C1A8-3E3058C29298}"/>
-              </a:ext>
-            </a:extLst>
-          </p:cNvPr>
-          <p:cNvSpPr/>
-          <p:nvPr/>
-        </p:nvSpPr>
-        <p:spPr>
-          <a:xfrm>
-            <a:off x="6721370" y="4756913"/>
-            <a:ext cx="178676" cy="266844"/>
-          </a:xfrm>
-          <a:prstGeom prst="rect">
-            <a:avLst/>
-          </a:prstGeom>
-        </p:spPr>
-        <p:style>
-          <a:lnRef idx="1">
-            <a:schemeClr val="dk1"/>
-          </a:lnRef>
-          <a:fillRef idx="2">
-            <a:schemeClr val="dk1"/>
-          </a:fillRef>
-          <a:effectRef idx="1">
-            <a:schemeClr val="dk1"/>
-          </a:effectRef>
-          <a:fontRef idx="minor">
-            <a:schemeClr val="dk1"/>
-          </a:fontRef>
-        </p:style>
-        <p:txBody>
-          <a:bodyPr rtlCol="0" anchor="ctr"/>
-          <a:lstStyle/>
-          <a:p>
-            <a:pPr algn="ctr"/>
-            <a:endParaRPr lang="en-US"/>
-          </a:p>
-        </p:txBody>
-      </p:sp>
-      <p:sp>
-        <p:nvSpPr>
-          <p:cNvPr id="26" name="Rectangle 25">
-            <a:extLst>
-              <a:ext uri="{FF2B5EF4-FFF2-40B4-BE49-F238E27FC236}">
-                <a16:creationId xmlns:a16="http://schemas.microsoft.com/office/drawing/2014/main" id="{0590E2C1-92CB-2B2B-4BB2-1ADC3CEC5873}"/>
-              </a:ext>
-            </a:extLst>
-          </p:cNvPr>
-          <p:cNvSpPr/>
-          <p:nvPr/>
-        </p:nvSpPr>
-        <p:spPr>
-          <a:xfrm>
-            <a:off x="6984129" y="4756913"/>
-            <a:ext cx="178676" cy="266844"/>
-          </a:xfrm>
-          <a:prstGeom prst="rect">
-            <a:avLst/>
-          </a:prstGeom>
-        </p:spPr>
-        <p:style>
-          <a:lnRef idx="1">
-            <a:schemeClr val="dk1"/>
-          </a:lnRef>
-          <a:fillRef idx="2">
-            <a:schemeClr val="dk1"/>
-          </a:fillRef>
-          <a:effectRef idx="1">
-            <a:schemeClr val="dk1"/>
-          </a:effectRef>
-          <a:fontRef idx="minor">
-            <a:schemeClr val="dk1"/>
-          </a:fontRef>
-        </p:style>
-        <p:txBody>
-          <a:bodyPr rtlCol="0" anchor="ctr"/>
-          <a:lstStyle/>
-          <a:p>
-            <a:pPr algn="ctr"/>
-            <a:endParaRPr lang="en-US"/>
+              <a:rPr lang="en-US" dirty="0">
+                <a:solidFill>
+                  <a:srgbClr val="C00000"/>
+                </a:solidFill>
+              </a:rPr>
+              <a:t>This may explain why some instances in MQC are slower e.g. </a:t>
+            </a:r>
+            <a:r>
+              <a:rPr lang="en-US" dirty="0" err="1">
+                <a:solidFill>
+                  <a:srgbClr val="C00000"/>
+                </a:solidFill>
+              </a:rPr>
+              <a:t>Flixter</a:t>
+            </a:r>
+            <a:endParaRPr lang="en-US" dirty="0">
+              <a:solidFill>
+                <a:srgbClr val="C00000"/>
+              </a:solidFill>
+            </a:endParaRPr>
           </a:p>
         </p:txBody>
       </p:sp>
     </p:spTree>
     <p:extLst>
       <p:ext uri="{BB962C8B-B14F-4D97-AF65-F5344CB8AC3E}">
-        <p14:creationId xmlns:p14="http://schemas.microsoft.com/office/powerpoint/2010/main" val="2434206618"/>
+        <p14:creationId xmlns:p14="http://schemas.microsoft.com/office/powerpoint/2010/main" val="7016712"/>
       </p:ext>
     </p:extLst>
   </p:cSld>
@@ -9231,7 +11093,98 @@
 </p:sld>
 </file>
 
-<file path=ppt/slides/slide20.xml><?xml version="1.0" encoding="utf-8"?>
+<file path=ppt/slides/slide3.xml><?xml version="1.0" encoding="utf-8"?>
+<p:sld xmlns:a="http://schemas.openxmlformats.org/drawingml/2006/main" xmlns:r="http://schemas.openxmlformats.org/officeDocument/2006/relationships" xmlns:p="http://schemas.openxmlformats.org/presentationml/2006/main">
+  <p:cSld>
+    <p:spTree>
+      <p:nvGrpSpPr>
+        <p:cNvPr id="1" name=""/>
+        <p:cNvGrpSpPr/>
+        <p:nvPr/>
+      </p:nvGrpSpPr>
+      <p:grpSpPr>
+        <a:xfrm>
+          <a:off x="0" y="0"/>
+          <a:ext cx="0" cy="0"/>
+          <a:chOff x="0" y="0"/>
+          <a:chExt cx="0" cy="0"/>
+        </a:xfrm>
+      </p:grpSpPr>
+      <p:sp>
+        <p:nvSpPr>
+          <p:cNvPr id="2" name="Title 1">
+            <a:extLst>
+              <a:ext uri="{FF2B5EF4-FFF2-40B4-BE49-F238E27FC236}">
+                <a16:creationId xmlns:a16="http://schemas.microsoft.com/office/drawing/2014/main" id="{8DC03FD5-EB14-7CC3-5BB1-285AB4037A82}"/>
+              </a:ext>
+            </a:extLst>
+          </p:cNvPr>
+          <p:cNvSpPr>
+            <a:spLocks noGrp="1"/>
+          </p:cNvSpPr>
+          <p:nvPr>
+            <p:ph type="title"/>
+          </p:nvPr>
+        </p:nvSpPr>
+        <p:spPr/>
+        <p:txBody>
+          <a:bodyPr/>
+          <a:lstStyle/>
+          <a:p>
+            <a:r>
+              <a:rPr lang="en-US"/>
+              <a:t>Quasi Clique Application</a:t>
+            </a:r>
+            <a:endParaRPr lang="en-US" dirty="0"/>
+          </a:p>
+        </p:txBody>
+      </p:sp>
+      <p:pic>
+        <p:nvPicPr>
+          <p:cNvPr id="5" name="Content Placeholder 4">
+            <a:extLst>
+              <a:ext uri="{FF2B5EF4-FFF2-40B4-BE49-F238E27FC236}">
+                <a16:creationId xmlns:a16="http://schemas.microsoft.com/office/drawing/2014/main" id="{DFAC095E-BF34-B701-4D03-C8F4840B959B}"/>
+              </a:ext>
+            </a:extLst>
+          </p:cNvPr>
+          <p:cNvPicPr>
+            <a:picLocks noGrp="1" noChangeAspect="1"/>
+          </p:cNvPicPr>
+          <p:nvPr>
+            <p:ph idx="1"/>
+          </p:nvPr>
+        </p:nvPicPr>
+        <p:blipFill>
+          <a:blip r:embed="rId2"/>
+          <a:stretch>
+            <a:fillRect/>
+          </a:stretch>
+        </p:blipFill>
+        <p:spPr>
+          <a:xfrm>
+            <a:off x="3641600" y="1393191"/>
+            <a:ext cx="4908800" cy="5004489"/>
+          </a:xfrm>
+          <a:prstGeom prst="rect">
+            <a:avLst/>
+          </a:prstGeom>
+        </p:spPr>
+      </p:pic>
+    </p:spTree>
+    <p:extLst>
+      <p:ext uri="{BB962C8B-B14F-4D97-AF65-F5344CB8AC3E}">
+        <p14:creationId xmlns:p14="http://schemas.microsoft.com/office/powerpoint/2010/main" val="3961375031"/>
+      </p:ext>
+    </p:extLst>
+  </p:cSld>
+  <p:clrMapOvr>
+    <a:masterClrMapping/>
+  </p:clrMapOvr>
+</p:sld>
+</file>
+
+<file path=ppt/slides/slide30.xml><?xml version="1.0" encoding="utf-8"?>
 <p:sld xmlns:a="http://schemas.openxmlformats.org/drawingml/2006/main" xmlns:r="http://schemas.openxmlformats.org/officeDocument/2006/relationships" xmlns:p="http://schemas.openxmlformats.org/presentationml/2006/main">
   <p:cSld>
     <p:spTree>
@@ -9394,7 +11347,7 @@
 </p:sld>
 </file>
 
-<file path=ppt/slides/slide21.xml><?xml version="1.0" encoding="utf-8"?>
+<file path=ppt/slides/slide31.xml><?xml version="1.0" encoding="utf-8"?>
 <p:sld xmlns:a="http://schemas.openxmlformats.org/drawingml/2006/main" xmlns:r="http://schemas.openxmlformats.org/officeDocument/2006/relationships" xmlns:p="http://schemas.openxmlformats.org/presentationml/2006/main">
   <p:cSld>
     <p:spTree>
@@ -10052,7 +12005,7 @@
 </p:sld>
 </file>
 
-<file path=ppt/slides/slide22.xml><?xml version="1.0" encoding="utf-8"?>
+<file path=ppt/slides/slide32.xml><?xml version="1.0" encoding="utf-8"?>
 <p:sld xmlns:a="http://schemas.openxmlformats.org/drawingml/2006/main" xmlns:r="http://schemas.openxmlformats.org/officeDocument/2006/relationships" xmlns:p="http://schemas.openxmlformats.org/presentationml/2006/main">
   <p:cSld>
     <p:spTree>
@@ -10585,97 +12538,6 @@
     <p:extLst>
       <p:ext uri="{BB962C8B-B14F-4D97-AF65-F5344CB8AC3E}">
         <p14:creationId xmlns:p14="http://schemas.microsoft.com/office/powerpoint/2010/main" val="49281363"/>
-      </p:ext>
-    </p:extLst>
-  </p:cSld>
-  <p:clrMapOvr>
-    <a:masterClrMapping/>
-  </p:clrMapOvr>
-</p:sld>
-</file>
-
-<file path=ppt/slides/slide3.xml><?xml version="1.0" encoding="utf-8"?>
-<p:sld xmlns:a="http://schemas.openxmlformats.org/drawingml/2006/main" xmlns:r="http://schemas.openxmlformats.org/officeDocument/2006/relationships" xmlns:p="http://schemas.openxmlformats.org/presentationml/2006/main">
-  <p:cSld>
-    <p:spTree>
-      <p:nvGrpSpPr>
-        <p:cNvPr id="1" name=""/>
-        <p:cNvGrpSpPr/>
-        <p:nvPr/>
-      </p:nvGrpSpPr>
-      <p:grpSpPr>
-        <a:xfrm>
-          <a:off x="0" y="0"/>
-          <a:ext cx="0" cy="0"/>
-          <a:chOff x="0" y="0"/>
-          <a:chExt cx="0" cy="0"/>
-        </a:xfrm>
-      </p:grpSpPr>
-      <p:sp>
-        <p:nvSpPr>
-          <p:cNvPr id="2" name="Title 1">
-            <a:extLst>
-              <a:ext uri="{FF2B5EF4-FFF2-40B4-BE49-F238E27FC236}">
-                <a16:creationId xmlns:a16="http://schemas.microsoft.com/office/drawing/2014/main" id="{8DC03FD5-EB14-7CC3-5BB1-285AB4037A82}"/>
-              </a:ext>
-            </a:extLst>
-          </p:cNvPr>
-          <p:cNvSpPr>
-            <a:spLocks noGrp="1"/>
-          </p:cNvSpPr>
-          <p:nvPr>
-            <p:ph type="title"/>
-          </p:nvPr>
-        </p:nvSpPr>
-        <p:spPr/>
-        <p:txBody>
-          <a:bodyPr/>
-          <a:lstStyle/>
-          <a:p>
-            <a:r>
-              <a:rPr lang="en-US"/>
-              <a:t>Quasi Clique Application</a:t>
-            </a:r>
-            <a:endParaRPr lang="en-US" dirty="0"/>
-          </a:p>
-        </p:txBody>
-      </p:sp>
-      <p:pic>
-        <p:nvPicPr>
-          <p:cNvPr id="5" name="Content Placeholder 4">
-            <a:extLst>
-              <a:ext uri="{FF2B5EF4-FFF2-40B4-BE49-F238E27FC236}">
-                <a16:creationId xmlns:a16="http://schemas.microsoft.com/office/drawing/2014/main" id="{DFAC095E-BF34-B701-4D03-C8F4840B959B}"/>
-              </a:ext>
-            </a:extLst>
-          </p:cNvPr>
-          <p:cNvPicPr>
-            <a:picLocks noGrp="1" noChangeAspect="1"/>
-          </p:cNvPicPr>
-          <p:nvPr>
-            <p:ph idx="1"/>
-          </p:nvPr>
-        </p:nvPicPr>
-        <p:blipFill>
-          <a:blip r:embed="rId2"/>
-          <a:stretch>
-            <a:fillRect/>
-          </a:stretch>
-        </p:blipFill>
-        <p:spPr>
-          <a:xfrm>
-            <a:off x="3641600" y="1393191"/>
-            <a:ext cx="4908800" cy="5004489"/>
-          </a:xfrm>
-          <a:prstGeom prst="rect">
-            <a:avLst/>
-          </a:prstGeom>
-        </p:spPr>
-      </p:pic>
-    </p:spTree>
-    <p:extLst>
-      <p:ext uri="{BB962C8B-B14F-4D97-AF65-F5344CB8AC3E}">
-        <p14:creationId xmlns:p14="http://schemas.microsoft.com/office/powerpoint/2010/main" val="3961375031"/>
       </p:ext>
     </p:extLst>
   </p:cSld>

</xml_diff>

<commit_message>
auto commit 2026-08-08 11:30:04
</commit_message>
<xml_diff>
--- a/revision.pptx
+++ b/revision.pptx
@@ -27,16 +27,16 @@
     <p:sldId id="288" r:id="rId21"/>
     <p:sldId id="289" r:id="rId22"/>
     <p:sldId id="290" r:id="rId23"/>
-    <p:sldId id="275" r:id="rId24"/>
-    <p:sldId id="281" r:id="rId25"/>
-    <p:sldId id="283" r:id="rId26"/>
-    <p:sldId id="258" r:id="rId27"/>
-    <p:sldId id="276" r:id="rId28"/>
-    <p:sldId id="277" r:id="rId29"/>
-    <p:sldId id="282" r:id="rId30"/>
-    <p:sldId id="278" r:id="rId31"/>
-    <p:sldId id="279" r:id="rId32"/>
-    <p:sldId id="269" r:id="rId33"/>
+    <p:sldId id="291" r:id="rId24"/>
+    <p:sldId id="275" r:id="rId25"/>
+    <p:sldId id="281" r:id="rId26"/>
+    <p:sldId id="283" r:id="rId27"/>
+    <p:sldId id="258" r:id="rId28"/>
+    <p:sldId id="276" r:id="rId29"/>
+    <p:sldId id="277" r:id="rId30"/>
+    <p:sldId id="282" r:id="rId31"/>
+    <p:sldId id="278" r:id="rId32"/>
+    <p:sldId id="279" r:id="rId33"/>
   </p:sldIdLst>
   <p:sldSz cx="12192000" cy="6858000"/>
   <p:notesSz cx="6858000" cy="9144000"/>
@@ -9453,7 +9453,7 @@
           <p:cNvPr id="2" name="Title 1">
             <a:extLst>
               <a:ext uri="{FF2B5EF4-FFF2-40B4-BE49-F238E27FC236}">
-                <a16:creationId xmlns:a16="http://schemas.microsoft.com/office/drawing/2014/main" id="{F79AD936-1399-EE37-291B-F67F6F53B8C5}"/>
+                <a16:creationId xmlns:a16="http://schemas.microsoft.com/office/drawing/2014/main" id="{31844550-FF5F-F747-4570-492D318B85FD}"/>
               </a:ext>
             </a:extLst>
           </p:cNvPr>
@@ -9471,7 +9471,7 @@
           <a:p>
             <a:r>
               <a:rPr lang="en-US" dirty="0"/>
-              <a:t>SM Application</a:t>
+              <a:t>Datasets for QC</a:t>
             </a:r>
           </a:p>
         </p:txBody>
@@ -9481,7 +9481,7 @@
           <p:cNvPr id="3" name="Content Placeholder 2">
             <a:extLst>
               <a:ext uri="{FF2B5EF4-FFF2-40B4-BE49-F238E27FC236}">
-                <a16:creationId xmlns:a16="http://schemas.microsoft.com/office/drawing/2014/main" id="{8FA57192-4680-17A3-7ACB-2A18544BDEC2}"/>
+                <a16:creationId xmlns:a16="http://schemas.microsoft.com/office/drawing/2014/main" id="{0523F0E2-9CAB-CF89-EB93-6E044F6F9AB2}"/>
               </a:ext>
             </a:extLst>
           </p:cNvPr>
@@ -9494,35 +9494,146 @@
         </p:nvSpPr>
         <p:spPr/>
         <p:txBody>
-          <a:bodyPr/>
+          <a:bodyPr>
+            <a:normAutofit fontScale="92500" lnSpcReduction="10000"/>
+          </a:bodyPr>
           <a:lstStyle/>
           <a:p>
-            <a:pPr lvl="0"/>
+            <a:r>
+              <a:rPr lang="en-US" dirty="0">
+                <a:solidFill>
+                  <a:srgbClr val="C00000"/>
+                </a:solidFill>
+              </a:rPr>
+              <a:t>Make sure datasets in Table 1 run OOM. If not, then QC (with some parameters set) gives good results and can be added to Application 3. Kick out those in Table 1 that do not run OOM, but gives bad QC results.</a:t>
+            </a:r>
+          </a:p>
+          <a:p>
+            <a:endParaRPr lang="en-US" dirty="0">
+              <a:solidFill>
+                <a:schemeClr val="accent1"/>
+              </a:solidFill>
+            </a:endParaRPr>
+          </a:p>
+          <a:p>
             <a:r>
               <a:rPr lang="en-US" dirty="0"/>
-              <a:t>G2-AIMD fails in two cases due to out-of-memory (OOM) errors and is consistently slower than GPU-Layered, with slowdowns of up to 1.98×.</a:t>
-            </a:r>
-          </a:p>
-          <a:p>
-            <a:pPr lvl="0"/>
+              <a:t>All datasets in </a:t>
+            </a:r>
+            <a:r>
+              <a:rPr lang="en-US" b="1" dirty="0"/>
+              <a:t>Table 1</a:t>
+            </a:r>
             <a:r>
               <a:rPr lang="en-US" dirty="0"/>
-              <a:t>GPU-Layered outperforms GPU-Hybrid in nearly all cases.</a:t>
-            </a:r>
-          </a:p>
-          <a:p>
-            <a:pPr lvl="0"/>
-            <a:r>
-              <a:rPr lang="en-US" dirty="0"/>
-              <a:t>The CPU-only implementation is prohibitively slow for this application, which also limits the performance of the CPU+GPU approach in CPU-bound scenarios.</a:t>
-            </a:r>
+              <a:t> ran out of memory (OOM) when using the QC dataset format (2-hop neighbors). For many datasets, the output file could not even be generated because its size would reach terabytes (TBs). Only the following datasets could be generated:</a:t>
+            </a:r>
+          </a:p>
+          <a:p>
+            <a:pPr lvl="1"/>
+            <a:r>
+              <a:rPr lang="en-US" dirty="0">
+                <a:solidFill>
+                  <a:schemeClr val="accent1"/>
+                </a:solidFill>
+              </a:rPr>
+              <a:t>310G </a:t>
+            </a:r>
+            <a:r>
+              <a:rPr lang="en-US" dirty="0" err="1">
+                <a:solidFill>
+                  <a:schemeClr val="accent1"/>
+                </a:solidFill>
+              </a:rPr>
+              <a:t>wikipedia_link_sh</a:t>
+            </a:r>
+            <a:endParaRPr lang="en-US" dirty="0">
+              <a:solidFill>
+                <a:schemeClr val="accent1"/>
+              </a:solidFill>
+            </a:endParaRPr>
+          </a:p>
+          <a:p>
+            <a:pPr lvl="1"/>
+            <a:r>
+              <a:rPr lang="en-US" dirty="0">
+                <a:solidFill>
+                  <a:schemeClr val="accent1"/>
+                </a:solidFill>
+              </a:rPr>
+              <a:t>623G </a:t>
+            </a:r>
+            <a:r>
+              <a:rPr lang="en-US" dirty="0" err="1">
+                <a:solidFill>
+                  <a:schemeClr val="accent1"/>
+                </a:solidFill>
+              </a:rPr>
+              <a:t>wikipedia_link_sr</a:t>
+            </a:r>
+            <a:endParaRPr lang="en-US" dirty="0">
+              <a:solidFill>
+                <a:schemeClr val="accent1"/>
+              </a:solidFill>
+            </a:endParaRPr>
+          </a:p>
+          <a:p>
+            <a:pPr lvl="1"/>
+            <a:r>
+              <a:rPr lang="en-US" dirty="0">
+                <a:solidFill>
+                  <a:schemeClr val="accent1"/>
+                </a:solidFill>
+              </a:rPr>
+              <a:t>1.8T </a:t>
+            </a:r>
+            <a:r>
+              <a:rPr lang="en-US" dirty="0" err="1">
+                <a:solidFill>
+                  <a:schemeClr val="accent1"/>
+                </a:solidFill>
+              </a:rPr>
+              <a:t>wikipedia_link_de</a:t>
+            </a:r>
+            <a:endParaRPr lang="en-US" dirty="0">
+              <a:solidFill>
+                <a:schemeClr val="accent1"/>
+              </a:solidFill>
+            </a:endParaRPr>
+          </a:p>
+          <a:p>
+            <a:pPr lvl="1"/>
+            <a:r>
+              <a:rPr lang="en-US" dirty="0">
+                <a:solidFill>
+                  <a:schemeClr val="accent1"/>
+                </a:solidFill>
+              </a:rPr>
+              <a:t>364G link-dynamic-</a:t>
+            </a:r>
+            <a:r>
+              <a:rPr lang="en-US" dirty="0" err="1">
+                <a:solidFill>
+                  <a:schemeClr val="accent1"/>
+                </a:solidFill>
+              </a:rPr>
+              <a:t>frwiki</a:t>
+            </a:r>
+            <a:endParaRPr lang="en-US" dirty="0">
+              <a:solidFill>
+                <a:schemeClr val="accent1"/>
+              </a:solidFill>
+            </a:endParaRPr>
+          </a:p>
+          <a:p>
+            <a:endParaRPr lang="en-US" dirty="0"/>
           </a:p>
         </p:txBody>
       </p:sp>
     </p:spTree>
     <p:extLst>
       <p:ext uri="{BB962C8B-B14F-4D97-AF65-F5344CB8AC3E}">
-        <p14:creationId xmlns:p14="http://schemas.microsoft.com/office/powerpoint/2010/main" val="4081842575"/>
+        <p14:creationId xmlns:p14="http://schemas.microsoft.com/office/powerpoint/2010/main" val="1752771575"/>
       </p:ext>
     </p:extLst>
   </p:cSld>
@@ -9554,7 +9665,7 @@
           <p:cNvPr id="2" name="Title 1">
             <a:extLst>
               <a:ext uri="{FF2B5EF4-FFF2-40B4-BE49-F238E27FC236}">
-                <a16:creationId xmlns:a16="http://schemas.microsoft.com/office/drawing/2014/main" id="{46A5DAA1-1F51-475B-350C-03993AAE1EFC}"/>
+                <a16:creationId xmlns:a16="http://schemas.microsoft.com/office/drawing/2014/main" id="{F79AD936-1399-EE37-291B-F67F6F53B8C5}"/>
               </a:ext>
             </a:extLst>
           </p:cNvPr>
@@ -9572,7 +9683,7 @@
           <a:p>
             <a:r>
               <a:rPr lang="en-US" dirty="0"/>
-              <a:t>MQC Application</a:t>
+              <a:t>SM Application</a:t>
             </a:r>
           </a:p>
         </p:txBody>
@@ -9582,7 +9693,7 @@
           <p:cNvPr id="3" name="Content Placeholder 2">
             <a:extLst>
               <a:ext uri="{FF2B5EF4-FFF2-40B4-BE49-F238E27FC236}">
-                <a16:creationId xmlns:a16="http://schemas.microsoft.com/office/drawing/2014/main" id="{8E0728CE-78F1-153D-476C-635EE54A2221}"/>
+                <a16:creationId xmlns:a16="http://schemas.microsoft.com/office/drawing/2014/main" id="{8FA57192-4680-17A3-7ACB-2A18544BDEC2}"/>
               </a:ext>
             </a:extLst>
           </p:cNvPr>
@@ -9601,28 +9712,21 @@
             <a:pPr lvl="0"/>
             <a:r>
               <a:rPr lang="en-US" dirty="0"/>
-              <a:t>G2-AIMD runs out of memory on two datasets and is up to 2.43× slower.</a:t>
+              <a:t>G2-AIMD fails in two cases due to out-of-memory (OOM) errors and is consistently slower than GPU-Layered, with slowdowns of up to 1.98×.</a:t>
             </a:r>
           </a:p>
           <a:p>
             <a:pPr lvl="0"/>
             <a:r>
               <a:rPr lang="en-US" dirty="0"/>
-              <a:t>GPU-Layered consistently outperforms GPU-hybrid.</a:t>
+              <a:t>GPU-Layered outperforms GPU-Hybrid in nearly all cases.</a:t>
             </a:r>
           </a:p>
           <a:p>
             <a:pPr lvl="0"/>
             <a:r>
               <a:rPr lang="en-US" dirty="0"/>
-              <a:t>Fixed GPU chunk sizes caused poor utilization, motivating adaptive chunk sizing.</a:t>
-            </a:r>
-          </a:p>
-          <a:p>
-            <a:pPr lvl="0"/>
-            <a:r>
-              <a:rPr lang="en-US" dirty="0"/>
-              <a:t>The combined CPU+GPU approach consistently outperforms GPU-Layered by up to 21.1×.</a:t>
+              <a:t>The CPU-only implementation is prohibitively slow for this application, which also limits the performance of the CPU+GPU approach in CPU-bound scenarios.</a:t>
             </a:r>
           </a:p>
         </p:txBody>
@@ -9630,7 +9734,7 @@
     </p:spTree>
     <p:extLst>
       <p:ext uri="{BB962C8B-B14F-4D97-AF65-F5344CB8AC3E}">
-        <p14:creationId xmlns:p14="http://schemas.microsoft.com/office/powerpoint/2010/main" val="3836206850"/>
+        <p14:creationId xmlns:p14="http://schemas.microsoft.com/office/powerpoint/2010/main" val="4081842575"/>
       </p:ext>
     </p:extLst>
   </p:cSld>
@@ -9662,6 +9766,114 @@
           <p:cNvPr id="2" name="Title 1">
             <a:extLst>
               <a:ext uri="{FF2B5EF4-FFF2-40B4-BE49-F238E27FC236}">
+                <a16:creationId xmlns:a16="http://schemas.microsoft.com/office/drawing/2014/main" id="{46A5DAA1-1F51-475B-350C-03993AAE1EFC}"/>
+              </a:ext>
+            </a:extLst>
+          </p:cNvPr>
+          <p:cNvSpPr>
+            <a:spLocks noGrp="1"/>
+          </p:cNvSpPr>
+          <p:nvPr>
+            <p:ph type="title"/>
+          </p:nvPr>
+        </p:nvSpPr>
+        <p:spPr/>
+        <p:txBody>
+          <a:bodyPr/>
+          <a:lstStyle/>
+          <a:p>
+            <a:r>
+              <a:rPr lang="en-US" dirty="0"/>
+              <a:t>MQC Application</a:t>
+            </a:r>
+          </a:p>
+        </p:txBody>
+      </p:sp>
+      <p:sp>
+        <p:nvSpPr>
+          <p:cNvPr id="3" name="Content Placeholder 2">
+            <a:extLst>
+              <a:ext uri="{FF2B5EF4-FFF2-40B4-BE49-F238E27FC236}">
+                <a16:creationId xmlns:a16="http://schemas.microsoft.com/office/drawing/2014/main" id="{8E0728CE-78F1-153D-476C-635EE54A2221}"/>
+              </a:ext>
+            </a:extLst>
+          </p:cNvPr>
+          <p:cNvSpPr>
+            <a:spLocks noGrp="1"/>
+          </p:cNvSpPr>
+          <p:nvPr>
+            <p:ph idx="1"/>
+          </p:nvPr>
+        </p:nvSpPr>
+        <p:spPr/>
+        <p:txBody>
+          <a:bodyPr/>
+          <a:lstStyle/>
+          <a:p>
+            <a:pPr lvl="0"/>
+            <a:r>
+              <a:rPr lang="en-US" dirty="0"/>
+              <a:t>G2-AIMD runs out of memory on two datasets and is up to 2.43× slower.</a:t>
+            </a:r>
+          </a:p>
+          <a:p>
+            <a:pPr lvl="0"/>
+            <a:r>
+              <a:rPr lang="en-US" dirty="0"/>
+              <a:t>GPU-Layered consistently outperforms GPU-hybrid.</a:t>
+            </a:r>
+          </a:p>
+          <a:p>
+            <a:pPr lvl="0"/>
+            <a:r>
+              <a:rPr lang="en-US" dirty="0"/>
+              <a:t>Fixed GPU chunk sizes caused poor utilization, motivating adaptive chunk sizing.</a:t>
+            </a:r>
+          </a:p>
+          <a:p>
+            <a:pPr lvl="0"/>
+            <a:r>
+              <a:rPr lang="en-US" dirty="0"/>
+              <a:t>The combined CPU+GPU approach consistently outperforms GPU-Layered by up to 21.1×.</a:t>
+            </a:r>
+          </a:p>
+        </p:txBody>
+      </p:sp>
+    </p:spTree>
+    <p:extLst>
+      <p:ext uri="{BB962C8B-B14F-4D97-AF65-F5344CB8AC3E}">
+        <p14:creationId xmlns:p14="http://schemas.microsoft.com/office/powerpoint/2010/main" val="3836206850"/>
+      </p:ext>
+    </p:extLst>
+  </p:cSld>
+  <p:clrMapOvr>
+    <a:masterClrMapping/>
+  </p:clrMapOvr>
+</p:sld>
+</file>
+
+<file path=ppt/slides/slide26.xml><?xml version="1.0" encoding="utf-8"?>
+<p:sld xmlns:a="http://schemas.openxmlformats.org/drawingml/2006/main" xmlns:r="http://schemas.openxmlformats.org/officeDocument/2006/relationships" xmlns:p="http://schemas.openxmlformats.org/presentationml/2006/main">
+  <p:cSld>
+    <p:spTree>
+      <p:nvGrpSpPr>
+        <p:cNvPr id="1" name=""/>
+        <p:cNvGrpSpPr/>
+        <p:nvPr/>
+      </p:nvGrpSpPr>
+      <p:grpSpPr>
+        <a:xfrm>
+          <a:off x="0" y="0"/>
+          <a:ext cx="0" cy="0"/>
+          <a:chOff x="0" y="0"/>
+          <a:chExt cx="0" cy="0"/>
+        </a:xfrm>
+      </p:grpSpPr>
+      <p:sp>
+        <p:nvSpPr>
+          <p:cNvPr id="2" name="Title 1">
+            <a:extLst>
+              <a:ext uri="{FF2B5EF4-FFF2-40B4-BE49-F238E27FC236}">
                 <a16:creationId xmlns:a16="http://schemas.microsoft.com/office/drawing/2014/main" id="{40527D02-03A8-BD45-4197-6BC5DC71D7C1}"/>
               </a:ext>
             </a:extLst>
@@ -9858,7 +10070,7 @@
 </p:sld>
 </file>
 
-<file path=ppt/slides/slide26.xml><?xml version="1.0" encoding="utf-8"?>
+<file path=ppt/slides/slide27.xml><?xml version="1.0" encoding="utf-8"?>
 <p:sld xmlns:a="http://schemas.openxmlformats.org/drawingml/2006/main" xmlns:r="http://schemas.openxmlformats.org/officeDocument/2006/relationships" xmlns:p="http://schemas.openxmlformats.org/presentationml/2006/main">
   <p:cSld>
     <p:spTree>
@@ -10188,489 +10400,6 @@
 </p:sld>
 </file>
 
-<file path=ppt/slides/slide27.xml><?xml version="1.0" encoding="utf-8"?>
-<p:sld xmlns:a="http://schemas.openxmlformats.org/drawingml/2006/main" xmlns:r="http://schemas.openxmlformats.org/officeDocument/2006/relationships" xmlns:p="http://schemas.openxmlformats.org/presentationml/2006/main">
-  <p:cSld>
-    <p:spTree>
-      <p:nvGrpSpPr>
-        <p:cNvPr id="1" name=""/>
-        <p:cNvGrpSpPr/>
-        <p:nvPr/>
-      </p:nvGrpSpPr>
-      <p:grpSpPr>
-        <a:xfrm>
-          <a:off x="0" y="0"/>
-          <a:ext cx="0" cy="0"/>
-          <a:chOff x="0" y="0"/>
-          <a:chExt cx="0" cy="0"/>
-        </a:xfrm>
-      </p:grpSpPr>
-      <p:sp>
-        <p:nvSpPr>
-          <p:cNvPr id="2" name="Title 1">
-            <a:extLst>
-              <a:ext uri="{FF2B5EF4-FFF2-40B4-BE49-F238E27FC236}">
-                <a16:creationId xmlns:a16="http://schemas.microsoft.com/office/drawing/2014/main" id="{EAC15F67-CC66-76E8-1A76-6F2AF3484E9F}"/>
-              </a:ext>
-            </a:extLst>
-          </p:cNvPr>
-          <p:cNvSpPr>
-            <a:spLocks noGrp="1"/>
-          </p:cNvSpPr>
-          <p:nvPr>
-            <p:ph type="title"/>
-          </p:nvPr>
-        </p:nvSpPr>
-        <p:spPr/>
-        <p:txBody>
-          <a:bodyPr/>
-          <a:lstStyle/>
-          <a:p>
-            <a:r>
-              <a:rPr lang="en-US" dirty="0"/>
-              <a:t>Buffer Reservation – System </a:t>
-            </a:r>
-          </a:p>
-        </p:txBody>
-      </p:sp>
-      <p:sp>
-        <p:nvSpPr>
-          <p:cNvPr id="3" name="Content Placeholder 2">
-            <a:extLst>
-              <a:ext uri="{FF2B5EF4-FFF2-40B4-BE49-F238E27FC236}">
-                <a16:creationId xmlns:a16="http://schemas.microsoft.com/office/drawing/2014/main" id="{2C54BF8F-E991-6701-FF2B-CB1E55E6C7C5}"/>
-              </a:ext>
-            </a:extLst>
-          </p:cNvPr>
-          <p:cNvSpPr>
-            <a:spLocks noGrp="1"/>
-          </p:cNvSpPr>
-          <p:nvPr>
-            <p:ph idx="1"/>
-          </p:nvPr>
-        </p:nvSpPr>
-        <p:spPr>
-          <a:xfrm>
-            <a:off x="838200" y="1825625"/>
-            <a:ext cx="10515600" cy="1535906"/>
-          </a:xfrm>
-        </p:spPr>
-        <p:txBody>
-          <a:bodyPr>
-            <a:normAutofit fontScale="92500" lnSpcReduction="20000"/>
-          </a:bodyPr>
-          <a:lstStyle/>
-          <a:p>
-            <a:r>
-              <a:rPr lang="en-US" dirty="0" err="1"/>
-              <a:t>BufferReservation</a:t>
-            </a:r>
-            <a:r>
-              <a:rPr lang="en-US" dirty="0"/>
-              <a:t> is a small value returned by append</a:t>
-            </a:r>
-          </a:p>
-          <a:p>
-            <a:r>
-              <a:rPr lang="en-US" dirty="0"/>
-              <a:t>The system tries the device buffer first. If failed, it appends on host buffer. </a:t>
-            </a:r>
-          </a:p>
-          <a:p>
-            <a:r>
-              <a:rPr lang="en-US" dirty="0"/>
-              <a:t>In hybrid-drop mode, it does not append on host</a:t>
-            </a:r>
-          </a:p>
-          <a:p>
-            <a:endParaRPr lang="en-US" dirty="0"/>
-          </a:p>
-        </p:txBody>
-      </p:sp>
-      <p:sp>
-        <p:nvSpPr>
-          <p:cNvPr id="5" name="TextBox 4">
-            <a:extLst>
-              <a:ext uri="{FF2B5EF4-FFF2-40B4-BE49-F238E27FC236}">
-                <a16:creationId xmlns:a16="http://schemas.microsoft.com/office/drawing/2014/main" id="{35B8D59D-4C1E-F677-6507-4B0E32C9983D}"/>
-              </a:ext>
-            </a:extLst>
-          </p:cNvPr>
-          <p:cNvSpPr txBox="1"/>
-          <p:nvPr/>
-        </p:nvSpPr>
-        <p:spPr>
-          <a:xfrm>
-            <a:off x="7409793" y="157719"/>
-            <a:ext cx="6096000" cy="1600438"/>
-          </a:xfrm>
-          <a:prstGeom prst="rect">
-            <a:avLst/>
-          </a:prstGeom>
-          <a:noFill/>
-        </p:spPr>
-        <p:txBody>
-          <a:bodyPr wrap="square">
-            <a:spAutoFit/>
-          </a:bodyPr>
-          <a:lstStyle/>
-          <a:p>
-            <a:pPr rtl="0">
-              <a:buNone/>
-            </a:pPr>
-            <a:r>
-              <a:rPr lang="en-US" sz="1400" dirty="0">
-                <a:latin typeface="Consolas" panose="020B0609020204030204" pitchFamily="49" charset="0"/>
-                <a:cs typeface="Consolas" panose="020B0609020204030204" pitchFamily="49" charset="0"/>
-              </a:rPr>
-              <a:t>struct </a:t>
-            </a:r>
-            <a:r>
-              <a:rPr lang="en-US" sz="1400" dirty="0" err="1">
-                <a:latin typeface="Consolas" panose="020B0609020204030204" pitchFamily="49" charset="0"/>
-                <a:cs typeface="Consolas" panose="020B0609020204030204" pitchFamily="49" charset="0"/>
-              </a:rPr>
-              <a:t>BufferReservation</a:t>
-            </a:r>
-            <a:r>
-              <a:rPr lang="en-US" sz="1400" dirty="0">
-                <a:latin typeface="Consolas" panose="020B0609020204030204" pitchFamily="49" charset="0"/>
-                <a:cs typeface="Consolas" panose="020B0609020204030204" pitchFamily="49" charset="0"/>
-              </a:rPr>
-              <a:t>{</a:t>
-            </a:r>
-          </a:p>
-          <a:p>
-            <a:pPr rtl="0">
-              <a:buNone/>
-            </a:pPr>
-            <a:r>
-              <a:rPr lang="en-US" sz="1400" dirty="0">
-                <a:latin typeface="Consolas" panose="020B0609020204030204" pitchFamily="49" charset="0"/>
-                <a:cs typeface="Consolas" panose="020B0609020204030204" pitchFamily="49" charset="0"/>
-              </a:rPr>
-              <a:t>    </a:t>
-            </a:r>
-            <a:r>
-              <a:rPr lang="en-US" sz="1400" dirty="0" err="1">
-                <a:latin typeface="Consolas" panose="020B0609020204030204" pitchFamily="49" charset="0"/>
-                <a:cs typeface="Consolas" panose="020B0609020204030204" pitchFamily="49" charset="0"/>
-              </a:rPr>
-              <a:t>ull</a:t>
-            </a:r>
-            <a:r>
-              <a:rPr lang="en-US" sz="1400" dirty="0">
-                <a:latin typeface="Consolas" panose="020B0609020204030204" pitchFamily="49" charset="0"/>
-                <a:cs typeface="Consolas" panose="020B0609020204030204" pitchFamily="49" charset="0"/>
-              </a:rPr>
-              <a:t> </a:t>
-            </a:r>
-            <a:r>
-              <a:rPr lang="en-US" sz="1400" dirty="0" err="1">
-                <a:latin typeface="Consolas" panose="020B0609020204030204" pitchFamily="49" charset="0"/>
-                <a:cs typeface="Consolas" panose="020B0609020204030204" pitchFamily="49" charset="0"/>
-              </a:rPr>
-              <a:t>vt</a:t>
-            </a:r>
-            <a:r>
-              <a:rPr lang="en-US" sz="1400" dirty="0">
-                <a:latin typeface="Consolas" panose="020B0609020204030204" pitchFamily="49" charset="0"/>
-                <a:cs typeface="Consolas" panose="020B0609020204030204" pitchFamily="49" charset="0"/>
-              </a:rPr>
-              <a:t>;</a:t>
-            </a:r>
-          </a:p>
-          <a:p>
-            <a:pPr rtl="0">
-              <a:buNone/>
-            </a:pPr>
-            <a:r>
-              <a:rPr lang="en-US" sz="1400" dirty="0">
-                <a:latin typeface="Consolas" panose="020B0609020204030204" pitchFamily="49" charset="0"/>
-                <a:cs typeface="Consolas" panose="020B0609020204030204" pitchFamily="49" charset="0"/>
-              </a:rPr>
-              <a:t>    bool </a:t>
-            </a:r>
-            <a:r>
-              <a:rPr lang="en-US" sz="1400" dirty="0" err="1">
-                <a:latin typeface="Consolas" panose="020B0609020204030204" pitchFamily="49" charset="0"/>
-                <a:cs typeface="Consolas" panose="020B0609020204030204" pitchFamily="49" charset="0"/>
-              </a:rPr>
-              <a:t>to_host</a:t>
-            </a:r>
-            <a:r>
-              <a:rPr lang="en-US" sz="1400" dirty="0">
-                <a:latin typeface="Consolas" panose="020B0609020204030204" pitchFamily="49" charset="0"/>
-                <a:cs typeface="Consolas" panose="020B0609020204030204" pitchFamily="49" charset="0"/>
-              </a:rPr>
-              <a:t>;</a:t>
-            </a:r>
-          </a:p>
-          <a:p>
-            <a:pPr rtl="0">
-              <a:buNone/>
-            </a:pPr>
-            <a:r>
-              <a:rPr lang="en-US" sz="1400" dirty="0">
-                <a:latin typeface="Consolas" panose="020B0609020204030204" pitchFamily="49" charset="0"/>
-                <a:cs typeface="Consolas" panose="020B0609020204030204" pitchFamily="49" charset="0"/>
-              </a:rPr>
-              <a:t>    __device__ __host__ bool valid()const{</a:t>
-            </a:r>
-          </a:p>
-          <a:p>
-            <a:pPr rtl="0">
-              <a:buNone/>
-            </a:pPr>
-            <a:r>
-              <a:rPr lang="en-US" sz="1400" dirty="0">
-                <a:latin typeface="Consolas" panose="020B0609020204030204" pitchFamily="49" charset="0"/>
-                <a:cs typeface="Consolas" panose="020B0609020204030204" pitchFamily="49" charset="0"/>
-              </a:rPr>
-              <a:t>        return </a:t>
-            </a:r>
-            <a:r>
-              <a:rPr lang="en-US" sz="1400" dirty="0" err="1">
-                <a:latin typeface="Consolas" panose="020B0609020204030204" pitchFamily="49" charset="0"/>
-                <a:cs typeface="Consolas" panose="020B0609020204030204" pitchFamily="49" charset="0"/>
-              </a:rPr>
-              <a:t>vt</a:t>
-            </a:r>
-            <a:r>
-              <a:rPr lang="en-US" sz="1400" dirty="0">
-                <a:latin typeface="Consolas" panose="020B0609020204030204" pitchFamily="49" charset="0"/>
-                <a:cs typeface="Consolas" panose="020B0609020204030204" pitchFamily="49" charset="0"/>
-              </a:rPr>
-              <a:t>!=INVALID_BUFFER_POS;</a:t>
-            </a:r>
-          </a:p>
-          <a:p>
-            <a:pPr rtl="0">
-              <a:buNone/>
-            </a:pPr>
-            <a:r>
-              <a:rPr lang="en-US" sz="1400" dirty="0">
-                <a:latin typeface="Consolas" panose="020B0609020204030204" pitchFamily="49" charset="0"/>
-                <a:cs typeface="Consolas" panose="020B0609020204030204" pitchFamily="49" charset="0"/>
-              </a:rPr>
-              <a:t>    }</a:t>
-            </a:r>
-          </a:p>
-          <a:p>
-            <a:pPr rtl="0">
-              <a:buNone/>
-            </a:pPr>
-            <a:r>
-              <a:rPr lang="en-US" sz="1400" dirty="0">
-                <a:latin typeface="Consolas" panose="020B0609020204030204" pitchFamily="49" charset="0"/>
-                <a:cs typeface="Consolas" panose="020B0609020204030204" pitchFamily="49" charset="0"/>
-              </a:rPr>
-              <a:t>};</a:t>
-            </a:r>
-          </a:p>
-        </p:txBody>
-      </p:sp>
-      <p:sp>
-        <p:nvSpPr>
-          <p:cNvPr id="7" name="TextBox 6">
-            <a:extLst>
-              <a:ext uri="{FF2B5EF4-FFF2-40B4-BE49-F238E27FC236}">
-                <a16:creationId xmlns:a16="http://schemas.microsoft.com/office/drawing/2014/main" id="{C4D44317-D602-0122-DF85-450740EEFDCC}"/>
-              </a:ext>
-            </a:extLst>
-          </p:cNvPr>
-          <p:cNvSpPr txBox="1"/>
-          <p:nvPr/>
-        </p:nvSpPr>
-        <p:spPr>
-          <a:xfrm>
-            <a:off x="3185948" y="4385441"/>
-            <a:ext cx="5820104" cy="1754326"/>
-          </a:xfrm>
-          <a:prstGeom prst="rect">
-            <a:avLst/>
-          </a:prstGeom>
-          <a:noFill/>
-        </p:spPr>
-        <p:txBody>
-          <a:bodyPr wrap="square">
-            <a:spAutoFit/>
-          </a:bodyPr>
-          <a:lstStyle/>
-          <a:p>
-            <a:r>
-              <a:rPr lang="en-US" dirty="0" err="1">
-                <a:latin typeface="Consolas" panose="020B0609020204030204" pitchFamily="49" charset="0"/>
-                <a:cs typeface="Consolas" panose="020B0609020204030204" pitchFamily="49" charset="0"/>
-              </a:rPr>
-              <a:t>BufferReservation</a:t>
-            </a:r>
-            <a:r>
-              <a:rPr lang="en-US" dirty="0">
-                <a:latin typeface="Consolas" panose="020B0609020204030204" pitchFamily="49" charset="0"/>
-                <a:cs typeface="Consolas" panose="020B0609020204030204" pitchFamily="49" charset="0"/>
-              </a:rPr>
-              <a:t> result=</a:t>
-            </a:r>
-            <a:r>
-              <a:rPr lang="en-US" dirty="0" err="1">
-                <a:latin typeface="Consolas" panose="020B0609020204030204" pitchFamily="49" charset="0"/>
-                <a:cs typeface="Consolas" panose="020B0609020204030204" pitchFamily="49" charset="0"/>
-              </a:rPr>
-              <a:t>Bwr.append</a:t>
-            </a:r>
-            <a:r>
-              <a:rPr lang="en-US" dirty="0">
-                <a:latin typeface="Consolas" panose="020B0609020204030204" pitchFamily="49" charset="0"/>
-                <a:cs typeface="Consolas" panose="020B0609020204030204" pitchFamily="49" charset="0"/>
-              </a:rPr>
-              <a:t>(</a:t>
-            </a:r>
-            <a:r>
-              <a:rPr lang="en-US" dirty="0" err="1">
-                <a:latin typeface="Consolas" panose="020B0609020204030204" pitchFamily="49" charset="0"/>
-                <a:cs typeface="Consolas" panose="020B0609020204030204" pitchFamily="49" charset="0"/>
-              </a:rPr>
-              <a:t>sglen</a:t>
-            </a:r>
-            <a:r>
-              <a:rPr lang="en-US" dirty="0">
-                <a:latin typeface="Consolas" panose="020B0609020204030204" pitchFamily="49" charset="0"/>
-                <a:cs typeface="Consolas" panose="020B0609020204030204" pitchFamily="49" charset="0"/>
-              </a:rPr>
-              <a:t>);</a:t>
-            </a:r>
-          </a:p>
-          <a:p>
-            <a:r>
-              <a:rPr lang="en-US" dirty="0">
-                <a:latin typeface="Consolas" panose="020B0609020204030204" pitchFamily="49" charset="0"/>
-                <a:cs typeface="Consolas" panose="020B0609020204030204" pitchFamily="49" charset="0"/>
-              </a:rPr>
-              <a:t>if(!</a:t>
-            </a:r>
-            <a:r>
-              <a:rPr lang="en-US" dirty="0" err="1">
-                <a:latin typeface="Consolas" panose="020B0609020204030204" pitchFamily="49" charset="0"/>
-                <a:cs typeface="Consolas" panose="020B0609020204030204" pitchFamily="49" charset="0"/>
-              </a:rPr>
-              <a:t>result.valid</a:t>
-            </a:r>
-            <a:r>
-              <a:rPr lang="en-US" dirty="0">
-                <a:latin typeface="Consolas" panose="020B0609020204030204" pitchFamily="49" charset="0"/>
-                <a:cs typeface="Consolas" panose="020B0609020204030204" pitchFamily="49" charset="0"/>
-              </a:rPr>
-              <a:t>() and !</a:t>
-            </a:r>
-            <a:r>
-              <a:rPr lang="en-US" dirty="0" err="1">
-                <a:latin typeface="Consolas" panose="020B0609020204030204" pitchFamily="49" charset="0"/>
-                <a:cs typeface="Consolas" panose="020B0609020204030204" pitchFamily="49" charset="0"/>
-              </a:rPr>
-              <a:t>hybrid_drop_mode</a:t>
-            </a:r>
-            <a:r>
-              <a:rPr lang="en-US" dirty="0">
-                <a:latin typeface="Consolas" panose="020B0609020204030204" pitchFamily="49" charset="0"/>
-                <a:cs typeface="Consolas" panose="020B0609020204030204" pitchFamily="49" charset="0"/>
-              </a:rPr>
-              <a:t>){</a:t>
-            </a:r>
-          </a:p>
-          <a:p>
-            <a:r>
-              <a:rPr lang="en-US" dirty="0">
-                <a:latin typeface="Consolas" panose="020B0609020204030204" pitchFamily="49" charset="0"/>
-                <a:cs typeface="Consolas" panose="020B0609020204030204" pitchFamily="49" charset="0"/>
-              </a:rPr>
-              <a:t>    result=</a:t>
-            </a:r>
-            <a:r>
-              <a:rPr lang="en-US" dirty="0" err="1">
-                <a:latin typeface="Consolas" panose="020B0609020204030204" pitchFamily="49" charset="0"/>
-                <a:cs typeface="Consolas" panose="020B0609020204030204" pitchFamily="49" charset="0"/>
-              </a:rPr>
-              <a:t>H.append</a:t>
-            </a:r>
-            <a:r>
-              <a:rPr lang="en-US" dirty="0">
-                <a:latin typeface="Consolas" panose="020B0609020204030204" pitchFamily="49" charset="0"/>
-                <a:cs typeface="Consolas" panose="020B0609020204030204" pitchFamily="49" charset="0"/>
-              </a:rPr>
-              <a:t>(</a:t>
-            </a:r>
-            <a:r>
-              <a:rPr lang="en-US" dirty="0" err="1">
-                <a:latin typeface="Consolas" panose="020B0609020204030204" pitchFamily="49" charset="0"/>
-                <a:cs typeface="Consolas" panose="020B0609020204030204" pitchFamily="49" charset="0"/>
-              </a:rPr>
-              <a:t>sglen</a:t>
-            </a:r>
-            <a:r>
-              <a:rPr lang="en-US" dirty="0">
-                <a:latin typeface="Consolas" panose="020B0609020204030204" pitchFamily="49" charset="0"/>
-                <a:cs typeface="Consolas" panose="020B0609020204030204" pitchFamily="49" charset="0"/>
-              </a:rPr>
-              <a:t>);</a:t>
-            </a:r>
-          </a:p>
-          <a:p>
-            <a:r>
-              <a:rPr lang="en-US" dirty="0">
-                <a:latin typeface="Consolas" panose="020B0609020204030204" pitchFamily="49" charset="0"/>
-                <a:cs typeface="Consolas" panose="020B0609020204030204" pitchFamily="49" charset="0"/>
-              </a:rPr>
-              <a:t>    </a:t>
-            </a:r>
-            <a:r>
-              <a:rPr lang="en-US" dirty="0" err="1">
-                <a:latin typeface="Consolas" panose="020B0609020204030204" pitchFamily="49" charset="0"/>
-                <a:cs typeface="Consolas" panose="020B0609020204030204" pitchFamily="49" charset="0"/>
-              </a:rPr>
-              <a:t>result.to_host</a:t>
-            </a:r>
-            <a:r>
-              <a:rPr lang="en-US" dirty="0">
-                <a:latin typeface="Consolas" panose="020B0609020204030204" pitchFamily="49" charset="0"/>
-                <a:cs typeface="Consolas" panose="020B0609020204030204" pitchFamily="49" charset="0"/>
-              </a:rPr>
-              <a:t>=true;</a:t>
-            </a:r>
-          </a:p>
-          <a:p>
-            <a:r>
-              <a:rPr lang="en-US" dirty="0">
-                <a:latin typeface="Consolas" panose="020B0609020204030204" pitchFamily="49" charset="0"/>
-                <a:cs typeface="Consolas" panose="020B0609020204030204" pitchFamily="49" charset="0"/>
-              </a:rPr>
-              <a:t>}</a:t>
-            </a:r>
-          </a:p>
-          <a:p>
-            <a:r>
-              <a:rPr lang="en-US" dirty="0">
-                <a:latin typeface="Consolas" panose="020B0609020204030204" pitchFamily="49" charset="0"/>
-                <a:cs typeface="Consolas" panose="020B0609020204030204" pitchFamily="49" charset="0"/>
-              </a:rPr>
-              <a:t>return result;</a:t>
-            </a:r>
-          </a:p>
-        </p:txBody>
-      </p:sp>
-    </p:spTree>
-    <p:extLst>
-      <p:ext uri="{BB962C8B-B14F-4D97-AF65-F5344CB8AC3E}">
-        <p14:creationId xmlns:p14="http://schemas.microsoft.com/office/powerpoint/2010/main" val="193670930"/>
-      </p:ext>
-    </p:extLst>
-  </p:cSld>
-  <p:clrMapOvr>
-    <a:masterClrMapping/>
-  </p:clrMapOvr>
-</p:sld>
-</file>
-
 <file path=ppt/slides/slide28.xml><?xml version="1.0" encoding="utf-8"?>
 <p:sld xmlns:a="http://schemas.openxmlformats.org/drawingml/2006/main" xmlns:r="http://schemas.openxmlformats.org/officeDocument/2006/relationships" xmlns:p="http://schemas.openxmlformats.org/presentationml/2006/main">
   <p:cSld>
@@ -10693,7 +10422,7 @@
           <p:cNvPr id="2" name="Title 1">
             <a:extLst>
               <a:ext uri="{FF2B5EF4-FFF2-40B4-BE49-F238E27FC236}">
-                <a16:creationId xmlns:a16="http://schemas.microsoft.com/office/drawing/2014/main" id="{BC1ABA0D-0AC8-1FE1-BFFE-7F7AAC630FF7}"/>
+                <a16:creationId xmlns:a16="http://schemas.microsoft.com/office/drawing/2014/main" id="{EAC15F67-CC66-76E8-1A76-6F2AF3484E9F}"/>
               </a:ext>
             </a:extLst>
           </p:cNvPr>
@@ -10711,7 +10440,7 @@
           <a:p>
             <a:r>
               <a:rPr lang="en-US" dirty="0"/>
-              <a:t>Buffer Reservation – App </a:t>
+              <a:t>Buffer Reservation – System </a:t>
             </a:r>
           </a:p>
         </p:txBody>
@@ -10721,7 +10450,7 @@
           <p:cNvPr id="3" name="Content Placeholder 2">
             <a:extLst>
               <a:ext uri="{FF2B5EF4-FFF2-40B4-BE49-F238E27FC236}">
-                <a16:creationId xmlns:a16="http://schemas.microsoft.com/office/drawing/2014/main" id="{35C61F98-D28B-FA5D-E29D-D3FF738D40DB}"/>
+                <a16:creationId xmlns:a16="http://schemas.microsoft.com/office/drawing/2014/main" id="{2C54BF8F-E991-6701-FF2B-CB1E55E6C7C5}"/>
               </a:ext>
             </a:extLst>
           </p:cNvPr>
@@ -10732,29 +10461,41 @@
             <p:ph idx="1"/>
           </p:nvPr>
         </p:nvSpPr>
-        <p:spPr/>
+        <p:spPr>
+          <a:xfrm>
+            <a:off x="838200" y="1825625"/>
+            <a:ext cx="10515600" cy="1535906"/>
+          </a:xfrm>
+        </p:spPr>
         <p:txBody>
-          <a:bodyPr/>
+          <a:bodyPr>
+            <a:normAutofit fontScale="92500" lnSpcReduction="20000"/>
+          </a:bodyPr>
           <a:lstStyle/>
           <a:p>
             <a:r>
+              <a:rPr lang="en-US" dirty="0" err="1"/>
+              <a:t>BufferReservation</a:t>
+            </a:r>
+            <a:r>
               <a:rPr lang="en-US" dirty="0"/>
-              <a:t>The application calls append, and checks if the reservation is valid. </a:t>
+              <a:t> is a small value returned by append</a:t>
             </a:r>
           </a:p>
           <a:p>
             <a:r>
               <a:rPr lang="en-US" dirty="0"/>
-              <a:t>Switches to device or host buffer based on </a:t>
-            </a:r>
-            <a:r>
-              <a:rPr lang="en-US" dirty="0" err="1"/>
-              <a:t>to_host</a:t>
-            </a:r>
+              <a:t>The system tries the device buffer first. If failed, it appends on host buffer. </a:t>
+            </a:r>
+          </a:p>
+          <a:p>
             <a:r>
               <a:rPr lang="en-US" dirty="0"/>
-              <a:t> flag. </a:t>
-            </a:r>
+              <a:t>In hybrid-drop mode, it does not append on host</a:t>
+            </a:r>
+          </a:p>
+          <a:p>
+            <a:endParaRPr lang="en-US" dirty="0"/>
           </a:p>
         </p:txBody>
       </p:sp>
@@ -10763,7 +10504,7 @@
           <p:cNvPr id="5" name="TextBox 4">
             <a:extLst>
               <a:ext uri="{FF2B5EF4-FFF2-40B4-BE49-F238E27FC236}">
-                <a16:creationId xmlns:a16="http://schemas.microsoft.com/office/drawing/2014/main" id="{E1317F2A-D790-DE9C-2764-64F64CB86CC0}"/>
+                <a16:creationId xmlns:a16="http://schemas.microsoft.com/office/drawing/2014/main" id="{35B8D59D-4C1E-F677-6507-4B0E32C9983D}"/>
               </a:ext>
             </a:extLst>
           </p:cNvPr>
@@ -10772,8 +10513,8 @@
         </p:nvSpPr>
         <p:spPr>
           <a:xfrm>
-            <a:off x="3048000" y="4080328"/>
-            <a:ext cx="6096000" cy="1477328"/>
+            <a:off x="7409793" y="157719"/>
+            <a:ext cx="6096000" cy="1600438"/>
           </a:xfrm>
           <a:prstGeom prst="rect">
             <a:avLst/>
@@ -10786,19 +10527,223 @@
           </a:bodyPr>
           <a:lstStyle/>
           <a:p>
+            <a:pPr rtl="0">
+              <a:buNone/>
+            </a:pPr>
+            <a:r>
+              <a:rPr lang="en-US" sz="1400" dirty="0">
+                <a:latin typeface="Consolas" panose="020B0609020204030204" pitchFamily="49" charset="0"/>
+                <a:cs typeface="Consolas" panose="020B0609020204030204" pitchFamily="49" charset="0"/>
+              </a:rPr>
+              <a:t>struct </a:t>
+            </a:r>
+            <a:r>
+              <a:rPr lang="en-US" sz="1400" dirty="0" err="1">
+                <a:latin typeface="Consolas" panose="020B0609020204030204" pitchFamily="49" charset="0"/>
+                <a:cs typeface="Consolas" panose="020B0609020204030204" pitchFamily="49" charset="0"/>
+              </a:rPr>
+              <a:t>BufferReservation</a:t>
+            </a:r>
+            <a:r>
+              <a:rPr lang="en-US" sz="1400" dirty="0">
+                <a:latin typeface="Consolas" panose="020B0609020204030204" pitchFamily="49" charset="0"/>
+                <a:cs typeface="Consolas" panose="020B0609020204030204" pitchFamily="49" charset="0"/>
+              </a:rPr>
+              <a:t>{</a:t>
+            </a:r>
+          </a:p>
+          <a:p>
+            <a:pPr rtl="0">
+              <a:buNone/>
+            </a:pPr>
+            <a:r>
+              <a:rPr lang="en-US" sz="1400" dirty="0">
+                <a:latin typeface="Consolas" panose="020B0609020204030204" pitchFamily="49" charset="0"/>
+                <a:cs typeface="Consolas" panose="020B0609020204030204" pitchFamily="49" charset="0"/>
+              </a:rPr>
+              <a:t>    </a:t>
+            </a:r>
+            <a:r>
+              <a:rPr lang="en-US" sz="1400" dirty="0" err="1">
+                <a:latin typeface="Consolas" panose="020B0609020204030204" pitchFamily="49" charset="0"/>
+                <a:cs typeface="Consolas" panose="020B0609020204030204" pitchFamily="49" charset="0"/>
+              </a:rPr>
+              <a:t>ull</a:t>
+            </a:r>
+            <a:r>
+              <a:rPr lang="en-US" sz="1400" dirty="0">
+                <a:latin typeface="Consolas" panose="020B0609020204030204" pitchFamily="49" charset="0"/>
+                <a:cs typeface="Consolas" panose="020B0609020204030204" pitchFamily="49" charset="0"/>
+              </a:rPr>
+              <a:t> </a:t>
+            </a:r>
+            <a:r>
+              <a:rPr lang="en-US" sz="1400" dirty="0" err="1">
+                <a:latin typeface="Consolas" panose="020B0609020204030204" pitchFamily="49" charset="0"/>
+                <a:cs typeface="Consolas" panose="020B0609020204030204" pitchFamily="49" charset="0"/>
+              </a:rPr>
+              <a:t>vt</a:t>
+            </a:r>
+            <a:r>
+              <a:rPr lang="en-US" sz="1400" dirty="0">
+                <a:latin typeface="Consolas" panose="020B0609020204030204" pitchFamily="49" charset="0"/>
+                <a:cs typeface="Consolas" panose="020B0609020204030204" pitchFamily="49" charset="0"/>
+              </a:rPr>
+              <a:t>;</a:t>
+            </a:r>
+          </a:p>
+          <a:p>
+            <a:pPr rtl="0">
+              <a:buNone/>
+            </a:pPr>
+            <a:r>
+              <a:rPr lang="en-US" sz="1400" dirty="0">
+                <a:latin typeface="Consolas" panose="020B0609020204030204" pitchFamily="49" charset="0"/>
+                <a:cs typeface="Consolas" panose="020B0609020204030204" pitchFamily="49" charset="0"/>
+              </a:rPr>
+              <a:t>    bool </a:t>
+            </a:r>
+            <a:r>
+              <a:rPr lang="en-US" sz="1400" dirty="0" err="1">
+                <a:latin typeface="Consolas" panose="020B0609020204030204" pitchFamily="49" charset="0"/>
+                <a:cs typeface="Consolas" panose="020B0609020204030204" pitchFamily="49" charset="0"/>
+              </a:rPr>
+              <a:t>to_host</a:t>
+            </a:r>
+            <a:r>
+              <a:rPr lang="en-US" sz="1400" dirty="0">
+                <a:latin typeface="Consolas" panose="020B0609020204030204" pitchFamily="49" charset="0"/>
+                <a:cs typeface="Consolas" panose="020B0609020204030204" pitchFamily="49" charset="0"/>
+              </a:rPr>
+              <a:t>;</a:t>
+            </a:r>
+          </a:p>
+          <a:p>
+            <a:pPr rtl="0">
+              <a:buNone/>
+            </a:pPr>
+            <a:r>
+              <a:rPr lang="en-US" sz="1400" dirty="0">
+                <a:latin typeface="Consolas" panose="020B0609020204030204" pitchFamily="49" charset="0"/>
+                <a:cs typeface="Consolas" panose="020B0609020204030204" pitchFamily="49" charset="0"/>
+              </a:rPr>
+              <a:t>    __device__ __host__ bool valid()const{</a:t>
+            </a:r>
+          </a:p>
+          <a:p>
+            <a:pPr rtl="0">
+              <a:buNone/>
+            </a:pPr>
+            <a:r>
+              <a:rPr lang="en-US" sz="1400" dirty="0">
+                <a:latin typeface="Consolas" panose="020B0609020204030204" pitchFamily="49" charset="0"/>
+                <a:cs typeface="Consolas" panose="020B0609020204030204" pitchFamily="49" charset="0"/>
+              </a:rPr>
+              <a:t>        return </a:t>
+            </a:r>
+            <a:r>
+              <a:rPr lang="en-US" sz="1400" dirty="0" err="1">
+                <a:latin typeface="Consolas" panose="020B0609020204030204" pitchFamily="49" charset="0"/>
+                <a:cs typeface="Consolas" panose="020B0609020204030204" pitchFamily="49" charset="0"/>
+              </a:rPr>
+              <a:t>vt</a:t>
+            </a:r>
+            <a:r>
+              <a:rPr lang="en-US" sz="1400" dirty="0">
+                <a:latin typeface="Consolas" panose="020B0609020204030204" pitchFamily="49" charset="0"/>
+                <a:cs typeface="Consolas" panose="020B0609020204030204" pitchFamily="49" charset="0"/>
+              </a:rPr>
+              <a:t>!=INVALID_BUFFER_POS;</a:t>
+            </a:r>
+          </a:p>
+          <a:p>
+            <a:pPr rtl="0">
+              <a:buNone/>
+            </a:pPr>
+            <a:r>
+              <a:rPr lang="en-US" sz="1400" dirty="0">
+                <a:latin typeface="Consolas" panose="020B0609020204030204" pitchFamily="49" charset="0"/>
+                <a:cs typeface="Consolas" panose="020B0609020204030204" pitchFamily="49" charset="0"/>
+              </a:rPr>
+              <a:t>    }</a:t>
+            </a:r>
+          </a:p>
+          <a:p>
+            <a:pPr rtl="0">
+              <a:buNone/>
+            </a:pPr>
+            <a:r>
+              <a:rPr lang="en-US" sz="1400" dirty="0">
+                <a:latin typeface="Consolas" panose="020B0609020204030204" pitchFamily="49" charset="0"/>
+                <a:cs typeface="Consolas" panose="020B0609020204030204" pitchFamily="49" charset="0"/>
+              </a:rPr>
+              <a:t>};</a:t>
+            </a:r>
+          </a:p>
+        </p:txBody>
+      </p:sp>
+      <p:sp>
+        <p:nvSpPr>
+          <p:cNvPr id="7" name="TextBox 6">
+            <a:extLst>
+              <a:ext uri="{FF2B5EF4-FFF2-40B4-BE49-F238E27FC236}">
+                <a16:creationId xmlns:a16="http://schemas.microsoft.com/office/drawing/2014/main" id="{C4D44317-D602-0122-DF85-450740EEFDCC}"/>
+              </a:ext>
+            </a:extLst>
+          </p:cNvPr>
+          <p:cNvSpPr txBox="1"/>
+          <p:nvPr/>
+        </p:nvSpPr>
+        <p:spPr>
+          <a:xfrm>
+            <a:off x="3185948" y="4385441"/>
+            <a:ext cx="5820104" cy="1754326"/>
+          </a:xfrm>
+          <a:prstGeom prst="rect">
+            <a:avLst/>
+          </a:prstGeom>
+          <a:noFill/>
+        </p:spPr>
+        <p:txBody>
+          <a:bodyPr wrap="square">
+            <a:spAutoFit/>
+          </a:bodyPr>
+          <a:lstStyle/>
+          <a:p>
+            <a:r>
+              <a:rPr lang="en-US" dirty="0" err="1">
+                <a:latin typeface="Consolas" panose="020B0609020204030204" pitchFamily="49" charset="0"/>
+                <a:cs typeface="Consolas" panose="020B0609020204030204" pitchFamily="49" charset="0"/>
+              </a:rPr>
+              <a:t>BufferReservation</a:t>
+            </a:r>
             <a:r>
               <a:rPr lang="en-US" dirty="0">
                 <a:latin typeface="Consolas" panose="020B0609020204030204" pitchFamily="49" charset="0"/>
                 <a:cs typeface="Consolas" panose="020B0609020204030204" pitchFamily="49" charset="0"/>
               </a:rPr>
-              <a:t>auto reservation = append(</a:t>
+              <a:t> result=</a:t>
             </a:r>
             <a:r>
               <a:rPr lang="en-US" dirty="0" err="1">
                 <a:latin typeface="Consolas" panose="020B0609020204030204" pitchFamily="49" charset="0"/>
                 <a:cs typeface="Consolas" panose="020B0609020204030204" pitchFamily="49" charset="0"/>
               </a:rPr>
-              <a:t>task_size</a:t>
+              <a:t>Bwr.append</a:t>
+            </a:r>
+            <a:r>
+              <a:rPr lang="en-US" dirty="0">
+                <a:latin typeface="Consolas" panose="020B0609020204030204" pitchFamily="49" charset="0"/>
+                <a:cs typeface="Consolas" panose="020B0609020204030204" pitchFamily="49" charset="0"/>
+              </a:rPr>
+              <a:t>(</a:t>
+            </a:r>
+            <a:r>
+              <a:rPr lang="en-US" dirty="0" err="1">
+                <a:latin typeface="Consolas" panose="020B0609020204030204" pitchFamily="49" charset="0"/>
+                <a:cs typeface="Consolas" panose="020B0609020204030204" pitchFamily="49" charset="0"/>
+              </a:rPr>
+              <a:t>sglen</a:t>
             </a:r>
             <a:r>
               <a:rPr lang="en-US" dirty="0">
@@ -10821,81 +10766,97 @@
                 <a:latin typeface="Consolas" panose="020B0609020204030204" pitchFamily="49" charset="0"/>
                 <a:cs typeface="Consolas" panose="020B0609020204030204" pitchFamily="49" charset="0"/>
               </a:rPr>
-              <a:t>reservation.valid</a:t>
+              <a:t>result.valid</a:t>
             </a:r>
             <a:r>
               <a:rPr lang="en-US" dirty="0">
                 <a:latin typeface="Consolas" panose="020B0609020204030204" pitchFamily="49" charset="0"/>
                 <a:cs typeface="Consolas" panose="020B0609020204030204" pitchFamily="49" charset="0"/>
               </a:rPr>
-              <a:t>()) return;</a:t>
-            </a:r>
-          </a:p>
-          <a:p>
+              <a:t>() and !</a:t>
+            </a:r>
+            <a:r>
+              <a:rPr lang="en-US" dirty="0" err="1">
+                <a:latin typeface="Consolas" panose="020B0609020204030204" pitchFamily="49" charset="0"/>
+                <a:cs typeface="Consolas" panose="020B0609020204030204" pitchFamily="49" charset="0"/>
+              </a:rPr>
+              <a:t>hybrid_drop_mode</a:t>
+            </a:r>
             <a:r>
               <a:rPr lang="en-US" dirty="0">
                 <a:latin typeface="Consolas" panose="020B0609020204030204" pitchFamily="49" charset="0"/>
                 <a:cs typeface="Consolas" panose="020B0609020204030204" pitchFamily="49" charset="0"/>
               </a:rPr>
-              <a:t>auto&amp; buffer = </a:t>
+              <a:t>){</a:t>
+            </a:r>
+          </a:p>
+          <a:p>
+            <a:r>
+              <a:rPr lang="en-US" dirty="0">
+                <a:latin typeface="Consolas" panose="020B0609020204030204" pitchFamily="49" charset="0"/>
+                <a:cs typeface="Consolas" panose="020B0609020204030204" pitchFamily="49" charset="0"/>
+              </a:rPr>
+              <a:t>    result=</a:t>
             </a:r>
             <a:r>
               <a:rPr lang="en-US" dirty="0" err="1">
                 <a:latin typeface="Consolas" panose="020B0609020204030204" pitchFamily="49" charset="0"/>
                 <a:cs typeface="Consolas" panose="020B0609020204030204" pitchFamily="49" charset="0"/>
               </a:rPr>
-              <a:t>reservation.to_host</a:t>
+              <a:t>H.append</a:t>
             </a:r>
             <a:r>
               <a:rPr lang="en-US" dirty="0">
                 <a:latin typeface="Consolas" panose="020B0609020204030204" pitchFamily="49" charset="0"/>
                 <a:cs typeface="Consolas" panose="020B0609020204030204" pitchFamily="49" charset="0"/>
               </a:rPr>
-              <a:t>? </a:t>
+              <a:t>(</a:t>
             </a:r>
             <a:r>
               <a:rPr lang="en-US" dirty="0" err="1">
                 <a:latin typeface="Consolas" panose="020B0609020204030204" pitchFamily="49" charset="0"/>
                 <a:cs typeface="Consolas" panose="020B0609020204030204" pitchFamily="49" charset="0"/>
               </a:rPr>
-              <a:t>H:Bwr</a:t>
+              <a:t>sglen</a:t>
             </a:r>
             <a:r>
               <a:rPr lang="en-US" dirty="0">
                 <a:latin typeface="Consolas" panose="020B0609020204030204" pitchFamily="49" charset="0"/>
                 <a:cs typeface="Consolas" panose="020B0609020204030204" pitchFamily="49" charset="0"/>
               </a:rPr>
-              <a:t>;</a:t>
-            </a:r>
-          </a:p>
-          <a:p>
+              <a:t>);</a:t>
+            </a:r>
+          </a:p>
+          <a:p>
+            <a:r>
+              <a:rPr lang="en-US" dirty="0">
+                <a:latin typeface="Consolas" panose="020B0609020204030204" pitchFamily="49" charset="0"/>
+                <a:cs typeface="Consolas" panose="020B0609020204030204" pitchFamily="49" charset="0"/>
+              </a:rPr>
+              <a:t>    </a:t>
+            </a:r>
             <a:r>
               <a:rPr lang="en-US" dirty="0" err="1">
                 <a:latin typeface="Consolas" panose="020B0609020204030204" pitchFamily="49" charset="0"/>
                 <a:cs typeface="Consolas" panose="020B0609020204030204" pitchFamily="49" charset="0"/>
               </a:rPr>
-              <a:t>ull</a:t>
+              <a:t>result.to_host</a:t>
             </a:r>
             <a:r>
               <a:rPr lang="en-US" dirty="0">
                 <a:latin typeface="Consolas" panose="020B0609020204030204" pitchFamily="49" charset="0"/>
                 <a:cs typeface="Consolas" panose="020B0609020204030204" pitchFamily="49" charset="0"/>
               </a:rPr>
-              <a:t> start = </a:t>
-            </a:r>
-            <a:r>
-              <a:rPr lang="en-US" dirty="0" err="1">
-                <a:latin typeface="Consolas" panose="020B0609020204030204" pitchFamily="49" charset="0"/>
-                <a:cs typeface="Consolas" panose="020B0609020204030204" pitchFamily="49" charset="0"/>
-              </a:rPr>
-              <a:t>reservation.vt</a:t>
-            </a:r>
+              <a:t>=true;</a:t>
+            </a:r>
+          </a:p>
+          <a:p>
             <a:r>
               <a:rPr lang="en-US" dirty="0">
                 <a:latin typeface="Consolas" panose="020B0609020204030204" pitchFamily="49" charset="0"/>
                 <a:cs typeface="Consolas" panose="020B0609020204030204" pitchFamily="49" charset="0"/>
               </a:rPr>
-              <a:t>;</a:t>
+              <a:t>}</a:t>
             </a:r>
           </a:p>
           <a:p>
@@ -10904,7 +10865,7 @@
                 <a:latin typeface="Consolas" panose="020B0609020204030204" pitchFamily="49" charset="0"/>
                 <a:cs typeface="Consolas" panose="020B0609020204030204" pitchFamily="49" charset="0"/>
               </a:rPr>
-              <a:t>...</a:t>
+              <a:t>return result;</a:t>
             </a:r>
           </a:p>
         </p:txBody>
@@ -10912,7 +10873,7 @@
     </p:spTree>
     <p:extLst>
       <p:ext uri="{BB962C8B-B14F-4D97-AF65-F5344CB8AC3E}">
-        <p14:creationId xmlns:p14="http://schemas.microsoft.com/office/powerpoint/2010/main" val="2873945218"/>
+        <p14:creationId xmlns:p14="http://schemas.microsoft.com/office/powerpoint/2010/main" val="193670930"/>
       </p:ext>
     </p:extLst>
   </p:cSld>
@@ -10944,7 +10905,7 @@
           <p:cNvPr id="2" name="Title 1">
             <a:extLst>
               <a:ext uri="{FF2B5EF4-FFF2-40B4-BE49-F238E27FC236}">
-                <a16:creationId xmlns:a16="http://schemas.microsoft.com/office/drawing/2014/main" id="{DF9C7201-1C1B-1754-0B8F-E07786E708BB}"/>
+                <a16:creationId xmlns:a16="http://schemas.microsoft.com/office/drawing/2014/main" id="{BC1ABA0D-0AC8-1FE1-BFFE-7F7AAC630FF7}"/>
               </a:ext>
             </a:extLst>
           </p:cNvPr>
@@ -10962,7 +10923,7 @@
           <a:p>
             <a:r>
               <a:rPr lang="en-US" dirty="0"/>
-              <a:t>Why G2-AIMD is Faster </a:t>
+              <a:t>Buffer Reservation – App </a:t>
             </a:r>
           </a:p>
         </p:txBody>
@@ -10972,7 +10933,7 @@
           <p:cNvPr id="3" name="Content Placeholder 2">
             <a:extLst>
               <a:ext uri="{FF2B5EF4-FFF2-40B4-BE49-F238E27FC236}">
-                <a16:creationId xmlns:a16="http://schemas.microsoft.com/office/drawing/2014/main" id="{7BD2331F-55B5-2DF4-61ED-3D123CA1E3FD}"/>
+                <a16:creationId xmlns:a16="http://schemas.microsoft.com/office/drawing/2014/main" id="{35C61F98-D28B-FA5D-E29D-D3FF738D40DB}"/>
               </a:ext>
             </a:extLst>
           </p:cNvPr>
@@ -10985,55 +10946,36 @@
         </p:nvSpPr>
         <p:spPr/>
         <p:txBody>
-          <a:bodyPr>
-            <a:normAutofit lnSpcReduction="10000"/>
-          </a:bodyPr>
+          <a:bodyPr/>
           <a:lstStyle/>
           <a:p>
-            <a:pPr marL="0" indent="0">
-              <a:buNone/>
-            </a:pPr>
             <a:r>
               <a:rPr lang="en-US" dirty="0"/>
-              <a:t>In some cases, G2-AIMD outperforms GPU-hybrid even when neither system overflows.</a:t>
-            </a:r>
-          </a:p>
-          <a:p>
-            <a:pPr lvl="0"/>
+              <a:t>The application calls append, and checks if the reservation is valid. </a:t>
+            </a:r>
+          </a:p>
+          <a:p>
             <a:r>
               <a:rPr lang="en-US" dirty="0"/>
-              <a:t>G2-AIMD follows a simpler, application-specific GPU execution path.</a:t>
-            </a:r>
-          </a:p>
-          <a:p>
-            <a:pPr lvl="0"/>
+              <a:t>Switches to device or host buffer based on </a:t>
+            </a:r>
+            <a:r>
+              <a:rPr lang="en-US" dirty="0" err="1"/>
+              <a:t>to_host</a:t>
+            </a:r>
             <a:r>
               <a:rPr lang="en-US" dirty="0"/>
-              <a:t>Our system uses adaptive device and host buffers to protect against overflow.</a:t>
-            </a:r>
-          </a:p>
-          <a:p>
-            <a:pPr lvl="0"/>
-            <a:r>
-              <a:rPr lang="en-US" dirty="0"/>
-              <a:t>This flexibility requires additional capacity checks, overflow tracking, and destination selection.</a:t>
-            </a:r>
-          </a:p>
-          <a:p>
-            <a:pPr lvl="0"/>
-            <a:r>
-              <a:rPr lang="en-US" dirty="0"/>
-              <a:t>The generic buffer interface keeps more state alive, which can change compiler optimizations and register allocations.</a:t>
+              <a:t> flag. </a:t>
             </a:r>
           </a:p>
         </p:txBody>
       </p:sp>
       <p:sp>
         <p:nvSpPr>
-          <p:cNvPr id="4" name="TextBox 3">
-            <a:extLst>
-              <a:ext uri="{FF2B5EF4-FFF2-40B4-BE49-F238E27FC236}">
-                <a16:creationId xmlns:a16="http://schemas.microsoft.com/office/drawing/2014/main" id="{734C9161-0742-3499-7282-73EBA029134B}"/>
+          <p:cNvPr id="5" name="TextBox 4">
+            <a:extLst>
+              <a:ext uri="{FF2B5EF4-FFF2-40B4-BE49-F238E27FC236}">
+                <a16:creationId xmlns:a16="http://schemas.microsoft.com/office/drawing/2014/main" id="{E1317F2A-D790-DE9C-2764-64F64CB86CC0}"/>
               </a:ext>
             </a:extLst>
           </p:cNvPr>
@@ -11042,8 +10984,8 @@
         </p:nvSpPr>
         <p:spPr>
           <a:xfrm>
-            <a:off x="4214811" y="6123543"/>
-            <a:ext cx="6807376" cy="369332"/>
+            <a:off x="3048000" y="4080328"/>
+            <a:ext cx="6096000" cy="1477328"/>
           </a:xfrm>
           <a:prstGeom prst="rect">
             <a:avLst/>
@@ -11051,39 +10993,138 @@
           <a:noFill/>
         </p:spPr>
         <p:txBody>
-          <a:bodyPr wrap="none" rtlCol="0">
+          <a:bodyPr wrap="square">
             <a:spAutoFit/>
           </a:bodyPr>
           <a:lstStyle/>
           <a:p>
             <a:r>
               <a:rPr lang="en-US" dirty="0">
-                <a:solidFill>
-                  <a:srgbClr val="C00000"/>
-                </a:solidFill>
+                <a:latin typeface="Consolas" panose="020B0609020204030204" pitchFamily="49" charset="0"/>
+                <a:cs typeface="Consolas" panose="020B0609020204030204" pitchFamily="49" charset="0"/>
               </a:rPr>
-              <a:t>This may explain why some instances in MQC are slower e.g. </a:t>
+              <a:t>auto reservation = append(</a:t>
             </a:r>
             <a:r>
               <a:rPr lang="en-US" dirty="0" err="1">
-                <a:solidFill>
-                  <a:srgbClr val="C00000"/>
-                </a:solidFill>
+                <a:latin typeface="Consolas" panose="020B0609020204030204" pitchFamily="49" charset="0"/>
+                <a:cs typeface="Consolas" panose="020B0609020204030204" pitchFamily="49" charset="0"/>
               </a:rPr>
-              <a:t>Flixter</a:t>
-            </a:r>
-            <a:endParaRPr lang="en-US" dirty="0">
-              <a:solidFill>
-                <a:srgbClr val="C00000"/>
-              </a:solidFill>
-            </a:endParaRPr>
+              <a:t>task_size</a:t>
+            </a:r>
+            <a:r>
+              <a:rPr lang="en-US" dirty="0">
+                <a:latin typeface="Consolas" panose="020B0609020204030204" pitchFamily="49" charset="0"/>
+                <a:cs typeface="Consolas" panose="020B0609020204030204" pitchFamily="49" charset="0"/>
+              </a:rPr>
+              <a:t>);</a:t>
+            </a:r>
+          </a:p>
+          <a:p>
+            <a:r>
+              <a:rPr lang="en-US" dirty="0">
+                <a:latin typeface="Consolas" panose="020B0609020204030204" pitchFamily="49" charset="0"/>
+                <a:cs typeface="Consolas" panose="020B0609020204030204" pitchFamily="49" charset="0"/>
+              </a:rPr>
+              <a:t>if(!</a:t>
+            </a:r>
+            <a:r>
+              <a:rPr lang="en-US" dirty="0" err="1">
+                <a:latin typeface="Consolas" panose="020B0609020204030204" pitchFamily="49" charset="0"/>
+                <a:cs typeface="Consolas" panose="020B0609020204030204" pitchFamily="49" charset="0"/>
+              </a:rPr>
+              <a:t>reservation.valid</a:t>
+            </a:r>
+            <a:r>
+              <a:rPr lang="en-US" dirty="0">
+                <a:latin typeface="Consolas" panose="020B0609020204030204" pitchFamily="49" charset="0"/>
+                <a:cs typeface="Consolas" panose="020B0609020204030204" pitchFamily="49" charset="0"/>
+              </a:rPr>
+              <a:t>()) return;</a:t>
+            </a:r>
+          </a:p>
+          <a:p>
+            <a:r>
+              <a:rPr lang="en-US" dirty="0">
+                <a:latin typeface="Consolas" panose="020B0609020204030204" pitchFamily="49" charset="0"/>
+                <a:cs typeface="Consolas" panose="020B0609020204030204" pitchFamily="49" charset="0"/>
+              </a:rPr>
+              <a:t>auto&amp; buffer = </a:t>
+            </a:r>
+            <a:r>
+              <a:rPr lang="en-US" dirty="0" err="1">
+                <a:latin typeface="Consolas" panose="020B0609020204030204" pitchFamily="49" charset="0"/>
+                <a:cs typeface="Consolas" panose="020B0609020204030204" pitchFamily="49" charset="0"/>
+              </a:rPr>
+              <a:t>reservation.to_host</a:t>
+            </a:r>
+            <a:r>
+              <a:rPr lang="en-US" dirty="0">
+                <a:latin typeface="Consolas" panose="020B0609020204030204" pitchFamily="49" charset="0"/>
+                <a:cs typeface="Consolas" panose="020B0609020204030204" pitchFamily="49" charset="0"/>
+              </a:rPr>
+              <a:t>? </a:t>
+            </a:r>
+            <a:r>
+              <a:rPr lang="en-US" dirty="0" err="1">
+                <a:latin typeface="Consolas" panose="020B0609020204030204" pitchFamily="49" charset="0"/>
+                <a:cs typeface="Consolas" panose="020B0609020204030204" pitchFamily="49" charset="0"/>
+              </a:rPr>
+              <a:t>H:Bwr</a:t>
+            </a:r>
+            <a:r>
+              <a:rPr lang="en-US" dirty="0">
+                <a:latin typeface="Consolas" panose="020B0609020204030204" pitchFamily="49" charset="0"/>
+                <a:cs typeface="Consolas" panose="020B0609020204030204" pitchFamily="49" charset="0"/>
+              </a:rPr>
+              <a:t>;</a:t>
+            </a:r>
+          </a:p>
+          <a:p>
+            <a:r>
+              <a:rPr lang="en-US" dirty="0" err="1">
+                <a:latin typeface="Consolas" panose="020B0609020204030204" pitchFamily="49" charset="0"/>
+                <a:cs typeface="Consolas" panose="020B0609020204030204" pitchFamily="49" charset="0"/>
+              </a:rPr>
+              <a:t>ull</a:t>
+            </a:r>
+            <a:r>
+              <a:rPr lang="en-US" dirty="0">
+                <a:latin typeface="Consolas" panose="020B0609020204030204" pitchFamily="49" charset="0"/>
+                <a:cs typeface="Consolas" panose="020B0609020204030204" pitchFamily="49" charset="0"/>
+              </a:rPr>
+              <a:t> start = </a:t>
+            </a:r>
+            <a:r>
+              <a:rPr lang="en-US" dirty="0" err="1">
+                <a:latin typeface="Consolas" panose="020B0609020204030204" pitchFamily="49" charset="0"/>
+                <a:cs typeface="Consolas" panose="020B0609020204030204" pitchFamily="49" charset="0"/>
+              </a:rPr>
+              <a:t>reservation.vt</a:t>
+            </a:r>
+            <a:r>
+              <a:rPr lang="en-US" dirty="0">
+                <a:latin typeface="Consolas" panose="020B0609020204030204" pitchFamily="49" charset="0"/>
+                <a:cs typeface="Consolas" panose="020B0609020204030204" pitchFamily="49" charset="0"/>
+              </a:rPr>
+              <a:t>;</a:t>
+            </a:r>
+          </a:p>
+          <a:p>
+            <a:r>
+              <a:rPr lang="en-US" dirty="0">
+                <a:latin typeface="Consolas" panose="020B0609020204030204" pitchFamily="49" charset="0"/>
+                <a:cs typeface="Consolas" panose="020B0609020204030204" pitchFamily="49" charset="0"/>
+              </a:rPr>
+              <a:t>...</a:t>
+            </a:r>
           </a:p>
         </p:txBody>
       </p:sp>
     </p:spTree>
     <p:extLst>
       <p:ext uri="{BB962C8B-B14F-4D97-AF65-F5344CB8AC3E}">
-        <p14:creationId xmlns:p14="http://schemas.microsoft.com/office/powerpoint/2010/main" val="7016712"/>
+        <p14:creationId xmlns:p14="http://schemas.microsoft.com/office/powerpoint/2010/main" val="2873945218"/>
       </p:ext>
     </p:extLst>
   </p:cSld>
@@ -11206,6 +11247,177 @@
           <p:cNvPr id="2" name="Title 1">
             <a:extLst>
               <a:ext uri="{FF2B5EF4-FFF2-40B4-BE49-F238E27FC236}">
+                <a16:creationId xmlns:a16="http://schemas.microsoft.com/office/drawing/2014/main" id="{DF9C7201-1C1B-1754-0B8F-E07786E708BB}"/>
+              </a:ext>
+            </a:extLst>
+          </p:cNvPr>
+          <p:cNvSpPr>
+            <a:spLocks noGrp="1"/>
+          </p:cNvSpPr>
+          <p:nvPr>
+            <p:ph type="title"/>
+          </p:nvPr>
+        </p:nvSpPr>
+        <p:spPr/>
+        <p:txBody>
+          <a:bodyPr/>
+          <a:lstStyle/>
+          <a:p>
+            <a:r>
+              <a:rPr lang="en-US" dirty="0"/>
+              <a:t>Why G2-AIMD is Faster </a:t>
+            </a:r>
+          </a:p>
+        </p:txBody>
+      </p:sp>
+      <p:sp>
+        <p:nvSpPr>
+          <p:cNvPr id="3" name="Content Placeholder 2">
+            <a:extLst>
+              <a:ext uri="{FF2B5EF4-FFF2-40B4-BE49-F238E27FC236}">
+                <a16:creationId xmlns:a16="http://schemas.microsoft.com/office/drawing/2014/main" id="{7BD2331F-55B5-2DF4-61ED-3D123CA1E3FD}"/>
+              </a:ext>
+            </a:extLst>
+          </p:cNvPr>
+          <p:cNvSpPr>
+            <a:spLocks noGrp="1"/>
+          </p:cNvSpPr>
+          <p:nvPr>
+            <p:ph idx="1"/>
+          </p:nvPr>
+        </p:nvSpPr>
+        <p:spPr/>
+        <p:txBody>
+          <a:bodyPr>
+            <a:normAutofit/>
+          </a:bodyPr>
+          <a:lstStyle/>
+          <a:p>
+            <a:pPr marL="0" indent="0">
+              <a:buNone/>
+            </a:pPr>
+            <a:r>
+              <a:rPr lang="en-US" dirty="0"/>
+              <a:t>In some cases, G2-AIMD outperforms GPU-hybrid even when neither system overflows.</a:t>
+            </a:r>
+          </a:p>
+          <a:p>
+            <a:pPr lvl="0"/>
+            <a:r>
+              <a:rPr lang="en-US" dirty="0"/>
+              <a:t>G2-AIMD follows a simpler GPU execution path.</a:t>
+            </a:r>
+          </a:p>
+          <a:p>
+            <a:pPr lvl="0"/>
+            <a:r>
+              <a:rPr lang="en-US" dirty="0"/>
+              <a:t>Our system uses adaptive device and host buffers to protect against overflow.</a:t>
+            </a:r>
+          </a:p>
+          <a:p>
+            <a:pPr lvl="0"/>
+            <a:r>
+              <a:rPr lang="en-US" dirty="0"/>
+              <a:t>This flexibility requires additional capacity checks, overflow tracking, and destination selection.</a:t>
+            </a:r>
+          </a:p>
+          <a:p>
+            <a:pPr lvl="0"/>
+            <a:r>
+              <a:rPr lang="en-US" dirty="0"/>
+              <a:t>The generic buffer interface keeps more state alive, which can change compiler optimizations and register allocations.</a:t>
+            </a:r>
+          </a:p>
+        </p:txBody>
+      </p:sp>
+      <p:sp>
+        <p:nvSpPr>
+          <p:cNvPr id="4" name="TextBox 3">
+            <a:extLst>
+              <a:ext uri="{FF2B5EF4-FFF2-40B4-BE49-F238E27FC236}">
+                <a16:creationId xmlns:a16="http://schemas.microsoft.com/office/drawing/2014/main" id="{734C9161-0742-3499-7282-73EBA029134B}"/>
+              </a:ext>
+            </a:extLst>
+          </p:cNvPr>
+          <p:cNvSpPr txBox="1"/>
+          <p:nvPr/>
+        </p:nvSpPr>
+        <p:spPr>
+          <a:xfrm>
+            <a:off x="4214811" y="6123543"/>
+            <a:ext cx="6807376" cy="369332"/>
+          </a:xfrm>
+          <a:prstGeom prst="rect">
+            <a:avLst/>
+          </a:prstGeom>
+          <a:noFill/>
+        </p:spPr>
+        <p:txBody>
+          <a:bodyPr wrap="none" rtlCol="0">
+            <a:spAutoFit/>
+          </a:bodyPr>
+          <a:lstStyle/>
+          <a:p>
+            <a:r>
+              <a:rPr lang="en-US" dirty="0">
+                <a:solidFill>
+                  <a:srgbClr val="C00000"/>
+                </a:solidFill>
+              </a:rPr>
+              <a:t>This may explain why some instances in MQC are slower e.g. </a:t>
+            </a:r>
+            <a:r>
+              <a:rPr lang="en-US" dirty="0" err="1">
+                <a:solidFill>
+                  <a:srgbClr val="C00000"/>
+                </a:solidFill>
+              </a:rPr>
+              <a:t>Flixter</a:t>
+            </a:r>
+            <a:endParaRPr lang="en-US" dirty="0">
+              <a:solidFill>
+                <a:srgbClr val="C00000"/>
+              </a:solidFill>
+            </a:endParaRPr>
+          </a:p>
+        </p:txBody>
+      </p:sp>
+    </p:spTree>
+    <p:extLst>
+      <p:ext uri="{BB962C8B-B14F-4D97-AF65-F5344CB8AC3E}">
+        <p14:creationId xmlns:p14="http://schemas.microsoft.com/office/powerpoint/2010/main" val="7016712"/>
+      </p:ext>
+    </p:extLst>
+  </p:cSld>
+  <p:clrMapOvr>
+    <a:masterClrMapping/>
+  </p:clrMapOvr>
+</p:sld>
+</file>
+
+<file path=ppt/slides/slide31.xml><?xml version="1.0" encoding="utf-8"?>
+<p:sld xmlns:a="http://schemas.openxmlformats.org/drawingml/2006/main" xmlns:r="http://schemas.openxmlformats.org/officeDocument/2006/relationships" xmlns:p="http://schemas.openxmlformats.org/presentationml/2006/main">
+  <p:cSld>
+    <p:spTree>
+      <p:nvGrpSpPr>
+        <p:cNvPr id="1" name=""/>
+        <p:cNvGrpSpPr/>
+        <p:nvPr/>
+      </p:nvGrpSpPr>
+      <p:grpSpPr>
+        <a:xfrm>
+          <a:off x="0" y="0"/>
+          <a:ext cx="0" cy="0"/>
+          <a:chOff x="0" y="0"/>
+          <a:chExt cx="0" cy="0"/>
+        </a:xfrm>
+      </p:grpSpPr>
+      <p:sp>
+        <p:nvSpPr>
+          <p:cNvPr id="2" name="Title 1">
+            <a:extLst>
+              <a:ext uri="{FF2B5EF4-FFF2-40B4-BE49-F238E27FC236}">
                 <a16:creationId xmlns:a16="http://schemas.microsoft.com/office/drawing/2014/main" id="{4FCD8988-8E15-7B7A-BAF1-331B63E6DD8C}"/>
               </a:ext>
             </a:extLst>
@@ -11281,7 +11493,7 @@
             </a:r>
             <a:r>
               <a:rPr lang="en-US" dirty="0"/>
-              <a:t>.</a:t>
+              <a:t> or H.</a:t>
             </a:r>
           </a:p>
           <a:p>
@@ -11347,7 +11559,7 @@
 </p:sld>
 </file>
 
-<file path=ppt/slides/slide31.xml><?xml version="1.0" encoding="utf-8"?>
+<file path=ppt/slides/slide32.xml><?xml version="1.0" encoding="utf-8"?>
 <p:sld xmlns:a="http://schemas.openxmlformats.org/drawingml/2006/main" xmlns:r="http://schemas.openxmlformats.org/officeDocument/2006/relationships" xmlns:p="http://schemas.openxmlformats.org/presentationml/2006/main">
   <p:cSld>
     <p:spTree>
@@ -11996,548 +12208,6 @@
     <p:extLst>
       <p:ext uri="{BB962C8B-B14F-4D97-AF65-F5344CB8AC3E}">
         <p14:creationId xmlns:p14="http://schemas.microsoft.com/office/powerpoint/2010/main" val="397359735"/>
-      </p:ext>
-    </p:extLst>
-  </p:cSld>
-  <p:clrMapOvr>
-    <a:masterClrMapping/>
-  </p:clrMapOvr>
-</p:sld>
-</file>
-
-<file path=ppt/slides/slide32.xml><?xml version="1.0" encoding="utf-8"?>
-<p:sld xmlns:a="http://schemas.openxmlformats.org/drawingml/2006/main" xmlns:r="http://schemas.openxmlformats.org/officeDocument/2006/relationships" xmlns:p="http://schemas.openxmlformats.org/presentationml/2006/main">
-  <p:cSld>
-    <p:spTree>
-      <p:nvGrpSpPr>
-        <p:cNvPr id="1" name=""/>
-        <p:cNvGrpSpPr/>
-        <p:nvPr/>
-      </p:nvGrpSpPr>
-      <p:grpSpPr>
-        <a:xfrm>
-          <a:off x="0" y="0"/>
-          <a:ext cx="0" cy="0"/>
-          <a:chOff x="0" y="0"/>
-          <a:chExt cx="0" cy="0"/>
-        </a:xfrm>
-      </p:grpSpPr>
-      <p:sp>
-        <p:nvSpPr>
-          <p:cNvPr id="2" name="Title 1">
-            <a:extLst>
-              <a:ext uri="{FF2B5EF4-FFF2-40B4-BE49-F238E27FC236}">
-                <a16:creationId xmlns:a16="http://schemas.microsoft.com/office/drawing/2014/main" id="{7D291E18-9DFD-BE05-AAD5-88906D182AFF}"/>
-              </a:ext>
-            </a:extLst>
-          </p:cNvPr>
-          <p:cNvSpPr>
-            <a:spLocks noGrp="1"/>
-          </p:cNvSpPr>
-          <p:nvPr>
-            <p:ph type="title"/>
-          </p:nvPr>
-        </p:nvSpPr>
-        <p:spPr/>
-        <p:txBody>
-          <a:bodyPr/>
-          <a:lstStyle/>
-          <a:p>
-            <a:r>
-              <a:rPr lang="en-US"/>
-              <a:t>Update CPU Worker</a:t>
-            </a:r>
-            <a:endParaRPr lang="en-US" dirty="0"/>
-          </a:p>
-        </p:txBody>
-      </p:sp>
-      <p:pic>
-        <p:nvPicPr>
-          <p:cNvPr id="4" name="Picture 3">
-            <a:extLst>
-              <a:ext uri="{FF2B5EF4-FFF2-40B4-BE49-F238E27FC236}">
-                <a16:creationId xmlns:a16="http://schemas.microsoft.com/office/drawing/2014/main" id="{B34F3316-7270-F1BB-A82C-E34019F8BAEE}"/>
-              </a:ext>
-            </a:extLst>
-          </p:cNvPr>
-          <p:cNvPicPr>
-            <a:picLocks noChangeAspect="1"/>
-          </p:cNvPicPr>
-          <p:nvPr/>
-        </p:nvPicPr>
-        <p:blipFill>
-          <a:blip r:embed="rId2"/>
-          <a:srcRect b="9091"/>
-          <a:stretch>
-            <a:fillRect/>
-          </a:stretch>
-        </p:blipFill>
-        <p:spPr>
-          <a:xfrm>
-            <a:off x="2349500" y="1955631"/>
-            <a:ext cx="7950200" cy="2603669"/>
-          </a:xfrm>
-          <a:prstGeom prst="rect">
-            <a:avLst/>
-          </a:prstGeom>
-        </p:spPr>
-      </p:pic>
-      <p:pic>
-        <p:nvPicPr>
-          <p:cNvPr id="7" name="Picture 6">
-            <a:extLst>
-              <a:ext uri="{FF2B5EF4-FFF2-40B4-BE49-F238E27FC236}">
-                <a16:creationId xmlns:a16="http://schemas.microsoft.com/office/drawing/2014/main" id="{0887BFF7-624C-257F-6649-8B778DD7D07F}"/>
-              </a:ext>
-            </a:extLst>
-          </p:cNvPr>
-          <p:cNvPicPr>
-            <a:picLocks noChangeAspect="1"/>
-          </p:cNvPicPr>
-          <p:nvPr/>
-        </p:nvPicPr>
-        <p:blipFill>
-          <a:blip r:embed="rId3"/>
-          <a:srcRect l="53140"/>
-          <a:stretch>
-            <a:fillRect/>
-          </a:stretch>
-        </p:blipFill>
-        <p:spPr>
-          <a:xfrm>
-            <a:off x="7412901" y="5259645"/>
-            <a:ext cx="390360" cy="730728"/>
-          </a:xfrm>
-          <a:prstGeom prst="rect">
-            <a:avLst/>
-          </a:prstGeom>
-        </p:spPr>
-      </p:pic>
-      <p:sp>
-        <p:nvSpPr>
-          <p:cNvPr id="8" name="TextBox 7">
-            <a:extLst>
-              <a:ext uri="{FF2B5EF4-FFF2-40B4-BE49-F238E27FC236}">
-                <a16:creationId xmlns:a16="http://schemas.microsoft.com/office/drawing/2014/main" id="{8D916048-DF75-1452-4265-9D9A582345D9}"/>
-              </a:ext>
-            </a:extLst>
-          </p:cNvPr>
-          <p:cNvSpPr txBox="1"/>
-          <p:nvPr/>
-        </p:nvSpPr>
-        <p:spPr>
-          <a:xfrm>
-            <a:off x="7412901" y="5259645"/>
-            <a:ext cx="626006" cy="276999"/>
-          </a:xfrm>
-          <a:prstGeom prst="rect">
-            <a:avLst/>
-          </a:prstGeom>
-          <a:noFill/>
-        </p:spPr>
-        <p:txBody>
-          <a:bodyPr wrap="square" rtlCol="0">
-            <a:spAutoFit/>
-          </a:bodyPr>
-          <a:lstStyle/>
-          <a:p>
-            <a:r>
-              <a:rPr lang="en-US" sz="1200" b="1" i="1" dirty="0"/>
-              <a:t>big</a:t>
-            </a:r>
-          </a:p>
-        </p:txBody>
-      </p:sp>
-      <p:pic>
-        <p:nvPicPr>
-          <p:cNvPr id="15" name="Picture 14">
-            <a:extLst>
-              <a:ext uri="{FF2B5EF4-FFF2-40B4-BE49-F238E27FC236}">
-                <a16:creationId xmlns:a16="http://schemas.microsoft.com/office/drawing/2014/main" id="{190DF368-E8DA-C66C-E90C-77DD0DB2C4F5}"/>
-              </a:ext>
-            </a:extLst>
-          </p:cNvPr>
-          <p:cNvPicPr>
-            <a:picLocks noChangeAspect="1"/>
-          </p:cNvPicPr>
-          <p:nvPr/>
-        </p:nvPicPr>
-        <p:blipFill>
-          <a:blip r:embed="rId4"/>
-          <a:stretch>
-            <a:fillRect/>
-          </a:stretch>
-        </p:blipFill>
-        <p:spPr>
-          <a:xfrm>
-            <a:off x="5721350" y="1663531"/>
-            <a:ext cx="2527300" cy="292100"/>
-          </a:xfrm>
-          <a:prstGeom prst="rect">
-            <a:avLst/>
-          </a:prstGeom>
-        </p:spPr>
-      </p:pic>
-      <p:sp>
-        <p:nvSpPr>
-          <p:cNvPr id="16" name="TextBox 15">
-            <a:extLst>
-              <a:ext uri="{FF2B5EF4-FFF2-40B4-BE49-F238E27FC236}">
-                <a16:creationId xmlns:a16="http://schemas.microsoft.com/office/drawing/2014/main" id="{132A7DEC-0ED2-99D7-C858-3C74D3068193}"/>
-              </a:ext>
-            </a:extLst>
-          </p:cNvPr>
-          <p:cNvSpPr txBox="1"/>
-          <p:nvPr/>
-        </p:nvSpPr>
-        <p:spPr>
-          <a:xfrm>
-            <a:off x="5721350" y="1321356"/>
-            <a:ext cx="954107" cy="369332"/>
-          </a:xfrm>
-          <a:prstGeom prst="rect">
-            <a:avLst/>
-          </a:prstGeom>
-          <a:noFill/>
-        </p:spPr>
-        <p:txBody>
-          <a:bodyPr wrap="none" rtlCol="0">
-            <a:spAutoFit/>
-          </a:bodyPr>
-          <a:lstStyle/>
-          <a:p>
-            <a:r>
-              <a:rPr lang="en-US"/>
-              <a:t>CPU </a:t>
-            </a:r>
-            <a:r>
-              <a:rPr lang="en-US">
-                <a:sym typeface="Wingdings" pitchFamily="2" charset="2"/>
-              </a:rPr>
-              <a:t> </a:t>
-            </a:r>
-            <a:endParaRPr lang="en-US" dirty="0"/>
-          </a:p>
-        </p:txBody>
-      </p:sp>
-      <p:sp>
-        <p:nvSpPr>
-          <p:cNvPr id="17" name="TextBox 16">
-            <a:extLst>
-              <a:ext uri="{FF2B5EF4-FFF2-40B4-BE49-F238E27FC236}">
-                <a16:creationId xmlns:a16="http://schemas.microsoft.com/office/drawing/2014/main" id="{12E7DE85-92A7-A7EA-AE7C-F1B776E35B2C}"/>
-              </a:ext>
-            </a:extLst>
-          </p:cNvPr>
-          <p:cNvSpPr txBox="1"/>
-          <p:nvPr/>
-        </p:nvSpPr>
-        <p:spPr>
-          <a:xfrm>
-            <a:off x="4622800" y="1586299"/>
-            <a:ext cx="989438" cy="369332"/>
-          </a:xfrm>
-          <a:prstGeom prst="rect">
-            <a:avLst/>
-          </a:prstGeom>
-          <a:noFill/>
-        </p:spPr>
-        <p:txBody>
-          <a:bodyPr wrap="none" rtlCol="0">
-            <a:spAutoFit/>
-          </a:bodyPr>
-          <a:lstStyle/>
-          <a:p>
-            <a:r>
-              <a:rPr lang="en-US" dirty="0" err="1"/>
-              <a:t>big_root</a:t>
-            </a:r>
-            <a:endParaRPr lang="en-US" dirty="0"/>
-          </a:p>
-        </p:txBody>
-      </p:sp>
-      <p:cxnSp>
-        <p:nvCxnSpPr>
-          <p:cNvPr id="19" name="Straight Arrow Connector 18">
-            <a:extLst>
-              <a:ext uri="{FF2B5EF4-FFF2-40B4-BE49-F238E27FC236}">
-                <a16:creationId xmlns:a16="http://schemas.microsoft.com/office/drawing/2014/main" id="{77C7BAF6-FF5F-E302-0365-0CAF2AAD1F7C}"/>
-              </a:ext>
-            </a:extLst>
-          </p:cNvPr>
-          <p:cNvCxnSpPr>
-            <a:stCxn id="15" idx="2"/>
-          </p:cNvCxnSpPr>
-          <p:nvPr/>
-        </p:nvCxnSpPr>
-        <p:spPr>
-          <a:xfrm>
-            <a:off x="6985000" y="1955631"/>
-            <a:ext cx="1263650" cy="1168569"/>
-          </a:xfrm>
-          <a:prstGeom prst="straightConnector1">
-            <a:avLst/>
-          </a:prstGeom>
-          <a:ln>
-            <a:tailEnd type="triangle"/>
-          </a:ln>
-        </p:spPr>
-        <p:style>
-          <a:lnRef idx="2">
-            <a:schemeClr val="accent1"/>
-          </a:lnRef>
-          <a:fillRef idx="0">
-            <a:schemeClr val="accent1"/>
-          </a:fillRef>
-          <a:effectRef idx="1">
-            <a:schemeClr val="accent1"/>
-          </a:effectRef>
-          <a:fontRef idx="minor">
-            <a:schemeClr val="tx1"/>
-          </a:fontRef>
-        </p:style>
-      </p:cxnSp>
-      <p:cxnSp>
-        <p:nvCxnSpPr>
-          <p:cNvPr id="20" name="Straight Arrow Connector 19">
-            <a:extLst>
-              <a:ext uri="{FF2B5EF4-FFF2-40B4-BE49-F238E27FC236}">
-                <a16:creationId xmlns:a16="http://schemas.microsoft.com/office/drawing/2014/main" id="{A188E86F-74E4-1777-90C5-96968350B754}"/>
-              </a:ext>
-            </a:extLst>
-          </p:cNvPr>
-          <p:cNvCxnSpPr>
-            <a:cxnSpLocks/>
-          </p:cNvCxnSpPr>
-          <p:nvPr/>
-        </p:nvCxnSpPr>
-        <p:spPr>
-          <a:xfrm>
-            <a:off x="7539468" y="3572171"/>
-            <a:ext cx="27025" cy="1687473"/>
-          </a:xfrm>
-          <a:prstGeom prst="straightConnector1">
-            <a:avLst/>
-          </a:prstGeom>
-          <a:ln>
-            <a:prstDash val="dash"/>
-            <a:tailEnd type="triangle"/>
-          </a:ln>
-        </p:spPr>
-        <p:style>
-          <a:lnRef idx="2">
-            <a:schemeClr val="accent1"/>
-          </a:lnRef>
-          <a:fillRef idx="0">
-            <a:schemeClr val="accent1"/>
-          </a:fillRef>
-          <a:effectRef idx="1">
-            <a:schemeClr val="accent1"/>
-          </a:effectRef>
-          <a:fontRef idx="minor">
-            <a:schemeClr val="tx1"/>
-          </a:fontRef>
-        </p:style>
-      </p:cxnSp>
-      <p:sp>
-        <p:nvSpPr>
-          <p:cNvPr id="22" name="TextBox 21">
-            <a:extLst>
-              <a:ext uri="{FF2B5EF4-FFF2-40B4-BE49-F238E27FC236}">
-                <a16:creationId xmlns:a16="http://schemas.microsoft.com/office/drawing/2014/main" id="{953AEAA8-B890-570B-D908-E2423BC4FBAA}"/>
-              </a:ext>
-            </a:extLst>
-          </p:cNvPr>
-          <p:cNvSpPr txBox="1"/>
-          <p:nvPr/>
-        </p:nvSpPr>
-        <p:spPr>
-          <a:xfrm>
-            <a:off x="6592907" y="4618895"/>
-            <a:ext cx="950004" cy="646331"/>
-          </a:xfrm>
-          <a:prstGeom prst="rect">
-            <a:avLst/>
-          </a:prstGeom>
-          <a:noFill/>
-        </p:spPr>
-        <p:txBody>
-          <a:bodyPr wrap="none" rtlCol="0">
-            <a:spAutoFit/>
-          </a:bodyPr>
-          <a:lstStyle/>
-          <a:p>
-            <a:r>
-              <a:rPr lang="en-US"/>
-              <a:t>still a </a:t>
-            </a:r>
-            <a:endParaRPr lang="en-US" dirty="0"/>
-          </a:p>
-          <a:p>
-            <a:r>
-              <a:rPr lang="en-US"/>
-              <a:t>big task</a:t>
-            </a:r>
-            <a:endParaRPr lang="en-US" dirty="0"/>
-          </a:p>
-        </p:txBody>
-      </p:sp>
-      <p:pic>
-        <p:nvPicPr>
-          <p:cNvPr id="25" name="Picture 24">
-            <a:extLst>
-              <a:ext uri="{FF2B5EF4-FFF2-40B4-BE49-F238E27FC236}">
-                <a16:creationId xmlns:a16="http://schemas.microsoft.com/office/drawing/2014/main" id="{93D4A19A-2EDE-CB25-E141-9CEF122CCFC2}"/>
-              </a:ext>
-            </a:extLst>
-          </p:cNvPr>
-          <p:cNvPicPr>
-            <a:picLocks noChangeAspect="1"/>
-          </p:cNvPicPr>
-          <p:nvPr/>
-        </p:nvPicPr>
-        <p:blipFill>
-          <a:blip r:embed="rId5"/>
-          <a:srcRect r="28414" b="18252"/>
-          <a:stretch>
-            <a:fillRect/>
-          </a:stretch>
-        </p:blipFill>
-        <p:spPr>
-          <a:xfrm>
-            <a:off x="8038907" y="5756778"/>
-            <a:ext cx="736405" cy="467190"/>
-          </a:xfrm>
-          <a:prstGeom prst="rect">
-            <a:avLst/>
-          </a:prstGeom>
-        </p:spPr>
-      </p:pic>
-      <p:cxnSp>
-        <p:nvCxnSpPr>
-          <p:cNvPr id="26" name="Straight Arrow Connector 25">
-            <a:extLst>
-              <a:ext uri="{FF2B5EF4-FFF2-40B4-BE49-F238E27FC236}">
-                <a16:creationId xmlns:a16="http://schemas.microsoft.com/office/drawing/2014/main" id="{F8B99B4F-A683-F981-B0B5-E57FAF0629D9}"/>
-              </a:ext>
-            </a:extLst>
-          </p:cNvPr>
-          <p:cNvCxnSpPr>
-            <a:cxnSpLocks/>
-            <a:endCxn id="25" idx="1"/>
-          </p:cNvCxnSpPr>
-          <p:nvPr/>
-        </p:nvCxnSpPr>
-        <p:spPr>
-          <a:xfrm>
-            <a:off x="7632312" y="5990373"/>
-            <a:ext cx="406595" cy="0"/>
-          </a:xfrm>
-          <a:prstGeom prst="straightConnector1">
-            <a:avLst/>
-          </a:prstGeom>
-          <a:ln>
-            <a:prstDash val="dash"/>
-            <a:tailEnd type="triangle"/>
-          </a:ln>
-        </p:spPr>
-        <p:style>
-          <a:lnRef idx="2">
-            <a:schemeClr val="accent1"/>
-          </a:lnRef>
-          <a:fillRef idx="0">
-            <a:schemeClr val="accent1"/>
-          </a:fillRef>
-          <a:effectRef idx="1">
-            <a:schemeClr val="accent1"/>
-          </a:effectRef>
-          <a:fontRef idx="minor">
-            <a:schemeClr val="tx1"/>
-          </a:fontRef>
-        </p:style>
-      </p:cxnSp>
-      <p:sp>
-        <p:nvSpPr>
-          <p:cNvPr id="31" name="TextBox 30">
-            <a:extLst>
-              <a:ext uri="{FF2B5EF4-FFF2-40B4-BE49-F238E27FC236}">
-                <a16:creationId xmlns:a16="http://schemas.microsoft.com/office/drawing/2014/main" id="{089AF7A7-23FB-40B7-63F6-C7FA798F1045}"/>
-              </a:ext>
-            </a:extLst>
-          </p:cNvPr>
-          <p:cNvSpPr txBox="1"/>
-          <p:nvPr/>
-        </p:nvSpPr>
-        <p:spPr>
-          <a:xfrm>
-            <a:off x="8700988" y="5805707"/>
-            <a:ext cx="716863" cy="369332"/>
-          </a:xfrm>
-          <a:prstGeom prst="rect">
-            <a:avLst/>
-          </a:prstGeom>
-          <a:noFill/>
-        </p:spPr>
-        <p:txBody>
-          <a:bodyPr wrap="none" rtlCol="0">
-            <a:spAutoFit/>
-          </a:bodyPr>
-          <a:lstStyle/>
-          <a:p>
-            <a:r>
-              <a:rPr lang="en-US" i="1" dirty="0" err="1"/>
-              <a:t>big_S</a:t>
-            </a:r>
-            <a:endParaRPr lang="en-US" i="1" dirty="0"/>
-          </a:p>
-        </p:txBody>
-      </p:sp>
-      <p:cxnSp>
-        <p:nvCxnSpPr>
-          <p:cNvPr id="33" name="Straight Arrow Connector 32">
-            <a:extLst>
-              <a:ext uri="{FF2B5EF4-FFF2-40B4-BE49-F238E27FC236}">
-                <a16:creationId xmlns:a16="http://schemas.microsoft.com/office/drawing/2014/main" id="{11A66878-DAE4-281F-4E7A-65095BA631A9}"/>
-              </a:ext>
-            </a:extLst>
-          </p:cNvPr>
-          <p:cNvCxnSpPr>
-            <a:cxnSpLocks/>
-            <a:stCxn id="25" idx="1"/>
-          </p:cNvCxnSpPr>
-          <p:nvPr/>
-        </p:nvCxnSpPr>
-        <p:spPr>
-          <a:xfrm flipV="1">
-            <a:off x="8038907" y="3552586"/>
-            <a:ext cx="474147" cy="2437787"/>
-          </a:xfrm>
-          <a:prstGeom prst="straightConnector1">
-            <a:avLst/>
-          </a:prstGeom>
-          <a:ln>
-            <a:tailEnd type="triangle"/>
-          </a:ln>
-        </p:spPr>
-        <p:style>
-          <a:lnRef idx="2">
-            <a:schemeClr val="accent1"/>
-          </a:lnRef>
-          <a:fillRef idx="0">
-            <a:schemeClr val="accent1"/>
-          </a:fillRef>
-          <a:effectRef idx="1">
-            <a:schemeClr val="accent1"/>
-          </a:effectRef>
-          <a:fontRef idx="minor">
-            <a:schemeClr val="tx1"/>
-          </a:fontRef>
-        </p:style>
-      </p:cxnSp>
-    </p:spTree>
-    <p:extLst>
-      <p:ext uri="{BB962C8B-B14F-4D97-AF65-F5344CB8AC3E}">
-        <p14:creationId xmlns:p14="http://schemas.microsoft.com/office/powerpoint/2010/main" val="49281363"/>
       </p:ext>
     </p:extLst>
   </p:cSld>

</xml_diff>

<commit_message>
auto commit 2026-08-14 15:02:30
</commit_message>
<xml_diff>
--- a/revision.pptx
+++ b/revision.pptx
@@ -34,9 +34,12 @@
     <p:sldId id="258" r:id="rId28"/>
     <p:sldId id="276" r:id="rId29"/>
     <p:sldId id="277" r:id="rId30"/>
-    <p:sldId id="282" r:id="rId31"/>
-    <p:sldId id="278" r:id="rId32"/>
-    <p:sldId id="279" r:id="rId33"/>
+    <p:sldId id="292" r:id="rId31"/>
+    <p:sldId id="282" r:id="rId32"/>
+    <p:sldId id="278" r:id="rId33"/>
+    <p:sldId id="279" r:id="rId34"/>
+    <p:sldId id="293" r:id="rId35"/>
+    <p:sldId id="294" r:id="rId36"/>
   </p:sldIdLst>
   <p:sldSz cx="12192000" cy="6858000"/>
   <p:notesSz cx="6858000" cy="9144000"/>
@@ -290,7 +293,7 @@
           <a:p>
             <a:fld id="{6F584DAC-AA37-8C49-B5B6-53E9519E19BB}" type="datetimeFigureOut">
               <a:rPr lang="en-US" smtClean="0"/>
-              <a:t>8/2/26</a:t>
+              <a:t>8/8/26</a:t>
             </a:fld>
             <a:endParaRPr lang="en-US"/>
           </a:p>
@@ -488,7 +491,7 @@
           <a:p>
             <a:fld id="{6F584DAC-AA37-8C49-B5B6-53E9519E19BB}" type="datetimeFigureOut">
               <a:rPr lang="en-US" smtClean="0"/>
-              <a:t>8/2/26</a:t>
+              <a:t>8/8/26</a:t>
             </a:fld>
             <a:endParaRPr lang="en-US"/>
           </a:p>
@@ -696,7 +699,7 @@
           <a:p>
             <a:fld id="{6F584DAC-AA37-8C49-B5B6-53E9519E19BB}" type="datetimeFigureOut">
               <a:rPr lang="en-US" smtClean="0"/>
-              <a:t>8/2/26</a:t>
+              <a:t>8/8/26</a:t>
             </a:fld>
             <a:endParaRPr lang="en-US"/>
           </a:p>
@@ -894,7 +897,7 @@
           <a:p>
             <a:fld id="{6F584DAC-AA37-8C49-B5B6-53E9519E19BB}" type="datetimeFigureOut">
               <a:rPr lang="en-US" smtClean="0"/>
-              <a:t>8/2/26</a:t>
+              <a:t>8/8/26</a:t>
             </a:fld>
             <a:endParaRPr lang="en-US"/>
           </a:p>
@@ -1169,7 +1172,7 @@
           <a:p>
             <a:fld id="{6F584DAC-AA37-8C49-B5B6-53E9519E19BB}" type="datetimeFigureOut">
               <a:rPr lang="en-US" smtClean="0"/>
-              <a:t>8/2/26</a:t>
+              <a:t>8/8/26</a:t>
             </a:fld>
             <a:endParaRPr lang="en-US"/>
           </a:p>
@@ -1434,7 +1437,7 @@
           <a:p>
             <a:fld id="{6F584DAC-AA37-8C49-B5B6-53E9519E19BB}" type="datetimeFigureOut">
               <a:rPr lang="en-US" smtClean="0"/>
-              <a:t>8/2/26</a:t>
+              <a:t>8/8/26</a:t>
             </a:fld>
             <a:endParaRPr lang="en-US"/>
           </a:p>
@@ -1846,7 +1849,7 @@
           <a:p>
             <a:fld id="{6F584DAC-AA37-8C49-B5B6-53E9519E19BB}" type="datetimeFigureOut">
               <a:rPr lang="en-US" smtClean="0"/>
-              <a:t>8/2/26</a:t>
+              <a:t>8/8/26</a:t>
             </a:fld>
             <a:endParaRPr lang="en-US"/>
           </a:p>
@@ -1987,7 +1990,7 @@
           <a:p>
             <a:fld id="{6F584DAC-AA37-8C49-B5B6-53E9519E19BB}" type="datetimeFigureOut">
               <a:rPr lang="en-US" smtClean="0"/>
-              <a:t>8/2/26</a:t>
+              <a:t>8/8/26</a:t>
             </a:fld>
             <a:endParaRPr lang="en-US"/>
           </a:p>
@@ -2100,7 +2103,7 @@
           <a:p>
             <a:fld id="{6F584DAC-AA37-8C49-B5B6-53E9519E19BB}" type="datetimeFigureOut">
               <a:rPr lang="en-US" smtClean="0"/>
-              <a:t>8/2/26</a:t>
+              <a:t>8/8/26</a:t>
             </a:fld>
             <a:endParaRPr lang="en-US"/>
           </a:p>
@@ -2411,7 +2414,7 @@
           <a:p>
             <a:fld id="{6F584DAC-AA37-8C49-B5B6-53E9519E19BB}" type="datetimeFigureOut">
               <a:rPr lang="en-US" smtClean="0"/>
-              <a:t>8/2/26</a:t>
+              <a:t>8/8/26</a:t>
             </a:fld>
             <a:endParaRPr lang="en-US"/>
           </a:p>
@@ -2699,7 +2702,7 @@
           <a:p>
             <a:fld id="{6F584DAC-AA37-8C49-B5B6-53E9519E19BB}" type="datetimeFigureOut">
               <a:rPr lang="en-US" smtClean="0"/>
-              <a:t>8/2/26</a:t>
+              <a:t>8/8/26</a:t>
             </a:fld>
             <a:endParaRPr lang="en-US"/>
           </a:p>
@@ -2940,7 +2943,7 @@
           <a:p>
             <a:fld id="{6F584DAC-AA37-8C49-B5B6-53E9519E19BB}" type="datetimeFigureOut">
               <a:rPr lang="en-US" smtClean="0"/>
-              <a:t>8/2/26</a:t>
+              <a:t>8/8/26</a:t>
             </a:fld>
             <a:endParaRPr lang="en-US"/>
           </a:p>
@@ -11247,6 +11250,602 @@
           <p:cNvPr id="2" name="Title 1">
             <a:extLst>
               <a:ext uri="{FF2B5EF4-FFF2-40B4-BE49-F238E27FC236}">
+                <a16:creationId xmlns:a16="http://schemas.microsoft.com/office/drawing/2014/main" id="{DB20E587-2136-19AE-BB08-5E7EA51DB52B}"/>
+              </a:ext>
+            </a:extLst>
+          </p:cNvPr>
+          <p:cNvSpPr>
+            <a:spLocks noGrp="1"/>
+          </p:cNvSpPr>
+          <p:nvPr>
+            <p:ph type="title"/>
+          </p:nvPr>
+        </p:nvSpPr>
+        <p:spPr/>
+        <p:txBody>
+          <a:bodyPr/>
+          <a:lstStyle/>
+          <a:p>
+            <a:r>
+              <a:rPr lang="en-US" dirty="0"/>
+              <a:t>Why OOM-Fixed version of G2-AIMD Faster?</a:t>
+            </a:r>
+          </a:p>
+        </p:txBody>
+      </p:sp>
+      <p:graphicFrame>
+        <p:nvGraphicFramePr>
+          <p:cNvPr id="4" name="Content Placeholder 3">
+            <a:extLst>
+              <a:ext uri="{FF2B5EF4-FFF2-40B4-BE49-F238E27FC236}">
+                <a16:creationId xmlns:a16="http://schemas.microsoft.com/office/drawing/2014/main" id="{29B8652E-5AB9-2D13-5A7B-FCD28C20BB62}"/>
+              </a:ext>
+            </a:extLst>
+          </p:cNvPr>
+          <p:cNvGraphicFramePr>
+            <a:graphicFrameLocks noGrp="1"/>
+          </p:cNvGraphicFramePr>
+          <p:nvPr>
+            <p:ph idx="1"/>
+            <p:extLst>
+              <p:ext uri="{D42A27DB-BD31-4B8C-83A1-F6EECF244321}">
+                <p14:modId xmlns:p14="http://schemas.microsoft.com/office/powerpoint/2010/main" val="4254775755"/>
+              </p:ext>
+            </p:extLst>
+          </p:nvPr>
+        </p:nvGraphicFramePr>
+        <p:xfrm>
+          <a:off x="5390708" y="5600436"/>
+          <a:ext cx="3728483" cy="892439"/>
+        </p:xfrm>
+        <a:graphic>
+          <a:graphicData uri="http://schemas.openxmlformats.org/drawingml/2006/table">
+            <a:tbl>
+              <a:tblPr>
+                <a:tableStyleId>{5C22544A-7EE6-4342-B048-85BDC9FD1C3A}</a:tableStyleId>
+              </a:tblPr>
+              <a:tblGrid>
+                <a:gridCol w="1219200">
+                  <a:extLst>
+                    <a:ext uri="{9D8B030D-6E8A-4147-A177-3AD203B41FA5}">
+                      <a16:colId xmlns:a16="http://schemas.microsoft.com/office/drawing/2014/main" val="713271382"/>
+                    </a:ext>
+                  </a:extLst>
+                </a:gridCol>
+                <a:gridCol w="1786270">
+                  <a:extLst>
+                    <a:ext uri="{9D8B030D-6E8A-4147-A177-3AD203B41FA5}">
+                      <a16:colId xmlns:a16="http://schemas.microsoft.com/office/drawing/2014/main" val="4145633645"/>
+                    </a:ext>
+                  </a:extLst>
+                </a:gridCol>
+                <a:gridCol w="723013">
+                  <a:extLst>
+                    <a:ext uri="{9D8B030D-6E8A-4147-A177-3AD203B41FA5}">
+                      <a16:colId xmlns:a16="http://schemas.microsoft.com/office/drawing/2014/main" val="2927860622"/>
+                    </a:ext>
+                  </a:extLst>
+                </a:gridCol>
+              </a:tblGrid>
+              <a:tr h="320017">
+                <a:tc>
+                  <a:txBody>
+                    <a:bodyPr/>
+                    <a:lstStyle/>
+                    <a:p>
+                      <a:pPr algn="l" fontAlgn="b">
+                        <a:buNone/>
+                      </a:pPr>
+                      <a:r>
+                        <a:rPr lang="en-US" sz="1300" b="1" u="none" strike="noStrike" dirty="0">
+                          <a:effectLst/>
+                        </a:rPr>
+                        <a:t>Dataset</a:t>
+                      </a:r>
+                      <a:endParaRPr lang="en-US" sz="1300" b="1" i="0" u="none" strike="noStrike" dirty="0">
+                        <a:solidFill>
+                          <a:srgbClr val="FFFFFF"/>
+                        </a:solidFill>
+                        <a:effectLst/>
+                        <a:latin typeface="Aptos Narrow" panose="020B0004020202020204" pitchFamily="34" charset="0"/>
+                      </a:endParaRPr>
+                    </a:p>
+                  </a:txBody>
+                  <a:tcPr marL="0" marR="0" marT="0" marB="0" anchor="b"/>
+                </a:tc>
+                <a:tc>
+                  <a:txBody>
+                    <a:bodyPr/>
+                    <a:lstStyle/>
+                    <a:p>
+                      <a:pPr algn="l" fontAlgn="b">
+                        <a:buNone/>
+                      </a:pPr>
+                      <a:r>
+                        <a:rPr lang="en-US" sz="1300" b="1" u="none" strike="noStrike" dirty="0">
+                          <a:effectLst/>
+                        </a:rPr>
+                        <a:t>G2-AIMD (OOM-Fixed)</a:t>
+                      </a:r>
+                      <a:endParaRPr lang="en-US" sz="1300" b="1" i="0" u="none" strike="noStrike" dirty="0">
+                        <a:solidFill>
+                          <a:srgbClr val="FFFFFF"/>
+                        </a:solidFill>
+                        <a:effectLst/>
+                        <a:latin typeface="Aptos Narrow" panose="020B0004020202020204" pitchFamily="34" charset="0"/>
+                      </a:endParaRPr>
+                    </a:p>
+                  </a:txBody>
+                  <a:tcPr marL="0" marR="0" marT="0" marB="0" anchor="b"/>
+                </a:tc>
+                <a:tc>
+                  <a:txBody>
+                    <a:bodyPr/>
+                    <a:lstStyle/>
+                    <a:p>
+                      <a:pPr algn="l" fontAlgn="b">
+                        <a:buNone/>
+                      </a:pPr>
+                      <a:r>
+                        <a:rPr lang="en-US" sz="1300" b="1" u="none" strike="noStrike" dirty="0">
+                          <a:effectLst/>
+                        </a:rPr>
+                        <a:t>G2-AIMD</a:t>
+                      </a:r>
+                      <a:endParaRPr lang="en-US" sz="1300" b="1" i="0" u="none" strike="noStrike" dirty="0">
+                        <a:solidFill>
+                          <a:srgbClr val="FFFFFF"/>
+                        </a:solidFill>
+                        <a:effectLst/>
+                        <a:latin typeface="Aptos Narrow" panose="020B0004020202020204" pitchFamily="34" charset="0"/>
+                      </a:endParaRPr>
+                    </a:p>
+                  </a:txBody>
+                  <a:tcPr marL="0" marR="0" marT="0" marB="0" anchor="b"/>
+                </a:tc>
+                <a:extLst>
+                  <a:ext uri="{0D108BD9-81ED-4DB2-BD59-A6C34878D82A}">
+                    <a16:rowId xmlns:a16="http://schemas.microsoft.com/office/drawing/2014/main" val="2770345006"/>
+                  </a:ext>
+                </a:extLst>
+              </a:tr>
+              <a:tr h="286211">
+                <a:tc>
+                  <a:txBody>
+                    <a:bodyPr/>
+                    <a:lstStyle/>
+                    <a:p>
+                      <a:pPr algn="l" fontAlgn="b">
+                        <a:buNone/>
+                      </a:pPr>
+                      <a:r>
+                        <a:rPr lang="en-US" sz="1300" u="none" strike="noStrike">
+                          <a:effectLst/>
+                        </a:rPr>
+                        <a:t>wikipedia_link_it</a:t>
+                      </a:r>
+                      <a:endParaRPr lang="en-US" sz="1300" b="0" i="0" u="none" strike="noStrike">
+                        <a:solidFill>
+                          <a:srgbClr val="000000"/>
+                        </a:solidFill>
+                        <a:effectLst/>
+                        <a:latin typeface="Aptos Narrow" panose="020B0004020202020204" pitchFamily="34" charset="0"/>
+                      </a:endParaRPr>
+                    </a:p>
+                  </a:txBody>
+                  <a:tcPr marL="0" marR="0" marT="0" marB="0" anchor="b"/>
+                </a:tc>
+                <a:tc>
+                  <a:txBody>
+                    <a:bodyPr/>
+                    <a:lstStyle/>
+                    <a:p>
+                      <a:pPr algn="ctr" fontAlgn="b">
+                        <a:buNone/>
+                      </a:pPr>
+                      <a:r>
+                        <a:rPr lang="en-US" sz="1300" u="none" strike="noStrike" dirty="0">
+                          <a:effectLst/>
+                        </a:rPr>
+                        <a:t>33.91</a:t>
+                      </a:r>
+                      <a:endParaRPr lang="en-US" sz="1300" b="0" i="0" u="none" strike="noStrike" dirty="0">
+                        <a:solidFill>
+                          <a:srgbClr val="000000"/>
+                        </a:solidFill>
+                        <a:effectLst/>
+                        <a:latin typeface="Aptos Narrow" panose="020B0004020202020204" pitchFamily="34" charset="0"/>
+                      </a:endParaRPr>
+                    </a:p>
+                  </a:txBody>
+                  <a:tcPr marL="0" marR="0" marT="0" marB="0" anchor="b"/>
+                </a:tc>
+                <a:tc>
+                  <a:txBody>
+                    <a:bodyPr/>
+                    <a:lstStyle/>
+                    <a:p>
+                      <a:pPr algn="ctr" fontAlgn="b">
+                        <a:buNone/>
+                      </a:pPr>
+                      <a:r>
+                        <a:rPr lang="en-US" sz="1500" u="none" strike="noStrike" dirty="0">
+                          <a:effectLst/>
+                        </a:rPr>
+                        <a:t>33.8</a:t>
+                      </a:r>
+                      <a:endParaRPr lang="en-US" sz="1500" b="0" i="0" u="none" strike="noStrike" dirty="0">
+                        <a:solidFill>
+                          <a:srgbClr val="000000"/>
+                        </a:solidFill>
+                        <a:effectLst/>
+                        <a:latin typeface="Aptos Narrow" panose="020B0004020202020204" pitchFamily="34" charset="0"/>
+                      </a:endParaRPr>
+                    </a:p>
+                  </a:txBody>
+                  <a:tcPr marL="0" marR="0" marT="0" marB="0" anchor="b"/>
+                </a:tc>
+                <a:extLst>
+                  <a:ext uri="{0D108BD9-81ED-4DB2-BD59-A6C34878D82A}">
+                    <a16:rowId xmlns:a16="http://schemas.microsoft.com/office/drawing/2014/main" val="1645920416"/>
+                  </a:ext>
+                </a:extLst>
+              </a:tr>
+              <a:tr h="286211">
+                <a:tc>
+                  <a:txBody>
+                    <a:bodyPr/>
+                    <a:lstStyle/>
+                    <a:p>
+                      <a:pPr algn="l" fontAlgn="b">
+                        <a:buNone/>
+                      </a:pPr>
+                      <a:r>
+                        <a:rPr lang="en-US" sz="1300" u="none" strike="noStrike">
+                          <a:effectLst/>
+                        </a:rPr>
+                        <a:t>sx-stackoverflow</a:t>
+                      </a:r>
+                      <a:endParaRPr lang="en-US" sz="1300" b="0" i="0" u="none" strike="noStrike">
+                        <a:solidFill>
+                          <a:srgbClr val="000000"/>
+                        </a:solidFill>
+                        <a:effectLst/>
+                        <a:latin typeface="Aptos Narrow" panose="020B0004020202020204" pitchFamily="34" charset="0"/>
+                      </a:endParaRPr>
+                    </a:p>
+                  </a:txBody>
+                  <a:tcPr marL="0" marR="0" marT="0" marB="0" anchor="b"/>
+                </a:tc>
+                <a:tc>
+                  <a:txBody>
+                    <a:bodyPr/>
+                    <a:lstStyle/>
+                    <a:p>
+                      <a:pPr algn="ctr" fontAlgn="b">
+                        <a:buNone/>
+                      </a:pPr>
+                      <a:r>
+                        <a:rPr lang="en-US" sz="1300" u="none" strike="noStrike" dirty="0">
+                          <a:effectLst/>
+                        </a:rPr>
+                        <a:t>21.52</a:t>
+                      </a:r>
+                      <a:endParaRPr lang="en-US" sz="1300" b="0" i="0" u="none" strike="noStrike" dirty="0">
+                        <a:solidFill>
+                          <a:srgbClr val="000000"/>
+                        </a:solidFill>
+                        <a:effectLst/>
+                        <a:latin typeface="Aptos Narrow" panose="020B0004020202020204" pitchFamily="34" charset="0"/>
+                      </a:endParaRPr>
+                    </a:p>
+                  </a:txBody>
+                  <a:tcPr marL="0" marR="0" marT="0" marB="0" anchor="b"/>
+                </a:tc>
+                <a:tc>
+                  <a:txBody>
+                    <a:bodyPr/>
+                    <a:lstStyle/>
+                    <a:p>
+                      <a:pPr algn="ctr" fontAlgn="b">
+                        <a:buNone/>
+                      </a:pPr>
+                      <a:r>
+                        <a:rPr lang="en-US" sz="1500" u="none" strike="noStrike" dirty="0">
+                          <a:effectLst/>
+                        </a:rPr>
+                        <a:t>71.7</a:t>
+                      </a:r>
+                      <a:endParaRPr lang="en-US" sz="1500" b="0" i="0" u="none" strike="noStrike" dirty="0">
+                        <a:solidFill>
+                          <a:srgbClr val="000000"/>
+                        </a:solidFill>
+                        <a:effectLst/>
+                        <a:latin typeface="Aptos Narrow" panose="020B0004020202020204" pitchFamily="34" charset="0"/>
+                      </a:endParaRPr>
+                    </a:p>
+                  </a:txBody>
+                  <a:tcPr marL="0" marR="0" marT="0" marB="0" anchor="b"/>
+                </a:tc>
+                <a:extLst>
+                  <a:ext uri="{0D108BD9-81ED-4DB2-BD59-A6C34878D82A}">
+                    <a16:rowId xmlns:a16="http://schemas.microsoft.com/office/drawing/2014/main" val="971046385"/>
+                  </a:ext>
+                </a:extLst>
+              </a:tr>
+            </a:tbl>
+          </a:graphicData>
+        </a:graphic>
+      </p:graphicFrame>
+      <p:sp>
+        <p:nvSpPr>
+          <p:cNvPr id="5" name="Content Placeholder 2">
+            <a:extLst>
+              <a:ext uri="{FF2B5EF4-FFF2-40B4-BE49-F238E27FC236}">
+                <a16:creationId xmlns:a16="http://schemas.microsoft.com/office/drawing/2014/main" id="{5FD46B0C-AED5-0170-9290-B59A9BC46EAD}"/>
+              </a:ext>
+            </a:extLst>
+          </p:cNvPr>
+          <p:cNvSpPr txBox="1">
+            <a:spLocks/>
+          </p:cNvSpPr>
+          <p:nvPr/>
+        </p:nvSpPr>
+        <p:spPr>
+          <a:xfrm>
+            <a:off x="838200" y="1825625"/>
+            <a:ext cx="10515600" cy="4351338"/>
+          </a:xfrm>
+          <a:prstGeom prst="rect">
+            <a:avLst/>
+          </a:prstGeom>
+        </p:spPr>
+        <p:txBody>
+          <a:bodyPr vert="horz" lIns="91440" tIns="45720" rIns="91440" bIns="45720" rtlCol="0">
+            <a:normAutofit/>
+          </a:bodyPr>
+          <a:lstStyle>
+            <a:lvl1pPr marL="228600" indent="-228600" algn="l" defTabSz="914400" rtl="0" eaLnBrk="1" latinLnBrk="0" hangingPunct="1">
+              <a:lnSpc>
+                <a:spcPct val="90000"/>
+              </a:lnSpc>
+              <a:spcBef>
+                <a:spcPts val="1000"/>
+              </a:spcBef>
+              <a:buFont typeface="Arial" panose="020B0604020202020204" pitchFamily="34" charset="0"/>
+              <a:buChar char="•"/>
+              <a:defRPr sz="2800" kern="1200">
+                <a:solidFill>
+                  <a:schemeClr val="tx1"/>
+                </a:solidFill>
+                <a:latin typeface="+mn-lt"/>
+                <a:ea typeface="+mn-ea"/>
+                <a:cs typeface="+mn-cs"/>
+              </a:defRPr>
+            </a:lvl1pPr>
+            <a:lvl2pPr marL="685800" indent="-228600" algn="l" defTabSz="914400" rtl="0" eaLnBrk="1" latinLnBrk="0" hangingPunct="1">
+              <a:lnSpc>
+                <a:spcPct val="90000"/>
+              </a:lnSpc>
+              <a:spcBef>
+                <a:spcPts val="500"/>
+              </a:spcBef>
+              <a:buFont typeface="Arial" panose="020B0604020202020204" pitchFamily="34" charset="0"/>
+              <a:buChar char="•"/>
+              <a:defRPr sz="2400" kern="1200">
+                <a:solidFill>
+                  <a:schemeClr val="tx1"/>
+                </a:solidFill>
+                <a:latin typeface="+mn-lt"/>
+                <a:ea typeface="+mn-ea"/>
+                <a:cs typeface="+mn-cs"/>
+              </a:defRPr>
+            </a:lvl2pPr>
+            <a:lvl3pPr marL="1143000" indent="-228600" algn="l" defTabSz="914400" rtl="0" eaLnBrk="1" latinLnBrk="0" hangingPunct="1">
+              <a:lnSpc>
+                <a:spcPct val="90000"/>
+              </a:lnSpc>
+              <a:spcBef>
+                <a:spcPts val="500"/>
+              </a:spcBef>
+              <a:buFont typeface="Arial" panose="020B0604020202020204" pitchFamily="34" charset="0"/>
+              <a:buChar char="•"/>
+              <a:defRPr sz="2000" kern="1200">
+                <a:solidFill>
+                  <a:schemeClr val="tx1"/>
+                </a:solidFill>
+                <a:latin typeface="+mn-lt"/>
+                <a:ea typeface="+mn-ea"/>
+                <a:cs typeface="+mn-cs"/>
+              </a:defRPr>
+            </a:lvl3pPr>
+            <a:lvl4pPr marL="1600200" indent="-228600" algn="l" defTabSz="914400" rtl="0" eaLnBrk="1" latinLnBrk="0" hangingPunct="1">
+              <a:lnSpc>
+                <a:spcPct val="90000"/>
+              </a:lnSpc>
+              <a:spcBef>
+                <a:spcPts val="500"/>
+              </a:spcBef>
+              <a:buFont typeface="Arial" panose="020B0604020202020204" pitchFamily="34" charset="0"/>
+              <a:buChar char="•"/>
+              <a:defRPr sz="1800" kern="1200">
+                <a:solidFill>
+                  <a:schemeClr val="tx1"/>
+                </a:solidFill>
+                <a:latin typeface="+mn-lt"/>
+                <a:ea typeface="+mn-ea"/>
+                <a:cs typeface="+mn-cs"/>
+              </a:defRPr>
+            </a:lvl4pPr>
+            <a:lvl5pPr marL="2057400" indent="-228600" algn="l" defTabSz="914400" rtl="0" eaLnBrk="1" latinLnBrk="0" hangingPunct="1">
+              <a:lnSpc>
+                <a:spcPct val="90000"/>
+              </a:lnSpc>
+              <a:spcBef>
+                <a:spcPts val="500"/>
+              </a:spcBef>
+              <a:buFont typeface="Arial" panose="020B0604020202020204" pitchFamily="34" charset="0"/>
+              <a:buChar char="•"/>
+              <a:defRPr sz="1800" kern="1200">
+                <a:solidFill>
+                  <a:schemeClr val="tx1"/>
+                </a:solidFill>
+                <a:latin typeface="+mn-lt"/>
+                <a:ea typeface="+mn-ea"/>
+                <a:cs typeface="+mn-cs"/>
+              </a:defRPr>
+            </a:lvl5pPr>
+            <a:lvl6pPr marL="2514600" indent="-228600" algn="l" defTabSz="914400" rtl="0" eaLnBrk="1" latinLnBrk="0" hangingPunct="1">
+              <a:lnSpc>
+                <a:spcPct val="90000"/>
+              </a:lnSpc>
+              <a:spcBef>
+                <a:spcPts val="500"/>
+              </a:spcBef>
+              <a:buFont typeface="Arial" panose="020B0604020202020204" pitchFamily="34" charset="0"/>
+              <a:buChar char="•"/>
+              <a:defRPr sz="1800" kern="1200">
+                <a:solidFill>
+                  <a:schemeClr val="tx1"/>
+                </a:solidFill>
+                <a:latin typeface="+mn-lt"/>
+                <a:ea typeface="+mn-ea"/>
+                <a:cs typeface="+mn-cs"/>
+              </a:defRPr>
+            </a:lvl6pPr>
+            <a:lvl7pPr marL="2971800" indent="-228600" algn="l" defTabSz="914400" rtl="0" eaLnBrk="1" latinLnBrk="0" hangingPunct="1">
+              <a:lnSpc>
+                <a:spcPct val="90000"/>
+              </a:lnSpc>
+              <a:spcBef>
+                <a:spcPts val="500"/>
+              </a:spcBef>
+              <a:buFont typeface="Arial" panose="020B0604020202020204" pitchFamily="34" charset="0"/>
+              <a:buChar char="•"/>
+              <a:defRPr sz="1800" kern="1200">
+                <a:solidFill>
+                  <a:schemeClr val="tx1"/>
+                </a:solidFill>
+                <a:latin typeface="+mn-lt"/>
+                <a:ea typeface="+mn-ea"/>
+                <a:cs typeface="+mn-cs"/>
+              </a:defRPr>
+            </a:lvl7pPr>
+            <a:lvl8pPr marL="3429000" indent="-228600" algn="l" defTabSz="914400" rtl="0" eaLnBrk="1" latinLnBrk="0" hangingPunct="1">
+              <a:lnSpc>
+                <a:spcPct val="90000"/>
+              </a:lnSpc>
+              <a:spcBef>
+                <a:spcPts val="500"/>
+              </a:spcBef>
+              <a:buFont typeface="Arial" panose="020B0604020202020204" pitchFamily="34" charset="0"/>
+              <a:buChar char="•"/>
+              <a:defRPr sz="1800" kern="1200">
+                <a:solidFill>
+                  <a:schemeClr val="tx1"/>
+                </a:solidFill>
+                <a:latin typeface="+mn-lt"/>
+                <a:ea typeface="+mn-ea"/>
+                <a:cs typeface="+mn-cs"/>
+              </a:defRPr>
+            </a:lvl8pPr>
+            <a:lvl9pPr marL="3886200" indent="-228600" algn="l" defTabSz="914400" rtl="0" eaLnBrk="1" latinLnBrk="0" hangingPunct="1">
+              <a:lnSpc>
+                <a:spcPct val="90000"/>
+              </a:lnSpc>
+              <a:spcBef>
+                <a:spcPts val="500"/>
+              </a:spcBef>
+              <a:buFont typeface="Arial" panose="020B0604020202020204" pitchFamily="34" charset="0"/>
+              <a:buChar char="•"/>
+              <a:defRPr sz="1800" kern="1200">
+                <a:solidFill>
+                  <a:schemeClr val="tx1"/>
+                </a:solidFill>
+                <a:latin typeface="+mn-lt"/>
+                <a:ea typeface="+mn-ea"/>
+                <a:cs typeface="+mn-cs"/>
+              </a:defRPr>
+            </a:lvl9pPr>
+          </a:lstStyle>
+          <a:p>
+            <a:pPr marL="0" indent="0">
+              <a:buNone/>
+            </a:pPr>
+            <a:r>
+              <a:rPr lang="en-US" dirty="0"/>
+              <a:t>Both versions stop expanding when append can no longer safely write.</a:t>
+            </a:r>
+          </a:p>
+          <a:p>
+            <a:pPr marL="0" indent="0">
+              <a:buNone/>
+            </a:pPr>
+            <a:r>
+              <a:rPr lang="en-US" dirty="0"/>
+              <a:t>Difference:</a:t>
+            </a:r>
+          </a:p>
+          <a:p>
+            <a:pPr lvl="1"/>
+            <a:r>
+              <a:rPr lang="en-US" dirty="0"/>
+              <a:t>G2-AIMD: overflow is set early, after a threshold, e.g. 90%.</a:t>
+            </a:r>
+          </a:p>
+          <a:p>
+            <a:pPr lvl="1"/>
+            <a:r>
+              <a:rPr lang="en-US" dirty="0"/>
+              <a:t>G2-AIMD OOM-Fixed: overflow is set only when append returns an invalid write location.</a:t>
+            </a:r>
+          </a:p>
+          <a:p>
+            <a:pPr marL="0" indent="0">
+              <a:buNone/>
+            </a:pPr>
+            <a:r>
+              <a:rPr lang="en-US" dirty="0"/>
+              <a:t>So OOM-Fixed may avoid premature failed iterations, making it faster.</a:t>
+            </a:r>
+          </a:p>
+        </p:txBody>
+      </p:sp>
+    </p:spTree>
+    <p:extLst>
+      <p:ext uri="{BB962C8B-B14F-4D97-AF65-F5344CB8AC3E}">
+        <p14:creationId xmlns:p14="http://schemas.microsoft.com/office/powerpoint/2010/main" val="2060020708"/>
+      </p:ext>
+    </p:extLst>
+  </p:cSld>
+  <p:clrMapOvr>
+    <a:masterClrMapping/>
+  </p:clrMapOvr>
+</p:sld>
+</file>
+
+<file path=ppt/slides/slide31.xml><?xml version="1.0" encoding="utf-8"?>
+<p:sld xmlns:a="http://schemas.openxmlformats.org/drawingml/2006/main" xmlns:r="http://schemas.openxmlformats.org/officeDocument/2006/relationships" xmlns:p="http://schemas.openxmlformats.org/presentationml/2006/main">
+  <p:cSld>
+    <p:spTree>
+      <p:nvGrpSpPr>
+        <p:cNvPr id="1" name=""/>
+        <p:cNvGrpSpPr/>
+        <p:nvPr/>
+      </p:nvGrpSpPr>
+      <p:grpSpPr>
+        <a:xfrm>
+          <a:off x="0" y="0"/>
+          <a:ext cx="0" cy="0"/>
+          <a:chOff x="0" y="0"/>
+          <a:chExt cx="0" cy="0"/>
+        </a:xfrm>
+      </p:grpSpPr>
+      <p:sp>
+        <p:nvSpPr>
+          <p:cNvPr id="2" name="Title 1">
+            <a:extLst>
+              <a:ext uri="{FF2B5EF4-FFF2-40B4-BE49-F238E27FC236}">
                 <a16:creationId xmlns:a16="http://schemas.microsoft.com/office/drawing/2014/main" id="{DF9C7201-1C1B-1754-0B8F-E07786E708BB}"/>
               </a:ext>
             </a:extLst>
@@ -11345,8 +11944,8 @@
         </p:nvSpPr>
         <p:spPr>
           <a:xfrm>
-            <a:off x="4214811" y="6123543"/>
-            <a:ext cx="6807376" cy="369332"/>
+            <a:off x="7708261" y="427741"/>
+            <a:ext cx="4285265" cy="1200329"/>
           </a:xfrm>
           <a:prstGeom prst="rect">
             <a:avLst/>
@@ -11354,32 +11953,29 @@
           <a:noFill/>
         </p:spPr>
         <p:txBody>
-          <a:bodyPr wrap="none" rtlCol="0">
+          <a:bodyPr wrap="square" rtlCol="0">
             <a:spAutoFit/>
           </a:bodyPr>
           <a:lstStyle/>
           <a:p>
             <a:r>
-              <a:rPr lang="en-US" dirty="0">
+              <a:rPr lang="en-US" b="1" dirty="0">
                 <a:solidFill>
                   <a:srgbClr val="C00000"/>
                 </a:solidFill>
               </a:rPr>
-              <a:t>This may explain why some instances in MQC are slower e.g. </a:t>
-            </a:r>
-            <a:r>
-              <a:rPr lang="en-US" dirty="0" err="1">
+              <a:t>Not a valid statement!!</a:t>
+            </a:r>
+          </a:p>
+          <a:p>
+            <a:r>
+              <a:rPr lang="en-US" b="1" dirty="0">
                 <a:solidFill>
                   <a:srgbClr val="C00000"/>
                 </a:solidFill>
               </a:rPr>
-              <a:t>Flixter</a:t>
-            </a:r>
-            <a:endParaRPr lang="en-US" dirty="0">
-              <a:solidFill>
-                <a:srgbClr val="C00000"/>
-              </a:solidFill>
-            </a:endParaRPr>
+              <a:t>Checked with a simplified system where only device buffer is used and there was no overflow for dataset</a:t>
+            </a:r>
           </a:p>
         </p:txBody>
       </p:sp>
@@ -11396,7 +11992,7 @@
 </p:sld>
 </file>
 
-<file path=ppt/slides/slide31.xml><?xml version="1.0" encoding="utf-8"?>
+<file path=ppt/slides/slide32.xml><?xml version="1.0" encoding="utf-8"?>
 <p:sld xmlns:a="http://schemas.openxmlformats.org/drawingml/2006/main" xmlns:r="http://schemas.openxmlformats.org/officeDocument/2006/relationships" xmlns:p="http://schemas.openxmlformats.org/presentationml/2006/main">
   <p:cSld>
     <p:spTree>
@@ -11559,7 +12155,7 @@
 </p:sld>
 </file>
 
-<file path=ppt/slides/slide32.xml><?xml version="1.0" encoding="utf-8"?>
+<file path=ppt/slides/slide33.xml><?xml version="1.0" encoding="utf-8"?>
 <p:sld xmlns:a="http://schemas.openxmlformats.org/drawingml/2006/main" xmlns:r="http://schemas.openxmlformats.org/officeDocument/2006/relationships" xmlns:p="http://schemas.openxmlformats.org/presentationml/2006/main">
   <p:cSld>
     <p:spTree>
@@ -12208,6 +12804,243 @@
     <p:extLst>
       <p:ext uri="{BB962C8B-B14F-4D97-AF65-F5344CB8AC3E}">
         <p14:creationId xmlns:p14="http://schemas.microsoft.com/office/powerpoint/2010/main" val="397359735"/>
+      </p:ext>
+    </p:extLst>
+  </p:cSld>
+  <p:clrMapOvr>
+    <a:masterClrMapping/>
+  </p:clrMapOvr>
+</p:sld>
+</file>
+
+<file path=ppt/slides/slide34.xml><?xml version="1.0" encoding="utf-8"?>
+<p:sld xmlns:a="http://schemas.openxmlformats.org/drawingml/2006/main" xmlns:r="http://schemas.openxmlformats.org/officeDocument/2006/relationships" xmlns:p="http://schemas.openxmlformats.org/presentationml/2006/main">
+  <p:cSld>
+    <p:spTree>
+      <p:nvGrpSpPr>
+        <p:cNvPr id="1" name=""/>
+        <p:cNvGrpSpPr/>
+        <p:nvPr/>
+      </p:nvGrpSpPr>
+      <p:grpSpPr>
+        <a:xfrm>
+          <a:off x="0" y="0"/>
+          <a:ext cx="0" cy="0"/>
+          <a:chOff x="0" y="0"/>
+          <a:chExt cx="0" cy="0"/>
+        </a:xfrm>
+      </p:grpSpPr>
+      <p:pic>
+        <p:nvPicPr>
+          <p:cNvPr id="5" name="Content Placeholder 4">
+            <a:extLst>
+              <a:ext uri="{FF2B5EF4-FFF2-40B4-BE49-F238E27FC236}">
+                <a16:creationId xmlns:a16="http://schemas.microsoft.com/office/drawing/2014/main" id="{F173191C-CD36-9DA7-DEA9-6F6448AA8931}"/>
+              </a:ext>
+            </a:extLst>
+          </p:cNvPr>
+          <p:cNvPicPr>
+            <a:picLocks noGrp="1" noChangeAspect="1"/>
+          </p:cNvPicPr>
+          <p:nvPr>
+            <p:ph idx="1"/>
+          </p:nvPr>
+        </p:nvPicPr>
+        <p:blipFill>
+          <a:blip r:embed="rId2"/>
+          <a:stretch>
+            <a:fillRect/>
+          </a:stretch>
+        </p:blipFill>
+        <p:spPr>
+          <a:xfrm>
+            <a:off x="3424150" y="362857"/>
+            <a:ext cx="8597307" cy="5882369"/>
+          </a:xfrm>
+          <a:prstGeom prst="rect">
+            <a:avLst/>
+          </a:prstGeom>
+        </p:spPr>
+      </p:pic>
+      <p:sp>
+        <p:nvSpPr>
+          <p:cNvPr id="6" name="TextBox 5">
+            <a:extLst>
+              <a:ext uri="{FF2B5EF4-FFF2-40B4-BE49-F238E27FC236}">
+                <a16:creationId xmlns:a16="http://schemas.microsoft.com/office/drawing/2014/main" id="{2B16930B-40FA-AC1C-60D8-3E3E52F28092}"/>
+              </a:ext>
+            </a:extLst>
+          </p:cNvPr>
+          <p:cNvSpPr txBox="1"/>
+          <p:nvPr/>
+        </p:nvSpPr>
+        <p:spPr>
+          <a:xfrm>
+            <a:off x="170543" y="1701209"/>
+            <a:ext cx="3551274" cy="923330"/>
+          </a:xfrm>
+          <a:prstGeom prst="rect">
+            <a:avLst/>
+          </a:prstGeom>
+          <a:noFill/>
+        </p:spPr>
+        <p:txBody>
+          <a:bodyPr wrap="square" rtlCol="0">
+            <a:spAutoFit/>
+          </a:bodyPr>
+          <a:lstStyle/>
+          <a:p>
+            <a:r>
+              <a:rPr lang="en-US" dirty="0"/>
+              <a:t>now, the warps are not reading directly from host, rather this is copied in bulk. </a:t>
+            </a:r>
+          </a:p>
+        </p:txBody>
+      </p:sp>
+    </p:spTree>
+    <p:extLst>
+      <p:ext uri="{BB962C8B-B14F-4D97-AF65-F5344CB8AC3E}">
+        <p14:creationId xmlns:p14="http://schemas.microsoft.com/office/powerpoint/2010/main" val="891164997"/>
+      </p:ext>
+    </p:extLst>
+  </p:cSld>
+  <p:clrMapOvr>
+    <a:masterClrMapping/>
+  </p:clrMapOvr>
+</p:sld>
+</file>
+
+<file path=ppt/slides/slide35.xml><?xml version="1.0" encoding="utf-8"?>
+<p:sld xmlns:a="http://schemas.openxmlformats.org/drawingml/2006/main" xmlns:r="http://schemas.openxmlformats.org/officeDocument/2006/relationships" xmlns:p="http://schemas.openxmlformats.org/presentationml/2006/main">
+  <p:cSld>
+    <p:spTree>
+      <p:nvGrpSpPr>
+        <p:cNvPr id="1" name="">
+          <a:extLst>
+            <a:ext uri="{FF2B5EF4-FFF2-40B4-BE49-F238E27FC236}">
+              <a16:creationId xmlns:a16="http://schemas.microsoft.com/office/drawing/2014/main" id="{40033E2C-E62C-544D-DAD5-404923F4500F}"/>
+            </a:ext>
+          </a:extLst>
+        </p:cNvPr>
+        <p:cNvGrpSpPr/>
+        <p:nvPr/>
+      </p:nvGrpSpPr>
+      <p:grpSpPr>
+        <a:xfrm>
+          <a:off x="0" y="0"/>
+          <a:ext cx="0" cy="0"/>
+          <a:chOff x="0" y="0"/>
+          <a:chExt cx="0" cy="0"/>
+        </a:xfrm>
+      </p:grpSpPr>
+      <p:pic>
+        <p:nvPicPr>
+          <p:cNvPr id="5" name="Content Placeholder 4">
+            <a:extLst>
+              <a:ext uri="{FF2B5EF4-FFF2-40B4-BE49-F238E27FC236}">
+                <a16:creationId xmlns:a16="http://schemas.microsoft.com/office/drawing/2014/main" id="{44DD87C4-9A76-620F-5174-93F69A0EBFCE}"/>
+              </a:ext>
+            </a:extLst>
+          </p:cNvPr>
+          <p:cNvPicPr>
+            <a:picLocks noGrp="1" noChangeAspect="1"/>
+          </p:cNvPicPr>
+          <p:nvPr>
+            <p:ph idx="1"/>
+          </p:nvPr>
+        </p:nvPicPr>
+        <p:blipFill>
+          <a:blip r:embed="rId2"/>
+          <a:srcRect l="39694" b="14708"/>
+          <a:stretch>
+            <a:fillRect/>
+          </a:stretch>
+        </p:blipFill>
+        <p:spPr>
+          <a:xfrm>
+            <a:off x="574159" y="532978"/>
+            <a:ext cx="5184722" cy="5017217"/>
+          </a:xfrm>
+          <a:prstGeom prst="rect">
+            <a:avLst/>
+          </a:prstGeom>
+        </p:spPr>
+      </p:pic>
+      <p:sp>
+        <p:nvSpPr>
+          <p:cNvPr id="6" name="TextBox 5">
+            <a:extLst>
+              <a:ext uri="{FF2B5EF4-FFF2-40B4-BE49-F238E27FC236}">
+                <a16:creationId xmlns:a16="http://schemas.microsoft.com/office/drawing/2014/main" id="{A1155FC0-06CE-0A69-D19B-D6E8A6BAAC54}"/>
+              </a:ext>
+            </a:extLst>
+          </p:cNvPr>
+          <p:cNvSpPr txBox="1"/>
+          <p:nvPr/>
+        </p:nvSpPr>
+        <p:spPr>
+          <a:xfrm>
+            <a:off x="6177939" y="1212112"/>
+            <a:ext cx="4773596" cy="3693319"/>
+          </a:xfrm>
+          <a:prstGeom prst="rect">
+            <a:avLst/>
+          </a:prstGeom>
+          <a:noFill/>
+        </p:spPr>
+        <p:txBody>
+          <a:bodyPr wrap="square" rtlCol="0">
+            <a:spAutoFit/>
+          </a:bodyPr>
+          <a:lstStyle/>
+          <a:p>
+            <a:r>
+              <a:rPr lang="en-US" dirty="0"/>
+              <a:t>Previously, it was [start, mid, end) because mid was used in SM app to store prefix information.</a:t>
+            </a:r>
+          </a:p>
+          <a:p>
+            <a:endParaRPr lang="en-US" dirty="0"/>
+          </a:p>
+          <a:p>
+            <a:endParaRPr lang="en-US" dirty="0"/>
+          </a:p>
+          <a:p>
+            <a:r>
+              <a:rPr lang="en-US" dirty="0"/>
+              <a:t>Now the offsets are truly [start, end). </a:t>
+            </a:r>
+          </a:p>
+          <a:p>
+            <a:r>
+              <a:rPr lang="en-US" dirty="0"/>
+              <a:t>The mid is moved to subgraph. The first element of subgraph is the mid point, e.g.:</a:t>
+            </a:r>
+          </a:p>
+          <a:p>
+            <a:endParaRPr lang="en-US" dirty="0"/>
+          </a:p>
+          <a:p>
+            <a:r>
+              <a:rPr lang="en-US" dirty="0"/>
+              <a:t>[2, s1, s2, c1, c2, c3, … ]   </a:t>
+            </a:r>
+          </a:p>
+          <a:p>
+            <a:endParaRPr lang="en-US" dirty="0"/>
+          </a:p>
+          <a:p>
+            <a:r>
+              <a:rPr lang="en-US" dirty="0"/>
+              <a:t>indicates 2 elements (s1, s2) are the partial match, and remaining are the candidates</a:t>
+            </a:r>
+          </a:p>
+        </p:txBody>
+      </p:sp>
+    </p:spTree>
+    <p:extLst>
+      <p:ext uri="{BB962C8B-B14F-4D97-AF65-F5344CB8AC3E}">
+        <p14:creationId xmlns:p14="http://schemas.microsoft.com/office/powerpoint/2010/main" val="2546531410"/>
       </p:ext>
     </p:extLst>
   </p:cSld>

</xml_diff>

<commit_message>
auto commit 2026-08-20 15:06:29
</commit_message>
<xml_diff>
--- a/revision.pptx
+++ b/revision.pptx
@@ -40,6 +40,7 @@
     <p:sldId id="279" r:id="rId34"/>
     <p:sldId id="293" r:id="rId35"/>
     <p:sldId id="294" r:id="rId36"/>
+    <p:sldId id="298" r:id="rId37"/>
   </p:sldIdLst>
   <p:sldSz cx="12192000" cy="6858000"/>
   <p:notesSz cx="6858000" cy="9144000"/>
@@ -293,7 +294,7 @@
           <a:p>
             <a:fld id="{6F584DAC-AA37-8C49-B5B6-53E9519E19BB}" type="datetimeFigureOut">
               <a:rPr lang="en-US" smtClean="0"/>
-              <a:t>8/8/26</a:t>
+              <a:t>8/14/26</a:t>
             </a:fld>
             <a:endParaRPr lang="en-US"/>
           </a:p>
@@ -491,7 +492,7 @@
           <a:p>
             <a:fld id="{6F584DAC-AA37-8C49-B5B6-53E9519E19BB}" type="datetimeFigureOut">
               <a:rPr lang="en-US" smtClean="0"/>
-              <a:t>8/8/26</a:t>
+              <a:t>8/14/26</a:t>
             </a:fld>
             <a:endParaRPr lang="en-US"/>
           </a:p>
@@ -699,7 +700,7 @@
           <a:p>
             <a:fld id="{6F584DAC-AA37-8C49-B5B6-53E9519E19BB}" type="datetimeFigureOut">
               <a:rPr lang="en-US" smtClean="0"/>
-              <a:t>8/8/26</a:t>
+              <a:t>8/14/26</a:t>
             </a:fld>
             <a:endParaRPr lang="en-US"/>
           </a:p>
@@ -897,7 +898,7 @@
           <a:p>
             <a:fld id="{6F584DAC-AA37-8C49-B5B6-53E9519E19BB}" type="datetimeFigureOut">
               <a:rPr lang="en-US" smtClean="0"/>
-              <a:t>8/8/26</a:t>
+              <a:t>8/14/26</a:t>
             </a:fld>
             <a:endParaRPr lang="en-US"/>
           </a:p>
@@ -1172,7 +1173,7 @@
           <a:p>
             <a:fld id="{6F584DAC-AA37-8C49-B5B6-53E9519E19BB}" type="datetimeFigureOut">
               <a:rPr lang="en-US" smtClean="0"/>
-              <a:t>8/8/26</a:t>
+              <a:t>8/14/26</a:t>
             </a:fld>
             <a:endParaRPr lang="en-US"/>
           </a:p>
@@ -1437,7 +1438,7 @@
           <a:p>
             <a:fld id="{6F584DAC-AA37-8C49-B5B6-53E9519E19BB}" type="datetimeFigureOut">
               <a:rPr lang="en-US" smtClean="0"/>
-              <a:t>8/8/26</a:t>
+              <a:t>8/14/26</a:t>
             </a:fld>
             <a:endParaRPr lang="en-US"/>
           </a:p>
@@ -1849,7 +1850,7 @@
           <a:p>
             <a:fld id="{6F584DAC-AA37-8C49-B5B6-53E9519E19BB}" type="datetimeFigureOut">
               <a:rPr lang="en-US" smtClean="0"/>
-              <a:t>8/8/26</a:t>
+              <a:t>8/14/26</a:t>
             </a:fld>
             <a:endParaRPr lang="en-US"/>
           </a:p>
@@ -1990,7 +1991,7 @@
           <a:p>
             <a:fld id="{6F584DAC-AA37-8C49-B5B6-53E9519E19BB}" type="datetimeFigureOut">
               <a:rPr lang="en-US" smtClean="0"/>
-              <a:t>8/8/26</a:t>
+              <a:t>8/14/26</a:t>
             </a:fld>
             <a:endParaRPr lang="en-US"/>
           </a:p>
@@ -2103,7 +2104,7 @@
           <a:p>
             <a:fld id="{6F584DAC-AA37-8C49-B5B6-53E9519E19BB}" type="datetimeFigureOut">
               <a:rPr lang="en-US" smtClean="0"/>
-              <a:t>8/8/26</a:t>
+              <a:t>8/14/26</a:t>
             </a:fld>
             <a:endParaRPr lang="en-US"/>
           </a:p>
@@ -2414,7 +2415,7 @@
           <a:p>
             <a:fld id="{6F584DAC-AA37-8C49-B5B6-53E9519E19BB}" type="datetimeFigureOut">
               <a:rPr lang="en-US" smtClean="0"/>
-              <a:t>8/8/26</a:t>
+              <a:t>8/14/26</a:t>
             </a:fld>
             <a:endParaRPr lang="en-US"/>
           </a:p>
@@ -2702,7 +2703,7 @@
           <a:p>
             <a:fld id="{6F584DAC-AA37-8C49-B5B6-53E9519E19BB}" type="datetimeFigureOut">
               <a:rPr lang="en-US" smtClean="0"/>
-              <a:t>8/8/26</a:t>
+              <a:t>8/14/26</a:t>
             </a:fld>
             <a:endParaRPr lang="en-US"/>
           </a:p>
@@ -2943,7 +2944,7 @@
           <a:p>
             <a:fld id="{6F584DAC-AA37-8C49-B5B6-53E9519E19BB}" type="datetimeFigureOut">
               <a:rPr lang="en-US" smtClean="0"/>
-              <a:t>8/8/26</a:t>
+              <a:t>8/14/26</a:t>
             </a:fld>
             <a:endParaRPr lang="en-US"/>
           </a:p>
@@ -12830,38 +12831,6 @@
           <a:chExt cx="0" cy="0"/>
         </a:xfrm>
       </p:grpSpPr>
-      <p:pic>
-        <p:nvPicPr>
-          <p:cNvPr id="5" name="Content Placeholder 4">
-            <a:extLst>
-              <a:ext uri="{FF2B5EF4-FFF2-40B4-BE49-F238E27FC236}">
-                <a16:creationId xmlns:a16="http://schemas.microsoft.com/office/drawing/2014/main" id="{F173191C-CD36-9DA7-DEA9-6F6448AA8931}"/>
-              </a:ext>
-            </a:extLst>
-          </p:cNvPr>
-          <p:cNvPicPr>
-            <a:picLocks noGrp="1" noChangeAspect="1"/>
-          </p:cNvPicPr>
-          <p:nvPr>
-            <p:ph idx="1"/>
-          </p:nvPr>
-        </p:nvPicPr>
-        <p:blipFill>
-          <a:blip r:embed="rId2"/>
-          <a:stretch>
-            <a:fillRect/>
-          </a:stretch>
-        </p:blipFill>
-        <p:spPr>
-          <a:xfrm>
-            <a:off x="3424150" y="362857"/>
-            <a:ext cx="8597307" cy="5882369"/>
-          </a:xfrm>
-          <a:prstGeom prst="rect">
-            <a:avLst/>
-          </a:prstGeom>
-        </p:spPr>
-      </p:pic>
       <p:sp>
         <p:nvSpPr>
           <p:cNvPr id="6" name="TextBox 5">
@@ -12894,6 +12863,138 @@
               <a:rPr lang="en-US" dirty="0"/>
               <a:t>now, the warps are not reading directly from host, rather this is copied in bulk. </a:t>
             </a:r>
+          </a:p>
+        </p:txBody>
+      </p:sp>
+      <p:pic>
+        <p:nvPicPr>
+          <p:cNvPr id="3" name="Picture 2">
+            <a:extLst>
+              <a:ext uri="{FF2B5EF4-FFF2-40B4-BE49-F238E27FC236}">
+                <a16:creationId xmlns:a16="http://schemas.microsoft.com/office/drawing/2014/main" id="{4620263E-4E94-789C-36F3-9EF57605F190}"/>
+              </a:ext>
+            </a:extLst>
+          </p:cNvPr>
+          <p:cNvPicPr>
+            <a:picLocks noChangeAspect="1"/>
+          </p:cNvPicPr>
+          <p:nvPr/>
+        </p:nvPicPr>
+        <p:blipFill>
+          <a:blip r:embed="rId2"/>
+          <a:stretch>
+            <a:fillRect/>
+          </a:stretch>
+        </p:blipFill>
+        <p:spPr>
+          <a:xfrm>
+            <a:off x="5328122" y="-60960"/>
+            <a:ext cx="6464808" cy="6858000"/>
+          </a:xfrm>
+          <a:prstGeom prst="rect">
+            <a:avLst/>
+          </a:prstGeom>
+        </p:spPr>
+      </p:pic>
+      <p:sp>
+        <p:nvSpPr>
+          <p:cNvPr id="8" name="Cross 7">
+            <a:extLst>
+              <a:ext uri="{FF2B5EF4-FFF2-40B4-BE49-F238E27FC236}">
+                <a16:creationId xmlns:a16="http://schemas.microsoft.com/office/drawing/2014/main" id="{E3DAC028-3F4B-2201-A02B-2A35ACC1D474}"/>
+              </a:ext>
+            </a:extLst>
+          </p:cNvPr>
+          <p:cNvSpPr/>
+          <p:nvPr/>
+        </p:nvSpPr>
+        <p:spPr>
+          <a:xfrm rot="2703491">
+            <a:off x="6810104" y="3560663"/>
+            <a:ext cx="635725" cy="635726"/>
+          </a:xfrm>
+          <a:prstGeom prst="plus">
+            <a:avLst>
+              <a:gd name="adj" fmla="val 40069"/>
+            </a:avLst>
+          </a:prstGeom>
+          <a:solidFill>
+            <a:srgbClr val="C00000"/>
+          </a:solidFill>
+        </p:spPr>
+        <p:style>
+          <a:lnRef idx="2">
+            <a:schemeClr val="accent1">
+              <a:shade val="15000"/>
+            </a:schemeClr>
+          </a:lnRef>
+          <a:fillRef idx="1">
+            <a:schemeClr val="accent1"/>
+          </a:fillRef>
+          <a:effectRef idx="0">
+            <a:schemeClr val="accent1"/>
+          </a:effectRef>
+          <a:fontRef idx="minor">
+            <a:schemeClr val="lt1"/>
+          </a:fontRef>
+        </p:style>
+        <p:txBody>
+          <a:bodyPr rtlCol="0" anchor="ctr"/>
+          <a:lstStyle/>
+          <a:p>
+            <a:pPr algn="ctr"/>
+            <a:endParaRPr lang="en-US"/>
+          </a:p>
+        </p:txBody>
+      </p:sp>
+      <p:sp>
+        <p:nvSpPr>
+          <p:cNvPr id="9" name="Cross 8">
+            <a:extLst>
+              <a:ext uri="{FF2B5EF4-FFF2-40B4-BE49-F238E27FC236}">
+                <a16:creationId xmlns:a16="http://schemas.microsoft.com/office/drawing/2014/main" id="{0CB1D70A-3D66-DFA0-6A01-A6FDAE079F23}"/>
+              </a:ext>
+            </a:extLst>
+          </p:cNvPr>
+          <p:cNvSpPr/>
+          <p:nvPr/>
+        </p:nvSpPr>
+        <p:spPr>
+          <a:xfrm rot="2703491">
+            <a:off x="9261567" y="5402526"/>
+            <a:ext cx="635725" cy="635726"/>
+          </a:xfrm>
+          <a:prstGeom prst="plus">
+            <a:avLst>
+              <a:gd name="adj" fmla="val 40069"/>
+            </a:avLst>
+          </a:prstGeom>
+          <a:solidFill>
+            <a:srgbClr val="C00000"/>
+          </a:solidFill>
+        </p:spPr>
+        <p:style>
+          <a:lnRef idx="2">
+            <a:schemeClr val="accent1">
+              <a:shade val="15000"/>
+            </a:schemeClr>
+          </a:lnRef>
+          <a:fillRef idx="1">
+            <a:schemeClr val="accent1"/>
+          </a:fillRef>
+          <a:effectRef idx="0">
+            <a:schemeClr val="accent1"/>
+          </a:effectRef>
+          <a:fontRef idx="minor">
+            <a:schemeClr val="lt1"/>
+          </a:fontRef>
+        </p:style>
+        <p:txBody>
+          <a:bodyPr rtlCol="0" anchor="ctr"/>
+          <a:lstStyle/>
+          <a:p>
+            <a:pPr algn="ctr"/>
+            <a:endParaRPr lang="en-US"/>
           </a:p>
         </p:txBody>
       </p:sp>
@@ -12933,39 +13034,6 @@
           <a:chExt cx="0" cy="0"/>
         </a:xfrm>
       </p:grpSpPr>
-      <p:pic>
-        <p:nvPicPr>
-          <p:cNvPr id="5" name="Content Placeholder 4">
-            <a:extLst>
-              <a:ext uri="{FF2B5EF4-FFF2-40B4-BE49-F238E27FC236}">
-                <a16:creationId xmlns:a16="http://schemas.microsoft.com/office/drawing/2014/main" id="{44DD87C4-9A76-620F-5174-93F69A0EBFCE}"/>
-              </a:ext>
-            </a:extLst>
-          </p:cNvPr>
-          <p:cNvPicPr>
-            <a:picLocks noGrp="1" noChangeAspect="1"/>
-          </p:cNvPicPr>
-          <p:nvPr>
-            <p:ph idx="1"/>
-          </p:nvPr>
-        </p:nvPicPr>
-        <p:blipFill>
-          <a:blip r:embed="rId2"/>
-          <a:srcRect l="39694" b="14708"/>
-          <a:stretch>
-            <a:fillRect/>
-          </a:stretch>
-        </p:blipFill>
-        <p:spPr>
-          <a:xfrm>
-            <a:off x="574159" y="532978"/>
-            <a:ext cx="5184722" cy="5017217"/>
-          </a:xfrm>
-          <a:prstGeom prst="rect">
-            <a:avLst/>
-          </a:prstGeom>
-        </p:spPr>
-      </p:pic>
       <p:sp>
         <p:nvSpPr>
           <p:cNvPr id="6" name="TextBox 5">
@@ -12980,7 +13048,7 @@
         </p:nvSpPr>
         <p:spPr>
           <a:xfrm>
-            <a:off x="6177939" y="1212112"/>
+            <a:off x="7418404" y="1313712"/>
             <a:ext cx="4773596" cy="3693319"/>
           </a:xfrm>
           <a:prstGeom prst="rect">
@@ -13037,10 +13105,584 @@
           </a:p>
         </p:txBody>
       </p:sp>
+      <p:pic>
+        <p:nvPicPr>
+          <p:cNvPr id="4" name="Picture 3">
+            <a:extLst>
+              <a:ext uri="{FF2B5EF4-FFF2-40B4-BE49-F238E27FC236}">
+                <a16:creationId xmlns:a16="http://schemas.microsoft.com/office/drawing/2014/main" id="{07E94065-4C0F-E50A-B72E-C3A7C8BB97FA}"/>
+              </a:ext>
+            </a:extLst>
+          </p:cNvPr>
+          <p:cNvPicPr>
+            <a:picLocks noChangeAspect="1"/>
+          </p:cNvPicPr>
+          <p:nvPr/>
+        </p:nvPicPr>
+        <p:blipFill>
+          <a:blip r:embed="rId2"/>
+          <a:stretch>
+            <a:fillRect/>
+          </a:stretch>
+        </p:blipFill>
+        <p:spPr>
+          <a:xfrm>
+            <a:off x="677745" y="-139337"/>
+            <a:ext cx="6464808" cy="6858000"/>
+          </a:xfrm>
+          <a:prstGeom prst="rect">
+            <a:avLst/>
+          </a:prstGeom>
+        </p:spPr>
+      </p:pic>
+      <p:sp>
+        <p:nvSpPr>
+          <p:cNvPr id="7" name="Cross 6">
+            <a:extLst>
+              <a:ext uri="{FF2B5EF4-FFF2-40B4-BE49-F238E27FC236}">
+                <a16:creationId xmlns:a16="http://schemas.microsoft.com/office/drawing/2014/main" id="{45D8CFE2-0A6E-B812-BE90-90B3FD44E966}"/>
+              </a:ext>
+            </a:extLst>
+          </p:cNvPr>
+          <p:cNvSpPr/>
+          <p:nvPr/>
+        </p:nvSpPr>
+        <p:spPr>
+          <a:xfrm rot="2703491">
+            <a:off x="2159727" y="3482286"/>
+            <a:ext cx="635725" cy="635726"/>
+          </a:xfrm>
+          <a:prstGeom prst="plus">
+            <a:avLst>
+              <a:gd name="adj" fmla="val 40069"/>
+            </a:avLst>
+          </a:prstGeom>
+          <a:solidFill>
+            <a:srgbClr val="C00000"/>
+          </a:solidFill>
+        </p:spPr>
+        <p:style>
+          <a:lnRef idx="2">
+            <a:schemeClr val="accent1">
+              <a:shade val="15000"/>
+            </a:schemeClr>
+          </a:lnRef>
+          <a:fillRef idx="1">
+            <a:schemeClr val="accent1"/>
+          </a:fillRef>
+          <a:effectRef idx="0">
+            <a:schemeClr val="accent1"/>
+          </a:effectRef>
+          <a:fontRef idx="minor">
+            <a:schemeClr val="lt1"/>
+          </a:fontRef>
+        </p:style>
+        <p:txBody>
+          <a:bodyPr rtlCol="0" anchor="ctr"/>
+          <a:lstStyle/>
+          <a:p>
+            <a:pPr algn="ctr"/>
+            <a:endParaRPr lang="en-US"/>
+          </a:p>
+        </p:txBody>
+      </p:sp>
+      <p:sp>
+        <p:nvSpPr>
+          <p:cNvPr id="8" name="Cross 7">
+            <a:extLst>
+              <a:ext uri="{FF2B5EF4-FFF2-40B4-BE49-F238E27FC236}">
+                <a16:creationId xmlns:a16="http://schemas.microsoft.com/office/drawing/2014/main" id="{10BBB2EB-BFE8-D1DC-28A3-73FC310C1949}"/>
+              </a:ext>
+            </a:extLst>
+          </p:cNvPr>
+          <p:cNvSpPr/>
+          <p:nvPr/>
+        </p:nvSpPr>
+        <p:spPr>
+          <a:xfrm rot="2703491">
+            <a:off x="4611190" y="5324149"/>
+            <a:ext cx="635725" cy="635726"/>
+          </a:xfrm>
+          <a:prstGeom prst="plus">
+            <a:avLst>
+              <a:gd name="adj" fmla="val 40069"/>
+            </a:avLst>
+          </a:prstGeom>
+          <a:solidFill>
+            <a:srgbClr val="C00000"/>
+          </a:solidFill>
+        </p:spPr>
+        <p:style>
+          <a:lnRef idx="2">
+            <a:schemeClr val="accent1">
+              <a:shade val="15000"/>
+            </a:schemeClr>
+          </a:lnRef>
+          <a:fillRef idx="1">
+            <a:schemeClr val="accent1"/>
+          </a:fillRef>
+          <a:effectRef idx="0">
+            <a:schemeClr val="accent1"/>
+          </a:effectRef>
+          <a:fontRef idx="minor">
+            <a:schemeClr val="lt1"/>
+          </a:fontRef>
+        </p:style>
+        <p:txBody>
+          <a:bodyPr rtlCol="0" anchor="ctr"/>
+          <a:lstStyle/>
+          <a:p>
+            <a:pPr algn="ctr"/>
+            <a:endParaRPr lang="en-US"/>
+          </a:p>
+        </p:txBody>
+      </p:sp>
+      <p:cxnSp>
+        <p:nvCxnSpPr>
+          <p:cNvPr id="10" name="Straight Arrow Connector 9">
+            <a:extLst>
+              <a:ext uri="{FF2B5EF4-FFF2-40B4-BE49-F238E27FC236}">
+                <a16:creationId xmlns:a16="http://schemas.microsoft.com/office/drawing/2014/main" id="{A2CD0DFE-4C14-2009-B874-CD411A72A9A5}"/>
+              </a:ext>
+            </a:extLst>
+          </p:cNvPr>
+          <p:cNvCxnSpPr/>
+          <p:nvPr/>
+        </p:nvCxnSpPr>
+        <p:spPr>
+          <a:xfrm flipV="1">
+            <a:off x="2477589" y="1676400"/>
+            <a:ext cx="4940815" cy="3516086"/>
+          </a:xfrm>
+          <a:prstGeom prst="straightConnector1">
+            <a:avLst/>
+          </a:prstGeom>
+          <a:ln w="38100">
+            <a:tailEnd type="triangle"/>
+          </a:ln>
+        </p:spPr>
+        <p:style>
+          <a:lnRef idx="2">
+            <a:schemeClr val="accent1"/>
+          </a:lnRef>
+          <a:fillRef idx="0">
+            <a:schemeClr val="accent1"/>
+          </a:fillRef>
+          <a:effectRef idx="1">
+            <a:schemeClr val="accent1"/>
+          </a:effectRef>
+          <a:fontRef idx="minor">
+            <a:schemeClr val="tx1"/>
+          </a:fontRef>
+        </p:style>
+      </p:cxnSp>
     </p:spTree>
     <p:extLst>
       <p:ext uri="{BB962C8B-B14F-4D97-AF65-F5344CB8AC3E}">
         <p14:creationId xmlns:p14="http://schemas.microsoft.com/office/powerpoint/2010/main" val="2546531410"/>
+      </p:ext>
+    </p:extLst>
+  </p:cSld>
+  <p:clrMapOvr>
+    <a:masterClrMapping/>
+  </p:clrMapOvr>
+</p:sld>
+</file>
+
+<file path=ppt/slides/slide36.xml><?xml version="1.0" encoding="utf-8"?>
+<p:sld xmlns:a="http://schemas.openxmlformats.org/drawingml/2006/main" xmlns:r="http://schemas.openxmlformats.org/officeDocument/2006/relationships" xmlns:p="http://schemas.openxmlformats.org/presentationml/2006/main">
+  <p:cSld>
+    <p:spTree>
+      <p:nvGrpSpPr>
+        <p:cNvPr id="1" name=""/>
+        <p:cNvGrpSpPr/>
+        <p:nvPr/>
+      </p:nvGrpSpPr>
+      <p:grpSpPr>
+        <a:xfrm>
+          <a:off x="0" y="0"/>
+          <a:ext cx="0" cy="0"/>
+          <a:chOff x="0" y="0"/>
+          <a:chExt cx="0" cy="0"/>
+        </a:xfrm>
+      </p:grpSpPr>
+      <p:sp>
+        <p:nvSpPr>
+          <p:cNvPr id="2" name="Title 1">
+            <a:extLst>
+              <a:ext uri="{FF2B5EF4-FFF2-40B4-BE49-F238E27FC236}">
+                <a16:creationId xmlns:a16="http://schemas.microsoft.com/office/drawing/2014/main" id="{B1F29B77-8C9A-8E46-9A65-4487986EB18A}"/>
+              </a:ext>
+            </a:extLst>
+          </p:cNvPr>
+          <p:cNvSpPr>
+            <a:spLocks noGrp="1"/>
+          </p:cNvSpPr>
+          <p:nvPr>
+            <p:ph type="title"/>
+          </p:nvPr>
+        </p:nvSpPr>
+        <p:spPr/>
+        <p:txBody>
+          <a:bodyPr/>
+          <a:lstStyle/>
+          <a:p>
+            <a:r>
+              <a:rPr lang="en-US" dirty="0"/>
+              <a:t>Queries for SM</a:t>
+            </a:r>
+          </a:p>
+        </p:txBody>
+      </p:sp>
+      <p:pic>
+        <p:nvPicPr>
+          <p:cNvPr id="4" name="Content Placeholder 4">
+            <a:extLst>
+              <a:ext uri="{FF2B5EF4-FFF2-40B4-BE49-F238E27FC236}">
+                <a16:creationId xmlns:a16="http://schemas.microsoft.com/office/drawing/2014/main" id="{753A3F1A-171A-5C1F-13B0-006D11EBDD48}"/>
+              </a:ext>
+            </a:extLst>
+          </p:cNvPr>
+          <p:cNvPicPr>
+            <a:picLocks noChangeAspect="1"/>
+          </p:cNvPicPr>
+          <p:nvPr/>
+        </p:nvPicPr>
+        <p:blipFill>
+          <a:blip r:embed="rId2"/>
+          <a:srcRect l="19060" t="6356" r="70586" b="61579"/>
+          <a:stretch>
+            <a:fillRect/>
+          </a:stretch>
+        </p:blipFill>
+        <p:spPr>
+          <a:xfrm>
+            <a:off x="4113936" y="3145257"/>
+            <a:ext cx="890650" cy="984147"/>
+          </a:xfrm>
+          <a:prstGeom prst="rect">
+            <a:avLst/>
+          </a:prstGeom>
+        </p:spPr>
+      </p:pic>
+      <p:pic>
+        <p:nvPicPr>
+          <p:cNvPr id="5" name="Content Placeholder 4">
+            <a:extLst>
+              <a:ext uri="{FF2B5EF4-FFF2-40B4-BE49-F238E27FC236}">
+                <a16:creationId xmlns:a16="http://schemas.microsoft.com/office/drawing/2014/main" id="{12A91F5D-C9CA-0060-71B0-CC5CD2D6BD3A}"/>
+              </a:ext>
+            </a:extLst>
+          </p:cNvPr>
+          <p:cNvPicPr>
+            <a:picLocks noChangeAspect="1"/>
+          </p:cNvPicPr>
+          <p:nvPr/>
+        </p:nvPicPr>
+        <p:blipFill>
+          <a:blip r:embed="rId2"/>
+          <a:srcRect l="59111" t="6811" r="30535" b="61124"/>
+          <a:stretch>
+            <a:fillRect/>
+          </a:stretch>
+        </p:blipFill>
+        <p:spPr>
+          <a:xfrm>
+            <a:off x="5102833" y="3159252"/>
+            <a:ext cx="890650" cy="984147"/>
+          </a:xfrm>
+          <a:prstGeom prst="rect">
+            <a:avLst/>
+          </a:prstGeom>
+        </p:spPr>
+      </p:pic>
+      <p:pic>
+        <p:nvPicPr>
+          <p:cNvPr id="6" name="Content Placeholder 4">
+            <a:extLst>
+              <a:ext uri="{FF2B5EF4-FFF2-40B4-BE49-F238E27FC236}">
+                <a16:creationId xmlns:a16="http://schemas.microsoft.com/office/drawing/2014/main" id="{E1162B88-0B2D-A7EC-3EE8-DA86CD7BCD88}"/>
+              </a:ext>
+            </a:extLst>
+          </p:cNvPr>
+          <p:cNvPicPr>
+            <a:picLocks noChangeAspect="1"/>
+          </p:cNvPicPr>
+          <p:nvPr/>
+        </p:nvPicPr>
+        <p:blipFill>
+          <a:blip r:embed="rId2"/>
+          <a:srcRect l="85899" t="6633" r="3747" b="61302"/>
+          <a:stretch>
+            <a:fillRect/>
+          </a:stretch>
+        </p:blipFill>
+        <p:spPr>
+          <a:xfrm>
+            <a:off x="6091730" y="3154584"/>
+            <a:ext cx="890650" cy="984147"/>
+          </a:xfrm>
+          <a:prstGeom prst="rect">
+            <a:avLst/>
+          </a:prstGeom>
+        </p:spPr>
+      </p:pic>
+      <p:pic>
+        <p:nvPicPr>
+          <p:cNvPr id="7" name="Content Placeholder 4">
+            <a:extLst>
+              <a:ext uri="{FF2B5EF4-FFF2-40B4-BE49-F238E27FC236}">
+                <a16:creationId xmlns:a16="http://schemas.microsoft.com/office/drawing/2014/main" id="{D37F5E7B-6B7A-0C83-9510-748ACFFBCF42}"/>
+              </a:ext>
+            </a:extLst>
+          </p:cNvPr>
+          <p:cNvPicPr>
+            <a:picLocks noChangeAspect="1"/>
+          </p:cNvPicPr>
+          <p:nvPr/>
+        </p:nvPicPr>
+        <p:blipFill>
+          <a:blip r:embed="rId2"/>
+          <a:srcRect l="5544" t="50549" r="84102" b="17386"/>
+          <a:stretch>
+            <a:fillRect/>
+          </a:stretch>
+        </p:blipFill>
+        <p:spPr>
+          <a:xfrm>
+            <a:off x="7080627" y="3131260"/>
+            <a:ext cx="890650" cy="984147"/>
+          </a:xfrm>
+          <a:prstGeom prst="rect">
+            <a:avLst/>
+          </a:prstGeom>
+        </p:spPr>
+      </p:pic>
+      <p:pic>
+        <p:nvPicPr>
+          <p:cNvPr id="8" name="Content Placeholder 4">
+            <a:extLst>
+              <a:ext uri="{FF2B5EF4-FFF2-40B4-BE49-F238E27FC236}">
+                <a16:creationId xmlns:a16="http://schemas.microsoft.com/office/drawing/2014/main" id="{744AC723-38A5-18DF-3291-12A6A38B65B4}"/>
+              </a:ext>
+            </a:extLst>
+          </p:cNvPr>
+          <p:cNvPicPr>
+            <a:picLocks noChangeAspect="1"/>
+          </p:cNvPicPr>
+          <p:nvPr/>
+        </p:nvPicPr>
+        <p:blipFill>
+          <a:blip r:embed="rId2"/>
+          <a:srcRect l="19009" t="50000" r="70637" b="17935"/>
+          <a:stretch>
+            <a:fillRect/>
+          </a:stretch>
+        </p:blipFill>
+        <p:spPr>
+          <a:xfrm>
+            <a:off x="8069524" y="3117264"/>
+            <a:ext cx="890650" cy="984147"/>
+          </a:xfrm>
+          <a:prstGeom prst="rect">
+            <a:avLst/>
+          </a:prstGeom>
+        </p:spPr>
+      </p:pic>
+      <p:sp>
+        <p:nvSpPr>
+          <p:cNvPr id="9" name="TextBox 8">
+            <a:extLst>
+              <a:ext uri="{FF2B5EF4-FFF2-40B4-BE49-F238E27FC236}">
+                <a16:creationId xmlns:a16="http://schemas.microsoft.com/office/drawing/2014/main" id="{BE94B52E-4BEC-396D-590F-3ADBC66076AE}"/>
+              </a:ext>
+            </a:extLst>
+          </p:cNvPr>
+          <p:cNvSpPr txBox="1"/>
+          <p:nvPr/>
+        </p:nvSpPr>
+        <p:spPr>
+          <a:xfrm>
+            <a:off x="4338688" y="4092789"/>
+            <a:ext cx="441146" cy="369332"/>
+          </a:xfrm>
+          <a:prstGeom prst="rect">
+            <a:avLst/>
+          </a:prstGeom>
+          <a:noFill/>
+        </p:spPr>
+        <p:txBody>
+          <a:bodyPr wrap="none" rtlCol="0">
+            <a:spAutoFit/>
+          </a:bodyPr>
+          <a:lstStyle/>
+          <a:p>
+            <a:r>
+              <a:rPr lang="en-US" dirty="0">
+                <a:latin typeface="Times New Roman" panose="02020603050405020304" pitchFamily="18" charset="0"/>
+                <a:cs typeface="Times New Roman" panose="02020603050405020304" pitchFamily="18" charset="0"/>
+              </a:rPr>
+              <a:t>P1</a:t>
+            </a:r>
+          </a:p>
+        </p:txBody>
+      </p:sp>
+      <p:sp>
+        <p:nvSpPr>
+          <p:cNvPr id="10" name="TextBox 9">
+            <a:extLst>
+              <a:ext uri="{FF2B5EF4-FFF2-40B4-BE49-F238E27FC236}">
+                <a16:creationId xmlns:a16="http://schemas.microsoft.com/office/drawing/2014/main" id="{F470D6FC-BD7E-A34C-741C-C654C438331C}"/>
+              </a:ext>
+            </a:extLst>
+          </p:cNvPr>
+          <p:cNvSpPr txBox="1"/>
+          <p:nvPr/>
+        </p:nvSpPr>
+        <p:spPr>
+          <a:xfrm>
+            <a:off x="5333997" y="4092789"/>
+            <a:ext cx="428322" cy="369332"/>
+          </a:xfrm>
+          <a:prstGeom prst="rect">
+            <a:avLst/>
+          </a:prstGeom>
+          <a:noFill/>
+        </p:spPr>
+        <p:txBody>
+          <a:bodyPr wrap="none" rtlCol="0">
+            <a:spAutoFit/>
+          </a:bodyPr>
+          <a:lstStyle/>
+          <a:p>
+            <a:r>
+              <a:rPr lang="en-US" dirty="0">
+                <a:latin typeface="Times New Roman" panose="02020603050405020304" pitchFamily="18" charset="0"/>
+                <a:cs typeface="Times New Roman" panose="02020603050405020304" pitchFamily="18" charset="0"/>
+              </a:rPr>
+              <a:t>P2</a:t>
+            </a:r>
+          </a:p>
+        </p:txBody>
+      </p:sp>
+      <p:sp>
+        <p:nvSpPr>
+          <p:cNvPr id="11" name="TextBox 10">
+            <a:extLst>
+              <a:ext uri="{FF2B5EF4-FFF2-40B4-BE49-F238E27FC236}">
+                <a16:creationId xmlns:a16="http://schemas.microsoft.com/office/drawing/2014/main" id="{5B90695E-AA2E-5782-6F26-85E755E9D93A}"/>
+              </a:ext>
+            </a:extLst>
+          </p:cNvPr>
+          <p:cNvSpPr txBox="1"/>
+          <p:nvPr/>
+        </p:nvSpPr>
+        <p:spPr>
+          <a:xfrm>
+            <a:off x="6322894" y="4092789"/>
+            <a:ext cx="428322" cy="369332"/>
+          </a:xfrm>
+          <a:prstGeom prst="rect">
+            <a:avLst/>
+          </a:prstGeom>
+          <a:noFill/>
+        </p:spPr>
+        <p:txBody>
+          <a:bodyPr wrap="none" rtlCol="0">
+            <a:spAutoFit/>
+          </a:bodyPr>
+          <a:lstStyle/>
+          <a:p>
+            <a:r>
+              <a:rPr lang="en-US" dirty="0">
+                <a:latin typeface="Times New Roman" panose="02020603050405020304" pitchFamily="18" charset="0"/>
+                <a:cs typeface="Times New Roman" panose="02020603050405020304" pitchFamily="18" charset="0"/>
+              </a:rPr>
+              <a:t>P3</a:t>
+            </a:r>
+          </a:p>
+        </p:txBody>
+      </p:sp>
+      <p:sp>
+        <p:nvSpPr>
+          <p:cNvPr id="12" name="TextBox 11">
+            <a:extLst>
+              <a:ext uri="{FF2B5EF4-FFF2-40B4-BE49-F238E27FC236}">
+                <a16:creationId xmlns:a16="http://schemas.microsoft.com/office/drawing/2014/main" id="{094E7582-6303-F225-2540-A985CBA1427D}"/>
+              </a:ext>
+            </a:extLst>
+          </p:cNvPr>
+          <p:cNvSpPr txBox="1"/>
+          <p:nvPr/>
+        </p:nvSpPr>
+        <p:spPr>
+          <a:xfrm>
+            <a:off x="7311791" y="4092789"/>
+            <a:ext cx="428322" cy="369332"/>
+          </a:xfrm>
+          <a:prstGeom prst="rect">
+            <a:avLst/>
+          </a:prstGeom>
+          <a:noFill/>
+        </p:spPr>
+        <p:txBody>
+          <a:bodyPr wrap="none" rtlCol="0">
+            <a:spAutoFit/>
+          </a:bodyPr>
+          <a:lstStyle/>
+          <a:p>
+            <a:r>
+              <a:rPr lang="en-US" dirty="0">
+                <a:latin typeface="Times New Roman" panose="02020603050405020304" pitchFamily="18" charset="0"/>
+                <a:cs typeface="Times New Roman" panose="02020603050405020304" pitchFamily="18" charset="0"/>
+              </a:rPr>
+              <a:t>P4</a:t>
+            </a:r>
+          </a:p>
+        </p:txBody>
+      </p:sp>
+      <p:sp>
+        <p:nvSpPr>
+          <p:cNvPr id="13" name="TextBox 12">
+            <a:extLst>
+              <a:ext uri="{FF2B5EF4-FFF2-40B4-BE49-F238E27FC236}">
+                <a16:creationId xmlns:a16="http://schemas.microsoft.com/office/drawing/2014/main" id="{3512F24E-735C-DA27-65D0-DB68766F1953}"/>
+              </a:ext>
+            </a:extLst>
+          </p:cNvPr>
+          <p:cNvSpPr txBox="1"/>
+          <p:nvPr/>
+        </p:nvSpPr>
+        <p:spPr>
+          <a:xfrm>
+            <a:off x="8300688" y="4092789"/>
+            <a:ext cx="428322" cy="369332"/>
+          </a:xfrm>
+          <a:prstGeom prst="rect">
+            <a:avLst/>
+          </a:prstGeom>
+          <a:noFill/>
+        </p:spPr>
+        <p:txBody>
+          <a:bodyPr wrap="none" rtlCol="0">
+            <a:spAutoFit/>
+          </a:bodyPr>
+          <a:lstStyle/>
+          <a:p>
+            <a:r>
+              <a:rPr lang="en-US" dirty="0">
+                <a:latin typeface="Times New Roman" panose="02020603050405020304" pitchFamily="18" charset="0"/>
+                <a:cs typeface="Times New Roman" panose="02020603050405020304" pitchFamily="18" charset="0"/>
+              </a:rPr>
+              <a:t>P5</a:t>
+            </a:r>
+          </a:p>
+        </p:txBody>
+      </p:sp>
+    </p:spTree>
+    <p:extLst>
+      <p:ext uri="{BB962C8B-B14F-4D97-AF65-F5344CB8AC3E}">
+        <p14:creationId xmlns:p14="http://schemas.microsoft.com/office/powerpoint/2010/main" val="2294495460"/>
       </p:ext>
     </p:extLst>
   </p:cSld>

</xml_diff>

<commit_message>
auto commit 2026-08-21 16:57:08
</commit_message>
<xml_diff>
--- a/revision.pptx
+++ b/revision.pptx
@@ -40,7 +40,8 @@
     <p:sldId id="279" r:id="rId34"/>
     <p:sldId id="293" r:id="rId35"/>
     <p:sldId id="294" r:id="rId36"/>
-    <p:sldId id="298" r:id="rId37"/>
+    <p:sldId id="299" r:id="rId37"/>
+    <p:sldId id="298" r:id="rId38"/>
   </p:sldIdLst>
   <p:sldSz cx="12192000" cy="6858000"/>
   <p:notesSz cx="6858000" cy="9144000"/>
@@ -13311,7 +13312,7 @@
           <p:cNvPr id="2" name="Title 1">
             <a:extLst>
               <a:ext uri="{FF2B5EF4-FFF2-40B4-BE49-F238E27FC236}">
-                <a16:creationId xmlns:a16="http://schemas.microsoft.com/office/drawing/2014/main" id="{B1F29B77-8C9A-8E46-9A65-4487986EB18A}"/>
+                <a16:creationId xmlns:a16="http://schemas.microsoft.com/office/drawing/2014/main" id="{64178FD8-3338-BEA4-3B41-C9C62283F198}"/>
               </a:ext>
             </a:extLst>
           </p:cNvPr>
@@ -13327,6 +13328,91 @@
           <a:bodyPr/>
           <a:lstStyle/>
           <a:p>
+            <a:endParaRPr lang="en-US"/>
+          </a:p>
+        </p:txBody>
+      </p:sp>
+      <p:sp>
+        <p:nvSpPr>
+          <p:cNvPr id="7" name="Content Placeholder 6">
+            <a:extLst>
+              <a:ext uri="{FF2B5EF4-FFF2-40B4-BE49-F238E27FC236}">
+                <a16:creationId xmlns:a16="http://schemas.microsoft.com/office/drawing/2014/main" id="{08BE59CE-AE00-A964-9D21-5D915148266A}"/>
+              </a:ext>
+            </a:extLst>
+          </p:cNvPr>
+          <p:cNvSpPr>
+            <a:spLocks noGrp="1"/>
+          </p:cNvSpPr>
+          <p:nvPr>
+            <p:ph idx="1"/>
+          </p:nvPr>
+        </p:nvSpPr>
+        <p:spPr/>
+        <p:txBody>
+          <a:bodyPr/>
+          <a:lstStyle/>
+          <a:p>
+            <a:endParaRPr lang="en-US"/>
+          </a:p>
+        </p:txBody>
+      </p:sp>
+    </p:spTree>
+    <p:extLst>
+      <p:ext uri="{BB962C8B-B14F-4D97-AF65-F5344CB8AC3E}">
+        <p14:creationId xmlns:p14="http://schemas.microsoft.com/office/powerpoint/2010/main" val="3227830537"/>
+      </p:ext>
+    </p:extLst>
+  </p:cSld>
+  <p:clrMapOvr>
+    <a:masterClrMapping/>
+  </p:clrMapOvr>
+</p:sld>
+</file>
+
+<file path=ppt/slides/slide37.xml><?xml version="1.0" encoding="utf-8"?>
+<p:sld xmlns:a="http://schemas.openxmlformats.org/drawingml/2006/main" xmlns:r="http://schemas.openxmlformats.org/officeDocument/2006/relationships" xmlns:p="http://schemas.openxmlformats.org/presentationml/2006/main">
+  <p:cSld>
+    <p:spTree>
+      <p:nvGrpSpPr>
+        <p:cNvPr id="1" name=""/>
+        <p:cNvGrpSpPr/>
+        <p:nvPr/>
+      </p:nvGrpSpPr>
+      <p:grpSpPr>
+        <a:xfrm>
+          <a:off x="0" y="0"/>
+          <a:ext cx="0" cy="0"/>
+          <a:chOff x="0" y="0"/>
+          <a:chExt cx="0" cy="0"/>
+        </a:xfrm>
+      </p:grpSpPr>
+      <p:sp>
+        <p:nvSpPr>
+          <p:cNvPr id="2" name="Title 1">
+            <a:extLst>
+              <a:ext uri="{FF2B5EF4-FFF2-40B4-BE49-F238E27FC236}">
+                <a16:creationId xmlns:a16="http://schemas.microsoft.com/office/drawing/2014/main" id="{B1F29B77-8C9A-8E46-9A65-4487986EB18A}"/>
+              </a:ext>
+            </a:extLst>
+          </p:cNvPr>
+          <p:cNvSpPr>
+            <a:spLocks noGrp="1"/>
+          </p:cNvSpPr>
+          <p:nvPr>
+            <p:ph type="title"/>
+          </p:nvPr>
+        </p:nvSpPr>
+        <p:spPr>
+          <a:xfrm>
+            <a:off x="735683" y="264275"/>
+            <a:ext cx="10515600" cy="1325563"/>
+          </a:xfrm>
+        </p:spPr>
+        <p:txBody>
+          <a:bodyPr/>
+          <a:lstStyle/>
+          <a:p>
             <a:r>
               <a:rPr lang="en-US" dirty="0"/>
               <a:t>Queries for SM</a:t>
@@ -13334,161 +13420,6 @@
           </a:p>
         </p:txBody>
       </p:sp>
-      <p:pic>
-        <p:nvPicPr>
-          <p:cNvPr id="4" name="Content Placeholder 4">
-            <a:extLst>
-              <a:ext uri="{FF2B5EF4-FFF2-40B4-BE49-F238E27FC236}">
-                <a16:creationId xmlns:a16="http://schemas.microsoft.com/office/drawing/2014/main" id="{753A3F1A-171A-5C1F-13B0-006D11EBDD48}"/>
-              </a:ext>
-            </a:extLst>
-          </p:cNvPr>
-          <p:cNvPicPr>
-            <a:picLocks noChangeAspect="1"/>
-          </p:cNvPicPr>
-          <p:nvPr/>
-        </p:nvPicPr>
-        <p:blipFill>
-          <a:blip r:embed="rId2"/>
-          <a:srcRect l="19060" t="6356" r="70586" b="61579"/>
-          <a:stretch>
-            <a:fillRect/>
-          </a:stretch>
-        </p:blipFill>
-        <p:spPr>
-          <a:xfrm>
-            <a:off x="4113936" y="3145257"/>
-            <a:ext cx="890650" cy="984147"/>
-          </a:xfrm>
-          <a:prstGeom prst="rect">
-            <a:avLst/>
-          </a:prstGeom>
-        </p:spPr>
-      </p:pic>
-      <p:pic>
-        <p:nvPicPr>
-          <p:cNvPr id="5" name="Content Placeholder 4">
-            <a:extLst>
-              <a:ext uri="{FF2B5EF4-FFF2-40B4-BE49-F238E27FC236}">
-                <a16:creationId xmlns:a16="http://schemas.microsoft.com/office/drawing/2014/main" id="{12A91F5D-C9CA-0060-71B0-CC5CD2D6BD3A}"/>
-              </a:ext>
-            </a:extLst>
-          </p:cNvPr>
-          <p:cNvPicPr>
-            <a:picLocks noChangeAspect="1"/>
-          </p:cNvPicPr>
-          <p:nvPr/>
-        </p:nvPicPr>
-        <p:blipFill>
-          <a:blip r:embed="rId2"/>
-          <a:srcRect l="59111" t="6811" r="30535" b="61124"/>
-          <a:stretch>
-            <a:fillRect/>
-          </a:stretch>
-        </p:blipFill>
-        <p:spPr>
-          <a:xfrm>
-            <a:off x="5102833" y="3159252"/>
-            <a:ext cx="890650" cy="984147"/>
-          </a:xfrm>
-          <a:prstGeom prst="rect">
-            <a:avLst/>
-          </a:prstGeom>
-        </p:spPr>
-      </p:pic>
-      <p:pic>
-        <p:nvPicPr>
-          <p:cNvPr id="6" name="Content Placeholder 4">
-            <a:extLst>
-              <a:ext uri="{FF2B5EF4-FFF2-40B4-BE49-F238E27FC236}">
-                <a16:creationId xmlns:a16="http://schemas.microsoft.com/office/drawing/2014/main" id="{E1162B88-0B2D-A7EC-3EE8-DA86CD7BCD88}"/>
-              </a:ext>
-            </a:extLst>
-          </p:cNvPr>
-          <p:cNvPicPr>
-            <a:picLocks noChangeAspect="1"/>
-          </p:cNvPicPr>
-          <p:nvPr/>
-        </p:nvPicPr>
-        <p:blipFill>
-          <a:blip r:embed="rId2"/>
-          <a:srcRect l="85899" t="6633" r="3747" b="61302"/>
-          <a:stretch>
-            <a:fillRect/>
-          </a:stretch>
-        </p:blipFill>
-        <p:spPr>
-          <a:xfrm>
-            <a:off x="6091730" y="3154584"/>
-            <a:ext cx="890650" cy="984147"/>
-          </a:xfrm>
-          <a:prstGeom prst="rect">
-            <a:avLst/>
-          </a:prstGeom>
-        </p:spPr>
-      </p:pic>
-      <p:pic>
-        <p:nvPicPr>
-          <p:cNvPr id="7" name="Content Placeholder 4">
-            <a:extLst>
-              <a:ext uri="{FF2B5EF4-FFF2-40B4-BE49-F238E27FC236}">
-                <a16:creationId xmlns:a16="http://schemas.microsoft.com/office/drawing/2014/main" id="{D37F5E7B-6B7A-0C83-9510-748ACFFBCF42}"/>
-              </a:ext>
-            </a:extLst>
-          </p:cNvPr>
-          <p:cNvPicPr>
-            <a:picLocks noChangeAspect="1"/>
-          </p:cNvPicPr>
-          <p:nvPr/>
-        </p:nvPicPr>
-        <p:blipFill>
-          <a:blip r:embed="rId2"/>
-          <a:srcRect l="5544" t="50549" r="84102" b="17386"/>
-          <a:stretch>
-            <a:fillRect/>
-          </a:stretch>
-        </p:blipFill>
-        <p:spPr>
-          <a:xfrm>
-            <a:off x="7080627" y="3131260"/>
-            <a:ext cx="890650" cy="984147"/>
-          </a:xfrm>
-          <a:prstGeom prst="rect">
-            <a:avLst/>
-          </a:prstGeom>
-        </p:spPr>
-      </p:pic>
-      <p:pic>
-        <p:nvPicPr>
-          <p:cNvPr id="8" name="Content Placeholder 4">
-            <a:extLst>
-              <a:ext uri="{FF2B5EF4-FFF2-40B4-BE49-F238E27FC236}">
-                <a16:creationId xmlns:a16="http://schemas.microsoft.com/office/drawing/2014/main" id="{744AC723-38A5-18DF-3291-12A6A38B65B4}"/>
-              </a:ext>
-            </a:extLst>
-          </p:cNvPr>
-          <p:cNvPicPr>
-            <a:picLocks noChangeAspect="1"/>
-          </p:cNvPicPr>
-          <p:nvPr/>
-        </p:nvPicPr>
-        <p:blipFill>
-          <a:blip r:embed="rId2"/>
-          <a:srcRect l="19009" t="50000" r="70637" b="17935"/>
-          <a:stretch>
-            <a:fillRect/>
-          </a:stretch>
-        </p:blipFill>
-        <p:spPr>
-          <a:xfrm>
-            <a:off x="8069524" y="3117264"/>
-            <a:ext cx="890650" cy="984147"/>
-          </a:xfrm>
-          <a:prstGeom prst="rect">
-            <a:avLst/>
-          </a:prstGeom>
-        </p:spPr>
-      </p:pic>
       <p:sp>
         <p:nvSpPr>
           <p:cNvPr id="9" name="TextBox 8">
@@ -13503,8 +13434,8 @@
         </p:nvSpPr>
         <p:spPr>
           <a:xfrm>
-            <a:off x="4338688" y="4092789"/>
-            <a:ext cx="441146" cy="369332"/>
+            <a:off x="4755693" y="3254423"/>
+            <a:ext cx="373820" cy="307777"/>
           </a:xfrm>
           <a:prstGeom prst="rect">
             <a:avLst/>
@@ -13518,7 +13449,7 @@
           <a:lstStyle/>
           <a:p>
             <a:r>
-              <a:rPr lang="en-US" dirty="0">
+              <a:rPr lang="en-US" sz="1400" dirty="0">
                 <a:latin typeface="Times New Roman" panose="02020603050405020304" pitchFamily="18" charset="0"/>
                 <a:cs typeface="Times New Roman" panose="02020603050405020304" pitchFamily="18" charset="0"/>
               </a:rPr>
@@ -13541,8 +13472,8 @@
         </p:nvSpPr>
         <p:spPr>
           <a:xfrm>
-            <a:off x="5333997" y="4092789"/>
-            <a:ext cx="428322" cy="369332"/>
+            <a:off x="5352165" y="3254423"/>
+            <a:ext cx="373820" cy="307777"/>
           </a:xfrm>
           <a:prstGeom prst="rect">
             <a:avLst/>
@@ -13556,7 +13487,7 @@
           <a:lstStyle/>
           <a:p>
             <a:r>
-              <a:rPr lang="en-US" dirty="0">
+              <a:rPr lang="en-US" sz="1400" dirty="0">
                 <a:latin typeface="Times New Roman" panose="02020603050405020304" pitchFamily="18" charset="0"/>
                 <a:cs typeface="Times New Roman" panose="02020603050405020304" pitchFamily="18" charset="0"/>
               </a:rPr>
@@ -13579,8 +13510,8 @@
         </p:nvSpPr>
         <p:spPr>
           <a:xfrm>
-            <a:off x="6322894" y="4092789"/>
-            <a:ext cx="428322" cy="369332"/>
+            <a:off x="5947228" y="3254423"/>
+            <a:ext cx="373820" cy="307777"/>
           </a:xfrm>
           <a:prstGeom prst="rect">
             <a:avLst/>
@@ -13594,7 +13525,7 @@
           <a:lstStyle/>
           <a:p>
             <a:r>
-              <a:rPr lang="en-US" dirty="0">
+              <a:rPr lang="en-US" sz="1400" dirty="0">
                 <a:latin typeface="Times New Roman" panose="02020603050405020304" pitchFamily="18" charset="0"/>
                 <a:cs typeface="Times New Roman" panose="02020603050405020304" pitchFamily="18" charset="0"/>
               </a:rPr>
@@ -13617,8 +13548,8 @@
         </p:nvSpPr>
         <p:spPr>
           <a:xfrm>
-            <a:off x="7311791" y="4092789"/>
-            <a:ext cx="428322" cy="369332"/>
+            <a:off x="6521179" y="3254423"/>
+            <a:ext cx="373820" cy="307777"/>
           </a:xfrm>
           <a:prstGeom prst="rect">
             <a:avLst/>
@@ -13632,7 +13563,7 @@
           <a:lstStyle/>
           <a:p>
             <a:r>
-              <a:rPr lang="en-US" dirty="0">
+              <a:rPr lang="en-US" sz="1400" dirty="0">
                 <a:latin typeface="Times New Roman" panose="02020603050405020304" pitchFamily="18" charset="0"/>
                 <a:cs typeface="Times New Roman" panose="02020603050405020304" pitchFamily="18" charset="0"/>
               </a:rPr>
@@ -13655,8 +13586,8 @@
         </p:nvSpPr>
         <p:spPr>
           <a:xfrm>
-            <a:off x="8300688" y="4092789"/>
-            <a:ext cx="428322" cy="369332"/>
+            <a:off x="7086011" y="3254423"/>
+            <a:ext cx="373820" cy="307777"/>
           </a:xfrm>
           <a:prstGeom prst="rect">
             <a:avLst/>
@@ -13670,7 +13601,7 @@
           <a:lstStyle/>
           <a:p>
             <a:r>
-              <a:rPr lang="en-US" dirty="0">
+              <a:rPr lang="en-US" sz="1400" dirty="0">
                 <a:latin typeface="Times New Roman" panose="02020603050405020304" pitchFamily="18" charset="0"/>
                 <a:cs typeface="Times New Roman" panose="02020603050405020304" pitchFamily="18" charset="0"/>
               </a:rPr>
@@ -13679,6 +13610,2845 @@
           </a:p>
         </p:txBody>
       </p:sp>
+      <p:sp>
+        <p:nvSpPr>
+          <p:cNvPr id="101" name="Oval 100">
+            <a:extLst>
+              <a:ext uri="{FF2B5EF4-FFF2-40B4-BE49-F238E27FC236}">
+                <a16:creationId xmlns:a16="http://schemas.microsoft.com/office/drawing/2014/main" id="{2A59C34E-8923-A0F5-647A-71CA45FF1289}"/>
+              </a:ext>
+            </a:extLst>
+          </p:cNvPr>
+          <p:cNvSpPr/>
+          <p:nvPr/>
+        </p:nvSpPr>
+        <p:spPr>
+          <a:xfrm>
+            <a:off x="4746032" y="2827328"/>
+            <a:ext cx="87313" cy="87313"/>
+          </a:xfrm>
+          <a:prstGeom prst="ellipse">
+            <a:avLst/>
+          </a:prstGeom>
+          <a:solidFill>
+            <a:schemeClr val="tx1"/>
+          </a:solidFill>
+          <a:ln>
+            <a:noFill/>
+          </a:ln>
+        </p:spPr>
+        <p:style>
+          <a:lnRef idx="2">
+            <a:schemeClr val="accent1">
+              <a:shade val="15000"/>
+            </a:schemeClr>
+          </a:lnRef>
+          <a:fillRef idx="1">
+            <a:schemeClr val="accent1"/>
+          </a:fillRef>
+          <a:effectRef idx="0">
+            <a:schemeClr val="accent1"/>
+          </a:effectRef>
+          <a:fontRef idx="minor">
+            <a:schemeClr val="lt1"/>
+          </a:fontRef>
+        </p:style>
+        <p:txBody>
+          <a:bodyPr rtlCol="0" anchor="ctr"/>
+          <a:lstStyle/>
+          <a:p>
+            <a:pPr algn="ctr"/>
+            <a:endParaRPr lang="en-US"/>
+          </a:p>
+        </p:txBody>
+      </p:sp>
+      <p:sp>
+        <p:nvSpPr>
+          <p:cNvPr id="102" name="Oval 101">
+            <a:extLst>
+              <a:ext uri="{FF2B5EF4-FFF2-40B4-BE49-F238E27FC236}">
+                <a16:creationId xmlns:a16="http://schemas.microsoft.com/office/drawing/2014/main" id="{946153F5-D9F5-A9C9-24A4-FF3673C75063}"/>
+              </a:ext>
+            </a:extLst>
+          </p:cNvPr>
+          <p:cNvSpPr/>
+          <p:nvPr/>
+        </p:nvSpPr>
+        <p:spPr>
+          <a:xfrm>
+            <a:off x="5112921" y="2823438"/>
+            <a:ext cx="87313" cy="87313"/>
+          </a:xfrm>
+          <a:prstGeom prst="ellipse">
+            <a:avLst/>
+          </a:prstGeom>
+          <a:solidFill>
+            <a:schemeClr val="tx1"/>
+          </a:solidFill>
+          <a:ln>
+            <a:noFill/>
+          </a:ln>
+        </p:spPr>
+        <p:style>
+          <a:lnRef idx="2">
+            <a:schemeClr val="accent1">
+              <a:shade val="15000"/>
+            </a:schemeClr>
+          </a:lnRef>
+          <a:fillRef idx="1">
+            <a:schemeClr val="accent1"/>
+          </a:fillRef>
+          <a:effectRef idx="0">
+            <a:schemeClr val="accent1"/>
+          </a:effectRef>
+          <a:fontRef idx="minor">
+            <a:schemeClr val="lt1"/>
+          </a:fontRef>
+        </p:style>
+        <p:txBody>
+          <a:bodyPr rtlCol="0" anchor="ctr"/>
+          <a:lstStyle/>
+          <a:p>
+            <a:pPr algn="ctr"/>
+            <a:endParaRPr lang="en-US"/>
+          </a:p>
+        </p:txBody>
+      </p:sp>
+      <p:sp>
+        <p:nvSpPr>
+          <p:cNvPr id="103" name="Oval 102">
+            <a:extLst>
+              <a:ext uri="{FF2B5EF4-FFF2-40B4-BE49-F238E27FC236}">
+                <a16:creationId xmlns:a16="http://schemas.microsoft.com/office/drawing/2014/main" id="{F2A9376B-9883-C0E8-21AE-628BBC20097B}"/>
+              </a:ext>
+            </a:extLst>
+          </p:cNvPr>
+          <p:cNvSpPr/>
+          <p:nvPr/>
+        </p:nvSpPr>
+        <p:spPr>
+          <a:xfrm>
+            <a:off x="4746032" y="3193651"/>
+            <a:ext cx="87313" cy="87313"/>
+          </a:xfrm>
+          <a:prstGeom prst="ellipse">
+            <a:avLst/>
+          </a:prstGeom>
+          <a:solidFill>
+            <a:schemeClr val="tx1"/>
+          </a:solidFill>
+          <a:ln>
+            <a:noFill/>
+          </a:ln>
+        </p:spPr>
+        <p:style>
+          <a:lnRef idx="2">
+            <a:schemeClr val="accent1">
+              <a:shade val="15000"/>
+            </a:schemeClr>
+          </a:lnRef>
+          <a:fillRef idx="1">
+            <a:schemeClr val="accent1"/>
+          </a:fillRef>
+          <a:effectRef idx="0">
+            <a:schemeClr val="accent1"/>
+          </a:effectRef>
+          <a:fontRef idx="minor">
+            <a:schemeClr val="lt1"/>
+          </a:fontRef>
+        </p:style>
+        <p:txBody>
+          <a:bodyPr rtlCol="0" anchor="ctr"/>
+          <a:lstStyle/>
+          <a:p>
+            <a:pPr algn="ctr"/>
+            <a:endParaRPr lang="en-US" sz="1400"/>
+          </a:p>
+        </p:txBody>
+      </p:sp>
+      <p:sp>
+        <p:nvSpPr>
+          <p:cNvPr id="104" name="Oval 103">
+            <a:extLst>
+              <a:ext uri="{FF2B5EF4-FFF2-40B4-BE49-F238E27FC236}">
+                <a16:creationId xmlns:a16="http://schemas.microsoft.com/office/drawing/2014/main" id="{B0DA270A-7C2B-F78A-EEB3-04FCA7430387}"/>
+              </a:ext>
+            </a:extLst>
+          </p:cNvPr>
+          <p:cNvSpPr/>
+          <p:nvPr/>
+        </p:nvSpPr>
+        <p:spPr>
+          <a:xfrm>
+            <a:off x="5109526" y="3193650"/>
+            <a:ext cx="87313" cy="87313"/>
+          </a:xfrm>
+          <a:prstGeom prst="ellipse">
+            <a:avLst/>
+          </a:prstGeom>
+          <a:solidFill>
+            <a:schemeClr val="tx1"/>
+          </a:solidFill>
+          <a:ln>
+            <a:noFill/>
+          </a:ln>
+        </p:spPr>
+        <p:style>
+          <a:lnRef idx="2">
+            <a:schemeClr val="accent1">
+              <a:shade val="15000"/>
+            </a:schemeClr>
+          </a:lnRef>
+          <a:fillRef idx="1">
+            <a:schemeClr val="accent1"/>
+          </a:fillRef>
+          <a:effectRef idx="0">
+            <a:schemeClr val="accent1"/>
+          </a:effectRef>
+          <a:fontRef idx="minor">
+            <a:schemeClr val="lt1"/>
+          </a:fontRef>
+        </p:style>
+        <p:txBody>
+          <a:bodyPr rtlCol="0" anchor="ctr"/>
+          <a:lstStyle/>
+          <a:p>
+            <a:pPr algn="ctr"/>
+            <a:endParaRPr lang="en-US" sz="1400"/>
+          </a:p>
+        </p:txBody>
+      </p:sp>
+      <p:cxnSp>
+        <p:nvCxnSpPr>
+          <p:cNvPr id="106" name="Straight Connector 105">
+            <a:extLst>
+              <a:ext uri="{FF2B5EF4-FFF2-40B4-BE49-F238E27FC236}">
+                <a16:creationId xmlns:a16="http://schemas.microsoft.com/office/drawing/2014/main" id="{538BDFA9-B153-CE33-0049-CA4B23415B6F}"/>
+              </a:ext>
+            </a:extLst>
+          </p:cNvPr>
+          <p:cNvCxnSpPr>
+            <a:cxnSpLocks/>
+          </p:cNvCxnSpPr>
+          <p:nvPr/>
+        </p:nvCxnSpPr>
+        <p:spPr>
+          <a:xfrm rot="16200000" flipV="1">
+            <a:off x="4784122" y="2858353"/>
+            <a:ext cx="361720" cy="361720"/>
+          </a:xfrm>
+          <a:prstGeom prst="line">
+            <a:avLst/>
+          </a:prstGeom>
+          <a:ln>
+            <a:solidFill>
+              <a:schemeClr val="tx1"/>
+            </a:solidFill>
+          </a:ln>
+        </p:spPr>
+        <p:style>
+          <a:lnRef idx="2">
+            <a:schemeClr val="accent1"/>
+          </a:lnRef>
+          <a:fillRef idx="0">
+            <a:schemeClr val="accent1"/>
+          </a:fillRef>
+          <a:effectRef idx="1">
+            <a:schemeClr val="accent1"/>
+          </a:effectRef>
+          <a:fontRef idx="minor">
+            <a:schemeClr val="tx1"/>
+          </a:fontRef>
+        </p:style>
+      </p:cxnSp>
+      <p:cxnSp>
+        <p:nvCxnSpPr>
+          <p:cNvPr id="107" name="Straight Connector 106">
+            <a:extLst>
+              <a:ext uri="{FF2B5EF4-FFF2-40B4-BE49-F238E27FC236}">
+                <a16:creationId xmlns:a16="http://schemas.microsoft.com/office/drawing/2014/main" id="{33D81001-D852-161A-7686-5FAE10AE12DC}"/>
+              </a:ext>
+            </a:extLst>
+          </p:cNvPr>
+          <p:cNvCxnSpPr>
+            <a:cxnSpLocks/>
+          </p:cNvCxnSpPr>
+          <p:nvPr/>
+        </p:nvCxnSpPr>
+        <p:spPr>
+          <a:xfrm flipV="1">
+            <a:off x="4793880" y="2874585"/>
+            <a:ext cx="0" cy="378954"/>
+          </a:xfrm>
+          <a:prstGeom prst="line">
+            <a:avLst/>
+          </a:prstGeom>
+          <a:ln>
+            <a:solidFill>
+              <a:schemeClr val="tx1"/>
+            </a:solidFill>
+          </a:ln>
+        </p:spPr>
+        <p:style>
+          <a:lnRef idx="2">
+            <a:schemeClr val="accent1"/>
+          </a:lnRef>
+          <a:fillRef idx="0">
+            <a:schemeClr val="accent1"/>
+          </a:fillRef>
+          <a:effectRef idx="1">
+            <a:schemeClr val="accent1"/>
+          </a:effectRef>
+          <a:fontRef idx="minor">
+            <a:schemeClr val="tx1"/>
+          </a:fontRef>
+        </p:style>
+      </p:cxnSp>
+      <p:cxnSp>
+        <p:nvCxnSpPr>
+          <p:cNvPr id="108" name="Straight Connector 107">
+            <a:extLst>
+              <a:ext uri="{FF2B5EF4-FFF2-40B4-BE49-F238E27FC236}">
+                <a16:creationId xmlns:a16="http://schemas.microsoft.com/office/drawing/2014/main" id="{9EF96196-3BAE-7299-0D44-15170825F8E3}"/>
+              </a:ext>
+            </a:extLst>
+          </p:cNvPr>
+          <p:cNvCxnSpPr>
+            <a:cxnSpLocks/>
+          </p:cNvCxnSpPr>
+          <p:nvPr/>
+        </p:nvCxnSpPr>
+        <p:spPr>
+          <a:xfrm flipV="1">
+            <a:off x="5157989" y="2865587"/>
+            <a:ext cx="0" cy="378954"/>
+          </a:xfrm>
+          <a:prstGeom prst="line">
+            <a:avLst/>
+          </a:prstGeom>
+          <a:ln>
+            <a:solidFill>
+              <a:schemeClr val="tx1"/>
+            </a:solidFill>
+          </a:ln>
+        </p:spPr>
+        <p:style>
+          <a:lnRef idx="2">
+            <a:schemeClr val="accent1"/>
+          </a:lnRef>
+          <a:fillRef idx="0">
+            <a:schemeClr val="accent1"/>
+          </a:fillRef>
+          <a:effectRef idx="1">
+            <a:schemeClr val="accent1"/>
+          </a:effectRef>
+          <a:fontRef idx="minor">
+            <a:schemeClr val="tx1"/>
+          </a:fontRef>
+        </p:style>
+      </p:cxnSp>
+      <p:cxnSp>
+        <p:nvCxnSpPr>
+          <p:cNvPr id="112" name="Straight Connector 111">
+            <a:extLst>
+              <a:ext uri="{FF2B5EF4-FFF2-40B4-BE49-F238E27FC236}">
+                <a16:creationId xmlns:a16="http://schemas.microsoft.com/office/drawing/2014/main" id="{F0DE6CAF-E354-CB90-7E4D-3FF7C234CE90}"/>
+              </a:ext>
+            </a:extLst>
+          </p:cNvPr>
+          <p:cNvCxnSpPr>
+            <a:cxnSpLocks/>
+          </p:cNvCxnSpPr>
+          <p:nvPr/>
+        </p:nvCxnSpPr>
+        <p:spPr>
+          <a:xfrm flipH="1">
+            <a:off x="4818733" y="3236832"/>
+            <a:ext cx="355154" cy="0"/>
+          </a:xfrm>
+          <a:prstGeom prst="line">
+            <a:avLst/>
+          </a:prstGeom>
+          <a:ln>
+            <a:solidFill>
+              <a:schemeClr val="tx1"/>
+            </a:solidFill>
+          </a:ln>
+        </p:spPr>
+        <p:style>
+          <a:lnRef idx="2">
+            <a:schemeClr val="accent1"/>
+          </a:lnRef>
+          <a:fillRef idx="0">
+            <a:schemeClr val="accent1"/>
+          </a:fillRef>
+          <a:effectRef idx="1">
+            <a:schemeClr val="accent1"/>
+          </a:effectRef>
+          <a:fontRef idx="minor">
+            <a:schemeClr val="tx1"/>
+          </a:fontRef>
+        </p:style>
+      </p:cxnSp>
+      <p:cxnSp>
+        <p:nvCxnSpPr>
+          <p:cNvPr id="113" name="Straight Connector 112">
+            <a:extLst>
+              <a:ext uri="{FF2B5EF4-FFF2-40B4-BE49-F238E27FC236}">
+                <a16:creationId xmlns:a16="http://schemas.microsoft.com/office/drawing/2014/main" id="{BFDEC3D0-AB79-EC01-53CD-C3397C6D3477}"/>
+              </a:ext>
+            </a:extLst>
+          </p:cNvPr>
+          <p:cNvCxnSpPr>
+            <a:cxnSpLocks/>
+          </p:cNvCxnSpPr>
+          <p:nvPr/>
+        </p:nvCxnSpPr>
+        <p:spPr>
+          <a:xfrm flipH="1">
+            <a:off x="4784122" y="2874585"/>
+            <a:ext cx="355154" cy="0"/>
+          </a:xfrm>
+          <a:prstGeom prst="line">
+            <a:avLst/>
+          </a:prstGeom>
+          <a:ln>
+            <a:solidFill>
+              <a:schemeClr val="tx1"/>
+            </a:solidFill>
+          </a:ln>
+        </p:spPr>
+        <p:style>
+          <a:lnRef idx="2">
+            <a:schemeClr val="accent1"/>
+          </a:lnRef>
+          <a:fillRef idx="0">
+            <a:schemeClr val="accent1"/>
+          </a:fillRef>
+          <a:effectRef idx="1">
+            <a:schemeClr val="accent1"/>
+          </a:effectRef>
+          <a:fontRef idx="minor">
+            <a:schemeClr val="tx1"/>
+          </a:fontRef>
+        </p:style>
+      </p:cxnSp>
+      <p:sp>
+        <p:nvSpPr>
+          <p:cNvPr id="118" name="Oval 117">
+            <a:extLst>
+              <a:ext uri="{FF2B5EF4-FFF2-40B4-BE49-F238E27FC236}">
+                <a16:creationId xmlns:a16="http://schemas.microsoft.com/office/drawing/2014/main" id="{8D187165-7E97-81BA-0A9F-198BD9B1319C}"/>
+              </a:ext>
+            </a:extLst>
+          </p:cNvPr>
+          <p:cNvSpPr/>
+          <p:nvPr/>
+        </p:nvSpPr>
+        <p:spPr>
+          <a:xfrm>
+            <a:off x="5316625" y="2827328"/>
+            <a:ext cx="87313" cy="87313"/>
+          </a:xfrm>
+          <a:prstGeom prst="ellipse">
+            <a:avLst/>
+          </a:prstGeom>
+          <a:solidFill>
+            <a:schemeClr val="tx1"/>
+          </a:solidFill>
+          <a:ln>
+            <a:noFill/>
+          </a:ln>
+        </p:spPr>
+        <p:style>
+          <a:lnRef idx="2">
+            <a:schemeClr val="accent1">
+              <a:shade val="15000"/>
+            </a:schemeClr>
+          </a:lnRef>
+          <a:fillRef idx="1">
+            <a:schemeClr val="accent1"/>
+          </a:fillRef>
+          <a:effectRef idx="0">
+            <a:schemeClr val="accent1"/>
+          </a:effectRef>
+          <a:fontRef idx="minor">
+            <a:schemeClr val="lt1"/>
+          </a:fontRef>
+        </p:style>
+        <p:txBody>
+          <a:bodyPr rtlCol="0" anchor="ctr"/>
+          <a:lstStyle/>
+          <a:p>
+            <a:pPr algn="ctr"/>
+            <a:endParaRPr lang="en-US"/>
+          </a:p>
+        </p:txBody>
+      </p:sp>
+      <p:sp>
+        <p:nvSpPr>
+          <p:cNvPr id="119" name="Oval 118">
+            <a:extLst>
+              <a:ext uri="{FF2B5EF4-FFF2-40B4-BE49-F238E27FC236}">
+                <a16:creationId xmlns:a16="http://schemas.microsoft.com/office/drawing/2014/main" id="{01D024CD-FEF2-71F9-0FF0-0F3F9BA552E2}"/>
+              </a:ext>
+            </a:extLst>
+          </p:cNvPr>
+          <p:cNvSpPr/>
+          <p:nvPr/>
+        </p:nvSpPr>
+        <p:spPr>
+          <a:xfrm>
+            <a:off x="5683514" y="2823438"/>
+            <a:ext cx="87313" cy="87313"/>
+          </a:xfrm>
+          <a:prstGeom prst="ellipse">
+            <a:avLst/>
+          </a:prstGeom>
+          <a:solidFill>
+            <a:schemeClr val="tx1"/>
+          </a:solidFill>
+          <a:ln>
+            <a:noFill/>
+          </a:ln>
+        </p:spPr>
+        <p:style>
+          <a:lnRef idx="2">
+            <a:schemeClr val="accent1">
+              <a:shade val="15000"/>
+            </a:schemeClr>
+          </a:lnRef>
+          <a:fillRef idx="1">
+            <a:schemeClr val="accent1"/>
+          </a:fillRef>
+          <a:effectRef idx="0">
+            <a:schemeClr val="accent1"/>
+          </a:effectRef>
+          <a:fontRef idx="minor">
+            <a:schemeClr val="lt1"/>
+          </a:fontRef>
+        </p:style>
+        <p:txBody>
+          <a:bodyPr rtlCol="0" anchor="ctr"/>
+          <a:lstStyle/>
+          <a:p>
+            <a:pPr algn="ctr"/>
+            <a:endParaRPr lang="en-US"/>
+          </a:p>
+        </p:txBody>
+      </p:sp>
+      <p:sp>
+        <p:nvSpPr>
+          <p:cNvPr id="120" name="Oval 119">
+            <a:extLst>
+              <a:ext uri="{FF2B5EF4-FFF2-40B4-BE49-F238E27FC236}">
+                <a16:creationId xmlns:a16="http://schemas.microsoft.com/office/drawing/2014/main" id="{F65B8414-3E53-9662-6AA1-92A278AEA448}"/>
+              </a:ext>
+            </a:extLst>
+          </p:cNvPr>
+          <p:cNvSpPr/>
+          <p:nvPr/>
+        </p:nvSpPr>
+        <p:spPr>
+          <a:xfrm>
+            <a:off x="5316625" y="3193651"/>
+            <a:ext cx="87313" cy="87313"/>
+          </a:xfrm>
+          <a:prstGeom prst="ellipse">
+            <a:avLst/>
+          </a:prstGeom>
+          <a:solidFill>
+            <a:schemeClr val="tx1"/>
+          </a:solidFill>
+          <a:ln>
+            <a:noFill/>
+          </a:ln>
+        </p:spPr>
+        <p:style>
+          <a:lnRef idx="2">
+            <a:schemeClr val="accent1">
+              <a:shade val="15000"/>
+            </a:schemeClr>
+          </a:lnRef>
+          <a:fillRef idx="1">
+            <a:schemeClr val="accent1"/>
+          </a:fillRef>
+          <a:effectRef idx="0">
+            <a:schemeClr val="accent1"/>
+          </a:effectRef>
+          <a:fontRef idx="minor">
+            <a:schemeClr val="lt1"/>
+          </a:fontRef>
+        </p:style>
+        <p:txBody>
+          <a:bodyPr rtlCol="0" anchor="ctr"/>
+          <a:lstStyle/>
+          <a:p>
+            <a:pPr algn="ctr"/>
+            <a:endParaRPr lang="en-US" sz="1400"/>
+          </a:p>
+        </p:txBody>
+      </p:sp>
+      <p:sp>
+        <p:nvSpPr>
+          <p:cNvPr id="121" name="Oval 120">
+            <a:extLst>
+              <a:ext uri="{FF2B5EF4-FFF2-40B4-BE49-F238E27FC236}">
+                <a16:creationId xmlns:a16="http://schemas.microsoft.com/office/drawing/2014/main" id="{C2C02BEC-5D0A-8897-17D8-B5A2F96B684E}"/>
+              </a:ext>
+            </a:extLst>
+          </p:cNvPr>
+          <p:cNvSpPr/>
+          <p:nvPr/>
+        </p:nvSpPr>
+        <p:spPr>
+          <a:xfrm>
+            <a:off x="5680119" y="3193650"/>
+            <a:ext cx="87313" cy="87313"/>
+          </a:xfrm>
+          <a:prstGeom prst="ellipse">
+            <a:avLst/>
+          </a:prstGeom>
+          <a:solidFill>
+            <a:schemeClr val="tx1"/>
+          </a:solidFill>
+          <a:ln>
+            <a:noFill/>
+          </a:ln>
+        </p:spPr>
+        <p:style>
+          <a:lnRef idx="2">
+            <a:schemeClr val="accent1">
+              <a:shade val="15000"/>
+            </a:schemeClr>
+          </a:lnRef>
+          <a:fillRef idx="1">
+            <a:schemeClr val="accent1"/>
+          </a:fillRef>
+          <a:effectRef idx="0">
+            <a:schemeClr val="accent1"/>
+          </a:effectRef>
+          <a:fontRef idx="minor">
+            <a:schemeClr val="lt1"/>
+          </a:fontRef>
+        </p:style>
+        <p:txBody>
+          <a:bodyPr rtlCol="0" anchor="ctr"/>
+          <a:lstStyle/>
+          <a:p>
+            <a:pPr algn="ctr"/>
+            <a:endParaRPr lang="en-US" sz="1400"/>
+          </a:p>
+        </p:txBody>
+      </p:sp>
+      <p:cxnSp>
+        <p:nvCxnSpPr>
+          <p:cNvPr id="122" name="Straight Connector 121">
+            <a:extLst>
+              <a:ext uri="{FF2B5EF4-FFF2-40B4-BE49-F238E27FC236}">
+                <a16:creationId xmlns:a16="http://schemas.microsoft.com/office/drawing/2014/main" id="{D9CCE777-0D4C-B964-0AF0-9AF9E56AE0B0}"/>
+              </a:ext>
+            </a:extLst>
+          </p:cNvPr>
+          <p:cNvCxnSpPr>
+            <a:cxnSpLocks/>
+          </p:cNvCxnSpPr>
+          <p:nvPr/>
+        </p:nvCxnSpPr>
+        <p:spPr>
+          <a:xfrm flipV="1">
+            <a:off x="5366863" y="2865587"/>
+            <a:ext cx="361720" cy="361720"/>
+          </a:xfrm>
+          <a:prstGeom prst="line">
+            <a:avLst/>
+          </a:prstGeom>
+          <a:ln>
+            <a:solidFill>
+              <a:schemeClr val="tx1"/>
+            </a:solidFill>
+          </a:ln>
+        </p:spPr>
+        <p:style>
+          <a:lnRef idx="2">
+            <a:schemeClr val="accent1"/>
+          </a:lnRef>
+          <a:fillRef idx="0">
+            <a:schemeClr val="accent1"/>
+          </a:fillRef>
+          <a:effectRef idx="1">
+            <a:schemeClr val="accent1"/>
+          </a:effectRef>
+          <a:fontRef idx="minor">
+            <a:schemeClr val="tx1"/>
+          </a:fontRef>
+        </p:style>
+      </p:cxnSp>
+      <p:cxnSp>
+        <p:nvCxnSpPr>
+          <p:cNvPr id="123" name="Straight Connector 122">
+            <a:extLst>
+              <a:ext uri="{FF2B5EF4-FFF2-40B4-BE49-F238E27FC236}">
+                <a16:creationId xmlns:a16="http://schemas.microsoft.com/office/drawing/2014/main" id="{2AF291C4-B03F-8AF9-B63A-D526F68CFFB1}"/>
+              </a:ext>
+            </a:extLst>
+          </p:cNvPr>
+          <p:cNvCxnSpPr>
+            <a:cxnSpLocks/>
+          </p:cNvCxnSpPr>
+          <p:nvPr/>
+        </p:nvCxnSpPr>
+        <p:spPr>
+          <a:xfrm rot="16200000" flipV="1">
+            <a:off x="5354715" y="2858353"/>
+            <a:ext cx="361720" cy="361720"/>
+          </a:xfrm>
+          <a:prstGeom prst="line">
+            <a:avLst/>
+          </a:prstGeom>
+          <a:ln>
+            <a:solidFill>
+              <a:schemeClr val="tx1"/>
+            </a:solidFill>
+          </a:ln>
+        </p:spPr>
+        <p:style>
+          <a:lnRef idx="2">
+            <a:schemeClr val="accent1"/>
+          </a:lnRef>
+          <a:fillRef idx="0">
+            <a:schemeClr val="accent1"/>
+          </a:fillRef>
+          <a:effectRef idx="1">
+            <a:schemeClr val="accent1"/>
+          </a:effectRef>
+          <a:fontRef idx="minor">
+            <a:schemeClr val="tx1"/>
+          </a:fontRef>
+        </p:style>
+      </p:cxnSp>
+      <p:cxnSp>
+        <p:nvCxnSpPr>
+          <p:cNvPr id="124" name="Straight Connector 123">
+            <a:extLst>
+              <a:ext uri="{FF2B5EF4-FFF2-40B4-BE49-F238E27FC236}">
+                <a16:creationId xmlns:a16="http://schemas.microsoft.com/office/drawing/2014/main" id="{B2046C4C-5874-345A-F012-6969C3CABF15}"/>
+              </a:ext>
+            </a:extLst>
+          </p:cNvPr>
+          <p:cNvCxnSpPr>
+            <a:cxnSpLocks/>
+          </p:cNvCxnSpPr>
+          <p:nvPr/>
+        </p:nvCxnSpPr>
+        <p:spPr>
+          <a:xfrm flipV="1">
+            <a:off x="5364473" y="2874585"/>
+            <a:ext cx="0" cy="378954"/>
+          </a:xfrm>
+          <a:prstGeom prst="line">
+            <a:avLst/>
+          </a:prstGeom>
+          <a:ln>
+            <a:solidFill>
+              <a:schemeClr val="tx1"/>
+            </a:solidFill>
+          </a:ln>
+        </p:spPr>
+        <p:style>
+          <a:lnRef idx="2">
+            <a:schemeClr val="accent1"/>
+          </a:lnRef>
+          <a:fillRef idx="0">
+            <a:schemeClr val="accent1"/>
+          </a:fillRef>
+          <a:effectRef idx="1">
+            <a:schemeClr val="accent1"/>
+          </a:effectRef>
+          <a:fontRef idx="minor">
+            <a:schemeClr val="tx1"/>
+          </a:fontRef>
+        </p:style>
+      </p:cxnSp>
+      <p:cxnSp>
+        <p:nvCxnSpPr>
+          <p:cNvPr id="125" name="Straight Connector 124">
+            <a:extLst>
+              <a:ext uri="{FF2B5EF4-FFF2-40B4-BE49-F238E27FC236}">
+                <a16:creationId xmlns:a16="http://schemas.microsoft.com/office/drawing/2014/main" id="{B2F37F20-BDE3-7011-C142-44DB3C3BF379}"/>
+              </a:ext>
+            </a:extLst>
+          </p:cNvPr>
+          <p:cNvCxnSpPr>
+            <a:cxnSpLocks/>
+          </p:cNvCxnSpPr>
+          <p:nvPr/>
+        </p:nvCxnSpPr>
+        <p:spPr>
+          <a:xfrm flipV="1">
+            <a:off x="5728582" y="2865587"/>
+            <a:ext cx="0" cy="378954"/>
+          </a:xfrm>
+          <a:prstGeom prst="line">
+            <a:avLst/>
+          </a:prstGeom>
+          <a:ln>
+            <a:solidFill>
+              <a:schemeClr val="tx1"/>
+            </a:solidFill>
+          </a:ln>
+        </p:spPr>
+        <p:style>
+          <a:lnRef idx="2">
+            <a:schemeClr val="accent1"/>
+          </a:lnRef>
+          <a:fillRef idx="0">
+            <a:schemeClr val="accent1"/>
+          </a:fillRef>
+          <a:effectRef idx="1">
+            <a:schemeClr val="accent1"/>
+          </a:effectRef>
+          <a:fontRef idx="minor">
+            <a:schemeClr val="tx1"/>
+          </a:fontRef>
+        </p:style>
+      </p:cxnSp>
+      <p:cxnSp>
+        <p:nvCxnSpPr>
+          <p:cNvPr id="126" name="Straight Connector 125">
+            <a:extLst>
+              <a:ext uri="{FF2B5EF4-FFF2-40B4-BE49-F238E27FC236}">
+                <a16:creationId xmlns:a16="http://schemas.microsoft.com/office/drawing/2014/main" id="{DE3ACE22-6C1A-13AB-EA58-12400B1E1702}"/>
+              </a:ext>
+            </a:extLst>
+          </p:cNvPr>
+          <p:cNvCxnSpPr>
+            <a:cxnSpLocks/>
+          </p:cNvCxnSpPr>
+          <p:nvPr/>
+        </p:nvCxnSpPr>
+        <p:spPr>
+          <a:xfrm flipH="1">
+            <a:off x="5389326" y="3236832"/>
+            <a:ext cx="355154" cy="0"/>
+          </a:xfrm>
+          <a:prstGeom prst="line">
+            <a:avLst/>
+          </a:prstGeom>
+          <a:ln>
+            <a:solidFill>
+              <a:schemeClr val="tx1"/>
+            </a:solidFill>
+          </a:ln>
+        </p:spPr>
+        <p:style>
+          <a:lnRef idx="2">
+            <a:schemeClr val="accent1"/>
+          </a:lnRef>
+          <a:fillRef idx="0">
+            <a:schemeClr val="accent1"/>
+          </a:fillRef>
+          <a:effectRef idx="1">
+            <a:schemeClr val="accent1"/>
+          </a:effectRef>
+          <a:fontRef idx="minor">
+            <a:schemeClr val="tx1"/>
+          </a:fontRef>
+        </p:style>
+      </p:cxnSp>
+      <p:cxnSp>
+        <p:nvCxnSpPr>
+          <p:cNvPr id="127" name="Straight Connector 126">
+            <a:extLst>
+              <a:ext uri="{FF2B5EF4-FFF2-40B4-BE49-F238E27FC236}">
+                <a16:creationId xmlns:a16="http://schemas.microsoft.com/office/drawing/2014/main" id="{964256EB-DC24-FBFC-99E1-7734028D071E}"/>
+              </a:ext>
+            </a:extLst>
+          </p:cNvPr>
+          <p:cNvCxnSpPr>
+            <a:cxnSpLocks/>
+          </p:cNvCxnSpPr>
+          <p:nvPr/>
+        </p:nvCxnSpPr>
+        <p:spPr>
+          <a:xfrm flipH="1">
+            <a:off x="5354715" y="2874585"/>
+            <a:ext cx="355154" cy="0"/>
+          </a:xfrm>
+          <a:prstGeom prst="line">
+            <a:avLst/>
+          </a:prstGeom>
+          <a:ln>
+            <a:solidFill>
+              <a:schemeClr val="tx1"/>
+            </a:solidFill>
+          </a:ln>
+        </p:spPr>
+        <p:style>
+          <a:lnRef idx="2">
+            <a:schemeClr val="accent1"/>
+          </a:lnRef>
+          <a:fillRef idx="0">
+            <a:schemeClr val="accent1"/>
+          </a:fillRef>
+          <a:effectRef idx="1">
+            <a:schemeClr val="accent1"/>
+          </a:effectRef>
+          <a:fontRef idx="minor">
+            <a:schemeClr val="tx1"/>
+          </a:fontRef>
+        </p:style>
+      </p:cxnSp>
+      <p:cxnSp>
+        <p:nvCxnSpPr>
+          <p:cNvPr id="128" name="Straight Connector 127">
+            <a:extLst>
+              <a:ext uri="{FF2B5EF4-FFF2-40B4-BE49-F238E27FC236}">
+                <a16:creationId xmlns:a16="http://schemas.microsoft.com/office/drawing/2014/main" id="{BB02D5E9-BD16-0984-15E8-2F9BC2322A23}"/>
+              </a:ext>
+            </a:extLst>
+          </p:cNvPr>
+          <p:cNvCxnSpPr>
+            <a:cxnSpLocks/>
+          </p:cNvCxnSpPr>
+          <p:nvPr/>
+        </p:nvCxnSpPr>
+        <p:spPr>
+          <a:xfrm flipV="1">
+            <a:off x="5358418" y="2698366"/>
+            <a:ext cx="167220" cy="167220"/>
+          </a:xfrm>
+          <a:prstGeom prst="line">
+            <a:avLst/>
+          </a:prstGeom>
+          <a:ln>
+            <a:solidFill>
+              <a:schemeClr val="tx1"/>
+            </a:solidFill>
+          </a:ln>
+        </p:spPr>
+        <p:style>
+          <a:lnRef idx="2">
+            <a:schemeClr val="accent1"/>
+          </a:lnRef>
+          <a:fillRef idx="0">
+            <a:schemeClr val="accent1"/>
+          </a:fillRef>
+          <a:effectRef idx="1">
+            <a:schemeClr val="accent1"/>
+          </a:effectRef>
+          <a:fontRef idx="minor">
+            <a:schemeClr val="tx1"/>
+          </a:fontRef>
+        </p:style>
+      </p:cxnSp>
+      <p:cxnSp>
+        <p:nvCxnSpPr>
+          <p:cNvPr id="129" name="Straight Connector 128">
+            <a:extLst>
+              <a:ext uri="{FF2B5EF4-FFF2-40B4-BE49-F238E27FC236}">
+                <a16:creationId xmlns:a16="http://schemas.microsoft.com/office/drawing/2014/main" id="{A699BADB-3087-8E6C-0985-48AF47B6945E}"/>
+              </a:ext>
+            </a:extLst>
+          </p:cNvPr>
+          <p:cNvCxnSpPr>
+            <a:cxnSpLocks/>
+          </p:cNvCxnSpPr>
+          <p:nvPr/>
+        </p:nvCxnSpPr>
+        <p:spPr>
+          <a:xfrm rot="16200000" flipV="1">
+            <a:off x="5552919" y="2694413"/>
+            <a:ext cx="167220" cy="167220"/>
+          </a:xfrm>
+          <a:prstGeom prst="line">
+            <a:avLst/>
+          </a:prstGeom>
+          <a:ln>
+            <a:solidFill>
+              <a:schemeClr val="tx1"/>
+            </a:solidFill>
+          </a:ln>
+        </p:spPr>
+        <p:style>
+          <a:lnRef idx="2">
+            <a:schemeClr val="accent1"/>
+          </a:lnRef>
+          <a:fillRef idx="0">
+            <a:schemeClr val="accent1"/>
+          </a:fillRef>
+          <a:effectRef idx="1">
+            <a:schemeClr val="accent1"/>
+          </a:effectRef>
+          <a:fontRef idx="minor">
+            <a:schemeClr val="tx1"/>
+          </a:fontRef>
+        </p:style>
+      </p:cxnSp>
+      <p:sp>
+        <p:nvSpPr>
+          <p:cNvPr id="130" name="Oval 129">
+            <a:extLst>
+              <a:ext uri="{FF2B5EF4-FFF2-40B4-BE49-F238E27FC236}">
+                <a16:creationId xmlns:a16="http://schemas.microsoft.com/office/drawing/2014/main" id="{6A0C3341-0C2A-39AC-3749-911B77200102}"/>
+              </a:ext>
+            </a:extLst>
+          </p:cNvPr>
+          <p:cNvSpPr/>
+          <p:nvPr/>
+        </p:nvSpPr>
+        <p:spPr>
+          <a:xfrm>
+            <a:off x="5499321" y="2650783"/>
+            <a:ext cx="87313" cy="87313"/>
+          </a:xfrm>
+          <a:prstGeom prst="ellipse">
+            <a:avLst/>
+          </a:prstGeom>
+          <a:solidFill>
+            <a:schemeClr val="tx1"/>
+          </a:solidFill>
+          <a:ln>
+            <a:noFill/>
+          </a:ln>
+        </p:spPr>
+        <p:style>
+          <a:lnRef idx="2">
+            <a:schemeClr val="accent1">
+              <a:shade val="15000"/>
+            </a:schemeClr>
+          </a:lnRef>
+          <a:fillRef idx="1">
+            <a:schemeClr val="accent1"/>
+          </a:fillRef>
+          <a:effectRef idx="0">
+            <a:schemeClr val="accent1"/>
+          </a:effectRef>
+          <a:fontRef idx="minor">
+            <a:schemeClr val="lt1"/>
+          </a:fontRef>
+        </p:style>
+        <p:txBody>
+          <a:bodyPr rtlCol="0" anchor="ctr"/>
+          <a:lstStyle/>
+          <a:p>
+            <a:pPr algn="ctr"/>
+            <a:endParaRPr lang="en-US"/>
+          </a:p>
+        </p:txBody>
+      </p:sp>
+      <p:sp>
+        <p:nvSpPr>
+          <p:cNvPr id="131" name="Oval 130">
+            <a:extLst>
+              <a:ext uri="{FF2B5EF4-FFF2-40B4-BE49-F238E27FC236}">
+                <a16:creationId xmlns:a16="http://schemas.microsoft.com/office/drawing/2014/main" id="{66728416-D95C-7D7D-9326-53B1505594EE}"/>
+              </a:ext>
+            </a:extLst>
+          </p:cNvPr>
+          <p:cNvSpPr/>
+          <p:nvPr/>
+        </p:nvSpPr>
+        <p:spPr>
+          <a:xfrm>
+            <a:off x="5887218" y="2827328"/>
+            <a:ext cx="87313" cy="87313"/>
+          </a:xfrm>
+          <a:prstGeom prst="ellipse">
+            <a:avLst/>
+          </a:prstGeom>
+          <a:solidFill>
+            <a:schemeClr val="tx1"/>
+          </a:solidFill>
+          <a:ln>
+            <a:noFill/>
+          </a:ln>
+        </p:spPr>
+        <p:style>
+          <a:lnRef idx="2">
+            <a:schemeClr val="accent1">
+              <a:shade val="15000"/>
+            </a:schemeClr>
+          </a:lnRef>
+          <a:fillRef idx="1">
+            <a:schemeClr val="accent1"/>
+          </a:fillRef>
+          <a:effectRef idx="0">
+            <a:schemeClr val="accent1"/>
+          </a:effectRef>
+          <a:fontRef idx="minor">
+            <a:schemeClr val="lt1"/>
+          </a:fontRef>
+        </p:style>
+        <p:txBody>
+          <a:bodyPr rtlCol="0" anchor="ctr"/>
+          <a:lstStyle/>
+          <a:p>
+            <a:pPr algn="ctr"/>
+            <a:endParaRPr lang="en-US"/>
+          </a:p>
+        </p:txBody>
+      </p:sp>
+      <p:sp>
+        <p:nvSpPr>
+          <p:cNvPr id="132" name="Oval 131">
+            <a:extLst>
+              <a:ext uri="{FF2B5EF4-FFF2-40B4-BE49-F238E27FC236}">
+                <a16:creationId xmlns:a16="http://schemas.microsoft.com/office/drawing/2014/main" id="{4D549711-299F-D81A-E5CB-52C4BE2B78E4}"/>
+              </a:ext>
+            </a:extLst>
+          </p:cNvPr>
+          <p:cNvSpPr/>
+          <p:nvPr/>
+        </p:nvSpPr>
+        <p:spPr>
+          <a:xfrm>
+            <a:off x="6254107" y="2823438"/>
+            <a:ext cx="87313" cy="87313"/>
+          </a:xfrm>
+          <a:prstGeom prst="ellipse">
+            <a:avLst/>
+          </a:prstGeom>
+          <a:solidFill>
+            <a:schemeClr val="tx1"/>
+          </a:solidFill>
+          <a:ln>
+            <a:noFill/>
+          </a:ln>
+        </p:spPr>
+        <p:style>
+          <a:lnRef idx="2">
+            <a:schemeClr val="accent1">
+              <a:shade val="15000"/>
+            </a:schemeClr>
+          </a:lnRef>
+          <a:fillRef idx="1">
+            <a:schemeClr val="accent1"/>
+          </a:fillRef>
+          <a:effectRef idx="0">
+            <a:schemeClr val="accent1"/>
+          </a:effectRef>
+          <a:fontRef idx="minor">
+            <a:schemeClr val="lt1"/>
+          </a:fontRef>
+        </p:style>
+        <p:txBody>
+          <a:bodyPr rtlCol="0" anchor="ctr"/>
+          <a:lstStyle/>
+          <a:p>
+            <a:pPr algn="ctr"/>
+            <a:endParaRPr lang="en-US"/>
+          </a:p>
+        </p:txBody>
+      </p:sp>
+      <p:sp>
+        <p:nvSpPr>
+          <p:cNvPr id="133" name="Oval 132">
+            <a:extLst>
+              <a:ext uri="{FF2B5EF4-FFF2-40B4-BE49-F238E27FC236}">
+                <a16:creationId xmlns:a16="http://schemas.microsoft.com/office/drawing/2014/main" id="{FB60D273-7557-F8EB-F832-ADA15DDA9996}"/>
+              </a:ext>
+            </a:extLst>
+          </p:cNvPr>
+          <p:cNvSpPr/>
+          <p:nvPr/>
+        </p:nvSpPr>
+        <p:spPr>
+          <a:xfrm>
+            <a:off x="5887218" y="3193651"/>
+            <a:ext cx="87313" cy="87313"/>
+          </a:xfrm>
+          <a:prstGeom prst="ellipse">
+            <a:avLst/>
+          </a:prstGeom>
+          <a:solidFill>
+            <a:schemeClr val="tx1"/>
+          </a:solidFill>
+          <a:ln>
+            <a:noFill/>
+          </a:ln>
+        </p:spPr>
+        <p:style>
+          <a:lnRef idx="2">
+            <a:schemeClr val="accent1">
+              <a:shade val="15000"/>
+            </a:schemeClr>
+          </a:lnRef>
+          <a:fillRef idx="1">
+            <a:schemeClr val="accent1"/>
+          </a:fillRef>
+          <a:effectRef idx="0">
+            <a:schemeClr val="accent1"/>
+          </a:effectRef>
+          <a:fontRef idx="minor">
+            <a:schemeClr val="lt1"/>
+          </a:fontRef>
+        </p:style>
+        <p:txBody>
+          <a:bodyPr rtlCol="0" anchor="ctr"/>
+          <a:lstStyle/>
+          <a:p>
+            <a:pPr algn="ctr"/>
+            <a:endParaRPr lang="en-US" sz="1400"/>
+          </a:p>
+        </p:txBody>
+      </p:sp>
+      <p:sp>
+        <p:nvSpPr>
+          <p:cNvPr id="134" name="Oval 133">
+            <a:extLst>
+              <a:ext uri="{FF2B5EF4-FFF2-40B4-BE49-F238E27FC236}">
+                <a16:creationId xmlns:a16="http://schemas.microsoft.com/office/drawing/2014/main" id="{77F8AFC6-0898-6033-7D08-195419BC4509}"/>
+              </a:ext>
+            </a:extLst>
+          </p:cNvPr>
+          <p:cNvSpPr/>
+          <p:nvPr/>
+        </p:nvSpPr>
+        <p:spPr>
+          <a:xfrm>
+            <a:off x="6250712" y="3193650"/>
+            <a:ext cx="87313" cy="87313"/>
+          </a:xfrm>
+          <a:prstGeom prst="ellipse">
+            <a:avLst/>
+          </a:prstGeom>
+          <a:solidFill>
+            <a:schemeClr val="tx1"/>
+          </a:solidFill>
+          <a:ln>
+            <a:noFill/>
+          </a:ln>
+        </p:spPr>
+        <p:style>
+          <a:lnRef idx="2">
+            <a:schemeClr val="accent1">
+              <a:shade val="15000"/>
+            </a:schemeClr>
+          </a:lnRef>
+          <a:fillRef idx="1">
+            <a:schemeClr val="accent1"/>
+          </a:fillRef>
+          <a:effectRef idx="0">
+            <a:schemeClr val="accent1"/>
+          </a:effectRef>
+          <a:fontRef idx="minor">
+            <a:schemeClr val="lt1"/>
+          </a:fontRef>
+        </p:style>
+        <p:txBody>
+          <a:bodyPr rtlCol="0" anchor="ctr"/>
+          <a:lstStyle/>
+          <a:p>
+            <a:pPr algn="ctr"/>
+            <a:endParaRPr lang="en-US" sz="1400"/>
+          </a:p>
+        </p:txBody>
+      </p:sp>
+      <p:cxnSp>
+        <p:nvCxnSpPr>
+          <p:cNvPr id="135" name="Straight Connector 134">
+            <a:extLst>
+              <a:ext uri="{FF2B5EF4-FFF2-40B4-BE49-F238E27FC236}">
+                <a16:creationId xmlns:a16="http://schemas.microsoft.com/office/drawing/2014/main" id="{A7B9A8EF-80CA-F4D7-C073-327B0DFB9792}"/>
+              </a:ext>
+            </a:extLst>
+          </p:cNvPr>
+          <p:cNvCxnSpPr>
+            <a:cxnSpLocks/>
+          </p:cNvCxnSpPr>
+          <p:nvPr/>
+        </p:nvCxnSpPr>
+        <p:spPr>
+          <a:xfrm flipV="1">
+            <a:off x="5942496" y="2696254"/>
+            <a:ext cx="169933" cy="546212"/>
+          </a:xfrm>
+          <a:prstGeom prst="line">
+            <a:avLst/>
+          </a:prstGeom>
+          <a:ln>
+            <a:solidFill>
+              <a:schemeClr val="tx1"/>
+            </a:solidFill>
+          </a:ln>
+        </p:spPr>
+        <p:style>
+          <a:lnRef idx="2">
+            <a:schemeClr val="accent1"/>
+          </a:lnRef>
+          <a:fillRef idx="0">
+            <a:schemeClr val="accent1"/>
+          </a:fillRef>
+          <a:effectRef idx="1">
+            <a:schemeClr val="accent1"/>
+          </a:effectRef>
+          <a:fontRef idx="minor">
+            <a:schemeClr val="tx1"/>
+          </a:fontRef>
+        </p:style>
+      </p:cxnSp>
+      <p:cxnSp>
+        <p:nvCxnSpPr>
+          <p:cNvPr id="137" name="Straight Connector 136">
+            <a:extLst>
+              <a:ext uri="{FF2B5EF4-FFF2-40B4-BE49-F238E27FC236}">
+                <a16:creationId xmlns:a16="http://schemas.microsoft.com/office/drawing/2014/main" id="{5D96E96B-6259-FF2B-898D-C0DB6A3D0E90}"/>
+              </a:ext>
+            </a:extLst>
+          </p:cNvPr>
+          <p:cNvCxnSpPr>
+            <a:cxnSpLocks/>
+          </p:cNvCxnSpPr>
+          <p:nvPr/>
+        </p:nvCxnSpPr>
+        <p:spPr>
+          <a:xfrm flipV="1">
+            <a:off x="5935066" y="2874585"/>
+            <a:ext cx="0" cy="378954"/>
+          </a:xfrm>
+          <a:prstGeom prst="line">
+            <a:avLst/>
+          </a:prstGeom>
+          <a:ln>
+            <a:solidFill>
+              <a:schemeClr val="tx1"/>
+            </a:solidFill>
+          </a:ln>
+        </p:spPr>
+        <p:style>
+          <a:lnRef idx="2">
+            <a:schemeClr val="accent1"/>
+          </a:lnRef>
+          <a:fillRef idx="0">
+            <a:schemeClr val="accent1"/>
+          </a:fillRef>
+          <a:effectRef idx="1">
+            <a:schemeClr val="accent1"/>
+          </a:effectRef>
+          <a:fontRef idx="minor">
+            <a:schemeClr val="tx1"/>
+          </a:fontRef>
+        </p:style>
+      </p:cxnSp>
+      <p:cxnSp>
+        <p:nvCxnSpPr>
+          <p:cNvPr id="138" name="Straight Connector 137">
+            <a:extLst>
+              <a:ext uri="{FF2B5EF4-FFF2-40B4-BE49-F238E27FC236}">
+                <a16:creationId xmlns:a16="http://schemas.microsoft.com/office/drawing/2014/main" id="{C865B579-F321-1CF2-8D2B-410897ACACE5}"/>
+              </a:ext>
+            </a:extLst>
+          </p:cNvPr>
+          <p:cNvCxnSpPr>
+            <a:cxnSpLocks/>
+          </p:cNvCxnSpPr>
+          <p:nvPr/>
+        </p:nvCxnSpPr>
+        <p:spPr>
+          <a:xfrm flipV="1">
+            <a:off x="6299175" y="2865587"/>
+            <a:ext cx="0" cy="378954"/>
+          </a:xfrm>
+          <a:prstGeom prst="line">
+            <a:avLst/>
+          </a:prstGeom>
+          <a:ln>
+            <a:solidFill>
+              <a:schemeClr val="tx1"/>
+            </a:solidFill>
+          </a:ln>
+        </p:spPr>
+        <p:style>
+          <a:lnRef idx="2">
+            <a:schemeClr val="accent1"/>
+          </a:lnRef>
+          <a:fillRef idx="0">
+            <a:schemeClr val="accent1"/>
+          </a:fillRef>
+          <a:effectRef idx="1">
+            <a:schemeClr val="accent1"/>
+          </a:effectRef>
+          <a:fontRef idx="minor">
+            <a:schemeClr val="tx1"/>
+          </a:fontRef>
+        </p:style>
+      </p:cxnSp>
+      <p:cxnSp>
+        <p:nvCxnSpPr>
+          <p:cNvPr id="139" name="Straight Connector 138">
+            <a:extLst>
+              <a:ext uri="{FF2B5EF4-FFF2-40B4-BE49-F238E27FC236}">
+                <a16:creationId xmlns:a16="http://schemas.microsoft.com/office/drawing/2014/main" id="{E759C308-0FAF-645C-BCED-29AD11286589}"/>
+              </a:ext>
+            </a:extLst>
+          </p:cNvPr>
+          <p:cNvCxnSpPr>
+            <a:cxnSpLocks/>
+          </p:cNvCxnSpPr>
+          <p:nvPr/>
+        </p:nvCxnSpPr>
+        <p:spPr>
+          <a:xfrm flipH="1">
+            <a:off x="5959919" y="3236832"/>
+            <a:ext cx="355154" cy="0"/>
+          </a:xfrm>
+          <a:prstGeom prst="line">
+            <a:avLst/>
+          </a:prstGeom>
+          <a:ln>
+            <a:solidFill>
+              <a:schemeClr val="tx1"/>
+            </a:solidFill>
+          </a:ln>
+        </p:spPr>
+        <p:style>
+          <a:lnRef idx="2">
+            <a:schemeClr val="accent1"/>
+          </a:lnRef>
+          <a:fillRef idx="0">
+            <a:schemeClr val="accent1"/>
+          </a:fillRef>
+          <a:effectRef idx="1">
+            <a:schemeClr val="accent1"/>
+          </a:effectRef>
+          <a:fontRef idx="minor">
+            <a:schemeClr val="tx1"/>
+          </a:fontRef>
+        </p:style>
+      </p:cxnSp>
+      <p:cxnSp>
+        <p:nvCxnSpPr>
+          <p:cNvPr id="141" name="Straight Connector 140">
+            <a:extLst>
+              <a:ext uri="{FF2B5EF4-FFF2-40B4-BE49-F238E27FC236}">
+                <a16:creationId xmlns:a16="http://schemas.microsoft.com/office/drawing/2014/main" id="{57225781-FBC5-95C6-98E1-CF85C1B33EE6}"/>
+              </a:ext>
+            </a:extLst>
+          </p:cNvPr>
+          <p:cNvCxnSpPr>
+            <a:cxnSpLocks/>
+          </p:cNvCxnSpPr>
+          <p:nvPr/>
+        </p:nvCxnSpPr>
+        <p:spPr>
+          <a:xfrm flipV="1">
+            <a:off x="5929011" y="2698366"/>
+            <a:ext cx="167220" cy="167220"/>
+          </a:xfrm>
+          <a:prstGeom prst="line">
+            <a:avLst/>
+          </a:prstGeom>
+          <a:ln>
+            <a:solidFill>
+              <a:schemeClr val="tx1"/>
+            </a:solidFill>
+          </a:ln>
+        </p:spPr>
+        <p:style>
+          <a:lnRef idx="2">
+            <a:schemeClr val="accent1"/>
+          </a:lnRef>
+          <a:fillRef idx="0">
+            <a:schemeClr val="accent1"/>
+          </a:fillRef>
+          <a:effectRef idx="1">
+            <a:schemeClr val="accent1"/>
+          </a:effectRef>
+          <a:fontRef idx="minor">
+            <a:schemeClr val="tx1"/>
+          </a:fontRef>
+        </p:style>
+      </p:cxnSp>
+      <p:cxnSp>
+        <p:nvCxnSpPr>
+          <p:cNvPr id="142" name="Straight Connector 141">
+            <a:extLst>
+              <a:ext uri="{FF2B5EF4-FFF2-40B4-BE49-F238E27FC236}">
+                <a16:creationId xmlns:a16="http://schemas.microsoft.com/office/drawing/2014/main" id="{17D74BB7-C9E5-FECF-F5F9-2C7C2FC5A2FD}"/>
+              </a:ext>
+            </a:extLst>
+          </p:cNvPr>
+          <p:cNvCxnSpPr>
+            <a:cxnSpLocks/>
+          </p:cNvCxnSpPr>
+          <p:nvPr/>
+        </p:nvCxnSpPr>
+        <p:spPr>
+          <a:xfrm rot="16200000" flipV="1">
+            <a:off x="6123512" y="2694413"/>
+            <a:ext cx="167220" cy="167220"/>
+          </a:xfrm>
+          <a:prstGeom prst="line">
+            <a:avLst/>
+          </a:prstGeom>
+          <a:ln>
+            <a:solidFill>
+              <a:schemeClr val="tx1"/>
+            </a:solidFill>
+          </a:ln>
+        </p:spPr>
+        <p:style>
+          <a:lnRef idx="2">
+            <a:schemeClr val="accent1"/>
+          </a:lnRef>
+          <a:fillRef idx="0">
+            <a:schemeClr val="accent1"/>
+          </a:fillRef>
+          <a:effectRef idx="1">
+            <a:schemeClr val="accent1"/>
+          </a:effectRef>
+          <a:fontRef idx="minor">
+            <a:schemeClr val="tx1"/>
+          </a:fontRef>
+        </p:style>
+      </p:cxnSp>
+      <p:sp>
+        <p:nvSpPr>
+          <p:cNvPr id="143" name="Oval 142">
+            <a:extLst>
+              <a:ext uri="{FF2B5EF4-FFF2-40B4-BE49-F238E27FC236}">
+                <a16:creationId xmlns:a16="http://schemas.microsoft.com/office/drawing/2014/main" id="{3C1FB421-F880-BF62-D038-47B3D7E0C6AE}"/>
+              </a:ext>
+            </a:extLst>
+          </p:cNvPr>
+          <p:cNvSpPr/>
+          <p:nvPr/>
+        </p:nvSpPr>
+        <p:spPr>
+          <a:xfrm>
+            <a:off x="6069914" y="2650783"/>
+            <a:ext cx="87313" cy="87313"/>
+          </a:xfrm>
+          <a:prstGeom prst="ellipse">
+            <a:avLst/>
+          </a:prstGeom>
+          <a:solidFill>
+            <a:schemeClr val="tx1"/>
+          </a:solidFill>
+          <a:ln>
+            <a:noFill/>
+          </a:ln>
+        </p:spPr>
+        <p:style>
+          <a:lnRef idx="2">
+            <a:schemeClr val="accent1">
+              <a:shade val="15000"/>
+            </a:schemeClr>
+          </a:lnRef>
+          <a:fillRef idx="1">
+            <a:schemeClr val="accent1"/>
+          </a:fillRef>
+          <a:effectRef idx="0">
+            <a:schemeClr val="accent1"/>
+          </a:effectRef>
+          <a:fontRef idx="minor">
+            <a:schemeClr val="lt1"/>
+          </a:fontRef>
+        </p:style>
+        <p:txBody>
+          <a:bodyPr rtlCol="0" anchor="ctr"/>
+          <a:lstStyle/>
+          <a:p>
+            <a:pPr algn="ctr"/>
+            <a:endParaRPr lang="en-US"/>
+          </a:p>
+        </p:txBody>
+      </p:sp>
+      <p:sp>
+        <p:nvSpPr>
+          <p:cNvPr id="144" name="Oval 143">
+            <a:extLst>
+              <a:ext uri="{FF2B5EF4-FFF2-40B4-BE49-F238E27FC236}">
+                <a16:creationId xmlns:a16="http://schemas.microsoft.com/office/drawing/2014/main" id="{7298819B-8B21-D4F4-ADF4-F7B6C42130F5}"/>
+              </a:ext>
+            </a:extLst>
+          </p:cNvPr>
+          <p:cNvSpPr/>
+          <p:nvPr/>
+        </p:nvSpPr>
+        <p:spPr>
+          <a:xfrm>
+            <a:off x="6457811" y="2827328"/>
+            <a:ext cx="87313" cy="87313"/>
+          </a:xfrm>
+          <a:prstGeom prst="ellipse">
+            <a:avLst/>
+          </a:prstGeom>
+          <a:solidFill>
+            <a:schemeClr val="tx1"/>
+          </a:solidFill>
+          <a:ln>
+            <a:noFill/>
+          </a:ln>
+        </p:spPr>
+        <p:style>
+          <a:lnRef idx="2">
+            <a:schemeClr val="accent1">
+              <a:shade val="15000"/>
+            </a:schemeClr>
+          </a:lnRef>
+          <a:fillRef idx="1">
+            <a:schemeClr val="accent1"/>
+          </a:fillRef>
+          <a:effectRef idx="0">
+            <a:schemeClr val="accent1"/>
+          </a:effectRef>
+          <a:fontRef idx="minor">
+            <a:schemeClr val="lt1"/>
+          </a:fontRef>
+        </p:style>
+        <p:txBody>
+          <a:bodyPr rtlCol="0" anchor="ctr"/>
+          <a:lstStyle/>
+          <a:p>
+            <a:pPr algn="ctr"/>
+            <a:endParaRPr lang="en-US"/>
+          </a:p>
+        </p:txBody>
+      </p:sp>
+      <p:sp>
+        <p:nvSpPr>
+          <p:cNvPr id="145" name="Oval 144">
+            <a:extLst>
+              <a:ext uri="{FF2B5EF4-FFF2-40B4-BE49-F238E27FC236}">
+                <a16:creationId xmlns:a16="http://schemas.microsoft.com/office/drawing/2014/main" id="{C043BA34-32D0-1808-ECD5-514EB5C34BDC}"/>
+              </a:ext>
+            </a:extLst>
+          </p:cNvPr>
+          <p:cNvSpPr/>
+          <p:nvPr/>
+        </p:nvSpPr>
+        <p:spPr>
+          <a:xfrm>
+            <a:off x="6824700" y="2823438"/>
+            <a:ext cx="87313" cy="87313"/>
+          </a:xfrm>
+          <a:prstGeom prst="ellipse">
+            <a:avLst/>
+          </a:prstGeom>
+          <a:solidFill>
+            <a:schemeClr val="tx1"/>
+          </a:solidFill>
+          <a:ln>
+            <a:noFill/>
+          </a:ln>
+        </p:spPr>
+        <p:style>
+          <a:lnRef idx="2">
+            <a:schemeClr val="accent1">
+              <a:shade val="15000"/>
+            </a:schemeClr>
+          </a:lnRef>
+          <a:fillRef idx="1">
+            <a:schemeClr val="accent1"/>
+          </a:fillRef>
+          <a:effectRef idx="0">
+            <a:schemeClr val="accent1"/>
+          </a:effectRef>
+          <a:fontRef idx="minor">
+            <a:schemeClr val="lt1"/>
+          </a:fontRef>
+        </p:style>
+        <p:txBody>
+          <a:bodyPr rtlCol="0" anchor="ctr"/>
+          <a:lstStyle/>
+          <a:p>
+            <a:pPr algn="ctr"/>
+            <a:endParaRPr lang="en-US"/>
+          </a:p>
+        </p:txBody>
+      </p:sp>
+      <p:sp>
+        <p:nvSpPr>
+          <p:cNvPr id="146" name="Oval 145">
+            <a:extLst>
+              <a:ext uri="{FF2B5EF4-FFF2-40B4-BE49-F238E27FC236}">
+                <a16:creationId xmlns:a16="http://schemas.microsoft.com/office/drawing/2014/main" id="{BD1479AB-00B6-23EB-C32D-744BB1EA3106}"/>
+              </a:ext>
+            </a:extLst>
+          </p:cNvPr>
+          <p:cNvSpPr/>
+          <p:nvPr/>
+        </p:nvSpPr>
+        <p:spPr>
+          <a:xfrm>
+            <a:off x="6457811" y="3193651"/>
+            <a:ext cx="87313" cy="87313"/>
+          </a:xfrm>
+          <a:prstGeom prst="ellipse">
+            <a:avLst/>
+          </a:prstGeom>
+          <a:solidFill>
+            <a:schemeClr val="tx1"/>
+          </a:solidFill>
+          <a:ln>
+            <a:noFill/>
+          </a:ln>
+        </p:spPr>
+        <p:style>
+          <a:lnRef idx="2">
+            <a:schemeClr val="accent1">
+              <a:shade val="15000"/>
+            </a:schemeClr>
+          </a:lnRef>
+          <a:fillRef idx="1">
+            <a:schemeClr val="accent1"/>
+          </a:fillRef>
+          <a:effectRef idx="0">
+            <a:schemeClr val="accent1"/>
+          </a:effectRef>
+          <a:fontRef idx="minor">
+            <a:schemeClr val="lt1"/>
+          </a:fontRef>
+        </p:style>
+        <p:txBody>
+          <a:bodyPr rtlCol="0" anchor="ctr"/>
+          <a:lstStyle/>
+          <a:p>
+            <a:pPr algn="ctr"/>
+            <a:endParaRPr lang="en-US" sz="1400"/>
+          </a:p>
+        </p:txBody>
+      </p:sp>
+      <p:sp>
+        <p:nvSpPr>
+          <p:cNvPr id="147" name="Oval 146">
+            <a:extLst>
+              <a:ext uri="{FF2B5EF4-FFF2-40B4-BE49-F238E27FC236}">
+                <a16:creationId xmlns:a16="http://schemas.microsoft.com/office/drawing/2014/main" id="{7792B757-3625-62DB-B0BC-4500C9240A41}"/>
+              </a:ext>
+            </a:extLst>
+          </p:cNvPr>
+          <p:cNvSpPr/>
+          <p:nvPr/>
+        </p:nvSpPr>
+        <p:spPr>
+          <a:xfrm>
+            <a:off x="6821305" y="3193650"/>
+            <a:ext cx="87313" cy="87313"/>
+          </a:xfrm>
+          <a:prstGeom prst="ellipse">
+            <a:avLst/>
+          </a:prstGeom>
+          <a:solidFill>
+            <a:schemeClr val="tx1"/>
+          </a:solidFill>
+          <a:ln>
+            <a:noFill/>
+          </a:ln>
+        </p:spPr>
+        <p:style>
+          <a:lnRef idx="2">
+            <a:schemeClr val="accent1">
+              <a:shade val="15000"/>
+            </a:schemeClr>
+          </a:lnRef>
+          <a:fillRef idx="1">
+            <a:schemeClr val="accent1"/>
+          </a:fillRef>
+          <a:effectRef idx="0">
+            <a:schemeClr val="accent1"/>
+          </a:effectRef>
+          <a:fontRef idx="minor">
+            <a:schemeClr val="lt1"/>
+          </a:fontRef>
+        </p:style>
+        <p:txBody>
+          <a:bodyPr rtlCol="0" anchor="ctr"/>
+          <a:lstStyle/>
+          <a:p>
+            <a:pPr algn="ctr"/>
+            <a:endParaRPr lang="en-US" sz="1400"/>
+          </a:p>
+        </p:txBody>
+      </p:sp>
+      <p:cxnSp>
+        <p:nvCxnSpPr>
+          <p:cNvPr id="150" name="Straight Connector 149">
+            <a:extLst>
+              <a:ext uri="{FF2B5EF4-FFF2-40B4-BE49-F238E27FC236}">
+                <a16:creationId xmlns:a16="http://schemas.microsoft.com/office/drawing/2014/main" id="{CB9D6291-63B2-1DB9-C21E-B893FDF00CD7}"/>
+              </a:ext>
+            </a:extLst>
+          </p:cNvPr>
+          <p:cNvCxnSpPr>
+            <a:cxnSpLocks/>
+          </p:cNvCxnSpPr>
+          <p:nvPr/>
+        </p:nvCxnSpPr>
+        <p:spPr>
+          <a:xfrm flipV="1">
+            <a:off x="6505659" y="2874585"/>
+            <a:ext cx="0" cy="378954"/>
+          </a:xfrm>
+          <a:prstGeom prst="line">
+            <a:avLst/>
+          </a:prstGeom>
+          <a:ln>
+            <a:solidFill>
+              <a:schemeClr val="tx1"/>
+            </a:solidFill>
+          </a:ln>
+        </p:spPr>
+        <p:style>
+          <a:lnRef idx="2">
+            <a:schemeClr val="accent1"/>
+          </a:lnRef>
+          <a:fillRef idx="0">
+            <a:schemeClr val="accent1"/>
+          </a:fillRef>
+          <a:effectRef idx="1">
+            <a:schemeClr val="accent1"/>
+          </a:effectRef>
+          <a:fontRef idx="minor">
+            <a:schemeClr val="tx1"/>
+          </a:fontRef>
+        </p:style>
+      </p:cxnSp>
+      <p:cxnSp>
+        <p:nvCxnSpPr>
+          <p:cNvPr id="151" name="Straight Connector 150">
+            <a:extLst>
+              <a:ext uri="{FF2B5EF4-FFF2-40B4-BE49-F238E27FC236}">
+                <a16:creationId xmlns:a16="http://schemas.microsoft.com/office/drawing/2014/main" id="{E864E4E7-C8B6-8C26-F9D4-852AE4BD3B51}"/>
+              </a:ext>
+            </a:extLst>
+          </p:cNvPr>
+          <p:cNvCxnSpPr>
+            <a:cxnSpLocks/>
+          </p:cNvCxnSpPr>
+          <p:nvPr/>
+        </p:nvCxnSpPr>
+        <p:spPr>
+          <a:xfrm flipV="1">
+            <a:off x="6869768" y="2865587"/>
+            <a:ext cx="0" cy="378954"/>
+          </a:xfrm>
+          <a:prstGeom prst="line">
+            <a:avLst/>
+          </a:prstGeom>
+          <a:ln>
+            <a:solidFill>
+              <a:schemeClr val="tx1"/>
+            </a:solidFill>
+          </a:ln>
+        </p:spPr>
+        <p:style>
+          <a:lnRef idx="2">
+            <a:schemeClr val="accent1"/>
+          </a:lnRef>
+          <a:fillRef idx="0">
+            <a:schemeClr val="accent1"/>
+          </a:fillRef>
+          <a:effectRef idx="1">
+            <a:schemeClr val="accent1"/>
+          </a:effectRef>
+          <a:fontRef idx="minor">
+            <a:schemeClr val="tx1"/>
+          </a:fontRef>
+        </p:style>
+      </p:cxnSp>
+      <p:cxnSp>
+        <p:nvCxnSpPr>
+          <p:cNvPr id="152" name="Straight Connector 151">
+            <a:extLst>
+              <a:ext uri="{FF2B5EF4-FFF2-40B4-BE49-F238E27FC236}">
+                <a16:creationId xmlns:a16="http://schemas.microsoft.com/office/drawing/2014/main" id="{DE7B809C-D886-A235-E29D-3D5B1E780D67}"/>
+              </a:ext>
+            </a:extLst>
+          </p:cNvPr>
+          <p:cNvCxnSpPr>
+            <a:cxnSpLocks/>
+          </p:cNvCxnSpPr>
+          <p:nvPr/>
+        </p:nvCxnSpPr>
+        <p:spPr>
+          <a:xfrm flipH="1">
+            <a:off x="6530512" y="3236832"/>
+            <a:ext cx="355154" cy="0"/>
+          </a:xfrm>
+          <a:prstGeom prst="line">
+            <a:avLst/>
+          </a:prstGeom>
+          <a:ln>
+            <a:solidFill>
+              <a:schemeClr val="tx1"/>
+            </a:solidFill>
+          </a:ln>
+        </p:spPr>
+        <p:style>
+          <a:lnRef idx="2">
+            <a:schemeClr val="accent1"/>
+          </a:lnRef>
+          <a:fillRef idx="0">
+            <a:schemeClr val="accent1"/>
+          </a:fillRef>
+          <a:effectRef idx="1">
+            <a:schemeClr val="accent1"/>
+          </a:effectRef>
+          <a:fontRef idx="minor">
+            <a:schemeClr val="tx1"/>
+          </a:fontRef>
+        </p:style>
+      </p:cxnSp>
+      <p:cxnSp>
+        <p:nvCxnSpPr>
+          <p:cNvPr id="153" name="Straight Connector 152">
+            <a:extLst>
+              <a:ext uri="{FF2B5EF4-FFF2-40B4-BE49-F238E27FC236}">
+                <a16:creationId xmlns:a16="http://schemas.microsoft.com/office/drawing/2014/main" id="{D4A51DBE-683A-691A-65E6-128F42B47D63}"/>
+              </a:ext>
+            </a:extLst>
+          </p:cNvPr>
+          <p:cNvCxnSpPr>
+            <a:cxnSpLocks/>
+          </p:cNvCxnSpPr>
+          <p:nvPr/>
+        </p:nvCxnSpPr>
+        <p:spPr>
+          <a:xfrm flipH="1">
+            <a:off x="6495901" y="2874585"/>
+            <a:ext cx="355154" cy="0"/>
+          </a:xfrm>
+          <a:prstGeom prst="line">
+            <a:avLst/>
+          </a:prstGeom>
+          <a:ln>
+            <a:solidFill>
+              <a:schemeClr val="tx1"/>
+            </a:solidFill>
+          </a:ln>
+        </p:spPr>
+        <p:style>
+          <a:lnRef idx="2">
+            <a:schemeClr val="accent1"/>
+          </a:lnRef>
+          <a:fillRef idx="0">
+            <a:schemeClr val="accent1"/>
+          </a:fillRef>
+          <a:effectRef idx="1">
+            <a:schemeClr val="accent1"/>
+          </a:effectRef>
+          <a:fontRef idx="minor">
+            <a:schemeClr val="tx1"/>
+          </a:fontRef>
+        </p:style>
+      </p:cxnSp>
+      <p:cxnSp>
+        <p:nvCxnSpPr>
+          <p:cNvPr id="154" name="Straight Connector 153">
+            <a:extLst>
+              <a:ext uri="{FF2B5EF4-FFF2-40B4-BE49-F238E27FC236}">
+                <a16:creationId xmlns:a16="http://schemas.microsoft.com/office/drawing/2014/main" id="{5BB96F83-D1E8-A024-E120-0116C1E4281D}"/>
+              </a:ext>
+            </a:extLst>
+          </p:cNvPr>
+          <p:cNvCxnSpPr>
+            <a:cxnSpLocks/>
+          </p:cNvCxnSpPr>
+          <p:nvPr/>
+        </p:nvCxnSpPr>
+        <p:spPr>
+          <a:xfrm flipV="1">
+            <a:off x="6499604" y="2698366"/>
+            <a:ext cx="167220" cy="167220"/>
+          </a:xfrm>
+          <a:prstGeom prst="line">
+            <a:avLst/>
+          </a:prstGeom>
+          <a:ln>
+            <a:solidFill>
+              <a:schemeClr val="tx1"/>
+            </a:solidFill>
+          </a:ln>
+        </p:spPr>
+        <p:style>
+          <a:lnRef idx="2">
+            <a:schemeClr val="accent1"/>
+          </a:lnRef>
+          <a:fillRef idx="0">
+            <a:schemeClr val="accent1"/>
+          </a:fillRef>
+          <a:effectRef idx="1">
+            <a:schemeClr val="accent1"/>
+          </a:effectRef>
+          <a:fontRef idx="minor">
+            <a:schemeClr val="tx1"/>
+          </a:fontRef>
+        </p:style>
+      </p:cxnSp>
+      <p:cxnSp>
+        <p:nvCxnSpPr>
+          <p:cNvPr id="155" name="Straight Connector 154">
+            <a:extLst>
+              <a:ext uri="{FF2B5EF4-FFF2-40B4-BE49-F238E27FC236}">
+                <a16:creationId xmlns:a16="http://schemas.microsoft.com/office/drawing/2014/main" id="{41FE0CE7-C0B2-29D9-211F-C4B82614F657}"/>
+              </a:ext>
+            </a:extLst>
+          </p:cNvPr>
+          <p:cNvCxnSpPr>
+            <a:cxnSpLocks/>
+          </p:cNvCxnSpPr>
+          <p:nvPr/>
+        </p:nvCxnSpPr>
+        <p:spPr>
+          <a:xfrm rot="16200000" flipV="1">
+            <a:off x="6694105" y="2694413"/>
+            <a:ext cx="167220" cy="167220"/>
+          </a:xfrm>
+          <a:prstGeom prst="line">
+            <a:avLst/>
+          </a:prstGeom>
+          <a:ln>
+            <a:solidFill>
+              <a:schemeClr val="tx1"/>
+            </a:solidFill>
+          </a:ln>
+        </p:spPr>
+        <p:style>
+          <a:lnRef idx="2">
+            <a:schemeClr val="accent1"/>
+          </a:lnRef>
+          <a:fillRef idx="0">
+            <a:schemeClr val="accent1"/>
+          </a:fillRef>
+          <a:effectRef idx="1">
+            <a:schemeClr val="accent1"/>
+          </a:effectRef>
+          <a:fontRef idx="minor">
+            <a:schemeClr val="tx1"/>
+          </a:fontRef>
+        </p:style>
+      </p:cxnSp>
+      <p:sp>
+        <p:nvSpPr>
+          <p:cNvPr id="156" name="Oval 155">
+            <a:extLst>
+              <a:ext uri="{FF2B5EF4-FFF2-40B4-BE49-F238E27FC236}">
+                <a16:creationId xmlns:a16="http://schemas.microsoft.com/office/drawing/2014/main" id="{6FAAF2AC-748D-D62D-5E38-E18EEBC5CFFE}"/>
+              </a:ext>
+            </a:extLst>
+          </p:cNvPr>
+          <p:cNvSpPr/>
+          <p:nvPr/>
+        </p:nvSpPr>
+        <p:spPr>
+          <a:xfrm>
+            <a:off x="6640507" y="2650783"/>
+            <a:ext cx="87313" cy="87313"/>
+          </a:xfrm>
+          <a:prstGeom prst="ellipse">
+            <a:avLst/>
+          </a:prstGeom>
+          <a:solidFill>
+            <a:schemeClr val="tx1"/>
+          </a:solidFill>
+          <a:ln>
+            <a:noFill/>
+          </a:ln>
+        </p:spPr>
+        <p:style>
+          <a:lnRef idx="2">
+            <a:schemeClr val="accent1">
+              <a:shade val="15000"/>
+            </a:schemeClr>
+          </a:lnRef>
+          <a:fillRef idx="1">
+            <a:schemeClr val="accent1"/>
+          </a:fillRef>
+          <a:effectRef idx="0">
+            <a:schemeClr val="accent1"/>
+          </a:effectRef>
+          <a:fontRef idx="minor">
+            <a:schemeClr val="lt1"/>
+          </a:fontRef>
+        </p:style>
+        <p:txBody>
+          <a:bodyPr rtlCol="0" anchor="ctr"/>
+          <a:lstStyle/>
+          <a:p>
+            <a:pPr algn="ctr"/>
+            <a:endParaRPr lang="en-US"/>
+          </a:p>
+        </p:txBody>
+      </p:sp>
+      <p:sp>
+        <p:nvSpPr>
+          <p:cNvPr id="157" name="Oval 156">
+            <a:extLst>
+              <a:ext uri="{FF2B5EF4-FFF2-40B4-BE49-F238E27FC236}">
+                <a16:creationId xmlns:a16="http://schemas.microsoft.com/office/drawing/2014/main" id="{7FB0AC81-D743-4A97-FBD1-4D287D6CDF9C}"/>
+              </a:ext>
+            </a:extLst>
+          </p:cNvPr>
+          <p:cNvSpPr/>
+          <p:nvPr/>
+        </p:nvSpPr>
+        <p:spPr>
+          <a:xfrm>
+            <a:off x="7028404" y="2827328"/>
+            <a:ext cx="87313" cy="87313"/>
+          </a:xfrm>
+          <a:prstGeom prst="ellipse">
+            <a:avLst/>
+          </a:prstGeom>
+          <a:solidFill>
+            <a:schemeClr val="tx1"/>
+          </a:solidFill>
+          <a:ln>
+            <a:noFill/>
+          </a:ln>
+        </p:spPr>
+        <p:style>
+          <a:lnRef idx="2">
+            <a:schemeClr val="accent1">
+              <a:shade val="15000"/>
+            </a:schemeClr>
+          </a:lnRef>
+          <a:fillRef idx="1">
+            <a:schemeClr val="accent1"/>
+          </a:fillRef>
+          <a:effectRef idx="0">
+            <a:schemeClr val="accent1"/>
+          </a:effectRef>
+          <a:fontRef idx="minor">
+            <a:schemeClr val="lt1"/>
+          </a:fontRef>
+        </p:style>
+        <p:txBody>
+          <a:bodyPr rtlCol="0" anchor="ctr"/>
+          <a:lstStyle/>
+          <a:p>
+            <a:pPr algn="ctr"/>
+            <a:endParaRPr lang="en-US"/>
+          </a:p>
+        </p:txBody>
+      </p:sp>
+      <p:sp>
+        <p:nvSpPr>
+          <p:cNvPr id="158" name="Oval 157">
+            <a:extLst>
+              <a:ext uri="{FF2B5EF4-FFF2-40B4-BE49-F238E27FC236}">
+                <a16:creationId xmlns:a16="http://schemas.microsoft.com/office/drawing/2014/main" id="{FE5332D7-39DA-D13E-546D-1FCEFD136C43}"/>
+              </a:ext>
+            </a:extLst>
+          </p:cNvPr>
+          <p:cNvSpPr/>
+          <p:nvPr/>
+        </p:nvSpPr>
+        <p:spPr>
+          <a:xfrm>
+            <a:off x="7395293" y="2823438"/>
+            <a:ext cx="87313" cy="87313"/>
+          </a:xfrm>
+          <a:prstGeom prst="ellipse">
+            <a:avLst/>
+          </a:prstGeom>
+          <a:solidFill>
+            <a:schemeClr val="tx1"/>
+          </a:solidFill>
+          <a:ln>
+            <a:noFill/>
+          </a:ln>
+        </p:spPr>
+        <p:style>
+          <a:lnRef idx="2">
+            <a:schemeClr val="accent1">
+              <a:shade val="15000"/>
+            </a:schemeClr>
+          </a:lnRef>
+          <a:fillRef idx="1">
+            <a:schemeClr val="accent1"/>
+          </a:fillRef>
+          <a:effectRef idx="0">
+            <a:schemeClr val="accent1"/>
+          </a:effectRef>
+          <a:fontRef idx="minor">
+            <a:schemeClr val="lt1"/>
+          </a:fontRef>
+        </p:style>
+        <p:txBody>
+          <a:bodyPr rtlCol="0" anchor="ctr"/>
+          <a:lstStyle/>
+          <a:p>
+            <a:pPr algn="ctr"/>
+            <a:endParaRPr lang="en-US"/>
+          </a:p>
+        </p:txBody>
+      </p:sp>
+      <p:sp>
+        <p:nvSpPr>
+          <p:cNvPr id="159" name="Oval 158">
+            <a:extLst>
+              <a:ext uri="{FF2B5EF4-FFF2-40B4-BE49-F238E27FC236}">
+                <a16:creationId xmlns:a16="http://schemas.microsoft.com/office/drawing/2014/main" id="{A0F6884B-0A06-9575-B298-3CCEEB08E102}"/>
+              </a:ext>
+            </a:extLst>
+          </p:cNvPr>
+          <p:cNvSpPr/>
+          <p:nvPr/>
+        </p:nvSpPr>
+        <p:spPr>
+          <a:xfrm>
+            <a:off x="7028404" y="3193651"/>
+            <a:ext cx="87313" cy="87313"/>
+          </a:xfrm>
+          <a:prstGeom prst="ellipse">
+            <a:avLst/>
+          </a:prstGeom>
+          <a:solidFill>
+            <a:schemeClr val="tx1"/>
+          </a:solidFill>
+          <a:ln>
+            <a:noFill/>
+          </a:ln>
+        </p:spPr>
+        <p:style>
+          <a:lnRef idx="2">
+            <a:schemeClr val="accent1">
+              <a:shade val="15000"/>
+            </a:schemeClr>
+          </a:lnRef>
+          <a:fillRef idx="1">
+            <a:schemeClr val="accent1"/>
+          </a:fillRef>
+          <a:effectRef idx="0">
+            <a:schemeClr val="accent1"/>
+          </a:effectRef>
+          <a:fontRef idx="minor">
+            <a:schemeClr val="lt1"/>
+          </a:fontRef>
+        </p:style>
+        <p:txBody>
+          <a:bodyPr rtlCol="0" anchor="ctr"/>
+          <a:lstStyle/>
+          <a:p>
+            <a:pPr algn="ctr"/>
+            <a:endParaRPr lang="en-US" sz="1400"/>
+          </a:p>
+        </p:txBody>
+      </p:sp>
+      <p:sp>
+        <p:nvSpPr>
+          <p:cNvPr id="160" name="Oval 159">
+            <a:extLst>
+              <a:ext uri="{FF2B5EF4-FFF2-40B4-BE49-F238E27FC236}">
+                <a16:creationId xmlns:a16="http://schemas.microsoft.com/office/drawing/2014/main" id="{B5F570D5-FC08-3D5B-1EE2-6F274468CBE4}"/>
+              </a:ext>
+            </a:extLst>
+          </p:cNvPr>
+          <p:cNvSpPr/>
+          <p:nvPr/>
+        </p:nvSpPr>
+        <p:spPr>
+          <a:xfrm>
+            <a:off x="7391898" y="3193650"/>
+            <a:ext cx="87313" cy="87313"/>
+          </a:xfrm>
+          <a:prstGeom prst="ellipse">
+            <a:avLst/>
+          </a:prstGeom>
+          <a:solidFill>
+            <a:schemeClr val="tx1"/>
+          </a:solidFill>
+          <a:ln>
+            <a:noFill/>
+          </a:ln>
+        </p:spPr>
+        <p:style>
+          <a:lnRef idx="2">
+            <a:schemeClr val="accent1">
+              <a:shade val="15000"/>
+            </a:schemeClr>
+          </a:lnRef>
+          <a:fillRef idx="1">
+            <a:schemeClr val="accent1"/>
+          </a:fillRef>
+          <a:effectRef idx="0">
+            <a:schemeClr val="accent1"/>
+          </a:effectRef>
+          <a:fontRef idx="minor">
+            <a:schemeClr val="lt1"/>
+          </a:fontRef>
+        </p:style>
+        <p:txBody>
+          <a:bodyPr rtlCol="0" anchor="ctr"/>
+          <a:lstStyle/>
+          <a:p>
+            <a:pPr algn="ctr"/>
+            <a:endParaRPr lang="en-US" sz="1400"/>
+          </a:p>
+        </p:txBody>
+      </p:sp>
+      <p:cxnSp>
+        <p:nvCxnSpPr>
+          <p:cNvPr id="161" name="Straight Connector 160">
+            <a:extLst>
+              <a:ext uri="{FF2B5EF4-FFF2-40B4-BE49-F238E27FC236}">
+                <a16:creationId xmlns:a16="http://schemas.microsoft.com/office/drawing/2014/main" id="{07381E75-7C34-6950-9590-9DC6F4F3EDCF}"/>
+              </a:ext>
+            </a:extLst>
+          </p:cNvPr>
+          <p:cNvCxnSpPr>
+            <a:cxnSpLocks/>
+          </p:cNvCxnSpPr>
+          <p:nvPr/>
+        </p:nvCxnSpPr>
+        <p:spPr>
+          <a:xfrm flipV="1">
+            <a:off x="7078642" y="2865587"/>
+            <a:ext cx="361720" cy="361720"/>
+          </a:xfrm>
+          <a:prstGeom prst="line">
+            <a:avLst/>
+          </a:prstGeom>
+          <a:ln>
+            <a:solidFill>
+              <a:schemeClr val="tx1"/>
+            </a:solidFill>
+          </a:ln>
+        </p:spPr>
+        <p:style>
+          <a:lnRef idx="2">
+            <a:schemeClr val="accent1"/>
+          </a:lnRef>
+          <a:fillRef idx="0">
+            <a:schemeClr val="accent1"/>
+          </a:fillRef>
+          <a:effectRef idx="1">
+            <a:schemeClr val="accent1"/>
+          </a:effectRef>
+          <a:fontRef idx="minor">
+            <a:schemeClr val="tx1"/>
+          </a:fontRef>
+        </p:style>
+      </p:cxnSp>
+      <p:cxnSp>
+        <p:nvCxnSpPr>
+          <p:cNvPr id="162" name="Straight Connector 161">
+            <a:extLst>
+              <a:ext uri="{FF2B5EF4-FFF2-40B4-BE49-F238E27FC236}">
+                <a16:creationId xmlns:a16="http://schemas.microsoft.com/office/drawing/2014/main" id="{1B613E94-0651-1B19-7CCF-236261B3D468}"/>
+              </a:ext>
+            </a:extLst>
+          </p:cNvPr>
+          <p:cNvCxnSpPr>
+            <a:cxnSpLocks/>
+          </p:cNvCxnSpPr>
+          <p:nvPr/>
+        </p:nvCxnSpPr>
+        <p:spPr>
+          <a:xfrm rot="16200000" flipV="1">
+            <a:off x="7066494" y="2858353"/>
+            <a:ext cx="361720" cy="361720"/>
+          </a:xfrm>
+          <a:prstGeom prst="line">
+            <a:avLst/>
+          </a:prstGeom>
+          <a:ln>
+            <a:solidFill>
+              <a:schemeClr val="tx1"/>
+            </a:solidFill>
+          </a:ln>
+        </p:spPr>
+        <p:style>
+          <a:lnRef idx="2">
+            <a:schemeClr val="accent1"/>
+          </a:lnRef>
+          <a:fillRef idx="0">
+            <a:schemeClr val="accent1"/>
+          </a:fillRef>
+          <a:effectRef idx="1">
+            <a:schemeClr val="accent1"/>
+          </a:effectRef>
+          <a:fontRef idx="minor">
+            <a:schemeClr val="tx1"/>
+          </a:fontRef>
+        </p:style>
+      </p:cxnSp>
+      <p:cxnSp>
+        <p:nvCxnSpPr>
+          <p:cNvPr id="163" name="Straight Connector 162">
+            <a:extLst>
+              <a:ext uri="{FF2B5EF4-FFF2-40B4-BE49-F238E27FC236}">
+                <a16:creationId xmlns:a16="http://schemas.microsoft.com/office/drawing/2014/main" id="{C5C9AB81-99DC-B456-DBA0-30DF19DED3C4}"/>
+              </a:ext>
+            </a:extLst>
+          </p:cNvPr>
+          <p:cNvCxnSpPr>
+            <a:cxnSpLocks/>
+          </p:cNvCxnSpPr>
+          <p:nvPr/>
+        </p:nvCxnSpPr>
+        <p:spPr>
+          <a:xfrm flipV="1">
+            <a:off x="7076252" y="2874585"/>
+            <a:ext cx="0" cy="378954"/>
+          </a:xfrm>
+          <a:prstGeom prst="line">
+            <a:avLst/>
+          </a:prstGeom>
+          <a:ln>
+            <a:solidFill>
+              <a:schemeClr val="tx1"/>
+            </a:solidFill>
+          </a:ln>
+        </p:spPr>
+        <p:style>
+          <a:lnRef idx="2">
+            <a:schemeClr val="accent1"/>
+          </a:lnRef>
+          <a:fillRef idx="0">
+            <a:schemeClr val="accent1"/>
+          </a:fillRef>
+          <a:effectRef idx="1">
+            <a:schemeClr val="accent1"/>
+          </a:effectRef>
+          <a:fontRef idx="minor">
+            <a:schemeClr val="tx1"/>
+          </a:fontRef>
+        </p:style>
+      </p:cxnSp>
+      <p:cxnSp>
+        <p:nvCxnSpPr>
+          <p:cNvPr id="164" name="Straight Connector 163">
+            <a:extLst>
+              <a:ext uri="{FF2B5EF4-FFF2-40B4-BE49-F238E27FC236}">
+                <a16:creationId xmlns:a16="http://schemas.microsoft.com/office/drawing/2014/main" id="{683E2C4B-B34E-5636-BED9-3E9D0AC02DDD}"/>
+              </a:ext>
+            </a:extLst>
+          </p:cNvPr>
+          <p:cNvCxnSpPr>
+            <a:cxnSpLocks/>
+          </p:cNvCxnSpPr>
+          <p:nvPr/>
+        </p:nvCxnSpPr>
+        <p:spPr>
+          <a:xfrm flipV="1">
+            <a:off x="7440361" y="2865587"/>
+            <a:ext cx="0" cy="378954"/>
+          </a:xfrm>
+          <a:prstGeom prst="line">
+            <a:avLst/>
+          </a:prstGeom>
+          <a:ln>
+            <a:solidFill>
+              <a:schemeClr val="tx1"/>
+            </a:solidFill>
+          </a:ln>
+        </p:spPr>
+        <p:style>
+          <a:lnRef idx="2">
+            <a:schemeClr val="accent1"/>
+          </a:lnRef>
+          <a:fillRef idx="0">
+            <a:schemeClr val="accent1"/>
+          </a:fillRef>
+          <a:effectRef idx="1">
+            <a:schemeClr val="accent1"/>
+          </a:effectRef>
+          <a:fontRef idx="minor">
+            <a:schemeClr val="tx1"/>
+          </a:fontRef>
+        </p:style>
+      </p:cxnSp>
+      <p:cxnSp>
+        <p:nvCxnSpPr>
+          <p:cNvPr id="165" name="Straight Connector 164">
+            <a:extLst>
+              <a:ext uri="{FF2B5EF4-FFF2-40B4-BE49-F238E27FC236}">
+                <a16:creationId xmlns:a16="http://schemas.microsoft.com/office/drawing/2014/main" id="{99CE56B6-9EF1-D525-21A3-E6FFF275A4F3}"/>
+              </a:ext>
+            </a:extLst>
+          </p:cNvPr>
+          <p:cNvCxnSpPr>
+            <a:cxnSpLocks/>
+          </p:cNvCxnSpPr>
+          <p:nvPr/>
+        </p:nvCxnSpPr>
+        <p:spPr>
+          <a:xfrm flipH="1">
+            <a:off x="7101105" y="3236832"/>
+            <a:ext cx="355154" cy="0"/>
+          </a:xfrm>
+          <a:prstGeom prst="line">
+            <a:avLst/>
+          </a:prstGeom>
+          <a:ln>
+            <a:solidFill>
+              <a:schemeClr val="tx1"/>
+            </a:solidFill>
+          </a:ln>
+        </p:spPr>
+        <p:style>
+          <a:lnRef idx="2">
+            <a:schemeClr val="accent1"/>
+          </a:lnRef>
+          <a:fillRef idx="0">
+            <a:schemeClr val="accent1"/>
+          </a:fillRef>
+          <a:effectRef idx="1">
+            <a:schemeClr val="accent1"/>
+          </a:effectRef>
+          <a:fontRef idx="minor">
+            <a:schemeClr val="tx1"/>
+          </a:fontRef>
+        </p:style>
+      </p:cxnSp>
+      <p:cxnSp>
+        <p:nvCxnSpPr>
+          <p:cNvPr id="167" name="Straight Connector 166">
+            <a:extLst>
+              <a:ext uri="{FF2B5EF4-FFF2-40B4-BE49-F238E27FC236}">
+                <a16:creationId xmlns:a16="http://schemas.microsoft.com/office/drawing/2014/main" id="{0AE2F513-B249-2370-264B-E595D00191FA}"/>
+              </a:ext>
+            </a:extLst>
+          </p:cNvPr>
+          <p:cNvCxnSpPr>
+            <a:cxnSpLocks/>
+          </p:cNvCxnSpPr>
+          <p:nvPr/>
+        </p:nvCxnSpPr>
+        <p:spPr>
+          <a:xfrm flipV="1">
+            <a:off x="7070197" y="2698366"/>
+            <a:ext cx="167220" cy="167220"/>
+          </a:xfrm>
+          <a:prstGeom prst="line">
+            <a:avLst/>
+          </a:prstGeom>
+          <a:ln>
+            <a:solidFill>
+              <a:schemeClr val="tx1"/>
+            </a:solidFill>
+          </a:ln>
+        </p:spPr>
+        <p:style>
+          <a:lnRef idx="2">
+            <a:schemeClr val="accent1"/>
+          </a:lnRef>
+          <a:fillRef idx="0">
+            <a:schemeClr val="accent1"/>
+          </a:fillRef>
+          <a:effectRef idx="1">
+            <a:schemeClr val="accent1"/>
+          </a:effectRef>
+          <a:fontRef idx="minor">
+            <a:schemeClr val="tx1"/>
+          </a:fontRef>
+        </p:style>
+      </p:cxnSp>
+      <p:cxnSp>
+        <p:nvCxnSpPr>
+          <p:cNvPr id="168" name="Straight Connector 167">
+            <a:extLst>
+              <a:ext uri="{FF2B5EF4-FFF2-40B4-BE49-F238E27FC236}">
+                <a16:creationId xmlns:a16="http://schemas.microsoft.com/office/drawing/2014/main" id="{4C7C464C-338E-0397-3407-C7F829547726}"/>
+              </a:ext>
+            </a:extLst>
+          </p:cNvPr>
+          <p:cNvCxnSpPr>
+            <a:cxnSpLocks/>
+          </p:cNvCxnSpPr>
+          <p:nvPr/>
+        </p:nvCxnSpPr>
+        <p:spPr>
+          <a:xfrm rot="16200000" flipV="1">
+            <a:off x="7264698" y="2694413"/>
+            <a:ext cx="167220" cy="167220"/>
+          </a:xfrm>
+          <a:prstGeom prst="line">
+            <a:avLst/>
+          </a:prstGeom>
+          <a:ln>
+            <a:solidFill>
+              <a:schemeClr val="tx1"/>
+            </a:solidFill>
+          </a:ln>
+        </p:spPr>
+        <p:style>
+          <a:lnRef idx="2">
+            <a:schemeClr val="accent1"/>
+          </a:lnRef>
+          <a:fillRef idx="0">
+            <a:schemeClr val="accent1"/>
+          </a:fillRef>
+          <a:effectRef idx="1">
+            <a:schemeClr val="accent1"/>
+          </a:effectRef>
+          <a:fontRef idx="minor">
+            <a:schemeClr val="tx1"/>
+          </a:fontRef>
+        </p:style>
+      </p:cxnSp>
+      <p:sp>
+        <p:nvSpPr>
+          <p:cNvPr id="169" name="Oval 168">
+            <a:extLst>
+              <a:ext uri="{FF2B5EF4-FFF2-40B4-BE49-F238E27FC236}">
+                <a16:creationId xmlns:a16="http://schemas.microsoft.com/office/drawing/2014/main" id="{18C57FE8-A459-4BC5-D9A9-EAAC90F9D7C0}"/>
+              </a:ext>
+            </a:extLst>
+          </p:cNvPr>
+          <p:cNvSpPr/>
+          <p:nvPr/>
+        </p:nvSpPr>
+        <p:spPr>
+          <a:xfrm>
+            <a:off x="7211100" y="2650783"/>
+            <a:ext cx="87313" cy="87313"/>
+          </a:xfrm>
+          <a:prstGeom prst="ellipse">
+            <a:avLst/>
+          </a:prstGeom>
+          <a:solidFill>
+            <a:schemeClr val="tx1"/>
+          </a:solidFill>
+          <a:ln>
+            <a:noFill/>
+          </a:ln>
+        </p:spPr>
+        <p:style>
+          <a:lnRef idx="2">
+            <a:schemeClr val="accent1">
+              <a:shade val="15000"/>
+            </a:schemeClr>
+          </a:lnRef>
+          <a:fillRef idx="1">
+            <a:schemeClr val="accent1"/>
+          </a:fillRef>
+          <a:effectRef idx="0">
+            <a:schemeClr val="accent1"/>
+          </a:effectRef>
+          <a:fontRef idx="minor">
+            <a:schemeClr val="lt1"/>
+          </a:fontRef>
+        </p:style>
+        <p:txBody>
+          <a:bodyPr rtlCol="0" anchor="ctr"/>
+          <a:lstStyle/>
+          <a:p>
+            <a:pPr algn="ctr"/>
+            <a:endParaRPr lang="en-US"/>
+          </a:p>
+        </p:txBody>
+      </p:sp>
+      <p:cxnSp>
+        <p:nvCxnSpPr>
+          <p:cNvPr id="173" name="Straight Connector 172">
+            <a:extLst>
+              <a:ext uri="{FF2B5EF4-FFF2-40B4-BE49-F238E27FC236}">
+                <a16:creationId xmlns:a16="http://schemas.microsoft.com/office/drawing/2014/main" id="{DBE27B40-33EE-751A-3A06-84FC31F4F3C2}"/>
+              </a:ext>
+            </a:extLst>
+          </p:cNvPr>
+          <p:cNvCxnSpPr>
+            <a:cxnSpLocks/>
+          </p:cNvCxnSpPr>
+          <p:nvPr/>
+        </p:nvCxnSpPr>
+        <p:spPr>
+          <a:xfrm>
+            <a:off x="6114761" y="2695495"/>
+            <a:ext cx="180975" cy="546100"/>
+          </a:xfrm>
+          <a:prstGeom prst="line">
+            <a:avLst/>
+          </a:prstGeom>
+          <a:ln>
+            <a:solidFill>
+              <a:schemeClr val="tx1"/>
+            </a:solidFill>
+          </a:ln>
+        </p:spPr>
+        <p:style>
+          <a:lnRef idx="2">
+            <a:schemeClr val="accent1"/>
+          </a:lnRef>
+          <a:fillRef idx="0">
+            <a:schemeClr val="accent1"/>
+          </a:fillRef>
+          <a:effectRef idx="1">
+            <a:schemeClr val="accent1"/>
+          </a:effectRef>
+          <a:fontRef idx="minor">
+            <a:schemeClr val="tx1"/>
+          </a:fontRef>
+        </p:style>
+      </p:cxnSp>
+      <p:cxnSp>
+        <p:nvCxnSpPr>
+          <p:cNvPr id="194" name="Straight Connector 193">
+            <a:extLst>
+              <a:ext uri="{FF2B5EF4-FFF2-40B4-BE49-F238E27FC236}">
+                <a16:creationId xmlns:a16="http://schemas.microsoft.com/office/drawing/2014/main" id="{37D35CE0-BE9D-8524-2B8F-56F3069F3744}"/>
+              </a:ext>
+            </a:extLst>
+          </p:cNvPr>
+          <p:cNvCxnSpPr>
+            <a:cxnSpLocks/>
+          </p:cNvCxnSpPr>
+          <p:nvPr/>
+        </p:nvCxnSpPr>
+        <p:spPr>
+          <a:xfrm flipV="1">
+            <a:off x="6513931" y="2708198"/>
+            <a:ext cx="169933" cy="546212"/>
+          </a:xfrm>
+          <a:prstGeom prst="line">
+            <a:avLst/>
+          </a:prstGeom>
+          <a:ln>
+            <a:solidFill>
+              <a:schemeClr val="tx1"/>
+            </a:solidFill>
+          </a:ln>
+        </p:spPr>
+        <p:style>
+          <a:lnRef idx="2">
+            <a:schemeClr val="accent1"/>
+          </a:lnRef>
+          <a:fillRef idx="0">
+            <a:schemeClr val="accent1"/>
+          </a:fillRef>
+          <a:effectRef idx="1">
+            <a:schemeClr val="accent1"/>
+          </a:effectRef>
+          <a:fontRef idx="minor">
+            <a:schemeClr val="tx1"/>
+          </a:fontRef>
+        </p:style>
+      </p:cxnSp>
+      <p:cxnSp>
+        <p:nvCxnSpPr>
+          <p:cNvPr id="195" name="Straight Connector 194">
+            <a:extLst>
+              <a:ext uri="{FF2B5EF4-FFF2-40B4-BE49-F238E27FC236}">
+                <a16:creationId xmlns:a16="http://schemas.microsoft.com/office/drawing/2014/main" id="{FD1AE621-938A-B7B5-64CF-0C8230795261}"/>
+              </a:ext>
+            </a:extLst>
+          </p:cNvPr>
+          <p:cNvCxnSpPr>
+            <a:cxnSpLocks/>
+          </p:cNvCxnSpPr>
+          <p:nvPr/>
+        </p:nvCxnSpPr>
+        <p:spPr>
+          <a:xfrm>
+            <a:off x="6686196" y="2707439"/>
+            <a:ext cx="180975" cy="546100"/>
+          </a:xfrm>
+          <a:prstGeom prst="line">
+            <a:avLst/>
+          </a:prstGeom>
+          <a:ln>
+            <a:solidFill>
+              <a:schemeClr val="tx1"/>
+            </a:solidFill>
+          </a:ln>
+        </p:spPr>
+        <p:style>
+          <a:lnRef idx="2">
+            <a:schemeClr val="accent1"/>
+          </a:lnRef>
+          <a:fillRef idx="0">
+            <a:schemeClr val="accent1"/>
+          </a:fillRef>
+          <a:effectRef idx="1">
+            <a:schemeClr val="accent1"/>
+          </a:effectRef>
+          <a:fontRef idx="minor">
+            <a:schemeClr val="tx1"/>
+          </a:fontRef>
+        </p:style>
+      </p:cxnSp>
+      <p:cxnSp>
+        <p:nvCxnSpPr>
+          <p:cNvPr id="196" name="Straight Connector 195">
+            <a:extLst>
+              <a:ext uri="{FF2B5EF4-FFF2-40B4-BE49-F238E27FC236}">
+                <a16:creationId xmlns:a16="http://schemas.microsoft.com/office/drawing/2014/main" id="{9952929E-5F6C-3B88-0D73-D4F4426043CE}"/>
+              </a:ext>
+            </a:extLst>
+          </p:cNvPr>
+          <p:cNvCxnSpPr>
+            <a:cxnSpLocks/>
+          </p:cNvCxnSpPr>
+          <p:nvPr/>
+        </p:nvCxnSpPr>
+        <p:spPr>
+          <a:xfrm flipV="1">
+            <a:off x="7080222" y="2691491"/>
+            <a:ext cx="169933" cy="546212"/>
+          </a:xfrm>
+          <a:prstGeom prst="line">
+            <a:avLst/>
+          </a:prstGeom>
+          <a:ln>
+            <a:solidFill>
+              <a:schemeClr val="tx1"/>
+            </a:solidFill>
+          </a:ln>
+        </p:spPr>
+        <p:style>
+          <a:lnRef idx="2">
+            <a:schemeClr val="accent1"/>
+          </a:lnRef>
+          <a:fillRef idx="0">
+            <a:schemeClr val="accent1"/>
+          </a:fillRef>
+          <a:effectRef idx="1">
+            <a:schemeClr val="accent1"/>
+          </a:effectRef>
+          <a:fontRef idx="minor">
+            <a:schemeClr val="tx1"/>
+          </a:fontRef>
+        </p:style>
+      </p:cxnSp>
+      <p:cxnSp>
+        <p:nvCxnSpPr>
+          <p:cNvPr id="197" name="Straight Connector 196">
+            <a:extLst>
+              <a:ext uri="{FF2B5EF4-FFF2-40B4-BE49-F238E27FC236}">
+                <a16:creationId xmlns:a16="http://schemas.microsoft.com/office/drawing/2014/main" id="{EC30C0E2-99FF-4AF4-8F3A-28A5C23A5E63}"/>
+              </a:ext>
+            </a:extLst>
+          </p:cNvPr>
+          <p:cNvCxnSpPr>
+            <a:cxnSpLocks/>
+          </p:cNvCxnSpPr>
+          <p:nvPr/>
+        </p:nvCxnSpPr>
+        <p:spPr>
+          <a:xfrm>
+            <a:off x="7252487" y="2690732"/>
+            <a:ext cx="180975" cy="546100"/>
+          </a:xfrm>
+          <a:prstGeom prst="line">
+            <a:avLst/>
+          </a:prstGeom>
+          <a:ln>
+            <a:solidFill>
+              <a:schemeClr val="tx1"/>
+            </a:solidFill>
+          </a:ln>
+        </p:spPr>
+        <p:style>
+          <a:lnRef idx="2">
+            <a:schemeClr val="accent1"/>
+          </a:lnRef>
+          <a:fillRef idx="0">
+            <a:schemeClr val="accent1"/>
+          </a:fillRef>
+          <a:effectRef idx="1">
+            <a:schemeClr val="accent1"/>
+          </a:effectRef>
+          <a:fontRef idx="minor">
+            <a:schemeClr val="tx1"/>
+          </a:fontRef>
+        </p:style>
+      </p:cxnSp>
     </p:spTree>
     <p:extLst>
       <p:ext uri="{BB962C8B-B14F-4D97-AF65-F5344CB8AC3E}">

</xml_diff>

<commit_message>
auto commit 2026-08-26 14:55:57
</commit_message>
<xml_diff>
--- a/revision.pptx
+++ b/revision.pptx
@@ -36,12 +36,14 @@
     <p:sldId id="277" r:id="rId30"/>
     <p:sldId id="292" r:id="rId31"/>
     <p:sldId id="282" r:id="rId32"/>
-    <p:sldId id="278" r:id="rId33"/>
-    <p:sldId id="279" r:id="rId34"/>
-    <p:sldId id="293" r:id="rId35"/>
-    <p:sldId id="294" r:id="rId36"/>
-    <p:sldId id="299" r:id="rId37"/>
-    <p:sldId id="298" r:id="rId38"/>
+    <p:sldId id="300" r:id="rId33"/>
+    <p:sldId id="301" r:id="rId34"/>
+    <p:sldId id="278" r:id="rId35"/>
+    <p:sldId id="279" r:id="rId36"/>
+    <p:sldId id="293" r:id="rId37"/>
+    <p:sldId id="294" r:id="rId38"/>
+    <p:sldId id="299" r:id="rId39"/>
+    <p:sldId id="298" r:id="rId40"/>
   </p:sldIdLst>
   <p:sldSz cx="12192000" cy="6858000"/>
   <p:notesSz cx="6858000" cy="9144000"/>
@@ -295,7 +297,7 @@
           <a:p>
             <a:fld id="{6F584DAC-AA37-8C49-B5B6-53E9519E19BB}" type="datetimeFigureOut">
               <a:rPr lang="en-US" smtClean="0"/>
-              <a:t>8/14/26</a:t>
+              <a:t>8/25/26</a:t>
             </a:fld>
             <a:endParaRPr lang="en-US"/>
           </a:p>
@@ -493,7 +495,7 @@
           <a:p>
             <a:fld id="{6F584DAC-AA37-8C49-B5B6-53E9519E19BB}" type="datetimeFigureOut">
               <a:rPr lang="en-US" smtClean="0"/>
-              <a:t>8/14/26</a:t>
+              <a:t>8/25/26</a:t>
             </a:fld>
             <a:endParaRPr lang="en-US"/>
           </a:p>
@@ -701,7 +703,7 @@
           <a:p>
             <a:fld id="{6F584DAC-AA37-8C49-B5B6-53E9519E19BB}" type="datetimeFigureOut">
               <a:rPr lang="en-US" smtClean="0"/>
-              <a:t>8/14/26</a:t>
+              <a:t>8/25/26</a:t>
             </a:fld>
             <a:endParaRPr lang="en-US"/>
           </a:p>
@@ -899,7 +901,7 @@
           <a:p>
             <a:fld id="{6F584DAC-AA37-8C49-B5B6-53E9519E19BB}" type="datetimeFigureOut">
               <a:rPr lang="en-US" smtClean="0"/>
-              <a:t>8/14/26</a:t>
+              <a:t>8/25/26</a:t>
             </a:fld>
             <a:endParaRPr lang="en-US"/>
           </a:p>
@@ -1174,7 +1176,7 @@
           <a:p>
             <a:fld id="{6F584DAC-AA37-8C49-B5B6-53E9519E19BB}" type="datetimeFigureOut">
               <a:rPr lang="en-US" smtClean="0"/>
-              <a:t>8/14/26</a:t>
+              <a:t>8/25/26</a:t>
             </a:fld>
             <a:endParaRPr lang="en-US"/>
           </a:p>
@@ -1439,7 +1441,7 @@
           <a:p>
             <a:fld id="{6F584DAC-AA37-8C49-B5B6-53E9519E19BB}" type="datetimeFigureOut">
               <a:rPr lang="en-US" smtClean="0"/>
-              <a:t>8/14/26</a:t>
+              <a:t>8/25/26</a:t>
             </a:fld>
             <a:endParaRPr lang="en-US"/>
           </a:p>
@@ -1851,7 +1853,7 @@
           <a:p>
             <a:fld id="{6F584DAC-AA37-8C49-B5B6-53E9519E19BB}" type="datetimeFigureOut">
               <a:rPr lang="en-US" smtClean="0"/>
-              <a:t>8/14/26</a:t>
+              <a:t>8/25/26</a:t>
             </a:fld>
             <a:endParaRPr lang="en-US"/>
           </a:p>
@@ -1992,7 +1994,7 @@
           <a:p>
             <a:fld id="{6F584DAC-AA37-8C49-B5B6-53E9519E19BB}" type="datetimeFigureOut">
               <a:rPr lang="en-US" smtClean="0"/>
-              <a:t>8/14/26</a:t>
+              <a:t>8/25/26</a:t>
             </a:fld>
             <a:endParaRPr lang="en-US"/>
           </a:p>
@@ -2105,7 +2107,7 @@
           <a:p>
             <a:fld id="{6F584DAC-AA37-8C49-B5B6-53E9519E19BB}" type="datetimeFigureOut">
               <a:rPr lang="en-US" smtClean="0"/>
-              <a:t>8/14/26</a:t>
+              <a:t>8/25/26</a:t>
             </a:fld>
             <a:endParaRPr lang="en-US"/>
           </a:p>
@@ -2416,7 +2418,7 @@
           <a:p>
             <a:fld id="{6F584DAC-AA37-8C49-B5B6-53E9519E19BB}" type="datetimeFigureOut">
               <a:rPr lang="en-US" smtClean="0"/>
-              <a:t>8/14/26</a:t>
+              <a:t>8/25/26</a:t>
             </a:fld>
             <a:endParaRPr lang="en-US"/>
           </a:p>
@@ -2704,7 +2706,7 @@
           <a:p>
             <a:fld id="{6F584DAC-AA37-8C49-B5B6-53E9519E19BB}" type="datetimeFigureOut">
               <a:rPr lang="en-US" smtClean="0"/>
-              <a:t>8/14/26</a:t>
+              <a:t>8/25/26</a:t>
             </a:fld>
             <a:endParaRPr lang="en-US"/>
           </a:p>
@@ -2945,7 +2947,7 @@
           <a:p>
             <a:fld id="{6F584DAC-AA37-8C49-B5B6-53E9519E19BB}" type="datetimeFigureOut">
               <a:rPr lang="en-US" smtClean="0"/>
-              <a:t>8/14/26</a:t>
+              <a:t>8/25/26</a:t>
             </a:fld>
             <a:endParaRPr lang="en-US"/>
           </a:p>
@@ -12016,6 +12018,293 @@
           <p:cNvPr id="2" name="Title 1">
             <a:extLst>
               <a:ext uri="{FF2B5EF4-FFF2-40B4-BE49-F238E27FC236}">
+                <a16:creationId xmlns:a16="http://schemas.microsoft.com/office/drawing/2014/main" id="{8207E6D5-C13B-ABA3-AB7C-D12C7374BFDC}"/>
+              </a:ext>
+            </a:extLst>
+          </p:cNvPr>
+          <p:cNvSpPr>
+            <a:spLocks noGrp="1"/>
+          </p:cNvSpPr>
+          <p:nvPr>
+            <p:ph type="title"/>
+          </p:nvPr>
+        </p:nvSpPr>
+        <p:spPr/>
+        <p:txBody>
+          <a:bodyPr/>
+          <a:lstStyle/>
+          <a:p>
+            <a:r>
+              <a:rPr lang="en-US" dirty="0"/>
+              <a:t>QC Task</a:t>
+            </a:r>
+          </a:p>
+        </p:txBody>
+      </p:sp>
+      <p:pic>
+        <p:nvPicPr>
+          <p:cNvPr id="4" name="Content Placeholder 3">
+            <a:extLst>
+              <a:ext uri="{FF2B5EF4-FFF2-40B4-BE49-F238E27FC236}">
+                <a16:creationId xmlns:a16="http://schemas.microsoft.com/office/drawing/2014/main" id="{AF4CDF9A-4B61-08FC-4F2D-FFD1C32EA981}"/>
+              </a:ext>
+            </a:extLst>
+          </p:cNvPr>
+          <p:cNvPicPr>
+            <a:picLocks noGrp="1" noChangeAspect="1"/>
+          </p:cNvPicPr>
+          <p:nvPr>
+            <p:ph idx="1"/>
+          </p:nvPr>
+        </p:nvPicPr>
+        <p:blipFill>
+          <a:blip r:embed="rId2"/>
+          <a:stretch>
+            <a:fillRect/>
+          </a:stretch>
+        </p:blipFill>
+        <p:spPr>
+          <a:xfrm>
+            <a:off x="1154849" y="1915090"/>
+            <a:ext cx="3340100" cy="3606800"/>
+          </a:xfrm>
+          <a:prstGeom prst="rect">
+            <a:avLst/>
+          </a:prstGeom>
+        </p:spPr>
+      </p:pic>
+      <p:sp>
+        <p:nvSpPr>
+          <p:cNvPr id="5" name="TextBox 4">
+            <a:extLst>
+              <a:ext uri="{FF2B5EF4-FFF2-40B4-BE49-F238E27FC236}">
+                <a16:creationId xmlns:a16="http://schemas.microsoft.com/office/drawing/2014/main" id="{CC379DAD-AD90-0C8D-5DAD-5A0693CE354E}"/>
+              </a:ext>
+            </a:extLst>
+          </p:cNvPr>
+          <p:cNvSpPr txBox="1"/>
+          <p:nvPr/>
+        </p:nvSpPr>
+        <p:spPr>
+          <a:xfrm>
+            <a:off x="5656083" y="2224726"/>
+            <a:ext cx="4600280" cy="646331"/>
+          </a:xfrm>
+          <a:prstGeom prst="rect">
+            <a:avLst/>
+          </a:prstGeom>
+          <a:noFill/>
+        </p:spPr>
+        <p:txBody>
+          <a:bodyPr wrap="square" rtlCol="0">
+            <a:spAutoFit/>
+          </a:bodyPr>
+          <a:lstStyle/>
+          <a:p>
+            <a:r>
+              <a:rPr lang="en-US" dirty="0"/>
+              <a:t>This is the task structure used by both original and current  implementation.</a:t>
+            </a:r>
+          </a:p>
+        </p:txBody>
+      </p:sp>
+    </p:spTree>
+    <p:extLst>
+      <p:ext uri="{BB962C8B-B14F-4D97-AF65-F5344CB8AC3E}">
+        <p14:creationId xmlns:p14="http://schemas.microsoft.com/office/powerpoint/2010/main" val="3263841427"/>
+      </p:ext>
+    </p:extLst>
+  </p:cSld>
+  <p:clrMapOvr>
+    <a:masterClrMapping/>
+  </p:clrMapOvr>
+</p:sld>
+</file>
+
+<file path=ppt/slides/slide33.xml><?xml version="1.0" encoding="utf-8"?>
+<p:sld xmlns:a="http://schemas.openxmlformats.org/drawingml/2006/main" xmlns:r="http://schemas.openxmlformats.org/officeDocument/2006/relationships" xmlns:p="http://schemas.openxmlformats.org/presentationml/2006/main">
+  <p:cSld>
+    <p:spTree>
+      <p:nvGrpSpPr>
+        <p:cNvPr id="1" name=""/>
+        <p:cNvGrpSpPr/>
+        <p:nvPr/>
+      </p:nvGrpSpPr>
+      <p:grpSpPr>
+        <a:xfrm>
+          <a:off x="0" y="0"/>
+          <a:ext cx="0" cy="0"/>
+          <a:chOff x="0" y="0"/>
+          <a:chExt cx="0" cy="0"/>
+        </a:xfrm>
+      </p:grpSpPr>
+      <p:sp>
+        <p:nvSpPr>
+          <p:cNvPr id="2" name="Title 1">
+            <a:extLst>
+              <a:ext uri="{FF2B5EF4-FFF2-40B4-BE49-F238E27FC236}">
+                <a16:creationId xmlns:a16="http://schemas.microsoft.com/office/drawing/2014/main" id="{B1A4D47B-08FA-4C4B-2A7F-6C4FBEF1BD3C}"/>
+              </a:ext>
+            </a:extLst>
+          </p:cNvPr>
+          <p:cNvSpPr>
+            <a:spLocks noGrp="1"/>
+          </p:cNvSpPr>
+          <p:nvPr>
+            <p:ph type="title"/>
+          </p:nvPr>
+        </p:nvSpPr>
+        <p:spPr/>
+        <p:txBody>
+          <a:bodyPr/>
+          <a:lstStyle/>
+          <a:p>
+            <a:r>
+              <a:rPr lang="en-US" dirty="0"/>
+              <a:t>Task Expansion</a:t>
+            </a:r>
+          </a:p>
+        </p:txBody>
+      </p:sp>
+      <p:pic>
+        <p:nvPicPr>
+          <p:cNvPr id="5" name="Content Placeholder 4">
+            <a:extLst>
+              <a:ext uri="{FF2B5EF4-FFF2-40B4-BE49-F238E27FC236}">
+                <a16:creationId xmlns:a16="http://schemas.microsoft.com/office/drawing/2014/main" id="{0981A931-398B-F352-0F3E-468753DC57D0}"/>
+              </a:ext>
+            </a:extLst>
+          </p:cNvPr>
+          <p:cNvPicPr>
+            <a:picLocks noGrp="1" noChangeAspect="1"/>
+          </p:cNvPicPr>
+          <p:nvPr>
+            <p:ph idx="1"/>
+          </p:nvPr>
+        </p:nvPicPr>
+        <p:blipFill>
+          <a:blip r:embed="rId2"/>
+          <a:stretch>
+            <a:fillRect/>
+          </a:stretch>
+        </p:blipFill>
+        <p:spPr>
+          <a:xfrm>
+            <a:off x="838200" y="1571102"/>
+            <a:ext cx="4818366" cy="4351338"/>
+          </a:xfrm>
+          <a:prstGeom prst="rect">
+            <a:avLst/>
+          </a:prstGeom>
+        </p:spPr>
+      </p:pic>
+      <p:sp>
+        <p:nvSpPr>
+          <p:cNvPr id="6" name="TextBox 5">
+            <a:extLst>
+              <a:ext uri="{FF2B5EF4-FFF2-40B4-BE49-F238E27FC236}">
+                <a16:creationId xmlns:a16="http://schemas.microsoft.com/office/drawing/2014/main" id="{66D68B21-CB79-B85D-88F3-3C7A08F2F10A}"/>
+              </a:ext>
+            </a:extLst>
+          </p:cNvPr>
+          <p:cNvSpPr txBox="1"/>
+          <p:nvPr/>
+        </p:nvSpPr>
+        <p:spPr>
+          <a:xfrm>
+            <a:off x="5656566" y="1847654"/>
+            <a:ext cx="5797001" cy="3139321"/>
+          </a:xfrm>
+          <a:prstGeom prst="rect">
+            <a:avLst/>
+          </a:prstGeom>
+          <a:noFill/>
+        </p:spPr>
+        <p:txBody>
+          <a:bodyPr wrap="square" rtlCol="0">
+            <a:spAutoFit/>
+          </a:bodyPr>
+          <a:lstStyle/>
+          <a:p>
+            <a:r>
+              <a:rPr lang="en-US" dirty="0"/>
+              <a:t>In the original implementation all of these allocations are static, which can easily overflow as graph size become larger. This is the reason why program crashes for many graphs. </a:t>
+            </a:r>
+          </a:p>
+          <a:p>
+            <a:endParaRPr lang="en-US" dirty="0"/>
+          </a:p>
+          <a:p>
+            <a:r>
+              <a:rPr lang="en-US" dirty="0"/>
+              <a:t>In our implementation we have </a:t>
+            </a:r>
+            <a:r>
+              <a:rPr lang="en-US" dirty="0" err="1"/>
+              <a:t>Brd</a:t>
+            </a:r>
+            <a:r>
+              <a:rPr lang="en-US" dirty="0"/>
+              <a:t>, </a:t>
+            </a:r>
+            <a:r>
+              <a:rPr lang="en-US" dirty="0" err="1"/>
+              <a:t>Bwr</a:t>
+            </a:r>
+            <a:r>
+              <a:rPr lang="en-US" dirty="0"/>
+              <a:t>, H which can better handle expansion.</a:t>
+            </a:r>
+          </a:p>
+          <a:p>
+            <a:endParaRPr lang="en-US" dirty="0"/>
+          </a:p>
+          <a:p>
+            <a:r>
+              <a:rPr lang="en-US" dirty="0"/>
+              <a:t>For temporary intersection and pruning operations, it uses a per warp buffer explained in next slide. </a:t>
+            </a:r>
+          </a:p>
+          <a:p>
+            <a:endParaRPr lang="en-US" dirty="0"/>
+          </a:p>
+        </p:txBody>
+      </p:sp>
+    </p:spTree>
+    <p:extLst>
+      <p:ext uri="{BB962C8B-B14F-4D97-AF65-F5344CB8AC3E}">
+        <p14:creationId xmlns:p14="http://schemas.microsoft.com/office/powerpoint/2010/main" val="183731531"/>
+      </p:ext>
+    </p:extLst>
+  </p:cSld>
+  <p:clrMapOvr>
+    <a:masterClrMapping/>
+  </p:clrMapOvr>
+</p:sld>
+</file>
+
+<file path=ppt/slides/slide34.xml><?xml version="1.0" encoding="utf-8"?>
+<p:sld xmlns:a="http://schemas.openxmlformats.org/drawingml/2006/main" xmlns:r="http://schemas.openxmlformats.org/officeDocument/2006/relationships" xmlns:p="http://schemas.openxmlformats.org/presentationml/2006/main">
+  <p:cSld>
+    <p:spTree>
+      <p:nvGrpSpPr>
+        <p:cNvPr id="1" name=""/>
+        <p:cNvGrpSpPr/>
+        <p:nvPr/>
+      </p:nvGrpSpPr>
+      <p:grpSpPr>
+        <a:xfrm>
+          <a:off x="0" y="0"/>
+          <a:ext cx="0" cy="0"/>
+          <a:chOff x="0" y="0"/>
+          <a:chExt cx="0" cy="0"/>
+        </a:xfrm>
+      </p:grpSpPr>
+      <p:sp>
+        <p:nvSpPr>
+          <p:cNvPr id="2" name="Title 1">
+            <a:extLst>
+              <a:ext uri="{FF2B5EF4-FFF2-40B4-BE49-F238E27FC236}">
                 <a16:creationId xmlns:a16="http://schemas.microsoft.com/office/drawing/2014/main" id="{4FCD8988-8E15-7B7A-BAF1-331B63E6DD8C}"/>
               </a:ext>
             </a:extLst>
@@ -12157,7 +12446,7 @@
 </p:sld>
 </file>
 
-<file path=ppt/slides/slide33.xml><?xml version="1.0" encoding="utf-8"?>
+<file path=ppt/slides/slide35.xml><?xml version="1.0" encoding="utf-8"?>
 <p:sld xmlns:a="http://schemas.openxmlformats.org/drawingml/2006/main" xmlns:r="http://schemas.openxmlformats.org/officeDocument/2006/relationships" xmlns:p="http://schemas.openxmlformats.org/presentationml/2006/main">
   <p:cSld>
     <p:spTree>
@@ -12815,7 +13104,7 @@
 </p:sld>
 </file>
 
-<file path=ppt/slides/slide34.xml><?xml version="1.0" encoding="utf-8"?>
+<file path=ppt/slides/slide36.xml><?xml version="1.0" encoding="utf-8"?>
 <p:sld xmlns:a="http://schemas.openxmlformats.org/drawingml/2006/main" xmlns:r="http://schemas.openxmlformats.org/officeDocument/2006/relationships" xmlns:p="http://schemas.openxmlformats.org/presentationml/2006/main">
   <p:cSld>
     <p:spTree>
@@ -13012,7 +13301,7 @@
 </p:sld>
 </file>
 
-<file path=ppt/slides/slide35.xml><?xml version="1.0" encoding="utf-8"?>
+<file path=ppt/slides/slide37.xml><?xml version="1.0" encoding="utf-8"?>
 <p:sld xmlns:a="http://schemas.openxmlformats.org/drawingml/2006/main" xmlns:r="http://schemas.openxmlformats.org/officeDocument/2006/relationships" xmlns:p="http://schemas.openxmlformats.org/presentationml/2006/main">
   <p:cSld>
     <p:spTree>
@@ -13290,7 +13579,7 @@
 </p:sld>
 </file>
 
-<file path=ppt/slides/slide36.xml><?xml version="1.0" encoding="utf-8"?>
+<file path=ppt/slides/slide38.xml><?xml version="1.0" encoding="utf-8"?>
 <p:sld xmlns:a="http://schemas.openxmlformats.org/drawingml/2006/main" xmlns:r="http://schemas.openxmlformats.org/officeDocument/2006/relationships" xmlns:p="http://schemas.openxmlformats.org/presentationml/2006/main">
   <p:cSld>
     <p:spTree>
@@ -13370,7 +13659,7 @@
 </p:sld>
 </file>
 
-<file path=ppt/slides/slide37.xml><?xml version="1.0" encoding="utf-8"?>
+<file path=ppt/slides/slide39.xml><?xml version="1.0" encoding="utf-8"?>
 <p:sld xmlns:a="http://schemas.openxmlformats.org/drawingml/2006/main" xmlns:r="http://schemas.openxmlformats.org/officeDocument/2006/relationships" xmlns:p="http://schemas.openxmlformats.org/presentationml/2006/main">
   <p:cSld>
     <p:spTree>

</xml_diff>